<commit_message>
Improve Saathi deck colours and show the website address
</commit_message>
<xml_diff>
--- a/submission/Saathi_Healthathon_Final.pptx
+++ b/submission/Saathi_Healthathon_Final.pptx
@@ -2,20 +2,20 @@
 <file path=ppt/presentation.xml><?xml version="1.0" encoding="utf-8"?>
 <p:presentation xmlns:p="http://schemas.openxmlformats.org/presentationml/2006/main">
   <p:sldMasterIdLst>
-    <p:sldMasterId xmlns:r="http://schemas.openxmlformats.org/officeDocument/2006/relationships" id="2147483648" r:id="R5c021d7ac7ed4138"/>
+    <p:sldMasterId xmlns:r="http://schemas.openxmlformats.org/officeDocument/2006/relationships" id="2147483648" r:id="Rfbf9f0d76543491e"/>
   </p:sldMasterIdLst>
   <p:notesMasterIdLst>
-    <p:notesMasterId xmlns:r="http://schemas.openxmlformats.org/officeDocument/2006/relationships" r:id="R0467c62d045a436a"/>
+    <p:notesMasterId xmlns:r="http://schemas.openxmlformats.org/officeDocument/2006/relationships" r:id="R7c385da5d4f04bfd"/>
   </p:notesMasterIdLst>
   <p:sldIdLst>
-    <p:sldId xmlns:r="http://schemas.openxmlformats.org/officeDocument/2006/relationships" id="256" r:id="Rb021a9bf3da74235"/>
-    <p:sldId xmlns:r="http://schemas.openxmlformats.org/officeDocument/2006/relationships" id="257" r:id="Rdba73b3d1cb3443a"/>
-    <p:sldId xmlns:r="http://schemas.openxmlformats.org/officeDocument/2006/relationships" id="258" r:id="R6ca15f81af0447b4"/>
-    <p:sldId xmlns:r="http://schemas.openxmlformats.org/officeDocument/2006/relationships" id="259" r:id="R58268324123e48d7"/>
-    <p:sldId xmlns:r="http://schemas.openxmlformats.org/officeDocument/2006/relationships" id="260" r:id="R2cb5cf818c34460b"/>
-    <p:sldId xmlns:r="http://schemas.openxmlformats.org/officeDocument/2006/relationships" id="261" r:id="Rfdbd75c6f89e4a36"/>
-    <p:sldId xmlns:r="http://schemas.openxmlformats.org/officeDocument/2006/relationships" id="262" r:id="R4478fc39652c46b5"/>
-    <p:sldId xmlns:r="http://schemas.openxmlformats.org/officeDocument/2006/relationships" id="263" r:id="Rdb32db8469cf4111"/>
+    <p:sldId xmlns:r="http://schemas.openxmlformats.org/officeDocument/2006/relationships" id="256" r:id="Rf34b3e9afaa341c5"/>
+    <p:sldId xmlns:r="http://schemas.openxmlformats.org/officeDocument/2006/relationships" id="257" r:id="Rc15c91ccc4554d9a"/>
+    <p:sldId xmlns:r="http://schemas.openxmlformats.org/officeDocument/2006/relationships" id="258" r:id="Rc635b369d8ad4c50"/>
+    <p:sldId xmlns:r="http://schemas.openxmlformats.org/officeDocument/2006/relationships" id="259" r:id="Rd337e3c49b2b4d0d"/>
+    <p:sldId xmlns:r="http://schemas.openxmlformats.org/officeDocument/2006/relationships" id="260" r:id="R486be6ba281c40fd"/>
+    <p:sldId xmlns:r="http://schemas.openxmlformats.org/officeDocument/2006/relationships" id="261" r:id="Ra6bb2d84982746ef"/>
+    <p:sldId xmlns:r="http://schemas.openxmlformats.org/officeDocument/2006/relationships" id="262" r:id="R732b48da8caa46f8"/>
+    <p:sldId xmlns:r="http://schemas.openxmlformats.org/officeDocument/2006/relationships" id="263" r:id="Ref55a49f3410490e"/>
   </p:sldIdLst>
   <p:sldSz cx="12192000" cy="6858000"/>
   <p:notesSz cx="6858000" cy="9144000"/>
@@ -949,7 +949,7 @@
           </a:p>
           <a:p xmlns:a="http://schemas.openxmlformats.org/drawingml/2006/main">
             <a:r>
-              <a:t>1. IARC. Global Cancer Observatory, 2024. India — GLOBOCAN 2024 Fact Sheet</a:t>
+              <a:t>1. IARC. Global Cancer Observatory, 2024. India: GLOBOCAN 2024 Fact Sheet</a:t>
             </a:r>
           </a:p>
           <a:p xmlns:a="http://schemas.openxmlformats.org/drawingml/2006/main">
@@ -1387,7 +1387,7 @@
   </p:cSld>
   <p:clrMap bg1="lt1" tx1="dk1" bg2="lt2" tx2="dk2" accent1="accent1" accent2="accent2" accent3="accent3" accent4="accent4" accent5="accent5" accent6="accent6" hlink="hlink" folHlink="folHlink"/>
   <p:sldLayoutIdLst>
-    <p:sldLayoutId xmlns:r="http://schemas.openxmlformats.org/officeDocument/2006/relationships" id="2147483649" r:id="R1628223642c44faf"/>
+    <p:sldLayoutId xmlns:r="http://schemas.openxmlformats.org/officeDocument/2006/relationships" id="2147483649" r:id="Rbe3f98b33d9b4c4f"/>
   </p:sldLayoutIdLst>
   <p:txStyles>
     <p:titleStyle>
@@ -2144,10 +2144,10 @@
           <p:nvPr/>
         </p:nvPicPr>
         <p:blipFill>
-          <a:blip xmlns:r="http://schemas.openxmlformats.org/officeDocument/2006/relationships" xmlns:a="http://schemas.openxmlformats.org/drawingml/2006/main" r:embed="R5b490bff0d9b48f8">
+          <a:blip xmlns:r="http://schemas.openxmlformats.org/officeDocument/2006/relationships" xmlns:a="http://schemas.openxmlformats.org/drawingml/2006/main" r:embed="R5e5de537c1644b85">
             <a:extLst>
               <a:ext uri="{96DAC541-7B7A-43D3-8B79-37D633B846F1}">
-                <asvg:svgBlip xmlns:asvg="http://schemas.microsoft.com/office/drawing/2016/SVG/main" r:embed="R3c3ebbaa99104f0b"/>
+                <asvg:svgBlip xmlns:asvg="http://schemas.microsoft.com/office/drawing/2016/SVG/main" r:embed="R6a5eddff09084ab7"/>
               </a:ext>
             </a:extLst>
           </a:blip>
@@ -2168,7 +2168,7 @@
           <p:cNvPr id="2" name="Brand">
             <a:extLst xmlns:a="http://schemas.openxmlformats.org/drawingml/2006/main">
               <a:ext uri="{FF2B5EF4-FFF2-40B4-BE49-F238E27FC236}">
-                <a16:creationId xmlns:a16="http://schemas.microsoft.com/office/drawing/2014/main" id="{C31D7F54-D3EF-47F8-B4DA-52CEE69A20F7}"/>
+                <a16:creationId xmlns:a16="http://schemas.microsoft.com/office/drawing/2014/main" id="{5547AA22-EA6E-4343-8C71-E78FB5DE7865}"/>
               </a:ext>
             </a:extLst>
           </p:cNvPr>
@@ -2225,7 +2225,7 @@
           <p:cNvPr id="3" name="Hindi name">
             <a:extLst xmlns:a="http://schemas.openxmlformats.org/drawingml/2006/main">
               <a:ext uri="{FF2B5EF4-FFF2-40B4-BE49-F238E27FC236}">
-                <a16:creationId xmlns:a16="http://schemas.microsoft.com/office/drawing/2014/main" id="{29CF915D-952B-4425-AAC4-F8DBA7FADEB0}"/>
+                <a16:creationId xmlns:a16="http://schemas.microsoft.com/office/drawing/2014/main" id="{384AC488-C40E-461E-B8E0-010CC2460678}"/>
               </a:ext>
             </a:extLst>
           </p:cNvPr>
@@ -2282,7 +2282,7 @@
           <p:cNvPr id="4" name="Name meaning">
             <a:extLst xmlns:a="http://schemas.openxmlformats.org/drawingml/2006/main">
               <a:ext uri="{FF2B5EF4-FFF2-40B4-BE49-F238E27FC236}">
-                <a16:creationId xmlns:a16="http://schemas.microsoft.com/office/drawing/2014/main" id="{EBF7EBF9-5071-4508-8F78-34855D44D198}"/>
+                <a16:creationId xmlns:a16="http://schemas.microsoft.com/office/drawing/2014/main" id="{8C18C6DB-19C8-49A5-9299-DEB80AA927D3}"/>
               </a:ext>
             </a:extLst>
           </p:cNvPr>
@@ -2339,7 +2339,7 @@
           <p:cNvPr id="5" name="Purpose">
             <a:extLst xmlns:a="http://schemas.openxmlformats.org/drawingml/2006/main">
               <a:ext uri="{FF2B5EF4-FFF2-40B4-BE49-F238E27FC236}">
-                <a16:creationId xmlns:a16="http://schemas.microsoft.com/office/drawing/2014/main" id="{9B0A2F93-7680-4BF6-8E57-21A620006EC4}"/>
+                <a16:creationId xmlns:a16="http://schemas.microsoft.com/office/drawing/2014/main" id="{10B27708-76D5-4E11-BB71-3689BDFD7F01}"/>
               </a:ext>
             </a:extLst>
           </p:cNvPr>
@@ -2386,7 +2386,7 @@
                 <a:ea typeface="Arial"/>
                 <a:cs typeface="Arial"/>
               </a:rPr>
-              <a:t>Saathi helps families organise cancer care—from conversations and records to medicines, practical help and emotional support.</a:t>
+              <a:t>Saathi helps families organise cancer care, from conversations and records to medicines, practical help and emotional support.</a:t>
             </a:r>
           </a:p>
         </p:txBody>
@@ -2400,7 +2400,7 @@
           <p:nvPr/>
         </p:nvPicPr>
         <p:blipFill>
-          <a:blip xmlns:r="http://schemas.openxmlformats.org/officeDocument/2006/relationships" xmlns:a="http://schemas.openxmlformats.org/drawingml/2006/main" r:embed="R3f16925b3c144c75"/>
+          <a:blip xmlns:r="http://schemas.openxmlformats.org/officeDocument/2006/relationships" xmlns:a="http://schemas.openxmlformats.org/drawingml/2006/main" r:embed="Rdae0d889d1584b81"/>
           <a:stretch xmlns:a="http://schemas.openxmlformats.org/drawingml/2006/main"/>
         </p:blipFill>
         <p:spPr>
@@ -2418,7 +2418,7 @@
           <p:cNvPr id="7" name="Website link">
             <a:extLst xmlns:a="http://schemas.openxmlformats.org/drawingml/2006/main">
               <a:ext uri="{FF2B5EF4-FFF2-40B4-BE49-F238E27FC236}">
-                <a16:creationId xmlns:a16="http://schemas.microsoft.com/office/drawing/2014/main" id="{BC631457-021E-46F5-8DD1-A23E25AA4273}"/>
+                <a16:creationId xmlns:a16="http://schemas.microsoft.com/office/drawing/2014/main" id="{B1D4CDDF-855D-4762-BA42-79C37E3998A5}"/>
               </a:ext>
             </a:extLst>
           </p:cNvPr>
@@ -2464,9 +2464,9 @@
                 <a:latin typeface="Arial"/>
                 <a:ea typeface="Arial"/>
                 <a:cs typeface="Arial"/>
-                <a:hlinkClick xmlns:r="http://schemas.openxmlformats.org/officeDocument/2006/relationships" r:id="R54567f05cac74a86"/>
-              </a:rPr>
-              <a:t>OPEN THE WEBSITE</a:t>
+                <a:hlinkClick xmlns:r="http://schemas.openxmlformats.org/officeDocument/2006/relationships" r:id="R9d5bf5d7398843d2"/>
+              </a:rPr>
+              <a:t>OPEN THE WEBSITE - saathi.wedevit.in</a:t>
             </a:r>
           </a:p>
         </p:txBody>
@@ -2480,10 +2480,10 @@
           <p:nvPr/>
         </p:nvPicPr>
         <p:blipFill>
-          <a:blip xmlns:r="http://schemas.openxmlformats.org/officeDocument/2006/relationships" xmlns:a="http://schemas.openxmlformats.org/drawingml/2006/main" r:embed="Ra50da29dd24a4f66">
+          <a:blip xmlns:r="http://schemas.openxmlformats.org/officeDocument/2006/relationships" xmlns:a="http://schemas.openxmlformats.org/drawingml/2006/main" r:embed="R090690a44cbd464a">
             <a:extLst>
               <a:ext uri="{96DAC541-7B7A-43D3-8B79-37D633B846F1}">
-                <asvg:svgBlip xmlns:asvg="http://schemas.microsoft.com/office/drawing/2016/SVG/main" r:embed="R8090e3e534424d46"/>
+                <asvg:svgBlip xmlns:asvg="http://schemas.microsoft.com/office/drawing/2016/SVG/main" r:embed="R46e0d379171c47d3"/>
               </a:ext>
             </a:extLst>
           </a:blip>
@@ -2504,7 +2504,7 @@
           <p:cNvPr id="9" name="Repository link">
             <a:extLst xmlns:a="http://schemas.openxmlformats.org/drawingml/2006/main">
               <a:ext uri="{FF2B5EF4-FFF2-40B4-BE49-F238E27FC236}">
-                <a16:creationId xmlns:a16="http://schemas.microsoft.com/office/drawing/2014/main" id="{E46DBE2B-CD5C-47AC-B6A2-6116A73565BC}"/>
+                <a16:creationId xmlns:a16="http://schemas.microsoft.com/office/drawing/2014/main" id="{40070222-2987-405E-8F9D-7A08CEFF804A}"/>
               </a:ext>
             </a:extLst>
           </p:cNvPr>
@@ -2550,7 +2550,7 @@
                 <a:latin typeface="Arial"/>
                 <a:ea typeface="Arial"/>
                 <a:cs typeface="Arial"/>
-                <a:hlinkClick xmlns:r="http://schemas.openxmlformats.org/officeDocument/2006/relationships" r:id="Re2be1f9303c64731"/>
+                <a:hlinkClick xmlns:r="http://schemas.openxmlformats.org/officeDocument/2006/relationships" r:id="R26da461d84f049bf"/>
               </a:rPr>
               <a:t>github.com/basithladdu/healthathon</a:t>
             </a:r>
@@ -2566,10 +2566,10 @@
           <p:nvPr/>
         </p:nvPicPr>
         <p:blipFill>
-          <a:blip xmlns:r="http://schemas.openxmlformats.org/officeDocument/2006/relationships" xmlns:a="http://schemas.openxmlformats.org/drawingml/2006/main" r:embed="Rd0781b761b2a40be">
+          <a:blip xmlns:r="http://schemas.openxmlformats.org/officeDocument/2006/relationships" xmlns:a="http://schemas.openxmlformats.org/drawingml/2006/main" r:embed="Rdc5fee4ad1384f6b">
             <a:extLst>
               <a:ext uri="{96DAC541-7B7A-43D3-8B79-37D633B846F1}">
-                <asvg:svgBlip xmlns:asvg="http://schemas.microsoft.com/office/drawing/2016/SVG/main" r:embed="Rd72eee54adff4ad8"/>
+                <asvg:svgBlip xmlns:asvg="http://schemas.microsoft.com/office/drawing/2016/SVG/main" r:embed="Rda64c2a8ec96442a"/>
               </a:ext>
             </a:extLst>
           </a:blip>
@@ -2590,7 +2590,7 @@
           <p:cNvPr id="11" name="Questions contact">
             <a:extLst xmlns:a="http://schemas.openxmlformats.org/drawingml/2006/main">
               <a:ext uri="{FF2B5EF4-FFF2-40B4-BE49-F238E27FC236}">
-                <a16:creationId xmlns:a16="http://schemas.microsoft.com/office/drawing/2014/main" id="{2BDC8508-A84B-46C2-8497-CAF829D53DD3}"/>
+                <a16:creationId xmlns:a16="http://schemas.microsoft.com/office/drawing/2014/main" id="{C909E356-0A9E-4F35-AAD2-E142CEF681BD}"/>
               </a:ext>
             </a:extLst>
           </p:cNvPr>
@@ -2636,7 +2636,7 @@
                 <a:latin typeface="Arial"/>
                 <a:ea typeface="Arial"/>
                 <a:cs typeface="Arial"/>
-                <a:hlinkClick xmlns:r="http://schemas.openxmlformats.org/officeDocument/2006/relationships" r:id="R6a7e66fd098c4cab"/>
+                <a:hlinkClick xmlns:r="http://schemas.openxmlformats.org/officeDocument/2006/relationships" r:id="Ree5d62189a9f4275"/>
               </a:rPr>
               <a:t>Questions? Contact us</a:t>
             </a:r>
@@ -2648,7 +2648,7 @@
           <p:cNvPr id="12" name="WhatsApp link">
             <a:extLst xmlns:a="http://schemas.openxmlformats.org/drawingml/2006/main">
               <a:ext uri="{FF2B5EF4-FFF2-40B4-BE49-F238E27FC236}">
-                <a16:creationId xmlns:a16="http://schemas.microsoft.com/office/drawing/2014/main" id="{FA624447-35D2-46F1-82CC-AA9AA2D6A2A9}"/>
+                <a16:creationId xmlns:a16="http://schemas.microsoft.com/office/drawing/2014/main" id="{6262E102-B3C1-4DAC-B94A-C74DF907A763}"/>
               </a:ext>
             </a:extLst>
           </p:cNvPr>
@@ -2694,7 +2694,7 @@
                 <a:latin typeface="Arial"/>
                 <a:ea typeface="Arial"/>
                 <a:cs typeface="Arial"/>
-                <a:hlinkClick xmlns:r="http://schemas.openxmlformats.org/officeDocument/2006/relationships" r:id="Rca0ab13d560e4b5c"/>
+                <a:hlinkClick xmlns:r="http://schemas.openxmlformats.org/officeDocument/2006/relationships" r:id="R702d8fd4595b4eb1"/>
               </a:rPr>
               <a:t>wa.me/919553321211</a:t>
             </a:r>
@@ -2706,7 +2706,7 @@
           <p:cNvPr id="13" name="">
             <a:extLst xmlns:a="http://schemas.openxmlformats.org/drawingml/2006/main">
               <a:ext uri="{FF2B5EF4-FFF2-40B4-BE49-F238E27FC236}">
-                <a16:creationId xmlns:a16="http://schemas.microsoft.com/office/drawing/2014/main" id="{BF366E9D-99EA-4E09-A0CE-362198D6A47A}"/>
+                <a16:creationId xmlns:a16="http://schemas.microsoft.com/office/drawing/2014/main" id="{C134C642-405F-4C51-848E-EC843730A079}"/>
               </a:ext>
             </a:extLst>
           </p:cNvPr>
@@ -2735,7 +2735,7 @@
           <p:cNvPr id="14" name="Team heading">
             <a:extLst xmlns:a="http://schemas.openxmlformats.org/drawingml/2006/main">
               <a:ext uri="{FF2B5EF4-FFF2-40B4-BE49-F238E27FC236}">
-                <a16:creationId xmlns:a16="http://schemas.microsoft.com/office/drawing/2014/main" id="{C7030D11-D61E-4EE4-BDCB-A28C7597B671}"/>
+                <a16:creationId xmlns:a16="http://schemas.microsoft.com/office/drawing/2014/main" id="{EC68B406-1B96-4477-ADE2-C890996F17BA}"/>
               </a:ext>
             </a:extLst>
           </p:cNvPr>
@@ -2796,7 +2796,7 @@
           <p:nvPr/>
         </p:nvPicPr>
         <p:blipFill>
-          <a:blip xmlns:r="http://schemas.openxmlformats.org/officeDocument/2006/relationships" xmlns:a="http://schemas.openxmlformats.org/drawingml/2006/main" r:embed="R1cd2c85d55f24931"/>
+          <a:blip xmlns:r="http://schemas.openxmlformats.org/officeDocument/2006/relationships" xmlns:a="http://schemas.openxmlformats.org/drawingml/2006/main" r:embed="Rb52d535c17244d17"/>
           <a:srcRect xmlns:a="http://schemas.openxmlformats.org/drawingml/2006/main" l="0" t="5331" r="0" b="5331"/>
           <a:stretch xmlns:a="http://schemas.openxmlformats.org/drawingml/2006/main">
             <a:fillRect l="0" t="0" r="0" b="0"/>
@@ -2817,7 +2817,7 @@
           <p:cNvPr id="16" name="Team member 1">
             <a:extLst xmlns:a="http://schemas.openxmlformats.org/drawingml/2006/main">
               <a:ext uri="{FF2B5EF4-FFF2-40B4-BE49-F238E27FC236}">
-                <a16:creationId xmlns:a16="http://schemas.microsoft.com/office/drawing/2014/main" id="{A38F6026-C9C5-495F-A818-1C9AA6CF4287}"/>
+                <a16:creationId xmlns:a16="http://schemas.microsoft.com/office/drawing/2014/main" id="{EE950659-3C00-4304-B78E-5B191AD815BD}"/>
               </a:ext>
             </a:extLst>
           </p:cNvPr>
@@ -2897,7 +2897,7 @@
           <p:cNvPr id="17" name="Team role 1">
             <a:extLst xmlns:a="http://schemas.openxmlformats.org/drawingml/2006/main">
               <a:ext uri="{FF2B5EF4-FFF2-40B4-BE49-F238E27FC236}">
-                <a16:creationId xmlns:a16="http://schemas.microsoft.com/office/drawing/2014/main" id="{0CECE9EA-DC2F-42C0-A27F-51DF53719D2A}"/>
+                <a16:creationId xmlns:a16="http://schemas.microsoft.com/office/drawing/2014/main" id="{9264044F-CFC9-4C2B-9528-13DF25AE1EBA}"/>
               </a:ext>
             </a:extLst>
           </p:cNvPr>
@@ -2958,7 +2958,7 @@
           <p:nvPr/>
         </p:nvPicPr>
         <p:blipFill>
-          <a:blip xmlns:r="http://schemas.openxmlformats.org/officeDocument/2006/relationships" xmlns:a="http://schemas.openxmlformats.org/drawingml/2006/main" r:embed="R8a84433637664990"/>
+          <a:blip xmlns:r="http://schemas.openxmlformats.org/officeDocument/2006/relationships" xmlns:a="http://schemas.openxmlformats.org/drawingml/2006/main" r:embed="R2178a5995d084343"/>
           <a:srcRect xmlns:a="http://schemas.openxmlformats.org/drawingml/2006/main" l="0" t="19104" r="0" b="19104"/>
           <a:stretch xmlns:a="http://schemas.openxmlformats.org/drawingml/2006/main">
             <a:fillRect l="0" t="0" r="0" b="0"/>
@@ -2979,7 +2979,7 @@
           <p:cNvPr id="19" name="Team member 2">
             <a:extLst xmlns:a="http://schemas.openxmlformats.org/drawingml/2006/main">
               <a:ext uri="{FF2B5EF4-FFF2-40B4-BE49-F238E27FC236}">
-                <a16:creationId xmlns:a16="http://schemas.microsoft.com/office/drawing/2014/main" id="{16C892BF-43C0-4D09-A18C-793728292246}"/>
+                <a16:creationId xmlns:a16="http://schemas.microsoft.com/office/drawing/2014/main" id="{32FE17B3-5C04-45C2-995C-A13F1780C69C}"/>
               </a:ext>
             </a:extLst>
           </p:cNvPr>
@@ -3059,7 +3059,7 @@
           <p:cNvPr id="20" name="Team role 2">
             <a:extLst xmlns:a="http://schemas.openxmlformats.org/drawingml/2006/main">
               <a:ext uri="{FF2B5EF4-FFF2-40B4-BE49-F238E27FC236}">
-                <a16:creationId xmlns:a16="http://schemas.microsoft.com/office/drawing/2014/main" id="{063FFA23-880E-44CC-90B2-9314B9AA4065}"/>
+                <a16:creationId xmlns:a16="http://schemas.microsoft.com/office/drawing/2014/main" id="{DF4C8D24-6F1B-4415-9872-ED9A3001A1F8}"/>
               </a:ext>
             </a:extLst>
           </p:cNvPr>
@@ -3116,7 +3116,7 @@
           <p:cNvPr id="21" name="Photo space for Dr Sharada&#10;Vinod Kutty">
             <a:extLst xmlns:a="http://schemas.openxmlformats.org/drawingml/2006/main">
               <a:ext uri="{FF2B5EF4-FFF2-40B4-BE49-F238E27FC236}">
-                <a16:creationId xmlns:a16="http://schemas.microsoft.com/office/drawing/2014/main" id="{7E11D085-0DB9-411F-BBEA-4AD9492A8225}"/>
+                <a16:creationId xmlns:a16="http://schemas.microsoft.com/office/drawing/2014/main" id="{A0A22A67-2978-45B2-9587-6913ACF51508}"/>
               </a:ext>
             </a:extLst>
           </p:cNvPr>
@@ -3148,7 +3148,7 @@
           <p:cNvPr id="22" name="Team member 3">
             <a:extLst xmlns:a="http://schemas.openxmlformats.org/drawingml/2006/main">
               <a:ext uri="{FF2B5EF4-FFF2-40B4-BE49-F238E27FC236}">
-                <a16:creationId xmlns:a16="http://schemas.microsoft.com/office/drawing/2014/main" id="{BA2FE28A-1893-438A-B845-6B651A3C7E38}"/>
+                <a16:creationId xmlns:a16="http://schemas.microsoft.com/office/drawing/2014/main" id="{E7A8EFDC-8FFD-4FED-9012-5035A697EC39}"/>
               </a:ext>
             </a:extLst>
           </p:cNvPr>
@@ -3228,7 +3228,7 @@
           <p:cNvPr id="23" name="Team role 3">
             <a:extLst xmlns:a="http://schemas.openxmlformats.org/drawingml/2006/main">
               <a:ext uri="{FF2B5EF4-FFF2-40B4-BE49-F238E27FC236}">
-                <a16:creationId xmlns:a16="http://schemas.microsoft.com/office/drawing/2014/main" id="{E2CC72D4-1922-44CA-81BC-797A03E40E8E}"/>
+                <a16:creationId xmlns:a16="http://schemas.microsoft.com/office/drawing/2014/main" id="{CBE10AAD-F218-40F2-A0A0-5117CD9E831B}"/>
               </a:ext>
             </a:extLst>
           </p:cNvPr>
@@ -3285,7 +3285,7 @@
           <p:cNvPr id="24" name="Photo space for Dr Sujay&#10;Halkur Shankar">
             <a:extLst xmlns:a="http://schemas.openxmlformats.org/drawingml/2006/main">
               <a:ext uri="{FF2B5EF4-FFF2-40B4-BE49-F238E27FC236}">
-                <a16:creationId xmlns:a16="http://schemas.microsoft.com/office/drawing/2014/main" id="{488359CA-AFDA-4647-8729-98E9C7097028}"/>
+                <a16:creationId xmlns:a16="http://schemas.microsoft.com/office/drawing/2014/main" id="{ADC6850E-C54C-456B-A805-50DB7804690E}"/>
               </a:ext>
             </a:extLst>
           </p:cNvPr>
@@ -3317,7 +3317,7 @@
           <p:cNvPr id="25" name="Team member 4">
             <a:extLst xmlns:a="http://schemas.openxmlformats.org/drawingml/2006/main">
               <a:ext uri="{FF2B5EF4-FFF2-40B4-BE49-F238E27FC236}">
-                <a16:creationId xmlns:a16="http://schemas.microsoft.com/office/drawing/2014/main" id="{B9ED00B3-049A-47C6-BB1A-A47EDFDC5539}"/>
+                <a16:creationId xmlns:a16="http://schemas.microsoft.com/office/drawing/2014/main" id="{C151C18F-73EA-4553-9A44-DDBCA9610102}"/>
               </a:ext>
             </a:extLst>
           </p:cNvPr>
@@ -3397,7 +3397,7 @@
           <p:cNvPr id="26" name="Team role 4">
             <a:extLst xmlns:a="http://schemas.openxmlformats.org/drawingml/2006/main">
               <a:ext uri="{FF2B5EF4-FFF2-40B4-BE49-F238E27FC236}">
-                <a16:creationId xmlns:a16="http://schemas.microsoft.com/office/drawing/2014/main" id="{68DB929E-E139-437A-8981-02FC2112F7E7}"/>
+                <a16:creationId xmlns:a16="http://schemas.microsoft.com/office/drawing/2014/main" id="{2A34FA39-7FA1-4176-ADDD-46522E97E97D}"/>
               </a:ext>
             </a:extLst>
           </p:cNvPr>
@@ -3454,7 +3454,7 @@
           <p:cNvPr id="27" name="Photo space for Shirin Ayub">
             <a:extLst xmlns:a="http://schemas.openxmlformats.org/drawingml/2006/main">
               <a:ext uri="{FF2B5EF4-FFF2-40B4-BE49-F238E27FC236}">
-                <a16:creationId xmlns:a16="http://schemas.microsoft.com/office/drawing/2014/main" id="{30019454-EDD1-4B92-8B2F-ECACBD47D4C9}"/>
+                <a16:creationId xmlns:a16="http://schemas.microsoft.com/office/drawing/2014/main" id="{B81C4423-9165-412E-AAD4-DB13B4C6CF23}"/>
               </a:ext>
             </a:extLst>
           </p:cNvPr>
@@ -3486,7 +3486,7 @@
           <p:cNvPr id="28" name="Team member 5">
             <a:extLst xmlns:a="http://schemas.openxmlformats.org/drawingml/2006/main">
               <a:ext uri="{FF2B5EF4-FFF2-40B4-BE49-F238E27FC236}">
-                <a16:creationId xmlns:a16="http://schemas.microsoft.com/office/drawing/2014/main" id="{8D2ECF42-0331-4D73-97BD-27FECBC43240}"/>
+                <a16:creationId xmlns:a16="http://schemas.microsoft.com/office/drawing/2014/main" id="{D3B2F1DF-723A-4B6F-8C50-2F81DC35F410}"/>
               </a:ext>
             </a:extLst>
           </p:cNvPr>
@@ -3543,7 +3543,7 @@
           <p:cNvPr id="29" name="Team role 5">
             <a:extLst xmlns:a="http://schemas.openxmlformats.org/drawingml/2006/main">
               <a:ext uri="{FF2B5EF4-FFF2-40B4-BE49-F238E27FC236}">
-                <a16:creationId xmlns:a16="http://schemas.microsoft.com/office/drawing/2014/main" id="{E047ED57-8154-4C96-A4A0-FFE04538F18B}"/>
+                <a16:creationId xmlns:a16="http://schemas.microsoft.com/office/drawing/2014/main" id="{307C723A-D9D5-4B48-9230-649EA0455FD5}"/>
               </a:ext>
             </a:extLst>
           </p:cNvPr>
@@ -3611,7 +3611,7 @@
     <p:bg>
       <p:bgPr>
         <a:solidFill xmlns:a="http://schemas.openxmlformats.org/drawingml/2006/main">
-          <a:srgbClr val="F7F3E9"/>
+          <a:srgbClr val="006C7C"/>
         </a:solidFill>
       </p:bgPr>
     </p:bg>
@@ -3629,7 +3629,7 @@
           <p:cNvPr id="16" name="Slide title">
             <a:extLst xmlns:a="http://schemas.openxmlformats.org/drawingml/2006/main">
               <a:ext uri="{FF2B5EF4-FFF2-40B4-BE49-F238E27FC236}">
-                <a16:creationId xmlns:a16="http://schemas.microsoft.com/office/drawing/2014/main" id="{F0024F24-80EB-4F5D-8A85-57F160BB6DAB}"/>
+                <a16:creationId xmlns:a16="http://schemas.microsoft.com/office/drawing/2014/main" id="{C18727ED-15AB-4FAB-95A6-7FCF935B987D}"/>
               </a:ext>
             </a:extLst>
           </p:cNvPr>
@@ -3660,7 +3660,7 @@
             <a:pPr>
               <a:defRPr sz="3075" b="1">
                 <a:solidFill>
-                  <a:srgbClr val="173F33"/>
+                  <a:srgbClr val="FFFFFF"/>
                 </a:solidFill>
                 <a:latin typeface="Arial"/>
                 <a:ea typeface="Arial"/>
@@ -3670,7 +3670,7 @@
             <a:r>
               <a:rPr sz="3075" b="1">
                 <a:solidFill>
-                  <a:srgbClr val="173F33"/>
+                  <a:srgbClr val="FFFFFF"/>
                 </a:solidFill>
                 <a:latin typeface="Arial"/>
                 <a:ea typeface="Arial"/>
@@ -3690,7 +3690,7 @@
           <p:nvPr/>
         </p:nvPicPr>
         <p:blipFill>
-          <a:blip xmlns:r="http://schemas.openxmlformats.org/officeDocument/2006/relationships" xmlns:a="http://schemas.openxmlformats.org/drawingml/2006/main" r:embed="R28e8f278421448cb"/>
+          <a:blip xmlns:r="http://schemas.openxmlformats.org/officeDocument/2006/relationships" xmlns:a="http://schemas.openxmlformats.org/drawingml/2006/main" r:embed="R4de7aac1f4f64ea7"/>
           <a:stretch xmlns:a="http://schemas.openxmlformats.org/drawingml/2006/main"/>
         </p:blipFill>
         <p:spPr>
@@ -3708,7 +3708,7 @@
           <p:cNvPr id="3" name="Care photo context">
             <a:extLst xmlns:a="http://schemas.openxmlformats.org/drawingml/2006/main">
               <a:ext uri="{FF2B5EF4-FFF2-40B4-BE49-F238E27FC236}">
-                <a16:creationId xmlns:a16="http://schemas.microsoft.com/office/drawing/2014/main" id="{6F8F33A5-185C-4ADA-8BF0-922D888B1226}"/>
+                <a16:creationId xmlns:a16="http://schemas.microsoft.com/office/drawing/2014/main" id="{0AACA21A-6071-44AF-9C29-89F8A515CAA5}"/>
               </a:ext>
             </a:extLst>
           </p:cNvPr>
@@ -3739,7 +3739,7 @@
             <a:pPr>
               <a:defRPr sz="1163" b="0">
                 <a:solidFill>
-                  <a:srgbClr val="53655C"/>
+                  <a:srgbClr val="DAEDEF"/>
                 </a:solidFill>
                 <a:latin typeface="Arial"/>
                 <a:ea typeface="Arial"/>
@@ -3749,7 +3749,7 @@
             <a:r>
               <a:rPr sz="1163" b="0">
                 <a:solidFill>
-                  <a:srgbClr val="53655C"/>
+                  <a:srgbClr val="DAEDEF"/>
                 </a:solidFill>
                 <a:latin typeface="Arial"/>
                 <a:ea typeface="Arial"/>
@@ -3765,7 +3765,7 @@
           <p:cNvPr id="4" name="Illustrative patient">
             <a:extLst xmlns:a="http://schemas.openxmlformats.org/drawingml/2006/main">
               <a:ext uri="{FF2B5EF4-FFF2-40B4-BE49-F238E27FC236}">
-                <a16:creationId xmlns:a16="http://schemas.microsoft.com/office/drawing/2014/main" id="{AE396AA4-5EBC-4032-8884-C85405B93D66}"/>
+                <a16:creationId xmlns:a16="http://schemas.microsoft.com/office/drawing/2014/main" id="{538EA391-E00F-408F-A499-8F0529DE4EAA}"/>
               </a:ext>
             </a:extLst>
           </p:cNvPr>
@@ -3796,7 +3796,7 @@
             <a:pPr>
               <a:defRPr sz="1875" b="1">
                 <a:solidFill>
-                  <a:srgbClr val="173F33"/>
+                  <a:srgbClr val="FFFFFF"/>
                 </a:solidFill>
                 <a:latin typeface="Arial"/>
                 <a:ea typeface="Arial"/>
@@ -3806,7 +3806,7 @@
             <a:r>
               <a:rPr sz="1875" b="1">
                 <a:solidFill>
-                  <a:srgbClr val="173F33"/>
+                  <a:srgbClr val="FFFFFF"/>
                 </a:solidFill>
                 <a:latin typeface="Arial"/>
                 <a:ea typeface="Arial"/>
@@ -3826,10 +3826,10 @@
           <p:nvPr/>
         </p:nvPicPr>
         <p:blipFill>
-          <a:blip xmlns:r="http://schemas.openxmlformats.org/officeDocument/2006/relationships" xmlns:a="http://schemas.openxmlformats.org/drawingml/2006/main" r:embed="Rda648d5654a74522">
+          <a:blip xmlns:r="http://schemas.openxmlformats.org/officeDocument/2006/relationships" xmlns:a="http://schemas.openxmlformats.org/drawingml/2006/main" r:embed="R1638e763dbda456a">
             <a:extLst>
               <a:ext uri="{96DAC541-7B7A-43D3-8B79-37D633B846F1}">
-                <asvg:svgBlip xmlns:asvg="http://schemas.microsoft.com/office/drawing/2016/SVG/main" r:embed="R23e1a9c8044d4c34"/>
+                <asvg:svgBlip xmlns:asvg="http://schemas.microsoft.com/office/drawing/2016/SVG/main" r:embed="R9a8cf3df228e4bcc"/>
               </a:ext>
             </a:extLst>
           </a:blip>
@@ -3850,7 +3850,7 @@
           <p:cNvPr id="6" name="Story step 1">
             <a:extLst xmlns:a="http://schemas.openxmlformats.org/drawingml/2006/main">
               <a:ext uri="{FF2B5EF4-FFF2-40B4-BE49-F238E27FC236}">
-                <a16:creationId xmlns:a16="http://schemas.microsoft.com/office/drawing/2014/main" id="{C36097D6-105A-47EE-B68E-C1EFD35A0C6C}"/>
+                <a16:creationId xmlns:a16="http://schemas.microsoft.com/office/drawing/2014/main" id="{826B84A1-EEA9-4AEE-BF36-FE6DF6D5FBDF}"/>
               </a:ext>
             </a:extLst>
           </p:cNvPr>
@@ -3881,7 +3881,7 @@
             <a:pPr>
               <a:defRPr sz="2100" b="1">
                 <a:solidFill>
-                  <a:srgbClr val="157B68"/>
+                  <a:srgbClr val="FFD154"/>
                 </a:solidFill>
                 <a:latin typeface="Arial"/>
                 <a:ea typeface="Arial"/>
@@ -3891,7 +3891,7 @@
             <a:r>
               <a:rPr sz="2100" b="1">
                 <a:solidFill>
-                  <a:srgbClr val="157B68"/>
+                  <a:srgbClr val="FFD154"/>
                 </a:solidFill>
                 <a:latin typeface="Arial"/>
                 <a:ea typeface="Arial"/>
@@ -3907,7 +3907,7 @@
           <p:cNvPr id="7" name="Story step 1 detail">
             <a:extLst xmlns:a="http://schemas.openxmlformats.org/drawingml/2006/main">
               <a:ext uri="{FF2B5EF4-FFF2-40B4-BE49-F238E27FC236}">
-                <a16:creationId xmlns:a16="http://schemas.microsoft.com/office/drawing/2014/main" id="{B5E00D25-D03D-493B-B028-1AEBEC9E84B4}"/>
+                <a16:creationId xmlns:a16="http://schemas.microsoft.com/office/drawing/2014/main" id="{B5EB7A40-377A-487F-A771-19E0E3A31CAA}"/>
               </a:ext>
             </a:extLst>
           </p:cNvPr>
@@ -3938,7 +3938,7 @@
             <a:pPr>
               <a:defRPr sz="1725" b="0">
                 <a:solidFill>
-                  <a:srgbClr val="173F33"/>
+                  <a:srgbClr val="FFFFFF"/>
                 </a:solidFill>
                 <a:latin typeface="Arial"/>
                 <a:ea typeface="Arial"/>
@@ -3948,7 +3948,7 @@
             <a:r>
               <a:rPr sz="1725" b="0">
                 <a:solidFill>
-                  <a:srgbClr val="173F33"/>
+                  <a:srgbClr val="FFFFFF"/>
                 </a:solidFill>
                 <a:latin typeface="Arial"/>
                 <a:ea typeface="Arial"/>
@@ -3968,10 +3968,10 @@
           <p:nvPr/>
         </p:nvPicPr>
         <p:blipFill>
-          <a:blip xmlns:r="http://schemas.openxmlformats.org/officeDocument/2006/relationships" xmlns:a="http://schemas.openxmlformats.org/drawingml/2006/main" r:embed="Rdd139076a0ae47d6">
+          <a:blip xmlns:r="http://schemas.openxmlformats.org/officeDocument/2006/relationships" xmlns:a="http://schemas.openxmlformats.org/drawingml/2006/main" r:embed="Rcbbc1732401b48f0">
             <a:extLst>
               <a:ext uri="{96DAC541-7B7A-43D3-8B79-37D633B846F1}">
-                <asvg:svgBlip xmlns:asvg="http://schemas.microsoft.com/office/drawing/2016/SVG/main" r:embed="R20568b23f9234937"/>
+                <asvg:svgBlip xmlns:asvg="http://schemas.microsoft.com/office/drawing/2016/SVG/main" r:embed="R74a39ca279ba483f"/>
               </a:ext>
             </a:extLst>
           </a:blip>
@@ -3992,7 +3992,7 @@
           <p:cNvPr id="9" name="Story step 2">
             <a:extLst xmlns:a="http://schemas.openxmlformats.org/drawingml/2006/main">
               <a:ext uri="{FF2B5EF4-FFF2-40B4-BE49-F238E27FC236}">
-                <a16:creationId xmlns:a16="http://schemas.microsoft.com/office/drawing/2014/main" id="{2A6F448C-686B-41D3-866F-1F999B89DEC3}"/>
+                <a16:creationId xmlns:a16="http://schemas.microsoft.com/office/drawing/2014/main" id="{0AC27A8D-CF64-469F-8F83-0D89AF0A23B1}"/>
               </a:ext>
             </a:extLst>
           </p:cNvPr>
@@ -4023,7 +4023,7 @@
             <a:pPr>
               <a:defRPr sz="2100" b="1">
                 <a:solidFill>
-                  <a:srgbClr val="7353AC"/>
+                  <a:srgbClr val="E0D7FF"/>
                 </a:solidFill>
                 <a:latin typeface="Arial"/>
                 <a:ea typeface="Arial"/>
@@ -4033,7 +4033,7 @@
             <a:r>
               <a:rPr sz="2100" b="1">
                 <a:solidFill>
-                  <a:srgbClr val="7353AC"/>
+                  <a:srgbClr val="E0D7FF"/>
                 </a:solidFill>
                 <a:latin typeface="Arial"/>
                 <a:ea typeface="Arial"/>
@@ -4049,7 +4049,7 @@
           <p:cNvPr id="10" name="Story step 2 detail">
             <a:extLst xmlns:a="http://schemas.openxmlformats.org/drawingml/2006/main">
               <a:ext uri="{FF2B5EF4-FFF2-40B4-BE49-F238E27FC236}">
-                <a16:creationId xmlns:a16="http://schemas.microsoft.com/office/drawing/2014/main" id="{D0A1F776-88BF-4935-AA1A-0CF11F419E03}"/>
+                <a16:creationId xmlns:a16="http://schemas.microsoft.com/office/drawing/2014/main" id="{88AAA7EF-8C5D-4D1C-8B1E-75A505D8A657}"/>
               </a:ext>
             </a:extLst>
           </p:cNvPr>
@@ -4080,7 +4080,7 @@
             <a:pPr>
               <a:defRPr sz="1725" b="0">
                 <a:solidFill>
-                  <a:srgbClr val="173F33"/>
+                  <a:srgbClr val="FFFFFF"/>
                 </a:solidFill>
                 <a:latin typeface="Arial"/>
                 <a:ea typeface="Arial"/>
@@ -4090,7 +4090,7 @@
             <a:r>
               <a:rPr sz="1725" b="0">
                 <a:solidFill>
-                  <a:srgbClr val="173F33"/>
+                  <a:srgbClr val="FFFFFF"/>
                 </a:solidFill>
                 <a:latin typeface="Arial"/>
                 <a:ea typeface="Arial"/>
@@ -4110,10 +4110,10 @@
           <p:nvPr/>
         </p:nvPicPr>
         <p:blipFill>
-          <a:blip xmlns:r="http://schemas.openxmlformats.org/officeDocument/2006/relationships" xmlns:a="http://schemas.openxmlformats.org/drawingml/2006/main" r:embed="Rcf6890d0fdc7442c">
+          <a:blip xmlns:r="http://schemas.openxmlformats.org/officeDocument/2006/relationships" xmlns:a="http://schemas.openxmlformats.org/drawingml/2006/main" r:embed="Rc8045b7d162c4f3e">
             <a:extLst>
               <a:ext uri="{96DAC541-7B7A-43D3-8B79-37D633B846F1}">
-                <asvg:svgBlip xmlns:asvg="http://schemas.microsoft.com/office/drawing/2016/SVG/main" r:embed="R6c9ad840427644c9"/>
+                <asvg:svgBlip xmlns:asvg="http://schemas.microsoft.com/office/drawing/2016/SVG/main" r:embed="Ra249f3ba8656472e"/>
               </a:ext>
             </a:extLst>
           </a:blip>
@@ -4134,7 +4134,7 @@
           <p:cNvPr id="12" name="Story step 3">
             <a:extLst xmlns:a="http://schemas.openxmlformats.org/drawingml/2006/main">
               <a:ext uri="{FF2B5EF4-FFF2-40B4-BE49-F238E27FC236}">
-                <a16:creationId xmlns:a16="http://schemas.microsoft.com/office/drawing/2014/main" id="{3099788C-76B2-4981-9AF8-BD24A1730149}"/>
+                <a16:creationId xmlns:a16="http://schemas.microsoft.com/office/drawing/2014/main" id="{38CD03CF-61AA-40CB-80E4-B79F132735CE}"/>
               </a:ext>
             </a:extLst>
           </p:cNvPr>
@@ -4165,7 +4165,7 @@
             <a:pPr>
               <a:defRPr sz="2100" b="1">
                 <a:solidFill>
-                  <a:srgbClr val="B75E43"/>
+                  <a:srgbClr val="FDBA74"/>
                 </a:solidFill>
                 <a:latin typeface="Arial"/>
                 <a:ea typeface="Arial"/>
@@ -4175,7 +4175,7 @@
             <a:r>
               <a:rPr sz="2100" b="1">
                 <a:solidFill>
-                  <a:srgbClr val="B75E43"/>
+                  <a:srgbClr val="FDBA74"/>
                 </a:solidFill>
                 <a:latin typeface="Arial"/>
                 <a:ea typeface="Arial"/>
@@ -4191,7 +4191,7 @@
           <p:cNvPr id="13" name="Story step 3 detail">
             <a:extLst xmlns:a="http://schemas.openxmlformats.org/drawingml/2006/main">
               <a:ext uri="{FF2B5EF4-FFF2-40B4-BE49-F238E27FC236}">
-                <a16:creationId xmlns:a16="http://schemas.microsoft.com/office/drawing/2014/main" id="{4CF9E17F-5A47-4567-9572-00FD9D13226B}"/>
+                <a16:creationId xmlns:a16="http://schemas.microsoft.com/office/drawing/2014/main" id="{E68BD7FB-878D-4702-9D67-B51035F92205}"/>
               </a:ext>
             </a:extLst>
           </p:cNvPr>
@@ -4222,7 +4222,7 @@
             <a:pPr>
               <a:defRPr sz="1725" b="0">
                 <a:solidFill>
-                  <a:srgbClr val="173F33"/>
+                  <a:srgbClr val="FFFFFF"/>
                 </a:solidFill>
                 <a:latin typeface="Arial"/>
                 <a:ea typeface="Arial"/>
@@ -4232,7 +4232,7 @@
             <a:r>
               <a:rPr sz="1725" b="0">
                 <a:solidFill>
-                  <a:srgbClr val="173F33"/>
+                  <a:srgbClr val="FFFFFF"/>
                 </a:solidFill>
                 <a:latin typeface="Arial"/>
                 <a:ea typeface="Arial"/>
@@ -4248,7 +4248,7 @@
           <p:cNvPr id="14" name="Shared record takeaway">
             <a:extLst xmlns:a="http://schemas.openxmlformats.org/drawingml/2006/main">
               <a:ext uri="{FF2B5EF4-FFF2-40B4-BE49-F238E27FC236}">
-                <a16:creationId xmlns:a16="http://schemas.microsoft.com/office/drawing/2014/main" id="{015BF1FE-3A66-494D-BE6B-559497D979E9}"/>
+                <a16:creationId xmlns:a16="http://schemas.microsoft.com/office/drawing/2014/main" id="{DC288057-1CB2-4E7B-ACAD-4CF2616BCF33}"/>
               </a:ext>
             </a:extLst>
           </p:cNvPr>
@@ -4266,7 +4266,7 @@
             <a:avLst/>
           </a:prstGeom>
           <a:solidFill xmlns:a="http://schemas.openxmlformats.org/drawingml/2006/main">
-            <a:srgbClr val="173F33"/>
+            <a:srgbClr val="073F49"/>
           </a:solidFill>
           <a:ln xmlns:a="http://schemas.openxmlformats.org/drawingml/2006/main" w="0">
             <a:noFill/>
@@ -4278,7 +4278,7 @@
           <p:cNvPr id="15" name="Closing thought">
             <a:extLst xmlns:a="http://schemas.openxmlformats.org/drawingml/2006/main">
               <a:ext uri="{FF2B5EF4-FFF2-40B4-BE49-F238E27FC236}">
-                <a16:creationId xmlns:a16="http://schemas.microsoft.com/office/drawing/2014/main" id="{9B253523-5302-4AE5-A4E3-2337A38FC930}"/>
+                <a16:creationId xmlns:a16="http://schemas.microsoft.com/office/drawing/2014/main" id="{26EED240-FDA1-4994-8F28-D1601E06C0C4}"/>
               </a:ext>
             </a:extLst>
           </p:cNvPr>
@@ -4346,7 +4346,7 @@
     <p:bg>
       <p:bgPr>
         <a:solidFill xmlns:a="http://schemas.openxmlformats.org/drawingml/2006/main">
-          <a:srgbClr val="FFF6E5"/>
+          <a:srgbClr val="CAD8ED"/>
         </a:solidFill>
       </p:bgPr>
     </p:bg>
@@ -4371,7 +4371,7 @@
         </p:xfrm>
         <a:graphic xmlns:a="http://schemas.openxmlformats.org/drawingml/2006/main">
           <a:graphicData uri="http://schemas.openxmlformats.org/drawingml/2006/chart">
-            <c:chart xmlns:r="http://schemas.openxmlformats.org/officeDocument/2006/relationships" xmlns:c="http://schemas.openxmlformats.org/drawingml/2006/chart" r:id="Rd97d2cd416f64b1b"/>
+            <c:chart xmlns:r="http://schemas.openxmlformats.org/officeDocument/2006/relationships" xmlns:c="http://schemas.openxmlformats.org/drawingml/2006/chart" r:id="R6e197b6ddae44dc3"/>
           </a:graphicData>
         </a:graphic>
       </p:graphicFrame>
@@ -4380,7 +4380,7 @@
           <p:cNvPr id="15" name="Slide title">
             <a:extLst xmlns:a="http://schemas.openxmlformats.org/drawingml/2006/main">
               <a:ext uri="{FF2B5EF4-FFF2-40B4-BE49-F238E27FC236}">
-                <a16:creationId xmlns:a16="http://schemas.microsoft.com/office/drawing/2014/main" id="{5EEA2545-07E2-4091-9061-35AAD6174DEA}"/>
+                <a16:creationId xmlns:a16="http://schemas.microsoft.com/office/drawing/2014/main" id="{D6315517-29D1-449F-924B-291B1ED7C64C}"/>
               </a:ext>
             </a:extLst>
           </p:cNvPr>
@@ -4437,7 +4437,7 @@
           <p:cNvPr id="16" name="Chennai evidence heading">
             <a:extLst xmlns:a="http://schemas.openxmlformats.org/drawingml/2006/main">
               <a:ext uri="{FF2B5EF4-FFF2-40B4-BE49-F238E27FC236}">
-                <a16:creationId xmlns:a16="http://schemas.microsoft.com/office/drawing/2014/main" id="{04C6086E-33FC-490C-A8C5-B97327EE5E6E}"/>
+                <a16:creationId xmlns:a16="http://schemas.microsoft.com/office/drawing/2014/main" id="{803D9749-6469-4724-9A00-C35DCA1584CB}"/>
               </a:ext>
             </a:extLst>
           </p:cNvPr>
@@ -4455,7 +4455,7 @@
             <a:avLst/>
           </a:prstGeom>
           <a:solidFill xmlns:a="http://schemas.openxmlformats.org/drawingml/2006/main">
-            <a:srgbClr val="D9EEE6"/>
+            <a:srgbClr val="F3F6FA"/>
           </a:solidFill>
           <a:ln xmlns:a="http://schemas.openxmlformats.org/drawingml/2006/main" w="0">
             <a:noFill/>
@@ -4467,7 +4467,7 @@
           <p:cNvPr id="17" name="Chennai evidence explanation">
             <a:extLst xmlns:a="http://schemas.openxmlformats.org/drawingml/2006/main">
               <a:ext uri="{FF2B5EF4-FFF2-40B4-BE49-F238E27FC236}">
-                <a16:creationId xmlns:a16="http://schemas.microsoft.com/office/drawing/2014/main" id="{95A770CF-8107-4464-8D2D-14D6EE7C4716}"/>
+                <a16:creationId xmlns:a16="http://schemas.microsoft.com/office/drawing/2014/main" id="{1E9F4293-59F6-47F3-997D-18985BE3A0B7}"/>
               </a:ext>
             </a:extLst>
           </p:cNvPr>
@@ -4485,7 +4485,7 @@
             <a:avLst/>
           </a:prstGeom>
           <a:solidFill xmlns:a="http://schemas.openxmlformats.org/drawingml/2006/main">
-            <a:srgbClr val="D9EEE6"/>
+            <a:srgbClr val="F3F6FA"/>
           </a:solidFill>
           <a:ln xmlns:a="http://schemas.openxmlformats.org/drawingml/2006/main" w="0">
             <a:noFill/>
@@ -4501,10 +4501,10 @@
           <p:nvPr/>
         </p:nvPicPr>
         <p:blipFill>
-          <a:blip xmlns:r="http://schemas.openxmlformats.org/officeDocument/2006/relationships" xmlns:a="http://schemas.openxmlformats.org/drawingml/2006/main" r:embed="Ra5051a3fa9d348b7">
+          <a:blip xmlns:r="http://schemas.openxmlformats.org/officeDocument/2006/relationships" xmlns:a="http://schemas.openxmlformats.org/drawingml/2006/main" r:embed="R45e284951ec24391">
             <a:extLst>
               <a:ext uri="{96DAC541-7B7A-43D3-8B79-37D633B846F1}">
-                <asvg:svgBlip xmlns:asvg="http://schemas.microsoft.com/office/drawing/2016/SVG/main" r:embed="R8dae656f18c14d0f"/>
+                <asvg:svgBlip xmlns:asvg="http://schemas.microsoft.com/office/drawing/2016/SVG/main" r:embed="R0b22cd7a48b44cd0"/>
               </a:ext>
             </a:extLst>
           </a:blip>
@@ -4525,7 +4525,7 @@
           <p:cNvPr id="19" name="Evidence 15.6 lakh">
             <a:extLst xmlns:a="http://schemas.openxmlformats.org/drawingml/2006/main">
               <a:ext uri="{FF2B5EF4-FFF2-40B4-BE49-F238E27FC236}">
-                <a16:creationId xmlns:a16="http://schemas.microsoft.com/office/drawing/2014/main" id="{3002F088-D0F9-4334-9BDA-D31CA2919589}"/>
+                <a16:creationId xmlns:a16="http://schemas.microsoft.com/office/drawing/2014/main" id="{58B347D8-C17D-48AC-B41D-779465952D07}"/>
               </a:ext>
             </a:extLst>
           </p:cNvPr>
@@ -4582,7 +4582,7 @@
           <p:cNvPr id="20" name="Evidence 15.6 lakh scope">
             <a:extLst xmlns:a="http://schemas.openxmlformats.org/drawingml/2006/main">
               <a:ext uri="{FF2B5EF4-FFF2-40B4-BE49-F238E27FC236}">
-                <a16:creationId xmlns:a16="http://schemas.microsoft.com/office/drawing/2014/main" id="{CC44C490-55DF-4495-8E15-59242DA352E6}"/>
+                <a16:creationId xmlns:a16="http://schemas.microsoft.com/office/drawing/2014/main" id="{64878CD5-C9BF-4027-B240-322CAAFC42FD}"/>
               </a:ext>
             </a:extLst>
           </p:cNvPr>
@@ -4639,7 +4639,7 @@
           <p:cNvPr id="21" name="Evidence 15.6 lakh source">
             <a:extLst xmlns:a="http://schemas.openxmlformats.org/drawingml/2006/main">
               <a:ext uri="{FF2B5EF4-FFF2-40B4-BE49-F238E27FC236}">
-                <a16:creationId xmlns:a16="http://schemas.microsoft.com/office/drawing/2014/main" id="{2EA8C87D-62A0-4BE4-BBDB-A6520D062742}"/>
+                <a16:creationId xmlns:a16="http://schemas.microsoft.com/office/drawing/2014/main" id="{14C2C84D-F58A-4E48-86C3-C07836893DDF}"/>
               </a:ext>
             </a:extLst>
           </p:cNvPr>
@@ -4685,7 +4685,7 @@
                 <a:latin typeface="Arial"/>
                 <a:ea typeface="Arial"/>
                 <a:cs typeface="Arial"/>
-                <a:hlinkClick xmlns:r="http://schemas.openxmlformats.org/officeDocument/2006/relationships" r:id="Ra9c5d9a018e94b89"/>
+                <a:hlinkClick xmlns:r="http://schemas.openxmlformats.org/officeDocument/2006/relationships" r:id="R9d9270c57adc46ad"/>
               </a:rPr>
               <a:t>IARC, GLOBOCAN 2024</a:t>
             </a:r>
@@ -4701,10 +4701,10 @@
           <p:nvPr/>
         </p:nvPicPr>
         <p:blipFill>
-          <a:blip xmlns:r="http://schemas.openxmlformats.org/officeDocument/2006/relationships" xmlns:a="http://schemas.openxmlformats.org/drawingml/2006/main" r:embed="R271b41cc77ef4fa8">
+          <a:blip xmlns:r="http://schemas.openxmlformats.org/officeDocument/2006/relationships" xmlns:a="http://schemas.openxmlformats.org/drawingml/2006/main" r:embed="Rea9f55adecf046c6">
             <a:extLst>
               <a:ext uri="{96DAC541-7B7A-43D3-8B79-37D633B846F1}">
-                <asvg:svgBlip xmlns:asvg="http://schemas.microsoft.com/office/drawing/2016/SVG/main" r:embed="Rb4edef06c91e47ab"/>
+                <asvg:svgBlip xmlns:asvg="http://schemas.microsoft.com/office/drawing/2016/SVG/main" r:embed="Rf3c270ef32bc427c"/>
               </a:ext>
             </a:extLst>
           </a:blip>
@@ -4725,7 +4725,7 @@
           <p:cNvPr id="23" name="Evidence 98.39%">
             <a:extLst xmlns:a="http://schemas.openxmlformats.org/drawingml/2006/main">
               <a:ext uri="{FF2B5EF4-FFF2-40B4-BE49-F238E27FC236}">
-                <a16:creationId xmlns:a16="http://schemas.microsoft.com/office/drawing/2014/main" id="{9277D3AA-D920-4C53-AF60-C5022F2AAB8F}"/>
+                <a16:creationId xmlns:a16="http://schemas.microsoft.com/office/drawing/2014/main" id="{EE20927A-6D4D-4FF3-8336-E334347C9A11}"/>
               </a:ext>
             </a:extLst>
           </p:cNvPr>
@@ -4782,7 +4782,7 @@
           <p:cNvPr id="24" name="Evidence 98.39% scope">
             <a:extLst xmlns:a="http://schemas.openxmlformats.org/drawingml/2006/main">
               <a:ext uri="{FF2B5EF4-FFF2-40B4-BE49-F238E27FC236}">
-                <a16:creationId xmlns:a16="http://schemas.microsoft.com/office/drawing/2014/main" id="{C9791D0D-E073-454E-8AB0-C395690C2289}"/>
+                <a16:creationId xmlns:a16="http://schemas.microsoft.com/office/drawing/2014/main" id="{1E9548D8-0E9D-489D-8BE1-B7A24A1DB433}"/>
               </a:ext>
             </a:extLst>
           </p:cNvPr>
@@ -4839,7 +4839,7 @@
           <p:cNvPr id="25" name="Evidence 98.39% source">
             <a:extLst xmlns:a="http://schemas.openxmlformats.org/drawingml/2006/main">
               <a:ext uri="{FF2B5EF4-FFF2-40B4-BE49-F238E27FC236}">
-                <a16:creationId xmlns:a16="http://schemas.microsoft.com/office/drawing/2014/main" id="{40CD45B3-BD7F-4000-A378-873A1073B9BA}"/>
+                <a16:creationId xmlns:a16="http://schemas.microsoft.com/office/drawing/2014/main" id="{0B582645-6F32-45F4-9126-14B24F7C9D5C}"/>
               </a:ext>
             </a:extLst>
           </p:cNvPr>
@@ -4885,7 +4885,7 @@
                 <a:latin typeface="Arial"/>
                 <a:ea typeface="Arial"/>
                 <a:cs typeface="Arial"/>
-                <a:hlinkClick xmlns:r="http://schemas.openxmlformats.org/officeDocument/2006/relationships" r:id="Rcda746b78fc4414a"/>
+                <a:hlinkClick xmlns:r="http://schemas.openxmlformats.org/officeDocument/2006/relationships" r:id="Re2daadf42a85445d"/>
               </a:rPr>
               <a:t>Patil et al., 2024</a:t>
             </a:r>
@@ -4901,10 +4901,10 @@
           <p:nvPr/>
         </p:nvPicPr>
         <p:blipFill>
-          <a:blip xmlns:r="http://schemas.openxmlformats.org/officeDocument/2006/relationships" xmlns:a="http://schemas.openxmlformats.org/drawingml/2006/main" r:embed="R00f25e175c4145d1">
+          <a:blip xmlns:r="http://schemas.openxmlformats.org/officeDocument/2006/relationships" xmlns:a="http://schemas.openxmlformats.org/drawingml/2006/main" r:embed="Rd80bf458939e4f24">
             <a:extLst>
               <a:ext uri="{96DAC541-7B7A-43D3-8B79-37D633B846F1}">
-                <asvg:svgBlip xmlns:asvg="http://schemas.microsoft.com/office/drawing/2016/SVG/main" r:embed="Rd80f3aa991f94769"/>
+                <asvg:svgBlip xmlns:asvg="http://schemas.microsoft.com/office/drawing/2016/SVG/main" r:embed="R11535fa347954080"/>
               </a:ext>
             </a:extLst>
           </a:blip>
@@ -4925,7 +4925,7 @@
           <p:cNvPr id="27" name="Evidence 88%">
             <a:extLst xmlns:a="http://schemas.openxmlformats.org/drawingml/2006/main">
               <a:ext uri="{FF2B5EF4-FFF2-40B4-BE49-F238E27FC236}">
-                <a16:creationId xmlns:a16="http://schemas.microsoft.com/office/drawing/2014/main" id="{9AFE624A-349D-4C0F-ABCB-50148CE952B2}"/>
+                <a16:creationId xmlns:a16="http://schemas.microsoft.com/office/drawing/2014/main" id="{E0C447DF-D940-4C3C-97E7-D92537A94B52}"/>
               </a:ext>
             </a:extLst>
           </p:cNvPr>
@@ -4982,7 +4982,7 @@
           <p:cNvPr id="28" name="Evidence 88% scope">
             <a:extLst xmlns:a="http://schemas.openxmlformats.org/drawingml/2006/main">
               <a:ext uri="{FF2B5EF4-FFF2-40B4-BE49-F238E27FC236}">
-                <a16:creationId xmlns:a16="http://schemas.microsoft.com/office/drawing/2014/main" id="{3C2B563D-1143-453D-90F0-55D6BA2BBAD7}"/>
+                <a16:creationId xmlns:a16="http://schemas.microsoft.com/office/drawing/2014/main" id="{FBA0C07F-72F3-45E9-A5F7-D7B77CDC7875}"/>
               </a:ext>
             </a:extLst>
           </p:cNvPr>
@@ -5039,7 +5039,7 @@
           <p:cNvPr id="29" name="Evidence 88% source">
             <a:extLst xmlns:a="http://schemas.openxmlformats.org/drawingml/2006/main">
               <a:ext uri="{FF2B5EF4-FFF2-40B4-BE49-F238E27FC236}">
-                <a16:creationId xmlns:a16="http://schemas.microsoft.com/office/drawing/2014/main" id="{8BCEF41D-F109-4EDF-965A-EF5BA7F010E8}"/>
+                <a16:creationId xmlns:a16="http://schemas.microsoft.com/office/drawing/2014/main" id="{6FDE1897-FC0D-4834-8D16-DCBD67ABCA08}"/>
               </a:ext>
             </a:extLst>
           </p:cNvPr>
@@ -5085,7 +5085,7 @@
                 <a:latin typeface="Arial"/>
                 <a:ea typeface="Arial"/>
                 <a:cs typeface="Arial"/>
-                <a:hlinkClick xmlns:r="http://schemas.openxmlformats.org/officeDocument/2006/relationships" r:id="R966a61598b434368"/>
+                <a:hlinkClick xmlns:r="http://schemas.openxmlformats.org/officeDocument/2006/relationships" r:id="Rbe58e6e529f445f7"/>
               </a:rPr>
               <a:t>IndiaSpend reporting; seven cities</a:t>
             </a:r>
@@ -5101,10 +5101,10 @@
           <p:nvPr/>
         </p:nvPicPr>
         <p:blipFill>
-          <a:blip xmlns:r="http://schemas.openxmlformats.org/officeDocument/2006/relationships" xmlns:a="http://schemas.openxmlformats.org/drawingml/2006/main" r:embed="R30939e948be1435b">
+          <a:blip xmlns:r="http://schemas.openxmlformats.org/officeDocument/2006/relationships" xmlns:a="http://schemas.openxmlformats.org/drawingml/2006/main" r:embed="Rb42be125c9c14c86">
             <a:extLst>
               <a:ext uri="{96DAC541-7B7A-43D3-8B79-37D633B846F1}">
-                <asvg:svgBlip xmlns:asvg="http://schemas.microsoft.com/office/drawing/2016/SVG/main" r:embed="Rbd9faffc2ed84d40"/>
+                <asvg:svgBlip xmlns:asvg="http://schemas.microsoft.com/office/drawing/2016/SVG/main" r:embed="R941dd79931b6442a"/>
               </a:ext>
             </a:extLst>
           </a:blip>
@@ -5125,7 +5125,7 @@
           <p:cNvPr id="31" name="Evidence 11.5%">
             <a:extLst xmlns:a="http://schemas.openxmlformats.org/drawingml/2006/main">
               <a:ext uri="{FF2B5EF4-FFF2-40B4-BE49-F238E27FC236}">
-                <a16:creationId xmlns:a16="http://schemas.microsoft.com/office/drawing/2014/main" id="{7AA94205-0F8F-4DF8-9B77-F8EE1F22B573}"/>
+                <a16:creationId xmlns:a16="http://schemas.microsoft.com/office/drawing/2014/main" id="{201B8E2E-10E9-4412-8470-3E9DE20A5A22}"/>
               </a:ext>
             </a:extLst>
           </p:cNvPr>
@@ -5182,7 +5182,7 @@
           <p:cNvPr id="32" name="Evidence 11.5% scope">
             <a:extLst xmlns:a="http://schemas.openxmlformats.org/drawingml/2006/main">
               <a:ext uri="{FF2B5EF4-FFF2-40B4-BE49-F238E27FC236}">
-                <a16:creationId xmlns:a16="http://schemas.microsoft.com/office/drawing/2014/main" id="{BA746BCE-8CD6-49C2-BE3E-CA0871C275FB}"/>
+                <a16:creationId xmlns:a16="http://schemas.microsoft.com/office/drawing/2014/main" id="{370DBF83-0EA4-405F-BE89-F08181E6DBF4}"/>
               </a:ext>
             </a:extLst>
           </p:cNvPr>
@@ -5239,7 +5239,7 @@
           <p:cNvPr id="33" name="Evidence 11.5% source">
             <a:extLst xmlns:a="http://schemas.openxmlformats.org/drawingml/2006/main">
               <a:ext uri="{FF2B5EF4-FFF2-40B4-BE49-F238E27FC236}">
-                <a16:creationId xmlns:a16="http://schemas.microsoft.com/office/drawing/2014/main" id="{58B3812E-B623-4C68-95D3-D9892DAA68B9}"/>
+                <a16:creationId xmlns:a16="http://schemas.microsoft.com/office/drawing/2014/main" id="{4221D382-B336-42F2-A88D-F14164135E61}"/>
               </a:ext>
             </a:extLst>
           </p:cNvPr>
@@ -5285,7 +5285,7 @@
                 <a:latin typeface="Arial"/>
                 <a:ea typeface="Arial"/>
                 <a:cs typeface="Arial"/>
-                <a:hlinkClick xmlns:r="http://schemas.openxmlformats.org/officeDocument/2006/relationships" r:id="R8411467bcc6b43ae"/>
+                <a:hlinkClick xmlns:r="http://schemas.openxmlformats.org/officeDocument/2006/relationships" r:id="Rf057f6d9d698446c"/>
               </a:rPr>
               <a:t>Jacob et al., CMC Vellore, 2026</a:t>
             </a:r>
@@ -5301,10 +5301,10 @@
           <p:nvPr/>
         </p:nvPicPr>
         <p:blipFill>
-          <a:blip xmlns:r="http://schemas.openxmlformats.org/officeDocument/2006/relationships" xmlns:a="http://schemas.openxmlformats.org/drawingml/2006/main" r:embed="Rcf2ba937c795462e">
+          <a:blip xmlns:r="http://schemas.openxmlformats.org/officeDocument/2006/relationships" xmlns:a="http://schemas.openxmlformats.org/drawingml/2006/main" r:embed="Re75c410e8930487e">
             <a:extLst>
               <a:ext uri="{96DAC541-7B7A-43D3-8B79-37D633B846F1}">
-                <asvg:svgBlip xmlns:asvg="http://schemas.microsoft.com/office/drawing/2016/SVG/main" r:embed="Re22df041d0754d0a"/>
+                <asvg:svgBlip xmlns:asvg="http://schemas.microsoft.com/office/drawing/2016/SVG/main" r:embed="R1ff1d7196100460b"/>
               </a:ext>
             </a:extLst>
           </a:blip>
@@ -5325,7 +5325,7 @@
           <p:cNvPr id="35" name="QI measure">
             <a:extLst xmlns:a="http://schemas.openxmlformats.org/drawingml/2006/main">
               <a:ext uri="{FF2B5EF4-FFF2-40B4-BE49-F238E27FC236}">
-                <a16:creationId xmlns:a16="http://schemas.microsoft.com/office/drawing/2014/main" id="{CE67983B-E7A7-41CA-A6D1-13F85849AD63}"/>
+                <a16:creationId xmlns:a16="http://schemas.microsoft.com/office/drawing/2014/main" id="{E435DA6C-E0C0-4C82-BE2F-7C6FA039AB03}"/>
               </a:ext>
             </a:extLst>
           </p:cNvPr>
@@ -5382,7 +5382,7 @@
           <p:cNvPr id="36" name="QI finding">
             <a:extLst xmlns:a="http://schemas.openxmlformats.org/drawingml/2006/main">
               <a:ext uri="{FF2B5EF4-FFF2-40B4-BE49-F238E27FC236}">
-                <a16:creationId xmlns:a16="http://schemas.microsoft.com/office/drawing/2014/main" id="{198CC26E-9B3B-44F9-857D-29EF847577C9}"/>
+                <a16:creationId xmlns:a16="http://schemas.microsoft.com/office/drawing/2014/main" id="{B207F852-586B-4074-887C-98E29FE815C5}"/>
               </a:ext>
             </a:extLst>
           </p:cNvPr>
@@ -5439,7 +5439,7 @@
           <p:cNvPr id="37" name="QI scope">
             <a:extLst xmlns:a="http://schemas.openxmlformats.org/drawingml/2006/main">
               <a:ext uri="{FF2B5EF4-FFF2-40B4-BE49-F238E27FC236}">
-                <a16:creationId xmlns:a16="http://schemas.microsoft.com/office/drawing/2014/main" id="{6BA89AF6-FD3F-4B80-B35A-E158C07D6384}"/>
+                <a16:creationId xmlns:a16="http://schemas.microsoft.com/office/drawing/2014/main" id="{DF0C099A-03C7-498E-9EB3-A91B8BC48944}"/>
               </a:ext>
             </a:extLst>
           </p:cNvPr>
@@ -5496,7 +5496,7 @@
           <p:cNvPr id="38" name="QI source">
             <a:extLst xmlns:a="http://schemas.openxmlformats.org/drawingml/2006/main">
               <a:ext uri="{FF2B5EF4-FFF2-40B4-BE49-F238E27FC236}">
-                <a16:creationId xmlns:a16="http://schemas.microsoft.com/office/drawing/2014/main" id="{A510FBFA-D30C-4D48-B1B5-AB275F2B7623}"/>
+                <a16:creationId xmlns:a16="http://schemas.microsoft.com/office/drawing/2014/main" id="{E92462C0-C6F6-4548-8DD8-3151E5B37025}"/>
               </a:ext>
             </a:extLst>
           </p:cNvPr>
@@ -5542,7 +5542,7 @@
                 <a:latin typeface="Arial"/>
                 <a:ea typeface="Arial"/>
                 <a:cs typeface="Arial"/>
-                <a:hlinkClick xmlns:r="http://schemas.openxmlformats.org/officeDocument/2006/relationships" r:id="Rc2f2862c8f6b4886"/>
+                <a:hlinkClick xmlns:r="http://schemas.openxmlformats.org/officeDocument/2006/relationships" r:id="Rfaae270b45c54b70"/>
               </a:rPr>
               <a:t>Thangasamy et al., 2025</a:t>
             </a:r>
@@ -5554,7 +5554,7 @@
           <p:cNvPr id="39" name="Evidence boundary">
             <a:extLst xmlns:a="http://schemas.openxmlformats.org/drawingml/2006/main">
               <a:ext uri="{FF2B5EF4-FFF2-40B4-BE49-F238E27FC236}">
-                <a16:creationId xmlns:a16="http://schemas.microsoft.com/office/drawing/2014/main" id="{31384E8A-EA7B-42B9-B32E-4B04A153CAB6}"/>
+                <a16:creationId xmlns:a16="http://schemas.microsoft.com/office/drawing/2014/main" id="{AA6519F0-4912-4824-A284-E3C9EF661978}"/>
               </a:ext>
             </a:extLst>
           </p:cNvPr>
@@ -5640,7 +5640,7 @@
           <p:cNvPr id="14" name="Slide title">
             <a:extLst xmlns:a="http://schemas.openxmlformats.org/drawingml/2006/main">
               <a:ext uri="{FF2B5EF4-FFF2-40B4-BE49-F238E27FC236}">
-                <a16:creationId xmlns:a16="http://schemas.microsoft.com/office/drawing/2014/main" id="{DB0A71C5-8968-4792-9D2B-35E5DE2DBC1F}"/>
+                <a16:creationId xmlns:a16="http://schemas.microsoft.com/office/drawing/2014/main" id="{577153C3-8370-4CB7-9D0A-449C92784D15}"/>
               </a:ext>
             </a:extLst>
           </p:cNvPr>
@@ -5697,7 +5697,7 @@
           <p:cNvPr id="2" name="Human review">
             <a:extLst xmlns:a="http://schemas.openxmlformats.org/drawingml/2006/main">
               <a:ext uri="{FF2B5EF4-FFF2-40B4-BE49-F238E27FC236}">
-                <a16:creationId xmlns:a16="http://schemas.microsoft.com/office/drawing/2014/main" id="{AFD7557B-D0BC-4539-A1CD-B67BEA487A35}"/>
+                <a16:creationId xmlns:a16="http://schemas.microsoft.com/office/drawing/2014/main" id="{1A90B96C-0D9D-43F1-85F6-44EA2B80590A}"/>
               </a:ext>
             </a:extLst>
           </p:cNvPr>
@@ -5758,7 +5758,7 @@
           <p:nvPr/>
         </p:nvPicPr>
         <p:blipFill>
-          <a:blip xmlns:r="http://schemas.openxmlformats.org/officeDocument/2006/relationships" xmlns:a="http://schemas.openxmlformats.org/drawingml/2006/main" r:embed="R92499889206a4ff1"/>
+          <a:blip xmlns:r="http://schemas.openxmlformats.org/officeDocument/2006/relationships" xmlns:a="http://schemas.openxmlformats.org/drawingml/2006/main" r:embed="R6f33b645acd242a5"/>
           <a:stretch xmlns:a="http://schemas.openxmlformats.org/drawingml/2006/main"/>
         </p:blipFill>
         <p:spPr>
@@ -5776,7 +5776,7 @@
           <p:cNvPr id="4" name="Source traceability">
             <a:extLst xmlns:a="http://schemas.openxmlformats.org/drawingml/2006/main">
               <a:ext uri="{FF2B5EF4-FFF2-40B4-BE49-F238E27FC236}">
-                <a16:creationId xmlns:a16="http://schemas.microsoft.com/office/drawing/2014/main" id="{ED58B33B-0F2B-45F1-B24A-FA4F77A3B995}"/>
+                <a16:creationId xmlns:a16="http://schemas.microsoft.com/office/drawing/2014/main" id="{0A907611-FFB4-4C8E-8EEE-135909407028}"/>
               </a:ext>
             </a:extLst>
           </p:cNvPr>
@@ -5833,7 +5833,7 @@
           <p:cNvPr id="5" name="Proposed voice provider">
             <a:extLst xmlns:a="http://schemas.openxmlformats.org/drawingml/2006/main">
               <a:ext uri="{FF2B5EF4-FFF2-40B4-BE49-F238E27FC236}">
-                <a16:creationId xmlns:a16="http://schemas.microsoft.com/office/drawing/2014/main" id="{A164A3D8-FBFB-4DDE-8A0A-23D351F03D43}"/>
+                <a16:creationId xmlns:a16="http://schemas.microsoft.com/office/drawing/2014/main" id="{74F304B2-D521-409C-9532-8F43738DAFD8}"/>
               </a:ext>
             </a:extLst>
           </p:cNvPr>
@@ -5879,7 +5879,7 @@
                 <a:latin typeface="Arial"/>
                 <a:ea typeface="Arial"/>
                 <a:cs typeface="Arial"/>
-                <a:hlinkClick xmlns:r="http://schemas.openxmlformats.org/officeDocument/2006/relationships" r:id="R4bfbad673ad24c48"/>
+                <a:hlinkClick xmlns:r="http://schemas.openxmlformats.org/officeDocument/2006/relationships" r:id="Rcfcd6a102ba14ea8"/>
               </a:rPr>
               <a:t>Planned with Sarvam AI: Indian-language speech, translation and read-aloud.</a:t>
             </a:r>
@@ -5891,7 +5891,7 @@
           <p:cNvPr id="6" name="AI step 1">
             <a:extLst xmlns:a="http://schemas.openxmlformats.org/drawingml/2006/main">
               <a:ext uri="{FF2B5EF4-FFF2-40B4-BE49-F238E27FC236}">
-                <a16:creationId xmlns:a16="http://schemas.microsoft.com/office/drawing/2014/main" id="{EE94EB4D-DEBB-43AE-9590-ADF081D0215F}"/>
+                <a16:creationId xmlns:a16="http://schemas.microsoft.com/office/drawing/2014/main" id="{DCEB05D0-729D-4A0E-A91A-75059EA83975}"/>
               </a:ext>
             </a:extLst>
           </p:cNvPr>
@@ -5948,7 +5948,7 @@
           <p:cNvPr id="7" name="AI step 1 detail">
             <a:extLst xmlns:a="http://schemas.openxmlformats.org/drawingml/2006/main">
               <a:ext uri="{FF2B5EF4-FFF2-40B4-BE49-F238E27FC236}">
-                <a16:creationId xmlns:a16="http://schemas.microsoft.com/office/drawing/2014/main" id="{ACAA817E-7528-43DF-8A9F-A3996D962D45}"/>
+                <a16:creationId xmlns:a16="http://schemas.microsoft.com/office/drawing/2014/main" id="{FF3CB9E8-1B42-466F-9A68-FA0020D49935}"/>
               </a:ext>
             </a:extLst>
           </p:cNvPr>
@@ -6005,7 +6005,7 @@
           <p:cNvPr id="8" name="AI step 2">
             <a:extLst xmlns:a="http://schemas.openxmlformats.org/drawingml/2006/main">
               <a:ext uri="{FF2B5EF4-FFF2-40B4-BE49-F238E27FC236}">
-                <a16:creationId xmlns:a16="http://schemas.microsoft.com/office/drawing/2014/main" id="{A280D7FD-D147-4A8E-A6B1-73EDB7745067}"/>
+                <a16:creationId xmlns:a16="http://schemas.microsoft.com/office/drawing/2014/main" id="{26E728B4-8D98-4DF7-8815-F9C9A9E652F1}"/>
               </a:ext>
             </a:extLst>
           </p:cNvPr>
@@ -6062,7 +6062,7 @@
           <p:cNvPr id="9" name="AI step 2 detail">
             <a:extLst xmlns:a="http://schemas.openxmlformats.org/drawingml/2006/main">
               <a:ext uri="{FF2B5EF4-FFF2-40B4-BE49-F238E27FC236}">
-                <a16:creationId xmlns:a16="http://schemas.microsoft.com/office/drawing/2014/main" id="{14BA0C46-F02D-49CB-A0DB-5A1AF54E584B}"/>
+                <a16:creationId xmlns:a16="http://schemas.microsoft.com/office/drawing/2014/main" id="{284969CB-3EC2-43D8-8A1D-73D7B62AA4A3}"/>
               </a:ext>
             </a:extLst>
           </p:cNvPr>
@@ -6119,7 +6119,7 @@
           <p:cNvPr id="10" name="AI step 3">
             <a:extLst xmlns:a="http://schemas.openxmlformats.org/drawingml/2006/main">
               <a:ext uri="{FF2B5EF4-FFF2-40B4-BE49-F238E27FC236}">
-                <a16:creationId xmlns:a16="http://schemas.microsoft.com/office/drawing/2014/main" id="{9FA69D5A-8CC4-442E-BF9A-E2AE4D48FD71}"/>
+                <a16:creationId xmlns:a16="http://schemas.microsoft.com/office/drawing/2014/main" id="{1B4FDA8F-34F6-4651-954C-768327FA4353}"/>
               </a:ext>
             </a:extLst>
           </p:cNvPr>
@@ -6176,7 +6176,7 @@
           <p:cNvPr id="11" name="AI step 3 detail">
             <a:extLst xmlns:a="http://schemas.openxmlformats.org/drawingml/2006/main">
               <a:ext uri="{FF2B5EF4-FFF2-40B4-BE49-F238E27FC236}">
-                <a16:creationId xmlns:a16="http://schemas.microsoft.com/office/drawing/2014/main" id="{BF6F6A33-B9B5-44CC-871D-6F99C6B3D3AC}"/>
+                <a16:creationId xmlns:a16="http://schemas.microsoft.com/office/drawing/2014/main" id="{6CC81D7C-C411-466C-B65A-1574F013BBF6}"/>
               </a:ext>
             </a:extLst>
           </p:cNvPr>
@@ -6233,7 +6233,7 @@
           <p:cNvPr id="12" name="AI step 4">
             <a:extLst xmlns:a="http://schemas.openxmlformats.org/drawingml/2006/main">
               <a:ext uri="{FF2B5EF4-FFF2-40B4-BE49-F238E27FC236}">
-                <a16:creationId xmlns:a16="http://schemas.microsoft.com/office/drawing/2014/main" id="{FF107825-282F-4E38-94E7-E76FB050C094}"/>
+                <a16:creationId xmlns:a16="http://schemas.microsoft.com/office/drawing/2014/main" id="{16D5C437-5367-4F95-B572-99E304C2D8BB}"/>
               </a:ext>
             </a:extLst>
           </p:cNvPr>
@@ -6290,7 +6290,7 @@
           <p:cNvPr id="13" name="AI step 4 detail">
             <a:extLst xmlns:a="http://schemas.openxmlformats.org/drawingml/2006/main">
               <a:ext uri="{FF2B5EF4-FFF2-40B4-BE49-F238E27FC236}">
-                <a16:creationId xmlns:a16="http://schemas.microsoft.com/office/drawing/2014/main" id="{F1D8909E-E9D8-4BB0-920D-31C9D0B974EF}"/>
+                <a16:creationId xmlns:a16="http://schemas.microsoft.com/office/drawing/2014/main" id="{DD688A44-2C33-4DC9-A2DE-1DE2DBE8B512}"/>
               </a:ext>
             </a:extLst>
           </p:cNvPr>
@@ -6376,7 +6376,7 @@
           <p:cNvPr id="11" name="Slide title">
             <a:extLst xmlns:a="http://schemas.openxmlformats.org/drawingml/2006/main">
               <a:ext uri="{FF2B5EF4-FFF2-40B4-BE49-F238E27FC236}">
-                <a16:creationId xmlns:a16="http://schemas.microsoft.com/office/drawing/2014/main" id="{4504641A-06E2-4466-930F-3C999D4E45F5}"/>
+                <a16:creationId xmlns:a16="http://schemas.microsoft.com/office/drawing/2014/main" id="{D7440968-45D0-4F41-BB3C-05A3D1B0592F}"/>
               </a:ext>
             </a:extLst>
           </p:cNvPr>
@@ -6433,7 +6433,7 @@
           <p:cNvPr id="2" name="Records assistant purpose">
             <a:extLst xmlns:a="http://schemas.openxmlformats.org/drawingml/2006/main">
               <a:ext uri="{FF2B5EF4-FFF2-40B4-BE49-F238E27FC236}">
-                <a16:creationId xmlns:a16="http://schemas.microsoft.com/office/drawing/2014/main" id="{E503F52C-6380-499A-8835-308A1149274B}"/>
+                <a16:creationId xmlns:a16="http://schemas.microsoft.com/office/drawing/2014/main" id="{6FA5CB08-1A0A-4866-966A-A83D024FAD6A}"/>
               </a:ext>
             </a:extLst>
           </p:cNvPr>
@@ -6494,7 +6494,7 @@
           <p:nvPr/>
         </p:nvPicPr>
         <p:blipFill>
-          <a:blip xmlns:r="http://schemas.openxmlformats.org/officeDocument/2006/relationships" xmlns:a="http://schemas.openxmlformats.org/drawingml/2006/main" r:embed="R611ffb97cae14403"/>
+          <a:blip xmlns:r="http://schemas.openxmlformats.org/officeDocument/2006/relationships" xmlns:a="http://schemas.openxmlformats.org/drawingml/2006/main" r:embed="Rf9322f8125d945dc"/>
           <a:stretch xmlns:a="http://schemas.openxmlformats.org/drawingml/2006/main"/>
         </p:blipFill>
         <p:spPr>
@@ -6512,7 +6512,7 @@
           <p:cNvPr id="4" name="Records assistant 1">
             <a:extLst xmlns:a="http://schemas.openxmlformats.org/drawingml/2006/main">
               <a:ext uri="{FF2B5EF4-FFF2-40B4-BE49-F238E27FC236}">
-                <a16:creationId xmlns:a16="http://schemas.microsoft.com/office/drawing/2014/main" id="{68316089-A931-492A-8C80-2577EDC6DA57}"/>
+                <a16:creationId xmlns:a16="http://schemas.microsoft.com/office/drawing/2014/main" id="{2C90545F-A970-4BB3-8091-A5EDB403B542}"/>
               </a:ext>
             </a:extLst>
           </p:cNvPr>
@@ -6569,7 +6569,7 @@
           <p:cNvPr id="5" name="Records assistant 1 detail">
             <a:extLst xmlns:a="http://schemas.openxmlformats.org/drawingml/2006/main">
               <a:ext uri="{FF2B5EF4-FFF2-40B4-BE49-F238E27FC236}">
-                <a16:creationId xmlns:a16="http://schemas.microsoft.com/office/drawing/2014/main" id="{51BED6C6-4E3A-4761-B539-7CBED264152E}"/>
+                <a16:creationId xmlns:a16="http://schemas.microsoft.com/office/drawing/2014/main" id="{F441F9C6-CF95-4301-91DC-E96ECA978000}"/>
               </a:ext>
             </a:extLst>
           </p:cNvPr>
@@ -6626,7 +6626,7 @@
           <p:cNvPr id="6" name="Records assistant 2">
             <a:extLst xmlns:a="http://schemas.openxmlformats.org/drawingml/2006/main">
               <a:ext uri="{FF2B5EF4-FFF2-40B4-BE49-F238E27FC236}">
-                <a16:creationId xmlns:a16="http://schemas.microsoft.com/office/drawing/2014/main" id="{5898EC28-F39E-40AA-BEBB-B99E32CDD7BA}"/>
+                <a16:creationId xmlns:a16="http://schemas.microsoft.com/office/drawing/2014/main" id="{E740F482-06A8-4588-87EE-5775015A9F1A}"/>
               </a:ext>
             </a:extLst>
           </p:cNvPr>
@@ -6683,7 +6683,7 @@
           <p:cNvPr id="7" name="Records assistant 2 detail">
             <a:extLst xmlns:a="http://schemas.openxmlformats.org/drawingml/2006/main">
               <a:ext uri="{FF2B5EF4-FFF2-40B4-BE49-F238E27FC236}">
-                <a16:creationId xmlns:a16="http://schemas.microsoft.com/office/drawing/2014/main" id="{0BD84060-C816-4E9D-A203-0CC3F2E78AD8}"/>
+                <a16:creationId xmlns:a16="http://schemas.microsoft.com/office/drawing/2014/main" id="{2BCFA858-F820-4957-928B-BD97C2E1E40D}"/>
               </a:ext>
             </a:extLst>
           </p:cNvPr>
@@ -6740,7 +6740,7 @@
           <p:cNvPr id="8" name="Records assistant 3">
             <a:extLst xmlns:a="http://schemas.openxmlformats.org/drawingml/2006/main">
               <a:ext uri="{FF2B5EF4-FFF2-40B4-BE49-F238E27FC236}">
-                <a16:creationId xmlns:a16="http://schemas.microsoft.com/office/drawing/2014/main" id="{A265BAB1-8609-428B-886E-8C38A5340526}"/>
+                <a16:creationId xmlns:a16="http://schemas.microsoft.com/office/drawing/2014/main" id="{91BE0889-B5D1-4F71-B74D-B6196D4572B8}"/>
               </a:ext>
             </a:extLst>
           </p:cNvPr>
@@ -6797,7 +6797,7 @@
           <p:cNvPr id="9" name="Records assistant 3 detail">
             <a:extLst xmlns:a="http://schemas.openxmlformats.org/drawingml/2006/main">
               <a:ext uri="{FF2B5EF4-FFF2-40B4-BE49-F238E27FC236}">
-                <a16:creationId xmlns:a16="http://schemas.microsoft.com/office/drawing/2014/main" id="{6035E60C-72D7-474F-8269-DB728849E311}"/>
+                <a16:creationId xmlns:a16="http://schemas.microsoft.com/office/drawing/2014/main" id="{893D62CA-2507-46D4-9C7A-9053BAFC71D1}"/>
               </a:ext>
             </a:extLst>
           </p:cNvPr>
@@ -6854,7 +6854,7 @@
           <p:cNvPr id="10" name="Clinical scope">
             <a:extLst xmlns:a="http://schemas.openxmlformats.org/drawingml/2006/main">
               <a:ext uri="{FF2B5EF4-FFF2-40B4-BE49-F238E27FC236}">
-                <a16:creationId xmlns:a16="http://schemas.microsoft.com/office/drawing/2014/main" id="{3CCE63B7-39A9-46E3-B10D-5D32F7A9C3A9}"/>
+                <a16:creationId xmlns:a16="http://schemas.microsoft.com/office/drawing/2014/main" id="{521ED95C-5F2C-4429-9D9E-11AD4A979E40}"/>
               </a:ext>
             </a:extLst>
           </p:cNvPr>
@@ -6940,7 +6940,7 @@
           <p:cNvPr id="40" name="Slide title">
             <a:extLst xmlns:a="http://schemas.openxmlformats.org/drawingml/2006/main">
               <a:ext uri="{FF2B5EF4-FFF2-40B4-BE49-F238E27FC236}">
-                <a16:creationId xmlns:a16="http://schemas.microsoft.com/office/drawing/2014/main" id="{78B95B02-7ACE-4965-90A3-988A2A5D4B2B}"/>
+                <a16:creationId xmlns:a16="http://schemas.microsoft.com/office/drawing/2014/main" id="{87E1DA51-AEF2-4FD0-AACB-B54D35EDE066}"/>
               </a:ext>
             </a:extLst>
           </p:cNvPr>
@@ -6997,7 +6997,7 @@
           <p:cNvPr id="2" name="Three sign-ins">
             <a:extLst xmlns:a="http://schemas.openxmlformats.org/drawingml/2006/main">
               <a:ext uri="{FF2B5EF4-FFF2-40B4-BE49-F238E27FC236}">
-                <a16:creationId xmlns:a16="http://schemas.microsoft.com/office/drawing/2014/main" id="{DF9000DF-575C-4DC7-B280-E827F61BBF57}"/>
+                <a16:creationId xmlns:a16="http://schemas.microsoft.com/office/drawing/2014/main" id="{C4920B5E-0E82-4DB2-8ED3-7DE69A11DB6F}"/>
               </a:ext>
             </a:extLst>
           </p:cNvPr>
@@ -7054,7 +7054,7 @@
           <p:cNvPr id="3" name="">
             <a:extLst xmlns:a="http://schemas.openxmlformats.org/drawingml/2006/main">
               <a:ext uri="{FF2B5EF4-FFF2-40B4-BE49-F238E27FC236}">
-                <a16:creationId xmlns:a16="http://schemas.microsoft.com/office/drawing/2014/main" id="{492E3A45-8EAF-49A8-A9C0-F76593E0974F}"/>
+                <a16:creationId xmlns:a16="http://schemas.microsoft.com/office/drawing/2014/main" id="{A6842D69-1617-497D-8417-884D7D4E973B}"/>
               </a:ext>
             </a:extLst>
           </p:cNvPr>
@@ -7086,7 +7086,7 @@
           <p:cNvPr id="4" name="Patient sign-in">
             <a:extLst xmlns:a="http://schemas.openxmlformats.org/drawingml/2006/main">
               <a:ext uri="{FF2B5EF4-FFF2-40B4-BE49-F238E27FC236}">
-                <a16:creationId xmlns:a16="http://schemas.microsoft.com/office/drawing/2014/main" id="{2147A091-1B8D-43D0-9363-57874BBDA6FF}"/>
+                <a16:creationId xmlns:a16="http://schemas.microsoft.com/office/drawing/2014/main" id="{6F3B15E5-737D-4D72-BC35-C01E8CC85425}"/>
               </a:ext>
             </a:extLst>
           </p:cNvPr>
@@ -7143,7 +7143,7 @@
           <p:cNvPr id="5" name="">
             <a:extLst xmlns:a="http://schemas.openxmlformats.org/drawingml/2006/main">
               <a:ext uri="{FF2B5EF4-FFF2-40B4-BE49-F238E27FC236}">
-                <a16:creationId xmlns:a16="http://schemas.microsoft.com/office/drawing/2014/main" id="{350AC942-1405-4B82-AD29-7D0DD69B1E73}"/>
+                <a16:creationId xmlns:a16="http://schemas.microsoft.com/office/drawing/2014/main" id="{525B9DF6-68ED-4D23-82AC-969991827266}"/>
               </a:ext>
             </a:extLst>
           </p:cNvPr>
@@ -7175,7 +7175,7 @@
           <p:cNvPr id="6" name="Family sign-in">
             <a:extLst xmlns:a="http://schemas.openxmlformats.org/drawingml/2006/main">
               <a:ext uri="{FF2B5EF4-FFF2-40B4-BE49-F238E27FC236}">
-                <a16:creationId xmlns:a16="http://schemas.microsoft.com/office/drawing/2014/main" id="{78F8182B-6FB3-417F-B2B5-F67083862536}"/>
+                <a16:creationId xmlns:a16="http://schemas.microsoft.com/office/drawing/2014/main" id="{DC472386-5176-48A5-B1C8-4F23B4A6E92D}"/>
               </a:ext>
             </a:extLst>
           </p:cNvPr>
@@ -7232,7 +7232,7 @@
           <p:cNvPr id="7" name="">
             <a:extLst xmlns:a="http://schemas.openxmlformats.org/drawingml/2006/main">
               <a:ext uri="{FF2B5EF4-FFF2-40B4-BE49-F238E27FC236}">
-                <a16:creationId xmlns:a16="http://schemas.microsoft.com/office/drawing/2014/main" id="{7E9B816A-E9B7-44C1-A0E2-2242FC12CD0D}"/>
+                <a16:creationId xmlns:a16="http://schemas.microsoft.com/office/drawing/2014/main" id="{5FA97D05-D2BD-48B2-9D7B-1FDCDF6B1409}"/>
               </a:ext>
             </a:extLst>
           </p:cNvPr>
@@ -7264,7 +7264,7 @@
           <p:cNvPr id="8" name="Doctor sign-in">
             <a:extLst xmlns:a="http://schemas.openxmlformats.org/drawingml/2006/main">
               <a:ext uri="{FF2B5EF4-FFF2-40B4-BE49-F238E27FC236}">
-                <a16:creationId xmlns:a16="http://schemas.microsoft.com/office/drawing/2014/main" id="{ABC0ACC1-ADCD-455F-A13C-94F57F164733}"/>
+                <a16:creationId xmlns:a16="http://schemas.microsoft.com/office/drawing/2014/main" id="{5961DCAC-5D81-47EC-A638-4A9B360F583D}"/>
               </a:ext>
             </a:extLst>
           </p:cNvPr>
@@ -7321,7 +7321,7 @@
           <p:cNvPr id="9" name="Before the visit">
             <a:extLst xmlns:a="http://schemas.openxmlformats.org/drawingml/2006/main">
               <a:ext uri="{FF2B5EF4-FFF2-40B4-BE49-F238E27FC236}">
-                <a16:creationId xmlns:a16="http://schemas.microsoft.com/office/drawing/2014/main" id="{53C77195-85DE-49D4-9FC3-7737722AE550}"/>
+                <a16:creationId xmlns:a16="http://schemas.microsoft.com/office/drawing/2014/main" id="{04C4A337-22D1-4F40-8542-1A3DE9185822}"/>
               </a:ext>
             </a:extLst>
           </p:cNvPr>
@@ -7351,7 +7351,7 @@
           <p:cNvPr id="10" name="Between visits">
             <a:extLst xmlns:a="http://schemas.openxmlformats.org/drawingml/2006/main">
               <a:ext uri="{FF2B5EF4-FFF2-40B4-BE49-F238E27FC236}">
-                <a16:creationId xmlns:a16="http://schemas.microsoft.com/office/drawing/2014/main" id="{7C3E056D-F30F-4442-833A-57D404C480DF}"/>
+                <a16:creationId xmlns:a16="http://schemas.microsoft.com/office/drawing/2014/main" id="{5C37B9BC-94D9-4963-A796-C5E189FC9C8A}"/>
               </a:ext>
             </a:extLst>
           </p:cNvPr>
@@ -7385,10 +7385,10 @@
           <p:nvPr/>
         </p:nvPicPr>
         <p:blipFill>
-          <a:blip xmlns:r="http://schemas.openxmlformats.org/officeDocument/2006/relationships" xmlns:a="http://schemas.openxmlformats.org/drawingml/2006/main" r:embed="Rb0c129a9f4e14e64">
+          <a:blip xmlns:r="http://schemas.openxmlformats.org/officeDocument/2006/relationships" xmlns:a="http://schemas.openxmlformats.org/drawingml/2006/main" r:embed="R4ca9e91ced4f48b8">
             <a:extLst>
               <a:ext uri="{96DAC541-7B7A-43D3-8B79-37D633B846F1}">
-                <asvg:svgBlip xmlns:asvg="http://schemas.microsoft.com/office/drawing/2016/SVG/main" r:embed="R8eff60f5fb184c11"/>
+                <asvg:svgBlip xmlns:asvg="http://schemas.microsoft.com/office/drawing/2016/SVG/main" r:embed="Ra703ca7f41d94e06"/>
               </a:ext>
             </a:extLst>
           </a:blip>
@@ -7409,7 +7409,7 @@
           <p:cNvPr id="12" name="Family journey number 1">
             <a:extLst xmlns:a="http://schemas.openxmlformats.org/drawingml/2006/main">
               <a:ext uri="{FF2B5EF4-FFF2-40B4-BE49-F238E27FC236}">
-                <a16:creationId xmlns:a16="http://schemas.microsoft.com/office/drawing/2014/main" id="{D966EF71-4EFE-40B5-9221-C575C35BDB1A}"/>
+                <a16:creationId xmlns:a16="http://schemas.microsoft.com/office/drawing/2014/main" id="{A6C47822-3B5F-46BE-97A7-E8CD9FE35920}"/>
               </a:ext>
             </a:extLst>
           </p:cNvPr>
@@ -7466,7 +7466,7 @@
           <p:cNvPr id="13" name="Family journey 1">
             <a:extLst xmlns:a="http://schemas.openxmlformats.org/drawingml/2006/main">
               <a:ext uri="{FF2B5EF4-FFF2-40B4-BE49-F238E27FC236}">
-                <a16:creationId xmlns:a16="http://schemas.microsoft.com/office/drawing/2014/main" id="{1BBB2A8D-018D-401E-88BC-22D149AB5AE0}"/>
+                <a16:creationId xmlns:a16="http://schemas.microsoft.com/office/drawing/2014/main" id="{6014A2B7-7CE0-4B8C-B698-C0292F812E8D}"/>
               </a:ext>
             </a:extLst>
           </p:cNvPr>
@@ -7523,7 +7523,7 @@
           <p:cNvPr id="14" name="Family journey 1 detail">
             <a:extLst xmlns:a="http://schemas.openxmlformats.org/drawingml/2006/main">
               <a:ext uri="{FF2B5EF4-FFF2-40B4-BE49-F238E27FC236}">
-                <a16:creationId xmlns:a16="http://schemas.microsoft.com/office/drawing/2014/main" id="{24924FF8-78DC-401A-BC49-73ED395EF6C4}"/>
+                <a16:creationId xmlns:a16="http://schemas.microsoft.com/office/drawing/2014/main" id="{E5616888-DCB3-43F3-8270-833D6C376539}"/>
               </a:ext>
             </a:extLst>
           </p:cNvPr>
@@ -7584,10 +7584,10 @@
           <p:nvPr/>
         </p:nvPicPr>
         <p:blipFill>
-          <a:blip xmlns:r="http://schemas.openxmlformats.org/officeDocument/2006/relationships" xmlns:a="http://schemas.openxmlformats.org/drawingml/2006/main" r:embed="R16947568142c44cc">
+          <a:blip xmlns:r="http://schemas.openxmlformats.org/officeDocument/2006/relationships" xmlns:a="http://schemas.openxmlformats.org/drawingml/2006/main" r:embed="R70edcd1cb61a4ba9">
             <a:extLst>
               <a:ext uri="{96DAC541-7B7A-43D3-8B79-37D633B846F1}">
-                <asvg:svgBlip xmlns:asvg="http://schemas.microsoft.com/office/drawing/2016/SVG/main" r:embed="R9d70a41c5352417d"/>
+                <asvg:svgBlip xmlns:asvg="http://schemas.microsoft.com/office/drawing/2016/SVG/main" r:embed="Rfc2c60352bfe4b8a"/>
               </a:ext>
             </a:extLst>
           </a:blip>
@@ -7612,10 +7612,10 @@
           <p:nvPr/>
         </p:nvPicPr>
         <p:blipFill>
-          <a:blip xmlns:r="http://schemas.openxmlformats.org/officeDocument/2006/relationships" xmlns:a="http://schemas.openxmlformats.org/drawingml/2006/main" r:embed="R7191a9ca12374df3">
+          <a:blip xmlns:r="http://schemas.openxmlformats.org/officeDocument/2006/relationships" xmlns:a="http://schemas.openxmlformats.org/drawingml/2006/main" r:embed="R5d3f072150eb44fe">
             <a:extLst>
               <a:ext uri="{96DAC541-7B7A-43D3-8B79-37D633B846F1}">
-                <asvg:svgBlip xmlns:asvg="http://schemas.microsoft.com/office/drawing/2016/SVG/main" r:embed="Ree727492da4a45a2"/>
+                <asvg:svgBlip xmlns:asvg="http://schemas.microsoft.com/office/drawing/2016/SVG/main" r:embed="Rab5aca4660b040dd"/>
               </a:ext>
             </a:extLst>
           </a:blip>
@@ -7636,7 +7636,7 @@
           <p:cNvPr id="17" name="Family journey number 2">
             <a:extLst xmlns:a="http://schemas.openxmlformats.org/drawingml/2006/main">
               <a:ext uri="{FF2B5EF4-FFF2-40B4-BE49-F238E27FC236}">
-                <a16:creationId xmlns:a16="http://schemas.microsoft.com/office/drawing/2014/main" id="{3BF274DF-DA28-4D05-B825-2CC9AD2D36C0}"/>
+                <a16:creationId xmlns:a16="http://schemas.microsoft.com/office/drawing/2014/main" id="{EAD4784B-3148-4DCB-A04B-C986A7CD39DC}"/>
               </a:ext>
             </a:extLst>
           </p:cNvPr>
@@ -7693,7 +7693,7 @@
           <p:cNvPr id="18" name="Family journey 2">
             <a:extLst xmlns:a="http://schemas.openxmlformats.org/drawingml/2006/main">
               <a:ext uri="{FF2B5EF4-FFF2-40B4-BE49-F238E27FC236}">
-                <a16:creationId xmlns:a16="http://schemas.microsoft.com/office/drawing/2014/main" id="{0C285198-0AF8-4668-B77E-785E67FF19B9}"/>
+                <a16:creationId xmlns:a16="http://schemas.microsoft.com/office/drawing/2014/main" id="{CD5FAAED-69D9-4937-B26F-3F6C6B196DED}"/>
               </a:ext>
             </a:extLst>
           </p:cNvPr>
@@ -7750,7 +7750,7 @@
           <p:cNvPr id="19" name="Family journey 2 detail">
             <a:extLst xmlns:a="http://schemas.openxmlformats.org/drawingml/2006/main">
               <a:ext uri="{FF2B5EF4-FFF2-40B4-BE49-F238E27FC236}">
-                <a16:creationId xmlns:a16="http://schemas.microsoft.com/office/drawing/2014/main" id="{7435F21D-04E2-4584-B0F2-65C073A1ACAB}"/>
+                <a16:creationId xmlns:a16="http://schemas.microsoft.com/office/drawing/2014/main" id="{33457DA6-3BA0-4C5F-A52C-056295323FF2}"/>
               </a:ext>
             </a:extLst>
           </p:cNvPr>
@@ -7811,10 +7811,10 @@
           <p:nvPr/>
         </p:nvPicPr>
         <p:blipFill>
-          <a:blip xmlns:r="http://schemas.openxmlformats.org/officeDocument/2006/relationships" xmlns:a="http://schemas.openxmlformats.org/drawingml/2006/main" r:embed="R67157b6d34e04ad2">
+          <a:blip xmlns:r="http://schemas.openxmlformats.org/officeDocument/2006/relationships" xmlns:a="http://schemas.openxmlformats.org/drawingml/2006/main" r:embed="Re8c130d34a5a479c">
             <a:extLst>
               <a:ext uri="{96DAC541-7B7A-43D3-8B79-37D633B846F1}">
-                <asvg:svgBlip xmlns:asvg="http://schemas.microsoft.com/office/drawing/2016/SVG/main" r:embed="Rfb0c703e99fa4b60"/>
+                <asvg:svgBlip xmlns:asvg="http://schemas.microsoft.com/office/drawing/2016/SVG/main" r:embed="R547dd55d1dba45f4"/>
               </a:ext>
             </a:extLst>
           </a:blip>
@@ -7839,10 +7839,10 @@
           <p:nvPr/>
         </p:nvPicPr>
         <p:blipFill>
-          <a:blip xmlns:r="http://schemas.openxmlformats.org/officeDocument/2006/relationships" xmlns:a="http://schemas.openxmlformats.org/drawingml/2006/main" r:embed="Rd55ed1559ba14a68">
+          <a:blip xmlns:r="http://schemas.openxmlformats.org/officeDocument/2006/relationships" xmlns:a="http://schemas.openxmlformats.org/drawingml/2006/main" r:embed="R7418e0b889da4438">
             <a:extLst>
               <a:ext uri="{96DAC541-7B7A-43D3-8B79-37D633B846F1}">
-                <asvg:svgBlip xmlns:asvg="http://schemas.microsoft.com/office/drawing/2016/SVG/main" r:embed="Rb2cd7dc900df482b"/>
+                <asvg:svgBlip xmlns:asvg="http://schemas.microsoft.com/office/drawing/2016/SVG/main" r:embed="Rca2bfd656e3b47cd"/>
               </a:ext>
             </a:extLst>
           </a:blip>
@@ -7863,7 +7863,7 @@
           <p:cNvPr id="22" name="Family journey number 3">
             <a:extLst xmlns:a="http://schemas.openxmlformats.org/drawingml/2006/main">
               <a:ext uri="{FF2B5EF4-FFF2-40B4-BE49-F238E27FC236}">
-                <a16:creationId xmlns:a16="http://schemas.microsoft.com/office/drawing/2014/main" id="{7D5605B5-B6AB-4B4A-B3C9-51C459EB7EE4}"/>
+                <a16:creationId xmlns:a16="http://schemas.microsoft.com/office/drawing/2014/main" id="{1B44ABC5-23AE-45B9-B41F-5315C9698870}"/>
               </a:ext>
             </a:extLst>
           </p:cNvPr>
@@ -7920,7 +7920,7 @@
           <p:cNvPr id="23" name="Family journey 3">
             <a:extLst xmlns:a="http://schemas.openxmlformats.org/drawingml/2006/main">
               <a:ext uri="{FF2B5EF4-FFF2-40B4-BE49-F238E27FC236}">
-                <a16:creationId xmlns:a16="http://schemas.microsoft.com/office/drawing/2014/main" id="{97905BC4-F583-43A1-AADD-BCA16DFABD64}"/>
+                <a16:creationId xmlns:a16="http://schemas.microsoft.com/office/drawing/2014/main" id="{0A44B6E4-589B-4025-B882-44CED892A40D}"/>
               </a:ext>
             </a:extLst>
           </p:cNvPr>
@@ -7977,7 +7977,7 @@
           <p:cNvPr id="24" name="Family journey 3 detail">
             <a:extLst xmlns:a="http://schemas.openxmlformats.org/drawingml/2006/main">
               <a:ext uri="{FF2B5EF4-FFF2-40B4-BE49-F238E27FC236}">
-                <a16:creationId xmlns:a16="http://schemas.microsoft.com/office/drawing/2014/main" id="{59E2175A-7A43-4583-8ED3-EF472B8E1865}"/>
+                <a16:creationId xmlns:a16="http://schemas.microsoft.com/office/drawing/2014/main" id="{D3F26257-6C41-4DAE-8A30-A88005D4A3DA}"/>
               </a:ext>
             </a:extLst>
           </p:cNvPr>
@@ -8038,10 +8038,10 @@
           <p:nvPr/>
         </p:nvPicPr>
         <p:blipFill>
-          <a:blip xmlns:r="http://schemas.openxmlformats.org/officeDocument/2006/relationships" xmlns:a="http://schemas.openxmlformats.org/drawingml/2006/main" r:embed="Ra093c691bc3f4d45">
+          <a:blip xmlns:r="http://schemas.openxmlformats.org/officeDocument/2006/relationships" xmlns:a="http://schemas.openxmlformats.org/drawingml/2006/main" r:embed="R883582fa468d4a53">
             <a:extLst>
               <a:ext uri="{96DAC541-7B7A-43D3-8B79-37D633B846F1}">
-                <asvg:svgBlip xmlns:asvg="http://schemas.microsoft.com/office/drawing/2016/SVG/main" r:embed="R6f4a3d29e6834636"/>
+                <asvg:svgBlip xmlns:asvg="http://schemas.microsoft.com/office/drawing/2016/SVG/main" r:embed="R5c67fb56f2924a1d"/>
               </a:ext>
             </a:extLst>
           </a:blip>
@@ -8062,7 +8062,7 @@
           <p:cNvPr id="26" name="Family journey number 4">
             <a:extLst xmlns:a="http://schemas.openxmlformats.org/drawingml/2006/main">
               <a:ext uri="{FF2B5EF4-FFF2-40B4-BE49-F238E27FC236}">
-                <a16:creationId xmlns:a16="http://schemas.microsoft.com/office/drawing/2014/main" id="{DED9AFA5-E45A-46D9-8F91-186AF690EDC7}"/>
+                <a16:creationId xmlns:a16="http://schemas.microsoft.com/office/drawing/2014/main" id="{8600D002-83BF-4071-8BF2-256C0837D128}"/>
               </a:ext>
             </a:extLst>
           </p:cNvPr>
@@ -8119,7 +8119,7 @@
           <p:cNvPr id="27" name="Family journey 4">
             <a:extLst xmlns:a="http://schemas.openxmlformats.org/drawingml/2006/main">
               <a:ext uri="{FF2B5EF4-FFF2-40B4-BE49-F238E27FC236}">
-                <a16:creationId xmlns:a16="http://schemas.microsoft.com/office/drawing/2014/main" id="{6BFAC181-59DE-4A55-A0CC-5F350F8E622B}"/>
+                <a16:creationId xmlns:a16="http://schemas.microsoft.com/office/drawing/2014/main" id="{2B9913D6-5FF4-47E6-BC69-2BFE91CDD880}"/>
               </a:ext>
             </a:extLst>
           </p:cNvPr>
@@ -8176,7 +8176,7 @@
           <p:cNvPr id="28" name="Family journey 4 detail">
             <a:extLst xmlns:a="http://schemas.openxmlformats.org/drawingml/2006/main">
               <a:ext uri="{FF2B5EF4-FFF2-40B4-BE49-F238E27FC236}">
-                <a16:creationId xmlns:a16="http://schemas.microsoft.com/office/drawing/2014/main" id="{03EBCAD6-121B-4BC2-9D1A-2BE07DA15769}"/>
+                <a16:creationId xmlns:a16="http://schemas.microsoft.com/office/drawing/2014/main" id="{375800ED-C1D7-47CA-81F0-F4075E576BFA}"/>
               </a:ext>
             </a:extLst>
           </p:cNvPr>
@@ -8237,10 +8237,10 @@
           <p:nvPr/>
         </p:nvPicPr>
         <p:blipFill>
-          <a:blip xmlns:r="http://schemas.openxmlformats.org/officeDocument/2006/relationships" xmlns:a="http://schemas.openxmlformats.org/drawingml/2006/main" r:embed="Rd67f713aa46a4431">
+          <a:blip xmlns:r="http://schemas.openxmlformats.org/officeDocument/2006/relationships" xmlns:a="http://schemas.openxmlformats.org/drawingml/2006/main" r:embed="R7ee4aa1db18e4106">
             <a:extLst>
               <a:ext uri="{96DAC541-7B7A-43D3-8B79-37D633B846F1}">
-                <asvg:svgBlip xmlns:asvg="http://schemas.microsoft.com/office/drawing/2016/SVG/main" r:embed="R79f0017b48334939"/>
+                <asvg:svgBlip xmlns:asvg="http://schemas.microsoft.com/office/drawing/2016/SVG/main" r:embed="R9da6135ccaff4e11"/>
               </a:ext>
             </a:extLst>
           </a:blip>
@@ -8265,10 +8265,10 @@
           <p:nvPr/>
         </p:nvPicPr>
         <p:blipFill>
-          <a:blip xmlns:r="http://schemas.openxmlformats.org/officeDocument/2006/relationships" xmlns:a="http://schemas.openxmlformats.org/drawingml/2006/main" r:embed="Ra8783d94b7e240b0">
+          <a:blip xmlns:r="http://schemas.openxmlformats.org/officeDocument/2006/relationships" xmlns:a="http://schemas.openxmlformats.org/drawingml/2006/main" r:embed="Rd7bbf8f14fd14bf6">
             <a:extLst>
               <a:ext uri="{96DAC541-7B7A-43D3-8B79-37D633B846F1}">
-                <asvg:svgBlip xmlns:asvg="http://schemas.microsoft.com/office/drawing/2016/SVG/main" r:embed="Rda212c2ce7a3459b"/>
+                <asvg:svgBlip xmlns:asvg="http://schemas.microsoft.com/office/drawing/2016/SVG/main" r:embed="Rbff6c3b366f84804"/>
               </a:ext>
             </a:extLst>
           </a:blip>
@@ -8289,7 +8289,7 @@
           <p:cNvPr id="31" name="Family journey number 5">
             <a:extLst xmlns:a="http://schemas.openxmlformats.org/drawingml/2006/main">
               <a:ext uri="{FF2B5EF4-FFF2-40B4-BE49-F238E27FC236}">
-                <a16:creationId xmlns:a16="http://schemas.microsoft.com/office/drawing/2014/main" id="{44D1C536-7E45-462F-BF5D-FD0449F7FA41}"/>
+                <a16:creationId xmlns:a16="http://schemas.microsoft.com/office/drawing/2014/main" id="{CC79B087-2B39-44C1-BEDE-F30D818652D4}"/>
               </a:ext>
             </a:extLst>
           </p:cNvPr>
@@ -8346,7 +8346,7 @@
           <p:cNvPr id="32" name="Family journey 5">
             <a:extLst xmlns:a="http://schemas.openxmlformats.org/drawingml/2006/main">
               <a:ext uri="{FF2B5EF4-FFF2-40B4-BE49-F238E27FC236}">
-                <a16:creationId xmlns:a16="http://schemas.microsoft.com/office/drawing/2014/main" id="{31BB71B6-7ADA-4339-8D0C-973B5CC9618A}"/>
+                <a16:creationId xmlns:a16="http://schemas.microsoft.com/office/drawing/2014/main" id="{807E8268-98F2-4FE5-878D-7A4E81876615}"/>
               </a:ext>
             </a:extLst>
           </p:cNvPr>
@@ -8403,7 +8403,7 @@
           <p:cNvPr id="33" name="Family journey 5 detail">
             <a:extLst xmlns:a="http://schemas.openxmlformats.org/drawingml/2006/main">
               <a:ext uri="{FF2B5EF4-FFF2-40B4-BE49-F238E27FC236}">
-                <a16:creationId xmlns:a16="http://schemas.microsoft.com/office/drawing/2014/main" id="{9888A7E9-6D93-41A2-893C-D9B98EE32C05}"/>
+                <a16:creationId xmlns:a16="http://schemas.microsoft.com/office/drawing/2014/main" id="{84E5021F-6316-493A-A3A7-8E1AEDE63BF3}"/>
               </a:ext>
             </a:extLst>
           </p:cNvPr>
@@ -8464,10 +8464,10 @@
           <p:nvPr/>
         </p:nvPicPr>
         <p:blipFill>
-          <a:blip xmlns:r="http://schemas.openxmlformats.org/officeDocument/2006/relationships" xmlns:a="http://schemas.openxmlformats.org/drawingml/2006/main" r:embed="Rc257465ac24646fd">
+          <a:blip xmlns:r="http://schemas.openxmlformats.org/officeDocument/2006/relationships" xmlns:a="http://schemas.openxmlformats.org/drawingml/2006/main" r:embed="R7b8179d9d8634b0b">
             <a:extLst>
               <a:ext uri="{96DAC541-7B7A-43D3-8B79-37D633B846F1}">
-                <asvg:svgBlip xmlns:asvg="http://schemas.microsoft.com/office/drawing/2016/SVG/main" r:embed="Rd4f345d5783048af"/>
+                <asvg:svgBlip xmlns:asvg="http://schemas.microsoft.com/office/drawing/2016/SVG/main" r:embed="Rc840716832e94848"/>
               </a:ext>
             </a:extLst>
           </a:blip>
@@ -8492,10 +8492,10 @@
           <p:nvPr/>
         </p:nvPicPr>
         <p:blipFill>
-          <a:blip xmlns:r="http://schemas.openxmlformats.org/officeDocument/2006/relationships" xmlns:a="http://schemas.openxmlformats.org/drawingml/2006/main" r:embed="R72dcba8b3b4248b8">
+          <a:blip xmlns:r="http://schemas.openxmlformats.org/officeDocument/2006/relationships" xmlns:a="http://schemas.openxmlformats.org/drawingml/2006/main" r:embed="R27bac49ce3d44955">
             <a:extLst>
               <a:ext uri="{96DAC541-7B7A-43D3-8B79-37D633B846F1}">
-                <asvg:svgBlip xmlns:asvg="http://schemas.microsoft.com/office/drawing/2016/SVG/main" r:embed="R0f75c5f2240b4522"/>
+                <asvg:svgBlip xmlns:asvg="http://schemas.microsoft.com/office/drawing/2016/SVG/main" r:embed="R229437a360664835"/>
               </a:ext>
             </a:extLst>
           </a:blip>
@@ -8516,7 +8516,7 @@
           <p:cNvPr id="36" name="Family journey number 6">
             <a:extLst xmlns:a="http://schemas.openxmlformats.org/drawingml/2006/main">
               <a:ext uri="{FF2B5EF4-FFF2-40B4-BE49-F238E27FC236}">
-                <a16:creationId xmlns:a16="http://schemas.microsoft.com/office/drawing/2014/main" id="{5E31BF26-ADAB-40A1-8C64-D42B8B3D4303}"/>
+                <a16:creationId xmlns:a16="http://schemas.microsoft.com/office/drawing/2014/main" id="{256EFB87-7562-4A58-A9C5-FB68EFEA60AE}"/>
               </a:ext>
             </a:extLst>
           </p:cNvPr>
@@ -8573,7 +8573,7 @@
           <p:cNvPr id="37" name="Family journey 6">
             <a:extLst xmlns:a="http://schemas.openxmlformats.org/drawingml/2006/main">
               <a:ext uri="{FF2B5EF4-FFF2-40B4-BE49-F238E27FC236}">
-                <a16:creationId xmlns:a16="http://schemas.microsoft.com/office/drawing/2014/main" id="{D5B22CF8-4574-461B-AD34-19A7E142F2AD}"/>
+                <a16:creationId xmlns:a16="http://schemas.microsoft.com/office/drawing/2014/main" id="{7345CBFC-B967-435C-ACF0-685C9DA2DF74}"/>
               </a:ext>
             </a:extLst>
           </p:cNvPr>
@@ -8630,7 +8630,7 @@
           <p:cNvPr id="38" name="Family journey 6 detail">
             <a:extLst xmlns:a="http://schemas.openxmlformats.org/drawingml/2006/main">
               <a:ext uri="{FF2B5EF4-FFF2-40B4-BE49-F238E27FC236}">
-                <a16:creationId xmlns:a16="http://schemas.microsoft.com/office/drawing/2014/main" id="{8153730A-CCB3-4A52-8C3E-FE301F7B8354}"/>
+                <a16:creationId xmlns:a16="http://schemas.microsoft.com/office/drawing/2014/main" id="{BAD1FB3E-7F4E-4E67-9855-D8E6123A569C}"/>
               </a:ext>
             </a:extLst>
           </p:cNvPr>
@@ -8687,7 +8687,7 @@
           <p:cNvPr id="39" name="Support directory">
             <a:extLst xmlns:a="http://schemas.openxmlformats.org/drawingml/2006/main">
               <a:ext uri="{FF2B5EF4-FFF2-40B4-BE49-F238E27FC236}">
-                <a16:creationId xmlns:a16="http://schemas.microsoft.com/office/drawing/2014/main" id="{78EDF3FD-4EA2-4D60-B3F5-B47CA7E2DF88}"/>
+                <a16:creationId xmlns:a16="http://schemas.microsoft.com/office/drawing/2014/main" id="{2BC5057E-33F2-4AF9-A7DC-76ACC8844774}"/>
               </a:ext>
             </a:extLst>
           </p:cNvPr>
@@ -8733,7 +8733,7 @@
                 <a:latin typeface="Arial"/>
                 <a:ea typeface="Arial"/>
                 <a:cs typeface="Arial"/>
-                <a:hlinkClick xmlns:r="http://schemas.openxmlformats.org/officeDocument/2006/relationships" r:id="R366d6397a71945e0"/>
+                <a:hlinkClick xmlns:r="http://schemas.openxmlformats.org/officeDocument/2006/relationships" r:id="R2a25721dcb4d4568"/>
               </a:rPr>
               <a:t>Find a centre → call to confirm → keep the contact and visit plan.</a:t>
             </a:r>
@@ -8774,7 +8774,7 @@
           <p:cNvPr id="14" name="Slide title">
             <a:extLst xmlns:a="http://schemas.openxmlformats.org/drawingml/2006/main">
               <a:ext uri="{FF2B5EF4-FFF2-40B4-BE49-F238E27FC236}">
-                <a16:creationId xmlns:a16="http://schemas.microsoft.com/office/drawing/2014/main" id="{96ECD5D1-87D8-4508-B85F-AE0E652755DA}"/>
+                <a16:creationId xmlns:a16="http://schemas.microsoft.com/office/drawing/2014/main" id="{C16D8A49-1396-4AA5-9EAA-69BF3813261C}"/>
               </a:ext>
             </a:extLst>
           </p:cNvPr>
@@ -8831,7 +8831,7 @@
           <p:cNvPr id="2" name="Trial design">
             <a:extLst xmlns:a="http://schemas.openxmlformats.org/drawingml/2006/main">
               <a:ext uri="{FF2B5EF4-FFF2-40B4-BE49-F238E27FC236}">
-                <a16:creationId xmlns:a16="http://schemas.microsoft.com/office/drawing/2014/main" id="{883138BD-5C7C-4D79-9BA4-D679480D0F40}"/>
+                <a16:creationId xmlns:a16="http://schemas.microsoft.com/office/drawing/2014/main" id="{EBFBE361-A99C-4269-B070-6D9D5FEAB949}"/>
               </a:ext>
             </a:extLst>
           </p:cNvPr>
@@ -8888,7 +8888,7 @@
           <p:cNvPr id="3" name="Primary measure 1">
             <a:extLst xmlns:a="http://schemas.openxmlformats.org/drawingml/2006/main">
               <a:ext uri="{FF2B5EF4-FFF2-40B4-BE49-F238E27FC236}">
-                <a16:creationId xmlns:a16="http://schemas.microsoft.com/office/drawing/2014/main" id="{BBB74CDA-4E79-46A5-9A10-831544FBA823}"/>
+                <a16:creationId xmlns:a16="http://schemas.microsoft.com/office/drawing/2014/main" id="{0300098E-4555-427D-BC81-B60C9D9E9A86}"/>
               </a:ext>
             </a:extLst>
           </p:cNvPr>
@@ -8945,7 +8945,7 @@
           <p:cNvPr id="4" name="Primary measure 1 detail">
             <a:extLst xmlns:a="http://schemas.openxmlformats.org/drawingml/2006/main">
               <a:ext uri="{FF2B5EF4-FFF2-40B4-BE49-F238E27FC236}">
-                <a16:creationId xmlns:a16="http://schemas.microsoft.com/office/drawing/2014/main" id="{9893A3B8-F19B-479F-BF1D-0AECF0CE3929}"/>
+                <a16:creationId xmlns:a16="http://schemas.microsoft.com/office/drawing/2014/main" id="{042291F0-294C-4DCF-8860-F43A0A5C1838}"/>
               </a:ext>
             </a:extLst>
           </p:cNvPr>
@@ -9002,7 +9002,7 @@
           <p:cNvPr id="5" name="Primary measure 2">
             <a:extLst xmlns:a="http://schemas.openxmlformats.org/drawingml/2006/main">
               <a:ext uri="{FF2B5EF4-FFF2-40B4-BE49-F238E27FC236}">
-                <a16:creationId xmlns:a16="http://schemas.microsoft.com/office/drawing/2014/main" id="{71D2F334-F1E0-4B14-BF81-DFF53D9B351E}"/>
+                <a16:creationId xmlns:a16="http://schemas.microsoft.com/office/drawing/2014/main" id="{BC879D6C-9AEE-43A8-A48A-C02914D42191}"/>
               </a:ext>
             </a:extLst>
           </p:cNvPr>
@@ -9059,7 +9059,7 @@
           <p:cNvPr id="6" name="Primary measure 2 detail">
             <a:extLst xmlns:a="http://schemas.openxmlformats.org/drawingml/2006/main">
               <a:ext uri="{FF2B5EF4-FFF2-40B4-BE49-F238E27FC236}">
-                <a16:creationId xmlns:a16="http://schemas.microsoft.com/office/drawing/2014/main" id="{383FA2A7-E09F-48FD-B388-E9A5D964F8C2}"/>
+                <a16:creationId xmlns:a16="http://schemas.microsoft.com/office/drawing/2014/main" id="{41833782-94C6-421F-81A7-CBBBD5910D11}"/>
               </a:ext>
             </a:extLst>
           </p:cNvPr>
@@ -9116,7 +9116,7 @@
           <p:cNvPr id="7" name="Primary measure 3">
             <a:extLst xmlns:a="http://schemas.openxmlformats.org/drawingml/2006/main">
               <a:ext uri="{FF2B5EF4-FFF2-40B4-BE49-F238E27FC236}">
-                <a16:creationId xmlns:a16="http://schemas.microsoft.com/office/drawing/2014/main" id="{0A5905C0-1D47-4C57-91E4-4C2618B2E530}"/>
+                <a16:creationId xmlns:a16="http://schemas.microsoft.com/office/drawing/2014/main" id="{F52CAB9D-319E-4692-9CC2-3D784A1E35B6}"/>
               </a:ext>
             </a:extLst>
           </p:cNvPr>
@@ -9173,7 +9173,7 @@
           <p:cNvPr id="8" name="Primary measure 3 detail">
             <a:extLst xmlns:a="http://schemas.openxmlformats.org/drawingml/2006/main">
               <a:ext uri="{FF2B5EF4-FFF2-40B4-BE49-F238E27FC236}">
-                <a16:creationId xmlns:a16="http://schemas.microsoft.com/office/drawing/2014/main" id="{B213C744-6455-4D9E-9437-3B449F194070}"/>
+                <a16:creationId xmlns:a16="http://schemas.microsoft.com/office/drawing/2014/main" id="{FD9FCD8F-F6F8-4056-B4C5-1D51498940D7}"/>
               </a:ext>
             </a:extLst>
           </p:cNvPr>
@@ -9230,7 +9230,7 @@
           <p:cNvPr id="9" name="">
             <a:extLst xmlns:a="http://schemas.openxmlformats.org/drawingml/2006/main">
               <a:ext uri="{FF2B5EF4-FFF2-40B4-BE49-F238E27FC236}">
-                <a16:creationId xmlns:a16="http://schemas.microsoft.com/office/drawing/2014/main" id="{D940663A-87B0-45C8-8740-846E7BA16CC6}"/>
+                <a16:creationId xmlns:a16="http://schemas.microsoft.com/office/drawing/2014/main" id="{9C66F07D-9BAE-4F02-B739-7DD974C2B3F8}"/>
               </a:ext>
             </a:extLst>
           </p:cNvPr>
@@ -9259,7 +9259,7 @@
           <p:cNvPr id="10" name="Comparison">
             <a:extLst xmlns:a="http://schemas.openxmlformats.org/drawingml/2006/main">
               <a:ext uri="{FF2B5EF4-FFF2-40B4-BE49-F238E27FC236}">
-                <a16:creationId xmlns:a16="http://schemas.microsoft.com/office/drawing/2014/main" id="{093031C7-C23C-4574-9DA4-0E32EEC4886F}"/>
+                <a16:creationId xmlns:a16="http://schemas.microsoft.com/office/drawing/2014/main" id="{4696A24D-909D-40FD-844A-E733D19545A0}"/>
               </a:ext>
             </a:extLst>
           </p:cNvPr>
@@ -9316,7 +9316,7 @@
           <p:cNvPr id="11" name="Primary outcome definition">
             <a:extLst xmlns:a="http://schemas.openxmlformats.org/drawingml/2006/main">
               <a:ext uri="{FF2B5EF4-FFF2-40B4-BE49-F238E27FC236}">
-                <a16:creationId xmlns:a16="http://schemas.microsoft.com/office/drawing/2014/main" id="{857F24BE-AD05-423C-98FA-3BEE3FA4018B}"/>
+                <a16:creationId xmlns:a16="http://schemas.microsoft.com/office/drawing/2014/main" id="{B978CF16-80B9-49DD-9284-D7C4A873AF05}"/>
               </a:ext>
             </a:extLst>
           </p:cNvPr>
@@ -9373,7 +9373,7 @@
           <p:cNvPr id="12" name="Additional measures">
             <a:extLst xmlns:a="http://schemas.openxmlformats.org/drawingml/2006/main">
               <a:ext uri="{FF2B5EF4-FFF2-40B4-BE49-F238E27FC236}">
-                <a16:creationId xmlns:a16="http://schemas.microsoft.com/office/drawing/2014/main" id="{BAD84F82-56ED-45EB-9A11-68363D09CA12}"/>
+                <a16:creationId xmlns:a16="http://schemas.microsoft.com/office/drawing/2014/main" id="{C08CDD21-6642-4AF7-B781-F51A00CCA6CB}"/>
               </a:ext>
             </a:extLst>
           </p:cNvPr>
@@ -9430,7 +9430,7 @@
           <p:cNvPr id="13" name="Implementation status">
             <a:extLst xmlns:a="http://schemas.openxmlformats.org/drawingml/2006/main">
               <a:ext uri="{FF2B5EF4-FFF2-40B4-BE49-F238E27FC236}">
-                <a16:creationId xmlns:a16="http://schemas.microsoft.com/office/drawing/2014/main" id="{4887E2CA-AF9C-412A-A41D-C4786EB06795}"/>
+                <a16:creationId xmlns:a16="http://schemas.microsoft.com/office/drawing/2014/main" id="{44B1A8CE-90FE-43B4-A967-0851AB4EC5A3}"/>
               </a:ext>
             </a:extLst>
           </p:cNvPr>
@@ -9516,7 +9516,7 @@
           <p:cNvPr id="29" name="References title">
             <a:extLst xmlns:a="http://schemas.openxmlformats.org/drawingml/2006/main">
               <a:ext uri="{FF2B5EF4-FFF2-40B4-BE49-F238E27FC236}">
-                <a16:creationId xmlns:a16="http://schemas.microsoft.com/office/drawing/2014/main" id="{4BFF80F6-AEF7-4AE3-B244-D637AA5896BC}"/>
+                <a16:creationId xmlns:a16="http://schemas.microsoft.com/office/drawing/2014/main" id="{70B1492F-11D9-434F-98BA-EA48C638C90C}"/>
               </a:ext>
             </a:extLst>
           </p:cNvPr>
@@ -9573,7 +9573,7 @@
           <p:cNvPr id="2" name="Reference 1 author">
             <a:extLst xmlns:a="http://schemas.openxmlformats.org/drawingml/2006/main">
               <a:ext uri="{FF2B5EF4-FFF2-40B4-BE49-F238E27FC236}">
-                <a16:creationId xmlns:a16="http://schemas.microsoft.com/office/drawing/2014/main" id="{18CEEE73-EF77-48E9-BE53-AC297BB4F354}"/>
+                <a16:creationId xmlns:a16="http://schemas.microsoft.com/office/drawing/2014/main" id="{26180823-26A2-4216-85B6-503D61E462C1}"/>
               </a:ext>
             </a:extLst>
           </p:cNvPr>
@@ -9630,7 +9630,7 @@
           <p:cNvPr id="3" name="Reference 1 title">
             <a:extLst xmlns:a="http://schemas.openxmlformats.org/drawingml/2006/main">
               <a:ext uri="{FF2B5EF4-FFF2-40B4-BE49-F238E27FC236}">
-                <a16:creationId xmlns:a16="http://schemas.microsoft.com/office/drawing/2014/main" id="{CEB71232-16B0-4BB8-85FA-B2D2844F4DB8}"/>
+                <a16:creationId xmlns:a16="http://schemas.microsoft.com/office/drawing/2014/main" id="{BF7BD6FC-55BB-43B0-93BA-27AE6BE51544}"/>
               </a:ext>
             </a:extLst>
           </p:cNvPr>
@@ -9676,9 +9676,9 @@
                 <a:latin typeface="Arial"/>
                 <a:ea typeface="Arial"/>
                 <a:cs typeface="Arial"/>
-                <a:hlinkClick xmlns:r="http://schemas.openxmlformats.org/officeDocument/2006/relationships" r:id="Rffcd7518ebb740c0"/>
-              </a:rPr>
-              <a:t>India — GLOBOCAN 2024 Fact Sheet</a:t>
+                <a:hlinkClick xmlns:r="http://schemas.openxmlformats.org/officeDocument/2006/relationships" r:id="Ra540cd6bd22f46c4"/>
+              </a:rPr>
+              <a:t>India: GLOBOCAN 2024 Fact Sheet</a:t>
             </a:r>
           </a:p>
         </p:txBody>
@@ -9688,7 +9688,7 @@
           <p:cNvPr id="4" name="Reference 1 link">
             <a:extLst xmlns:a="http://schemas.openxmlformats.org/drawingml/2006/main">
               <a:ext uri="{FF2B5EF4-FFF2-40B4-BE49-F238E27FC236}">
-                <a16:creationId xmlns:a16="http://schemas.microsoft.com/office/drawing/2014/main" id="{800194C1-EBF2-4962-991B-74CBF5D6BE52}"/>
+                <a16:creationId xmlns:a16="http://schemas.microsoft.com/office/drawing/2014/main" id="{8B9AEEE4-7316-43E0-B726-EED99B2C345F}"/>
               </a:ext>
             </a:extLst>
           </p:cNvPr>
@@ -9734,7 +9734,7 @@
                 <a:latin typeface="Arial"/>
                 <a:ea typeface="Arial"/>
                 <a:cs typeface="Arial"/>
-                <a:hlinkClick xmlns:r="http://schemas.openxmlformats.org/officeDocument/2006/relationships" r:id="Ra9c94895c00d46fd"/>
+                <a:hlinkClick xmlns:r="http://schemas.openxmlformats.org/officeDocument/2006/relationships" r:id="R443939e682764032"/>
               </a:rPr>
               <a:t>https://gco.iarc.who.int/media/globocan/factsheets/populations/356-india-fact-sheet.pdf</a:t>
             </a:r>
@@ -9746,7 +9746,7 @@
           <p:cNvPr id="5" name="Reference 2 author">
             <a:extLst xmlns:a="http://schemas.openxmlformats.org/drawingml/2006/main">
               <a:ext uri="{FF2B5EF4-FFF2-40B4-BE49-F238E27FC236}">
-                <a16:creationId xmlns:a16="http://schemas.microsoft.com/office/drawing/2014/main" id="{E9D6E1D1-3DE7-4868-AB93-590C81D92D2D}"/>
+                <a16:creationId xmlns:a16="http://schemas.microsoft.com/office/drawing/2014/main" id="{038B3E91-5205-48FB-B3A9-6CF92C951555}"/>
               </a:ext>
             </a:extLst>
           </p:cNvPr>
@@ -9803,7 +9803,7 @@
           <p:cNvPr id="6" name="Reference 2 title">
             <a:extLst xmlns:a="http://schemas.openxmlformats.org/drawingml/2006/main">
               <a:ext uri="{FF2B5EF4-FFF2-40B4-BE49-F238E27FC236}">
-                <a16:creationId xmlns:a16="http://schemas.microsoft.com/office/drawing/2014/main" id="{2538133F-A334-49A6-A4B9-ECD576BDEC6C}"/>
+                <a16:creationId xmlns:a16="http://schemas.microsoft.com/office/drawing/2014/main" id="{431F0E53-ED39-46D9-9336-E6BA88DC652D}"/>
               </a:ext>
             </a:extLst>
           </p:cNvPr>
@@ -9849,7 +9849,7 @@
                 <a:latin typeface="Arial"/>
                 <a:ea typeface="Arial"/>
                 <a:cs typeface="Arial"/>
-                <a:hlinkClick xmlns:r="http://schemas.openxmlformats.org/officeDocument/2006/relationships" r:id="R3dcc1e077ce84ccd"/>
+                <a:hlinkClick xmlns:r="http://schemas.openxmlformats.org/officeDocument/2006/relationships" r:id="Ra528503def54403f"/>
               </a:rPr>
               <a:t>Unmet need for cancer palliative care in India</a:t>
             </a:r>
@@ -9861,7 +9861,7 @@
           <p:cNvPr id="7" name="Reference 2 link">
             <a:extLst xmlns:a="http://schemas.openxmlformats.org/drawingml/2006/main">
               <a:ext uri="{FF2B5EF4-FFF2-40B4-BE49-F238E27FC236}">
-                <a16:creationId xmlns:a16="http://schemas.microsoft.com/office/drawing/2014/main" id="{C3289A00-D453-4812-ABD5-A1224B727CE7}"/>
+                <a16:creationId xmlns:a16="http://schemas.microsoft.com/office/drawing/2014/main" id="{A904C24E-60D1-4D9B-961F-FF06D4182A34}"/>
               </a:ext>
             </a:extLst>
           </p:cNvPr>
@@ -9907,7 +9907,7 @@
                 <a:latin typeface="Arial"/>
                 <a:ea typeface="Arial"/>
                 <a:cs typeface="Arial"/>
-                <a:hlinkClick xmlns:r="http://schemas.openxmlformats.org/officeDocument/2006/relationships" r:id="Re8e2256362204fb6"/>
+                <a:hlinkClick xmlns:r="http://schemas.openxmlformats.org/officeDocument/2006/relationships" r:id="Reaea4c34f57f411a"/>
               </a:rPr>
               <a:t>https://doi.org/10.1136/spcare-2024-004978</a:t>
             </a:r>
@@ -9919,7 +9919,7 @@
           <p:cNvPr id="8" name="Reference 3 author">
             <a:extLst xmlns:a="http://schemas.openxmlformats.org/drawingml/2006/main">
               <a:ext uri="{FF2B5EF4-FFF2-40B4-BE49-F238E27FC236}">
-                <a16:creationId xmlns:a16="http://schemas.microsoft.com/office/drawing/2014/main" id="{6332E015-25B3-4A90-8167-0039B57475A3}"/>
+                <a16:creationId xmlns:a16="http://schemas.microsoft.com/office/drawing/2014/main" id="{F5EFFC9D-73E1-427C-ADC2-682ED66EC11A}"/>
               </a:ext>
             </a:extLst>
           </p:cNvPr>
@@ -9976,7 +9976,7 @@
           <p:cNvPr id="9" name="Reference 3 title">
             <a:extLst xmlns:a="http://schemas.openxmlformats.org/drawingml/2006/main">
               <a:ext uri="{FF2B5EF4-FFF2-40B4-BE49-F238E27FC236}">
-                <a16:creationId xmlns:a16="http://schemas.microsoft.com/office/drawing/2014/main" id="{94E5A5FB-9CA3-4089-9C41-CAECFFE56F78}"/>
+                <a16:creationId xmlns:a16="http://schemas.microsoft.com/office/drawing/2014/main" id="{590708BD-4F98-43F4-99B1-A63F443F206B}"/>
               </a:ext>
             </a:extLst>
           </p:cNvPr>
@@ -10022,7 +10022,7 @@
                 <a:latin typeface="Arial"/>
                 <a:ea typeface="Arial"/>
                 <a:cs typeface="Arial"/>
-                <a:hlinkClick xmlns:r="http://schemas.openxmlformats.org/officeDocument/2006/relationships" r:id="R42acd986712a4cc0"/>
+                <a:hlinkClick xmlns:r="http://schemas.openxmlformats.org/officeDocument/2006/relationships" r:id="Ra2926c34e74e4f70"/>
               </a:rPr>
               <a:t>Early Goal of Care Discussions in Healthcare: A Survey Case Report on Benefits and Perceptions</a:t>
             </a:r>
@@ -10034,7 +10034,7 @@
           <p:cNvPr id="10" name="Reference 3 link">
             <a:extLst xmlns:a="http://schemas.openxmlformats.org/drawingml/2006/main">
               <a:ext uri="{FF2B5EF4-FFF2-40B4-BE49-F238E27FC236}">
-                <a16:creationId xmlns:a16="http://schemas.microsoft.com/office/drawing/2014/main" id="{0435C134-9EAC-4DD8-9433-7B758608CFBC}"/>
+                <a16:creationId xmlns:a16="http://schemas.microsoft.com/office/drawing/2014/main" id="{FF370709-16E0-4EC8-BC88-23B2C259FDEE}"/>
               </a:ext>
             </a:extLst>
           </p:cNvPr>
@@ -10080,7 +10080,7 @@
                 <a:latin typeface="Arial"/>
                 <a:ea typeface="Arial"/>
                 <a:cs typeface="Arial"/>
-                <a:hlinkClick xmlns:r="http://schemas.openxmlformats.org/officeDocument/2006/relationships" r:id="R3218ab4ff1b94c6b"/>
+                <a:hlinkClick xmlns:r="http://schemas.openxmlformats.org/officeDocument/2006/relationships" r:id="Rffead67030c94e05"/>
               </a:rPr>
               <a:t>https://doi.org/10.1016/j.jpainsymman.2024.02.030</a:t>
             </a:r>
@@ -10092,7 +10092,7 @@
           <p:cNvPr id="11" name="Reference 4 author">
             <a:extLst xmlns:a="http://schemas.openxmlformats.org/drawingml/2006/main">
               <a:ext uri="{FF2B5EF4-FFF2-40B4-BE49-F238E27FC236}">
-                <a16:creationId xmlns:a16="http://schemas.microsoft.com/office/drawing/2014/main" id="{85C505E3-3CF5-4530-AB1E-8CE967722B0C}"/>
+                <a16:creationId xmlns:a16="http://schemas.microsoft.com/office/drawing/2014/main" id="{663CD61E-EB72-4254-8046-6DDD34C33355}"/>
               </a:ext>
             </a:extLst>
           </p:cNvPr>
@@ -10149,7 +10149,7 @@
           <p:cNvPr id="12" name="Reference 4 title">
             <a:extLst xmlns:a="http://schemas.openxmlformats.org/drawingml/2006/main">
               <a:ext uri="{FF2B5EF4-FFF2-40B4-BE49-F238E27FC236}">
-                <a16:creationId xmlns:a16="http://schemas.microsoft.com/office/drawing/2014/main" id="{A7B89B3D-EC50-42D4-8B61-F597B1D94560}"/>
+                <a16:creationId xmlns:a16="http://schemas.microsoft.com/office/drawing/2014/main" id="{B83C0DD6-C3B4-444C-87CD-0EBE8F3E7A00}"/>
               </a:ext>
             </a:extLst>
           </p:cNvPr>
@@ -10195,7 +10195,7 @@
                 <a:latin typeface="Arial"/>
                 <a:ea typeface="Arial"/>
                 <a:cs typeface="Arial"/>
-                <a:hlinkClick xmlns:r="http://schemas.openxmlformats.org/officeDocument/2006/relationships" r:id="Rf4d9beb853d24dca"/>
+                <a:hlinkClick xmlns:r="http://schemas.openxmlformats.org/officeDocument/2006/relationships" r:id="Rf5716dfb4c9141b3"/>
               </a:rPr>
               <a:t>Initiating and Documenting Goals of Care Discussion in Patients with Advanced Pancreatic and Colorectal Cancers: A Quality Improvement Project in a Low Resource Setting</a:t>
             </a:r>
@@ -10207,7 +10207,7 @@
           <p:cNvPr id="13" name="Reference 4 link">
             <a:extLst xmlns:a="http://schemas.openxmlformats.org/drawingml/2006/main">
               <a:ext uri="{FF2B5EF4-FFF2-40B4-BE49-F238E27FC236}">
-                <a16:creationId xmlns:a16="http://schemas.microsoft.com/office/drawing/2014/main" id="{796C53E4-1A83-4531-8270-C90D29B2BD7A}"/>
+                <a16:creationId xmlns:a16="http://schemas.microsoft.com/office/drawing/2014/main" id="{8951B852-C6FA-4B8F-ADA2-C87C43048265}"/>
               </a:ext>
             </a:extLst>
           </p:cNvPr>
@@ -10253,7 +10253,7 @@
                 <a:latin typeface="Arial"/>
                 <a:ea typeface="Arial"/>
                 <a:cs typeface="Arial"/>
-                <a:hlinkClick xmlns:r="http://schemas.openxmlformats.org/officeDocument/2006/relationships" r:id="R676e162e9eb44b8e"/>
+                <a:hlinkClick xmlns:r="http://schemas.openxmlformats.org/officeDocument/2006/relationships" r:id="R842c30e009724a9d"/>
               </a:rPr>
               <a:t>https://doi.org/10.1177/26892820251392545</a:t>
             </a:r>
@@ -10265,7 +10265,7 @@
           <p:cNvPr id="14" name="Reference 5 author">
             <a:extLst xmlns:a="http://schemas.openxmlformats.org/drawingml/2006/main">
               <a:ext uri="{FF2B5EF4-FFF2-40B4-BE49-F238E27FC236}">
-                <a16:creationId xmlns:a16="http://schemas.microsoft.com/office/drawing/2014/main" id="{F1C7AEE3-89A1-4428-BC1B-E4538601FBBA}"/>
+                <a16:creationId xmlns:a16="http://schemas.microsoft.com/office/drawing/2014/main" id="{0D9E08E6-072B-4B18-ABCE-4E076A99905A}"/>
               </a:ext>
             </a:extLst>
           </p:cNvPr>
@@ -10322,7 +10322,7 @@
           <p:cNvPr id="15" name="Reference 5 title">
             <a:extLst xmlns:a="http://schemas.openxmlformats.org/drawingml/2006/main">
               <a:ext uri="{FF2B5EF4-FFF2-40B4-BE49-F238E27FC236}">
-                <a16:creationId xmlns:a16="http://schemas.microsoft.com/office/drawing/2014/main" id="{52488D65-D473-4C2F-AC1F-927E987DB657}"/>
+                <a16:creationId xmlns:a16="http://schemas.microsoft.com/office/drawing/2014/main" id="{3ECB0BBF-4B34-4CE1-8234-0434D60B301B}"/>
               </a:ext>
             </a:extLst>
           </p:cNvPr>
@@ -10368,7 +10368,7 @@
                 <a:latin typeface="Arial"/>
                 <a:ea typeface="Arial"/>
                 <a:cs typeface="Arial"/>
-                <a:hlinkClick xmlns:r="http://schemas.openxmlformats.org/officeDocument/2006/relationships" r:id="Reaab94f642424e24"/>
+                <a:hlinkClick xmlns:r="http://schemas.openxmlformats.org/officeDocument/2006/relationships" r:id="R01bab28c22aa4500"/>
               </a:rPr>
               <a:t>73% urban Indians do not know about their right to make a living will, finds a survey</a:t>
             </a:r>
@@ -10380,7 +10380,7 @@
           <p:cNvPr id="16" name="Reference 5 link">
             <a:extLst xmlns:a="http://schemas.openxmlformats.org/drawingml/2006/main">
               <a:ext uri="{FF2B5EF4-FFF2-40B4-BE49-F238E27FC236}">
-                <a16:creationId xmlns:a16="http://schemas.microsoft.com/office/drawing/2014/main" id="{902D7559-75DE-4B6B-BE82-E25EFA45C3A2}"/>
+                <a16:creationId xmlns:a16="http://schemas.microsoft.com/office/drawing/2014/main" id="{6E4A6297-5D81-4862-AE4B-78BC092532EB}"/>
               </a:ext>
             </a:extLst>
           </p:cNvPr>
@@ -10426,7 +10426,7 @@
                 <a:latin typeface="Arial"/>
                 <a:ea typeface="Arial"/>
                 <a:cs typeface="Arial"/>
-                <a:hlinkClick xmlns:r="http://schemas.openxmlformats.org/officeDocument/2006/relationships" r:id="Rece69212f56f438c"/>
+                <a:hlinkClick xmlns:r="http://schemas.openxmlformats.org/officeDocument/2006/relationships" r:id="R8c3da352a68240df"/>
               </a:rPr>
               <a:t>https://scroll.in/article/925875/73-urban-indians-do-not-know-about-their-right-to-make-a-living-will-finds-a-survey</a:t>
             </a:r>
@@ -10438,7 +10438,7 @@
           <p:cNvPr id="17" name="Reference 6 author">
             <a:extLst xmlns:a="http://schemas.openxmlformats.org/drawingml/2006/main">
               <a:ext uri="{FF2B5EF4-FFF2-40B4-BE49-F238E27FC236}">
-                <a16:creationId xmlns:a16="http://schemas.microsoft.com/office/drawing/2014/main" id="{302A819C-1F9F-4D54-A0D9-66C3AAB232D8}"/>
+                <a16:creationId xmlns:a16="http://schemas.microsoft.com/office/drawing/2014/main" id="{462B4C30-1C25-48B9-B784-4E6CD57ECC66}"/>
               </a:ext>
             </a:extLst>
           </p:cNvPr>
@@ -10495,7 +10495,7 @@
           <p:cNvPr id="18" name="Reference 6 title">
             <a:extLst xmlns:a="http://schemas.openxmlformats.org/drawingml/2006/main">
               <a:ext uri="{FF2B5EF4-FFF2-40B4-BE49-F238E27FC236}">
-                <a16:creationId xmlns:a16="http://schemas.microsoft.com/office/drawing/2014/main" id="{CA29E195-8BE9-4CC1-947D-1BD543325C8F}"/>
+                <a16:creationId xmlns:a16="http://schemas.microsoft.com/office/drawing/2014/main" id="{4D1500BE-DF31-4798-B285-67F685F1AA64}"/>
               </a:ext>
             </a:extLst>
           </p:cNvPr>
@@ -10541,7 +10541,7 @@
                 <a:latin typeface="Arial"/>
                 <a:ea typeface="Arial"/>
                 <a:cs typeface="Arial"/>
-                <a:hlinkClick xmlns:r="http://schemas.openxmlformats.org/officeDocument/2006/relationships" r:id="R84a16defcae842db"/>
+                <a:hlinkClick xmlns:r="http://schemas.openxmlformats.org/officeDocument/2006/relationships" r:id="R21da459c7684438b"/>
               </a:rPr>
               <a:t>Knowledge and attitude towards advance directives for patients with terminal illnesses among doctors working in a tertiary care hospital</a:t>
             </a:r>
@@ -10553,7 +10553,7 @@
           <p:cNvPr id="19" name="Reference 6 link">
             <a:extLst xmlns:a="http://schemas.openxmlformats.org/drawingml/2006/main">
               <a:ext uri="{FF2B5EF4-FFF2-40B4-BE49-F238E27FC236}">
-                <a16:creationId xmlns:a16="http://schemas.microsoft.com/office/drawing/2014/main" id="{AA734F90-B23E-4DCE-A3AB-3A022C063D0C}"/>
+                <a16:creationId xmlns:a16="http://schemas.microsoft.com/office/drawing/2014/main" id="{76CB2FAD-3CE2-4E09-8C22-07135F201D24}"/>
               </a:ext>
             </a:extLst>
           </p:cNvPr>
@@ -10599,7 +10599,7 @@
                 <a:latin typeface="Arial"/>
                 <a:ea typeface="Arial"/>
                 <a:cs typeface="Arial"/>
-                <a:hlinkClick xmlns:r="http://schemas.openxmlformats.org/officeDocument/2006/relationships" r:id="R464aca1bf1b8485e"/>
+                <a:hlinkClick xmlns:r="http://schemas.openxmlformats.org/officeDocument/2006/relationships" r:id="R8d762100621a421f"/>
               </a:rPr>
               <a:t>https://doi.org/10.25259/NMJI_817_2023</a:t>
             </a:r>
@@ -10611,7 +10611,7 @@
           <p:cNvPr id="20" name="Reference 7 author">
             <a:extLst xmlns:a="http://schemas.openxmlformats.org/drawingml/2006/main">
               <a:ext uri="{FF2B5EF4-FFF2-40B4-BE49-F238E27FC236}">
-                <a16:creationId xmlns:a16="http://schemas.microsoft.com/office/drawing/2014/main" id="{6C5E33A0-9FC9-4EBB-9A53-323975B366D5}"/>
+                <a16:creationId xmlns:a16="http://schemas.microsoft.com/office/drawing/2014/main" id="{C32C221E-622D-4166-9FF6-4220291AB527}"/>
               </a:ext>
             </a:extLst>
           </p:cNvPr>
@@ -10668,7 +10668,7 @@
           <p:cNvPr id="21" name="Reference 7 title">
             <a:extLst xmlns:a="http://schemas.openxmlformats.org/drawingml/2006/main">
               <a:ext uri="{FF2B5EF4-FFF2-40B4-BE49-F238E27FC236}">
-                <a16:creationId xmlns:a16="http://schemas.microsoft.com/office/drawing/2014/main" id="{96A659AF-D517-4720-A844-DD9560F3EA19}"/>
+                <a16:creationId xmlns:a16="http://schemas.microsoft.com/office/drawing/2014/main" id="{6EB3490B-A43F-4186-B607-A42C539925FD}"/>
               </a:ext>
             </a:extLst>
           </p:cNvPr>
@@ -10714,7 +10714,7 @@
                 <a:latin typeface="Arial"/>
                 <a:ea typeface="Arial"/>
                 <a:cs typeface="Arial"/>
-                <a:hlinkClick xmlns:r="http://schemas.openxmlformats.org/officeDocument/2006/relationships" r:id="R22fceacadbdb44ab"/>
+                <a:hlinkClick xmlns:r="http://schemas.openxmlformats.org/officeDocument/2006/relationships" r:id="Rcc4d324e49b3433b"/>
               </a:rPr>
               <a:t>Barriers and Facilitators to Advance Care Planning Implementation for Patients with Neurodegenerative Diseases among Indian Physicians: A Mixed-Methods Analysis</a:t>
             </a:r>
@@ -10726,7 +10726,7 @@
           <p:cNvPr id="22" name="Reference 7 link">
             <a:extLst xmlns:a="http://schemas.openxmlformats.org/drawingml/2006/main">
               <a:ext uri="{FF2B5EF4-FFF2-40B4-BE49-F238E27FC236}">
-                <a16:creationId xmlns:a16="http://schemas.microsoft.com/office/drawing/2014/main" id="{FB21AA3D-6C09-4E04-8D77-EEBA820EB4EA}"/>
+                <a16:creationId xmlns:a16="http://schemas.microsoft.com/office/drawing/2014/main" id="{D3DA45CF-54FD-4993-BC65-133C08285333}"/>
               </a:ext>
             </a:extLst>
           </p:cNvPr>
@@ -10772,7 +10772,7 @@
                 <a:latin typeface="Arial"/>
                 <a:ea typeface="Arial"/>
                 <a:cs typeface="Arial"/>
-                <a:hlinkClick xmlns:r="http://schemas.openxmlformats.org/officeDocument/2006/relationships" r:id="Rb793612e06774f3b"/>
+                <a:hlinkClick xmlns:r="http://schemas.openxmlformats.org/officeDocument/2006/relationships" r:id="R4e61801ea5c548d2"/>
               </a:rPr>
               <a:t>https://doi.org/10.1101/2025.10.17.25338242</a:t>
             </a:r>
@@ -10784,7 +10784,7 @@
           <p:cNvPr id="23" name="Reference 8 author">
             <a:extLst xmlns:a="http://schemas.openxmlformats.org/drawingml/2006/main">
               <a:ext uri="{FF2B5EF4-FFF2-40B4-BE49-F238E27FC236}">
-                <a16:creationId xmlns:a16="http://schemas.microsoft.com/office/drawing/2014/main" id="{A6065865-7767-47B9-8E55-1F009FB1967A}"/>
+                <a16:creationId xmlns:a16="http://schemas.microsoft.com/office/drawing/2014/main" id="{7A744B26-5940-4C9C-929D-5BAB91A4806A}"/>
               </a:ext>
             </a:extLst>
           </p:cNvPr>
@@ -10841,7 +10841,7 @@
           <p:cNvPr id="24" name="Reference 8 title">
             <a:extLst xmlns:a="http://schemas.openxmlformats.org/drawingml/2006/main">
               <a:ext uri="{FF2B5EF4-FFF2-40B4-BE49-F238E27FC236}">
-                <a16:creationId xmlns:a16="http://schemas.microsoft.com/office/drawing/2014/main" id="{745B2407-0495-4FED-81E9-CDE8BDE007AC}"/>
+                <a16:creationId xmlns:a16="http://schemas.microsoft.com/office/drawing/2014/main" id="{DCF2EF99-C2AC-456F-BDF4-0EA5C396F666}"/>
               </a:ext>
             </a:extLst>
           </p:cNvPr>
@@ -10887,7 +10887,7 @@
                 <a:latin typeface="Arial"/>
                 <a:ea typeface="Arial"/>
                 <a:cs typeface="Arial"/>
-                <a:hlinkClick xmlns:r="http://schemas.openxmlformats.org/officeDocument/2006/relationships" r:id="R6836bb6dfd5a42b6"/>
+                <a:hlinkClick xmlns:r="http://schemas.openxmlformats.org/officeDocument/2006/relationships" r:id="Re5f4efbd76c84744"/>
               </a:rPr>
               <a:t>An Ethnographic Study of Barriers to Cancer Pain Management and Opioid Availability in India</a:t>
             </a:r>
@@ -10899,7 +10899,7 @@
           <p:cNvPr id="25" name="Reference 8 link">
             <a:extLst xmlns:a="http://schemas.openxmlformats.org/drawingml/2006/main">
               <a:ext uri="{FF2B5EF4-FFF2-40B4-BE49-F238E27FC236}">
-                <a16:creationId xmlns:a16="http://schemas.microsoft.com/office/drawing/2014/main" id="{6038E7C3-3A88-49E7-86F0-D3E1208E03D0}"/>
+                <a16:creationId xmlns:a16="http://schemas.microsoft.com/office/drawing/2014/main" id="{E950125E-49A5-406B-BA20-BEB45DFB81C2}"/>
               </a:ext>
             </a:extLst>
           </p:cNvPr>
@@ -10945,7 +10945,7 @@
                 <a:latin typeface="Arial"/>
                 <a:ea typeface="Arial"/>
                 <a:cs typeface="Arial"/>
-                <a:hlinkClick xmlns:r="http://schemas.openxmlformats.org/officeDocument/2006/relationships" r:id="R86ec70da02854d3a"/>
+                <a:hlinkClick xmlns:r="http://schemas.openxmlformats.org/officeDocument/2006/relationships" r:id="Re7143ac7d8e44b72"/>
               </a:rPr>
               <a:t>https://doi.org/10.1634/theoncologist.2013-0435</a:t>
             </a:r>
@@ -10957,7 +10957,7 @@
           <p:cNvPr id="26" name="Reference 9 author">
             <a:extLst xmlns:a="http://schemas.openxmlformats.org/drawingml/2006/main">
               <a:ext uri="{FF2B5EF4-FFF2-40B4-BE49-F238E27FC236}">
-                <a16:creationId xmlns:a16="http://schemas.microsoft.com/office/drawing/2014/main" id="{15615E27-B43A-4EE8-9F77-93D3660FF390}"/>
+                <a16:creationId xmlns:a16="http://schemas.microsoft.com/office/drawing/2014/main" id="{C1372F50-2F13-4EC5-BF40-C96D81950094}"/>
               </a:ext>
             </a:extLst>
           </p:cNvPr>
@@ -11014,7 +11014,7 @@
           <p:cNvPr id="27" name="Reference 9 title">
             <a:extLst xmlns:a="http://schemas.openxmlformats.org/drawingml/2006/main">
               <a:ext uri="{FF2B5EF4-FFF2-40B4-BE49-F238E27FC236}">
-                <a16:creationId xmlns:a16="http://schemas.microsoft.com/office/drawing/2014/main" id="{1603E274-0C86-4C2E-B279-172C6C876DB5}"/>
+                <a16:creationId xmlns:a16="http://schemas.microsoft.com/office/drawing/2014/main" id="{BF6ED5F0-1CD1-48AB-9158-BE0A771AB431}"/>
               </a:ext>
             </a:extLst>
           </p:cNvPr>
@@ -11060,7 +11060,7 @@
                 <a:latin typeface="Arial"/>
                 <a:ea typeface="Arial"/>
                 <a:cs typeface="Arial"/>
-                <a:hlinkClick xmlns:r="http://schemas.openxmlformats.org/officeDocument/2006/relationships" r:id="Rdd7a78ca03904605"/>
+                <a:hlinkClick xmlns:r="http://schemas.openxmlformats.org/officeDocument/2006/relationships" r:id="Rcadefec2c7da4acb"/>
               </a:rPr>
               <a:t>Receipt of Psychosocial Care Among Cancer Survivors in the United States</a:t>
             </a:r>
@@ -11072,7 +11072,7 @@
           <p:cNvPr id="28" name="Reference 9 link">
             <a:extLst xmlns:a="http://schemas.openxmlformats.org/drawingml/2006/main">
               <a:ext uri="{FF2B5EF4-FFF2-40B4-BE49-F238E27FC236}">
-                <a16:creationId xmlns:a16="http://schemas.microsoft.com/office/drawing/2014/main" id="{652E2603-E678-4966-9CCD-C4E9A4D548BA}"/>
+                <a16:creationId xmlns:a16="http://schemas.microsoft.com/office/drawing/2014/main" id="{5EBBCBFC-6131-4E36-97AA-D16BDC524DA4}"/>
               </a:ext>
             </a:extLst>
           </p:cNvPr>
@@ -11118,7 +11118,7 @@
                 <a:latin typeface="Arial"/>
                 <a:ea typeface="Arial"/>
                 <a:cs typeface="Arial"/>
-                <a:hlinkClick xmlns:r="http://schemas.openxmlformats.org/officeDocument/2006/relationships" r:id="R6fd4a1f57c6c4f5e"/>
+                <a:hlinkClick xmlns:r="http://schemas.openxmlformats.org/officeDocument/2006/relationships" r:id="R49f6bfdd1b4845fc"/>
               </a:rPr>
               <a:t>https://doi.org/10.1200/JCO.2012.46.2101</a:t>
             </a:r>

</xml_diff>

<commit_message>
Give the reference slide a stronger closing palette
</commit_message>
<xml_diff>
--- a/submission/Saathi_Healthathon_Final.pptx
+++ b/submission/Saathi_Healthathon_Final.pptx
@@ -2,20 +2,20 @@
 <file path=ppt/presentation.xml><?xml version="1.0" encoding="utf-8"?>
 <p:presentation xmlns:p="http://schemas.openxmlformats.org/presentationml/2006/main">
   <p:sldMasterIdLst>
-    <p:sldMasterId xmlns:r="http://schemas.openxmlformats.org/officeDocument/2006/relationships" id="2147483648" r:id="Rfbf9f0d76543491e"/>
+    <p:sldMasterId xmlns:r="http://schemas.openxmlformats.org/officeDocument/2006/relationships" id="2147483648" r:id="R7447360e79e74cf9"/>
   </p:sldMasterIdLst>
   <p:notesMasterIdLst>
-    <p:notesMasterId xmlns:r="http://schemas.openxmlformats.org/officeDocument/2006/relationships" r:id="R7c385da5d4f04bfd"/>
+    <p:notesMasterId xmlns:r="http://schemas.openxmlformats.org/officeDocument/2006/relationships" r:id="R2a7f1143416247cf"/>
   </p:notesMasterIdLst>
   <p:sldIdLst>
-    <p:sldId xmlns:r="http://schemas.openxmlformats.org/officeDocument/2006/relationships" id="256" r:id="Rf34b3e9afaa341c5"/>
-    <p:sldId xmlns:r="http://schemas.openxmlformats.org/officeDocument/2006/relationships" id="257" r:id="Rc15c91ccc4554d9a"/>
-    <p:sldId xmlns:r="http://schemas.openxmlformats.org/officeDocument/2006/relationships" id="258" r:id="Rc635b369d8ad4c50"/>
-    <p:sldId xmlns:r="http://schemas.openxmlformats.org/officeDocument/2006/relationships" id="259" r:id="Rd337e3c49b2b4d0d"/>
-    <p:sldId xmlns:r="http://schemas.openxmlformats.org/officeDocument/2006/relationships" id="260" r:id="R486be6ba281c40fd"/>
-    <p:sldId xmlns:r="http://schemas.openxmlformats.org/officeDocument/2006/relationships" id="261" r:id="Ra6bb2d84982746ef"/>
-    <p:sldId xmlns:r="http://schemas.openxmlformats.org/officeDocument/2006/relationships" id="262" r:id="R732b48da8caa46f8"/>
-    <p:sldId xmlns:r="http://schemas.openxmlformats.org/officeDocument/2006/relationships" id="263" r:id="Ref55a49f3410490e"/>
+    <p:sldId xmlns:r="http://schemas.openxmlformats.org/officeDocument/2006/relationships" id="256" r:id="R473d67c8d11c4fb5"/>
+    <p:sldId xmlns:r="http://schemas.openxmlformats.org/officeDocument/2006/relationships" id="257" r:id="R1e4e2336af2c4c4b"/>
+    <p:sldId xmlns:r="http://schemas.openxmlformats.org/officeDocument/2006/relationships" id="258" r:id="R05d75bf406034e57"/>
+    <p:sldId xmlns:r="http://schemas.openxmlformats.org/officeDocument/2006/relationships" id="259" r:id="R9562f9f7e651428d"/>
+    <p:sldId xmlns:r="http://schemas.openxmlformats.org/officeDocument/2006/relationships" id="260" r:id="R70ad3b27d8444bfe"/>
+    <p:sldId xmlns:r="http://schemas.openxmlformats.org/officeDocument/2006/relationships" id="261" r:id="R72cf717420a14775"/>
+    <p:sldId xmlns:r="http://schemas.openxmlformats.org/officeDocument/2006/relationships" id="262" r:id="R7a182b31120c45ea"/>
+    <p:sldId xmlns:r="http://schemas.openxmlformats.org/officeDocument/2006/relationships" id="263" r:id="R5f5adecb63be488b"/>
   </p:sldIdLst>
   <p:sldSz cx="12192000" cy="6858000"/>
   <p:notesSz cx="6858000" cy="9144000"/>
@@ -1387,7 +1387,7 @@
   </p:cSld>
   <p:clrMap bg1="lt1" tx1="dk1" bg2="lt2" tx2="dk2" accent1="accent1" accent2="accent2" accent3="accent3" accent4="accent4" accent5="accent5" accent6="accent6" hlink="hlink" folHlink="folHlink"/>
   <p:sldLayoutIdLst>
-    <p:sldLayoutId xmlns:r="http://schemas.openxmlformats.org/officeDocument/2006/relationships" id="2147483649" r:id="Rbe3f98b33d9b4c4f"/>
+    <p:sldLayoutId xmlns:r="http://schemas.openxmlformats.org/officeDocument/2006/relationships" id="2147483649" r:id="R934c815e40354b52"/>
   </p:sldLayoutIdLst>
   <p:txStyles>
     <p:titleStyle>
@@ -2144,10 +2144,10 @@
           <p:nvPr/>
         </p:nvPicPr>
         <p:blipFill>
-          <a:blip xmlns:r="http://schemas.openxmlformats.org/officeDocument/2006/relationships" xmlns:a="http://schemas.openxmlformats.org/drawingml/2006/main" r:embed="R5e5de537c1644b85">
+          <a:blip xmlns:r="http://schemas.openxmlformats.org/officeDocument/2006/relationships" xmlns:a="http://schemas.openxmlformats.org/drawingml/2006/main" r:embed="R30130442cec44730">
             <a:extLst>
               <a:ext uri="{96DAC541-7B7A-43D3-8B79-37D633B846F1}">
-                <asvg:svgBlip xmlns:asvg="http://schemas.microsoft.com/office/drawing/2016/SVG/main" r:embed="R6a5eddff09084ab7"/>
+                <asvg:svgBlip xmlns:asvg="http://schemas.microsoft.com/office/drawing/2016/SVG/main" r:embed="R6db39ec149734681"/>
               </a:ext>
             </a:extLst>
           </a:blip>
@@ -2168,7 +2168,7 @@
           <p:cNvPr id="2" name="Brand">
             <a:extLst xmlns:a="http://schemas.openxmlformats.org/drawingml/2006/main">
               <a:ext uri="{FF2B5EF4-FFF2-40B4-BE49-F238E27FC236}">
-                <a16:creationId xmlns:a16="http://schemas.microsoft.com/office/drawing/2014/main" id="{5547AA22-EA6E-4343-8C71-E78FB5DE7865}"/>
+                <a16:creationId xmlns:a16="http://schemas.microsoft.com/office/drawing/2014/main" id="{7D8BB98D-71E9-40B2-97EE-3C37CDE4E968}"/>
               </a:ext>
             </a:extLst>
           </p:cNvPr>
@@ -2225,7 +2225,7 @@
           <p:cNvPr id="3" name="Hindi name">
             <a:extLst xmlns:a="http://schemas.openxmlformats.org/drawingml/2006/main">
               <a:ext uri="{FF2B5EF4-FFF2-40B4-BE49-F238E27FC236}">
-                <a16:creationId xmlns:a16="http://schemas.microsoft.com/office/drawing/2014/main" id="{384AC488-C40E-461E-B8E0-010CC2460678}"/>
+                <a16:creationId xmlns:a16="http://schemas.microsoft.com/office/drawing/2014/main" id="{B35744F1-C926-4577-9635-2FB3FAC42CCA}"/>
               </a:ext>
             </a:extLst>
           </p:cNvPr>
@@ -2282,7 +2282,7 @@
           <p:cNvPr id="4" name="Name meaning">
             <a:extLst xmlns:a="http://schemas.openxmlformats.org/drawingml/2006/main">
               <a:ext uri="{FF2B5EF4-FFF2-40B4-BE49-F238E27FC236}">
-                <a16:creationId xmlns:a16="http://schemas.microsoft.com/office/drawing/2014/main" id="{8C18C6DB-19C8-49A5-9299-DEB80AA927D3}"/>
+                <a16:creationId xmlns:a16="http://schemas.microsoft.com/office/drawing/2014/main" id="{A417DA08-C0FF-4931-BD24-81B4A5F6C97B}"/>
               </a:ext>
             </a:extLst>
           </p:cNvPr>
@@ -2339,7 +2339,7 @@
           <p:cNvPr id="5" name="Purpose">
             <a:extLst xmlns:a="http://schemas.openxmlformats.org/drawingml/2006/main">
               <a:ext uri="{FF2B5EF4-FFF2-40B4-BE49-F238E27FC236}">
-                <a16:creationId xmlns:a16="http://schemas.microsoft.com/office/drawing/2014/main" id="{10B27708-76D5-4E11-BB71-3689BDFD7F01}"/>
+                <a16:creationId xmlns:a16="http://schemas.microsoft.com/office/drawing/2014/main" id="{82610A93-5219-4391-A09F-23D2ADA0C7E2}"/>
               </a:ext>
             </a:extLst>
           </p:cNvPr>
@@ -2400,7 +2400,7 @@
           <p:nvPr/>
         </p:nvPicPr>
         <p:blipFill>
-          <a:blip xmlns:r="http://schemas.openxmlformats.org/officeDocument/2006/relationships" xmlns:a="http://schemas.openxmlformats.org/drawingml/2006/main" r:embed="Rdae0d889d1584b81"/>
+          <a:blip xmlns:r="http://schemas.openxmlformats.org/officeDocument/2006/relationships" xmlns:a="http://schemas.openxmlformats.org/drawingml/2006/main" r:embed="Rbbe0fd68a15b40a8"/>
           <a:stretch xmlns:a="http://schemas.openxmlformats.org/drawingml/2006/main"/>
         </p:blipFill>
         <p:spPr>
@@ -2418,7 +2418,7 @@
           <p:cNvPr id="7" name="Website link">
             <a:extLst xmlns:a="http://schemas.openxmlformats.org/drawingml/2006/main">
               <a:ext uri="{FF2B5EF4-FFF2-40B4-BE49-F238E27FC236}">
-                <a16:creationId xmlns:a16="http://schemas.microsoft.com/office/drawing/2014/main" id="{B1D4CDDF-855D-4762-BA42-79C37E3998A5}"/>
+                <a16:creationId xmlns:a16="http://schemas.microsoft.com/office/drawing/2014/main" id="{243B086D-E3C1-46E8-B1FE-7EFFA788748A}"/>
               </a:ext>
             </a:extLst>
           </p:cNvPr>
@@ -2464,7 +2464,7 @@
                 <a:latin typeface="Arial"/>
                 <a:ea typeface="Arial"/>
                 <a:cs typeface="Arial"/>
-                <a:hlinkClick xmlns:r="http://schemas.openxmlformats.org/officeDocument/2006/relationships" r:id="R9d5bf5d7398843d2"/>
+                <a:hlinkClick xmlns:r="http://schemas.openxmlformats.org/officeDocument/2006/relationships" r:id="R40707b338ac14922"/>
               </a:rPr>
               <a:t>OPEN THE WEBSITE - saathi.wedevit.in</a:t>
             </a:r>
@@ -2480,10 +2480,10 @@
           <p:nvPr/>
         </p:nvPicPr>
         <p:blipFill>
-          <a:blip xmlns:r="http://schemas.openxmlformats.org/officeDocument/2006/relationships" xmlns:a="http://schemas.openxmlformats.org/drawingml/2006/main" r:embed="R090690a44cbd464a">
+          <a:blip xmlns:r="http://schemas.openxmlformats.org/officeDocument/2006/relationships" xmlns:a="http://schemas.openxmlformats.org/drawingml/2006/main" r:embed="Rb1d10f65e03346ae">
             <a:extLst>
               <a:ext uri="{96DAC541-7B7A-43D3-8B79-37D633B846F1}">
-                <asvg:svgBlip xmlns:asvg="http://schemas.microsoft.com/office/drawing/2016/SVG/main" r:embed="R46e0d379171c47d3"/>
+                <asvg:svgBlip xmlns:asvg="http://schemas.microsoft.com/office/drawing/2016/SVG/main" r:embed="R855ec724def8433b"/>
               </a:ext>
             </a:extLst>
           </a:blip>
@@ -2504,7 +2504,7 @@
           <p:cNvPr id="9" name="Repository link">
             <a:extLst xmlns:a="http://schemas.openxmlformats.org/drawingml/2006/main">
               <a:ext uri="{FF2B5EF4-FFF2-40B4-BE49-F238E27FC236}">
-                <a16:creationId xmlns:a16="http://schemas.microsoft.com/office/drawing/2014/main" id="{40070222-2987-405E-8F9D-7A08CEFF804A}"/>
+                <a16:creationId xmlns:a16="http://schemas.microsoft.com/office/drawing/2014/main" id="{888D1162-997B-402E-9479-59AA371D2D3F}"/>
               </a:ext>
             </a:extLst>
           </p:cNvPr>
@@ -2550,7 +2550,7 @@
                 <a:latin typeface="Arial"/>
                 <a:ea typeface="Arial"/>
                 <a:cs typeface="Arial"/>
-                <a:hlinkClick xmlns:r="http://schemas.openxmlformats.org/officeDocument/2006/relationships" r:id="R26da461d84f049bf"/>
+                <a:hlinkClick xmlns:r="http://schemas.openxmlformats.org/officeDocument/2006/relationships" r:id="R1cf8669fb36f4a02"/>
               </a:rPr>
               <a:t>github.com/basithladdu/healthathon</a:t>
             </a:r>
@@ -2566,10 +2566,10 @@
           <p:nvPr/>
         </p:nvPicPr>
         <p:blipFill>
-          <a:blip xmlns:r="http://schemas.openxmlformats.org/officeDocument/2006/relationships" xmlns:a="http://schemas.openxmlformats.org/drawingml/2006/main" r:embed="Rdc5fee4ad1384f6b">
+          <a:blip xmlns:r="http://schemas.openxmlformats.org/officeDocument/2006/relationships" xmlns:a="http://schemas.openxmlformats.org/drawingml/2006/main" r:embed="R01496778073a4155">
             <a:extLst>
               <a:ext uri="{96DAC541-7B7A-43D3-8B79-37D633B846F1}">
-                <asvg:svgBlip xmlns:asvg="http://schemas.microsoft.com/office/drawing/2016/SVG/main" r:embed="Rda64c2a8ec96442a"/>
+                <asvg:svgBlip xmlns:asvg="http://schemas.microsoft.com/office/drawing/2016/SVG/main" r:embed="R6bdeb857882947ca"/>
               </a:ext>
             </a:extLst>
           </a:blip>
@@ -2590,7 +2590,7 @@
           <p:cNvPr id="11" name="Questions contact">
             <a:extLst xmlns:a="http://schemas.openxmlformats.org/drawingml/2006/main">
               <a:ext uri="{FF2B5EF4-FFF2-40B4-BE49-F238E27FC236}">
-                <a16:creationId xmlns:a16="http://schemas.microsoft.com/office/drawing/2014/main" id="{C909E356-0A9E-4F35-AAD2-E142CEF681BD}"/>
+                <a16:creationId xmlns:a16="http://schemas.microsoft.com/office/drawing/2014/main" id="{D5096E3E-02BD-4922-A834-769CD9F4CE03}"/>
               </a:ext>
             </a:extLst>
           </p:cNvPr>
@@ -2636,7 +2636,7 @@
                 <a:latin typeface="Arial"/>
                 <a:ea typeface="Arial"/>
                 <a:cs typeface="Arial"/>
-                <a:hlinkClick xmlns:r="http://schemas.openxmlformats.org/officeDocument/2006/relationships" r:id="Ree5d62189a9f4275"/>
+                <a:hlinkClick xmlns:r="http://schemas.openxmlformats.org/officeDocument/2006/relationships" r:id="R1bd14870e96b474f"/>
               </a:rPr>
               <a:t>Questions? Contact us</a:t>
             </a:r>
@@ -2648,7 +2648,7 @@
           <p:cNvPr id="12" name="WhatsApp link">
             <a:extLst xmlns:a="http://schemas.openxmlformats.org/drawingml/2006/main">
               <a:ext uri="{FF2B5EF4-FFF2-40B4-BE49-F238E27FC236}">
-                <a16:creationId xmlns:a16="http://schemas.microsoft.com/office/drawing/2014/main" id="{6262E102-B3C1-4DAC-B94A-C74DF907A763}"/>
+                <a16:creationId xmlns:a16="http://schemas.microsoft.com/office/drawing/2014/main" id="{F29B7FF4-853F-4C2D-93C7-49E35BDAB82D}"/>
               </a:ext>
             </a:extLst>
           </p:cNvPr>
@@ -2694,7 +2694,7 @@
                 <a:latin typeface="Arial"/>
                 <a:ea typeface="Arial"/>
                 <a:cs typeface="Arial"/>
-                <a:hlinkClick xmlns:r="http://schemas.openxmlformats.org/officeDocument/2006/relationships" r:id="R702d8fd4595b4eb1"/>
+                <a:hlinkClick xmlns:r="http://schemas.openxmlformats.org/officeDocument/2006/relationships" r:id="R03acf4e8f9464bf5"/>
               </a:rPr>
               <a:t>wa.me/919553321211</a:t>
             </a:r>
@@ -2706,7 +2706,7 @@
           <p:cNvPr id="13" name="">
             <a:extLst xmlns:a="http://schemas.openxmlformats.org/drawingml/2006/main">
               <a:ext uri="{FF2B5EF4-FFF2-40B4-BE49-F238E27FC236}">
-                <a16:creationId xmlns:a16="http://schemas.microsoft.com/office/drawing/2014/main" id="{C134C642-405F-4C51-848E-EC843730A079}"/>
+                <a16:creationId xmlns:a16="http://schemas.microsoft.com/office/drawing/2014/main" id="{8F02BC6F-7D6C-4893-9CA8-F94F01562388}"/>
               </a:ext>
             </a:extLst>
           </p:cNvPr>
@@ -2735,7 +2735,7 @@
           <p:cNvPr id="14" name="Team heading">
             <a:extLst xmlns:a="http://schemas.openxmlformats.org/drawingml/2006/main">
               <a:ext uri="{FF2B5EF4-FFF2-40B4-BE49-F238E27FC236}">
-                <a16:creationId xmlns:a16="http://schemas.microsoft.com/office/drawing/2014/main" id="{EC68B406-1B96-4477-ADE2-C890996F17BA}"/>
+                <a16:creationId xmlns:a16="http://schemas.microsoft.com/office/drawing/2014/main" id="{8B2786F9-8298-4A4D-8F76-5811A494C0B5}"/>
               </a:ext>
             </a:extLst>
           </p:cNvPr>
@@ -2796,7 +2796,7 @@
           <p:nvPr/>
         </p:nvPicPr>
         <p:blipFill>
-          <a:blip xmlns:r="http://schemas.openxmlformats.org/officeDocument/2006/relationships" xmlns:a="http://schemas.openxmlformats.org/drawingml/2006/main" r:embed="Rb52d535c17244d17"/>
+          <a:blip xmlns:r="http://schemas.openxmlformats.org/officeDocument/2006/relationships" xmlns:a="http://schemas.openxmlformats.org/drawingml/2006/main" r:embed="R30c8e3e3b0b64483"/>
           <a:srcRect xmlns:a="http://schemas.openxmlformats.org/drawingml/2006/main" l="0" t="5331" r="0" b="5331"/>
           <a:stretch xmlns:a="http://schemas.openxmlformats.org/drawingml/2006/main">
             <a:fillRect l="0" t="0" r="0" b="0"/>
@@ -2817,7 +2817,7 @@
           <p:cNvPr id="16" name="Team member 1">
             <a:extLst xmlns:a="http://schemas.openxmlformats.org/drawingml/2006/main">
               <a:ext uri="{FF2B5EF4-FFF2-40B4-BE49-F238E27FC236}">
-                <a16:creationId xmlns:a16="http://schemas.microsoft.com/office/drawing/2014/main" id="{EE950659-3C00-4304-B78E-5B191AD815BD}"/>
+                <a16:creationId xmlns:a16="http://schemas.microsoft.com/office/drawing/2014/main" id="{17D139CB-6B6A-46DD-BEA0-4AD57904352B}"/>
               </a:ext>
             </a:extLst>
           </p:cNvPr>
@@ -2897,7 +2897,7 @@
           <p:cNvPr id="17" name="Team role 1">
             <a:extLst xmlns:a="http://schemas.openxmlformats.org/drawingml/2006/main">
               <a:ext uri="{FF2B5EF4-FFF2-40B4-BE49-F238E27FC236}">
-                <a16:creationId xmlns:a16="http://schemas.microsoft.com/office/drawing/2014/main" id="{9264044F-CFC9-4C2B-9528-13DF25AE1EBA}"/>
+                <a16:creationId xmlns:a16="http://schemas.microsoft.com/office/drawing/2014/main" id="{FF8E6538-AB3C-4004-8B82-98A7C638832D}"/>
               </a:ext>
             </a:extLst>
           </p:cNvPr>
@@ -2958,7 +2958,7 @@
           <p:nvPr/>
         </p:nvPicPr>
         <p:blipFill>
-          <a:blip xmlns:r="http://schemas.openxmlformats.org/officeDocument/2006/relationships" xmlns:a="http://schemas.openxmlformats.org/drawingml/2006/main" r:embed="R2178a5995d084343"/>
+          <a:blip xmlns:r="http://schemas.openxmlformats.org/officeDocument/2006/relationships" xmlns:a="http://schemas.openxmlformats.org/drawingml/2006/main" r:embed="Rb64ce5be8d104cdb"/>
           <a:srcRect xmlns:a="http://schemas.openxmlformats.org/drawingml/2006/main" l="0" t="19104" r="0" b="19104"/>
           <a:stretch xmlns:a="http://schemas.openxmlformats.org/drawingml/2006/main">
             <a:fillRect l="0" t="0" r="0" b="0"/>
@@ -2979,7 +2979,7 @@
           <p:cNvPr id="19" name="Team member 2">
             <a:extLst xmlns:a="http://schemas.openxmlformats.org/drawingml/2006/main">
               <a:ext uri="{FF2B5EF4-FFF2-40B4-BE49-F238E27FC236}">
-                <a16:creationId xmlns:a16="http://schemas.microsoft.com/office/drawing/2014/main" id="{32FE17B3-5C04-45C2-995C-A13F1780C69C}"/>
+                <a16:creationId xmlns:a16="http://schemas.microsoft.com/office/drawing/2014/main" id="{D6D80B80-36DA-46B7-AFDD-DB2F244B43A6}"/>
               </a:ext>
             </a:extLst>
           </p:cNvPr>
@@ -3059,7 +3059,7 @@
           <p:cNvPr id="20" name="Team role 2">
             <a:extLst xmlns:a="http://schemas.openxmlformats.org/drawingml/2006/main">
               <a:ext uri="{FF2B5EF4-FFF2-40B4-BE49-F238E27FC236}">
-                <a16:creationId xmlns:a16="http://schemas.microsoft.com/office/drawing/2014/main" id="{DF4C8D24-6F1B-4415-9872-ED9A3001A1F8}"/>
+                <a16:creationId xmlns:a16="http://schemas.microsoft.com/office/drawing/2014/main" id="{4F7BB01F-FA1E-4148-BF12-3DA7D310D880}"/>
               </a:ext>
             </a:extLst>
           </p:cNvPr>
@@ -3116,7 +3116,7 @@
           <p:cNvPr id="21" name="Photo space for Dr Sharada&#10;Vinod Kutty">
             <a:extLst xmlns:a="http://schemas.openxmlformats.org/drawingml/2006/main">
               <a:ext uri="{FF2B5EF4-FFF2-40B4-BE49-F238E27FC236}">
-                <a16:creationId xmlns:a16="http://schemas.microsoft.com/office/drawing/2014/main" id="{A0A22A67-2978-45B2-9587-6913ACF51508}"/>
+                <a16:creationId xmlns:a16="http://schemas.microsoft.com/office/drawing/2014/main" id="{9BEF968F-6892-4C04-B6DE-7EC37B8401C1}"/>
               </a:ext>
             </a:extLst>
           </p:cNvPr>
@@ -3148,7 +3148,7 @@
           <p:cNvPr id="22" name="Team member 3">
             <a:extLst xmlns:a="http://schemas.openxmlformats.org/drawingml/2006/main">
               <a:ext uri="{FF2B5EF4-FFF2-40B4-BE49-F238E27FC236}">
-                <a16:creationId xmlns:a16="http://schemas.microsoft.com/office/drawing/2014/main" id="{E7A8EFDC-8FFD-4FED-9012-5035A697EC39}"/>
+                <a16:creationId xmlns:a16="http://schemas.microsoft.com/office/drawing/2014/main" id="{5F484A58-03EB-4C7C-90F6-F5C839072D85}"/>
               </a:ext>
             </a:extLst>
           </p:cNvPr>
@@ -3228,7 +3228,7 @@
           <p:cNvPr id="23" name="Team role 3">
             <a:extLst xmlns:a="http://schemas.openxmlformats.org/drawingml/2006/main">
               <a:ext uri="{FF2B5EF4-FFF2-40B4-BE49-F238E27FC236}">
-                <a16:creationId xmlns:a16="http://schemas.microsoft.com/office/drawing/2014/main" id="{CBE10AAD-F218-40F2-A0A0-5117CD9E831B}"/>
+                <a16:creationId xmlns:a16="http://schemas.microsoft.com/office/drawing/2014/main" id="{FDA3A752-6C63-4752-A865-1CE6BEA4B5E1}"/>
               </a:ext>
             </a:extLst>
           </p:cNvPr>
@@ -3285,7 +3285,7 @@
           <p:cNvPr id="24" name="Photo space for Dr Sujay&#10;Halkur Shankar">
             <a:extLst xmlns:a="http://schemas.openxmlformats.org/drawingml/2006/main">
               <a:ext uri="{FF2B5EF4-FFF2-40B4-BE49-F238E27FC236}">
-                <a16:creationId xmlns:a16="http://schemas.microsoft.com/office/drawing/2014/main" id="{ADC6850E-C54C-456B-A805-50DB7804690E}"/>
+                <a16:creationId xmlns:a16="http://schemas.microsoft.com/office/drawing/2014/main" id="{008EFD23-BC25-420D-958F-D184536C2171}"/>
               </a:ext>
             </a:extLst>
           </p:cNvPr>
@@ -3317,7 +3317,7 @@
           <p:cNvPr id="25" name="Team member 4">
             <a:extLst xmlns:a="http://schemas.openxmlformats.org/drawingml/2006/main">
               <a:ext uri="{FF2B5EF4-FFF2-40B4-BE49-F238E27FC236}">
-                <a16:creationId xmlns:a16="http://schemas.microsoft.com/office/drawing/2014/main" id="{C151C18F-73EA-4553-9A44-DDBCA9610102}"/>
+                <a16:creationId xmlns:a16="http://schemas.microsoft.com/office/drawing/2014/main" id="{A74A4506-9E2C-4B6D-9F27-FE690E11E476}"/>
               </a:ext>
             </a:extLst>
           </p:cNvPr>
@@ -3397,7 +3397,7 @@
           <p:cNvPr id="26" name="Team role 4">
             <a:extLst xmlns:a="http://schemas.openxmlformats.org/drawingml/2006/main">
               <a:ext uri="{FF2B5EF4-FFF2-40B4-BE49-F238E27FC236}">
-                <a16:creationId xmlns:a16="http://schemas.microsoft.com/office/drawing/2014/main" id="{2A34FA39-7FA1-4176-ADDD-46522E97E97D}"/>
+                <a16:creationId xmlns:a16="http://schemas.microsoft.com/office/drawing/2014/main" id="{C0A09DC6-2F75-4F8F-97D3-22E69984DBFB}"/>
               </a:ext>
             </a:extLst>
           </p:cNvPr>
@@ -3454,7 +3454,7 @@
           <p:cNvPr id="27" name="Photo space for Shirin Ayub">
             <a:extLst xmlns:a="http://schemas.openxmlformats.org/drawingml/2006/main">
               <a:ext uri="{FF2B5EF4-FFF2-40B4-BE49-F238E27FC236}">
-                <a16:creationId xmlns:a16="http://schemas.microsoft.com/office/drawing/2014/main" id="{B81C4423-9165-412E-AAD4-DB13B4C6CF23}"/>
+                <a16:creationId xmlns:a16="http://schemas.microsoft.com/office/drawing/2014/main" id="{43F5FE0D-9796-4332-9362-0758D111BF31}"/>
               </a:ext>
             </a:extLst>
           </p:cNvPr>
@@ -3486,7 +3486,7 @@
           <p:cNvPr id="28" name="Team member 5">
             <a:extLst xmlns:a="http://schemas.openxmlformats.org/drawingml/2006/main">
               <a:ext uri="{FF2B5EF4-FFF2-40B4-BE49-F238E27FC236}">
-                <a16:creationId xmlns:a16="http://schemas.microsoft.com/office/drawing/2014/main" id="{D3B2F1DF-723A-4B6F-8C50-2F81DC35F410}"/>
+                <a16:creationId xmlns:a16="http://schemas.microsoft.com/office/drawing/2014/main" id="{49AEB020-69C0-4CE8-9A18-C7678629D237}"/>
               </a:ext>
             </a:extLst>
           </p:cNvPr>
@@ -3543,7 +3543,7 @@
           <p:cNvPr id="29" name="Team role 5">
             <a:extLst xmlns:a="http://schemas.openxmlformats.org/drawingml/2006/main">
               <a:ext uri="{FF2B5EF4-FFF2-40B4-BE49-F238E27FC236}">
-                <a16:creationId xmlns:a16="http://schemas.microsoft.com/office/drawing/2014/main" id="{307C723A-D9D5-4B48-9230-649EA0455FD5}"/>
+                <a16:creationId xmlns:a16="http://schemas.microsoft.com/office/drawing/2014/main" id="{E0655BEE-58E9-4703-9F94-96A6C372177E}"/>
               </a:ext>
             </a:extLst>
           </p:cNvPr>
@@ -3629,7 +3629,7 @@
           <p:cNvPr id="16" name="Slide title">
             <a:extLst xmlns:a="http://schemas.openxmlformats.org/drawingml/2006/main">
               <a:ext uri="{FF2B5EF4-FFF2-40B4-BE49-F238E27FC236}">
-                <a16:creationId xmlns:a16="http://schemas.microsoft.com/office/drawing/2014/main" id="{C18727ED-15AB-4FAB-95A6-7FCF935B987D}"/>
+                <a16:creationId xmlns:a16="http://schemas.microsoft.com/office/drawing/2014/main" id="{1CFDD4F0-1612-4405-9E52-D87EC8BBCC3D}"/>
               </a:ext>
             </a:extLst>
           </p:cNvPr>
@@ -3690,7 +3690,7 @@
           <p:nvPr/>
         </p:nvPicPr>
         <p:blipFill>
-          <a:blip xmlns:r="http://schemas.openxmlformats.org/officeDocument/2006/relationships" xmlns:a="http://schemas.openxmlformats.org/drawingml/2006/main" r:embed="R4de7aac1f4f64ea7"/>
+          <a:blip xmlns:r="http://schemas.openxmlformats.org/officeDocument/2006/relationships" xmlns:a="http://schemas.openxmlformats.org/drawingml/2006/main" r:embed="R0d796594cdf24e89"/>
           <a:stretch xmlns:a="http://schemas.openxmlformats.org/drawingml/2006/main"/>
         </p:blipFill>
         <p:spPr>
@@ -3708,7 +3708,7 @@
           <p:cNvPr id="3" name="Care photo context">
             <a:extLst xmlns:a="http://schemas.openxmlformats.org/drawingml/2006/main">
               <a:ext uri="{FF2B5EF4-FFF2-40B4-BE49-F238E27FC236}">
-                <a16:creationId xmlns:a16="http://schemas.microsoft.com/office/drawing/2014/main" id="{0AACA21A-6071-44AF-9C29-89F8A515CAA5}"/>
+                <a16:creationId xmlns:a16="http://schemas.microsoft.com/office/drawing/2014/main" id="{3C31AFA2-9932-47BE-80FE-24A12041DF80}"/>
               </a:ext>
             </a:extLst>
           </p:cNvPr>
@@ -3765,7 +3765,7 @@
           <p:cNvPr id="4" name="Illustrative patient">
             <a:extLst xmlns:a="http://schemas.openxmlformats.org/drawingml/2006/main">
               <a:ext uri="{FF2B5EF4-FFF2-40B4-BE49-F238E27FC236}">
-                <a16:creationId xmlns:a16="http://schemas.microsoft.com/office/drawing/2014/main" id="{538EA391-E00F-408F-A499-8F0529DE4EAA}"/>
+                <a16:creationId xmlns:a16="http://schemas.microsoft.com/office/drawing/2014/main" id="{1B150F19-6171-4355-B0AE-DEF10248DB78}"/>
               </a:ext>
             </a:extLst>
           </p:cNvPr>
@@ -3826,10 +3826,10 @@
           <p:nvPr/>
         </p:nvPicPr>
         <p:blipFill>
-          <a:blip xmlns:r="http://schemas.openxmlformats.org/officeDocument/2006/relationships" xmlns:a="http://schemas.openxmlformats.org/drawingml/2006/main" r:embed="R1638e763dbda456a">
+          <a:blip xmlns:r="http://schemas.openxmlformats.org/officeDocument/2006/relationships" xmlns:a="http://schemas.openxmlformats.org/drawingml/2006/main" r:embed="R868efaa07c8f418a">
             <a:extLst>
               <a:ext uri="{96DAC541-7B7A-43D3-8B79-37D633B846F1}">
-                <asvg:svgBlip xmlns:asvg="http://schemas.microsoft.com/office/drawing/2016/SVG/main" r:embed="R9a8cf3df228e4bcc"/>
+                <asvg:svgBlip xmlns:asvg="http://schemas.microsoft.com/office/drawing/2016/SVG/main" r:embed="R53f91e36ce3b45d1"/>
               </a:ext>
             </a:extLst>
           </a:blip>
@@ -3850,7 +3850,7 @@
           <p:cNvPr id="6" name="Story step 1">
             <a:extLst xmlns:a="http://schemas.openxmlformats.org/drawingml/2006/main">
               <a:ext uri="{FF2B5EF4-FFF2-40B4-BE49-F238E27FC236}">
-                <a16:creationId xmlns:a16="http://schemas.microsoft.com/office/drawing/2014/main" id="{826B84A1-EEA9-4AEE-BF36-FE6DF6D5FBDF}"/>
+                <a16:creationId xmlns:a16="http://schemas.microsoft.com/office/drawing/2014/main" id="{8E1379A0-D813-47C1-BEBE-A38AF37F537F}"/>
               </a:ext>
             </a:extLst>
           </p:cNvPr>
@@ -3907,7 +3907,7 @@
           <p:cNvPr id="7" name="Story step 1 detail">
             <a:extLst xmlns:a="http://schemas.openxmlformats.org/drawingml/2006/main">
               <a:ext uri="{FF2B5EF4-FFF2-40B4-BE49-F238E27FC236}">
-                <a16:creationId xmlns:a16="http://schemas.microsoft.com/office/drawing/2014/main" id="{B5EB7A40-377A-487F-A771-19E0E3A31CAA}"/>
+                <a16:creationId xmlns:a16="http://schemas.microsoft.com/office/drawing/2014/main" id="{C062E55A-D813-4FB7-9B14-9BF4A855A8D9}"/>
               </a:ext>
             </a:extLst>
           </p:cNvPr>
@@ -3968,10 +3968,10 @@
           <p:nvPr/>
         </p:nvPicPr>
         <p:blipFill>
-          <a:blip xmlns:r="http://schemas.openxmlformats.org/officeDocument/2006/relationships" xmlns:a="http://schemas.openxmlformats.org/drawingml/2006/main" r:embed="Rcbbc1732401b48f0">
+          <a:blip xmlns:r="http://schemas.openxmlformats.org/officeDocument/2006/relationships" xmlns:a="http://schemas.openxmlformats.org/drawingml/2006/main" r:embed="R455a06312f8240ec">
             <a:extLst>
               <a:ext uri="{96DAC541-7B7A-43D3-8B79-37D633B846F1}">
-                <asvg:svgBlip xmlns:asvg="http://schemas.microsoft.com/office/drawing/2016/SVG/main" r:embed="R74a39ca279ba483f"/>
+                <asvg:svgBlip xmlns:asvg="http://schemas.microsoft.com/office/drawing/2016/SVG/main" r:embed="Rb3c0b29c51874e24"/>
               </a:ext>
             </a:extLst>
           </a:blip>
@@ -3992,7 +3992,7 @@
           <p:cNvPr id="9" name="Story step 2">
             <a:extLst xmlns:a="http://schemas.openxmlformats.org/drawingml/2006/main">
               <a:ext uri="{FF2B5EF4-FFF2-40B4-BE49-F238E27FC236}">
-                <a16:creationId xmlns:a16="http://schemas.microsoft.com/office/drawing/2014/main" id="{0AC27A8D-CF64-469F-8F83-0D89AF0A23B1}"/>
+                <a16:creationId xmlns:a16="http://schemas.microsoft.com/office/drawing/2014/main" id="{361BC88C-ED82-4C59-BBF5-4759B2DEAE3E}"/>
               </a:ext>
             </a:extLst>
           </p:cNvPr>
@@ -4049,7 +4049,7 @@
           <p:cNvPr id="10" name="Story step 2 detail">
             <a:extLst xmlns:a="http://schemas.openxmlformats.org/drawingml/2006/main">
               <a:ext uri="{FF2B5EF4-FFF2-40B4-BE49-F238E27FC236}">
-                <a16:creationId xmlns:a16="http://schemas.microsoft.com/office/drawing/2014/main" id="{88AAA7EF-8C5D-4D1C-8B1E-75A505D8A657}"/>
+                <a16:creationId xmlns:a16="http://schemas.microsoft.com/office/drawing/2014/main" id="{F1B32DBA-E93A-4AA9-883F-F83B7E4A91C5}"/>
               </a:ext>
             </a:extLst>
           </p:cNvPr>
@@ -4110,10 +4110,10 @@
           <p:nvPr/>
         </p:nvPicPr>
         <p:blipFill>
-          <a:blip xmlns:r="http://schemas.openxmlformats.org/officeDocument/2006/relationships" xmlns:a="http://schemas.openxmlformats.org/drawingml/2006/main" r:embed="Rc8045b7d162c4f3e">
+          <a:blip xmlns:r="http://schemas.openxmlformats.org/officeDocument/2006/relationships" xmlns:a="http://schemas.openxmlformats.org/drawingml/2006/main" r:embed="R5bef7ed572c24424">
             <a:extLst>
               <a:ext uri="{96DAC541-7B7A-43D3-8B79-37D633B846F1}">
-                <asvg:svgBlip xmlns:asvg="http://schemas.microsoft.com/office/drawing/2016/SVG/main" r:embed="Ra249f3ba8656472e"/>
+                <asvg:svgBlip xmlns:asvg="http://schemas.microsoft.com/office/drawing/2016/SVG/main" r:embed="Rc69cbbcaf2a84398"/>
               </a:ext>
             </a:extLst>
           </a:blip>
@@ -4134,7 +4134,7 @@
           <p:cNvPr id="12" name="Story step 3">
             <a:extLst xmlns:a="http://schemas.openxmlformats.org/drawingml/2006/main">
               <a:ext uri="{FF2B5EF4-FFF2-40B4-BE49-F238E27FC236}">
-                <a16:creationId xmlns:a16="http://schemas.microsoft.com/office/drawing/2014/main" id="{38CD03CF-61AA-40CB-80E4-B79F132735CE}"/>
+                <a16:creationId xmlns:a16="http://schemas.microsoft.com/office/drawing/2014/main" id="{F7FA0BD4-A74B-4AEF-A4FC-4784A4825246}"/>
               </a:ext>
             </a:extLst>
           </p:cNvPr>
@@ -4191,7 +4191,7 @@
           <p:cNvPr id="13" name="Story step 3 detail">
             <a:extLst xmlns:a="http://schemas.openxmlformats.org/drawingml/2006/main">
               <a:ext uri="{FF2B5EF4-FFF2-40B4-BE49-F238E27FC236}">
-                <a16:creationId xmlns:a16="http://schemas.microsoft.com/office/drawing/2014/main" id="{E68BD7FB-878D-4702-9D67-B51035F92205}"/>
+                <a16:creationId xmlns:a16="http://schemas.microsoft.com/office/drawing/2014/main" id="{5A633429-4439-4A0F-891F-17169DB01DFA}"/>
               </a:ext>
             </a:extLst>
           </p:cNvPr>
@@ -4248,7 +4248,7 @@
           <p:cNvPr id="14" name="Shared record takeaway">
             <a:extLst xmlns:a="http://schemas.openxmlformats.org/drawingml/2006/main">
               <a:ext uri="{FF2B5EF4-FFF2-40B4-BE49-F238E27FC236}">
-                <a16:creationId xmlns:a16="http://schemas.microsoft.com/office/drawing/2014/main" id="{DC288057-1CB2-4E7B-ACAD-4CF2616BCF33}"/>
+                <a16:creationId xmlns:a16="http://schemas.microsoft.com/office/drawing/2014/main" id="{3DD853B7-226B-4910-B65F-F5DE8E1F4CF6}"/>
               </a:ext>
             </a:extLst>
           </p:cNvPr>
@@ -4278,7 +4278,7 @@
           <p:cNvPr id="15" name="Closing thought">
             <a:extLst xmlns:a="http://schemas.openxmlformats.org/drawingml/2006/main">
               <a:ext uri="{FF2B5EF4-FFF2-40B4-BE49-F238E27FC236}">
-                <a16:creationId xmlns:a16="http://schemas.microsoft.com/office/drawing/2014/main" id="{26EED240-FDA1-4994-8F28-D1601E06C0C4}"/>
+                <a16:creationId xmlns:a16="http://schemas.microsoft.com/office/drawing/2014/main" id="{32550E02-67E6-4839-AB5B-E984A392019D}"/>
               </a:ext>
             </a:extLst>
           </p:cNvPr>
@@ -4371,7 +4371,7 @@
         </p:xfrm>
         <a:graphic xmlns:a="http://schemas.openxmlformats.org/drawingml/2006/main">
           <a:graphicData uri="http://schemas.openxmlformats.org/drawingml/2006/chart">
-            <c:chart xmlns:r="http://schemas.openxmlformats.org/officeDocument/2006/relationships" xmlns:c="http://schemas.openxmlformats.org/drawingml/2006/chart" r:id="R6e197b6ddae44dc3"/>
+            <c:chart xmlns:r="http://schemas.openxmlformats.org/officeDocument/2006/relationships" xmlns:c="http://schemas.openxmlformats.org/drawingml/2006/chart" r:id="Rfc11ca11897241c7"/>
           </a:graphicData>
         </a:graphic>
       </p:graphicFrame>
@@ -4380,7 +4380,7 @@
           <p:cNvPr id="15" name="Slide title">
             <a:extLst xmlns:a="http://schemas.openxmlformats.org/drawingml/2006/main">
               <a:ext uri="{FF2B5EF4-FFF2-40B4-BE49-F238E27FC236}">
-                <a16:creationId xmlns:a16="http://schemas.microsoft.com/office/drawing/2014/main" id="{D6315517-29D1-449F-924B-291B1ED7C64C}"/>
+                <a16:creationId xmlns:a16="http://schemas.microsoft.com/office/drawing/2014/main" id="{E3D06F67-D825-4186-BC7C-2BFCBD0F4812}"/>
               </a:ext>
             </a:extLst>
           </p:cNvPr>
@@ -4437,7 +4437,7 @@
           <p:cNvPr id="16" name="Chennai evidence heading">
             <a:extLst xmlns:a="http://schemas.openxmlformats.org/drawingml/2006/main">
               <a:ext uri="{FF2B5EF4-FFF2-40B4-BE49-F238E27FC236}">
-                <a16:creationId xmlns:a16="http://schemas.microsoft.com/office/drawing/2014/main" id="{803D9749-6469-4724-9A00-C35DCA1584CB}"/>
+                <a16:creationId xmlns:a16="http://schemas.microsoft.com/office/drawing/2014/main" id="{954B7C64-F3B8-4A61-ACA0-F47FE969FE51}"/>
               </a:ext>
             </a:extLst>
           </p:cNvPr>
@@ -4467,7 +4467,7 @@
           <p:cNvPr id="17" name="Chennai evidence explanation">
             <a:extLst xmlns:a="http://schemas.openxmlformats.org/drawingml/2006/main">
               <a:ext uri="{FF2B5EF4-FFF2-40B4-BE49-F238E27FC236}">
-                <a16:creationId xmlns:a16="http://schemas.microsoft.com/office/drawing/2014/main" id="{1E9F4293-59F6-47F3-997D-18985BE3A0B7}"/>
+                <a16:creationId xmlns:a16="http://schemas.microsoft.com/office/drawing/2014/main" id="{9D1B600D-F16E-46A2-AB4A-1716E3952F7A}"/>
               </a:ext>
             </a:extLst>
           </p:cNvPr>
@@ -4501,10 +4501,10 @@
           <p:nvPr/>
         </p:nvPicPr>
         <p:blipFill>
-          <a:blip xmlns:r="http://schemas.openxmlformats.org/officeDocument/2006/relationships" xmlns:a="http://schemas.openxmlformats.org/drawingml/2006/main" r:embed="R45e284951ec24391">
+          <a:blip xmlns:r="http://schemas.openxmlformats.org/officeDocument/2006/relationships" xmlns:a="http://schemas.openxmlformats.org/drawingml/2006/main" r:embed="R76163d06dfd549ee">
             <a:extLst>
               <a:ext uri="{96DAC541-7B7A-43D3-8B79-37D633B846F1}">
-                <asvg:svgBlip xmlns:asvg="http://schemas.microsoft.com/office/drawing/2016/SVG/main" r:embed="R0b22cd7a48b44cd0"/>
+                <asvg:svgBlip xmlns:asvg="http://schemas.microsoft.com/office/drawing/2016/SVG/main" r:embed="R0fcca0f54d2e4af7"/>
               </a:ext>
             </a:extLst>
           </a:blip>
@@ -4525,7 +4525,7 @@
           <p:cNvPr id="19" name="Evidence 15.6 lakh">
             <a:extLst xmlns:a="http://schemas.openxmlformats.org/drawingml/2006/main">
               <a:ext uri="{FF2B5EF4-FFF2-40B4-BE49-F238E27FC236}">
-                <a16:creationId xmlns:a16="http://schemas.microsoft.com/office/drawing/2014/main" id="{58B347D8-C17D-48AC-B41D-779465952D07}"/>
+                <a16:creationId xmlns:a16="http://schemas.microsoft.com/office/drawing/2014/main" id="{92FB0AF2-2A13-4C06-B01E-2A2E268EC46A}"/>
               </a:ext>
             </a:extLst>
           </p:cNvPr>
@@ -4582,7 +4582,7 @@
           <p:cNvPr id="20" name="Evidence 15.6 lakh scope">
             <a:extLst xmlns:a="http://schemas.openxmlformats.org/drawingml/2006/main">
               <a:ext uri="{FF2B5EF4-FFF2-40B4-BE49-F238E27FC236}">
-                <a16:creationId xmlns:a16="http://schemas.microsoft.com/office/drawing/2014/main" id="{64878CD5-C9BF-4027-B240-322CAAFC42FD}"/>
+                <a16:creationId xmlns:a16="http://schemas.microsoft.com/office/drawing/2014/main" id="{36A7E813-782E-4A2B-A2D3-067FED81A88C}"/>
               </a:ext>
             </a:extLst>
           </p:cNvPr>
@@ -4639,7 +4639,7 @@
           <p:cNvPr id="21" name="Evidence 15.6 lakh source">
             <a:extLst xmlns:a="http://schemas.openxmlformats.org/drawingml/2006/main">
               <a:ext uri="{FF2B5EF4-FFF2-40B4-BE49-F238E27FC236}">
-                <a16:creationId xmlns:a16="http://schemas.microsoft.com/office/drawing/2014/main" id="{14C2C84D-F58A-4E48-86C3-C07836893DDF}"/>
+                <a16:creationId xmlns:a16="http://schemas.microsoft.com/office/drawing/2014/main" id="{A15AC7CC-415E-4CB7-A3E9-172C2C671700}"/>
               </a:ext>
             </a:extLst>
           </p:cNvPr>
@@ -4685,7 +4685,7 @@
                 <a:latin typeface="Arial"/>
                 <a:ea typeface="Arial"/>
                 <a:cs typeface="Arial"/>
-                <a:hlinkClick xmlns:r="http://schemas.openxmlformats.org/officeDocument/2006/relationships" r:id="R9d9270c57adc46ad"/>
+                <a:hlinkClick xmlns:r="http://schemas.openxmlformats.org/officeDocument/2006/relationships" r:id="Rab6fa42c7df148e1"/>
               </a:rPr>
               <a:t>IARC, GLOBOCAN 2024</a:t>
             </a:r>
@@ -4701,10 +4701,10 @@
           <p:nvPr/>
         </p:nvPicPr>
         <p:blipFill>
-          <a:blip xmlns:r="http://schemas.openxmlformats.org/officeDocument/2006/relationships" xmlns:a="http://schemas.openxmlformats.org/drawingml/2006/main" r:embed="Rea9f55adecf046c6">
+          <a:blip xmlns:r="http://schemas.openxmlformats.org/officeDocument/2006/relationships" xmlns:a="http://schemas.openxmlformats.org/drawingml/2006/main" r:embed="R350bef4171974d80">
             <a:extLst>
               <a:ext uri="{96DAC541-7B7A-43D3-8B79-37D633B846F1}">
-                <asvg:svgBlip xmlns:asvg="http://schemas.microsoft.com/office/drawing/2016/SVG/main" r:embed="Rf3c270ef32bc427c"/>
+                <asvg:svgBlip xmlns:asvg="http://schemas.microsoft.com/office/drawing/2016/SVG/main" r:embed="R101febf06eb64f36"/>
               </a:ext>
             </a:extLst>
           </a:blip>
@@ -4725,7 +4725,7 @@
           <p:cNvPr id="23" name="Evidence 98.39%">
             <a:extLst xmlns:a="http://schemas.openxmlformats.org/drawingml/2006/main">
               <a:ext uri="{FF2B5EF4-FFF2-40B4-BE49-F238E27FC236}">
-                <a16:creationId xmlns:a16="http://schemas.microsoft.com/office/drawing/2014/main" id="{EE20927A-6D4D-4FF3-8336-E334347C9A11}"/>
+                <a16:creationId xmlns:a16="http://schemas.microsoft.com/office/drawing/2014/main" id="{B2A01FD3-B982-4727-ADAD-BC1632A32DBC}"/>
               </a:ext>
             </a:extLst>
           </p:cNvPr>
@@ -4782,7 +4782,7 @@
           <p:cNvPr id="24" name="Evidence 98.39% scope">
             <a:extLst xmlns:a="http://schemas.openxmlformats.org/drawingml/2006/main">
               <a:ext uri="{FF2B5EF4-FFF2-40B4-BE49-F238E27FC236}">
-                <a16:creationId xmlns:a16="http://schemas.microsoft.com/office/drawing/2014/main" id="{1E9548D8-0E9D-489D-8BE1-B7A24A1DB433}"/>
+                <a16:creationId xmlns:a16="http://schemas.microsoft.com/office/drawing/2014/main" id="{5AFD1190-0DC7-4073-8939-4F79FCF94917}"/>
               </a:ext>
             </a:extLst>
           </p:cNvPr>
@@ -4839,7 +4839,7 @@
           <p:cNvPr id="25" name="Evidence 98.39% source">
             <a:extLst xmlns:a="http://schemas.openxmlformats.org/drawingml/2006/main">
               <a:ext uri="{FF2B5EF4-FFF2-40B4-BE49-F238E27FC236}">
-                <a16:creationId xmlns:a16="http://schemas.microsoft.com/office/drawing/2014/main" id="{0B582645-6F32-45F4-9126-14B24F7C9D5C}"/>
+                <a16:creationId xmlns:a16="http://schemas.microsoft.com/office/drawing/2014/main" id="{745457AD-3110-439C-AD2C-1A47EC756AB5}"/>
               </a:ext>
             </a:extLst>
           </p:cNvPr>
@@ -4885,7 +4885,7 @@
                 <a:latin typeface="Arial"/>
                 <a:ea typeface="Arial"/>
                 <a:cs typeface="Arial"/>
-                <a:hlinkClick xmlns:r="http://schemas.openxmlformats.org/officeDocument/2006/relationships" r:id="Re2daadf42a85445d"/>
+                <a:hlinkClick xmlns:r="http://schemas.openxmlformats.org/officeDocument/2006/relationships" r:id="R2410539b0c794485"/>
               </a:rPr>
               <a:t>Patil et al., 2024</a:t>
             </a:r>
@@ -4901,10 +4901,10 @@
           <p:nvPr/>
         </p:nvPicPr>
         <p:blipFill>
-          <a:blip xmlns:r="http://schemas.openxmlformats.org/officeDocument/2006/relationships" xmlns:a="http://schemas.openxmlformats.org/drawingml/2006/main" r:embed="Rd80bf458939e4f24">
+          <a:blip xmlns:r="http://schemas.openxmlformats.org/officeDocument/2006/relationships" xmlns:a="http://schemas.openxmlformats.org/drawingml/2006/main" r:embed="Ra4b40fb512b14e4a">
             <a:extLst>
               <a:ext uri="{96DAC541-7B7A-43D3-8B79-37D633B846F1}">
-                <asvg:svgBlip xmlns:asvg="http://schemas.microsoft.com/office/drawing/2016/SVG/main" r:embed="R11535fa347954080"/>
+                <asvg:svgBlip xmlns:asvg="http://schemas.microsoft.com/office/drawing/2016/SVG/main" r:embed="R13eac5924e2f4bf5"/>
               </a:ext>
             </a:extLst>
           </a:blip>
@@ -4925,7 +4925,7 @@
           <p:cNvPr id="27" name="Evidence 88%">
             <a:extLst xmlns:a="http://schemas.openxmlformats.org/drawingml/2006/main">
               <a:ext uri="{FF2B5EF4-FFF2-40B4-BE49-F238E27FC236}">
-                <a16:creationId xmlns:a16="http://schemas.microsoft.com/office/drawing/2014/main" id="{E0C447DF-D940-4C3C-97E7-D92537A94B52}"/>
+                <a16:creationId xmlns:a16="http://schemas.microsoft.com/office/drawing/2014/main" id="{005D0C34-66DC-4FB4-B950-B1FA880E14B1}"/>
               </a:ext>
             </a:extLst>
           </p:cNvPr>
@@ -4982,7 +4982,7 @@
           <p:cNvPr id="28" name="Evidence 88% scope">
             <a:extLst xmlns:a="http://schemas.openxmlformats.org/drawingml/2006/main">
               <a:ext uri="{FF2B5EF4-FFF2-40B4-BE49-F238E27FC236}">
-                <a16:creationId xmlns:a16="http://schemas.microsoft.com/office/drawing/2014/main" id="{FBA0C07F-72F3-45E9-A5F7-D7B77CDC7875}"/>
+                <a16:creationId xmlns:a16="http://schemas.microsoft.com/office/drawing/2014/main" id="{AC881B58-7150-434C-A1EB-5F306CA5171A}"/>
               </a:ext>
             </a:extLst>
           </p:cNvPr>
@@ -5039,7 +5039,7 @@
           <p:cNvPr id="29" name="Evidence 88% source">
             <a:extLst xmlns:a="http://schemas.openxmlformats.org/drawingml/2006/main">
               <a:ext uri="{FF2B5EF4-FFF2-40B4-BE49-F238E27FC236}">
-                <a16:creationId xmlns:a16="http://schemas.microsoft.com/office/drawing/2014/main" id="{6FDE1897-FC0D-4834-8D16-DCBD67ABCA08}"/>
+                <a16:creationId xmlns:a16="http://schemas.microsoft.com/office/drawing/2014/main" id="{6F113E7D-96CA-42B9-B856-88A7A587B162}"/>
               </a:ext>
             </a:extLst>
           </p:cNvPr>
@@ -5085,7 +5085,7 @@
                 <a:latin typeface="Arial"/>
                 <a:ea typeface="Arial"/>
                 <a:cs typeface="Arial"/>
-                <a:hlinkClick xmlns:r="http://schemas.openxmlformats.org/officeDocument/2006/relationships" r:id="Rbe58e6e529f445f7"/>
+                <a:hlinkClick xmlns:r="http://schemas.openxmlformats.org/officeDocument/2006/relationships" r:id="R9742cc5a0ff44c36"/>
               </a:rPr>
               <a:t>IndiaSpend reporting; seven cities</a:t>
             </a:r>
@@ -5101,10 +5101,10 @@
           <p:nvPr/>
         </p:nvPicPr>
         <p:blipFill>
-          <a:blip xmlns:r="http://schemas.openxmlformats.org/officeDocument/2006/relationships" xmlns:a="http://schemas.openxmlformats.org/drawingml/2006/main" r:embed="Rb42be125c9c14c86">
+          <a:blip xmlns:r="http://schemas.openxmlformats.org/officeDocument/2006/relationships" xmlns:a="http://schemas.openxmlformats.org/drawingml/2006/main" r:embed="Rdf58d6a0009a4a4f">
             <a:extLst>
               <a:ext uri="{96DAC541-7B7A-43D3-8B79-37D633B846F1}">
-                <asvg:svgBlip xmlns:asvg="http://schemas.microsoft.com/office/drawing/2016/SVG/main" r:embed="R941dd79931b6442a"/>
+                <asvg:svgBlip xmlns:asvg="http://schemas.microsoft.com/office/drawing/2016/SVG/main" r:embed="R8045cbd10a234fb2"/>
               </a:ext>
             </a:extLst>
           </a:blip>
@@ -5125,7 +5125,7 @@
           <p:cNvPr id="31" name="Evidence 11.5%">
             <a:extLst xmlns:a="http://schemas.openxmlformats.org/drawingml/2006/main">
               <a:ext uri="{FF2B5EF4-FFF2-40B4-BE49-F238E27FC236}">
-                <a16:creationId xmlns:a16="http://schemas.microsoft.com/office/drawing/2014/main" id="{201B8E2E-10E9-4412-8470-3E9DE20A5A22}"/>
+                <a16:creationId xmlns:a16="http://schemas.microsoft.com/office/drawing/2014/main" id="{8ED6D1AF-4FD4-4FF1-B0B2-76C8091AE6E8}"/>
               </a:ext>
             </a:extLst>
           </p:cNvPr>
@@ -5182,7 +5182,7 @@
           <p:cNvPr id="32" name="Evidence 11.5% scope">
             <a:extLst xmlns:a="http://schemas.openxmlformats.org/drawingml/2006/main">
               <a:ext uri="{FF2B5EF4-FFF2-40B4-BE49-F238E27FC236}">
-                <a16:creationId xmlns:a16="http://schemas.microsoft.com/office/drawing/2014/main" id="{370DBF83-0EA4-405F-BE89-F08181E6DBF4}"/>
+                <a16:creationId xmlns:a16="http://schemas.microsoft.com/office/drawing/2014/main" id="{89BB2C15-BF69-4FB7-B448-2230DED274D9}"/>
               </a:ext>
             </a:extLst>
           </p:cNvPr>
@@ -5239,7 +5239,7 @@
           <p:cNvPr id="33" name="Evidence 11.5% source">
             <a:extLst xmlns:a="http://schemas.openxmlformats.org/drawingml/2006/main">
               <a:ext uri="{FF2B5EF4-FFF2-40B4-BE49-F238E27FC236}">
-                <a16:creationId xmlns:a16="http://schemas.microsoft.com/office/drawing/2014/main" id="{4221D382-B336-42F2-A88D-F14164135E61}"/>
+                <a16:creationId xmlns:a16="http://schemas.microsoft.com/office/drawing/2014/main" id="{0F1ED713-1D93-429E-AA85-CE6F2EF25194}"/>
               </a:ext>
             </a:extLst>
           </p:cNvPr>
@@ -5285,7 +5285,7 @@
                 <a:latin typeface="Arial"/>
                 <a:ea typeface="Arial"/>
                 <a:cs typeface="Arial"/>
-                <a:hlinkClick xmlns:r="http://schemas.openxmlformats.org/officeDocument/2006/relationships" r:id="Rf057f6d9d698446c"/>
+                <a:hlinkClick xmlns:r="http://schemas.openxmlformats.org/officeDocument/2006/relationships" r:id="R4b894f2e3f5c4b27"/>
               </a:rPr>
               <a:t>Jacob et al., CMC Vellore, 2026</a:t>
             </a:r>
@@ -5301,10 +5301,10 @@
           <p:nvPr/>
         </p:nvPicPr>
         <p:blipFill>
-          <a:blip xmlns:r="http://schemas.openxmlformats.org/officeDocument/2006/relationships" xmlns:a="http://schemas.openxmlformats.org/drawingml/2006/main" r:embed="Re75c410e8930487e">
+          <a:blip xmlns:r="http://schemas.openxmlformats.org/officeDocument/2006/relationships" xmlns:a="http://schemas.openxmlformats.org/drawingml/2006/main" r:embed="R12881ede430f4726">
             <a:extLst>
               <a:ext uri="{96DAC541-7B7A-43D3-8B79-37D633B846F1}">
-                <asvg:svgBlip xmlns:asvg="http://schemas.microsoft.com/office/drawing/2016/SVG/main" r:embed="R1ff1d7196100460b"/>
+                <asvg:svgBlip xmlns:asvg="http://schemas.microsoft.com/office/drawing/2016/SVG/main" r:embed="R36f984ec41054231"/>
               </a:ext>
             </a:extLst>
           </a:blip>
@@ -5325,7 +5325,7 @@
           <p:cNvPr id="35" name="QI measure">
             <a:extLst xmlns:a="http://schemas.openxmlformats.org/drawingml/2006/main">
               <a:ext uri="{FF2B5EF4-FFF2-40B4-BE49-F238E27FC236}">
-                <a16:creationId xmlns:a16="http://schemas.microsoft.com/office/drawing/2014/main" id="{E435DA6C-E0C0-4C82-BE2F-7C6FA039AB03}"/>
+                <a16:creationId xmlns:a16="http://schemas.microsoft.com/office/drawing/2014/main" id="{7AD8B5F7-B2A6-4576-866E-1F8DECA16D30}"/>
               </a:ext>
             </a:extLst>
           </p:cNvPr>
@@ -5382,7 +5382,7 @@
           <p:cNvPr id="36" name="QI finding">
             <a:extLst xmlns:a="http://schemas.openxmlformats.org/drawingml/2006/main">
               <a:ext uri="{FF2B5EF4-FFF2-40B4-BE49-F238E27FC236}">
-                <a16:creationId xmlns:a16="http://schemas.microsoft.com/office/drawing/2014/main" id="{B207F852-586B-4074-887C-98E29FE815C5}"/>
+                <a16:creationId xmlns:a16="http://schemas.microsoft.com/office/drawing/2014/main" id="{DCE568A7-E3A8-4031-A14A-287D4A82241A}"/>
               </a:ext>
             </a:extLst>
           </p:cNvPr>
@@ -5439,7 +5439,7 @@
           <p:cNvPr id="37" name="QI scope">
             <a:extLst xmlns:a="http://schemas.openxmlformats.org/drawingml/2006/main">
               <a:ext uri="{FF2B5EF4-FFF2-40B4-BE49-F238E27FC236}">
-                <a16:creationId xmlns:a16="http://schemas.microsoft.com/office/drawing/2014/main" id="{DF0C099A-03C7-498E-9EB3-A91B8BC48944}"/>
+                <a16:creationId xmlns:a16="http://schemas.microsoft.com/office/drawing/2014/main" id="{7795C86D-8501-4262-8E75-39804073BACC}"/>
               </a:ext>
             </a:extLst>
           </p:cNvPr>
@@ -5496,7 +5496,7 @@
           <p:cNvPr id="38" name="QI source">
             <a:extLst xmlns:a="http://schemas.openxmlformats.org/drawingml/2006/main">
               <a:ext uri="{FF2B5EF4-FFF2-40B4-BE49-F238E27FC236}">
-                <a16:creationId xmlns:a16="http://schemas.microsoft.com/office/drawing/2014/main" id="{E92462C0-C6F6-4548-8DD8-3151E5B37025}"/>
+                <a16:creationId xmlns:a16="http://schemas.microsoft.com/office/drawing/2014/main" id="{F3710DA7-F888-4945-80C1-1481B5C9B691}"/>
               </a:ext>
             </a:extLst>
           </p:cNvPr>
@@ -5542,7 +5542,7 @@
                 <a:latin typeface="Arial"/>
                 <a:ea typeface="Arial"/>
                 <a:cs typeface="Arial"/>
-                <a:hlinkClick xmlns:r="http://schemas.openxmlformats.org/officeDocument/2006/relationships" r:id="Rfaae270b45c54b70"/>
+                <a:hlinkClick xmlns:r="http://schemas.openxmlformats.org/officeDocument/2006/relationships" r:id="Rdaf3af87ee454c98"/>
               </a:rPr>
               <a:t>Thangasamy et al., 2025</a:t>
             </a:r>
@@ -5554,7 +5554,7 @@
           <p:cNvPr id="39" name="Evidence boundary">
             <a:extLst xmlns:a="http://schemas.openxmlformats.org/drawingml/2006/main">
               <a:ext uri="{FF2B5EF4-FFF2-40B4-BE49-F238E27FC236}">
-                <a16:creationId xmlns:a16="http://schemas.microsoft.com/office/drawing/2014/main" id="{AA6519F0-4912-4824-A284-E3C9EF661978}"/>
+                <a16:creationId xmlns:a16="http://schemas.microsoft.com/office/drawing/2014/main" id="{A4754E71-FCB7-481D-A0DD-89A8894892A6}"/>
               </a:ext>
             </a:extLst>
           </p:cNvPr>
@@ -5640,7 +5640,7 @@
           <p:cNvPr id="14" name="Slide title">
             <a:extLst xmlns:a="http://schemas.openxmlformats.org/drawingml/2006/main">
               <a:ext uri="{FF2B5EF4-FFF2-40B4-BE49-F238E27FC236}">
-                <a16:creationId xmlns:a16="http://schemas.microsoft.com/office/drawing/2014/main" id="{577153C3-8370-4CB7-9D0A-449C92784D15}"/>
+                <a16:creationId xmlns:a16="http://schemas.microsoft.com/office/drawing/2014/main" id="{7A5F87DC-C2FB-4970-BA5E-C7E6470A1B65}"/>
               </a:ext>
             </a:extLst>
           </p:cNvPr>
@@ -5697,7 +5697,7 @@
           <p:cNvPr id="2" name="Human review">
             <a:extLst xmlns:a="http://schemas.openxmlformats.org/drawingml/2006/main">
               <a:ext uri="{FF2B5EF4-FFF2-40B4-BE49-F238E27FC236}">
-                <a16:creationId xmlns:a16="http://schemas.microsoft.com/office/drawing/2014/main" id="{1A90B96C-0D9D-43F1-85F6-44EA2B80590A}"/>
+                <a16:creationId xmlns:a16="http://schemas.microsoft.com/office/drawing/2014/main" id="{5ABDF0AC-466E-43A1-8AC7-A434B7C605BE}"/>
               </a:ext>
             </a:extLst>
           </p:cNvPr>
@@ -5758,7 +5758,7 @@
           <p:nvPr/>
         </p:nvPicPr>
         <p:blipFill>
-          <a:blip xmlns:r="http://schemas.openxmlformats.org/officeDocument/2006/relationships" xmlns:a="http://schemas.openxmlformats.org/drawingml/2006/main" r:embed="R6f33b645acd242a5"/>
+          <a:blip xmlns:r="http://schemas.openxmlformats.org/officeDocument/2006/relationships" xmlns:a="http://schemas.openxmlformats.org/drawingml/2006/main" r:embed="R4d9c9e85d50f48c7"/>
           <a:stretch xmlns:a="http://schemas.openxmlformats.org/drawingml/2006/main"/>
         </p:blipFill>
         <p:spPr>
@@ -5776,7 +5776,7 @@
           <p:cNvPr id="4" name="Source traceability">
             <a:extLst xmlns:a="http://schemas.openxmlformats.org/drawingml/2006/main">
               <a:ext uri="{FF2B5EF4-FFF2-40B4-BE49-F238E27FC236}">
-                <a16:creationId xmlns:a16="http://schemas.microsoft.com/office/drawing/2014/main" id="{0A907611-FFB4-4C8E-8EEE-135909407028}"/>
+                <a16:creationId xmlns:a16="http://schemas.microsoft.com/office/drawing/2014/main" id="{38C27635-6E5F-4A60-8B14-08D13811EAAD}"/>
               </a:ext>
             </a:extLst>
           </p:cNvPr>
@@ -5833,7 +5833,7 @@
           <p:cNvPr id="5" name="Proposed voice provider">
             <a:extLst xmlns:a="http://schemas.openxmlformats.org/drawingml/2006/main">
               <a:ext uri="{FF2B5EF4-FFF2-40B4-BE49-F238E27FC236}">
-                <a16:creationId xmlns:a16="http://schemas.microsoft.com/office/drawing/2014/main" id="{74F304B2-D521-409C-9532-8F43738DAFD8}"/>
+                <a16:creationId xmlns:a16="http://schemas.microsoft.com/office/drawing/2014/main" id="{E54ADEE8-DFE6-44FC-A19E-0BD4BA166643}"/>
               </a:ext>
             </a:extLst>
           </p:cNvPr>
@@ -5879,7 +5879,7 @@
                 <a:latin typeface="Arial"/>
                 <a:ea typeface="Arial"/>
                 <a:cs typeface="Arial"/>
-                <a:hlinkClick xmlns:r="http://schemas.openxmlformats.org/officeDocument/2006/relationships" r:id="Rcfcd6a102ba14ea8"/>
+                <a:hlinkClick xmlns:r="http://schemas.openxmlformats.org/officeDocument/2006/relationships" r:id="R4b5b00a57e484bcd"/>
               </a:rPr>
               <a:t>Planned with Sarvam AI: Indian-language speech, translation and read-aloud.</a:t>
             </a:r>
@@ -5891,7 +5891,7 @@
           <p:cNvPr id="6" name="AI step 1">
             <a:extLst xmlns:a="http://schemas.openxmlformats.org/drawingml/2006/main">
               <a:ext uri="{FF2B5EF4-FFF2-40B4-BE49-F238E27FC236}">
-                <a16:creationId xmlns:a16="http://schemas.microsoft.com/office/drawing/2014/main" id="{DCEB05D0-729D-4A0E-A91A-75059EA83975}"/>
+                <a16:creationId xmlns:a16="http://schemas.microsoft.com/office/drawing/2014/main" id="{2F62543C-E6A3-45C8-9D7C-00BEDEE32EBB}"/>
               </a:ext>
             </a:extLst>
           </p:cNvPr>
@@ -5948,7 +5948,7 @@
           <p:cNvPr id="7" name="AI step 1 detail">
             <a:extLst xmlns:a="http://schemas.openxmlformats.org/drawingml/2006/main">
               <a:ext uri="{FF2B5EF4-FFF2-40B4-BE49-F238E27FC236}">
-                <a16:creationId xmlns:a16="http://schemas.microsoft.com/office/drawing/2014/main" id="{FF3CB9E8-1B42-466F-9A68-FA0020D49935}"/>
+                <a16:creationId xmlns:a16="http://schemas.microsoft.com/office/drawing/2014/main" id="{A371CA76-71CA-48BE-A9A6-D0CBF700EB09}"/>
               </a:ext>
             </a:extLst>
           </p:cNvPr>
@@ -6005,7 +6005,7 @@
           <p:cNvPr id="8" name="AI step 2">
             <a:extLst xmlns:a="http://schemas.openxmlformats.org/drawingml/2006/main">
               <a:ext uri="{FF2B5EF4-FFF2-40B4-BE49-F238E27FC236}">
-                <a16:creationId xmlns:a16="http://schemas.microsoft.com/office/drawing/2014/main" id="{26E728B4-8D98-4DF7-8815-F9C9A9E652F1}"/>
+                <a16:creationId xmlns:a16="http://schemas.microsoft.com/office/drawing/2014/main" id="{7041D8B0-48C2-40E5-A06D-FF74FC6E974F}"/>
               </a:ext>
             </a:extLst>
           </p:cNvPr>
@@ -6062,7 +6062,7 @@
           <p:cNvPr id="9" name="AI step 2 detail">
             <a:extLst xmlns:a="http://schemas.openxmlformats.org/drawingml/2006/main">
               <a:ext uri="{FF2B5EF4-FFF2-40B4-BE49-F238E27FC236}">
-                <a16:creationId xmlns:a16="http://schemas.microsoft.com/office/drawing/2014/main" id="{284969CB-3EC2-43D8-8A1D-73D7B62AA4A3}"/>
+                <a16:creationId xmlns:a16="http://schemas.microsoft.com/office/drawing/2014/main" id="{053C8040-8DE7-4235-BA54-B05347374194}"/>
               </a:ext>
             </a:extLst>
           </p:cNvPr>
@@ -6119,7 +6119,7 @@
           <p:cNvPr id="10" name="AI step 3">
             <a:extLst xmlns:a="http://schemas.openxmlformats.org/drawingml/2006/main">
               <a:ext uri="{FF2B5EF4-FFF2-40B4-BE49-F238E27FC236}">
-                <a16:creationId xmlns:a16="http://schemas.microsoft.com/office/drawing/2014/main" id="{1B4FDA8F-34F6-4651-954C-768327FA4353}"/>
+                <a16:creationId xmlns:a16="http://schemas.microsoft.com/office/drawing/2014/main" id="{767D801E-163D-4127-AEDD-E1B6AAEB669D}"/>
               </a:ext>
             </a:extLst>
           </p:cNvPr>
@@ -6176,7 +6176,7 @@
           <p:cNvPr id="11" name="AI step 3 detail">
             <a:extLst xmlns:a="http://schemas.openxmlformats.org/drawingml/2006/main">
               <a:ext uri="{FF2B5EF4-FFF2-40B4-BE49-F238E27FC236}">
-                <a16:creationId xmlns:a16="http://schemas.microsoft.com/office/drawing/2014/main" id="{6CC81D7C-C411-466C-B65A-1574F013BBF6}"/>
+                <a16:creationId xmlns:a16="http://schemas.microsoft.com/office/drawing/2014/main" id="{1AC5BC56-6C7F-4158-9E8A-B7A55BFA3D58}"/>
               </a:ext>
             </a:extLst>
           </p:cNvPr>
@@ -6233,7 +6233,7 @@
           <p:cNvPr id="12" name="AI step 4">
             <a:extLst xmlns:a="http://schemas.openxmlformats.org/drawingml/2006/main">
               <a:ext uri="{FF2B5EF4-FFF2-40B4-BE49-F238E27FC236}">
-                <a16:creationId xmlns:a16="http://schemas.microsoft.com/office/drawing/2014/main" id="{16D5C437-5367-4F95-B572-99E304C2D8BB}"/>
+                <a16:creationId xmlns:a16="http://schemas.microsoft.com/office/drawing/2014/main" id="{1A748BDD-AA86-4B82-9E6D-F98040983E2C}"/>
               </a:ext>
             </a:extLst>
           </p:cNvPr>
@@ -6290,7 +6290,7 @@
           <p:cNvPr id="13" name="AI step 4 detail">
             <a:extLst xmlns:a="http://schemas.openxmlformats.org/drawingml/2006/main">
               <a:ext uri="{FF2B5EF4-FFF2-40B4-BE49-F238E27FC236}">
-                <a16:creationId xmlns:a16="http://schemas.microsoft.com/office/drawing/2014/main" id="{DD688A44-2C33-4DC9-A2DE-1DE2DBE8B512}"/>
+                <a16:creationId xmlns:a16="http://schemas.microsoft.com/office/drawing/2014/main" id="{80762F6B-BD17-4C9A-B8F9-30730B31BEC7}"/>
               </a:ext>
             </a:extLst>
           </p:cNvPr>
@@ -6376,7 +6376,7 @@
           <p:cNvPr id="11" name="Slide title">
             <a:extLst xmlns:a="http://schemas.openxmlformats.org/drawingml/2006/main">
               <a:ext uri="{FF2B5EF4-FFF2-40B4-BE49-F238E27FC236}">
-                <a16:creationId xmlns:a16="http://schemas.microsoft.com/office/drawing/2014/main" id="{D7440968-45D0-4F41-BB3C-05A3D1B0592F}"/>
+                <a16:creationId xmlns:a16="http://schemas.microsoft.com/office/drawing/2014/main" id="{30799EEE-135F-4275-BE8D-95F9C801EB56}"/>
               </a:ext>
             </a:extLst>
           </p:cNvPr>
@@ -6433,7 +6433,7 @@
           <p:cNvPr id="2" name="Records assistant purpose">
             <a:extLst xmlns:a="http://schemas.openxmlformats.org/drawingml/2006/main">
               <a:ext uri="{FF2B5EF4-FFF2-40B4-BE49-F238E27FC236}">
-                <a16:creationId xmlns:a16="http://schemas.microsoft.com/office/drawing/2014/main" id="{6FA5CB08-1A0A-4866-966A-A83D024FAD6A}"/>
+                <a16:creationId xmlns:a16="http://schemas.microsoft.com/office/drawing/2014/main" id="{F147C6F5-2DB9-4B3F-9A42-CA252B2DD0BA}"/>
               </a:ext>
             </a:extLst>
           </p:cNvPr>
@@ -6494,7 +6494,7 @@
           <p:nvPr/>
         </p:nvPicPr>
         <p:blipFill>
-          <a:blip xmlns:r="http://schemas.openxmlformats.org/officeDocument/2006/relationships" xmlns:a="http://schemas.openxmlformats.org/drawingml/2006/main" r:embed="Rf9322f8125d945dc"/>
+          <a:blip xmlns:r="http://schemas.openxmlformats.org/officeDocument/2006/relationships" xmlns:a="http://schemas.openxmlformats.org/drawingml/2006/main" r:embed="R4527554a8e3843ca"/>
           <a:stretch xmlns:a="http://schemas.openxmlformats.org/drawingml/2006/main"/>
         </p:blipFill>
         <p:spPr>
@@ -6512,7 +6512,7 @@
           <p:cNvPr id="4" name="Records assistant 1">
             <a:extLst xmlns:a="http://schemas.openxmlformats.org/drawingml/2006/main">
               <a:ext uri="{FF2B5EF4-FFF2-40B4-BE49-F238E27FC236}">
-                <a16:creationId xmlns:a16="http://schemas.microsoft.com/office/drawing/2014/main" id="{2C90545F-A970-4BB3-8091-A5EDB403B542}"/>
+                <a16:creationId xmlns:a16="http://schemas.microsoft.com/office/drawing/2014/main" id="{BE34FEFF-FC88-45CD-B9AE-980CA7A6068B}"/>
               </a:ext>
             </a:extLst>
           </p:cNvPr>
@@ -6569,7 +6569,7 @@
           <p:cNvPr id="5" name="Records assistant 1 detail">
             <a:extLst xmlns:a="http://schemas.openxmlformats.org/drawingml/2006/main">
               <a:ext uri="{FF2B5EF4-FFF2-40B4-BE49-F238E27FC236}">
-                <a16:creationId xmlns:a16="http://schemas.microsoft.com/office/drawing/2014/main" id="{F441F9C6-CF95-4301-91DC-E96ECA978000}"/>
+                <a16:creationId xmlns:a16="http://schemas.microsoft.com/office/drawing/2014/main" id="{A2004826-E29C-4DF4-AB7E-6FEA67241407}"/>
               </a:ext>
             </a:extLst>
           </p:cNvPr>
@@ -6626,7 +6626,7 @@
           <p:cNvPr id="6" name="Records assistant 2">
             <a:extLst xmlns:a="http://schemas.openxmlformats.org/drawingml/2006/main">
               <a:ext uri="{FF2B5EF4-FFF2-40B4-BE49-F238E27FC236}">
-                <a16:creationId xmlns:a16="http://schemas.microsoft.com/office/drawing/2014/main" id="{E740F482-06A8-4588-87EE-5775015A9F1A}"/>
+                <a16:creationId xmlns:a16="http://schemas.microsoft.com/office/drawing/2014/main" id="{842C0ADA-8DAF-4992-A00B-F5B7D7B3C5B6}"/>
               </a:ext>
             </a:extLst>
           </p:cNvPr>
@@ -6683,7 +6683,7 @@
           <p:cNvPr id="7" name="Records assistant 2 detail">
             <a:extLst xmlns:a="http://schemas.openxmlformats.org/drawingml/2006/main">
               <a:ext uri="{FF2B5EF4-FFF2-40B4-BE49-F238E27FC236}">
-                <a16:creationId xmlns:a16="http://schemas.microsoft.com/office/drawing/2014/main" id="{2BCFA858-F820-4957-928B-BD97C2E1E40D}"/>
+                <a16:creationId xmlns:a16="http://schemas.microsoft.com/office/drawing/2014/main" id="{E309FD23-9014-438A-A66F-D753CCE4E88D}"/>
               </a:ext>
             </a:extLst>
           </p:cNvPr>
@@ -6740,7 +6740,7 @@
           <p:cNvPr id="8" name="Records assistant 3">
             <a:extLst xmlns:a="http://schemas.openxmlformats.org/drawingml/2006/main">
               <a:ext uri="{FF2B5EF4-FFF2-40B4-BE49-F238E27FC236}">
-                <a16:creationId xmlns:a16="http://schemas.microsoft.com/office/drawing/2014/main" id="{91BE0889-B5D1-4F71-B74D-B6196D4572B8}"/>
+                <a16:creationId xmlns:a16="http://schemas.microsoft.com/office/drawing/2014/main" id="{237661BD-BC41-41F1-A849-6242F36AEEF8}"/>
               </a:ext>
             </a:extLst>
           </p:cNvPr>
@@ -6797,7 +6797,7 @@
           <p:cNvPr id="9" name="Records assistant 3 detail">
             <a:extLst xmlns:a="http://schemas.openxmlformats.org/drawingml/2006/main">
               <a:ext uri="{FF2B5EF4-FFF2-40B4-BE49-F238E27FC236}">
-                <a16:creationId xmlns:a16="http://schemas.microsoft.com/office/drawing/2014/main" id="{893D62CA-2507-46D4-9C7A-9053BAFC71D1}"/>
+                <a16:creationId xmlns:a16="http://schemas.microsoft.com/office/drawing/2014/main" id="{5B4A581B-15DB-4BC0-ACE1-F8F5F5D5CD4A}"/>
               </a:ext>
             </a:extLst>
           </p:cNvPr>
@@ -6854,7 +6854,7 @@
           <p:cNvPr id="10" name="Clinical scope">
             <a:extLst xmlns:a="http://schemas.openxmlformats.org/drawingml/2006/main">
               <a:ext uri="{FF2B5EF4-FFF2-40B4-BE49-F238E27FC236}">
-                <a16:creationId xmlns:a16="http://schemas.microsoft.com/office/drawing/2014/main" id="{521ED95C-5F2C-4429-9D9E-11AD4A979E40}"/>
+                <a16:creationId xmlns:a16="http://schemas.microsoft.com/office/drawing/2014/main" id="{F6934068-CF3D-4B01-9DF3-F1936CFB70C2}"/>
               </a:ext>
             </a:extLst>
           </p:cNvPr>
@@ -6940,7 +6940,7 @@
           <p:cNvPr id="40" name="Slide title">
             <a:extLst xmlns:a="http://schemas.openxmlformats.org/drawingml/2006/main">
               <a:ext uri="{FF2B5EF4-FFF2-40B4-BE49-F238E27FC236}">
-                <a16:creationId xmlns:a16="http://schemas.microsoft.com/office/drawing/2014/main" id="{87E1DA51-AEF2-4FD0-AACB-B54D35EDE066}"/>
+                <a16:creationId xmlns:a16="http://schemas.microsoft.com/office/drawing/2014/main" id="{B0F36175-AE72-47B1-AA63-7078DD5B7602}"/>
               </a:ext>
             </a:extLst>
           </p:cNvPr>
@@ -6997,7 +6997,7 @@
           <p:cNvPr id="2" name="Three sign-ins">
             <a:extLst xmlns:a="http://schemas.openxmlformats.org/drawingml/2006/main">
               <a:ext uri="{FF2B5EF4-FFF2-40B4-BE49-F238E27FC236}">
-                <a16:creationId xmlns:a16="http://schemas.microsoft.com/office/drawing/2014/main" id="{C4920B5E-0E82-4DB2-8ED3-7DE69A11DB6F}"/>
+                <a16:creationId xmlns:a16="http://schemas.microsoft.com/office/drawing/2014/main" id="{EAB8FA50-10C2-45D3-8846-C6255BB61294}"/>
               </a:ext>
             </a:extLst>
           </p:cNvPr>
@@ -7054,7 +7054,7 @@
           <p:cNvPr id="3" name="">
             <a:extLst xmlns:a="http://schemas.openxmlformats.org/drawingml/2006/main">
               <a:ext uri="{FF2B5EF4-FFF2-40B4-BE49-F238E27FC236}">
-                <a16:creationId xmlns:a16="http://schemas.microsoft.com/office/drawing/2014/main" id="{A6842D69-1617-497D-8417-884D7D4E973B}"/>
+                <a16:creationId xmlns:a16="http://schemas.microsoft.com/office/drawing/2014/main" id="{896DEB04-9B9C-4511-9CC5-C7D283032D1A}"/>
               </a:ext>
             </a:extLst>
           </p:cNvPr>
@@ -7086,7 +7086,7 @@
           <p:cNvPr id="4" name="Patient sign-in">
             <a:extLst xmlns:a="http://schemas.openxmlformats.org/drawingml/2006/main">
               <a:ext uri="{FF2B5EF4-FFF2-40B4-BE49-F238E27FC236}">
-                <a16:creationId xmlns:a16="http://schemas.microsoft.com/office/drawing/2014/main" id="{6F3B15E5-737D-4D72-BC35-C01E8CC85425}"/>
+                <a16:creationId xmlns:a16="http://schemas.microsoft.com/office/drawing/2014/main" id="{E56BBB50-0315-4410-B31B-FE6417F80982}"/>
               </a:ext>
             </a:extLst>
           </p:cNvPr>
@@ -7143,7 +7143,7 @@
           <p:cNvPr id="5" name="">
             <a:extLst xmlns:a="http://schemas.openxmlformats.org/drawingml/2006/main">
               <a:ext uri="{FF2B5EF4-FFF2-40B4-BE49-F238E27FC236}">
-                <a16:creationId xmlns:a16="http://schemas.microsoft.com/office/drawing/2014/main" id="{525B9DF6-68ED-4D23-82AC-969991827266}"/>
+                <a16:creationId xmlns:a16="http://schemas.microsoft.com/office/drawing/2014/main" id="{6E3F5DFE-E700-413B-8526-3A25F37D3262}"/>
               </a:ext>
             </a:extLst>
           </p:cNvPr>
@@ -7175,7 +7175,7 @@
           <p:cNvPr id="6" name="Family sign-in">
             <a:extLst xmlns:a="http://schemas.openxmlformats.org/drawingml/2006/main">
               <a:ext uri="{FF2B5EF4-FFF2-40B4-BE49-F238E27FC236}">
-                <a16:creationId xmlns:a16="http://schemas.microsoft.com/office/drawing/2014/main" id="{DC472386-5176-48A5-B1C8-4F23B4A6E92D}"/>
+                <a16:creationId xmlns:a16="http://schemas.microsoft.com/office/drawing/2014/main" id="{5D8A22C6-36B0-4404-9081-C646D2C5AD1C}"/>
               </a:ext>
             </a:extLst>
           </p:cNvPr>
@@ -7232,7 +7232,7 @@
           <p:cNvPr id="7" name="">
             <a:extLst xmlns:a="http://schemas.openxmlformats.org/drawingml/2006/main">
               <a:ext uri="{FF2B5EF4-FFF2-40B4-BE49-F238E27FC236}">
-                <a16:creationId xmlns:a16="http://schemas.microsoft.com/office/drawing/2014/main" id="{5FA97D05-D2BD-48B2-9D7B-1FDCDF6B1409}"/>
+                <a16:creationId xmlns:a16="http://schemas.microsoft.com/office/drawing/2014/main" id="{3F031A52-0D4C-4FFC-91CC-D048F2EC2C67}"/>
               </a:ext>
             </a:extLst>
           </p:cNvPr>
@@ -7264,7 +7264,7 @@
           <p:cNvPr id="8" name="Doctor sign-in">
             <a:extLst xmlns:a="http://schemas.openxmlformats.org/drawingml/2006/main">
               <a:ext uri="{FF2B5EF4-FFF2-40B4-BE49-F238E27FC236}">
-                <a16:creationId xmlns:a16="http://schemas.microsoft.com/office/drawing/2014/main" id="{5961DCAC-5D81-47EC-A638-4A9B360F583D}"/>
+                <a16:creationId xmlns:a16="http://schemas.microsoft.com/office/drawing/2014/main" id="{A03967EE-1BAA-4D13-96D4-AC88597133A4}"/>
               </a:ext>
             </a:extLst>
           </p:cNvPr>
@@ -7321,7 +7321,7 @@
           <p:cNvPr id="9" name="Before the visit">
             <a:extLst xmlns:a="http://schemas.openxmlformats.org/drawingml/2006/main">
               <a:ext uri="{FF2B5EF4-FFF2-40B4-BE49-F238E27FC236}">
-                <a16:creationId xmlns:a16="http://schemas.microsoft.com/office/drawing/2014/main" id="{04C4A337-22D1-4F40-8542-1A3DE9185822}"/>
+                <a16:creationId xmlns:a16="http://schemas.microsoft.com/office/drawing/2014/main" id="{AC48D1C9-CBE2-4AA8-8BC7-75F5FFFCEE60}"/>
               </a:ext>
             </a:extLst>
           </p:cNvPr>
@@ -7351,7 +7351,7 @@
           <p:cNvPr id="10" name="Between visits">
             <a:extLst xmlns:a="http://schemas.openxmlformats.org/drawingml/2006/main">
               <a:ext uri="{FF2B5EF4-FFF2-40B4-BE49-F238E27FC236}">
-                <a16:creationId xmlns:a16="http://schemas.microsoft.com/office/drawing/2014/main" id="{5C37B9BC-94D9-4963-A796-C5E189FC9C8A}"/>
+                <a16:creationId xmlns:a16="http://schemas.microsoft.com/office/drawing/2014/main" id="{911A306D-AC5A-46B9-A6B3-2AA6FDAAD1C0}"/>
               </a:ext>
             </a:extLst>
           </p:cNvPr>
@@ -7385,10 +7385,10 @@
           <p:nvPr/>
         </p:nvPicPr>
         <p:blipFill>
-          <a:blip xmlns:r="http://schemas.openxmlformats.org/officeDocument/2006/relationships" xmlns:a="http://schemas.openxmlformats.org/drawingml/2006/main" r:embed="R4ca9e91ced4f48b8">
+          <a:blip xmlns:r="http://schemas.openxmlformats.org/officeDocument/2006/relationships" xmlns:a="http://schemas.openxmlformats.org/drawingml/2006/main" r:embed="R5366dd923ca74b10">
             <a:extLst>
               <a:ext uri="{96DAC541-7B7A-43D3-8B79-37D633B846F1}">
-                <asvg:svgBlip xmlns:asvg="http://schemas.microsoft.com/office/drawing/2016/SVG/main" r:embed="Ra703ca7f41d94e06"/>
+                <asvg:svgBlip xmlns:asvg="http://schemas.microsoft.com/office/drawing/2016/SVG/main" r:embed="R20fd0ab06e6a423f"/>
               </a:ext>
             </a:extLst>
           </a:blip>
@@ -7409,7 +7409,7 @@
           <p:cNvPr id="12" name="Family journey number 1">
             <a:extLst xmlns:a="http://schemas.openxmlformats.org/drawingml/2006/main">
               <a:ext uri="{FF2B5EF4-FFF2-40B4-BE49-F238E27FC236}">
-                <a16:creationId xmlns:a16="http://schemas.microsoft.com/office/drawing/2014/main" id="{A6C47822-3B5F-46BE-97A7-E8CD9FE35920}"/>
+                <a16:creationId xmlns:a16="http://schemas.microsoft.com/office/drawing/2014/main" id="{6C092F34-8871-4A76-AACD-E6D8BABAC465}"/>
               </a:ext>
             </a:extLst>
           </p:cNvPr>
@@ -7466,7 +7466,7 @@
           <p:cNvPr id="13" name="Family journey 1">
             <a:extLst xmlns:a="http://schemas.openxmlformats.org/drawingml/2006/main">
               <a:ext uri="{FF2B5EF4-FFF2-40B4-BE49-F238E27FC236}">
-                <a16:creationId xmlns:a16="http://schemas.microsoft.com/office/drawing/2014/main" id="{6014A2B7-7CE0-4B8C-B698-C0292F812E8D}"/>
+                <a16:creationId xmlns:a16="http://schemas.microsoft.com/office/drawing/2014/main" id="{AFE22432-9DC9-45A3-AACE-0D903470E90A}"/>
               </a:ext>
             </a:extLst>
           </p:cNvPr>
@@ -7523,7 +7523,7 @@
           <p:cNvPr id="14" name="Family journey 1 detail">
             <a:extLst xmlns:a="http://schemas.openxmlformats.org/drawingml/2006/main">
               <a:ext uri="{FF2B5EF4-FFF2-40B4-BE49-F238E27FC236}">
-                <a16:creationId xmlns:a16="http://schemas.microsoft.com/office/drawing/2014/main" id="{E5616888-DCB3-43F3-8270-833D6C376539}"/>
+                <a16:creationId xmlns:a16="http://schemas.microsoft.com/office/drawing/2014/main" id="{DEFEAE2F-70BA-426A-A71B-A0D0DACF6488}"/>
               </a:ext>
             </a:extLst>
           </p:cNvPr>
@@ -7584,10 +7584,10 @@
           <p:nvPr/>
         </p:nvPicPr>
         <p:blipFill>
-          <a:blip xmlns:r="http://schemas.openxmlformats.org/officeDocument/2006/relationships" xmlns:a="http://schemas.openxmlformats.org/drawingml/2006/main" r:embed="R70edcd1cb61a4ba9">
+          <a:blip xmlns:r="http://schemas.openxmlformats.org/officeDocument/2006/relationships" xmlns:a="http://schemas.openxmlformats.org/drawingml/2006/main" r:embed="Ra1981f84f06445a6">
             <a:extLst>
               <a:ext uri="{96DAC541-7B7A-43D3-8B79-37D633B846F1}">
-                <asvg:svgBlip xmlns:asvg="http://schemas.microsoft.com/office/drawing/2016/SVG/main" r:embed="Rfc2c60352bfe4b8a"/>
+                <asvg:svgBlip xmlns:asvg="http://schemas.microsoft.com/office/drawing/2016/SVG/main" r:embed="Rbf173c406cdf49ad"/>
               </a:ext>
             </a:extLst>
           </a:blip>
@@ -7612,10 +7612,10 @@
           <p:nvPr/>
         </p:nvPicPr>
         <p:blipFill>
-          <a:blip xmlns:r="http://schemas.openxmlformats.org/officeDocument/2006/relationships" xmlns:a="http://schemas.openxmlformats.org/drawingml/2006/main" r:embed="R5d3f072150eb44fe">
+          <a:blip xmlns:r="http://schemas.openxmlformats.org/officeDocument/2006/relationships" xmlns:a="http://schemas.openxmlformats.org/drawingml/2006/main" r:embed="Rb04799ddf1d449de">
             <a:extLst>
               <a:ext uri="{96DAC541-7B7A-43D3-8B79-37D633B846F1}">
-                <asvg:svgBlip xmlns:asvg="http://schemas.microsoft.com/office/drawing/2016/SVG/main" r:embed="Rab5aca4660b040dd"/>
+                <asvg:svgBlip xmlns:asvg="http://schemas.microsoft.com/office/drawing/2016/SVG/main" r:embed="R53bf81545e9a463d"/>
               </a:ext>
             </a:extLst>
           </a:blip>
@@ -7636,7 +7636,7 @@
           <p:cNvPr id="17" name="Family journey number 2">
             <a:extLst xmlns:a="http://schemas.openxmlformats.org/drawingml/2006/main">
               <a:ext uri="{FF2B5EF4-FFF2-40B4-BE49-F238E27FC236}">
-                <a16:creationId xmlns:a16="http://schemas.microsoft.com/office/drawing/2014/main" id="{EAD4784B-3148-4DCB-A04B-C986A7CD39DC}"/>
+                <a16:creationId xmlns:a16="http://schemas.microsoft.com/office/drawing/2014/main" id="{01118313-4510-4A07-AA26-FD3354784EA0}"/>
               </a:ext>
             </a:extLst>
           </p:cNvPr>
@@ -7693,7 +7693,7 @@
           <p:cNvPr id="18" name="Family journey 2">
             <a:extLst xmlns:a="http://schemas.openxmlformats.org/drawingml/2006/main">
               <a:ext uri="{FF2B5EF4-FFF2-40B4-BE49-F238E27FC236}">
-                <a16:creationId xmlns:a16="http://schemas.microsoft.com/office/drawing/2014/main" id="{CD5FAAED-69D9-4937-B26F-3F6C6B196DED}"/>
+                <a16:creationId xmlns:a16="http://schemas.microsoft.com/office/drawing/2014/main" id="{0DE6B8B7-9B32-4665-BF43-6523E36B29D4}"/>
               </a:ext>
             </a:extLst>
           </p:cNvPr>
@@ -7750,7 +7750,7 @@
           <p:cNvPr id="19" name="Family journey 2 detail">
             <a:extLst xmlns:a="http://schemas.openxmlformats.org/drawingml/2006/main">
               <a:ext uri="{FF2B5EF4-FFF2-40B4-BE49-F238E27FC236}">
-                <a16:creationId xmlns:a16="http://schemas.microsoft.com/office/drawing/2014/main" id="{33457DA6-3BA0-4C5F-A52C-056295323FF2}"/>
+                <a16:creationId xmlns:a16="http://schemas.microsoft.com/office/drawing/2014/main" id="{E85B8DA3-9484-4EC6-9FD8-0968A30EA18E}"/>
               </a:ext>
             </a:extLst>
           </p:cNvPr>
@@ -7811,10 +7811,10 @@
           <p:nvPr/>
         </p:nvPicPr>
         <p:blipFill>
-          <a:blip xmlns:r="http://schemas.openxmlformats.org/officeDocument/2006/relationships" xmlns:a="http://schemas.openxmlformats.org/drawingml/2006/main" r:embed="Re8c130d34a5a479c">
+          <a:blip xmlns:r="http://schemas.openxmlformats.org/officeDocument/2006/relationships" xmlns:a="http://schemas.openxmlformats.org/drawingml/2006/main" r:embed="Rf118d60c9da245f8">
             <a:extLst>
               <a:ext uri="{96DAC541-7B7A-43D3-8B79-37D633B846F1}">
-                <asvg:svgBlip xmlns:asvg="http://schemas.microsoft.com/office/drawing/2016/SVG/main" r:embed="R547dd55d1dba45f4"/>
+                <asvg:svgBlip xmlns:asvg="http://schemas.microsoft.com/office/drawing/2016/SVG/main" r:embed="R3dbcc2b1018f40fc"/>
               </a:ext>
             </a:extLst>
           </a:blip>
@@ -7839,10 +7839,10 @@
           <p:nvPr/>
         </p:nvPicPr>
         <p:blipFill>
-          <a:blip xmlns:r="http://schemas.openxmlformats.org/officeDocument/2006/relationships" xmlns:a="http://schemas.openxmlformats.org/drawingml/2006/main" r:embed="R7418e0b889da4438">
+          <a:blip xmlns:r="http://schemas.openxmlformats.org/officeDocument/2006/relationships" xmlns:a="http://schemas.openxmlformats.org/drawingml/2006/main" r:embed="R9317a7ce87b546e7">
             <a:extLst>
               <a:ext uri="{96DAC541-7B7A-43D3-8B79-37D633B846F1}">
-                <asvg:svgBlip xmlns:asvg="http://schemas.microsoft.com/office/drawing/2016/SVG/main" r:embed="Rca2bfd656e3b47cd"/>
+                <asvg:svgBlip xmlns:asvg="http://schemas.microsoft.com/office/drawing/2016/SVG/main" r:embed="R92b39c266a0140c3"/>
               </a:ext>
             </a:extLst>
           </a:blip>
@@ -7863,7 +7863,7 @@
           <p:cNvPr id="22" name="Family journey number 3">
             <a:extLst xmlns:a="http://schemas.openxmlformats.org/drawingml/2006/main">
               <a:ext uri="{FF2B5EF4-FFF2-40B4-BE49-F238E27FC236}">
-                <a16:creationId xmlns:a16="http://schemas.microsoft.com/office/drawing/2014/main" id="{1B44ABC5-23AE-45B9-B41F-5315C9698870}"/>
+                <a16:creationId xmlns:a16="http://schemas.microsoft.com/office/drawing/2014/main" id="{70DA3DA0-D62F-4317-AC83-89EC6198BBF3}"/>
               </a:ext>
             </a:extLst>
           </p:cNvPr>
@@ -7920,7 +7920,7 @@
           <p:cNvPr id="23" name="Family journey 3">
             <a:extLst xmlns:a="http://schemas.openxmlformats.org/drawingml/2006/main">
               <a:ext uri="{FF2B5EF4-FFF2-40B4-BE49-F238E27FC236}">
-                <a16:creationId xmlns:a16="http://schemas.microsoft.com/office/drawing/2014/main" id="{0A44B6E4-589B-4025-B882-44CED892A40D}"/>
+                <a16:creationId xmlns:a16="http://schemas.microsoft.com/office/drawing/2014/main" id="{7D5C4A83-5AB1-4F96-94B6-8E52B0004B8E}"/>
               </a:ext>
             </a:extLst>
           </p:cNvPr>
@@ -7977,7 +7977,7 @@
           <p:cNvPr id="24" name="Family journey 3 detail">
             <a:extLst xmlns:a="http://schemas.openxmlformats.org/drawingml/2006/main">
               <a:ext uri="{FF2B5EF4-FFF2-40B4-BE49-F238E27FC236}">
-                <a16:creationId xmlns:a16="http://schemas.microsoft.com/office/drawing/2014/main" id="{D3F26257-6C41-4DAE-8A30-A88005D4A3DA}"/>
+                <a16:creationId xmlns:a16="http://schemas.microsoft.com/office/drawing/2014/main" id="{8F4D1E93-34FA-4CC9-A768-AB7EB7ED042C}"/>
               </a:ext>
             </a:extLst>
           </p:cNvPr>
@@ -8038,10 +8038,10 @@
           <p:nvPr/>
         </p:nvPicPr>
         <p:blipFill>
-          <a:blip xmlns:r="http://schemas.openxmlformats.org/officeDocument/2006/relationships" xmlns:a="http://schemas.openxmlformats.org/drawingml/2006/main" r:embed="R883582fa468d4a53">
+          <a:blip xmlns:r="http://schemas.openxmlformats.org/officeDocument/2006/relationships" xmlns:a="http://schemas.openxmlformats.org/drawingml/2006/main" r:embed="R9cf4905d615c4a62">
             <a:extLst>
               <a:ext uri="{96DAC541-7B7A-43D3-8B79-37D633B846F1}">
-                <asvg:svgBlip xmlns:asvg="http://schemas.microsoft.com/office/drawing/2016/SVG/main" r:embed="R5c67fb56f2924a1d"/>
+                <asvg:svgBlip xmlns:asvg="http://schemas.microsoft.com/office/drawing/2016/SVG/main" r:embed="R2cb45655ee47419b"/>
               </a:ext>
             </a:extLst>
           </a:blip>
@@ -8062,7 +8062,7 @@
           <p:cNvPr id="26" name="Family journey number 4">
             <a:extLst xmlns:a="http://schemas.openxmlformats.org/drawingml/2006/main">
               <a:ext uri="{FF2B5EF4-FFF2-40B4-BE49-F238E27FC236}">
-                <a16:creationId xmlns:a16="http://schemas.microsoft.com/office/drawing/2014/main" id="{8600D002-83BF-4071-8BF2-256C0837D128}"/>
+                <a16:creationId xmlns:a16="http://schemas.microsoft.com/office/drawing/2014/main" id="{B643CBCC-6C6F-4640-BA19-ABBFE4919127}"/>
               </a:ext>
             </a:extLst>
           </p:cNvPr>
@@ -8119,7 +8119,7 @@
           <p:cNvPr id="27" name="Family journey 4">
             <a:extLst xmlns:a="http://schemas.openxmlformats.org/drawingml/2006/main">
               <a:ext uri="{FF2B5EF4-FFF2-40B4-BE49-F238E27FC236}">
-                <a16:creationId xmlns:a16="http://schemas.microsoft.com/office/drawing/2014/main" id="{2B9913D6-5FF4-47E6-BC69-2BFE91CDD880}"/>
+                <a16:creationId xmlns:a16="http://schemas.microsoft.com/office/drawing/2014/main" id="{64D286EB-4325-40E1-A043-8AA13AB32CD5}"/>
               </a:ext>
             </a:extLst>
           </p:cNvPr>
@@ -8176,7 +8176,7 @@
           <p:cNvPr id="28" name="Family journey 4 detail">
             <a:extLst xmlns:a="http://schemas.openxmlformats.org/drawingml/2006/main">
               <a:ext uri="{FF2B5EF4-FFF2-40B4-BE49-F238E27FC236}">
-                <a16:creationId xmlns:a16="http://schemas.microsoft.com/office/drawing/2014/main" id="{375800ED-C1D7-47CA-81F0-F4075E576BFA}"/>
+                <a16:creationId xmlns:a16="http://schemas.microsoft.com/office/drawing/2014/main" id="{BDC85B54-9C07-4EDA-9B1C-95D64E35A547}"/>
               </a:ext>
             </a:extLst>
           </p:cNvPr>
@@ -8237,10 +8237,10 @@
           <p:nvPr/>
         </p:nvPicPr>
         <p:blipFill>
-          <a:blip xmlns:r="http://schemas.openxmlformats.org/officeDocument/2006/relationships" xmlns:a="http://schemas.openxmlformats.org/drawingml/2006/main" r:embed="R7ee4aa1db18e4106">
+          <a:blip xmlns:r="http://schemas.openxmlformats.org/officeDocument/2006/relationships" xmlns:a="http://schemas.openxmlformats.org/drawingml/2006/main" r:embed="R10653ffa980048cc">
             <a:extLst>
               <a:ext uri="{96DAC541-7B7A-43D3-8B79-37D633B846F1}">
-                <asvg:svgBlip xmlns:asvg="http://schemas.microsoft.com/office/drawing/2016/SVG/main" r:embed="R9da6135ccaff4e11"/>
+                <asvg:svgBlip xmlns:asvg="http://schemas.microsoft.com/office/drawing/2016/SVG/main" r:embed="Re7c578e44e7f4d19"/>
               </a:ext>
             </a:extLst>
           </a:blip>
@@ -8265,10 +8265,10 @@
           <p:nvPr/>
         </p:nvPicPr>
         <p:blipFill>
-          <a:blip xmlns:r="http://schemas.openxmlformats.org/officeDocument/2006/relationships" xmlns:a="http://schemas.openxmlformats.org/drawingml/2006/main" r:embed="Rd7bbf8f14fd14bf6">
+          <a:blip xmlns:r="http://schemas.openxmlformats.org/officeDocument/2006/relationships" xmlns:a="http://schemas.openxmlformats.org/drawingml/2006/main" r:embed="R27a1b96e85434fe5">
             <a:extLst>
               <a:ext uri="{96DAC541-7B7A-43D3-8B79-37D633B846F1}">
-                <asvg:svgBlip xmlns:asvg="http://schemas.microsoft.com/office/drawing/2016/SVG/main" r:embed="Rbff6c3b366f84804"/>
+                <asvg:svgBlip xmlns:asvg="http://schemas.microsoft.com/office/drawing/2016/SVG/main" r:embed="Rd9ae1781679242b0"/>
               </a:ext>
             </a:extLst>
           </a:blip>
@@ -8289,7 +8289,7 @@
           <p:cNvPr id="31" name="Family journey number 5">
             <a:extLst xmlns:a="http://schemas.openxmlformats.org/drawingml/2006/main">
               <a:ext uri="{FF2B5EF4-FFF2-40B4-BE49-F238E27FC236}">
-                <a16:creationId xmlns:a16="http://schemas.microsoft.com/office/drawing/2014/main" id="{CC79B087-2B39-44C1-BEDE-F30D818652D4}"/>
+                <a16:creationId xmlns:a16="http://schemas.microsoft.com/office/drawing/2014/main" id="{F3DDCCBB-5B1B-42BD-BE62-45315A3FF904}"/>
               </a:ext>
             </a:extLst>
           </p:cNvPr>
@@ -8346,7 +8346,7 @@
           <p:cNvPr id="32" name="Family journey 5">
             <a:extLst xmlns:a="http://schemas.openxmlformats.org/drawingml/2006/main">
               <a:ext uri="{FF2B5EF4-FFF2-40B4-BE49-F238E27FC236}">
-                <a16:creationId xmlns:a16="http://schemas.microsoft.com/office/drawing/2014/main" id="{807E8268-98F2-4FE5-878D-7A4E81876615}"/>
+                <a16:creationId xmlns:a16="http://schemas.microsoft.com/office/drawing/2014/main" id="{7488ACA1-9190-42BD-AC87-E2039152C058}"/>
               </a:ext>
             </a:extLst>
           </p:cNvPr>
@@ -8403,7 +8403,7 @@
           <p:cNvPr id="33" name="Family journey 5 detail">
             <a:extLst xmlns:a="http://schemas.openxmlformats.org/drawingml/2006/main">
               <a:ext uri="{FF2B5EF4-FFF2-40B4-BE49-F238E27FC236}">
-                <a16:creationId xmlns:a16="http://schemas.microsoft.com/office/drawing/2014/main" id="{84E5021F-6316-493A-A3A7-8E1AEDE63BF3}"/>
+                <a16:creationId xmlns:a16="http://schemas.microsoft.com/office/drawing/2014/main" id="{A72C1ABE-F3E1-4887-9E5D-E0ADDD784BA9}"/>
               </a:ext>
             </a:extLst>
           </p:cNvPr>
@@ -8464,10 +8464,10 @@
           <p:nvPr/>
         </p:nvPicPr>
         <p:blipFill>
-          <a:blip xmlns:r="http://schemas.openxmlformats.org/officeDocument/2006/relationships" xmlns:a="http://schemas.openxmlformats.org/drawingml/2006/main" r:embed="R7b8179d9d8634b0b">
+          <a:blip xmlns:r="http://schemas.openxmlformats.org/officeDocument/2006/relationships" xmlns:a="http://schemas.openxmlformats.org/drawingml/2006/main" r:embed="Reddcefe6054848ad">
             <a:extLst>
               <a:ext uri="{96DAC541-7B7A-43D3-8B79-37D633B846F1}">
-                <asvg:svgBlip xmlns:asvg="http://schemas.microsoft.com/office/drawing/2016/SVG/main" r:embed="Rc840716832e94848"/>
+                <asvg:svgBlip xmlns:asvg="http://schemas.microsoft.com/office/drawing/2016/SVG/main" r:embed="Ra262f0da205e420b"/>
               </a:ext>
             </a:extLst>
           </a:blip>
@@ -8492,10 +8492,10 @@
           <p:nvPr/>
         </p:nvPicPr>
         <p:blipFill>
-          <a:blip xmlns:r="http://schemas.openxmlformats.org/officeDocument/2006/relationships" xmlns:a="http://schemas.openxmlformats.org/drawingml/2006/main" r:embed="R27bac49ce3d44955">
+          <a:blip xmlns:r="http://schemas.openxmlformats.org/officeDocument/2006/relationships" xmlns:a="http://schemas.openxmlformats.org/drawingml/2006/main" r:embed="R8c384d842e314711">
             <a:extLst>
               <a:ext uri="{96DAC541-7B7A-43D3-8B79-37D633B846F1}">
-                <asvg:svgBlip xmlns:asvg="http://schemas.microsoft.com/office/drawing/2016/SVG/main" r:embed="R229437a360664835"/>
+                <asvg:svgBlip xmlns:asvg="http://schemas.microsoft.com/office/drawing/2016/SVG/main" r:embed="Rdd635a956c61407b"/>
               </a:ext>
             </a:extLst>
           </a:blip>
@@ -8516,7 +8516,7 @@
           <p:cNvPr id="36" name="Family journey number 6">
             <a:extLst xmlns:a="http://schemas.openxmlformats.org/drawingml/2006/main">
               <a:ext uri="{FF2B5EF4-FFF2-40B4-BE49-F238E27FC236}">
-                <a16:creationId xmlns:a16="http://schemas.microsoft.com/office/drawing/2014/main" id="{256EFB87-7562-4A58-A9C5-FB68EFEA60AE}"/>
+                <a16:creationId xmlns:a16="http://schemas.microsoft.com/office/drawing/2014/main" id="{2149B374-A890-4095-957E-C057E306D576}"/>
               </a:ext>
             </a:extLst>
           </p:cNvPr>
@@ -8573,7 +8573,7 @@
           <p:cNvPr id="37" name="Family journey 6">
             <a:extLst xmlns:a="http://schemas.openxmlformats.org/drawingml/2006/main">
               <a:ext uri="{FF2B5EF4-FFF2-40B4-BE49-F238E27FC236}">
-                <a16:creationId xmlns:a16="http://schemas.microsoft.com/office/drawing/2014/main" id="{7345CBFC-B967-435C-ACF0-685C9DA2DF74}"/>
+                <a16:creationId xmlns:a16="http://schemas.microsoft.com/office/drawing/2014/main" id="{0C67A111-83DF-4A88-8FB8-A69994C50286}"/>
               </a:ext>
             </a:extLst>
           </p:cNvPr>
@@ -8630,7 +8630,7 @@
           <p:cNvPr id="38" name="Family journey 6 detail">
             <a:extLst xmlns:a="http://schemas.openxmlformats.org/drawingml/2006/main">
               <a:ext uri="{FF2B5EF4-FFF2-40B4-BE49-F238E27FC236}">
-                <a16:creationId xmlns:a16="http://schemas.microsoft.com/office/drawing/2014/main" id="{BAD1FB3E-7F4E-4E67-9855-D8E6123A569C}"/>
+                <a16:creationId xmlns:a16="http://schemas.microsoft.com/office/drawing/2014/main" id="{30F7E9D0-6520-4387-A795-D101748D443A}"/>
               </a:ext>
             </a:extLst>
           </p:cNvPr>
@@ -8687,7 +8687,7 @@
           <p:cNvPr id="39" name="Support directory">
             <a:extLst xmlns:a="http://schemas.openxmlformats.org/drawingml/2006/main">
               <a:ext uri="{FF2B5EF4-FFF2-40B4-BE49-F238E27FC236}">
-                <a16:creationId xmlns:a16="http://schemas.microsoft.com/office/drawing/2014/main" id="{2BC5057E-33F2-4AF9-A7DC-76ACC8844774}"/>
+                <a16:creationId xmlns:a16="http://schemas.microsoft.com/office/drawing/2014/main" id="{2E75A865-6C0F-4135-97A4-B02C7C959E9B}"/>
               </a:ext>
             </a:extLst>
           </p:cNvPr>
@@ -8733,7 +8733,7 @@
                 <a:latin typeface="Arial"/>
                 <a:ea typeface="Arial"/>
                 <a:cs typeface="Arial"/>
-                <a:hlinkClick xmlns:r="http://schemas.openxmlformats.org/officeDocument/2006/relationships" r:id="R2a25721dcb4d4568"/>
+                <a:hlinkClick xmlns:r="http://schemas.openxmlformats.org/officeDocument/2006/relationships" r:id="Rb22a101764e445d0"/>
               </a:rPr>
               <a:t>Find a centre → call to confirm → keep the contact and visit plan.</a:t>
             </a:r>
@@ -8774,7 +8774,7 @@
           <p:cNvPr id="14" name="Slide title">
             <a:extLst xmlns:a="http://schemas.openxmlformats.org/drawingml/2006/main">
               <a:ext uri="{FF2B5EF4-FFF2-40B4-BE49-F238E27FC236}">
-                <a16:creationId xmlns:a16="http://schemas.microsoft.com/office/drawing/2014/main" id="{C16D8A49-1396-4AA5-9EAA-69BF3813261C}"/>
+                <a16:creationId xmlns:a16="http://schemas.microsoft.com/office/drawing/2014/main" id="{E6D97D31-6C7C-45AF-BE21-179D8B6D4DF5}"/>
               </a:ext>
             </a:extLst>
           </p:cNvPr>
@@ -8831,7 +8831,7 @@
           <p:cNvPr id="2" name="Trial design">
             <a:extLst xmlns:a="http://schemas.openxmlformats.org/drawingml/2006/main">
               <a:ext uri="{FF2B5EF4-FFF2-40B4-BE49-F238E27FC236}">
-                <a16:creationId xmlns:a16="http://schemas.microsoft.com/office/drawing/2014/main" id="{EBFBE361-A99C-4269-B070-6D9D5FEAB949}"/>
+                <a16:creationId xmlns:a16="http://schemas.microsoft.com/office/drawing/2014/main" id="{6CFD42F9-A91B-40DD-9950-C19D46FCCAE7}"/>
               </a:ext>
             </a:extLst>
           </p:cNvPr>
@@ -8888,7 +8888,7 @@
           <p:cNvPr id="3" name="Primary measure 1">
             <a:extLst xmlns:a="http://schemas.openxmlformats.org/drawingml/2006/main">
               <a:ext uri="{FF2B5EF4-FFF2-40B4-BE49-F238E27FC236}">
-                <a16:creationId xmlns:a16="http://schemas.microsoft.com/office/drawing/2014/main" id="{0300098E-4555-427D-BC81-B60C9D9E9A86}"/>
+                <a16:creationId xmlns:a16="http://schemas.microsoft.com/office/drawing/2014/main" id="{C35FA485-5687-420D-9417-C02BEEAA354B}"/>
               </a:ext>
             </a:extLst>
           </p:cNvPr>
@@ -8945,7 +8945,7 @@
           <p:cNvPr id="4" name="Primary measure 1 detail">
             <a:extLst xmlns:a="http://schemas.openxmlformats.org/drawingml/2006/main">
               <a:ext uri="{FF2B5EF4-FFF2-40B4-BE49-F238E27FC236}">
-                <a16:creationId xmlns:a16="http://schemas.microsoft.com/office/drawing/2014/main" id="{042291F0-294C-4DCF-8860-F43A0A5C1838}"/>
+                <a16:creationId xmlns:a16="http://schemas.microsoft.com/office/drawing/2014/main" id="{83121768-9075-4539-8941-CBA00F9FDCD6}"/>
               </a:ext>
             </a:extLst>
           </p:cNvPr>
@@ -9002,7 +9002,7 @@
           <p:cNvPr id="5" name="Primary measure 2">
             <a:extLst xmlns:a="http://schemas.openxmlformats.org/drawingml/2006/main">
               <a:ext uri="{FF2B5EF4-FFF2-40B4-BE49-F238E27FC236}">
-                <a16:creationId xmlns:a16="http://schemas.microsoft.com/office/drawing/2014/main" id="{BC879D6C-9AEE-43A8-A48A-C02914D42191}"/>
+                <a16:creationId xmlns:a16="http://schemas.microsoft.com/office/drawing/2014/main" id="{27F26141-ADD9-4BDB-8054-3DDC31E7728B}"/>
               </a:ext>
             </a:extLst>
           </p:cNvPr>
@@ -9059,7 +9059,7 @@
           <p:cNvPr id="6" name="Primary measure 2 detail">
             <a:extLst xmlns:a="http://schemas.openxmlformats.org/drawingml/2006/main">
               <a:ext uri="{FF2B5EF4-FFF2-40B4-BE49-F238E27FC236}">
-                <a16:creationId xmlns:a16="http://schemas.microsoft.com/office/drawing/2014/main" id="{41833782-94C6-421F-81A7-CBBBD5910D11}"/>
+                <a16:creationId xmlns:a16="http://schemas.microsoft.com/office/drawing/2014/main" id="{91EFCE1F-8F9E-43A2-A8BC-F75C17E83C31}"/>
               </a:ext>
             </a:extLst>
           </p:cNvPr>
@@ -9116,7 +9116,7 @@
           <p:cNvPr id="7" name="Primary measure 3">
             <a:extLst xmlns:a="http://schemas.openxmlformats.org/drawingml/2006/main">
               <a:ext uri="{FF2B5EF4-FFF2-40B4-BE49-F238E27FC236}">
-                <a16:creationId xmlns:a16="http://schemas.microsoft.com/office/drawing/2014/main" id="{F52CAB9D-319E-4692-9CC2-3D784A1E35B6}"/>
+                <a16:creationId xmlns:a16="http://schemas.microsoft.com/office/drawing/2014/main" id="{0A674C49-2D60-445F-ADA3-EA4CA5D3094A}"/>
               </a:ext>
             </a:extLst>
           </p:cNvPr>
@@ -9173,7 +9173,7 @@
           <p:cNvPr id="8" name="Primary measure 3 detail">
             <a:extLst xmlns:a="http://schemas.openxmlformats.org/drawingml/2006/main">
               <a:ext uri="{FF2B5EF4-FFF2-40B4-BE49-F238E27FC236}">
-                <a16:creationId xmlns:a16="http://schemas.microsoft.com/office/drawing/2014/main" id="{FD9FCD8F-F6F8-4056-B4C5-1D51498940D7}"/>
+                <a16:creationId xmlns:a16="http://schemas.microsoft.com/office/drawing/2014/main" id="{54826EAA-B40E-4A5C-AA7E-4AEA588A3E62}"/>
               </a:ext>
             </a:extLst>
           </p:cNvPr>
@@ -9230,7 +9230,7 @@
           <p:cNvPr id="9" name="">
             <a:extLst xmlns:a="http://schemas.openxmlformats.org/drawingml/2006/main">
               <a:ext uri="{FF2B5EF4-FFF2-40B4-BE49-F238E27FC236}">
-                <a16:creationId xmlns:a16="http://schemas.microsoft.com/office/drawing/2014/main" id="{9C66F07D-9BAE-4F02-B739-7DD974C2B3F8}"/>
+                <a16:creationId xmlns:a16="http://schemas.microsoft.com/office/drawing/2014/main" id="{1E9FDB96-2510-4907-9C66-7267FEC71439}"/>
               </a:ext>
             </a:extLst>
           </p:cNvPr>
@@ -9259,7 +9259,7 @@
           <p:cNvPr id="10" name="Comparison">
             <a:extLst xmlns:a="http://schemas.openxmlformats.org/drawingml/2006/main">
               <a:ext uri="{FF2B5EF4-FFF2-40B4-BE49-F238E27FC236}">
-                <a16:creationId xmlns:a16="http://schemas.microsoft.com/office/drawing/2014/main" id="{4696A24D-909D-40FD-844A-E733D19545A0}"/>
+                <a16:creationId xmlns:a16="http://schemas.microsoft.com/office/drawing/2014/main" id="{B9EDF9CF-E661-45D8-8291-CF8EA58E0E2B}"/>
               </a:ext>
             </a:extLst>
           </p:cNvPr>
@@ -9316,7 +9316,7 @@
           <p:cNvPr id="11" name="Primary outcome definition">
             <a:extLst xmlns:a="http://schemas.openxmlformats.org/drawingml/2006/main">
               <a:ext uri="{FF2B5EF4-FFF2-40B4-BE49-F238E27FC236}">
-                <a16:creationId xmlns:a16="http://schemas.microsoft.com/office/drawing/2014/main" id="{B978CF16-80B9-49DD-9284-D7C4A873AF05}"/>
+                <a16:creationId xmlns:a16="http://schemas.microsoft.com/office/drawing/2014/main" id="{F1547387-A7F0-4E7C-8C05-84E4485429F7}"/>
               </a:ext>
             </a:extLst>
           </p:cNvPr>
@@ -9373,7 +9373,7 @@
           <p:cNvPr id="12" name="Additional measures">
             <a:extLst xmlns:a="http://schemas.openxmlformats.org/drawingml/2006/main">
               <a:ext uri="{FF2B5EF4-FFF2-40B4-BE49-F238E27FC236}">
-                <a16:creationId xmlns:a16="http://schemas.microsoft.com/office/drawing/2014/main" id="{C08CDD21-6642-4AF7-B781-F51A00CCA6CB}"/>
+                <a16:creationId xmlns:a16="http://schemas.microsoft.com/office/drawing/2014/main" id="{1E753437-09E3-4E69-81EA-D9C870226C04}"/>
               </a:ext>
             </a:extLst>
           </p:cNvPr>
@@ -9430,7 +9430,7 @@
           <p:cNvPr id="13" name="Implementation status">
             <a:extLst xmlns:a="http://schemas.openxmlformats.org/drawingml/2006/main">
               <a:ext uri="{FF2B5EF4-FFF2-40B4-BE49-F238E27FC236}">
-                <a16:creationId xmlns:a16="http://schemas.microsoft.com/office/drawing/2014/main" id="{44B1A8CE-90FE-43B4-A967-0851AB4EC5A3}"/>
+                <a16:creationId xmlns:a16="http://schemas.microsoft.com/office/drawing/2014/main" id="{A6FBFEFF-5BF4-4E38-A19F-2F038010FF63}"/>
               </a:ext>
             </a:extLst>
           </p:cNvPr>
@@ -9498,7 +9498,7 @@
     <p:bg>
       <p:bgPr>
         <a:solidFill xmlns:a="http://schemas.openxmlformats.org/drawingml/2006/main">
-          <a:srgbClr val="F7F3E9"/>
+          <a:srgbClr val="0B1744"/>
         </a:solidFill>
       </p:bgPr>
     </p:bg>
@@ -9513,51 +9513,51 @@
       </p:grpSpPr>
       <p:sp>
         <p:nvSpPr>
-          <p:cNvPr id="29" name="References title">
-            <a:extLst xmlns:a="http://schemas.openxmlformats.org/drawingml/2006/main">
-              <a:ext uri="{FF2B5EF4-FFF2-40B4-BE49-F238E27FC236}">
-                <a16:creationId xmlns:a16="http://schemas.microsoft.com/office/drawing/2014/main" id="{70B1492F-11D9-434F-98BA-EA48C638C90C}"/>
-              </a:ext>
-            </a:extLst>
-          </p:cNvPr>
-          <p:cNvSpPr>
-            <a:spLocks xmlns:a="http://schemas.openxmlformats.org/drawingml/2006/main" noGrp="1"/>
-          </p:cNvSpPr>
-          <p:nvPr/>
-        </p:nvSpPr>
-        <p:spPr>
-          <a:xfrm xmlns:a="http://schemas.openxmlformats.org/drawingml/2006/main">
-            <a:off x="533400" y="342900"/>
-            <a:ext cx="11125200" cy="552450"/>
-          </a:xfrm>
-          <a:prstGeom xmlns:a="http://schemas.openxmlformats.org/drawingml/2006/main" prst="rect">
-            <a:avLst/>
-          </a:prstGeom>
-          <a:noFill xmlns:a="http://schemas.openxmlformats.org/drawingml/2006/main"/>
-          <a:ln xmlns:a="http://schemas.openxmlformats.org/drawingml/2006/main" w="0">
-            <a:noFill/>
-          </a:ln>
-        </p:spPr>
-        <p:txBody>
-          <a:bodyPr xmlns:a="http://schemas.openxmlformats.org/drawingml/2006/main" wrap="square" lIns="0" tIns="0" rIns="0" bIns="0">
-            <a:normAutofit fontScale="100000"/>
-          </a:bodyPr>
-          <a:lstStyle xmlns:a="http://schemas.openxmlformats.org/drawingml/2006/main"/>
-          <a:p xmlns:a="http://schemas.openxmlformats.org/drawingml/2006/main">
-            <a:pPr>
-              <a:defRPr sz="3000" b="1">
-                <a:solidFill>
-                  <a:srgbClr val="173F33"/>
-                </a:solidFill>
-                <a:latin typeface="Arial"/>
-                <a:ea typeface="Arial"/>
-                <a:cs typeface="Arial"/>
-              </a:defRPr>
-            </a:pPr>
-            <a:r>
-              <a:rPr sz="3000" b="1">
-                <a:solidFill>
-                  <a:srgbClr val="173F33"/>
+          <p:cNvPr id="31" name="References title">
+            <a:extLst xmlns:a="http://schemas.openxmlformats.org/drawingml/2006/main">
+              <a:ext uri="{FF2B5EF4-FFF2-40B4-BE49-F238E27FC236}">
+                <a16:creationId xmlns:a16="http://schemas.microsoft.com/office/drawing/2014/main" id="{B57EC4D1-4F16-4FBE-84F7-75A0E7724977}"/>
+              </a:ext>
+            </a:extLst>
+          </p:cNvPr>
+          <p:cNvSpPr>
+            <a:spLocks xmlns:a="http://schemas.openxmlformats.org/drawingml/2006/main" noGrp="1"/>
+          </p:cNvSpPr>
+          <p:nvPr/>
+        </p:nvSpPr>
+        <p:spPr>
+          <a:xfrm xmlns:a="http://schemas.openxmlformats.org/drawingml/2006/main">
+            <a:off x="533400" y="285750"/>
+            <a:ext cx="11125200" cy="590550"/>
+          </a:xfrm>
+          <a:prstGeom xmlns:a="http://schemas.openxmlformats.org/drawingml/2006/main" prst="rect">
+            <a:avLst/>
+          </a:prstGeom>
+          <a:noFill xmlns:a="http://schemas.openxmlformats.org/drawingml/2006/main"/>
+          <a:ln xmlns:a="http://schemas.openxmlformats.org/drawingml/2006/main" w="0">
+            <a:noFill/>
+          </a:ln>
+        </p:spPr>
+        <p:txBody>
+          <a:bodyPr xmlns:a="http://schemas.openxmlformats.org/drawingml/2006/main" wrap="square" lIns="0" tIns="0" rIns="0" bIns="0">
+            <a:normAutofit fontScale="100000"/>
+          </a:bodyPr>
+          <a:lstStyle xmlns:a="http://schemas.openxmlformats.org/drawingml/2006/main"/>
+          <a:p xmlns:a="http://schemas.openxmlformats.org/drawingml/2006/main">
+            <a:pPr>
+              <a:defRPr sz="3450" b="1">
+                <a:solidFill>
+                  <a:srgbClr val="FFD154"/>
+                </a:solidFill>
+                <a:latin typeface="Arial"/>
+                <a:ea typeface="Arial"/>
+                <a:cs typeface="Arial"/>
+              </a:defRPr>
+            </a:pPr>
+            <a:r>
+              <a:rPr sz="3450" b="1">
+                <a:solidFill>
+                  <a:srgbClr val="FFD154"/>
                 </a:solidFill>
                 <a:latin typeface="Arial"/>
                 <a:ea typeface="Arial"/>
@@ -9570,10 +9570,70 @@
       </p:sp>
       <p:sp>
         <p:nvSpPr>
-          <p:cNvPr id="2" name="Reference 1 author">
-            <a:extLst xmlns:a="http://schemas.openxmlformats.org/drawingml/2006/main">
-              <a:ext uri="{FF2B5EF4-FFF2-40B4-BE49-F238E27FC236}">
-                <a16:creationId xmlns:a16="http://schemas.microsoft.com/office/drawing/2014/main" id="{26180823-26A2-4216-85B6-503D61E462C1}"/>
+          <p:cNvPr id="2" name="References one to four">
+            <a:extLst xmlns:a="http://schemas.openxmlformats.org/drawingml/2006/main">
+              <a:ext uri="{FF2B5EF4-FFF2-40B4-BE49-F238E27FC236}">
+                <a16:creationId xmlns:a16="http://schemas.microsoft.com/office/drawing/2014/main" id="{67EC1266-D103-45BD-BD0A-BEDDCD076E1F}"/>
+              </a:ext>
+            </a:extLst>
+          </p:cNvPr>
+          <p:cNvSpPr>
+            <a:spLocks xmlns:a="http://schemas.openxmlformats.org/drawingml/2006/main" noGrp="1"/>
+          </p:cNvSpPr>
+          <p:nvPr/>
+        </p:nvSpPr>
+        <p:spPr>
+          <a:xfrm xmlns:a="http://schemas.openxmlformats.org/drawingml/2006/main">
+            <a:off x="381000" y="981075"/>
+            <a:ext cx="5638800" cy="5810250"/>
+          </a:xfrm>
+          <a:prstGeom xmlns:a="http://schemas.openxmlformats.org/drawingml/2006/main" prst="rect">
+            <a:avLst/>
+          </a:prstGeom>
+          <a:solidFill xmlns:a="http://schemas.openxmlformats.org/drawingml/2006/main">
+            <a:srgbClr val="E8F4F0"/>
+          </a:solidFill>
+          <a:ln xmlns:a="http://schemas.openxmlformats.org/drawingml/2006/main" w="0">
+            <a:noFill/>
+          </a:ln>
+        </p:spPr>
+      </p:sp>
+      <p:sp>
+        <p:nvSpPr>
+          <p:cNvPr id="3" name="References five to nine">
+            <a:extLst xmlns:a="http://schemas.openxmlformats.org/drawingml/2006/main">
+              <a:ext uri="{FF2B5EF4-FFF2-40B4-BE49-F238E27FC236}">
+                <a16:creationId xmlns:a16="http://schemas.microsoft.com/office/drawing/2014/main" id="{2E13A932-098E-4C4E-9268-DA224A3A6D34}"/>
+              </a:ext>
+            </a:extLst>
+          </p:cNvPr>
+          <p:cNvSpPr>
+            <a:spLocks xmlns:a="http://schemas.openxmlformats.org/drawingml/2006/main" noGrp="1"/>
+          </p:cNvSpPr>
+          <p:nvPr/>
+        </p:nvSpPr>
+        <p:spPr>
+          <a:xfrm xmlns:a="http://schemas.openxmlformats.org/drawingml/2006/main">
+            <a:off x="6096000" y="981075"/>
+            <a:ext cx="5638800" cy="5810250"/>
+          </a:xfrm>
+          <a:prstGeom xmlns:a="http://schemas.openxmlformats.org/drawingml/2006/main" prst="rect">
+            <a:avLst/>
+          </a:prstGeom>
+          <a:solidFill xmlns:a="http://schemas.openxmlformats.org/drawingml/2006/main">
+            <a:srgbClr val="EEE7FA"/>
+          </a:solidFill>
+          <a:ln xmlns:a="http://schemas.openxmlformats.org/drawingml/2006/main" w="0">
+            <a:noFill/>
+          </a:ln>
+        </p:spPr>
+      </p:sp>
+      <p:sp>
+        <p:nvSpPr>
+          <p:cNvPr id="4" name="Reference 1 author">
+            <a:extLst xmlns:a="http://schemas.openxmlformats.org/drawingml/2006/main">
+              <a:ext uri="{FF2B5EF4-FFF2-40B4-BE49-F238E27FC236}">
+                <a16:creationId xmlns:a16="http://schemas.microsoft.com/office/drawing/2014/main" id="{72B7F9DA-4241-4F52-8898-602D87ED79D3}"/>
               </a:ext>
             </a:extLst>
           </p:cNvPr>
@@ -9627,10 +9687,10 @@
       </p:sp>
       <p:sp>
         <p:nvSpPr>
-          <p:cNvPr id="3" name="Reference 1 title">
-            <a:extLst xmlns:a="http://schemas.openxmlformats.org/drawingml/2006/main">
-              <a:ext uri="{FF2B5EF4-FFF2-40B4-BE49-F238E27FC236}">
-                <a16:creationId xmlns:a16="http://schemas.microsoft.com/office/drawing/2014/main" id="{BF7BD6FC-55BB-43B0-93BA-27AE6BE51544}"/>
+          <p:cNvPr id="5" name="Reference 1 title">
+            <a:extLst xmlns:a="http://schemas.openxmlformats.org/drawingml/2006/main">
+              <a:ext uri="{FF2B5EF4-FFF2-40B4-BE49-F238E27FC236}">
+                <a16:creationId xmlns:a16="http://schemas.microsoft.com/office/drawing/2014/main" id="{6B23E8D3-C2A9-4BB1-A7B0-C6D862701A64}"/>
               </a:ext>
             </a:extLst>
           </p:cNvPr>
@@ -9676,7 +9736,7 @@
                 <a:latin typeface="Arial"/>
                 <a:ea typeface="Arial"/>
                 <a:cs typeface="Arial"/>
-                <a:hlinkClick xmlns:r="http://schemas.openxmlformats.org/officeDocument/2006/relationships" r:id="Ra540cd6bd22f46c4"/>
+                <a:hlinkClick xmlns:r="http://schemas.openxmlformats.org/officeDocument/2006/relationships" r:id="R4dc226c9244d40ec"/>
               </a:rPr>
               <a:t>India: GLOBOCAN 2024 Fact Sheet</a:t>
             </a:r>
@@ -9685,10 +9745,10 @@
       </p:sp>
       <p:sp>
         <p:nvSpPr>
-          <p:cNvPr id="4" name="Reference 1 link">
-            <a:extLst xmlns:a="http://schemas.openxmlformats.org/drawingml/2006/main">
-              <a:ext uri="{FF2B5EF4-FFF2-40B4-BE49-F238E27FC236}">
-                <a16:creationId xmlns:a16="http://schemas.microsoft.com/office/drawing/2014/main" id="{8B9AEEE4-7316-43E0-B726-EED99B2C345F}"/>
+          <p:cNvPr id="6" name="Reference 1 link">
+            <a:extLst xmlns:a="http://schemas.openxmlformats.org/drawingml/2006/main">
+              <a:ext uri="{FF2B5EF4-FFF2-40B4-BE49-F238E27FC236}">
+                <a16:creationId xmlns:a16="http://schemas.microsoft.com/office/drawing/2014/main" id="{2548D416-875D-4F11-BF03-05BFAAD160E8}"/>
               </a:ext>
             </a:extLst>
           </p:cNvPr>
@@ -9734,7 +9794,7 @@
                 <a:latin typeface="Arial"/>
                 <a:ea typeface="Arial"/>
                 <a:cs typeface="Arial"/>
-                <a:hlinkClick xmlns:r="http://schemas.openxmlformats.org/officeDocument/2006/relationships" r:id="R443939e682764032"/>
+                <a:hlinkClick xmlns:r="http://schemas.openxmlformats.org/officeDocument/2006/relationships" r:id="Ra45fe59619454f63"/>
               </a:rPr>
               <a:t>https://gco.iarc.who.int/media/globocan/factsheets/populations/356-india-fact-sheet.pdf</a:t>
             </a:r>
@@ -9743,10 +9803,10 @@
       </p:sp>
       <p:sp>
         <p:nvSpPr>
-          <p:cNvPr id="5" name="Reference 2 author">
-            <a:extLst xmlns:a="http://schemas.openxmlformats.org/drawingml/2006/main">
-              <a:ext uri="{FF2B5EF4-FFF2-40B4-BE49-F238E27FC236}">
-                <a16:creationId xmlns:a16="http://schemas.microsoft.com/office/drawing/2014/main" id="{038B3E91-5205-48FB-B3A9-6CF92C951555}"/>
+          <p:cNvPr id="7" name="Reference 2 author">
+            <a:extLst xmlns:a="http://schemas.openxmlformats.org/drawingml/2006/main">
+              <a:ext uri="{FF2B5EF4-FFF2-40B4-BE49-F238E27FC236}">
+                <a16:creationId xmlns:a16="http://schemas.microsoft.com/office/drawing/2014/main" id="{BC774ACA-919E-4244-8D83-5A35491C73A0}"/>
               </a:ext>
             </a:extLst>
           </p:cNvPr>
@@ -9800,10 +9860,10 @@
       </p:sp>
       <p:sp>
         <p:nvSpPr>
-          <p:cNvPr id="6" name="Reference 2 title">
-            <a:extLst xmlns:a="http://schemas.openxmlformats.org/drawingml/2006/main">
-              <a:ext uri="{FF2B5EF4-FFF2-40B4-BE49-F238E27FC236}">
-                <a16:creationId xmlns:a16="http://schemas.microsoft.com/office/drawing/2014/main" id="{431F0E53-ED39-46D9-9336-E6BA88DC652D}"/>
+          <p:cNvPr id="8" name="Reference 2 title">
+            <a:extLst xmlns:a="http://schemas.openxmlformats.org/drawingml/2006/main">
+              <a:ext uri="{FF2B5EF4-FFF2-40B4-BE49-F238E27FC236}">
+                <a16:creationId xmlns:a16="http://schemas.microsoft.com/office/drawing/2014/main" id="{165D9109-CE91-4956-9F1A-80B477B86AA6}"/>
               </a:ext>
             </a:extLst>
           </p:cNvPr>
@@ -9849,7 +9909,7 @@
                 <a:latin typeface="Arial"/>
                 <a:ea typeface="Arial"/>
                 <a:cs typeface="Arial"/>
-                <a:hlinkClick xmlns:r="http://schemas.openxmlformats.org/officeDocument/2006/relationships" r:id="Ra528503def54403f"/>
+                <a:hlinkClick xmlns:r="http://schemas.openxmlformats.org/officeDocument/2006/relationships" r:id="R0e42d417d82746b2"/>
               </a:rPr>
               <a:t>Unmet need for cancer palliative care in India</a:t>
             </a:r>
@@ -9858,10 +9918,10 @@
       </p:sp>
       <p:sp>
         <p:nvSpPr>
-          <p:cNvPr id="7" name="Reference 2 link">
-            <a:extLst xmlns:a="http://schemas.openxmlformats.org/drawingml/2006/main">
-              <a:ext uri="{FF2B5EF4-FFF2-40B4-BE49-F238E27FC236}">
-                <a16:creationId xmlns:a16="http://schemas.microsoft.com/office/drawing/2014/main" id="{A904C24E-60D1-4D9B-961F-FF06D4182A34}"/>
+          <p:cNvPr id="9" name="Reference 2 link">
+            <a:extLst xmlns:a="http://schemas.openxmlformats.org/drawingml/2006/main">
+              <a:ext uri="{FF2B5EF4-FFF2-40B4-BE49-F238E27FC236}">
+                <a16:creationId xmlns:a16="http://schemas.microsoft.com/office/drawing/2014/main" id="{2FBF3253-661F-48D3-9341-F76AD9D1659F}"/>
               </a:ext>
             </a:extLst>
           </p:cNvPr>
@@ -9907,7 +9967,7 @@
                 <a:latin typeface="Arial"/>
                 <a:ea typeface="Arial"/>
                 <a:cs typeface="Arial"/>
-                <a:hlinkClick xmlns:r="http://schemas.openxmlformats.org/officeDocument/2006/relationships" r:id="Reaea4c34f57f411a"/>
+                <a:hlinkClick xmlns:r="http://schemas.openxmlformats.org/officeDocument/2006/relationships" r:id="R29b7dc52f1b4493c"/>
               </a:rPr>
               <a:t>https://doi.org/10.1136/spcare-2024-004978</a:t>
             </a:r>
@@ -9916,10 +9976,10 @@
       </p:sp>
       <p:sp>
         <p:nvSpPr>
-          <p:cNvPr id="8" name="Reference 3 author">
-            <a:extLst xmlns:a="http://schemas.openxmlformats.org/drawingml/2006/main">
-              <a:ext uri="{FF2B5EF4-FFF2-40B4-BE49-F238E27FC236}">
-                <a16:creationId xmlns:a16="http://schemas.microsoft.com/office/drawing/2014/main" id="{F5EFFC9D-73E1-427C-ADC2-682ED66EC11A}"/>
+          <p:cNvPr id="10" name="Reference 3 author">
+            <a:extLst xmlns:a="http://schemas.openxmlformats.org/drawingml/2006/main">
+              <a:ext uri="{FF2B5EF4-FFF2-40B4-BE49-F238E27FC236}">
+                <a16:creationId xmlns:a16="http://schemas.microsoft.com/office/drawing/2014/main" id="{C76D97F5-C03E-46F2-BF8E-175793FF11A2}"/>
               </a:ext>
             </a:extLst>
           </p:cNvPr>
@@ -9973,10 +10033,10 @@
       </p:sp>
       <p:sp>
         <p:nvSpPr>
-          <p:cNvPr id="9" name="Reference 3 title">
-            <a:extLst xmlns:a="http://schemas.openxmlformats.org/drawingml/2006/main">
-              <a:ext uri="{FF2B5EF4-FFF2-40B4-BE49-F238E27FC236}">
-                <a16:creationId xmlns:a16="http://schemas.microsoft.com/office/drawing/2014/main" id="{590708BD-4F98-43F4-99B1-A63F443F206B}"/>
+          <p:cNvPr id="11" name="Reference 3 title">
+            <a:extLst xmlns:a="http://schemas.openxmlformats.org/drawingml/2006/main">
+              <a:ext uri="{FF2B5EF4-FFF2-40B4-BE49-F238E27FC236}">
+                <a16:creationId xmlns:a16="http://schemas.microsoft.com/office/drawing/2014/main" id="{2315F4F2-DB4C-4AC9-BF1F-E2865085A476}"/>
               </a:ext>
             </a:extLst>
           </p:cNvPr>
@@ -10022,7 +10082,7 @@
                 <a:latin typeface="Arial"/>
                 <a:ea typeface="Arial"/>
                 <a:cs typeface="Arial"/>
-                <a:hlinkClick xmlns:r="http://schemas.openxmlformats.org/officeDocument/2006/relationships" r:id="Ra2926c34e74e4f70"/>
+                <a:hlinkClick xmlns:r="http://schemas.openxmlformats.org/officeDocument/2006/relationships" r:id="R554027444ecc4dac"/>
               </a:rPr>
               <a:t>Early Goal of Care Discussions in Healthcare: A Survey Case Report on Benefits and Perceptions</a:t>
             </a:r>
@@ -10031,10 +10091,10 @@
       </p:sp>
       <p:sp>
         <p:nvSpPr>
-          <p:cNvPr id="10" name="Reference 3 link">
-            <a:extLst xmlns:a="http://schemas.openxmlformats.org/drawingml/2006/main">
-              <a:ext uri="{FF2B5EF4-FFF2-40B4-BE49-F238E27FC236}">
-                <a16:creationId xmlns:a16="http://schemas.microsoft.com/office/drawing/2014/main" id="{FF370709-16E0-4EC8-BC88-23B2C259FDEE}"/>
+          <p:cNvPr id="12" name="Reference 3 link">
+            <a:extLst xmlns:a="http://schemas.openxmlformats.org/drawingml/2006/main">
+              <a:ext uri="{FF2B5EF4-FFF2-40B4-BE49-F238E27FC236}">
+                <a16:creationId xmlns:a16="http://schemas.microsoft.com/office/drawing/2014/main" id="{93FE5718-7896-4E6A-80B4-55EBB13D110A}"/>
               </a:ext>
             </a:extLst>
           </p:cNvPr>
@@ -10080,7 +10140,7 @@
                 <a:latin typeface="Arial"/>
                 <a:ea typeface="Arial"/>
                 <a:cs typeface="Arial"/>
-                <a:hlinkClick xmlns:r="http://schemas.openxmlformats.org/officeDocument/2006/relationships" r:id="Rffead67030c94e05"/>
+                <a:hlinkClick xmlns:r="http://schemas.openxmlformats.org/officeDocument/2006/relationships" r:id="R5520ba3d31c6415d"/>
               </a:rPr>
               <a:t>https://doi.org/10.1016/j.jpainsymman.2024.02.030</a:t>
             </a:r>
@@ -10089,10 +10149,10 @@
       </p:sp>
       <p:sp>
         <p:nvSpPr>
-          <p:cNvPr id="11" name="Reference 4 author">
-            <a:extLst xmlns:a="http://schemas.openxmlformats.org/drawingml/2006/main">
-              <a:ext uri="{FF2B5EF4-FFF2-40B4-BE49-F238E27FC236}">
-                <a16:creationId xmlns:a16="http://schemas.microsoft.com/office/drawing/2014/main" id="{663CD61E-EB72-4254-8046-6DDD34C33355}"/>
+          <p:cNvPr id="13" name="Reference 4 author">
+            <a:extLst xmlns:a="http://schemas.openxmlformats.org/drawingml/2006/main">
+              <a:ext uri="{FF2B5EF4-FFF2-40B4-BE49-F238E27FC236}">
+                <a16:creationId xmlns:a16="http://schemas.microsoft.com/office/drawing/2014/main" id="{32BA84EE-300C-48CE-A22A-7571A7FDDAEB}"/>
               </a:ext>
             </a:extLst>
           </p:cNvPr>
@@ -10146,10 +10206,10 @@
       </p:sp>
       <p:sp>
         <p:nvSpPr>
-          <p:cNvPr id="12" name="Reference 4 title">
-            <a:extLst xmlns:a="http://schemas.openxmlformats.org/drawingml/2006/main">
-              <a:ext uri="{FF2B5EF4-FFF2-40B4-BE49-F238E27FC236}">
-                <a16:creationId xmlns:a16="http://schemas.microsoft.com/office/drawing/2014/main" id="{B83C0DD6-C3B4-444C-87CD-0EBE8F3E7A00}"/>
+          <p:cNvPr id="14" name="Reference 4 title">
+            <a:extLst xmlns:a="http://schemas.openxmlformats.org/drawingml/2006/main">
+              <a:ext uri="{FF2B5EF4-FFF2-40B4-BE49-F238E27FC236}">
+                <a16:creationId xmlns:a16="http://schemas.microsoft.com/office/drawing/2014/main" id="{E7E1390B-79DF-4113-9A6C-E822BFEF47F7}"/>
               </a:ext>
             </a:extLst>
           </p:cNvPr>
@@ -10195,7 +10255,7 @@
                 <a:latin typeface="Arial"/>
                 <a:ea typeface="Arial"/>
                 <a:cs typeface="Arial"/>
-                <a:hlinkClick xmlns:r="http://schemas.openxmlformats.org/officeDocument/2006/relationships" r:id="Rf5716dfb4c9141b3"/>
+                <a:hlinkClick xmlns:r="http://schemas.openxmlformats.org/officeDocument/2006/relationships" r:id="R4cc117fb0b804dd1"/>
               </a:rPr>
               <a:t>Initiating and Documenting Goals of Care Discussion in Patients with Advanced Pancreatic and Colorectal Cancers: A Quality Improvement Project in a Low Resource Setting</a:t>
             </a:r>
@@ -10204,10 +10264,10 @@
       </p:sp>
       <p:sp>
         <p:nvSpPr>
-          <p:cNvPr id="13" name="Reference 4 link">
-            <a:extLst xmlns:a="http://schemas.openxmlformats.org/drawingml/2006/main">
-              <a:ext uri="{FF2B5EF4-FFF2-40B4-BE49-F238E27FC236}">
-                <a16:creationId xmlns:a16="http://schemas.microsoft.com/office/drawing/2014/main" id="{8951B852-C6FA-4B8F-ADA2-C87C43048265}"/>
+          <p:cNvPr id="15" name="Reference 4 link">
+            <a:extLst xmlns:a="http://schemas.openxmlformats.org/drawingml/2006/main">
+              <a:ext uri="{FF2B5EF4-FFF2-40B4-BE49-F238E27FC236}">
+                <a16:creationId xmlns:a16="http://schemas.microsoft.com/office/drawing/2014/main" id="{6BC7A654-2AFB-4A9E-AE9D-8B0A78334239}"/>
               </a:ext>
             </a:extLst>
           </p:cNvPr>
@@ -10253,7 +10313,7 @@
                 <a:latin typeface="Arial"/>
                 <a:ea typeface="Arial"/>
                 <a:cs typeface="Arial"/>
-                <a:hlinkClick xmlns:r="http://schemas.openxmlformats.org/officeDocument/2006/relationships" r:id="R842c30e009724a9d"/>
+                <a:hlinkClick xmlns:r="http://schemas.openxmlformats.org/officeDocument/2006/relationships" r:id="R815cc88d79754926"/>
               </a:rPr>
               <a:t>https://doi.org/10.1177/26892820251392545</a:t>
             </a:r>
@@ -10262,10 +10322,10 @@
       </p:sp>
       <p:sp>
         <p:nvSpPr>
-          <p:cNvPr id="14" name="Reference 5 author">
-            <a:extLst xmlns:a="http://schemas.openxmlformats.org/drawingml/2006/main">
-              <a:ext uri="{FF2B5EF4-FFF2-40B4-BE49-F238E27FC236}">
-                <a16:creationId xmlns:a16="http://schemas.microsoft.com/office/drawing/2014/main" id="{0D9E08E6-072B-4B18-ABCE-4E076A99905A}"/>
+          <p:cNvPr id="16" name="Reference 5 author">
+            <a:extLst xmlns:a="http://schemas.openxmlformats.org/drawingml/2006/main">
+              <a:ext uri="{FF2B5EF4-FFF2-40B4-BE49-F238E27FC236}">
+                <a16:creationId xmlns:a16="http://schemas.microsoft.com/office/drawing/2014/main" id="{FF5CB745-D041-41CD-BF78-10E8008361D2}"/>
               </a:ext>
             </a:extLst>
           </p:cNvPr>
@@ -10319,10 +10379,10 @@
       </p:sp>
       <p:sp>
         <p:nvSpPr>
-          <p:cNvPr id="15" name="Reference 5 title">
-            <a:extLst xmlns:a="http://schemas.openxmlformats.org/drawingml/2006/main">
-              <a:ext uri="{FF2B5EF4-FFF2-40B4-BE49-F238E27FC236}">
-                <a16:creationId xmlns:a16="http://schemas.microsoft.com/office/drawing/2014/main" id="{3ECB0BBF-4B34-4CE1-8234-0434D60B301B}"/>
+          <p:cNvPr id="17" name="Reference 5 title">
+            <a:extLst xmlns:a="http://schemas.openxmlformats.org/drawingml/2006/main">
+              <a:ext uri="{FF2B5EF4-FFF2-40B4-BE49-F238E27FC236}">
+                <a16:creationId xmlns:a16="http://schemas.microsoft.com/office/drawing/2014/main" id="{FB25FF3E-2C87-44F5-9A10-1F4DDA899873}"/>
               </a:ext>
             </a:extLst>
           </p:cNvPr>
@@ -10368,7 +10428,7 @@
                 <a:latin typeface="Arial"/>
                 <a:ea typeface="Arial"/>
                 <a:cs typeface="Arial"/>
-                <a:hlinkClick xmlns:r="http://schemas.openxmlformats.org/officeDocument/2006/relationships" r:id="R01bab28c22aa4500"/>
+                <a:hlinkClick xmlns:r="http://schemas.openxmlformats.org/officeDocument/2006/relationships" r:id="R2d98ea2adcf5492e"/>
               </a:rPr>
               <a:t>73% urban Indians do not know about their right to make a living will, finds a survey</a:t>
             </a:r>
@@ -10377,10 +10437,10 @@
       </p:sp>
       <p:sp>
         <p:nvSpPr>
-          <p:cNvPr id="16" name="Reference 5 link">
-            <a:extLst xmlns:a="http://schemas.openxmlformats.org/drawingml/2006/main">
-              <a:ext uri="{FF2B5EF4-FFF2-40B4-BE49-F238E27FC236}">
-                <a16:creationId xmlns:a16="http://schemas.microsoft.com/office/drawing/2014/main" id="{6E4A6297-5D81-4862-AE4B-78BC092532EB}"/>
+          <p:cNvPr id="18" name="Reference 5 link">
+            <a:extLst xmlns:a="http://schemas.openxmlformats.org/drawingml/2006/main">
+              <a:ext uri="{FF2B5EF4-FFF2-40B4-BE49-F238E27FC236}">
+                <a16:creationId xmlns:a16="http://schemas.microsoft.com/office/drawing/2014/main" id="{462FC475-6C8E-4C1E-9FA8-5F1E22BFF081}"/>
               </a:ext>
             </a:extLst>
           </p:cNvPr>
@@ -10426,7 +10486,7 @@
                 <a:latin typeface="Arial"/>
                 <a:ea typeface="Arial"/>
                 <a:cs typeface="Arial"/>
-                <a:hlinkClick xmlns:r="http://schemas.openxmlformats.org/officeDocument/2006/relationships" r:id="R8c3da352a68240df"/>
+                <a:hlinkClick xmlns:r="http://schemas.openxmlformats.org/officeDocument/2006/relationships" r:id="R59ef83456d6341bc"/>
               </a:rPr>
               <a:t>https://scroll.in/article/925875/73-urban-indians-do-not-know-about-their-right-to-make-a-living-will-finds-a-survey</a:t>
             </a:r>
@@ -10435,10 +10495,10 @@
       </p:sp>
       <p:sp>
         <p:nvSpPr>
-          <p:cNvPr id="17" name="Reference 6 author">
-            <a:extLst xmlns:a="http://schemas.openxmlformats.org/drawingml/2006/main">
-              <a:ext uri="{FF2B5EF4-FFF2-40B4-BE49-F238E27FC236}">
-                <a16:creationId xmlns:a16="http://schemas.microsoft.com/office/drawing/2014/main" id="{462B4C30-1C25-48B9-B784-4E6CD57ECC66}"/>
+          <p:cNvPr id="19" name="Reference 6 author">
+            <a:extLst xmlns:a="http://schemas.openxmlformats.org/drawingml/2006/main">
+              <a:ext uri="{FF2B5EF4-FFF2-40B4-BE49-F238E27FC236}">
+                <a16:creationId xmlns:a16="http://schemas.microsoft.com/office/drawing/2014/main" id="{99E71B0E-97E8-49F6-9F8C-B091ED98417B}"/>
               </a:ext>
             </a:extLst>
           </p:cNvPr>
@@ -10492,10 +10552,10 @@
       </p:sp>
       <p:sp>
         <p:nvSpPr>
-          <p:cNvPr id="18" name="Reference 6 title">
-            <a:extLst xmlns:a="http://schemas.openxmlformats.org/drawingml/2006/main">
-              <a:ext uri="{FF2B5EF4-FFF2-40B4-BE49-F238E27FC236}">
-                <a16:creationId xmlns:a16="http://schemas.microsoft.com/office/drawing/2014/main" id="{4D1500BE-DF31-4798-B285-67F685F1AA64}"/>
+          <p:cNvPr id="20" name="Reference 6 title">
+            <a:extLst xmlns:a="http://schemas.openxmlformats.org/drawingml/2006/main">
+              <a:ext uri="{FF2B5EF4-FFF2-40B4-BE49-F238E27FC236}">
+                <a16:creationId xmlns:a16="http://schemas.microsoft.com/office/drawing/2014/main" id="{DC4807CF-BA93-452A-878C-165483D9E6FD}"/>
               </a:ext>
             </a:extLst>
           </p:cNvPr>
@@ -10541,7 +10601,7 @@
                 <a:latin typeface="Arial"/>
                 <a:ea typeface="Arial"/>
                 <a:cs typeface="Arial"/>
-                <a:hlinkClick xmlns:r="http://schemas.openxmlformats.org/officeDocument/2006/relationships" r:id="R21da459c7684438b"/>
+                <a:hlinkClick xmlns:r="http://schemas.openxmlformats.org/officeDocument/2006/relationships" r:id="Rc99b2de02fea4fcc"/>
               </a:rPr>
               <a:t>Knowledge and attitude towards advance directives for patients with terminal illnesses among doctors working in a tertiary care hospital</a:t>
             </a:r>
@@ -10550,10 +10610,10 @@
       </p:sp>
       <p:sp>
         <p:nvSpPr>
-          <p:cNvPr id="19" name="Reference 6 link">
-            <a:extLst xmlns:a="http://schemas.openxmlformats.org/drawingml/2006/main">
-              <a:ext uri="{FF2B5EF4-FFF2-40B4-BE49-F238E27FC236}">
-                <a16:creationId xmlns:a16="http://schemas.microsoft.com/office/drawing/2014/main" id="{76CB2FAD-3CE2-4E09-8C22-07135F201D24}"/>
+          <p:cNvPr id="21" name="Reference 6 link">
+            <a:extLst xmlns:a="http://schemas.openxmlformats.org/drawingml/2006/main">
+              <a:ext uri="{FF2B5EF4-FFF2-40B4-BE49-F238E27FC236}">
+                <a16:creationId xmlns:a16="http://schemas.microsoft.com/office/drawing/2014/main" id="{532CB3F1-AD4B-4163-9A10-C6F94AE88C56}"/>
               </a:ext>
             </a:extLst>
           </p:cNvPr>
@@ -10599,7 +10659,7 @@
                 <a:latin typeface="Arial"/>
                 <a:ea typeface="Arial"/>
                 <a:cs typeface="Arial"/>
-                <a:hlinkClick xmlns:r="http://schemas.openxmlformats.org/officeDocument/2006/relationships" r:id="R8d762100621a421f"/>
+                <a:hlinkClick xmlns:r="http://schemas.openxmlformats.org/officeDocument/2006/relationships" r:id="Re4c86d7427a44f06"/>
               </a:rPr>
               <a:t>https://doi.org/10.25259/NMJI_817_2023</a:t>
             </a:r>
@@ -10608,10 +10668,10 @@
       </p:sp>
       <p:sp>
         <p:nvSpPr>
-          <p:cNvPr id="20" name="Reference 7 author">
-            <a:extLst xmlns:a="http://schemas.openxmlformats.org/drawingml/2006/main">
-              <a:ext uri="{FF2B5EF4-FFF2-40B4-BE49-F238E27FC236}">
-                <a16:creationId xmlns:a16="http://schemas.microsoft.com/office/drawing/2014/main" id="{C32C221E-622D-4166-9FF6-4220291AB527}"/>
+          <p:cNvPr id="22" name="Reference 7 author">
+            <a:extLst xmlns:a="http://schemas.openxmlformats.org/drawingml/2006/main">
+              <a:ext uri="{FF2B5EF4-FFF2-40B4-BE49-F238E27FC236}">
+                <a16:creationId xmlns:a16="http://schemas.microsoft.com/office/drawing/2014/main" id="{A251DDDE-B9AB-47E6-A420-597CC700BFAB}"/>
               </a:ext>
             </a:extLst>
           </p:cNvPr>
@@ -10665,10 +10725,10 @@
       </p:sp>
       <p:sp>
         <p:nvSpPr>
-          <p:cNvPr id="21" name="Reference 7 title">
-            <a:extLst xmlns:a="http://schemas.openxmlformats.org/drawingml/2006/main">
-              <a:ext uri="{FF2B5EF4-FFF2-40B4-BE49-F238E27FC236}">
-                <a16:creationId xmlns:a16="http://schemas.microsoft.com/office/drawing/2014/main" id="{6EB3490B-A43F-4186-B607-A42C539925FD}"/>
+          <p:cNvPr id="23" name="Reference 7 title">
+            <a:extLst xmlns:a="http://schemas.openxmlformats.org/drawingml/2006/main">
+              <a:ext uri="{FF2B5EF4-FFF2-40B4-BE49-F238E27FC236}">
+                <a16:creationId xmlns:a16="http://schemas.microsoft.com/office/drawing/2014/main" id="{53D16A98-581E-4F8F-8321-6DFDCE834CCE}"/>
               </a:ext>
             </a:extLst>
           </p:cNvPr>
@@ -10714,7 +10774,7 @@
                 <a:latin typeface="Arial"/>
                 <a:ea typeface="Arial"/>
                 <a:cs typeface="Arial"/>
-                <a:hlinkClick xmlns:r="http://schemas.openxmlformats.org/officeDocument/2006/relationships" r:id="Rcc4d324e49b3433b"/>
+                <a:hlinkClick xmlns:r="http://schemas.openxmlformats.org/officeDocument/2006/relationships" r:id="R337869d4c1aa4b9e"/>
               </a:rPr>
               <a:t>Barriers and Facilitators to Advance Care Planning Implementation for Patients with Neurodegenerative Diseases among Indian Physicians: A Mixed-Methods Analysis</a:t>
             </a:r>
@@ -10723,10 +10783,10 @@
       </p:sp>
       <p:sp>
         <p:nvSpPr>
-          <p:cNvPr id="22" name="Reference 7 link">
-            <a:extLst xmlns:a="http://schemas.openxmlformats.org/drawingml/2006/main">
-              <a:ext uri="{FF2B5EF4-FFF2-40B4-BE49-F238E27FC236}">
-                <a16:creationId xmlns:a16="http://schemas.microsoft.com/office/drawing/2014/main" id="{D3DA45CF-54FD-4993-BC65-133C08285333}"/>
+          <p:cNvPr id="24" name="Reference 7 link">
+            <a:extLst xmlns:a="http://schemas.openxmlformats.org/drawingml/2006/main">
+              <a:ext uri="{FF2B5EF4-FFF2-40B4-BE49-F238E27FC236}">
+                <a16:creationId xmlns:a16="http://schemas.microsoft.com/office/drawing/2014/main" id="{B7B77071-8B9C-4248-AB3E-59A57113761A}"/>
               </a:ext>
             </a:extLst>
           </p:cNvPr>
@@ -10772,7 +10832,7 @@
                 <a:latin typeface="Arial"/>
                 <a:ea typeface="Arial"/>
                 <a:cs typeface="Arial"/>
-                <a:hlinkClick xmlns:r="http://schemas.openxmlformats.org/officeDocument/2006/relationships" r:id="R4e61801ea5c548d2"/>
+                <a:hlinkClick xmlns:r="http://schemas.openxmlformats.org/officeDocument/2006/relationships" r:id="R5919be9b485044c4"/>
               </a:rPr>
               <a:t>https://doi.org/10.1101/2025.10.17.25338242</a:t>
             </a:r>
@@ -10781,10 +10841,10 @@
       </p:sp>
       <p:sp>
         <p:nvSpPr>
-          <p:cNvPr id="23" name="Reference 8 author">
-            <a:extLst xmlns:a="http://schemas.openxmlformats.org/drawingml/2006/main">
-              <a:ext uri="{FF2B5EF4-FFF2-40B4-BE49-F238E27FC236}">
-                <a16:creationId xmlns:a16="http://schemas.microsoft.com/office/drawing/2014/main" id="{7A744B26-5940-4C9C-929D-5BAB91A4806A}"/>
+          <p:cNvPr id="25" name="Reference 8 author">
+            <a:extLst xmlns:a="http://schemas.openxmlformats.org/drawingml/2006/main">
+              <a:ext uri="{FF2B5EF4-FFF2-40B4-BE49-F238E27FC236}">
+                <a16:creationId xmlns:a16="http://schemas.microsoft.com/office/drawing/2014/main" id="{C4975B5C-C56D-4AD5-8E65-798E4F6A6D9E}"/>
               </a:ext>
             </a:extLst>
           </p:cNvPr>
@@ -10838,10 +10898,10 @@
       </p:sp>
       <p:sp>
         <p:nvSpPr>
-          <p:cNvPr id="24" name="Reference 8 title">
-            <a:extLst xmlns:a="http://schemas.openxmlformats.org/drawingml/2006/main">
-              <a:ext uri="{FF2B5EF4-FFF2-40B4-BE49-F238E27FC236}">
-                <a16:creationId xmlns:a16="http://schemas.microsoft.com/office/drawing/2014/main" id="{DCF2EF99-C2AC-456F-BDF4-0EA5C396F666}"/>
+          <p:cNvPr id="26" name="Reference 8 title">
+            <a:extLst xmlns:a="http://schemas.openxmlformats.org/drawingml/2006/main">
+              <a:ext uri="{FF2B5EF4-FFF2-40B4-BE49-F238E27FC236}">
+                <a16:creationId xmlns:a16="http://schemas.microsoft.com/office/drawing/2014/main" id="{244A1FCE-0B3C-46A4-A37D-5EA127F6DC34}"/>
               </a:ext>
             </a:extLst>
           </p:cNvPr>
@@ -10887,7 +10947,7 @@
                 <a:latin typeface="Arial"/>
                 <a:ea typeface="Arial"/>
                 <a:cs typeface="Arial"/>
-                <a:hlinkClick xmlns:r="http://schemas.openxmlformats.org/officeDocument/2006/relationships" r:id="Re5f4efbd76c84744"/>
+                <a:hlinkClick xmlns:r="http://schemas.openxmlformats.org/officeDocument/2006/relationships" r:id="Ra397577d3cf341a2"/>
               </a:rPr>
               <a:t>An Ethnographic Study of Barriers to Cancer Pain Management and Opioid Availability in India</a:t>
             </a:r>
@@ -10896,10 +10956,10 @@
       </p:sp>
       <p:sp>
         <p:nvSpPr>
-          <p:cNvPr id="25" name="Reference 8 link">
-            <a:extLst xmlns:a="http://schemas.openxmlformats.org/drawingml/2006/main">
-              <a:ext uri="{FF2B5EF4-FFF2-40B4-BE49-F238E27FC236}">
-                <a16:creationId xmlns:a16="http://schemas.microsoft.com/office/drawing/2014/main" id="{E950125E-49A5-406B-BA20-BEB45DFB81C2}"/>
+          <p:cNvPr id="27" name="Reference 8 link">
+            <a:extLst xmlns:a="http://schemas.openxmlformats.org/drawingml/2006/main">
+              <a:ext uri="{FF2B5EF4-FFF2-40B4-BE49-F238E27FC236}">
+                <a16:creationId xmlns:a16="http://schemas.microsoft.com/office/drawing/2014/main" id="{325B0C27-9E2B-4CA8-A3DB-80EA57E1C40E}"/>
               </a:ext>
             </a:extLst>
           </p:cNvPr>
@@ -10945,7 +11005,7 @@
                 <a:latin typeface="Arial"/>
                 <a:ea typeface="Arial"/>
                 <a:cs typeface="Arial"/>
-                <a:hlinkClick xmlns:r="http://schemas.openxmlformats.org/officeDocument/2006/relationships" r:id="Re7143ac7d8e44b72"/>
+                <a:hlinkClick xmlns:r="http://schemas.openxmlformats.org/officeDocument/2006/relationships" r:id="R5bb9e085a56442f1"/>
               </a:rPr>
               <a:t>https://doi.org/10.1634/theoncologist.2013-0435</a:t>
             </a:r>
@@ -10954,10 +11014,10 @@
       </p:sp>
       <p:sp>
         <p:nvSpPr>
-          <p:cNvPr id="26" name="Reference 9 author">
-            <a:extLst xmlns:a="http://schemas.openxmlformats.org/drawingml/2006/main">
-              <a:ext uri="{FF2B5EF4-FFF2-40B4-BE49-F238E27FC236}">
-                <a16:creationId xmlns:a16="http://schemas.microsoft.com/office/drawing/2014/main" id="{C1372F50-2F13-4EC5-BF40-C96D81950094}"/>
+          <p:cNvPr id="28" name="Reference 9 author">
+            <a:extLst xmlns:a="http://schemas.openxmlformats.org/drawingml/2006/main">
+              <a:ext uri="{FF2B5EF4-FFF2-40B4-BE49-F238E27FC236}">
+                <a16:creationId xmlns:a16="http://schemas.microsoft.com/office/drawing/2014/main" id="{E7979A23-1D43-4F3F-8D50-DBB64BD84B8A}"/>
               </a:ext>
             </a:extLst>
           </p:cNvPr>
@@ -11011,10 +11071,10 @@
       </p:sp>
       <p:sp>
         <p:nvSpPr>
-          <p:cNvPr id="27" name="Reference 9 title">
-            <a:extLst xmlns:a="http://schemas.openxmlformats.org/drawingml/2006/main">
-              <a:ext uri="{FF2B5EF4-FFF2-40B4-BE49-F238E27FC236}">
-                <a16:creationId xmlns:a16="http://schemas.microsoft.com/office/drawing/2014/main" id="{BF6ED5F0-1CD1-48AB-9158-BE0A771AB431}"/>
+          <p:cNvPr id="29" name="Reference 9 title">
+            <a:extLst xmlns:a="http://schemas.openxmlformats.org/drawingml/2006/main">
+              <a:ext uri="{FF2B5EF4-FFF2-40B4-BE49-F238E27FC236}">
+                <a16:creationId xmlns:a16="http://schemas.microsoft.com/office/drawing/2014/main" id="{713701DA-1269-48C6-8CBD-57E85D624787}"/>
               </a:ext>
             </a:extLst>
           </p:cNvPr>
@@ -11060,7 +11120,7 @@
                 <a:latin typeface="Arial"/>
                 <a:ea typeface="Arial"/>
                 <a:cs typeface="Arial"/>
-                <a:hlinkClick xmlns:r="http://schemas.openxmlformats.org/officeDocument/2006/relationships" r:id="Rcadefec2c7da4acb"/>
+                <a:hlinkClick xmlns:r="http://schemas.openxmlformats.org/officeDocument/2006/relationships" r:id="Rbeb1385177ad4367"/>
               </a:rPr>
               <a:t>Receipt of Psychosocial Care Among Cancer Survivors in the United States</a:t>
             </a:r>
@@ -11069,10 +11129,10 @@
       </p:sp>
       <p:sp>
         <p:nvSpPr>
-          <p:cNvPr id="28" name="Reference 9 link">
-            <a:extLst xmlns:a="http://schemas.openxmlformats.org/drawingml/2006/main">
-              <a:ext uri="{FF2B5EF4-FFF2-40B4-BE49-F238E27FC236}">
-                <a16:creationId xmlns:a16="http://schemas.microsoft.com/office/drawing/2014/main" id="{5EBBCBFC-6131-4E36-97AA-D16BDC524DA4}"/>
+          <p:cNvPr id="30" name="Reference 9 link">
+            <a:extLst xmlns:a="http://schemas.openxmlformats.org/drawingml/2006/main">
+              <a:ext uri="{FF2B5EF4-FFF2-40B4-BE49-F238E27FC236}">
+                <a16:creationId xmlns:a16="http://schemas.microsoft.com/office/drawing/2014/main" id="{023BFF9C-FF78-49E4-BD65-71C744E7C88D}"/>
               </a:ext>
             </a:extLst>
           </p:cNvPr>
@@ -11118,7 +11178,7 @@
                 <a:latin typeface="Arial"/>
                 <a:ea typeface="Arial"/>
                 <a:cs typeface="Arial"/>
-                <a:hlinkClick xmlns:r="http://schemas.openxmlformats.org/officeDocument/2006/relationships" r:id="R49f6bfdd1b4845fc"/>
+                <a:hlinkClick xmlns:r="http://schemas.openxmlformats.org/officeDocument/2006/relationships" r:id="R8584764cb0c64d3c"/>
               </a:rPr>
               <a:t>https://doi.org/10.1200/JCO.2012.46.2101</a:t>
             </a:r>

</xml_diff>

<commit_message>
Show the patient home and three sign-in roles in the Saathi deck
</commit_message>
<xml_diff>
--- a/submission/Saathi_Healthathon_Final.pptx
+++ b/submission/Saathi_Healthathon_Final.pptx
@@ -2,20 +2,20 @@
 <file path=ppt/presentation.xml><?xml version="1.0" encoding="utf-8"?>
 <p:presentation xmlns:p="http://schemas.openxmlformats.org/presentationml/2006/main">
   <p:sldMasterIdLst>
-    <p:sldMasterId xmlns:r="http://schemas.openxmlformats.org/officeDocument/2006/relationships" id="2147483648" r:id="R7447360e79e74cf9"/>
+    <p:sldMasterId xmlns:r="http://schemas.openxmlformats.org/officeDocument/2006/relationships" id="2147483648" r:id="R179ae768ea0b400c"/>
   </p:sldMasterIdLst>
   <p:notesMasterIdLst>
-    <p:notesMasterId xmlns:r="http://schemas.openxmlformats.org/officeDocument/2006/relationships" r:id="R2a7f1143416247cf"/>
+    <p:notesMasterId xmlns:r="http://schemas.openxmlformats.org/officeDocument/2006/relationships" r:id="Rf79ebac7195e44aa"/>
   </p:notesMasterIdLst>
   <p:sldIdLst>
-    <p:sldId xmlns:r="http://schemas.openxmlformats.org/officeDocument/2006/relationships" id="256" r:id="R473d67c8d11c4fb5"/>
-    <p:sldId xmlns:r="http://schemas.openxmlformats.org/officeDocument/2006/relationships" id="257" r:id="R1e4e2336af2c4c4b"/>
-    <p:sldId xmlns:r="http://schemas.openxmlformats.org/officeDocument/2006/relationships" id="258" r:id="R05d75bf406034e57"/>
-    <p:sldId xmlns:r="http://schemas.openxmlformats.org/officeDocument/2006/relationships" id="259" r:id="R9562f9f7e651428d"/>
-    <p:sldId xmlns:r="http://schemas.openxmlformats.org/officeDocument/2006/relationships" id="260" r:id="R70ad3b27d8444bfe"/>
-    <p:sldId xmlns:r="http://schemas.openxmlformats.org/officeDocument/2006/relationships" id="261" r:id="R72cf717420a14775"/>
-    <p:sldId xmlns:r="http://schemas.openxmlformats.org/officeDocument/2006/relationships" id="262" r:id="R7a182b31120c45ea"/>
-    <p:sldId xmlns:r="http://schemas.openxmlformats.org/officeDocument/2006/relationships" id="263" r:id="R5f5adecb63be488b"/>
+    <p:sldId xmlns:r="http://schemas.openxmlformats.org/officeDocument/2006/relationships" id="256" r:id="R4a7c2b4e74d745e7"/>
+    <p:sldId xmlns:r="http://schemas.openxmlformats.org/officeDocument/2006/relationships" id="257" r:id="R7bc417c98a524080"/>
+    <p:sldId xmlns:r="http://schemas.openxmlformats.org/officeDocument/2006/relationships" id="258" r:id="Rabe58e0939444e20"/>
+    <p:sldId xmlns:r="http://schemas.openxmlformats.org/officeDocument/2006/relationships" id="259" r:id="Rbc25a46361824dd6"/>
+    <p:sldId xmlns:r="http://schemas.openxmlformats.org/officeDocument/2006/relationships" id="260" r:id="R438f337bda9a4eed"/>
+    <p:sldId xmlns:r="http://schemas.openxmlformats.org/officeDocument/2006/relationships" id="261" r:id="R8c5ef62f1387490d"/>
+    <p:sldId xmlns:r="http://schemas.openxmlformats.org/officeDocument/2006/relationships" id="262" r:id="R1d9a479dcac441e6"/>
+    <p:sldId xmlns:r="http://schemas.openxmlformats.org/officeDocument/2006/relationships" id="263" r:id="Rcec1c45489b04266"/>
   </p:sldIdLst>
   <p:sldSz cx="12192000" cy="6858000"/>
   <p:notesSz cx="6858000" cy="9144000"/>
@@ -799,7 +799,7 @@
           <a:lstStyle xmlns:a="http://schemas.openxmlformats.org/drawingml/2006/main"/>
           <a:p xmlns:a="http://schemas.openxmlformats.org/drawingml/2006/main">
             <a:r>
-              <a:t>Illustrative family journey; Priya and Arjun are fictional names that make each handoff concrete. This is the broader intended family-support workflow, not a claim of completed rides, guaranteed stock, payments or a deployed financial-assistance system. Current browser features include the latest signed Care Note and patient/version QR, earlier versions, document passages, confirmed treatment dates, medicine and appointment plans, named family tasks, journaling and support discovery. Receipts, financial-help paperwork and caregiver-training handoffs are proposed supporting work, not connected financial services. Doctor reviews and signs first; patient reviews and signs the same version. The cover QR opens the app. Three current role choices are Patient, Family and Doctor; verified accounts and phone sharing remain to connect. Directory: Pallium India, https://palliumindia.org/clinics/telangana, lists home/inpatient/outpatient services and medicine availability, but a listing does not establish today's stock, oral formulation or a confirmed appointment. The family must call to confirm the prescribed medicine and service; no autonomous booking or treatment recommendation is shown. Caregiver support evidence: https://journals.plos.org/plosone/article?id=10.1371/journal.pone.0274770 supports information, training, practical and emotional support needs. Additional sources: both meeting transcripts and the user's 24 September feedback. Icons: Lucide https://lucide.dev/license, ISC/MIT, SVGs recoloured with unchanged paths; full license in submission/assets/2026-09-24-family/Lucide-LICENSE.txt.</a:t>
+              <a:t>Both images are actual Chrome captures of https://saathi.wedevit.in/home for this revision, saved as output/playwright/2026-09-24-saathi-patient-home.png and output/playwright/2026-09-24-saathi-three-role-login.png. The sign-in image is cropped inside PowerPoint to the original form; no UI has been redrawn. The patient image includes the complete home page, showing the latest Care Note, documents, Find support, My space, Calendar, the upcoming visit and medicine and family-help shortcuts. Meera and the other stored records are fictional. The three current role choices are Patient, Family and Doctor. Patient sign-in was exercised with a different arbitrary 14-digit value and opened the existing patient home. This checks the present format-only entry flow, not real ABHA authentication or permission to open another person's medical records. Verified accounts and sharing between phones remain to connect. This is the broader intended family-support workflow, not a claim of completed rides, guaranteed stock, payments or a deployed financial-assistance system. Patients and families can keep questions, records, confirmed treatment dates, medicine and appointment plans, named tasks, journal entries and support contacts together. Receipts, financial-help paperwork and caregiver-training handoffs remain proposed supporting work. The doctor reviews and signs first; the patient reviews and signs the same version. Directory: Pallium India, https://palliumindia.org/clinics/telangana, lists home/inpatient/outpatient services and medicine availability. The family must call to confirm the prescribed medicine and service; a listing does not establish today's stock, oral formulation or a booked appointment. Caregiver support evidence: https://journals.plos.org/plosone/article?id=10.1371/journal.pone.0274770 supports information, training, practical and emotional support needs. Additional sources: both meeting transcripts and the user's feedback.</a:t>
             </a:r>
           </a:p>
         </p:txBody>
@@ -1387,7 +1387,7 @@
   </p:cSld>
   <p:clrMap bg1="lt1" tx1="dk1" bg2="lt2" tx2="dk2" accent1="accent1" accent2="accent2" accent3="accent3" accent4="accent4" accent5="accent5" accent6="accent6" hlink="hlink" folHlink="folHlink"/>
   <p:sldLayoutIdLst>
-    <p:sldLayoutId xmlns:r="http://schemas.openxmlformats.org/officeDocument/2006/relationships" id="2147483649" r:id="R934c815e40354b52"/>
+    <p:sldLayoutId xmlns:r="http://schemas.openxmlformats.org/officeDocument/2006/relationships" id="2147483649" r:id="R0cca68611fc445c5"/>
   </p:sldLayoutIdLst>
   <p:txStyles>
     <p:titleStyle>
@@ -2144,10 +2144,10 @@
           <p:nvPr/>
         </p:nvPicPr>
         <p:blipFill>
-          <a:blip xmlns:r="http://schemas.openxmlformats.org/officeDocument/2006/relationships" xmlns:a="http://schemas.openxmlformats.org/drawingml/2006/main" r:embed="R30130442cec44730">
+          <a:blip xmlns:r="http://schemas.openxmlformats.org/officeDocument/2006/relationships" xmlns:a="http://schemas.openxmlformats.org/drawingml/2006/main" r:embed="Rbe1355cc630d4eab">
             <a:extLst>
               <a:ext uri="{96DAC541-7B7A-43D3-8B79-37D633B846F1}">
-                <asvg:svgBlip xmlns:asvg="http://schemas.microsoft.com/office/drawing/2016/SVG/main" r:embed="R6db39ec149734681"/>
+                <asvg:svgBlip xmlns:asvg="http://schemas.microsoft.com/office/drawing/2016/SVG/main" r:embed="R90e67966794544d0"/>
               </a:ext>
             </a:extLst>
           </a:blip>
@@ -2168,7 +2168,7 @@
           <p:cNvPr id="2" name="Brand">
             <a:extLst xmlns:a="http://schemas.openxmlformats.org/drawingml/2006/main">
               <a:ext uri="{FF2B5EF4-FFF2-40B4-BE49-F238E27FC236}">
-                <a16:creationId xmlns:a16="http://schemas.microsoft.com/office/drawing/2014/main" id="{7D8BB98D-71E9-40B2-97EE-3C37CDE4E968}"/>
+                <a16:creationId xmlns:a16="http://schemas.microsoft.com/office/drawing/2014/main" id="{E73AC438-A948-47D3-8ECE-4FE9CAC712ED}"/>
               </a:ext>
             </a:extLst>
           </p:cNvPr>
@@ -2225,7 +2225,7 @@
           <p:cNvPr id="3" name="Hindi name">
             <a:extLst xmlns:a="http://schemas.openxmlformats.org/drawingml/2006/main">
               <a:ext uri="{FF2B5EF4-FFF2-40B4-BE49-F238E27FC236}">
-                <a16:creationId xmlns:a16="http://schemas.microsoft.com/office/drawing/2014/main" id="{B35744F1-C926-4577-9635-2FB3FAC42CCA}"/>
+                <a16:creationId xmlns:a16="http://schemas.microsoft.com/office/drawing/2014/main" id="{EBDA7BAB-F470-4993-B58E-2D96FC44E0D0}"/>
               </a:ext>
             </a:extLst>
           </p:cNvPr>
@@ -2282,7 +2282,7 @@
           <p:cNvPr id="4" name="Name meaning">
             <a:extLst xmlns:a="http://schemas.openxmlformats.org/drawingml/2006/main">
               <a:ext uri="{FF2B5EF4-FFF2-40B4-BE49-F238E27FC236}">
-                <a16:creationId xmlns:a16="http://schemas.microsoft.com/office/drawing/2014/main" id="{A417DA08-C0FF-4931-BD24-81B4A5F6C97B}"/>
+                <a16:creationId xmlns:a16="http://schemas.microsoft.com/office/drawing/2014/main" id="{8BC25651-7E7C-45EF-B3BE-DB8BEDD04F81}"/>
               </a:ext>
             </a:extLst>
           </p:cNvPr>
@@ -2339,7 +2339,7 @@
           <p:cNvPr id="5" name="Purpose">
             <a:extLst xmlns:a="http://schemas.openxmlformats.org/drawingml/2006/main">
               <a:ext uri="{FF2B5EF4-FFF2-40B4-BE49-F238E27FC236}">
-                <a16:creationId xmlns:a16="http://schemas.microsoft.com/office/drawing/2014/main" id="{82610A93-5219-4391-A09F-23D2ADA0C7E2}"/>
+                <a16:creationId xmlns:a16="http://schemas.microsoft.com/office/drawing/2014/main" id="{29A037D6-D44B-4B2F-B1FE-646FC7AF0822}"/>
               </a:ext>
             </a:extLst>
           </p:cNvPr>
@@ -2400,7 +2400,7 @@
           <p:nvPr/>
         </p:nvPicPr>
         <p:blipFill>
-          <a:blip xmlns:r="http://schemas.openxmlformats.org/officeDocument/2006/relationships" xmlns:a="http://schemas.openxmlformats.org/drawingml/2006/main" r:embed="Rbbe0fd68a15b40a8"/>
+          <a:blip xmlns:r="http://schemas.openxmlformats.org/officeDocument/2006/relationships" xmlns:a="http://schemas.openxmlformats.org/drawingml/2006/main" r:embed="R7d6a6ec7559c4fa9"/>
           <a:stretch xmlns:a="http://schemas.openxmlformats.org/drawingml/2006/main"/>
         </p:blipFill>
         <p:spPr>
@@ -2418,7 +2418,7 @@
           <p:cNvPr id="7" name="Website link">
             <a:extLst xmlns:a="http://schemas.openxmlformats.org/drawingml/2006/main">
               <a:ext uri="{FF2B5EF4-FFF2-40B4-BE49-F238E27FC236}">
-                <a16:creationId xmlns:a16="http://schemas.microsoft.com/office/drawing/2014/main" id="{243B086D-E3C1-46E8-B1FE-7EFFA788748A}"/>
+                <a16:creationId xmlns:a16="http://schemas.microsoft.com/office/drawing/2014/main" id="{703DCBB2-2108-402A-BF11-3889B8ED1E43}"/>
               </a:ext>
             </a:extLst>
           </p:cNvPr>
@@ -2464,7 +2464,7 @@
                 <a:latin typeface="Arial"/>
                 <a:ea typeface="Arial"/>
                 <a:cs typeface="Arial"/>
-                <a:hlinkClick xmlns:r="http://schemas.openxmlformats.org/officeDocument/2006/relationships" r:id="R40707b338ac14922"/>
+                <a:hlinkClick xmlns:r="http://schemas.openxmlformats.org/officeDocument/2006/relationships" r:id="R7e13c9f304114f98"/>
               </a:rPr>
               <a:t>OPEN THE WEBSITE - saathi.wedevit.in</a:t>
             </a:r>
@@ -2480,10 +2480,10 @@
           <p:nvPr/>
         </p:nvPicPr>
         <p:blipFill>
-          <a:blip xmlns:r="http://schemas.openxmlformats.org/officeDocument/2006/relationships" xmlns:a="http://schemas.openxmlformats.org/drawingml/2006/main" r:embed="Rb1d10f65e03346ae">
+          <a:blip xmlns:r="http://schemas.openxmlformats.org/officeDocument/2006/relationships" xmlns:a="http://schemas.openxmlformats.org/drawingml/2006/main" r:embed="Re20caa07df4b49be">
             <a:extLst>
               <a:ext uri="{96DAC541-7B7A-43D3-8B79-37D633B846F1}">
-                <asvg:svgBlip xmlns:asvg="http://schemas.microsoft.com/office/drawing/2016/SVG/main" r:embed="R855ec724def8433b"/>
+                <asvg:svgBlip xmlns:asvg="http://schemas.microsoft.com/office/drawing/2016/SVG/main" r:embed="Re67fc7e3e47e46c0"/>
               </a:ext>
             </a:extLst>
           </a:blip>
@@ -2504,7 +2504,7 @@
           <p:cNvPr id="9" name="Repository link">
             <a:extLst xmlns:a="http://schemas.openxmlformats.org/drawingml/2006/main">
               <a:ext uri="{FF2B5EF4-FFF2-40B4-BE49-F238E27FC236}">
-                <a16:creationId xmlns:a16="http://schemas.microsoft.com/office/drawing/2014/main" id="{888D1162-997B-402E-9479-59AA371D2D3F}"/>
+                <a16:creationId xmlns:a16="http://schemas.microsoft.com/office/drawing/2014/main" id="{6DD2182E-ADE2-48E7-97DC-4E761BA3E1B6}"/>
               </a:ext>
             </a:extLst>
           </p:cNvPr>
@@ -2550,7 +2550,7 @@
                 <a:latin typeface="Arial"/>
                 <a:ea typeface="Arial"/>
                 <a:cs typeface="Arial"/>
-                <a:hlinkClick xmlns:r="http://schemas.openxmlformats.org/officeDocument/2006/relationships" r:id="R1cf8669fb36f4a02"/>
+                <a:hlinkClick xmlns:r="http://schemas.openxmlformats.org/officeDocument/2006/relationships" r:id="R9f82135b221c4ede"/>
               </a:rPr>
               <a:t>github.com/basithladdu/healthathon</a:t>
             </a:r>
@@ -2566,10 +2566,10 @@
           <p:nvPr/>
         </p:nvPicPr>
         <p:blipFill>
-          <a:blip xmlns:r="http://schemas.openxmlformats.org/officeDocument/2006/relationships" xmlns:a="http://schemas.openxmlformats.org/drawingml/2006/main" r:embed="R01496778073a4155">
+          <a:blip xmlns:r="http://schemas.openxmlformats.org/officeDocument/2006/relationships" xmlns:a="http://schemas.openxmlformats.org/drawingml/2006/main" r:embed="R03ae1f2f2e934d6e">
             <a:extLst>
               <a:ext uri="{96DAC541-7B7A-43D3-8B79-37D633B846F1}">
-                <asvg:svgBlip xmlns:asvg="http://schemas.microsoft.com/office/drawing/2016/SVG/main" r:embed="R6bdeb857882947ca"/>
+                <asvg:svgBlip xmlns:asvg="http://schemas.microsoft.com/office/drawing/2016/SVG/main" r:embed="R06c2c2e5a6604ea8"/>
               </a:ext>
             </a:extLst>
           </a:blip>
@@ -2590,7 +2590,7 @@
           <p:cNvPr id="11" name="Questions contact">
             <a:extLst xmlns:a="http://schemas.openxmlformats.org/drawingml/2006/main">
               <a:ext uri="{FF2B5EF4-FFF2-40B4-BE49-F238E27FC236}">
-                <a16:creationId xmlns:a16="http://schemas.microsoft.com/office/drawing/2014/main" id="{D5096E3E-02BD-4922-A834-769CD9F4CE03}"/>
+                <a16:creationId xmlns:a16="http://schemas.microsoft.com/office/drawing/2014/main" id="{B1DB5106-7798-4F2F-BE7F-8BAF2639DAC6}"/>
               </a:ext>
             </a:extLst>
           </p:cNvPr>
@@ -2636,7 +2636,7 @@
                 <a:latin typeface="Arial"/>
                 <a:ea typeface="Arial"/>
                 <a:cs typeface="Arial"/>
-                <a:hlinkClick xmlns:r="http://schemas.openxmlformats.org/officeDocument/2006/relationships" r:id="R1bd14870e96b474f"/>
+                <a:hlinkClick xmlns:r="http://schemas.openxmlformats.org/officeDocument/2006/relationships" r:id="R328d3167ee3e4ffe"/>
               </a:rPr>
               <a:t>Questions? Contact us</a:t>
             </a:r>
@@ -2648,7 +2648,7 @@
           <p:cNvPr id="12" name="WhatsApp link">
             <a:extLst xmlns:a="http://schemas.openxmlformats.org/drawingml/2006/main">
               <a:ext uri="{FF2B5EF4-FFF2-40B4-BE49-F238E27FC236}">
-                <a16:creationId xmlns:a16="http://schemas.microsoft.com/office/drawing/2014/main" id="{F29B7FF4-853F-4C2D-93C7-49E35BDAB82D}"/>
+                <a16:creationId xmlns:a16="http://schemas.microsoft.com/office/drawing/2014/main" id="{08A31515-BF4F-4E13-BEAB-F65C2DFEA956}"/>
               </a:ext>
             </a:extLst>
           </p:cNvPr>
@@ -2694,7 +2694,7 @@
                 <a:latin typeface="Arial"/>
                 <a:ea typeface="Arial"/>
                 <a:cs typeface="Arial"/>
-                <a:hlinkClick xmlns:r="http://schemas.openxmlformats.org/officeDocument/2006/relationships" r:id="R03acf4e8f9464bf5"/>
+                <a:hlinkClick xmlns:r="http://schemas.openxmlformats.org/officeDocument/2006/relationships" r:id="R83575541d5b94ba4"/>
               </a:rPr>
               <a:t>wa.me/919553321211</a:t>
             </a:r>
@@ -2706,7 +2706,7 @@
           <p:cNvPr id="13" name="">
             <a:extLst xmlns:a="http://schemas.openxmlformats.org/drawingml/2006/main">
               <a:ext uri="{FF2B5EF4-FFF2-40B4-BE49-F238E27FC236}">
-                <a16:creationId xmlns:a16="http://schemas.microsoft.com/office/drawing/2014/main" id="{8F02BC6F-7D6C-4893-9CA8-F94F01562388}"/>
+                <a16:creationId xmlns:a16="http://schemas.microsoft.com/office/drawing/2014/main" id="{5BCD4B02-6011-43A4-B835-C9D6AD09781F}"/>
               </a:ext>
             </a:extLst>
           </p:cNvPr>
@@ -2735,7 +2735,7 @@
           <p:cNvPr id="14" name="Team heading">
             <a:extLst xmlns:a="http://schemas.openxmlformats.org/drawingml/2006/main">
               <a:ext uri="{FF2B5EF4-FFF2-40B4-BE49-F238E27FC236}">
-                <a16:creationId xmlns:a16="http://schemas.microsoft.com/office/drawing/2014/main" id="{8B2786F9-8298-4A4D-8F76-5811A494C0B5}"/>
+                <a16:creationId xmlns:a16="http://schemas.microsoft.com/office/drawing/2014/main" id="{A63CC1D0-4A80-43A7-91F4-E830EB181814}"/>
               </a:ext>
             </a:extLst>
           </p:cNvPr>
@@ -2796,7 +2796,7 @@
           <p:nvPr/>
         </p:nvPicPr>
         <p:blipFill>
-          <a:blip xmlns:r="http://schemas.openxmlformats.org/officeDocument/2006/relationships" xmlns:a="http://schemas.openxmlformats.org/drawingml/2006/main" r:embed="R30c8e3e3b0b64483"/>
+          <a:blip xmlns:r="http://schemas.openxmlformats.org/officeDocument/2006/relationships" xmlns:a="http://schemas.openxmlformats.org/drawingml/2006/main" r:embed="R58f0fe82ae5c484d"/>
           <a:srcRect xmlns:a="http://schemas.openxmlformats.org/drawingml/2006/main" l="0" t="5331" r="0" b="5331"/>
           <a:stretch xmlns:a="http://schemas.openxmlformats.org/drawingml/2006/main">
             <a:fillRect l="0" t="0" r="0" b="0"/>
@@ -2817,7 +2817,7 @@
           <p:cNvPr id="16" name="Team member 1">
             <a:extLst xmlns:a="http://schemas.openxmlformats.org/drawingml/2006/main">
               <a:ext uri="{FF2B5EF4-FFF2-40B4-BE49-F238E27FC236}">
-                <a16:creationId xmlns:a16="http://schemas.microsoft.com/office/drawing/2014/main" id="{17D139CB-6B6A-46DD-BEA0-4AD57904352B}"/>
+                <a16:creationId xmlns:a16="http://schemas.microsoft.com/office/drawing/2014/main" id="{9E046D52-9809-43C5-A1A7-713B9376F9F6}"/>
               </a:ext>
             </a:extLst>
           </p:cNvPr>
@@ -2897,7 +2897,7 @@
           <p:cNvPr id="17" name="Team role 1">
             <a:extLst xmlns:a="http://schemas.openxmlformats.org/drawingml/2006/main">
               <a:ext uri="{FF2B5EF4-FFF2-40B4-BE49-F238E27FC236}">
-                <a16:creationId xmlns:a16="http://schemas.microsoft.com/office/drawing/2014/main" id="{FF8E6538-AB3C-4004-8B82-98A7C638832D}"/>
+                <a16:creationId xmlns:a16="http://schemas.microsoft.com/office/drawing/2014/main" id="{623B71B1-6774-4684-ABC1-DE607AD6310D}"/>
               </a:ext>
             </a:extLst>
           </p:cNvPr>
@@ -2958,7 +2958,7 @@
           <p:nvPr/>
         </p:nvPicPr>
         <p:blipFill>
-          <a:blip xmlns:r="http://schemas.openxmlformats.org/officeDocument/2006/relationships" xmlns:a="http://schemas.openxmlformats.org/drawingml/2006/main" r:embed="Rb64ce5be8d104cdb"/>
+          <a:blip xmlns:r="http://schemas.openxmlformats.org/officeDocument/2006/relationships" xmlns:a="http://schemas.openxmlformats.org/drawingml/2006/main" r:embed="R41c6c715c08546d4"/>
           <a:srcRect xmlns:a="http://schemas.openxmlformats.org/drawingml/2006/main" l="0" t="19104" r="0" b="19104"/>
           <a:stretch xmlns:a="http://schemas.openxmlformats.org/drawingml/2006/main">
             <a:fillRect l="0" t="0" r="0" b="0"/>
@@ -2979,7 +2979,7 @@
           <p:cNvPr id="19" name="Team member 2">
             <a:extLst xmlns:a="http://schemas.openxmlformats.org/drawingml/2006/main">
               <a:ext uri="{FF2B5EF4-FFF2-40B4-BE49-F238E27FC236}">
-                <a16:creationId xmlns:a16="http://schemas.microsoft.com/office/drawing/2014/main" id="{D6D80B80-36DA-46B7-AFDD-DB2F244B43A6}"/>
+                <a16:creationId xmlns:a16="http://schemas.microsoft.com/office/drawing/2014/main" id="{3A0A7ABE-4221-432A-89D4-B9076621ACEA}"/>
               </a:ext>
             </a:extLst>
           </p:cNvPr>
@@ -3059,7 +3059,7 @@
           <p:cNvPr id="20" name="Team role 2">
             <a:extLst xmlns:a="http://schemas.openxmlformats.org/drawingml/2006/main">
               <a:ext uri="{FF2B5EF4-FFF2-40B4-BE49-F238E27FC236}">
-                <a16:creationId xmlns:a16="http://schemas.microsoft.com/office/drawing/2014/main" id="{4F7BB01F-FA1E-4148-BF12-3DA7D310D880}"/>
+                <a16:creationId xmlns:a16="http://schemas.microsoft.com/office/drawing/2014/main" id="{82049A53-3C3F-4900-BFF4-2DA8E7099FAA}"/>
               </a:ext>
             </a:extLst>
           </p:cNvPr>
@@ -3116,7 +3116,7 @@
           <p:cNvPr id="21" name="Photo space for Dr Sharada&#10;Vinod Kutty">
             <a:extLst xmlns:a="http://schemas.openxmlformats.org/drawingml/2006/main">
               <a:ext uri="{FF2B5EF4-FFF2-40B4-BE49-F238E27FC236}">
-                <a16:creationId xmlns:a16="http://schemas.microsoft.com/office/drawing/2014/main" id="{9BEF968F-6892-4C04-B6DE-7EC37B8401C1}"/>
+                <a16:creationId xmlns:a16="http://schemas.microsoft.com/office/drawing/2014/main" id="{BAEBA162-7672-4DB3-BA35-B00D96050C8D}"/>
               </a:ext>
             </a:extLst>
           </p:cNvPr>
@@ -3148,7 +3148,7 @@
           <p:cNvPr id="22" name="Team member 3">
             <a:extLst xmlns:a="http://schemas.openxmlformats.org/drawingml/2006/main">
               <a:ext uri="{FF2B5EF4-FFF2-40B4-BE49-F238E27FC236}">
-                <a16:creationId xmlns:a16="http://schemas.microsoft.com/office/drawing/2014/main" id="{5F484A58-03EB-4C7C-90F6-F5C839072D85}"/>
+                <a16:creationId xmlns:a16="http://schemas.microsoft.com/office/drawing/2014/main" id="{9D244A0E-43AF-4646-9C02-8E0C1B2F7A2B}"/>
               </a:ext>
             </a:extLst>
           </p:cNvPr>
@@ -3228,7 +3228,7 @@
           <p:cNvPr id="23" name="Team role 3">
             <a:extLst xmlns:a="http://schemas.openxmlformats.org/drawingml/2006/main">
               <a:ext uri="{FF2B5EF4-FFF2-40B4-BE49-F238E27FC236}">
-                <a16:creationId xmlns:a16="http://schemas.microsoft.com/office/drawing/2014/main" id="{FDA3A752-6C63-4752-A865-1CE6BEA4B5E1}"/>
+                <a16:creationId xmlns:a16="http://schemas.microsoft.com/office/drawing/2014/main" id="{B6E1E55B-B000-4B14-BE6C-94F30931DA09}"/>
               </a:ext>
             </a:extLst>
           </p:cNvPr>
@@ -3285,7 +3285,7 @@
           <p:cNvPr id="24" name="Photo space for Dr Sujay&#10;Halkur Shankar">
             <a:extLst xmlns:a="http://schemas.openxmlformats.org/drawingml/2006/main">
               <a:ext uri="{FF2B5EF4-FFF2-40B4-BE49-F238E27FC236}">
-                <a16:creationId xmlns:a16="http://schemas.microsoft.com/office/drawing/2014/main" id="{008EFD23-BC25-420D-958F-D184536C2171}"/>
+                <a16:creationId xmlns:a16="http://schemas.microsoft.com/office/drawing/2014/main" id="{E9B2503A-3480-41E9-9624-45740A9F8814}"/>
               </a:ext>
             </a:extLst>
           </p:cNvPr>
@@ -3317,7 +3317,7 @@
           <p:cNvPr id="25" name="Team member 4">
             <a:extLst xmlns:a="http://schemas.openxmlformats.org/drawingml/2006/main">
               <a:ext uri="{FF2B5EF4-FFF2-40B4-BE49-F238E27FC236}">
-                <a16:creationId xmlns:a16="http://schemas.microsoft.com/office/drawing/2014/main" id="{A74A4506-9E2C-4B6D-9F27-FE690E11E476}"/>
+                <a16:creationId xmlns:a16="http://schemas.microsoft.com/office/drawing/2014/main" id="{7DC0589B-A412-473E-9C38-9A88E9D6DCF0}"/>
               </a:ext>
             </a:extLst>
           </p:cNvPr>
@@ -3397,7 +3397,7 @@
           <p:cNvPr id="26" name="Team role 4">
             <a:extLst xmlns:a="http://schemas.openxmlformats.org/drawingml/2006/main">
               <a:ext uri="{FF2B5EF4-FFF2-40B4-BE49-F238E27FC236}">
-                <a16:creationId xmlns:a16="http://schemas.microsoft.com/office/drawing/2014/main" id="{C0A09DC6-2F75-4F8F-97D3-22E69984DBFB}"/>
+                <a16:creationId xmlns:a16="http://schemas.microsoft.com/office/drawing/2014/main" id="{BD9887F1-1F3B-425C-879D-ACEFD1D7751D}"/>
               </a:ext>
             </a:extLst>
           </p:cNvPr>
@@ -3454,7 +3454,7 @@
           <p:cNvPr id="27" name="Photo space for Shirin Ayub">
             <a:extLst xmlns:a="http://schemas.openxmlformats.org/drawingml/2006/main">
               <a:ext uri="{FF2B5EF4-FFF2-40B4-BE49-F238E27FC236}">
-                <a16:creationId xmlns:a16="http://schemas.microsoft.com/office/drawing/2014/main" id="{43F5FE0D-9796-4332-9362-0758D111BF31}"/>
+                <a16:creationId xmlns:a16="http://schemas.microsoft.com/office/drawing/2014/main" id="{9363AD9F-C210-44F2-AC01-4B76AA9C86DD}"/>
               </a:ext>
             </a:extLst>
           </p:cNvPr>
@@ -3486,7 +3486,7 @@
           <p:cNvPr id="28" name="Team member 5">
             <a:extLst xmlns:a="http://schemas.openxmlformats.org/drawingml/2006/main">
               <a:ext uri="{FF2B5EF4-FFF2-40B4-BE49-F238E27FC236}">
-                <a16:creationId xmlns:a16="http://schemas.microsoft.com/office/drawing/2014/main" id="{49AEB020-69C0-4CE8-9A18-C7678629D237}"/>
+                <a16:creationId xmlns:a16="http://schemas.microsoft.com/office/drawing/2014/main" id="{97BEBD02-30E2-4EED-BC35-BDB5F0087ADE}"/>
               </a:ext>
             </a:extLst>
           </p:cNvPr>
@@ -3543,7 +3543,7 @@
           <p:cNvPr id="29" name="Team role 5">
             <a:extLst xmlns:a="http://schemas.openxmlformats.org/drawingml/2006/main">
               <a:ext uri="{FF2B5EF4-FFF2-40B4-BE49-F238E27FC236}">
-                <a16:creationId xmlns:a16="http://schemas.microsoft.com/office/drawing/2014/main" id="{E0655BEE-58E9-4703-9F94-96A6C372177E}"/>
+                <a16:creationId xmlns:a16="http://schemas.microsoft.com/office/drawing/2014/main" id="{2AF2123E-B348-4D46-ACCE-842953A3215A}"/>
               </a:ext>
             </a:extLst>
           </p:cNvPr>
@@ -3629,7 +3629,7 @@
           <p:cNvPr id="16" name="Slide title">
             <a:extLst xmlns:a="http://schemas.openxmlformats.org/drawingml/2006/main">
               <a:ext uri="{FF2B5EF4-FFF2-40B4-BE49-F238E27FC236}">
-                <a16:creationId xmlns:a16="http://schemas.microsoft.com/office/drawing/2014/main" id="{1CFDD4F0-1612-4405-9E52-D87EC8BBCC3D}"/>
+                <a16:creationId xmlns:a16="http://schemas.microsoft.com/office/drawing/2014/main" id="{11A7A922-F1DC-48F3-B637-1867F975709A}"/>
               </a:ext>
             </a:extLst>
           </p:cNvPr>
@@ -3690,7 +3690,7 @@
           <p:nvPr/>
         </p:nvPicPr>
         <p:blipFill>
-          <a:blip xmlns:r="http://schemas.openxmlformats.org/officeDocument/2006/relationships" xmlns:a="http://schemas.openxmlformats.org/drawingml/2006/main" r:embed="R0d796594cdf24e89"/>
+          <a:blip xmlns:r="http://schemas.openxmlformats.org/officeDocument/2006/relationships" xmlns:a="http://schemas.openxmlformats.org/drawingml/2006/main" r:embed="Rd3e67d9399bd4b63"/>
           <a:stretch xmlns:a="http://schemas.openxmlformats.org/drawingml/2006/main"/>
         </p:blipFill>
         <p:spPr>
@@ -3708,7 +3708,7 @@
           <p:cNvPr id="3" name="Care photo context">
             <a:extLst xmlns:a="http://schemas.openxmlformats.org/drawingml/2006/main">
               <a:ext uri="{FF2B5EF4-FFF2-40B4-BE49-F238E27FC236}">
-                <a16:creationId xmlns:a16="http://schemas.microsoft.com/office/drawing/2014/main" id="{3C31AFA2-9932-47BE-80FE-24A12041DF80}"/>
+                <a16:creationId xmlns:a16="http://schemas.microsoft.com/office/drawing/2014/main" id="{FF84EE67-B0A8-47A5-A76F-D136AA8C5719}"/>
               </a:ext>
             </a:extLst>
           </p:cNvPr>
@@ -3765,7 +3765,7 @@
           <p:cNvPr id="4" name="Illustrative patient">
             <a:extLst xmlns:a="http://schemas.openxmlformats.org/drawingml/2006/main">
               <a:ext uri="{FF2B5EF4-FFF2-40B4-BE49-F238E27FC236}">
-                <a16:creationId xmlns:a16="http://schemas.microsoft.com/office/drawing/2014/main" id="{1B150F19-6171-4355-B0AE-DEF10248DB78}"/>
+                <a16:creationId xmlns:a16="http://schemas.microsoft.com/office/drawing/2014/main" id="{FFE651C5-6BA3-441C-9F8A-4FE649E09182}"/>
               </a:ext>
             </a:extLst>
           </p:cNvPr>
@@ -3826,10 +3826,10 @@
           <p:nvPr/>
         </p:nvPicPr>
         <p:blipFill>
-          <a:blip xmlns:r="http://schemas.openxmlformats.org/officeDocument/2006/relationships" xmlns:a="http://schemas.openxmlformats.org/drawingml/2006/main" r:embed="R868efaa07c8f418a">
+          <a:blip xmlns:r="http://schemas.openxmlformats.org/officeDocument/2006/relationships" xmlns:a="http://schemas.openxmlformats.org/drawingml/2006/main" r:embed="R34e802462b4e421e">
             <a:extLst>
               <a:ext uri="{96DAC541-7B7A-43D3-8B79-37D633B846F1}">
-                <asvg:svgBlip xmlns:asvg="http://schemas.microsoft.com/office/drawing/2016/SVG/main" r:embed="R53f91e36ce3b45d1"/>
+                <asvg:svgBlip xmlns:asvg="http://schemas.microsoft.com/office/drawing/2016/SVG/main" r:embed="R06c0e1248169463b"/>
               </a:ext>
             </a:extLst>
           </a:blip>
@@ -3850,7 +3850,7 @@
           <p:cNvPr id="6" name="Story step 1">
             <a:extLst xmlns:a="http://schemas.openxmlformats.org/drawingml/2006/main">
               <a:ext uri="{FF2B5EF4-FFF2-40B4-BE49-F238E27FC236}">
-                <a16:creationId xmlns:a16="http://schemas.microsoft.com/office/drawing/2014/main" id="{8E1379A0-D813-47C1-BEBE-A38AF37F537F}"/>
+                <a16:creationId xmlns:a16="http://schemas.microsoft.com/office/drawing/2014/main" id="{83C5805E-3630-4AE8-A807-A5C9372295BC}"/>
               </a:ext>
             </a:extLst>
           </p:cNvPr>
@@ -3907,7 +3907,7 @@
           <p:cNvPr id="7" name="Story step 1 detail">
             <a:extLst xmlns:a="http://schemas.openxmlformats.org/drawingml/2006/main">
               <a:ext uri="{FF2B5EF4-FFF2-40B4-BE49-F238E27FC236}">
-                <a16:creationId xmlns:a16="http://schemas.microsoft.com/office/drawing/2014/main" id="{C062E55A-D813-4FB7-9B14-9BF4A855A8D9}"/>
+                <a16:creationId xmlns:a16="http://schemas.microsoft.com/office/drawing/2014/main" id="{A8FB3A5C-9FDE-404E-85FA-9346637A3832}"/>
               </a:ext>
             </a:extLst>
           </p:cNvPr>
@@ -3968,10 +3968,10 @@
           <p:nvPr/>
         </p:nvPicPr>
         <p:blipFill>
-          <a:blip xmlns:r="http://schemas.openxmlformats.org/officeDocument/2006/relationships" xmlns:a="http://schemas.openxmlformats.org/drawingml/2006/main" r:embed="R455a06312f8240ec">
+          <a:blip xmlns:r="http://schemas.openxmlformats.org/officeDocument/2006/relationships" xmlns:a="http://schemas.openxmlformats.org/drawingml/2006/main" r:embed="R6e749abb67784109">
             <a:extLst>
               <a:ext uri="{96DAC541-7B7A-43D3-8B79-37D633B846F1}">
-                <asvg:svgBlip xmlns:asvg="http://schemas.microsoft.com/office/drawing/2016/SVG/main" r:embed="Rb3c0b29c51874e24"/>
+                <asvg:svgBlip xmlns:asvg="http://schemas.microsoft.com/office/drawing/2016/SVG/main" r:embed="Rcef25f6aed5246bb"/>
               </a:ext>
             </a:extLst>
           </a:blip>
@@ -3992,7 +3992,7 @@
           <p:cNvPr id="9" name="Story step 2">
             <a:extLst xmlns:a="http://schemas.openxmlformats.org/drawingml/2006/main">
               <a:ext uri="{FF2B5EF4-FFF2-40B4-BE49-F238E27FC236}">
-                <a16:creationId xmlns:a16="http://schemas.microsoft.com/office/drawing/2014/main" id="{361BC88C-ED82-4C59-BBF5-4759B2DEAE3E}"/>
+                <a16:creationId xmlns:a16="http://schemas.microsoft.com/office/drawing/2014/main" id="{454958A1-80F4-4493-9ED3-9054DA7FEE25}"/>
               </a:ext>
             </a:extLst>
           </p:cNvPr>
@@ -4049,7 +4049,7 @@
           <p:cNvPr id="10" name="Story step 2 detail">
             <a:extLst xmlns:a="http://schemas.openxmlformats.org/drawingml/2006/main">
               <a:ext uri="{FF2B5EF4-FFF2-40B4-BE49-F238E27FC236}">
-                <a16:creationId xmlns:a16="http://schemas.microsoft.com/office/drawing/2014/main" id="{F1B32DBA-E93A-4AA9-883F-F83B7E4A91C5}"/>
+                <a16:creationId xmlns:a16="http://schemas.microsoft.com/office/drawing/2014/main" id="{84A65D98-213D-481C-9842-ACD70A993A00}"/>
               </a:ext>
             </a:extLst>
           </p:cNvPr>
@@ -4110,10 +4110,10 @@
           <p:nvPr/>
         </p:nvPicPr>
         <p:blipFill>
-          <a:blip xmlns:r="http://schemas.openxmlformats.org/officeDocument/2006/relationships" xmlns:a="http://schemas.openxmlformats.org/drawingml/2006/main" r:embed="R5bef7ed572c24424">
+          <a:blip xmlns:r="http://schemas.openxmlformats.org/officeDocument/2006/relationships" xmlns:a="http://schemas.openxmlformats.org/drawingml/2006/main" r:embed="Rd7ef592b79e54ef3">
             <a:extLst>
               <a:ext uri="{96DAC541-7B7A-43D3-8B79-37D633B846F1}">
-                <asvg:svgBlip xmlns:asvg="http://schemas.microsoft.com/office/drawing/2016/SVG/main" r:embed="Rc69cbbcaf2a84398"/>
+                <asvg:svgBlip xmlns:asvg="http://schemas.microsoft.com/office/drawing/2016/SVG/main" r:embed="R5bdb02f6d5c5482b"/>
               </a:ext>
             </a:extLst>
           </a:blip>
@@ -4134,7 +4134,7 @@
           <p:cNvPr id="12" name="Story step 3">
             <a:extLst xmlns:a="http://schemas.openxmlformats.org/drawingml/2006/main">
               <a:ext uri="{FF2B5EF4-FFF2-40B4-BE49-F238E27FC236}">
-                <a16:creationId xmlns:a16="http://schemas.microsoft.com/office/drawing/2014/main" id="{F7FA0BD4-A74B-4AEF-A4FC-4784A4825246}"/>
+                <a16:creationId xmlns:a16="http://schemas.microsoft.com/office/drawing/2014/main" id="{7406C37D-AAC2-45E2-B7A9-088505B35A40}"/>
               </a:ext>
             </a:extLst>
           </p:cNvPr>
@@ -4191,7 +4191,7 @@
           <p:cNvPr id="13" name="Story step 3 detail">
             <a:extLst xmlns:a="http://schemas.openxmlformats.org/drawingml/2006/main">
               <a:ext uri="{FF2B5EF4-FFF2-40B4-BE49-F238E27FC236}">
-                <a16:creationId xmlns:a16="http://schemas.microsoft.com/office/drawing/2014/main" id="{5A633429-4439-4A0F-891F-17169DB01DFA}"/>
+                <a16:creationId xmlns:a16="http://schemas.microsoft.com/office/drawing/2014/main" id="{320123CA-D13C-4D96-A0C8-F60A9B055BF8}"/>
               </a:ext>
             </a:extLst>
           </p:cNvPr>
@@ -4248,7 +4248,7 @@
           <p:cNvPr id="14" name="Shared record takeaway">
             <a:extLst xmlns:a="http://schemas.openxmlformats.org/drawingml/2006/main">
               <a:ext uri="{FF2B5EF4-FFF2-40B4-BE49-F238E27FC236}">
-                <a16:creationId xmlns:a16="http://schemas.microsoft.com/office/drawing/2014/main" id="{3DD853B7-226B-4910-B65F-F5DE8E1F4CF6}"/>
+                <a16:creationId xmlns:a16="http://schemas.microsoft.com/office/drawing/2014/main" id="{426C2484-F0D3-418D-9610-1149DE985AAB}"/>
               </a:ext>
             </a:extLst>
           </p:cNvPr>
@@ -4278,7 +4278,7 @@
           <p:cNvPr id="15" name="Closing thought">
             <a:extLst xmlns:a="http://schemas.openxmlformats.org/drawingml/2006/main">
               <a:ext uri="{FF2B5EF4-FFF2-40B4-BE49-F238E27FC236}">
-                <a16:creationId xmlns:a16="http://schemas.microsoft.com/office/drawing/2014/main" id="{32550E02-67E6-4839-AB5B-E984A392019D}"/>
+                <a16:creationId xmlns:a16="http://schemas.microsoft.com/office/drawing/2014/main" id="{F6E39BE8-1A03-4D7A-A977-A56176F96D9D}"/>
               </a:ext>
             </a:extLst>
           </p:cNvPr>
@@ -4371,7 +4371,7 @@
         </p:xfrm>
         <a:graphic xmlns:a="http://schemas.openxmlformats.org/drawingml/2006/main">
           <a:graphicData uri="http://schemas.openxmlformats.org/drawingml/2006/chart">
-            <c:chart xmlns:r="http://schemas.openxmlformats.org/officeDocument/2006/relationships" xmlns:c="http://schemas.openxmlformats.org/drawingml/2006/chart" r:id="Rfc11ca11897241c7"/>
+            <c:chart xmlns:r="http://schemas.openxmlformats.org/officeDocument/2006/relationships" xmlns:c="http://schemas.openxmlformats.org/drawingml/2006/chart" r:id="R913b9c9b099a4fb8"/>
           </a:graphicData>
         </a:graphic>
       </p:graphicFrame>
@@ -4380,7 +4380,7 @@
           <p:cNvPr id="15" name="Slide title">
             <a:extLst xmlns:a="http://schemas.openxmlformats.org/drawingml/2006/main">
               <a:ext uri="{FF2B5EF4-FFF2-40B4-BE49-F238E27FC236}">
-                <a16:creationId xmlns:a16="http://schemas.microsoft.com/office/drawing/2014/main" id="{E3D06F67-D825-4186-BC7C-2BFCBD0F4812}"/>
+                <a16:creationId xmlns:a16="http://schemas.microsoft.com/office/drawing/2014/main" id="{13947CDC-EFDB-4353-8E23-BC88C17E9A67}"/>
               </a:ext>
             </a:extLst>
           </p:cNvPr>
@@ -4437,7 +4437,7 @@
           <p:cNvPr id="16" name="Chennai evidence heading">
             <a:extLst xmlns:a="http://schemas.openxmlformats.org/drawingml/2006/main">
               <a:ext uri="{FF2B5EF4-FFF2-40B4-BE49-F238E27FC236}">
-                <a16:creationId xmlns:a16="http://schemas.microsoft.com/office/drawing/2014/main" id="{954B7C64-F3B8-4A61-ACA0-F47FE969FE51}"/>
+                <a16:creationId xmlns:a16="http://schemas.microsoft.com/office/drawing/2014/main" id="{DF20DB2A-5E27-40F8-8436-CB14D473A66F}"/>
               </a:ext>
             </a:extLst>
           </p:cNvPr>
@@ -4467,7 +4467,7 @@
           <p:cNvPr id="17" name="Chennai evidence explanation">
             <a:extLst xmlns:a="http://schemas.openxmlformats.org/drawingml/2006/main">
               <a:ext uri="{FF2B5EF4-FFF2-40B4-BE49-F238E27FC236}">
-                <a16:creationId xmlns:a16="http://schemas.microsoft.com/office/drawing/2014/main" id="{9D1B600D-F16E-46A2-AB4A-1716E3952F7A}"/>
+                <a16:creationId xmlns:a16="http://schemas.microsoft.com/office/drawing/2014/main" id="{44D3BBAE-949D-4EF9-9373-AC2683D5018F}"/>
               </a:ext>
             </a:extLst>
           </p:cNvPr>
@@ -4501,10 +4501,10 @@
           <p:nvPr/>
         </p:nvPicPr>
         <p:blipFill>
-          <a:blip xmlns:r="http://schemas.openxmlformats.org/officeDocument/2006/relationships" xmlns:a="http://schemas.openxmlformats.org/drawingml/2006/main" r:embed="R76163d06dfd549ee">
+          <a:blip xmlns:r="http://schemas.openxmlformats.org/officeDocument/2006/relationships" xmlns:a="http://schemas.openxmlformats.org/drawingml/2006/main" r:embed="R920f763b925442ba">
             <a:extLst>
               <a:ext uri="{96DAC541-7B7A-43D3-8B79-37D633B846F1}">
-                <asvg:svgBlip xmlns:asvg="http://schemas.microsoft.com/office/drawing/2016/SVG/main" r:embed="R0fcca0f54d2e4af7"/>
+                <asvg:svgBlip xmlns:asvg="http://schemas.microsoft.com/office/drawing/2016/SVG/main" r:embed="R79f0a532ba84428e"/>
               </a:ext>
             </a:extLst>
           </a:blip>
@@ -4525,7 +4525,7 @@
           <p:cNvPr id="19" name="Evidence 15.6 lakh">
             <a:extLst xmlns:a="http://schemas.openxmlformats.org/drawingml/2006/main">
               <a:ext uri="{FF2B5EF4-FFF2-40B4-BE49-F238E27FC236}">
-                <a16:creationId xmlns:a16="http://schemas.microsoft.com/office/drawing/2014/main" id="{92FB0AF2-2A13-4C06-B01E-2A2E268EC46A}"/>
+                <a16:creationId xmlns:a16="http://schemas.microsoft.com/office/drawing/2014/main" id="{1E0D3F00-149C-4E3B-A160-745E4FF732EA}"/>
               </a:ext>
             </a:extLst>
           </p:cNvPr>
@@ -4582,7 +4582,7 @@
           <p:cNvPr id="20" name="Evidence 15.6 lakh scope">
             <a:extLst xmlns:a="http://schemas.openxmlformats.org/drawingml/2006/main">
               <a:ext uri="{FF2B5EF4-FFF2-40B4-BE49-F238E27FC236}">
-                <a16:creationId xmlns:a16="http://schemas.microsoft.com/office/drawing/2014/main" id="{36A7E813-782E-4A2B-A2D3-067FED81A88C}"/>
+                <a16:creationId xmlns:a16="http://schemas.microsoft.com/office/drawing/2014/main" id="{6CDEA900-F524-4372-ACB9-F53F91FC444A}"/>
               </a:ext>
             </a:extLst>
           </p:cNvPr>
@@ -4639,7 +4639,7 @@
           <p:cNvPr id="21" name="Evidence 15.6 lakh source">
             <a:extLst xmlns:a="http://schemas.openxmlformats.org/drawingml/2006/main">
               <a:ext uri="{FF2B5EF4-FFF2-40B4-BE49-F238E27FC236}">
-                <a16:creationId xmlns:a16="http://schemas.microsoft.com/office/drawing/2014/main" id="{A15AC7CC-415E-4CB7-A3E9-172C2C671700}"/>
+                <a16:creationId xmlns:a16="http://schemas.microsoft.com/office/drawing/2014/main" id="{E7D3F050-0B7E-45BF-96C4-6D7AEC175C84}"/>
               </a:ext>
             </a:extLst>
           </p:cNvPr>
@@ -4685,7 +4685,7 @@
                 <a:latin typeface="Arial"/>
                 <a:ea typeface="Arial"/>
                 <a:cs typeface="Arial"/>
-                <a:hlinkClick xmlns:r="http://schemas.openxmlformats.org/officeDocument/2006/relationships" r:id="Rab6fa42c7df148e1"/>
+                <a:hlinkClick xmlns:r="http://schemas.openxmlformats.org/officeDocument/2006/relationships" r:id="Rab4c578e80334357"/>
               </a:rPr>
               <a:t>IARC, GLOBOCAN 2024</a:t>
             </a:r>
@@ -4701,10 +4701,10 @@
           <p:nvPr/>
         </p:nvPicPr>
         <p:blipFill>
-          <a:blip xmlns:r="http://schemas.openxmlformats.org/officeDocument/2006/relationships" xmlns:a="http://schemas.openxmlformats.org/drawingml/2006/main" r:embed="R350bef4171974d80">
+          <a:blip xmlns:r="http://schemas.openxmlformats.org/officeDocument/2006/relationships" xmlns:a="http://schemas.openxmlformats.org/drawingml/2006/main" r:embed="R4bff11e25d7d4488">
             <a:extLst>
               <a:ext uri="{96DAC541-7B7A-43D3-8B79-37D633B846F1}">
-                <asvg:svgBlip xmlns:asvg="http://schemas.microsoft.com/office/drawing/2016/SVG/main" r:embed="R101febf06eb64f36"/>
+                <asvg:svgBlip xmlns:asvg="http://schemas.microsoft.com/office/drawing/2016/SVG/main" r:embed="R4cf26de1dd9f4ec4"/>
               </a:ext>
             </a:extLst>
           </a:blip>
@@ -4725,7 +4725,7 @@
           <p:cNvPr id="23" name="Evidence 98.39%">
             <a:extLst xmlns:a="http://schemas.openxmlformats.org/drawingml/2006/main">
               <a:ext uri="{FF2B5EF4-FFF2-40B4-BE49-F238E27FC236}">
-                <a16:creationId xmlns:a16="http://schemas.microsoft.com/office/drawing/2014/main" id="{B2A01FD3-B982-4727-ADAD-BC1632A32DBC}"/>
+                <a16:creationId xmlns:a16="http://schemas.microsoft.com/office/drawing/2014/main" id="{6CE93032-0102-4554-A8C8-5FD06036B029}"/>
               </a:ext>
             </a:extLst>
           </p:cNvPr>
@@ -4782,7 +4782,7 @@
           <p:cNvPr id="24" name="Evidence 98.39% scope">
             <a:extLst xmlns:a="http://schemas.openxmlformats.org/drawingml/2006/main">
               <a:ext uri="{FF2B5EF4-FFF2-40B4-BE49-F238E27FC236}">
-                <a16:creationId xmlns:a16="http://schemas.microsoft.com/office/drawing/2014/main" id="{5AFD1190-0DC7-4073-8939-4F79FCF94917}"/>
+                <a16:creationId xmlns:a16="http://schemas.microsoft.com/office/drawing/2014/main" id="{32B58A39-88D9-42C5-B9F3-5BE22F46425F}"/>
               </a:ext>
             </a:extLst>
           </p:cNvPr>
@@ -4839,7 +4839,7 @@
           <p:cNvPr id="25" name="Evidence 98.39% source">
             <a:extLst xmlns:a="http://schemas.openxmlformats.org/drawingml/2006/main">
               <a:ext uri="{FF2B5EF4-FFF2-40B4-BE49-F238E27FC236}">
-                <a16:creationId xmlns:a16="http://schemas.microsoft.com/office/drawing/2014/main" id="{745457AD-3110-439C-AD2C-1A47EC756AB5}"/>
+                <a16:creationId xmlns:a16="http://schemas.microsoft.com/office/drawing/2014/main" id="{CA977751-1DB2-4171-9168-1158C8ADD222}"/>
               </a:ext>
             </a:extLst>
           </p:cNvPr>
@@ -4885,7 +4885,7 @@
                 <a:latin typeface="Arial"/>
                 <a:ea typeface="Arial"/>
                 <a:cs typeface="Arial"/>
-                <a:hlinkClick xmlns:r="http://schemas.openxmlformats.org/officeDocument/2006/relationships" r:id="R2410539b0c794485"/>
+                <a:hlinkClick xmlns:r="http://schemas.openxmlformats.org/officeDocument/2006/relationships" r:id="Rd799c1bf899c4352"/>
               </a:rPr>
               <a:t>Patil et al., 2024</a:t>
             </a:r>
@@ -4901,10 +4901,10 @@
           <p:nvPr/>
         </p:nvPicPr>
         <p:blipFill>
-          <a:blip xmlns:r="http://schemas.openxmlformats.org/officeDocument/2006/relationships" xmlns:a="http://schemas.openxmlformats.org/drawingml/2006/main" r:embed="Ra4b40fb512b14e4a">
+          <a:blip xmlns:r="http://schemas.openxmlformats.org/officeDocument/2006/relationships" xmlns:a="http://schemas.openxmlformats.org/drawingml/2006/main" r:embed="Rcc55cf1aedb44bb6">
             <a:extLst>
               <a:ext uri="{96DAC541-7B7A-43D3-8B79-37D633B846F1}">
-                <asvg:svgBlip xmlns:asvg="http://schemas.microsoft.com/office/drawing/2016/SVG/main" r:embed="R13eac5924e2f4bf5"/>
+                <asvg:svgBlip xmlns:asvg="http://schemas.microsoft.com/office/drawing/2016/SVG/main" r:embed="Rf12737ff2b1443c1"/>
               </a:ext>
             </a:extLst>
           </a:blip>
@@ -4925,7 +4925,7 @@
           <p:cNvPr id="27" name="Evidence 88%">
             <a:extLst xmlns:a="http://schemas.openxmlformats.org/drawingml/2006/main">
               <a:ext uri="{FF2B5EF4-FFF2-40B4-BE49-F238E27FC236}">
-                <a16:creationId xmlns:a16="http://schemas.microsoft.com/office/drawing/2014/main" id="{005D0C34-66DC-4FB4-B950-B1FA880E14B1}"/>
+                <a16:creationId xmlns:a16="http://schemas.microsoft.com/office/drawing/2014/main" id="{4E9CD7F5-B611-453D-8179-7B5DAF869144}"/>
               </a:ext>
             </a:extLst>
           </p:cNvPr>
@@ -4982,7 +4982,7 @@
           <p:cNvPr id="28" name="Evidence 88% scope">
             <a:extLst xmlns:a="http://schemas.openxmlformats.org/drawingml/2006/main">
               <a:ext uri="{FF2B5EF4-FFF2-40B4-BE49-F238E27FC236}">
-                <a16:creationId xmlns:a16="http://schemas.microsoft.com/office/drawing/2014/main" id="{AC881B58-7150-434C-A1EB-5F306CA5171A}"/>
+                <a16:creationId xmlns:a16="http://schemas.microsoft.com/office/drawing/2014/main" id="{6EC8E998-40F4-41E4-848A-E657D591F75C}"/>
               </a:ext>
             </a:extLst>
           </p:cNvPr>
@@ -5039,7 +5039,7 @@
           <p:cNvPr id="29" name="Evidence 88% source">
             <a:extLst xmlns:a="http://schemas.openxmlformats.org/drawingml/2006/main">
               <a:ext uri="{FF2B5EF4-FFF2-40B4-BE49-F238E27FC236}">
-                <a16:creationId xmlns:a16="http://schemas.microsoft.com/office/drawing/2014/main" id="{6F113E7D-96CA-42B9-B856-88A7A587B162}"/>
+                <a16:creationId xmlns:a16="http://schemas.microsoft.com/office/drawing/2014/main" id="{0B6494A8-2AAC-4AB9-8BB8-E42E05550CAE}"/>
               </a:ext>
             </a:extLst>
           </p:cNvPr>
@@ -5085,7 +5085,7 @@
                 <a:latin typeface="Arial"/>
                 <a:ea typeface="Arial"/>
                 <a:cs typeface="Arial"/>
-                <a:hlinkClick xmlns:r="http://schemas.openxmlformats.org/officeDocument/2006/relationships" r:id="R9742cc5a0ff44c36"/>
+                <a:hlinkClick xmlns:r="http://schemas.openxmlformats.org/officeDocument/2006/relationships" r:id="R5089ef7c1d744f08"/>
               </a:rPr>
               <a:t>IndiaSpend reporting; seven cities</a:t>
             </a:r>
@@ -5101,10 +5101,10 @@
           <p:nvPr/>
         </p:nvPicPr>
         <p:blipFill>
-          <a:blip xmlns:r="http://schemas.openxmlformats.org/officeDocument/2006/relationships" xmlns:a="http://schemas.openxmlformats.org/drawingml/2006/main" r:embed="Rdf58d6a0009a4a4f">
+          <a:blip xmlns:r="http://schemas.openxmlformats.org/officeDocument/2006/relationships" xmlns:a="http://schemas.openxmlformats.org/drawingml/2006/main" r:embed="Rddbd7cb823314ba5">
             <a:extLst>
               <a:ext uri="{96DAC541-7B7A-43D3-8B79-37D633B846F1}">
-                <asvg:svgBlip xmlns:asvg="http://schemas.microsoft.com/office/drawing/2016/SVG/main" r:embed="R8045cbd10a234fb2"/>
+                <asvg:svgBlip xmlns:asvg="http://schemas.microsoft.com/office/drawing/2016/SVG/main" r:embed="R9fc2583e67574187"/>
               </a:ext>
             </a:extLst>
           </a:blip>
@@ -5125,7 +5125,7 @@
           <p:cNvPr id="31" name="Evidence 11.5%">
             <a:extLst xmlns:a="http://schemas.openxmlformats.org/drawingml/2006/main">
               <a:ext uri="{FF2B5EF4-FFF2-40B4-BE49-F238E27FC236}">
-                <a16:creationId xmlns:a16="http://schemas.microsoft.com/office/drawing/2014/main" id="{8ED6D1AF-4FD4-4FF1-B0B2-76C8091AE6E8}"/>
+                <a16:creationId xmlns:a16="http://schemas.microsoft.com/office/drawing/2014/main" id="{514AB0BC-89CD-4642-9E56-8FFD985B36A8}"/>
               </a:ext>
             </a:extLst>
           </p:cNvPr>
@@ -5182,7 +5182,7 @@
           <p:cNvPr id="32" name="Evidence 11.5% scope">
             <a:extLst xmlns:a="http://schemas.openxmlformats.org/drawingml/2006/main">
               <a:ext uri="{FF2B5EF4-FFF2-40B4-BE49-F238E27FC236}">
-                <a16:creationId xmlns:a16="http://schemas.microsoft.com/office/drawing/2014/main" id="{89BB2C15-BF69-4FB7-B448-2230DED274D9}"/>
+                <a16:creationId xmlns:a16="http://schemas.microsoft.com/office/drawing/2014/main" id="{FD6D0EED-41EF-4DB9-8280-2C878C0E01B4}"/>
               </a:ext>
             </a:extLst>
           </p:cNvPr>
@@ -5239,7 +5239,7 @@
           <p:cNvPr id="33" name="Evidence 11.5% source">
             <a:extLst xmlns:a="http://schemas.openxmlformats.org/drawingml/2006/main">
               <a:ext uri="{FF2B5EF4-FFF2-40B4-BE49-F238E27FC236}">
-                <a16:creationId xmlns:a16="http://schemas.microsoft.com/office/drawing/2014/main" id="{0F1ED713-1D93-429E-AA85-CE6F2EF25194}"/>
+                <a16:creationId xmlns:a16="http://schemas.microsoft.com/office/drawing/2014/main" id="{9B8E6C53-3906-4A0A-8CFE-8E7F2EE6B42F}"/>
               </a:ext>
             </a:extLst>
           </p:cNvPr>
@@ -5285,7 +5285,7 @@
                 <a:latin typeface="Arial"/>
                 <a:ea typeface="Arial"/>
                 <a:cs typeface="Arial"/>
-                <a:hlinkClick xmlns:r="http://schemas.openxmlformats.org/officeDocument/2006/relationships" r:id="R4b894f2e3f5c4b27"/>
+                <a:hlinkClick xmlns:r="http://schemas.openxmlformats.org/officeDocument/2006/relationships" r:id="Rb053a137070f4f44"/>
               </a:rPr>
               <a:t>Jacob et al., CMC Vellore, 2026</a:t>
             </a:r>
@@ -5301,10 +5301,10 @@
           <p:nvPr/>
         </p:nvPicPr>
         <p:blipFill>
-          <a:blip xmlns:r="http://schemas.openxmlformats.org/officeDocument/2006/relationships" xmlns:a="http://schemas.openxmlformats.org/drawingml/2006/main" r:embed="R12881ede430f4726">
+          <a:blip xmlns:r="http://schemas.openxmlformats.org/officeDocument/2006/relationships" xmlns:a="http://schemas.openxmlformats.org/drawingml/2006/main" r:embed="R1f9e082886864a11">
             <a:extLst>
               <a:ext uri="{96DAC541-7B7A-43D3-8B79-37D633B846F1}">
-                <asvg:svgBlip xmlns:asvg="http://schemas.microsoft.com/office/drawing/2016/SVG/main" r:embed="R36f984ec41054231"/>
+                <asvg:svgBlip xmlns:asvg="http://schemas.microsoft.com/office/drawing/2016/SVG/main" r:embed="Rc9bae1b679b64aa3"/>
               </a:ext>
             </a:extLst>
           </a:blip>
@@ -5325,7 +5325,7 @@
           <p:cNvPr id="35" name="QI measure">
             <a:extLst xmlns:a="http://schemas.openxmlformats.org/drawingml/2006/main">
               <a:ext uri="{FF2B5EF4-FFF2-40B4-BE49-F238E27FC236}">
-                <a16:creationId xmlns:a16="http://schemas.microsoft.com/office/drawing/2014/main" id="{7AD8B5F7-B2A6-4576-866E-1F8DECA16D30}"/>
+                <a16:creationId xmlns:a16="http://schemas.microsoft.com/office/drawing/2014/main" id="{E4494B7E-9A16-4DBC-B6A4-FCDB9CB609E3}"/>
               </a:ext>
             </a:extLst>
           </p:cNvPr>
@@ -5382,7 +5382,7 @@
           <p:cNvPr id="36" name="QI finding">
             <a:extLst xmlns:a="http://schemas.openxmlformats.org/drawingml/2006/main">
               <a:ext uri="{FF2B5EF4-FFF2-40B4-BE49-F238E27FC236}">
-                <a16:creationId xmlns:a16="http://schemas.microsoft.com/office/drawing/2014/main" id="{DCE568A7-E3A8-4031-A14A-287D4A82241A}"/>
+                <a16:creationId xmlns:a16="http://schemas.microsoft.com/office/drawing/2014/main" id="{E71F5A69-FC3A-48C3-BCBC-CB252287AB3F}"/>
               </a:ext>
             </a:extLst>
           </p:cNvPr>
@@ -5439,7 +5439,7 @@
           <p:cNvPr id="37" name="QI scope">
             <a:extLst xmlns:a="http://schemas.openxmlformats.org/drawingml/2006/main">
               <a:ext uri="{FF2B5EF4-FFF2-40B4-BE49-F238E27FC236}">
-                <a16:creationId xmlns:a16="http://schemas.microsoft.com/office/drawing/2014/main" id="{7795C86D-8501-4262-8E75-39804073BACC}"/>
+                <a16:creationId xmlns:a16="http://schemas.microsoft.com/office/drawing/2014/main" id="{93D39431-A01C-4349-8221-3A0CF1CD05D3}"/>
               </a:ext>
             </a:extLst>
           </p:cNvPr>
@@ -5496,7 +5496,7 @@
           <p:cNvPr id="38" name="QI source">
             <a:extLst xmlns:a="http://schemas.openxmlformats.org/drawingml/2006/main">
               <a:ext uri="{FF2B5EF4-FFF2-40B4-BE49-F238E27FC236}">
-                <a16:creationId xmlns:a16="http://schemas.microsoft.com/office/drawing/2014/main" id="{F3710DA7-F888-4945-80C1-1481B5C9B691}"/>
+                <a16:creationId xmlns:a16="http://schemas.microsoft.com/office/drawing/2014/main" id="{C23E94AB-CFED-4A30-B468-1C1DA1A42A56}"/>
               </a:ext>
             </a:extLst>
           </p:cNvPr>
@@ -5542,7 +5542,7 @@
                 <a:latin typeface="Arial"/>
                 <a:ea typeface="Arial"/>
                 <a:cs typeface="Arial"/>
-                <a:hlinkClick xmlns:r="http://schemas.openxmlformats.org/officeDocument/2006/relationships" r:id="Rdaf3af87ee454c98"/>
+                <a:hlinkClick xmlns:r="http://schemas.openxmlformats.org/officeDocument/2006/relationships" r:id="R444c0cc6359745f8"/>
               </a:rPr>
               <a:t>Thangasamy et al., 2025</a:t>
             </a:r>
@@ -5554,7 +5554,7 @@
           <p:cNvPr id="39" name="Evidence boundary">
             <a:extLst xmlns:a="http://schemas.openxmlformats.org/drawingml/2006/main">
               <a:ext uri="{FF2B5EF4-FFF2-40B4-BE49-F238E27FC236}">
-                <a16:creationId xmlns:a16="http://schemas.microsoft.com/office/drawing/2014/main" id="{A4754E71-FCB7-481D-A0DD-89A8894892A6}"/>
+                <a16:creationId xmlns:a16="http://schemas.microsoft.com/office/drawing/2014/main" id="{6ED18324-044A-463B-BCFF-492C9AFFDEFF}"/>
               </a:ext>
             </a:extLst>
           </p:cNvPr>
@@ -5640,7 +5640,7 @@
           <p:cNvPr id="14" name="Slide title">
             <a:extLst xmlns:a="http://schemas.openxmlformats.org/drawingml/2006/main">
               <a:ext uri="{FF2B5EF4-FFF2-40B4-BE49-F238E27FC236}">
-                <a16:creationId xmlns:a16="http://schemas.microsoft.com/office/drawing/2014/main" id="{7A5F87DC-C2FB-4970-BA5E-C7E6470A1B65}"/>
+                <a16:creationId xmlns:a16="http://schemas.microsoft.com/office/drawing/2014/main" id="{7A2E1FB1-0E42-4360-ACD8-FB011EEFE95F}"/>
               </a:ext>
             </a:extLst>
           </p:cNvPr>
@@ -5697,7 +5697,7 @@
           <p:cNvPr id="2" name="Human review">
             <a:extLst xmlns:a="http://schemas.openxmlformats.org/drawingml/2006/main">
               <a:ext uri="{FF2B5EF4-FFF2-40B4-BE49-F238E27FC236}">
-                <a16:creationId xmlns:a16="http://schemas.microsoft.com/office/drawing/2014/main" id="{5ABDF0AC-466E-43A1-8AC7-A434B7C605BE}"/>
+                <a16:creationId xmlns:a16="http://schemas.microsoft.com/office/drawing/2014/main" id="{984C3DBF-75F1-4D9A-9A72-C3DD39288085}"/>
               </a:ext>
             </a:extLst>
           </p:cNvPr>
@@ -5758,7 +5758,7 @@
           <p:nvPr/>
         </p:nvPicPr>
         <p:blipFill>
-          <a:blip xmlns:r="http://schemas.openxmlformats.org/officeDocument/2006/relationships" xmlns:a="http://schemas.openxmlformats.org/drawingml/2006/main" r:embed="R4d9c9e85d50f48c7"/>
+          <a:blip xmlns:r="http://schemas.openxmlformats.org/officeDocument/2006/relationships" xmlns:a="http://schemas.openxmlformats.org/drawingml/2006/main" r:embed="R42288b82276e45d2"/>
           <a:stretch xmlns:a="http://schemas.openxmlformats.org/drawingml/2006/main"/>
         </p:blipFill>
         <p:spPr>
@@ -5776,7 +5776,7 @@
           <p:cNvPr id="4" name="Source traceability">
             <a:extLst xmlns:a="http://schemas.openxmlformats.org/drawingml/2006/main">
               <a:ext uri="{FF2B5EF4-FFF2-40B4-BE49-F238E27FC236}">
-                <a16:creationId xmlns:a16="http://schemas.microsoft.com/office/drawing/2014/main" id="{38C27635-6E5F-4A60-8B14-08D13811EAAD}"/>
+                <a16:creationId xmlns:a16="http://schemas.microsoft.com/office/drawing/2014/main" id="{F08467FF-51A5-4489-8B8F-45BDD55A1746}"/>
               </a:ext>
             </a:extLst>
           </p:cNvPr>
@@ -5833,7 +5833,7 @@
           <p:cNvPr id="5" name="Proposed voice provider">
             <a:extLst xmlns:a="http://schemas.openxmlformats.org/drawingml/2006/main">
               <a:ext uri="{FF2B5EF4-FFF2-40B4-BE49-F238E27FC236}">
-                <a16:creationId xmlns:a16="http://schemas.microsoft.com/office/drawing/2014/main" id="{E54ADEE8-DFE6-44FC-A19E-0BD4BA166643}"/>
+                <a16:creationId xmlns:a16="http://schemas.microsoft.com/office/drawing/2014/main" id="{7A759568-FC1C-4D90-B802-CE2B6514E9F4}"/>
               </a:ext>
             </a:extLst>
           </p:cNvPr>
@@ -5879,7 +5879,7 @@
                 <a:latin typeface="Arial"/>
                 <a:ea typeface="Arial"/>
                 <a:cs typeface="Arial"/>
-                <a:hlinkClick xmlns:r="http://schemas.openxmlformats.org/officeDocument/2006/relationships" r:id="R4b5b00a57e484bcd"/>
+                <a:hlinkClick xmlns:r="http://schemas.openxmlformats.org/officeDocument/2006/relationships" r:id="R2ee9c6937c7046b1"/>
               </a:rPr>
               <a:t>Planned with Sarvam AI: Indian-language speech, translation and read-aloud.</a:t>
             </a:r>
@@ -5891,7 +5891,7 @@
           <p:cNvPr id="6" name="AI step 1">
             <a:extLst xmlns:a="http://schemas.openxmlformats.org/drawingml/2006/main">
               <a:ext uri="{FF2B5EF4-FFF2-40B4-BE49-F238E27FC236}">
-                <a16:creationId xmlns:a16="http://schemas.microsoft.com/office/drawing/2014/main" id="{2F62543C-E6A3-45C8-9D7C-00BEDEE32EBB}"/>
+                <a16:creationId xmlns:a16="http://schemas.microsoft.com/office/drawing/2014/main" id="{8825B2B9-ABB2-4B77-94C8-354A81DE411C}"/>
               </a:ext>
             </a:extLst>
           </p:cNvPr>
@@ -5948,7 +5948,7 @@
           <p:cNvPr id="7" name="AI step 1 detail">
             <a:extLst xmlns:a="http://schemas.openxmlformats.org/drawingml/2006/main">
               <a:ext uri="{FF2B5EF4-FFF2-40B4-BE49-F238E27FC236}">
-                <a16:creationId xmlns:a16="http://schemas.microsoft.com/office/drawing/2014/main" id="{A371CA76-71CA-48BE-A9A6-D0CBF700EB09}"/>
+                <a16:creationId xmlns:a16="http://schemas.microsoft.com/office/drawing/2014/main" id="{5FE7B7F3-F5AA-49F3-8522-D6007326250D}"/>
               </a:ext>
             </a:extLst>
           </p:cNvPr>
@@ -6005,7 +6005,7 @@
           <p:cNvPr id="8" name="AI step 2">
             <a:extLst xmlns:a="http://schemas.openxmlformats.org/drawingml/2006/main">
               <a:ext uri="{FF2B5EF4-FFF2-40B4-BE49-F238E27FC236}">
-                <a16:creationId xmlns:a16="http://schemas.microsoft.com/office/drawing/2014/main" id="{7041D8B0-48C2-40E5-A06D-FF74FC6E974F}"/>
+                <a16:creationId xmlns:a16="http://schemas.microsoft.com/office/drawing/2014/main" id="{0582A7B6-AE3E-492A-A4B2-B8C622484F40}"/>
               </a:ext>
             </a:extLst>
           </p:cNvPr>
@@ -6062,7 +6062,7 @@
           <p:cNvPr id="9" name="AI step 2 detail">
             <a:extLst xmlns:a="http://schemas.openxmlformats.org/drawingml/2006/main">
               <a:ext uri="{FF2B5EF4-FFF2-40B4-BE49-F238E27FC236}">
-                <a16:creationId xmlns:a16="http://schemas.microsoft.com/office/drawing/2014/main" id="{053C8040-8DE7-4235-BA54-B05347374194}"/>
+                <a16:creationId xmlns:a16="http://schemas.microsoft.com/office/drawing/2014/main" id="{B61D7E8E-4D5A-4C0E-8FE3-498F0C4082A6}"/>
               </a:ext>
             </a:extLst>
           </p:cNvPr>
@@ -6119,7 +6119,7 @@
           <p:cNvPr id="10" name="AI step 3">
             <a:extLst xmlns:a="http://schemas.openxmlformats.org/drawingml/2006/main">
               <a:ext uri="{FF2B5EF4-FFF2-40B4-BE49-F238E27FC236}">
-                <a16:creationId xmlns:a16="http://schemas.microsoft.com/office/drawing/2014/main" id="{767D801E-163D-4127-AEDD-E1B6AAEB669D}"/>
+                <a16:creationId xmlns:a16="http://schemas.microsoft.com/office/drawing/2014/main" id="{B7916987-8A88-42A7-A4FD-5DB0AE154E94}"/>
               </a:ext>
             </a:extLst>
           </p:cNvPr>
@@ -6176,7 +6176,7 @@
           <p:cNvPr id="11" name="AI step 3 detail">
             <a:extLst xmlns:a="http://schemas.openxmlformats.org/drawingml/2006/main">
               <a:ext uri="{FF2B5EF4-FFF2-40B4-BE49-F238E27FC236}">
-                <a16:creationId xmlns:a16="http://schemas.microsoft.com/office/drawing/2014/main" id="{1AC5BC56-6C7F-4158-9E8A-B7A55BFA3D58}"/>
+                <a16:creationId xmlns:a16="http://schemas.microsoft.com/office/drawing/2014/main" id="{BA743D06-0EDC-4B2E-987C-0FDE1068CC79}"/>
               </a:ext>
             </a:extLst>
           </p:cNvPr>
@@ -6233,7 +6233,7 @@
           <p:cNvPr id="12" name="AI step 4">
             <a:extLst xmlns:a="http://schemas.openxmlformats.org/drawingml/2006/main">
               <a:ext uri="{FF2B5EF4-FFF2-40B4-BE49-F238E27FC236}">
-                <a16:creationId xmlns:a16="http://schemas.microsoft.com/office/drawing/2014/main" id="{1A748BDD-AA86-4B82-9E6D-F98040983E2C}"/>
+                <a16:creationId xmlns:a16="http://schemas.microsoft.com/office/drawing/2014/main" id="{7826E4A5-4B60-46C5-9D34-AA009BD8001A}"/>
               </a:ext>
             </a:extLst>
           </p:cNvPr>
@@ -6290,7 +6290,7 @@
           <p:cNvPr id="13" name="AI step 4 detail">
             <a:extLst xmlns:a="http://schemas.openxmlformats.org/drawingml/2006/main">
               <a:ext uri="{FF2B5EF4-FFF2-40B4-BE49-F238E27FC236}">
-                <a16:creationId xmlns:a16="http://schemas.microsoft.com/office/drawing/2014/main" id="{80762F6B-BD17-4C9A-B8F9-30730B31BEC7}"/>
+                <a16:creationId xmlns:a16="http://schemas.microsoft.com/office/drawing/2014/main" id="{28B90533-8EC2-4453-9390-E202F350E4AB}"/>
               </a:ext>
             </a:extLst>
           </p:cNvPr>
@@ -6376,7 +6376,7 @@
           <p:cNvPr id="11" name="Slide title">
             <a:extLst xmlns:a="http://schemas.openxmlformats.org/drawingml/2006/main">
               <a:ext uri="{FF2B5EF4-FFF2-40B4-BE49-F238E27FC236}">
-                <a16:creationId xmlns:a16="http://schemas.microsoft.com/office/drawing/2014/main" id="{30799EEE-135F-4275-BE8D-95F9C801EB56}"/>
+                <a16:creationId xmlns:a16="http://schemas.microsoft.com/office/drawing/2014/main" id="{5BF878A1-D41B-44B5-BDEA-2AAD4275F6E2}"/>
               </a:ext>
             </a:extLst>
           </p:cNvPr>
@@ -6433,7 +6433,7 @@
           <p:cNvPr id="2" name="Records assistant purpose">
             <a:extLst xmlns:a="http://schemas.openxmlformats.org/drawingml/2006/main">
               <a:ext uri="{FF2B5EF4-FFF2-40B4-BE49-F238E27FC236}">
-                <a16:creationId xmlns:a16="http://schemas.microsoft.com/office/drawing/2014/main" id="{F147C6F5-2DB9-4B3F-9A42-CA252B2DD0BA}"/>
+                <a16:creationId xmlns:a16="http://schemas.microsoft.com/office/drawing/2014/main" id="{90CAD21E-62E0-4A5D-92D0-098B5B5DE82F}"/>
               </a:ext>
             </a:extLst>
           </p:cNvPr>
@@ -6494,7 +6494,7 @@
           <p:nvPr/>
         </p:nvPicPr>
         <p:blipFill>
-          <a:blip xmlns:r="http://schemas.openxmlformats.org/officeDocument/2006/relationships" xmlns:a="http://schemas.openxmlformats.org/drawingml/2006/main" r:embed="R4527554a8e3843ca"/>
+          <a:blip xmlns:r="http://schemas.openxmlformats.org/officeDocument/2006/relationships" xmlns:a="http://schemas.openxmlformats.org/drawingml/2006/main" r:embed="R8ad2fb7eeeaa49a0"/>
           <a:stretch xmlns:a="http://schemas.openxmlformats.org/drawingml/2006/main"/>
         </p:blipFill>
         <p:spPr>
@@ -6512,7 +6512,7 @@
           <p:cNvPr id="4" name="Records assistant 1">
             <a:extLst xmlns:a="http://schemas.openxmlformats.org/drawingml/2006/main">
               <a:ext uri="{FF2B5EF4-FFF2-40B4-BE49-F238E27FC236}">
-                <a16:creationId xmlns:a16="http://schemas.microsoft.com/office/drawing/2014/main" id="{BE34FEFF-FC88-45CD-B9AE-980CA7A6068B}"/>
+                <a16:creationId xmlns:a16="http://schemas.microsoft.com/office/drawing/2014/main" id="{37F61E7F-1860-438D-B8A5-3E3A9F3C9E6B}"/>
               </a:ext>
             </a:extLst>
           </p:cNvPr>
@@ -6569,7 +6569,7 @@
           <p:cNvPr id="5" name="Records assistant 1 detail">
             <a:extLst xmlns:a="http://schemas.openxmlformats.org/drawingml/2006/main">
               <a:ext uri="{FF2B5EF4-FFF2-40B4-BE49-F238E27FC236}">
-                <a16:creationId xmlns:a16="http://schemas.microsoft.com/office/drawing/2014/main" id="{A2004826-E29C-4DF4-AB7E-6FEA67241407}"/>
+                <a16:creationId xmlns:a16="http://schemas.microsoft.com/office/drawing/2014/main" id="{6E651E4A-D000-4F47-9C1E-0412BAA346AA}"/>
               </a:ext>
             </a:extLst>
           </p:cNvPr>
@@ -6626,7 +6626,7 @@
           <p:cNvPr id="6" name="Records assistant 2">
             <a:extLst xmlns:a="http://schemas.openxmlformats.org/drawingml/2006/main">
               <a:ext uri="{FF2B5EF4-FFF2-40B4-BE49-F238E27FC236}">
-                <a16:creationId xmlns:a16="http://schemas.microsoft.com/office/drawing/2014/main" id="{842C0ADA-8DAF-4992-A00B-F5B7D7B3C5B6}"/>
+                <a16:creationId xmlns:a16="http://schemas.microsoft.com/office/drawing/2014/main" id="{7234EE46-0F1F-46A4-8F99-6C246351C487}"/>
               </a:ext>
             </a:extLst>
           </p:cNvPr>
@@ -6683,7 +6683,7 @@
           <p:cNvPr id="7" name="Records assistant 2 detail">
             <a:extLst xmlns:a="http://schemas.openxmlformats.org/drawingml/2006/main">
               <a:ext uri="{FF2B5EF4-FFF2-40B4-BE49-F238E27FC236}">
-                <a16:creationId xmlns:a16="http://schemas.microsoft.com/office/drawing/2014/main" id="{E309FD23-9014-438A-A66F-D753CCE4E88D}"/>
+                <a16:creationId xmlns:a16="http://schemas.microsoft.com/office/drawing/2014/main" id="{725DCB49-04B8-4316-920A-D17644CF8B7B}"/>
               </a:ext>
             </a:extLst>
           </p:cNvPr>
@@ -6740,7 +6740,7 @@
           <p:cNvPr id="8" name="Records assistant 3">
             <a:extLst xmlns:a="http://schemas.openxmlformats.org/drawingml/2006/main">
               <a:ext uri="{FF2B5EF4-FFF2-40B4-BE49-F238E27FC236}">
-                <a16:creationId xmlns:a16="http://schemas.microsoft.com/office/drawing/2014/main" id="{237661BD-BC41-41F1-A849-6242F36AEEF8}"/>
+                <a16:creationId xmlns:a16="http://schemas.microsoft.com/office/drawing/2014/main" id="{5EB1CBA9-B72A-4B0C-B81F-56337BA6F580}"/>
               </a:ext>
             </a:extLst>
           </p:cNvPr>
@@ -6797,7 +6797,7 @@
           <p:cNvPr id="9" name="Records assistant 3 detail">
             <a:extLst xmlns:a="http://schemas.openxmlformats.org/drawingml/2006/main">
               <a:ext uri="{FF2B5EF4-FFF2-40B4-BE49-F238E27FC236}">
-                <a16:creationId xmlns:a16="http://schemas.microsoft.com/office/drawing/2014/main" id="{5B4A581B-15DB-4BC0-ACE1-F8F5F5D5CD4A}"/>
+                <a16:creationId xmlns:a16="http://schemas.microsoft.com/office/drawing/2014/main" id="{D9C8CBD6-3FF0-447A-B77C-F845EDDCC1BC}"/>
               </a:ext>
             </a:extLst>
           </p:cNvPr>
@@ -6854,7 +6854,7 @@
           <p:cNvPr id="10" name="Clinical scope">
             <a:extLst xmlns:a="http://schemas.openxmlformats.org/drawingml/2006/main">
               <a:ext uri="{FF2B5EF4-FFF2-40B4-BE49-F238E27FC236}">
-                <a16:creationId xmlns:a16="http://schemas.microsoft.com/office/drawing/2014/main" id="{F6934068-CF3D-4B01-9DF3-F1936CFB70C2}"/>
+                <a16:creationId xmlns:a16="http://schemas.microsoft.com/office/drawing/2014/main" id="{3553AE5D-CC73-4940-AC25-9A4E69F63497}"/>
               </a:ext>
             </a:extLst>
           </p:cNvPr>
@@ -6937,10 +6937,10 @@
       </p:grpSpPr>
       <p:sp>
         <p:nvSpPr>
-          <p:cNvPr id="40" name="Slide title">
-            <a:extLst xmlns:a="http://schemas.openxmlformats.org/drawingml/2006/main">
-              <a:ext uri="{FF2B5EF4-FFF2-40B4-BE49-F238E27FC236}">
-                <a16:creationId xmlns:a16="http://schemas.microsoft.com/office/drawing/2014/main" id="{B0F36175-AE72-47B1-AA63-7078DD5B7602}"/>
+          <p:cNvPr id="10" name="Slide title">
+            <a:extLst xmlns:a="http://schemas.openxmlformats.org/drawingml/2006/main">
+              <a:ext uri="{FF2B5EF4-FFF2-40B4-BE49-F238E27FC236}">
+                <a16:creationId xmlns:a16="http://schemas.microsoft.com/office/drawing/2014/main" id="{1E9EF11D-75C8-4F85-8EFA-7827D85A75A8}"/>
               </a:ext>
             </a:extLst>
           </p:cNvPr>
@@ -6987,417 +6987,27 @@
                 <a:ea typeface="Arial"/>
                 <a:cs typeface="Arial"/>
               </a:rPr>
-              <a:t>Care keeps moving when everyone knows their part.</a:t>
-            </a:r>
-          </a:p>
-        </p:txBody>
-      </p:sp>
-      <p:sp>
-        <p:nvSpPr>
-          <p:cNvPr id="2" name="Three sign-ins">
-            <a:extLst xmlns:a="http://schemas.openxmlformats.org/drawingml/2006/main">
-              <a:ext uri="{FF2B5EF4-FFF2-40B4-BE49-F238E27FC236}">
-                <a16:creationId xmlns:a16="http://schemas.microsoft.com/office/drawing/2014/main" id="{EAB8FA50-10C2-45D3-8846-C6255BB61294}"/>
-              </a:ext>
-            </a:extLst>
-          </p:cNvPr>
-          <p:cNvSpPr>
-            <a:spLocks xmlns:a="http://schemas.openxmlformats.org/drawingml/2006/main" noGrp="1"/>
-          </p:cNvSpPr>
-          <p:nvPr/>
-        </p:nvSpPr>
-        <p:spPr>
-          <a:xfrm xmlns:a="http://schemas.openxmlformats.org/drawingml/2006/main">
-            <a:off x="533400" y="1181100"/>
-            <a:ext cx="1781175" cy="342900"/>
-          </a:xfrm>
-          <a:prstGeom xmlns:a="http://schemas.openxmlformats.org/drawingml/2006/main" prst="rect">
-            <a:avLst/>
-          </a:prstGeom>
-          <a:noFill xmlns:a="http://schemas.openxmlformats.org/drawingml/2006/main"/>
-          <a:ln xmlns:a="http://schemas.openxmlformats.org/drawingml/2006/main" w="0">
-            <a:noFill/>
-          </a:ln>
-        </p:spPr>
-        <p:txBody>
-          <a:bodyPr xmlns:a="http://schemas.openxmlformats.org/drawingml/2006/main" wrap="square" lIns="0" tIns="0" rIns="0" bIns="0">
-            <a:normAutofit fontScale="100000"/>
-          </a:bodyPr>
-          <a:lstStyle xmlns:a="http://schemas.openxmlformats.org/drawingml/2006/main"/>
-          <a:p xmlns:a="http://schemas.openxmlformats.org/drawingml/2006/main">
-            <a:pPr>
-              <a:defRPr sz="1575" b="1">
-                <a:solidFill>
-                  <a:srgbClr val="53655C"/>
-                </a:solidFill>
-                <a:latin typeface="Arial"/>
-                <a:ea typeface="Arial"/>
-                <a:cs typeface="Arial"/>
-              </a:defRPr>
-            </a:pPr>
-            <a:r>
-              <a:rPr sz="1575" b="1">
-                <a:solidFill>
-                  <a:srgbClr val="53655C"/>
-                </a:solidFill>
-                <a:latin typeface="Arial"/>
-                <a:ea typeface="Arial"/>
-                <a:cs typeface="Arial"/>
-              </a:rPr>
-              <a:t>Three sign-ins</a:t>
-            </a:r>
-          </a:p>
-        </p:txBody>
-      </p:sp>
-      <p:sp>
-        <p:nvSpPr>
-          <p:cNvPr id="3" name="">
-            <a:extLst xmlns:a="http://schemas.openxmlformats.org/drawingml/2006/main">
-              <a:ext uri="{FF2B5EF4-FFF2-40B4-BE49-F238E27FC236}">
-                <a16:creationId xmlns:a16="http://schemas.microsoft.com/office/drawing/2014/main" id="{896DEB04-9B9C-4511-9CC5-C7D283032D1A}"/>
-              </a:ext>
-            </a:extLst>
-          </p:cNvPr>
-          <p:cNvSpPr>
-            <a:spLocks xmlns:a="http://schemas.openxmlformats.org/drawingml/2006/main" noGrp="1"/>
-          </p:cNvSpPr>
-          <p:nvPr/>
-        </p:nvSpPr>
-        <p:spPr>
-          <a:xfrm xmlns:a="http://schemas.openxmlformats.org/drawingml/2006/main">
-            <a:off x="2447925" y="1143000"/>
-            <a:ext cx="1714500" cy="400050"/>
-          </a:xfrm>
-          <a:prstGeom xmlns:a="http://schemas.openxmlformats.org/drawingml/2006/main" prst="roundRect">
-            <a:avLst>
-              <a:gd name="adj" fmla="val 19048"/>
-            </a:avLst>
-          </a:prstGeom>
-          <a:solidFill xmlns:a="http://schemas.openxmlformats.org/drawingml/2006/main">
-            <a:srgbClr val="E8F4F0"/>
-          </a:solidFill>
-          <a:ln xmlns:a="http://schemas.openxmlformats.org/drawingml/2006/main" w="0">
-            <a:noFill/>
-          </a:ln>
-        </p:spPr>
-      </p:sp>
-      <p:sp>
-        <p:nvSpPr>
-          <p:cNvPr id="4" name="Patient sign-in">
-            <a:extLst xmlns:a="http://schemas.openxmlformats.org/drawingml/2006/main">
-              <a:ext uri="{FF2B5EF4-FFF2-40B4-BE49-F238E27FC236}">
-                <a16:creationId xmlns:a16="http://schemas.microsoft.com/office/drawing/2014/main" id="{E56BBB50-0315-4410-B31B-FE6417F80982}"/>
-              </a:ext>
-            </a:extLst>
-          </p:cNvPr>
-          <p:cNvSpPr>
-            <a:spLocks xmlns:a="http://schemas.openxmlformats.org/drawingml/2006/main" noGrp="1"/>
-          </p:cNvSpPr>
-          <p:nvPr/>
-        </p:nvSpPr>
-        <p:spPr>
-          <a:xfrm xmlns:a="http://schemas.openxmlformats.org/drawingml/2006/main">
-            <a:off x="2619375" y="1209675"/>
-            <a:ext cx="1447800" cy="266700"/>
-          </a:xfrm>
-          <a:prstGeom xmlns:a="http://schemas.openxmlformats.org/drawingml/2006/main" prst="rect">
-            <a:avLst/>
-          </a:prstGeom>
-          <a:noFill xmlns:a="http://schemas.openxmlformats.org/drawingml/2006/main"/>
-          <a:ln xmlns:a="http://schemas.openxmlformats.org/drawingml/2006/main" w="0">
-            <a:noFill/>
-          </a:ln>
-        </p:spPr>
-        <p:txBody>
-          <a:bodyPr xmlns:a="http://schemas.openxmlformats.org/drawingml/2006/main" wrap="square" lIns="0" tIns="0" rIns="0" bIns="0">
-            <a:normAutofit fontScale="100000"/>
-          </a:bodyPr>
-          <a:lstStyle xmlns:a="http://schemas.openxmlformats.org/drawingml/2006/main"/>
-          <a:p xmlns:a="http://schemas.openxmlformats.org/drawingml/2006/main">
-            <a:pPr>
-              <a:defRPr sz="1575" b="1">
-                <a:solidFill>
-                  <a:srgbClr val="173F33"/>
-                </a:solidFill>
-                <a:latin typeface="Arial"/>
-                <a:ea typeface="Arial"/>
-                <a:cs typeface="Arial"/>
-              </a:defRPr>
-            </a:pPr>
-            <a:r>
-              <a:rPr sz="1575" b="1">
-                <a:solidFill>
-                  <a:srgbClr val="173F33"/>
-                </a:solidFill>
-                <a:latin typeface="Arial"/>
-                <a:ea typeface="Arial"/>
-                <a:cs typeface="Arial"/>
-              </a:rPr>
-              <a:t>Patient</a:t>
-            </a:r>
-          </a:p>
-        </p:txBody>
-      </p:sp>
-      <p:sp>
-        <p:nvSpPr>
-          <p:cNvPr id="5" name="">
-            <a:extLst xmlns:a="http://schemas.openxmlformats.org/drawingml/2006/main">
-              <a:ext uri="{FF2B5EF4-FFF2-40B4-BE49-F238E27FC236}">
-                <a16:creationId xmlns:a16="http://schemas.microsoft.com/office/drawing/2014/main" id="{6E3F5DFE-E700-413B-8526-3A25F37D3262}"/>
-              </a:ext>
-            </a:extLst>
-          </p:cNvPr>
-          <p:cNvSpPr>
-            <a:spLocks xmlns:a="http://schemas.openxmlformats.org/drawingml/2006/main" noGrp="1"/>
-          </p:cNvSpPr>
-          <p:nvPr/>
-        </p:nvSpPr>
-        <p:spPr>
-          <a:xfrm xmlns:a="http://schemas.openxmlformats.org/drawingml/2006/main">
-            <a:off x="4400550" y="1143000"/>
-            <a:ext cx="1714500" cy="400050"/>
-          </a:xfrm>
-          <a:prstGeom xmlns:a="http://schemas.openxmlformats.org/drawingml/2006/main" prst="roundRect">
-            <a:avLst>
-              <a:gd name="adj" fmla="val 19048"/>
-            </a:avLst>
-          </a:prstGeom>
-          <a:solidFill xmlns:a="http://schemas.openxmlformats.org/drawingml/2006/main">
-            <a:srgbClr val="EEE7FA"/>
-          </a:solidFill>
-          <a:ln xmlns:a="http://schemas.openxmlformats.org/drawingml/2006/main" w="0">
-            <a:noFill/>
-          </a:ln>
-        </p:spPr>
-      </p:sp>
-      <p:sp>
-        <p:nvSpPr>
-          <p:cNvPr id="6" name="Family sign-in">
-            <a:extLst xmlns:a="http://schemas.openxmlformats.org/drawingml/2006/main">
-              <a:ext uri="{FF2B5EF4-FFF2-40B4-BE49-F238E27FC236}">
-                <a16:creationId xmlns:a16="http://schemas.microsoft.com/office/drawing/2014/main" id="{5D8A22C6-36B0-4404-9081-C646D2C5AD1C}"/>
-              </a:ext>
-            </a:extLst>
-          </p:cNvPr>
-          <p:cNvSpPr>
-            <a:spLocks xmlns:a="http://schemas.openxmlformats.org/drawingml/2006/main" noGrp="1"/>
-          </p:cNvSpPr>
-          <p:nvPr/>
-        </p:nvSpPr>
-        <p:spPr>
-          <a:xfrm xmlns:a="http://schemas.openxmlformats.org/drawingml/2006/main">
-            <a:off x="4572000" y="1209675"/>
-            <a:ext cx="1447800" cy="266700"/>
-          </a:xfrm>
-          <a:prstGeom xmlns:a="http://schemas.openxmlformats.org/drawingml/2006/main" prst="rect">
-            <a:avLst/>
-          </a:prstGeom>
-          <a:noFill xmlns:a="http://schemas.openxmlformats.org/drawingml/2006/main"/>
-          <a:ln xmlns:a="http://schemas.openxmlformats.org/drawingml/2006/main" w="0">
-            <a:noFill/>
-          </a:ln>
-        </p:spPr>
-        <p:txBody>
-          <a:bodyPr xmlns:a="http://schemas.openxmlformats.org/drawingml/2006/main" wrap="square" lIns="0" tIns="0" rIns="0" bIns="0">
-            <a:normAutofit fontScale="100000"/>
-          </a:bodyPr>
-          <a:lstStyle xmlns:a="http://schemas.openxmlformats.org/drawingml/2006/main"/>
-          <a:p xmlns:a="http://schemas.openxmlformats.org/drawingml/2006/main">
-            <a:pPr>
-              <a:defRPr sz="1575" b="1">
-                <a:solidFill>
-                  <a:srgbClr val="173F33"/>
-                </a:solidFill>
-                <a:latin typeface="Arial"/>
-                <a:ea typeface="Arial"/>
-                <a:cs typeface="Arial"/>
-              </a:defRPr>
-            </a:pPr>
-            <a:r>
-              <a:rPr sz="1575" b="1">
-                <a:solidFill>
-                  <a:srgbClr val="173F33"/>
-                </a:solidFill>
-                <a:latin typeface="Arial"/>
-                <a:ea typeface="Arial"/>
-                <a:cs typeface="Arial"/>
-              </a:rPr>
-              <a:t>Family</a:t>
-            </a:r>
-          </a:p>
-        </p:txBody>
-      </p:sp>
-      <p:sp>
-        <p:nvSpPr>
-          <p:cNvPr id="7" name="">
-            <a:extLst xmlns:a="http://schemas.openxmlformats.org/drawingml/2006/main">
-              <a:ext uri="{FF2B5EF4-FFF2-40B4-BE49-F238E27FC236}">
-                <a16:creationId xmlns:a16="http://schemas.microsoft.com/office/drawing/2014/main" id="{3F031A52-0D4C-4FFC-91CC-D048F2EC2C67}"/>
-              </a:ext>
-            </a:extLst>
-          </p:cNvPr>
-          <p:cNvSpPr>
-            <a:spLocks xmlns:a="http://schemas.openxmlformats.org/drawingml/2006/main" noGrp="1"/>
-          </p:cNvSpPr>
-          <p:nvPr/>
-        </p:nvSpPr>
-        <p:spPr>
-          <a:xfrm xmlns:a="http://schemas.openxmlformats.org/drawingml/2006/main">
-            <a:off x="6353175" y="1143000"/>
-            <a:ext cx="1714500" cy="400050"/>
-          </a:xfrm>
-          <a:prstGeom xmlns:a="http://schemas.openxmlformats.org/drawingml/2006/main" prst="roundRect">
-            <a:avLst>
-              <a:gd name="adj" fmla="val 19048"/>
-            </a:avLst>
-          </a:prstGeom>
-          <a:solidFill xmlns:a="http://schemas.openxmlformats.org/drawingml/2006/main">
-            <a:srgbClr val="FFF0C6"/>
-          </a:solidFill>
-          <a:ln xmlns:a="http://schemas.openxmlformats.org/drawingml/2006/main" w="0">
-            <a:noFill/>
-          </a:ln>
-        </p:spPr>
-      </p:sp>
-      <p:sp>
-        <p:nvSpPr>
-          <p:cNvPr id="8" name="Doctor sign-in">
-            <a:extLst xmlns:a="http://schemas.openxmlformats.org/drawingml/2006/main">
-              <a:ext uri="{FF2B5EF4-FFF2-40B4-BE49-F238E27FC236}">
-                <a16:creationId xmlns:a16="http://schemas.microsoft.com/office/drawing/2014/main" id="{A03967EE-1BAA-4D13-96D4-AC88597133A4}"/>
-              </a:ext>
-            </a:extLst>
-          </p:cNvPr>
-          <p:cNvSpPr>
-            <a:spLocks xmlns:a="http://schemas.openxmlformats.org/drawingml/2006/main" noGrp="1"/>
-          </p:cNvSpPr>
-          <p:nvPr/>
-        </p:nvSpPr>
-        <p:spPr>
-          <a:xfrm xmlns:a="http://schemas.openxmlformats.org/drawingml/2006/main">
-            <a:off x="6524625" y="1209675"/>
-            <a:ext cx="1447800" cy="266700"/>
-          </a:xfrm>
-          <a:prstGeom xmlns:a="http://schemas.openxmlformats.org/drawingml/2006/main" prst="rect">
-            <a:avLst/>
-          </a:prstGeom>
-          <a:noFill xmlns:a="http://schemas.openxmlformats.org/drawingml/2006/main"/>
-          <a:ln xmlns:a="http://schemas.openxmlformats.org/drawingml/2006/main" w="0">
-            <a:noFill/>
-          </a:ln>
-        </p:spPr>
-        <p:txBody>
-          <a:bodyPr xmlns:a="http://schemas.openxmlformats.org/drawingml/2006/main" wrap="square" lIns="0" tIns="0" rIns="0" bIns="0">
-            <a:normAutofit fontScale="100000"/>
-          </a:bodyPr>
-          <a:lstStyle xmlns:a="http://schemas.openxmlformats.org/drawingml/2006/main"/>
-          <a:p xmlns:a="http://schemas.openxmlformats.org/drawingml/2006/main">
-            <a:pPr>
-              <a:defRPr sz="1575" b="1">
-                <a:solidFill>
-                  <a:srgbClr val="173F33"/>
-                </a:solidFill>
-                <a:latin typeface="Arial"/>
-                <a:ea typeface="Arial"/>
-                <a:cs typeface="Arial"/>
-              </a:defRPr>
-            </a:pPr>
-            <a:r>
-              <a:rPr sz="1575" b="1">
-                <a:solidFill>
-                  <a:srgbClr val="173F33"/>
-                </a:solidFill>
-                <a:latin typeface="Arial"/>
-                <a:ea typeface="Arial"/>
-                <a:cs typeface="Arial"/>
-              </a:rPr>
-              <a:t>Doctor</a:t>
-            </a:r>
-          </a:p>
-        </p:txBody>
-      </p:sp>
-      <p:sp>
-        <p:nvSpPr>
-          <p:cNvPr id="9" name="Before the visit">
-            <a:extLst xmlns:a="http://schemas.openxmlformats.org/drawingml/2006/main">
-              <a:ext uri="{FF2B5EF4-FFF2-40B4-BE49-F238E27FC236}">
-                <a16:creationId xmlns:a16="http://schemas.microsoft.com/office/drawing/2014/main" id="{AC48D1C9-CBE2-4AA8-8BC7-75F5FFFCEE60}"/>
-              </a:ext>
-            </a:extLst>
-          </p:cNvPr>
-          <p:cNvSpPr>
-            <a:spLocks xmlns:a="http://schemas.openxmlformats.org/drawingml/2006/main" noGrp="1"/>
-          </p:cNvSpPr>
-          <p:nvPr/>
-        </p:nvSpPr>
-        <p:spPr>
-          <a:xfrm xmlns:a="http://schemas.openxmlformats.org/drawingml/2006/main">
-            <a:off x="381000" y="1809750"/>
-            <a:ext cx="11430000" cy="2095500"/>
-          </a:xfrm>
-          <a:prstGeom xmlns:a="http://schemas.openxmlformats.org/drawingml/2006/main" prst="rect">
-            <a:avLst/>
-          </a:prstGeom>
-          <a:solidFill xmlns:a="http://schemas.openxmlformats.org/drawingml/2006/main">
-            <a:srgbClr val="E8F4F0"/>
-          </a:solidFill>
-          <a:ln xmlns:a="http://schemas.openxmlformats.org/drawingml/2006/main" w="0">
-            <a:noFill/>
-          </a:ln>
-        </p:spPr>
-      </p:sp>
-      <p:sp>
-        <p:nvSpPr>
-          <p:cNvPr id="10" name="Between visits">
-            <a:extLst xmlns:a="http://schemas.openxmlformats.org/drawingml/2006/main">
-              <a:ext uri="{FF2B5EF4-FFF2-40B4-BE49-F238E27FC236}">
-                <a16:creationId xmlns:a16="http://schemas.microsoft.com/office/drawing/2014/main" id="{911A306D-AC5A-46B9-A6B3-2AA6FDAAD1C0}"/>
-              </a:ext>
-            </a:extLst>
-          </p:cNvPr>
-          <p:cNvSpPr>
-            <a:spLocks xmlns:a="http://schemas.openxmlformats.org/drawingml/2006/main" noGrp="1"/>
-          </p:cNvSpPr>
-          <p:nvPr/>
-        </p:nvSpPr>
-        <p:spPr>
-          <a:xfrm xmlns:a="http://schemas.openxmlformats.org/drawingml/2006/main">
-            <a:off x="381000" y="4219575"/>
-            <a:ext cx="11430000" cy="2095500"/>
-          </a:xfrm>
-          <a:prstGeom xmlns:a="http://schemas.openxmlformats.org/drawingml/2006/main" prst="rect">
-            <a:avLst/>
-          </a:prstGeom>
-          <a:solidFill xmlns:a="http://schemas.openxmlformats.org/drawingml/2006/main">
-            <a:srgbClr val="FFF0D8"/>
-          </a:solidFill>
-          <a:ln xmlns:a="http://schemas.openxmlformats.org/drawingml/2006/main" w="0">
-            <a:noFill/>
-          </a:ln>
-        </p:spPr>
+              <a:t>Your care, medicines and help in one place.</a:t>
+            </a:r>
+          </a:p>
+        </p:txBody>
       </p:sp>
       <p:pic>
         <p:nvPicPr>
-          <p:cNvPr id="50" name=""/>
+          <p:cNvPr id="11" name=""/>
           <p:cNvPicPr>
             <a:picLocks xmlns:a="http://schemas.openxmlformats.org/drawingml/2006/main" noChangeAspect="1"/>
           </p:cNvPicPr>
           <p:nvPr/>
         </p:nvPicPr>
         <p:blipFill>
-          <a:blip xmlns:r="http://schemas.openxmlformats.org/officeDocument/2006/relationships" xmlns:a="http://schemas.openxmlformats.org/drawingml/2006/main" r:embed="R5366dd923ca74b10">
-            <a:extLst>
-              <a:ext uri="{96DAC541-7B7A-43D3-8B79-37D633B846F1}">
-                <asvg:svgBlip xmlns:asvg="http://schemas.microsoft.com/office/drawing/2016/SVG/main" r:embed="R20fd0ab06e6a423f"/>
-              </a:ext>
-            </a:extLst>
-          </a:blip>
+          <a:blip xmlns:r="http://schemas.openxmlformats.org/officeDocument/2006/relationships" xmlns:a="http://schemas.openxmlformats.org/drawingml/2006/main" r:embed="R857bef5b39344b3e"/>
           <a:stretch xmlns:a="http://schemas.openxmlformats.org/drawingml/2006/main"/>
         </p:blipFill>
         <p:spPr>
           <a:xfrm xmlns:a="http://schemas.openxmlformats.org/drawingml/2006/main">
-            <a:off x="533400" y="1981200"/>
-            <a:ext cx="371475" cy="371475"/>
+            <a:off x="273222" y="1066800"/>
+            <a:ext cx="8673757" cy="5067300"/>
           </a:xfrm>
           <a:prstGeom xmlns:a="http://schemas.openxmlformats.org/drawingml/2006/main" prst="rect">
             <a:avLst/>
@@ -7406,96 +7016,39 @@
       </p:pic>
       <p:sp>
         <p:nvSpPr>
-          <p:cNvPr id="12" name="Family journey number 1">
-            <a:extLst xmlns:a="http://schemas.openxmlformats.org/drawingml/2006/main">
-              <a:ext uri="{FF2B5EF4-FFF2-40B4-BE49-F238E27FC236}">
-                <a16:creationId xmlns:a16="http://schemas.microsoft.com/office/drawing/2014/main" id="{6C092F34-8871-4A76-AACD-E6D8BABAC465}"/>
-              </a:ext>
-            </a:extLst>
-          </p:cNvPr>
-          <p:cNvSpPr>
-            <a:spLocks xmlns:a="http://schemas.openxmlformats.org/drawingml/2006/main" noGrp="1"/>
-          </p:cNvSpPr>
-          <p:nvPr/>
-        </p:nvSpPr>
-        <p:spPr>
-          <a:xfrm xmlns:a="http://schemas.openxmlformats.org/drawingml/2006/main">
-            <a:off x="1028700" y="2019300"/>
-            <a:ext cx="619125" cy="361950"/>
-          </a:xfrm>
-          <a:prstGeom xmlns:a="http://schemas.openxmlformats.org/drawingml/2006/main" prst="rect">
-            <a:avLst/>
-          </a:prstGeom>
-          <a:noFill xmlns:a="http://schemas.openxmlformats.org/drawingml/2006/main"/>
-          <a:ln xmlns:a="http://schemas.openxmlformats.org/drawingml/2006/main" w="0">
-            <a:noFill/>
-          </a:ln>
-        </p:spPr>
-        <p:txBody>
-          <a:bodyPr xmlns:a="http://schemas.openxmlformats.org/drawingml/2006/main" wrap="square" lIns="0" tIns="0" rIns="0" bIns="0">
-            <a:normAutofit fontScale="100000"/>
-          </a:bodyPr>
-          <a:lstStyle xmlns:a="http://schemas.openxmlformats.org/drawingml/2006/main"/>
-          <a:p xmlns:a="http://schemas.openxmlformats.org/drawingml/2006/main">
-            <a:pPr>
-              <a:defRPr sz="1725" b="1">
-                <a:solidFill>
-                  <a:srgbClr val="157B68"/>
-                </a:solidFill>
-                <a:latin typeface="Arial"/>
-                <a:ea typeface="Arial"/>
-                <a:cs typeface="Arial"/>
-              </a:defRPr>
-            </a:pPr>
-            <a:r>
-              <a:rPr sz="1725" b="1">
-                <a:solidFill>
-                  <a:srgbClr val="157B68"/>
-                </a:solidFill>
-                <a:latin typeface="Arial"/>
-                <a:ea typeface="Arial"/>
-                <a:cs typeface="Arial"/>
-              </a:rPr>
-              <a:t>01</a:t>
-            </a:r>
-          </a:p>
-        </p:txBody>
-      </p:sp>
-      <p:sp>
-        <p:nvSpPr>
-          <p:cNvPr id="13" name="Family journey 1">
-            <a:extLst xmlns:a="http://schemas.openxmlformats.org/drawingml/2006/main">
-              <a:ext uri="{FF2B5EF4-FFF2-40B4-BE49-F238E27FC236}">
-                <a16:creationId xmlns:a16="http://schemas.microsoft.com/office/drawing/2014/main" id="{AFE22432-9DC9-45A3-AACE-0D903470E90A}"/>
-              </a:ext>
-            </a:extLst>
-          </p:cNvPr>
-          <p:cNvSpPr>
-            <a:spLocks xmlns:a="http://schemas.openxmlformats.org/drawingml/2006/main" noGrp="1"/>
-          </p:cNvSpPr>
-          <p:nvPr/>
-        </p:nvSpPr>
-        <p:spPr>
-          <a:xfrm xmlns:a="http://schemas.openxmlformats.org/drawingml/2006/main">
-            <a:off x="533400" y="2505075"/>
-            <a:ext cx="3333750" cy="552450"/>
-          </a:xfrm>
-          <a:prstGeom xmlns:a="http://schemas.openxmlformats.org/drawingml/2006/main" prst="rect">
-            <a:avLst/>
-          </a:prstGeom>
-          <a:noFill xmlns:a="http://schemas.openxmlformats.org/drawingml/2006/main"/>
-          <a:ln xmlns:a="http://schemas.openxmlformats.org/drawingml/2006/main" w="0">
-            <a:noFill/>
-          </a:ln>
-        </p:spPr>
-        <p:txBody>
-          <a:bodyPr xmlns:a="http://schemas.openxmlformats.org/drawingml/2006/main" wrap="square" lIns="0" tIns="0" rIns="0" bIns="0">
-            <a:normAutofit fontScale="100000"/>
-          </a:bodyPr>
-          <a:lstStyle xmlns:a="http://schemas.openxmlformats.org/drawingml/2006/main"/>
-          <a:p xmlns:a="http://schemas.openxmlformats.org/drawingml/2006/main">
-            <a:pPr>
-              <a:defRPr sz="1800" b="1">
+          <p:cNvPr id="3" name="Three sign-ins">
+            <a:extLst xmlns:a="http://schemas.openxmlformats.org/drawingml/2006/main">
+              <a:ext uri="{FF2B5EF4-FFF2-40B4-BE49-F238E27FC236}">
+                <a16:creationId xmlns:a16="http://schemas.microsoft.com/office/drawing/2014/main" id="{DE10829C-98BB-4B12-88B6-6339E26E3E93}"/>
+              </a:ext>
+            </a:extLst>
+          </p:cNvPr>
+          <p:cNvSpPr>
+            <a:spLocks xmlns:a="http://schemas.openxmlformats.org/drawingml/2006/main" noGrp="1"/>
+          </p:cNvSpPr>
+          <p:nvPr/>
+        </p:nvSpPr>
+        <p:spPr>
+          <a:xfrm xmlns:a="http://schemas.openxmlformats.org/drawingml/2006/main">
+            <a:off x="9296400" y="1076325"/>
+            <a:ext cx="2362200" cy="342900"/>
+          </a:xfrm>
+          <a:prstGeom xmlns:a="http://schemas.openxmlformats.org/drawingml/2006/main" prst="rect">
+            <a:avLst/>
+          </a:prstGeom>
+          <a:noFill xmlns:a="http://schemas.openxmlformats.org/drawingml/2006/main"/>
+          <a:ln xmlns:a="http://schemas.openxmlformats.org/drawingml/2006/main" w="0">
+            <a:noFill/>
+          </a:ln>
+        </p:spPr>
+        <p:txBody>
+          <a:bodyPr xmlns:a="http://schemas.openxmlformats.org/drawingml/2006/main" wrap="square" lIns="0" tIns="0" rIns="0" bIns="0">
+            <a:normAutofit fontScale="100000"/>
+          </a:bodyPr>
+          <a:lstStyle xmlns:a="http://schemas.openxmlformats.org/drawingml/2006/main"/>
+          <a:p xmlns:a="http://schemas.openxmlformats.org/drawingml/2006/main">
+            <a:pPr>
+              <a:defRPr sz="1875" b="1">
                 <a:solidFill>
                   <a:srgbClr val="173F33"/>
                 </a:solidFill>
@@ -7505,7 +7058,7 @@
               </a:defRPr>
             </a:pPr>
             <a:r>
-              <a:rPr sz="1800" b="1">
+              <a:rPr sz="1875" b="1">
                 <a:solidFill>
                   <a:srgbClr val="173F33"/>
                 </a:solidFill>
@@ -7513,159 +7066,125 @@
                 <a:ea typeface="Arial"/>
                 <a:cs typeface="Arial"/>
               </a:rPr>
-              <a:t>Keep the conversation together.</a:t>
-            </a:r>
-          </a:p>
-        </p:txBody>
-      </p:sp>
-      <p:sp>
-        <p:nvSpPr>
-          <p:cNvPr id="14" name="Family journey 1 detail">
-            <a:extLst xmlns:a="http://schemas.openxmlformats.org/drawingml/2006/main">
-              <a:ext uri="{FF2B5EF4-FFF2-40B4-BE49-F238E27FC236}">
-                <a16:creationId xmlns:a16="http://schemas.microsoft.com/office/drawing/2014/main" id="{DEFEAE2F-70BA-426A-A71B-A0D0DACF6488}"/>
-              </a:ext>
-            </a:extLst>
-          </p:cNvPr>
-          <p:cNvSpPr>
-            <a:spLocks xmlns:a="http://schemas.openxmlformats.org/drawingml/2006/main" noGrp="1"/>
-          </p:cNvSpPr>
-          <p:nvPr/>
-        </p:nvSpPr>
-        <p:spPr>
-          <a:xfrm xmlns:a="http://schemas.openxmlformats.org/drawingml/2006/main">
-            <a:off x="533400" y="3105150"/>
-            <a:ext cx="3333750" cy="866775"/>
-          </a:xfrm>
-          <a:prstGeom xmlns:a="http://schemas.openxmlformats.org/drawingml/2006/main" prst="rect">
-            <a:avLst/>
-          </a:prstGeom>
-          <a:noFill xmlns:a="http://schemas.openxmlformats.org/drawingml/2006/main"/>
-          <a:ln xmlns:a="http://schemas.openxmlformats.org/drawingml/2006/main" w="0">
-            <a:noFill/>
-          </a:ln>
-        </p:spPr>
-        <p:txBody>
-          <a:bodyPr xmlns:a="http://schemas.openxmlformats.org/drawingml/2006/main" wrap="square" lIns="0" tIns="0" rIns="0" bIns="0">
-            <a:normAutofit fontScale="100000"/>
-          </a:bodyPr>
-          <a:lstStyle xmlns:a="http://schemas.openxmlformats.org/drawingml/2006/main"/>
-          <a:p xmlns:a="http://schemas.openxmlformats.org/drawingml/2006/main">
-            <a:pPr>
-              <a:defRPr sz="1538" b="0">
-                <a:solidFill>
-                  <a:srgbClr val="173F33"/>
-                </a:solidFill>
-                <a:latin typeface="Arial"/>
-                <a:ea typeface="Arial"/>
-                <a:cs typeface="Arial"/>
-              </a:defRPr>
-            </a:pPr>
-            <a:r>
-              <a:rPr sz="1538" b="0">
-                <a:solidFill>
-                  <a:srgbClr val="173F33"/>
-                </a:solidFill>
-                <a:latin typeface="Arial"/>
-                <a:ea typeface="Arial"/>
-                <a:cs typeface="Arial"/>
-              </a:rPr>
-              <a:t>The family opens the latest signed Care Note and keeps questions for the next visit.</a:t>
+              <a:t>Three sign-ins</a:t>
             </a:r>
           </a:p>
         </p:txBody>
       </p:sp>
       <p:pic>
         <p:nvPicPr>
-          <p:cNvPr id="54" name=""/>
+          <p:cNvPr id="13" name=""/>
           <p:cNvPicPr>
             <a:picLocks xmlns:a="http://schemas.openxmlformats.org/drawingml/2006/main" noChangeAspect="1"/>
           </p:cNvPicPr>
           <p:nvPr/>
         </p:nvPicPr>
         <p:blipFill>
-          <a:blip xmlns:r="http://schemas.openxmlformats.org/officeDocument/2006/relationships" xmlns:a="http://schemas.openxmlformats.org/drawingml/2006/main" r:embed="Ra1981f84f06445a6">
-            <a:extLst>
-              <a:ext uri="{96DAC541-7B7A-43D3-8B79-37D633B846F1}">
-                <asvg:svgBlip xmlns:asvg="http://schemas.microsoft.com/office/drawing/2016/SVG/main" r:embed="Rbf173c406cdf49ad"/>
-              </a:ext>
-            </a:extLst>
-          </a:blip>
+          <a:blip xmlns:r="http://schemas.openxmlformats.org/officeDocument/2006/relationships" xmlns:a="http://schemas.openxmlformats.org/drawingml/2006/main" r:embed="R4f7d4c11c4d24583"/>
           <a:stretch xmlns:a="http://schemas.openxmlformats.org/drawingml/2006/main"/>
         </p:blipFill>
         <p:spPr>
           <a:xfrm xmlns:a="http://schemas.openxmlformats.org/drawingml/2006/main">
-            <a:off x="3952875" y="2028825"/>
-            <a:ext cx="266700" cy="266700"/>
+            <a:off x="9144000" y="1498066"/>
+            <a:ext cx="2514600" cy="2690293"/>
           </a:xfrm>
           <a:prstGeom xmlns:a="http://schemas.openxmlformats.org/drawingml/2006/main" prst="rect">
             <a:avLst/>
           </a:prstGeom>
         </p:spPr>
       </p:pic>
-      <p:pic>
-        <p:nvPicPr>
-          <p:cNvPr id="55" name=""/>
-          <p:cNvPicPr>
-            <a:picLocks xmlns:a="http://schemas.openxmlformats.org/drawingml/2006/main" noChangeAspect="1"/>
-          </p:cNvPicPr>
-          <p:nvPr/>
-        </p:nvPicPr>
-        <p:blipFill>
-          <a:blip xmlns:r="http://schemas.openxmlformats.org/officeDocument/2006/relationships" xmlns:a="http://schemas.openxmlformats.org/drawingml/2006/main" r:embed="Rb04799ddf1d449de">
-            <a:extLst>
-              <a:ext uri="{96DAC541-7B7A-43D3-8B79-37D633B846F1}">
-                <asvg:svgBlip xmlns:asvg="http://schemas.microsoft.com/office/drawing/2016/SVG/main" r:embed="R53bf81545e9a463d"/>
-              </a:ext>
-            </a:extLst>
-          </a:blip>
-          <a:stretch xmlns:a="http://schemas.openxmlformats.org/drawingml/2006/main"/>
-        </p:blipFill>
-        <p:spPr>
-          <a:xfrm xmlns:a="http://schemas.openxmlformats.org/drawingml/2006/main">
-            <a:off x="4343400" y="1981200"/>
-            <a:ext cx="371475" cy="371475"/>
-          </a:xfrm>
-          <a:prstGeom xmlns:a="http://schemas.openxmlformats.org/drawingml/2006/main" prst="rect">
-            <a:avLst/>
-          </a:prstGeom>
-        </p:spPr>
-      </p:pic>
-      <p:sp>
-        <p:nvSpPr>
-          <p:cNvPr id="17" name="Family journey number 2">
-            <a:extLst xmlns:a="http://schemas.openxmlformats.org/drawingml/2006/main">
-              <a:ext uri="{FF2B5EF4-FFF2-40B4-BE49-F238E27FC236}">
-                <a16:creationId xmlns:a16="http://schemas.microsoft.com/office/drawing/2014/main" id="{01118313-4510-4A07-AA26-FD3354784EA0}"/>
-              </a:ext>
-            </a:extLst>
-          </p:cNvPr>
-          <p:cNvSpPr>
-            <a:spLocks xmlns:a="http://schemas.openxmlformats.org/drawingml/2006/main" noGrp="1"/>
-          </p:cNvSpPr>
-          <p:nvPr/>
-        </p:nvSpPr>
-        <p:spPr>
-          <a:xfrm xmlns:a="http://schemas.openxmlformats.org/drawingml/2006/main">
-            <a:off x="4838700" y="2019300"/>
-            <a:ext cx="619125" cy="361950"/>
-          </a:xfrm>
-          <a:prstGeom xmlns:a="http://schemas.openxmlformats.org/drawingml/2006/main" prst="rect">
-            <a:avLst/>
-          </a:prstGeom>
-          <a:noFill xmlns:a="http://schemas.openxmlformats.org/drawingml/2006/main"/>
-          <a:ln xmlns:a="http://schemas.openxmlformats.org/drawingml/2006/main" w="0">
-            <a:noFill/>
-          </a:ln>
-        </p:spPr>
-        <p:txBody>
-          <a:bodyPr xmlns:a="http://schemas.openxmlformats.org/drawingml/2006/main" wrap="square" lIns="0" tIns="0" rIns="0" bIns="0">
-            <a:normAutofit fontScale="100000"/>
-          </a:bodyPr>
-          <a:lstStyle xmlns:a="http://schemas.openxmlformats.org/drawingml/2006/main"/>
-          <a:p xmlns:a="http://schemas.openxmlformats.org/drawingml/2006/main">
-            <a:pPr>
-              <a:defRPr sz="1725" b="1">
+      <p:sp>
+        <p:nvSpPr>
+          <p:cNvPr id="5" name="Patient role">
+            <a:extLst xmlns:a="http://schemas.openxmlformats.org/drawingml/2006/main">
+              <a:ext uri="{FF2B5EF4-FFF2-40B4-BE49-F238E27FC236}">
+                <a16:creationId xmlns:a16="http://schemas.microsoft.com/office/drawing/2014/main" id="{8689E2EB-57A0-42F3-8F44-F5E4AE2E9FFE}"/>
+              </a:ext>
+            </a:extLst>
+          </p:cNvPr>
+          <p:cNvSpPr>
+            <a:spLocks xmlns:a="http://schemas.openxmlformats.org/drawingml/2006/main" noGrp="1"/>
+          </p:cNvSpPr>
+          <p:nvPr/>
+        </p:nvSpPr>
+        <p:spPr>
+          <a:xfrm xmlns:a="http://schemas.openxmlformats.org/drawingml/2006/main">
+            <a:off x="9296400" y="4362450"/>
+            <a:ext cx="2362200" cy="304800"/>
+          </a:xfrm>
+          <a:prstGeom xmlns:a="http://schemas.openxmlformats.org/drawingml/2006/main" prst="rect">
+            <a:avLst/>
+          </a:prstGeom>
+          <a:noFill xmlns:a="http://schemas.openxmlformats.org/drawingml/2006/main"/>
+          <a:ln xmlns:a="http://schemas.openxmlformats.org/drawingml/2006/main" w="0">
+            <a:noFill/>
+          </a:ln>
+        </p:spPr>
+        <p:txBody>
+          <a:bodyPr xmlns:a="http://schemas.openxmlformats.org/drawingml/2006/main" wrap="square" lIns="0" tIns="0" rIns="0" bIns="0">
+            <a:normAutofit fontScale="100000"/>
+          </a:bodyPr>
+          <a:lstStyle xmlns:a="http://schemas.openxmlformats.org/drawingml/2006/main"/>
+          <a:p xmlns:a="http://schemas.openxmlformats.org/drawingml/2006/main">
+            <a:pPr>
+              <a:defRPr sz="1575" b="1">
+                <a:solidFill>
+                  <a:srgbClr val="157B68"/>
+                </a:solidFill>
+                <a:latin typeface="Arial"/>
+                <a:ea typeface="Arial"/>
+                <a:cs typeface="Arial"/>
+              </a:defRPr>
+            </a:pPr>
+            <a:r>
+              <a:rPr sz="1575" b="1">
+                <a:solidFill>
+                  <a:srgbClr val="157B68"/>
+                </a:solidFill>
+                <a:latin typeface="Arial"/>
+                <a:ea typeface="Arial"/>
+                <a:cs typeface="Arial"/>
+              </a:rPr>
+              <a:t>Patients see their care.</a:t>
+            </a:r>
+          </a:p>
+        </p:txBody>
+      </p:sp>
+      <p:sp>
+        <p:nvSpPr>
+          <p:cNvPr id="6" name="Family role">
+            <a:extLst xmlns:a="http://schemas.openxmlformats.org/drawingml/2006/main">
+              <a:ext uri="{FF2B5EF4-FFF2-40B4-BE49-F238E27FC236}">
+                <a16:creationId xmlns:a16="http://schemas.microsoft.com/office/drawing/2014/main" id="{777085A5-A05C-4320-B5E8-D2CBF79CF575}"/>
+              </a:ext>
+            </a:extLst>
+          </p:cNvPr>
+          <p:cNvSpPr>
+            <a:spLocks xmlns:a="http://schemas.openxmlformats.org/drawingml/2006/main" noGrp="1"/>
+          </p:cNvSpPr>
+          <p:nvPr/>
+        </p:nvSpPr>
+        <p:spPr>
+          <a:xfrm xmlns:a="http://schemas.openxmlformats.org/drawingml/2006/main">
+            <a:off x="9296400" y="4714875"/>
+            <a:ext cx="2362200" cy="304800"/>
+          </a:xfrm>
+          <a:prstGeom xmlns:a="http://schemas.openxmlformats.org/drawingml/2006/main" prst="rect">
+            <a:avLst/>
+          </a:prstGeom>
+          <a:noFill xmlns:a="http://schemas.openxmlformats.org/drawingml/2006/main"/>
+          <a:ln xmlns:a="http://schemas.openxmlformats.org/drawingml/2006/main" w="0">
+            <a:noFill/>
+          </a:ln>
+        </p:spPr>
+        <p:txBody>
+          <a:bodyPr xmlns:a="http://schemas.openxmlformats.org/drawingml/2006/main" wrap="square" lIns="0" tIns="0" rIns="0" bIns="0">
+            <a:normAutofit fontScale="100000"/>
+          </a:bodyPr>
+          <a:lstStyle xmlns:a="http://schemas.openxmlformats.org/drawingml/2006/main"/>
+          <a:p xmlns:a="http://schemas.openxmlformats.org/drawingml/2006/main">
+            <a:pPr>
+              <a:defRPr sz="1575" b="1">
                 <a:solidFill>
                   <a:srgbClr val="7353AC"/>
                 </a:solidFill>
@@ -7675,7 +7194,7 @@
               </a:defRPr>
             </a:pPr>
             <a:r>
-              <a:rPr sz="1725" b="1">
+              <a:rPr sz="1575" b="1">
                 <a:solidFill>
                   <a:srgbClr val="7353AC"/>
                 </a:solidFill>
@@ -7683,46 +7202,103 @@
                 <a:ea typeface="Arial"/>
                 <a:cs typeface="Arial"/>
               </a:rPr>
-              <a:t>02</a:t>
-            </a:r>
-          </a:p>
-        </p:txBody>
-      </p:sp>
-      <p:sp>
-        <p:nvSpPr>
-          <p:cNvPr id="18" name="Family journey 2">
-            <a:extLst xmlns:a="http://schemas.openxmlformats.org/drawingml/2006/main">
-              <a:ext uri="{FF2B5EF4-FFF2-40B4-BE49-F238E27FC236}">
-                <a16:creationId xmlns:a16="http://schemas.microsoft.com/office/drawing/2014/main" id="{0DE6B8B7-9B32-4665-BF43-6523E36B29D4}"/>
-              </a:ext>
-            </a:extLst>
-          </p:cNvPr>
-          <p:cNvSpPr>
-            <a:spLocks xmlns:a="http://schemas.openxmlformats.org/drawingml/2006/main" noGrp="1"/>
-          </p:cNvSpPr>
-          <p:nvPr/>
-        </p:nvSpPr>
-        <p:spPr>
-          <a:xfrm xmlns:a="http://schemas.openxmlformats.org/drawingml/2006/main">
-            <a:off x="4343400" y="2505075"/>
-            <a:ext cx="3333750" cy="552450"/>
-          </a:xfrm>
-          <a:prstGeom xmlns:a="http://schemas.openxmlformats.org/drawingml/2006/main" prst="rect">
-            <a:avLst/>
-          </a:prstGeom>
-          <a:noFill xmlns:a="http://schemas.openxmlformats.org/drawingml/2006/main"/>
-          <a:ln xmlns:a="http://schemas.openxmlformats.org/drawingml/2006/main" w="0">
-            <a:noFill/>
-          </a:ln>
-        </p:spPr>
-        <p:txBody>
-          <a:bodyPr xmlns:a="http://schemas.openxmlformats.org/drawingml/2006/main" wrap="square" lIns="0" tIns="0" rIns="0" bIns="0">
-            <a:normAutofit fontScale="100000"/>
-          </a:bodyPr>
-          <a:lstStyle xmlns:a="http://schemas.openxmlformats.org/drawingml/2006/main"/>
-          <a:p xmlns:a="http://schemas.openxmlformats.org/drawingml/2006/main">
-            <a:pPr>
-              <a:defRPr sz="1800" b="1">
+              <a:t>Families organise help.</a:t>
+            </a:r>
+          </a:p>
+        </p:txBody>
+      </p:sp>
+      <p:sp>
+        <p:nvSpPr>
+          <p:cNvPr id="7" name="Doctor role">
+            <a:extLst xmlns:a="http://schemas.openxmlformats.org/drawingml/2006/main">
+              <a:ext uri="{FF2B5EF4-FFF2-40B4-BE49-F238E27FC236}">
+                <a16:creationId xmlns:a16="http://schemas.microsoft.com/office/drawing/2014/main" id="{F7E42846-4F2F-489D-B612-6330DB0FD1E2}"/>
+              </a:ext>
+            </a:extLst>
+          </p:cNvPr>
+          <p:cNvSpPr>
+            <a:spLocks xmlns:a="http://schemas.openxmlformats.org/drawingml/2006/main" noGrp="1"/>
+          </p:cNvSpPr>
+          <p:nvPr/>
+        </p:nvSpPr>
+        <p:spPr>
+          <a:xfrm xmlns:a="http://schemas.openxmlformats.org/drawingml/2006/main">
+            <a:off x="9296400" y="5067300"/>
+            <a:ext cx="2362200" cy="304800"/>
+          </a:xfrm>
+          <a:prstGeom xmlns:a="http://schemas.openxmlformats.org/drawingml/2006/main" prst="rect">
+            <a:avLst/>
+          </a:prstGeom>
+          <a:noFill xmlns:a="http://schemas.openxmlformats.org/drawingml/2006/main"/>
+          <a:ln xmlns:a="http://schemas.openxmlformats.org/drawingml/2006/main" w="0">
+            <a:noFill/>
+          </a:ln>
+        </p:spPr>
+        <p:txBody>
+          <a:bodyPr xmlns:a="http://schemas.openxmlformats.org/drawingml/2006/main" wrap="square" lIns="0" tIns="0" rIns="0" bIns="0">
+            <a:normAutofit fontScale="99374"/>
+          </a:bodyPr>
+          <a:lstStyle xmlns:a="http://schemas.openxmlformats.org/drawingml/2006/main"/>
+          <a:p xmlns:a="http://schemas.openxmlformats.org/drawingml/2006/main">
+            <a:pPr>
+              <a:defRPr sz="1575" b="1">
+                <a:solidFill>
+                  <a:srgbClr val="B75E43"/>
+                </a:solidFill>
+                <a:latin typeface="Arial"/>
+                <a:ea typeface="Arial"/>
+                <a:cs typeface="Arial"/>
+              </a:defRPr>
+            </a:pPr>
+            <a:r>
+              <a:rPr sz="1575" b="1">
+                <a:solidFill>
+                  <a:srgbClr val="B75E43"/>
+                </a:solidFill>
+                <a:latin typeface="Arial"/>
+                <a:ea typeface="Arial"/>
+                <a:cs typeface="Arial"/>
+              </a:rPr>
+              <a:t>Doctors review and sign.</a:t>
+            </a:r>
+          </a:p>
+        </p:txBody>
+      </p:sp>
+      <p:sp>
+        <p:nvSpPr>
+          <p:cNvPr id="8" name="Practical family support">
+            <a:extLst xmlns:a="http://schemas.openxmlformats.org/drawingml/2006/main">
+              <a:ext uri="{FF2B5EF4-FFF2-40B4-BE49-F238E27FC236}">
+                <a16:creationId xmlns:a16="http://schemas.microsoft.com/office/drawing/2014/main" id="{69033310-A3F1-4208-8E63-F24E6B178FA9}"/>
+              </a:ext>
+            </a:extLst>
+          </p:cNvPr>
+          <p:cNvSpPr>
+            <a:spLocks xmlns:a="http://schemas.openxmlformats.org/drawingml/2006/main" noGrp="1"/>
+          </p:cNvSpPr>
+          <p:nvPr/>
+        </p:nvSpPr>
+        <p:spPr>
+          <a:xfrm xmlns:a="http://schemas.openxmlformats.org/drawingml/2006/main">
+            <a:off x="9296400" y="5486400"/>
+            <a:ext cx="2362200" cy="895350"/>
+          </a:xfrm>
+          <a:prstGeom xmlns:a="http://schemas.openxmlformats.org/drawingml/2006/main" prst="rect">
+            <a:avLst/>
+          </a:prstGeom>
+          <a:noFill xmlns:a="http://schemas.openxmlformats.org/drawingml/2006/main"/>
+          <a:ln xmlns:a="http://schemas.openxmlformats.org/drawingml/2006/main" w="0">
+            <a:noFill/>
+          </a:ln>
+        </p:spPr>
+        <p:txBody>
+          <a:bodyPr xmlns:a="http://schemas.openxmlformats.org/drawingml/2006/main" wrap="square" lIns="0" tIns="0" rIns="0" bIns="0">
+            <a:normAutofit fontScale="100000"/>
+          </a:bodyPr>
+          <a:lstStyle xmlns:a="http://schemas.openxmlformats.org/drawingml/2006/main"/>
+          <a:p xmlns:a="http://schemas.openxmlformats.org/drawingml/2006/main">
+            <a:pPr>
+              <a:defRPr sz="1388" b="0">
                 <a:solidFill>
                   <a:srgbClr val="173F33"/>
                 </a:solidFill>
@@ -7732,7 +7308,7 @@
               </a:defRPr>
             </a:pPr>
             <a:r>
-              <a:rPr sz="1800" b="1">
+              <a:rPr sz="1388" b="0">
                 <a:solidFill>
                   <a:srgbClr val="173F33"/>
                 </a:solidFill>
@@ -7740,954 +7316,17 @@
                 <a:ea typeface="Arial"/>
                 <a:cs typeface="Arial"/>
               </a:rPr>
-              <a:t>Bring the right records.</a:t>
-            </a:r>
-          </a:p>
-        </p:txBody>
-      </p:sp>
-      <p:sp>
-        <p:nvSpPr>
-          <p:cNvPr id="19" name="Family journey 2 detail">
-            <a:extLst xmlns:a="http://schemas.openxmlformats.org/drawingml/2006/main">
-              <a:ext uri="{FF2B5EF4-FFF2-40B4-BE49-F238E27FC236}">
-                <a16:creationId xmlns:a16="http://schemas.microsoft.com/office/drawing/2014/main" id="{E85B8DA3-9484-4EC6-9FD8-0968A30EA18E}"/>
-              </a:ext>
-            </a:extLst>
-          </p:cNvPr>
-          <p:cNvSpPr>
-            <a:spLocks xmlns:a="http://schemas.openxmlformats.org/drawingml/2006/main" noGrp="1"/>
-          </p:cNvSpPr>
-          <p:nvPr/>
-        </p:nvSpPr>
-        <p:spPr>
-          <a:xfrm xmlns:a="http://schemas.openxmlformats.org/drawingml/2006/main">
-            <a:off x="4343400" y="3105150"/>
-            <a:ext cx="3333750" cy="866775"/>
-          </a:xfrm>
-          <a:prstGeom xmlns:a="http://schemas.openxmlformats.org/drawingml/2006/main" prst="rect">
-            <a:avLst/>
-          </a:prstGeom>
-          <a:noFill xmlns:a="http://schemas.openxmlformats.org/drawingml/2006/main"/>
-          <a:ln xmlns:a="http://schemas.openxmlformats.org/drawingml/2006/main" w="0">
-            <a:noFill/>
-          </a:ln>
-        </p:spPr>
-        <p:txBody>
-          <a:bodyPr xmlns:a="http://schemas.openxmlformats.org/drawingml/2006/main" wrap="square" lIns="0" tIns="0" rIns="0" bIns="0">
-            <a:normAutofit fontScale="100000"/>
-          </a:bodyPr>
-          <a:lstStyle xmlns:a="http://schemas.openxmlformats.org/drawingml/2006/main"/>
-          <a:p xmlns:a="http://schemas.openxmlformats.org/drawingml/2006/main">
-            <a:pPr>
-              <a:defRPr sz="1538" b="0">
-                <a:solidFill>
-                  <a:srgbClr val="173F33"/>
-                </a:solidFill>
-                <a:latin typeface="Arial"/>
-                <a:ea typeface="Arial"/>
-                <a:cs typeface="Arial"/>
-              </a:defRPr>
-            </a:pPr>
-            <a:r>
-              <a:rPr sz="1538" b="0">
-                <a:solidFill>
-                  <a:srgbClr val="173F33"/>
-                </a:solidFill>
-                <a:latin typeface="Arial"/>
-                <a:ea typeface="Arial"/>
-                <a:cs typeface="Arial"/>
-              </a:rPr>
-              <a:t>Priya gathers reports and checks the quoted sources and confirmed treatment dates.</a:t>
-            </a:r>
-          </a:p>
-        </p:txBody>
-      </p:sp>
-      <p:pic>
-        <p:nvPicPr>
-          <p:cNvPr id="59" name=""/>
-          <p:cNvPicPr>
-            <a:picLocks xmlns:a="http://schemas.openxmlformats.org/drawingml/2006/main" noChangeAspect="1"/>
-          </p:cNvPicPr>
-          <p:nvPr/>
-        </p:nvPicPr>
-        <p:blipFill>
-          <a:blip xmlns:r="http://schemas.openxmlformats.org/officeDocument/2006/relationships" xmlns:a="http://schemas.openxmlformats.org/drawingml/2006/main" r:embed="Rf118d60c9da245f8">
-            <a:extLst>
-              <a:ext uri="{96DAC541-7B7A-43D3-8B79-37D633B846F1}">
-                <asvg:svgBlip xmlns:asvg="http://schemas.microsoft.com/office/drawing/2016/SVG/main" r:embed="R3dbcc2b1018f40fc"/>
-              </a:ext>
-            </a:extLst>
-          </a:blip>
-          <a:stretch xmlns:a="http://schemas.openxmlformats.org/drawingml/2006/main"/>
-        </p:blipFill>
-        <p:spPr>
-          <a:xfrm xmlns:a="http://schemas.openxmlformats.org/drawingml/2006/main">
-            <a:off x="7762875" y="2028825"/>
-            <a:ext cx="266700" cy="266700"/>
-          </a:xfrm>
-          <a:prstGeom xmlns:a="http://schemas.openxmlformats.org/drawingml/2006/main" prst="rect">
-            <a:avLst/>
-          </a:prstGeom>
-        </p:spPr>
-      </p:pic>
-      <p:pic>
-        <p:nvPicPr>
-          <p:cNvPr id="60" name=""/>
-          <p:cNvPicPr>
-            <a:picLocks xmlns:a="http://schemas.openxmlformats.org/drawingml/2006/main" noChangeAspect="1"/>
-          </p:cNvPicPr>
-          <p:nvPr/>
-        </p:nvPicPr>
-        <p:blipFill>
-          <a:blip xmlns:r="http://schemas.openxmlformats.org/officeDocument/2006/relationships" xmlns:a="http://schemas.openxmlformats.org/drawingml/2006/main" r:embed="R9317a7ce87b546e7">
-            <a:extLst>
-              <a:ext uri="{96DAC541-7B7A-43D3-8B79-37D633B846F1}">
-                <asvg:svgBlip xmlns:asvg="http://schemas.microsoft.com/office/drawing/2016/SVG/main" r:embed="R92b39c266a0140c3"/>
-              </a:ext>
-            </a:extLst>
-          </a:blip>
-          <a:stretch xmlns:a="http://schemas.openxmlformats.org/drawingml/2006/main"/>
-        </p:blipFill>
-        <p:spPr>
-          <a:xfrm xmlns:a="http://schemas.openxmlformats.org/drawingml/2006/main">
-            <a:off x="8153400" y="1981200"/>
-            <a:ext cx="371475" cy="371475"/>
-          </a:xfrm>
-          <a:prstGeom xmlns:a="http://schemas.openxmlformats.org/drawingml/2006/main" prst="rect">
-            <a:avLst/>
-          </a:prstGeom>
-        </p:spPr>
-      </p:pic>
-      <p:sp>
-        <p:nvSpPr>
-          <p:cNvPr id="22" name="Family journey number 3">
-            <a:extLst xmlns:a="http://schemas.openxmlformats.org/drawingml/2006/main">
-              <a:ext uri="{FF2B5EF4-FFF2-40B4-BE49-F238E27FC236}">
-                <a16:creationId xmlns:a16="http://schemas.microsoft.com/office/drawing/2014/main" id="{70DA3DA0-D62F-4317-AC83-89EC6198BBF3}"/>
-              </a:ext>
-            </a:extLst>
-          </p:cNvPr>
-          <p:cNvSpPr>
-            <a:spLocks xmlns:a="http://schemas.openxmlformats.org/drawingml/2006/main" noGrp="1"/>
-          </p:cNvSpPr>
-          <p:nvPr/>
-        </p:nvSpPr>
-        <p:spPr>
-          <a:xfrm xmlns:a="http://schemas.openxmlformats.org/drawingml/2006/main">
-            <a:off x="8648700" y="2019300"/>
-            <a:ext cx="619125" cy="361950"/>
-          </a:xfrm>
-          <a:prstGeom xmlns:a="http://schemas.openxmlformats.org/drawingml/2006/main" prst="rect">
-            <a:avLst/>
-          </a:prstGeom>
-          <a:noFill xmlns:a="http://schemas.openxmlformats.org/drawingml/2006/main"/>
-          <a:ln xmlns:a="http://schemas.openxmlformats.org/drawingml/2006/main" w="0">
-            <a:noFill/>
-          </a:ln>
-        </p:spPr>
-        <p:txBody>
-          <a:bodyPr xmlns:a="http://schemas.openxmlformats.org/drawingml/2006/main" wrap="square" lIns="0" tIns="0" rIns="0" bIns="0">
-            <a:normAutofit fontScale="100000"/>
-          </a:bodyPr>
-          <a:lstStyle xmlns:a="http://schemas.openxmlformats.org/drawingml/2006/main"/>
-          <a:p xmlns:a="http://schemas.openxmlformats.org/drawingml/2006/main">
-            <a:pPr>
-              <a:defRPr sz="1725" b="1">
-                <a:solidFill>
-                  <a:srgbClr val="B75E43"/>
-                </a:solidFill>
-                <a:latin typeface="Arial"/>
-                <a:ea typeface="Arial"/>
-                <a:cs typeface="Arial"/>
-              </a:defRPr>
-            </a:pPr>
-            <a:r>
-              <a:rPr sz="1725" b="1">
-                <a:solidFill>
-                  <a:srgbClr val="B75E43"/>
-                </a:solidFill>
-                <a:latin typeface="Arial"/>
-                <a:ea typeface="Arial"/>
-                <a:cs typeface="Arial"/>
-              </a:rPr>
-              <a:t>03</a:t>
-            </a:r>
-          </a:p>
-        </p:txBody>
-      </p:sp>
-      <p:sp>
-        <p:nvSpPr>
-          <p:cNvPr id="23" name="Family journey 3">
-            <a:extLst xmlns:a="http://schemas.openxmlformats.org/drawingml/2006/main">
-              <a:ext uri="{FF2B5EF4-FFF2-40B4-BE49-F238E27FC236}">
-                <a16:creationId xmlns:a16="http://schemas.microsoft.com/office/drawing/2014/main" id="{7D5C4A83-5AB1-4F96-94B6-8E52B0004B8E}"/>
-              </a:ext>
-            </a:extLst>
-          </p:cNvPr>
-          <p:cNvSpPr>
-            <a:spLocks xmlns:a="http://schemas.openxmlformats.org/drawingml/2006/main" noGrp="1"/>
-          </p:cNvSpPr>
-          <p:nvPr/>
-        </p:nvSpPr>
-        <p:spPr>
-          <a:xfrm xmlns:a="http://schemas.openxmlformats.org/drawingml/2006/main">
-            <a:off x="8153400" y="2505075"/>
-            <a:ext cx="3333750" cy="552450"/>
-          </a:xfrm>
-          <a:prstGeom xmlns:a="http://schemas.openxmlformats.org/drawingml/2006/main" prst="rect">
-            <a:avLst/>
-          </a:prstGeom>
-          <a:noFill xmlns:a="http://schemas.openxmlformats.org/drawingml/2006/main"/>
-          <a:ln xmlns:a="http://schemas.openxmlformats.org/drawingml/2006/main" w="0">
-            <a:noFill/>
-          </a:ln>
-        </p:spPr>
-        <p:txBody>
-          <a:bodyPr xmlns:a="http://schemas.openxmlformats.org/drawingml/2006/main" wrap="square" lIns="0" tIns="0" rIns="0" bIns="0">
-            <a:normAutofit fontScale="100000"/>
-          </a:bodyPr>
-          <a:lstStyle xmlns:a="http://schemas.openxmlformats.org/drawingml/2006/main"/>
-          <a:p xmlns:a="http://schemas.openxmlformats.org/drawingml/2006/main">
-            <a:pPr>
-              <a:defRPr sz="1800" b="1">
-                <a:solidFill>
-                  <a:srgbClr val="173F33"/>
-                </a:solidFill>
-                <a:latin typeface="Arial"/>
-                <a:ea typeface="Arial"/>
-                <a:cs typeface="Arial"/>
-              </a:defRPr>
-            </a:pPr>
-            <a:r>
-              <a:rPr sz="1800" b="1">
-                <a:solidFill>
-                  <a:srgbClr val="173F33"/>
-                </a:solidFill>
-                <a:latin typeface="Arial"/>
-                <a:ea typeface="Arial"/>
-                <a:cs typeface="Arial"/>
-              </a:rPr>
-              <a:t>Plan medicines and visits.</a:t>
-            </a:r>
-          </a:p>
-        </p:txBody>
-      </p:sp>
-      <p:sp>
-        <p:nvSpPr>
-          <p:cNvPr id="24" name="Family journey 3 detail">
-            <a:extLst xmlns:a="http://schemas.openxmlformats.org/drawingml/2006/main">
-              <a:ext uri="{FF2B5EF4-FFF2-40B4-BE49-F238E27FC236}">
-                <a16:creationId xmlns:a16="http://schemas.microsoft.com/office/drawing/2014/main" id="{8F4D1E93-34FA-4CC9-A768-AB7EB7ED042C}"/>
-              </a:ext>
-            </a:extLst>
-          </p:cNvPr>
-          <p:cNvSpPr>
-            <a:spLocks xmlns:a="http://schemas.openxmlformats.org/drawingml/2006/main" noGrp="1"/>
-          </p:cNvSpPr>
-          <p:nvPr/>
-        </p:nvSpPr>
-        <p:spPr>
-          <a:xfrm xmlns:a="http://schemas.openxmlformats.org/drawingml/2006/main">
-            <a:off x="8153400" y="3105150"/>
-            <a:ext cx="3333750" cy="866775"/>
-          </a:xfrm>
-          <a:prstGeom xmlns:a="http://schemas.openxmlformats.org/drawingml/2006/main" prst="rect">
-            <a:avLst/>
-          </a:prstGeom>
-          <a:noFill xmlns:a="http://schemas.openxmlformats.org/drawingml/2006/main"/>
-          <a:ln xmlns:a="http://schemas.openxmlformats.org/drawingml/2006/main" w="0">
-            <a:noFill/>
-          </a:ln>
-        </p:spPr>
-        <p:txBody>
-          <a:bodyPr xmlns:a="http://schemas.openxmlformats.org/drawingml/2006/main" wrap="square" lIns="0" tIns="0" rIns="0" bIns="0">
-            <a:normAutofit fontScale="100000"/>
-          </a:bodyPr>
-          <a:lstStyle xmlns:a="http://schemas.openxmlformats.org/drawingml/2006/main"/>
-          <a:p xmlns:a="http://schemas.openxmlformats.org/drawingml/2006/main">
-            <a:pPr>
-              <a:defRPr sz="1538" b="0">
-                <a:solidFill>
-                  <a:srgbClr val="173F33"/>
-                </a:solidFill>
-                <a:latin typeface="Arial"/>
-                <a:ea typeface="Arial"/>
-                <a:cs typeface="Arial"/>
-              </a:defRPr>
-            </a:pPr>
-            <a:r>
-              <a:rPr sz="1538" b="0">
-                <a:solidFill>
-                  <a:srgbClr val="173F33"/>
-                </a:solidFill>
-                <a:latin typeface="Arial"/>
-                <a:ea typeface="Arial"/>
-                <a:cs typeface="Arial"/>
-              </a:rPr>
-              <a:t>Arjun checks reminders against the prescription and adds the next appointment.</a:t>
-            </a:r>
-          </a:p>
-        </p:txBody>
-      </p:sp>
-      <p:pic>
-        <p:nvPicPr>
-          <p:cNvPr id="64" name=""/>
-          <p:cNvPicPr>
-            <a:picLocks xmlns:a="http://schemas.openxmlformats.org/drawingml/2006/main" noChangeAspect="1"/>
-          </p:cNvPicPr>
-          <p:nvPr/>
-        </p:nvPicPr>
-        <p:blipFill>
-          <a:blip xmlns:r="http://schemas.openxmlformats.org/officeDocument/2006/relationships" xmlns:a="http://schemas.openxmlformats.org/drawingml/2006/main" r:embed="R9cf4905d615c4a62">
-            <a:extLst>
-              <a:ext uri="{96DAC541-7B7A-43D3-8B79-37D633B846F1}">
-                <asvg:svgBlip xmlns:asvg="http://schemas.microsoft.com/office/drawing/2016/SVG/main" r:embed="R2cb45655ee47419b"/>
-              </a:ext>
-            </a:extLst>
-          </a:blip>
-          <a:stretch xmlns:a="http://schemas.openxmlformats.org/drawingml/2006/main"/>
-        </p:blipFill>
-        <p:spPr>
-          <a:xfrm xmlns:a="http://schemas.openxmlformats.org/drawingml/2006/main">
-            <a:off x="533400" y="4391025"/>
-            <a:ext cx="371475" cy="371475"/>
-          </a:xfrm>
-          <a:prstGeom xmlns:a="http://schemas.openxmlformats.org/drawingml/2006/main" prst="rect">
-            <a:avLst/>
-          </a:prstGeom>
-        </p:spPr>
-      </p:pic>
-      <p:sp>
-        <p:nvSpPr>
-          <p:cNvPr id="26" name="Family journey number 4">
-            <a:extLst xmlns:a="http://schemas.openxmlformats.org/drawingml/2006/main">
-              <a:ext uri="{FF2B5EF4-FFF2-40B4-BE49-F238E27FC236}">
-                <a16:creationId xmlns:a16="http://schemas.microsoft.com/office/drawing/2014/main" id="{B643CBCC-6C6F-4640-BA19-ABBFE4919127}"/>
-              </a:ext>
-            </a:extLst>
-          </p:cNvPr>
-          <p:cNvSpPr>
-            <a:spLocks xmlns:a="http://schemas.openxmlformats.org/drawingml/2006/main" noGrp="1"/>
-          </p:cNvSpPr>
-          <p:nvPr/>
-        </p:nvSpPr>
-        <p:spPr>
-          <a:xfrm xmlns:a="http://schemas.openxmlformats.org/drawingml/2006/main">
-            <a:off x="1028700" y="4429125"/>
-            <a:ext cx="619125" cy="361950"/>
-          </a:xfrm>
-          <a:prstGeom xmlns:a="http://schemas.openxmlformats.org/drawingml/2006/main" prst="rect">
-            <a:avLst/>
-          </a:prstGeom>
-          <a:noFill xmlns:a="http://schemas.openxmlformats.org/drawingml/2006/main"/>
-          <a:ln xmlns:a="http://schemas.openxmlformats.org/drawingml/2006/main" w="0">
-            <a:noFill/>
-          </a:ln>
-        </p:spPr>
-        <p:txBody>
-          <a:bodyPr xmlns:a="http://schemas.openxmlformats.org/drawingml/2006/main" wrap="square" lIns="0" tIns="0" rIns="0" bIns="0">
-            <a:normAutofit fontScale="100000"/>
-          </a:bodyPr>
-          <a:lstStyle xmlns:a="http://schemas.openxmlformats.org/drawingml/2006/main"/>
-          <a:p xmlns:a="http://schemas.openxmlformats.org/drawingml/2006/main">
-            <a:pPr>
-              <a:defRPr sz="1725" b="1">
-                <a:solidFill>
-                  <a:srgbClr val="B75E43"/>
-                </a:solidFill>
-                <a:latin typeface="Arial"/>
-                <a:ea typeface="Arial"/>
-                <a:cs typeface="Arial"/>
-              </a:defRPr>
-            </a:pPr>
-            <a:r>
-              <a:rPr sz="1725" b="1">
-                <a:solidFill>
-                  <a:srgbClr val="B75E43"/>
-                </a:solidFill>
-                <a:latin typeface="Arial"/>
-                <a:ea typeface="Arial"/>
-                <a:cs typeface="Arial"/>
-              </a:rPr>
-              <a:t>04</a:t>
-            </a:r>
-          </a:p>
-        </p:txBody>
-      </p:sp>
-      <p:sp>
-        <p:nvSpPr>
-          <p:cNvPr id="27" name="Family journey 4">
-            <a:extLst xmlns:a="http://schemas.openxmlformats.org/drawingml/2006/main">
-              <a:ext uri="{FF2B5EF4-FFF2-40B4-BE49-F238E27FC236}">
-                <a16:creationId xmlns:a16="http://schemas.microsoft.com/office/drawing/2014/main" id="{64D286EB-4325-40E1-A043-8AA13AB32CD5}"/>
-              </a:ext>
-            </a:extLst>
-          </p:cNvPr>
-          <p:cNvSpPr>
-            <a:spLocks xmlns:a="http://schemas.openxmlformats.org/drawingml/2006/main" noGrp="1"/>
-          </p:cNvSpPr>
-          <p:nvPr/>
-        </p:nvSpPr>
-        <p:spPr>
-          <a:xfrm xmlns:a="http://schemas.openxmlformats.org/drawingml/2006/main">
-            <a:off x="533400" y="4914900"/>
-            <a:ext cx="3333750" cy="552450"/>
-          </a:xfrm>
-          <a:prstGeom xmlns:a="http://schemas.openxmlformats.org/drawingml/2006/main" prst="rect">
-            <a:avLst/>
-          </a:prstGeom>
-          <a:noFill xmlns:a="http://schemas.openxmlformats.org/drawingml/2006/main"/>
-          <a:ln xmlns:a="http://schemas.openxmlformats.org/drawingml/2006/main" w="0">
-            <a:noFill/>
-          </a:ln>
-        </p:spPr>
-        <p:txBody>
-          <a:bodyPr xmlns:a="http://schemas.openxmlformats.org/drawingml/2006/main" wrap="square" lIns="0" tIns="0" rIns="0" bIns="0">
-            <a:normAutofit fontScale="100000"/>
-          </a:bodyPr>
-          <a:lstStyle xmlns:a="http://schemas.openxmlformats.org/drawingml/2006/main"/>
-          <a:p xmlns:a="http://schemas.openxmlformats.org/drawingml/2006/main">
-            <a:pPr>
-              <a:defRPr sz="1800" b="1">
-                <a:solidFill>
-                  <a:srgbClr val="173F33"/>
-                </a:solidFill>
-                <a:latin typeface="Arial"/>
-                <a:ea typeface="Arial"/>
-                <a:cs typeface="Arial"/>
-              </a:defRPr>
-            </a:pPr>
-            <a:r>
-              <a:rPr sz="1800" b="1">
-                <a:solidFill>
-                  <a:srgbClr val="173F33"/>
-                </a:solidFill>
-                <a:latin typeface="Arial"/>
-                <a:ea typeface="Arial"/>
-                <a:cs typeface="Arial"/>
-              </a:rPr>
-              <a:t>Arrange help before leaving.</a:t>
-            </a:r>
-          </a:p>
-        </p:txBody>
-      </p:sp>
-      <p:sp>
-        <p:nvSpPr>
-          <p:cNvPr id="28" name="Family journey 4 detail">
-            <a:extLst xmlns:a="http://schemas.openxmlformats.org/drawingml/2006/main">
-              <a:ext uri="{FF2B5EF4-FFF2-40B4-BE49-F238E27FC236}">
-                <a16:creationId xmlns:a16="http://schemas.microsoft.com/office/drawing/2014/main" id="{BDC85B54-9C07-4EDA-9B1C-95D64E35A547}"/>
-              </a:ext>
-            </a:extLst>
-          </p:cNvPr>
-          <p:cNvSpPr>
-            <a:spLocks xmlns:a="http://schemas.openxmlformats.org/drawingml/2006/main" noGrp="1"/>
-          </p:cNvSpPr>
-          <p:nvPr/>
-        </p:nvSpPr>
-        <p:spPr>
-          <a:xfrm xmlns:a="http://schemas.openxmlformats.org/drawingml/2006/main">
-            <a:off x="533400" y="5514975"/>
-            <a:ext cx="3333750" cy="866775"/>
-          </a:xfrm>
-          <a:prstGeom xmlns:a="http://schemas.openxmlformats.org/drawingml/2006/main" prst="rect">
-            <a:avLst/>
-          </a:prstGeom>
-          <a:noFill xmlns:a="http://schemas.openxmlformats.org/drawingml/2006/main"/>
-          <a:ln xmlns:a="http://schemas.openxmlformats.org/drawingml/2006/main" w="0">
-            <a:noFill/>
-          </a:ln>
-        </p:spPr>
-        <p:txBody>
-          <a:bodyPr xmlns:a="http://schemas.openxmlformats.org/drawingml/2006/main" wrap="square" lIns="0" tIns="0" rIns="0" bIns="0">
-            <a:normAutofit fontScale="100000"/>
-          </a:bodyPr>
-          <a:lstStyle xmlns:a="http://schemas.openxmlformats.org/drawingml/2006/main"/>
-          <a:p xmlns:a="http://schemas.openxmlformats.org/drawingml/2006/main">
-            <a:pPr>
-              <a:defRPr sz="1538" b="0">
-                <a:solidFill>
-                  <a:srgbClr val="173F33"/>
-                </a:solidFill>
-                <a:latin typeface="Arial"/>
-                <a:ea typeface="Arial"/>
-                <a:cs typeface="Arial"/>
-              </a:defRPr>
-            </a:pPr>
-            <a:r>
-              <a:rPr sz="1538" b="0">
-                <a:solidFill>
-                  <a:srgbClr val="173F33"/>
-                </a:solidFill>
-                <a:latin typeface="Arial"/>
-                <a:ea typeface="Arial"/>
-                <a:cs typeface="Arial"/>
-              </a:rPr>
-              <a:t>Priya arranges a ride. Arjun calls to confirm home-care support and prescribed medicine availability.</a:t>
-            </a:r>
-          </a:p>
-        </p:txBody>
-      </p:sp>
-      <p:pic>
-        <p:nvPicPr>
-          <p:cNvPr id="68" name=""/>
-          <p:cNvPicPr>
-            <a:picLocks xmlns:a="http://schemas.openxmlformats.org/drawingml/2006/main" noChangeAspect="1"/>
-          </p:cNvPicPr>
-          <p:nvPr/>
-        </p:nvPicPr>
-        <p:blipFill>
-          <a:blip xmlns:r="http://schemas.openxmlformats.org/officeDocument/2006/relationships" xmlns:a="http://schemas.openxmlformats.org/drawingml/2006/main" r:embed="R10653ffa980048cc">
-            <a:extLst>
-              <a:ext uri="{96DAC541-7B7A-43D3-8B79-37D633B846F1}">
-                <asvg:svgBlip xmlns:asvg="http://schemas.microsoft.com/office/drawing/2016/SVG/main" r:embed="Re7c578e44e7f4d19"/>
-              </a:ext>
-            </a:extLst>
-          </a:blip>
-          <a:stretch xmlns:a="http://schemas.openxmlformats.org/drawingml/2006/main"/>
-        </p:blipFill>
-        <p:spPr>
-          <a:xfrm xmlns:a="http://schemas.openxmlformats.org/drawingml/2006/main">
-            <a:off x="3952875" y="4438650"/>
-            <a:ext cx="266700" cy="266700"/>
-          </a:xfrm>
-          <a:prstGeom xmlns:a="http://schemas.openxmlformats.org/drawingml/2006/main" prst="rect">
-            <a:avLst/>
-          </a:prstGeom>
-        </p:spPr>
-      </p:pic>
-      <p:pic>
-        <p:nvPicPr>
-          <p:cNvPr id="69" name=""/>
-          <p:cNvPicPr>
-            <a:picLocks xmlns:a="http://schemas.openxmlformats.org/drawingml/2006/main" noChangeAspect="1"/>
-          </p:cNvPicPr>
-          <p:nvPr/>
-        </p:nvPicPr>
-        <p:blipFill>
-          <a:blip xmlns:r="http://schemas.openxmlformats.org/officeDocument/2006/relationships" xmlns:a="http://schemas.openxmlformats.org/drawingml/2006/main" r:embed="R27a1b96e85434fe5">
-            <a:extLst>
-              <a:ext uri="{96DAC541-7B7A-43D3-8B79-37D633B846F1}">
-                <asvg:svgBlip xmlns:asvg="http://schemas.microsoft.com/office/drawing/2016/SVG/main" r:embed="Rd9ae1781679242b0"/>
-              </a:ext>
-            </a:extLst>
-          </a:blip>
-          <a:stretch xmlns:a="http://schemas.openxmlformats.org/drawingml/2006/main"/>
-        </p:blipFill>
-        <p:spPr>
-          <a:xfrm xmlns:a="http://schemas.openxmlformats.org/drawingml/2006/main">
-            <a:off x="4343400" y="4391025"/>
-            <a:ext cx="371475" cy="371475"/>
-          </a:xfrm>
-          <a:prstGeom xmlns:a="http://schemas.openxmlformats.org/drawingml/2006/main" prst="rect">
-            <a:avLst/>
-          </a:prstGeom>
-        </p:spPr>
-      </p:pic>
-      <p:sp>
-        <p:nvSpPr>
-          <p:cNvPr id="31" name="Family journey number 5">
-            <a:extLst xmlns:a="http://schemas.openxmlformats.org/drawingml/2006/main">
-              <a:ext uri="{FF2B5EF4-FFF2-40B4-BE49-F238E27FC236}">
-                <a16:creationId xmlns:a16="http://schemas.microsoft.com/office/drawing/2014/main" id="{F3DDCCBB-5B1B-42BD-BE62-45315A3FF904}"/>
-              </a:ext>
-            </a:extLst>
-          </p:cNvPr>
-          <p:cNvSpPr>
-            <a:spLocks xmlns:a="http://schemas.openxmlformats.org/drawingml/2006/main" noGrp="1"/>
-          </p:cNvSpPr>
-          <p:nvPr/>
-        </p:nvSpPr>
-        <p:spPr>
-          <a:xfrm xmlns:a="http://schemas.openxmlformats.org/drawingml/2006/main">
-            <a:off x="4838700" y="4429125"/>
-            <a:ext cx="619125" cy="361950"/>
-          </a:xfrm>
-          <a:prstGeom xmlns:a="http://schemas.openxmlformats.org/drawingml/2006/main" prst="rect">
-            <a:avLst/>
-          </a:prstGeom>
-          <a:noFill xmlns:a="http://schemas.openxmlformats.org/drawingml/2006/main"/>
-          <a:ln xmlns:a="http://schemas.openxmlformats.org/drawingml/2006/main" w="0">
-            <a:noFill/>
-          </a:ln>
-        </p:spPr>
-        <p:txBody>
-          <a:bodyPr xmlns:a="http://schemas.openxmlformats.org/drawingml/2006/main" wrap="square" lIns="0" tIns="0" rIns="0" bIns="0">
-            <a:normAutofit fontScale="100000"/>
-          </a:bodyPr>
-          <a:lstStyle xmlns:a="http://schemas.openxmlformats.org/drawingml/2006/main"/>
-          <a:p xmlns:a="http://schemas.openxmlformats.org/drawingml/2006/main">
-            <a:pPr>
-              <a:defRPr sz="1725" b="1">
-                <a:solidFill>
-                  <a:srgbClr val="7353AC"/>
-                </a:solidFill>
-                <a:latin typeface="Arial"/>
-                <a:ea typeface="Arial"/>
-                <a:cs typeface="Arial"/>
-              </a:defRPr>
-            </a:pPr>
-            <a:r>
-              <a:rPr sz="1725" b="1">
-                <a:solidFill>
-                  <a:srgbClr val="7353AC"/>
-                </a:solidFill>
-                <a:latin typeface="Arial"/>
-                <a:ea typeface="Arial"/>
-                <a:cs typeface="Arial"/>
-              </a:rPr>
-              <a:t>05</a:t>
-            </a:r>
-          </a:p>
-        </p:txBody>
-      </p:sp>
-      <p:sp>
-        <p:nvSpPr>
-          <p:cNvPr id="32" name="Family journey 5">
-            <a:extLst xmlns:a="http://schemas.openxmlformats.org/drawingml/2006/main">
-              <a:ext uri="{FF2B5EF4-FFF2-40B4-BE49-F238E27FC236}">
-                <a16:creationId xmlns:a16="http://schemas.microsoft.com/office/drawing/2014/main" id="{7488ACA1-9190-42BD-AC87-E2039152C058}"/>
-              </a:ext>
-            </a:extLst>
-          </p:cNvPr>
-          <p:cNvSpPr>
-            <a:spLocks xmlns:a="http://schemas.openxmlformats.org/drawingml/2006/main" noGrp="1"/>
-          </p:cNvSpPr>
-          <p:nvPr/>
-        </p:nvSpPr>
-        <p:spPr>
-          <a:xfrm xmlns:a="http://schemas.openxmlformats.org/drawingml/2006/main">
-            <a:off x="4343400" y="4914900"/>
-            <a:ext cx="3333750" cy="552450"/>
-          </a:xfrm>
-          <a:prstGeom xmlns:a="http://schemas.openxmlformats.org/drawingml/2006/main" prst="rect">
-            <a:avLst/>
-          </a:prstGeom>
-          <a:noFill xmlns:a="http://schemas.openxmlformats.org/drawingml/2006/main"/>
-          <a:ln xmlns:a="http://schemas.openxmlformats.org/drawingml/2006/main" w="0">
-            <a:noFill/>
-          </a:ln>
-        </p:spPr>
-        <p:txBody>
-          <a:bodyPr xmlns:a="http://schemas.openxmlformats.org/drawingml/2006/main" wrap="square" lIns="0" tIns="0" rIns="0" bIns="0">
-            <a:normAutofit fontScale="100000"/>
-          </a:bodyPr>
-          <a:lstStyle xmlns:a="http://schemas.openxmlformats.org/drawingml/2006/main"/>
-          <a:p xmlns:a="http://schemas.openxmlformats.org/drawingml/2006/main">
-            <a:pPr>
-              <a:defRPr sz="1800" b="1">
-                <a:solidFill>
-                  <a:srgbClr val="173F33"/>
-                </a:solidFill>
-                <a:latin typeface="Arial"/>
-                <a:ea typeface="Arial"/>
-                <a:cs typeface="Arial"/>
-              </a:defRPr>
-            </a:pPr>
-            <a:r>
-              <a:rPr sz="1800" b="1">
-                <a:solidFill>
-                  <a:srgbClr val="173F33"/>
-                </a:solidFill>
-                <a:latin typeface="Arial"/>
-                <a:ea typeface="Arial"/>
-                <a:cs typeface="Arial"/>
-              </a:rPr>
-              <a:t>Keep costs and papers together.</a:t>
-            </a:r>
-          </a:p>
-        </p:txBody>
-      </p:sp>
-      <p:sp>
-        <p:nvSpPr>
-          <p:cNvPr id="33" name="Family journey 5 detail">
-            <a:extLst xmlns:a="http://schemas.openxmlformats.org/drawingml/2006/main">
-              <a:ext uri="{FF2B5EF4-FFF2-40B4-BE49-F238E27FC236}">
-                <a16:creationId xmlns:a16="http://schemas.microsoft.com/office/drawing/2014/main" id="{A72C1ABE-F3E1-4887-9E5D-E0ADDD784BA9}"/>
-              </a:ext>
-            </a:extLst>
-          </p:cNvPr>
-          <p:cNvSpPr>
-            <a:spLocks xmlns:a="http://schemas.openxmlformats.org/drawingml/2006/main" noGrp="1"/>
-          </p:cNvSpPr>
-          <p:nvPr/>
-        </p:nvSpPr>
-        <p:spPr>
-          <a:xfrm xmlns:a="http://schemas.openxmlformats.org/drawingml/2006/main">
-            <a:off x="4343400" y="5514975"/>
-            <a:ext cx="3333750" cy="866775"/>
-          </a:xfrm>
-          <a:prstGeom xmlns:a="http://schemas.openxmlformats.org/drawingml/2006/main" prst="rect">
-            <a:avLst/>
-          </a:prstGeom>
-          <a:noFill xmlns:a="http://schemas.openxmlformats.org/drawingml/2006/main"/>
-          <a:ln xmlns:a="http://schemas.openxmlformats.org/drawingml/2006/main" w="0">
-            <a:noFill/>
-          </a:ln>
-        </p:spPr>
-        <p:txBody>
-          <a:bodyPr xmlns:a="http://schemas.openxmlformats.org/drawingml/2006/main" wrap="square" lIns="0" tIns="0" rIns="0" bIns="0">
-            <a:normAutofit fontScale="100000"/>
-          </a:bodyPr>
-          <a:lstStyle xmlns:a="http://schemas.openxmlformats.org/drawingml/2006/main"/>
-          <a:p xmlns:a="http://schemas.openxmlformats.org/drawingml/2006/main">
-            <a:pPr>
-              <a:defRPr sz="1538" b="0">
-                <a:solidFill>
-                  <a:srgbClr val="173F33"/>
-                </a:solidFill>
-                <a:latin typeface="Arial"/>
-                <a:ea typeface="Arial"/>
-                <a:cs typeface="Arial"/>
-              </a:defRPr>
-            </a:pPr>
-            <a:r>
-              <a:rPr sz="1538" b="0">
-                <a:solidFill>
-                  <a:srgbClr val="173F33"/>
-                </a:solidFill>
-                <a:latin typeface="Arial"/>
-                <a:ea typeface="Arial"/>
-                <a:cs typeface="Arial"/>
-              </a:rPr>
-              <a:t>Arjun keeps receipts, expenses and the paperwork needed to ask for financial help.</a:t>
-            </a:r>
-          </a:p>
-        </p:txBody>
-      </p:sp>
-      <p:pic>
-        <p:nvPicPr>
-          <p:cNvPr id="73" name=""/>
-          <p:cNvPicPr>
-            <a:picLocks xmlns:a="http://schemas.openxmlformats.org/drawingml/2006/main" noChangeAspect="1"/>
-          </p:cNvPicPr>
-          <p:nvPr/>
-        </p:nvPicPr>
-        <p:blipFill>
-          <a:blip xmlns:r="http://schemas.openxmlformats.org/officeDocument/2006/relationships" xmlns:a="http://schemas.openxmlformats.org/drawingml/2006/main" r:embed="Reddcefe6054848ad">
-            <a:extLst>
-              <a:ext uri="{96DAC541-7B7A-43D3-8B79-37D633B846F1}">
-                <asvg:svgBlip xmlns:asvg="http://schemas.microsoft.com/office/drawing/2016/SVG/main" r:embed="Ra262f0da205e420b"/>
-              </a:ext>
-            </a:extLst>
-          </a:blip>
-          <a:stretch xmlns:a="http://schemas.openxmlformats.org/drawingml/2006/main"/>
-        </p:blipFill>
-        <p:spPr>
-          <a:xfrm xmlns:a="http://schemas.openxmlformats.org/drawingml/2006/main">
-            <a:off x="7762875" y="4438650"/>
-            <a:ext cx="266700" cy="266700"/>
-          </a:xfrm>
-          <a:prstGeom xmlns:a="http://schemas.openxmlformats.org/drawingml/2006/main" prst="rect">
-            <a:avLst/>
-          </a:prstGeom>
-        </p:spPr>
-      </p:pic>
-      <p:pic>
-        <p:nvPicPr>
-          <p:cNvPr id="74" name=""/>
-          <p:cNvPicPr>
-            <a:picLocks xmlns:a="http://schemas.openxmlformats.org/drawingml/2006/main" noChangeAspect="1"/>
-          </p:cNvPicPr>
-          <p:nvPr/>
-        </p:nvPicPr>
-        <p:blipFill>
-          <a:blip xmlns:r="http://schemas.openxmlformats.org/officeDocument/2006/relationships" xmlns:a="http://schemas.openxmlformats.org/drawingml/2006/main" r:embed="R8c384d842e314711">
-            <a:extLst>
-              <a:ext uri="{96DAC541-7B7A-43D3-8B79-37D633B846F1}">
-                <asvg:svgBlip xmlns:asvg="http://schemas.microsoft.com/office/drawing/2016/SVG/main" r:embed="Rdd635a956c61407b"/>
-              </a:ext>
-            </a:extLst>
-          </a:blip>
-          <a:stretch xmlns:a="http://schemas.openxmlformats.org/drawingml/2006/main"/>
-        </p:blipFill>
-        <p:spPr>
-          <a:xfrm xmlns:a="http://schemas.openxmlformats.org/drawingml/2006/main">
-            <a:off x="8153400" y="4391025"/>
-            <a:ext cx="371475" cy="371475"/>
-          </a:xfrm>
-          <a:prstGeom xmlns:a="http://schemas.openxmlformats.org/drawingml/2006/main" prst="rect">
-            <a:avLst/>
-          </a:prstGeom>
-        </p:spPr>
-      </p:pic>
-      <p:sp>
-        <p:nvSpPr>
-          <p:cNvPr id="36" name="Family journey number 6">
-            <a:extLst xmlns:a="http://schemas.openxmlformats.org/drawingml/2006/main">
-              <a:ext uri="{FF2B5EF4-FFF2-40B4-BE49-F238E27FC236}">
-                <a16:creationId xmlns:a16="http://schemas.microsoft.com/office/drawing/2014/main" id="{2149B374-A890-4095-957E-C057E306D576}"/>
-              </a:ext>
-            </a:extLst>
-          </p:cNvPr>
-          <p:cNvSpPr>
-            <a:spLocks xmlns:a="http://schemas.openxmlformats.org/drawingml/2006/main" noGrp="1"/>
-          </p:cNvSpPr>
-          <p:nvPr/>
-        </p:nvSpPr>
-        <p:spPr>
-          <a:xfrm xmlns:a="http://schemas.openxmlformats.org/drawingml/2006/main">
-            <a:off x="8648700" y="4429125"/>
-            <a:ext cx="619125" cy="361950"/>
-          </a:xfrm>
-          <a:prstGeom xmlns:a="http://schemas.openxmlformats.org/drawingml/2006/main" prst="rect">
-            <a:avLst/>
-          </a:prstGeom>
-          <a:noFill xmlns:a="http://schemas.openxmlformats.org/drawingml/2006/main"/>
-          <a:ln xmlns:a="http://schemas.openxmlformats.org/drawingml/2006/main" w="0">
-            <a:noFill/>
-          </a:ln>
-        </p:spPr>
-        <p:txBody>
-          <a:bodyPr xmlns:a="http://schemas.openxmlformats.org/drawingml/2006/main" wrap="square" lIns="0" tIns="0" rIns="0" bIns="0">
-            <a:normAutofit fontScale="100000"/>
-          </a:bodyPr>
-          <a:lstStyle xmlns:a="http://schemas.openxmlformats.org/drawingml/2006/main"/>
-          <a:p xmlns:a="http://schemas.openxmlformats.org/drawingml/2006/main">
-            <a:pPr>
-              <a:defRPr sz="1725" b="1">
-                <a:solidFill>
-                  <a:srgbClr val="157B68"/>
-                </a:solidFill>
-                <a:latin typeface="Arial"/>
-                <a:ea typeface="Arial"/>
-                <a:cs typeface="Arial"/>
-              </a:defRPr>
-            </a:pPr>
-            <a:r>
-              <a:rPr sz="1725" b="1">
-                <a:solidFill>
-                  <a:srgbClr val="157B68"/>
-                </a:solidFill>
-                <a:latin typeface="Arial"/>
-                <a:ea typeface="Arial"/>
-                <a:cs typeface="Arial"/>
-              </a:rPr>
-              <a:t>06</a:t>
-            </a:r>
-          </a:p>
-        </p:txBody>
-      </p:sp>
-      <p:sp>
-        <p:nvSpPr>
-          <p:cNvPr id="37" name="Family journey 6">
-            <a:extLst xmlns:a="http://schemas.openxmlformats.org/drawingml/2006/main">
-              <a:ext uri="{FF2B5EF4-FFF2-40B4-BE49-F238E27FC236}">
-                <a16:creationId xmlns:a16="http://schemas.microsoft.com/office/drawing/2014/main" id="{0C67A111-83DF-4A88-8FB8-A69994C50286}"/>
-              </a:ext>
-            </a:extLst>
-          </p:cNvPr>
-          <p:cNvSpPr>
-            <a:spLocks xmlns:a="http://schemas.openxmlformats.org/drawingml/2006/main" noGrp="1"/>
-          </p:cNvSpPr>
-          <p:nvPr/>
-        </p:nvSpPr>
-        <p:spPr>
-          <a:xfrm xmlns:a="http://schemas.openxmlformats.org/drawingml/2006/main">
-            <a:off x="8153400" y="4914900"/>
-            <a:ext cx="3333750" cy="552450"/>
-          </a:xfrm>
-          <a:prstGeom xmlns:a="http://schemas.openxmlformats.org/drawingml/2006/main" prst="rect">
-            <a:avLst/>
-          </a:prstGeom>
-          <a:noFill xmlns:a="http://schemas.openxmlformats.org/drawingml/2006/main"/>
-          <a:ln xmlns:a="http://schemas.openxmlformats.org/drawingml/2006/main" w="0">
-            <a:noFill/>
-          </a:ln>
-        </p:spPr>
-        <p:txBody>
-          <a:bodyPr xmlns:a="http://schemas.openxmlformats.org/drawingml/2006/main" wrap="square" lIns="0" tIns="0" rIns="0" bIns="0">
-            <a:normAutofit fontScale="100000"/>
-          </a:bodyPr>
-          <a:lstStyle xmlns:a="http://schemas.openxmlformats.org/drawingml/2006/main"/>
-          <a:p xmlns:a="http://schemas.openxmlformats.org/drawingml/2006/main">
-            <a:pPr>
-              <a:defRPr sz="1800" b="1">
-                <a:solidFill>
-                  <a:srgbClr val="173F33"/>
-                </a:solidFill>
-                <a:latin typeface="Arial"/>
-                <a:ea typeface="Arial"/>
-                <a:cs typeface="Arial"/>
-              </a:defRPr>
-            </a:pPr>
-            <a:r>
-              <a:rPr sz="1800" b="1">
-                <a:solidFill>
-                  <a:srgbClr val="173F33"/>
-                </a:solidFill>
-                <a:latin typeface="Arial"/>
-                <a:ea typeface="Arial"/>
-                <a:cs typeface="Arial"/>
-              </a:rPr>
-              <a:t>Make space for the caregiver.</a:t>
-            </a:r>
-          </a:p>
-        </p:txBody>
-      </p:sp>
-      <p:sp>
-        <p:nvSpPr>
-          <p:cNvPr id="38" name="Family journey 6 detail">
-            <a:extLst xmlns:a="http://schemas.openxmlformats.org/drawingml/2006/main">
-              <a:ext uri="{FF2B5EF4-FFF2-40B4-BE49-F238E27FC236}">
-                <a16:creationId xmlns:a16="http://schemas.microsoft.com/office/drawing/2014/main" id="{30F7E9D0-6520-4387-A795-D101748D443A}"/>
-              </a:ext>
-            </a:extLst>
-          </p:cNvPr>
-          <p:cNvSpPr>
-            <a:spLocks xmlns:a="http://schemas.openxmlformats.org/drawingml/2006/main" noGrp="1"/>
-          </p:cNvSpPr>
-          <p:nvPr/>
-        </p:nvSpPr>
-        <p:spPr>
-          <a:xfrm xmlns:a="http://schemas.openxmlformats.org/drawingml/2006/main">
-            <a:off x="8153400" y="5514975"/>
-            <a:ext cx="3333750" cy="866775"/>
-          </a:xfrm>
-          <a:prstGeom xmlns:a="http://schemas.openxmlformats.org/drawingml/2006/main" prst="rect">
-            <a:avLst/>
-          </a:prstGeom>
-          <a:noFill xmlns:a="http://schemas.openxmlformats.org/drawingml/2006/main"/>
-          <a:ln xmlns:a="http://schemas.openxmlformats.org/drawingml/2006/main" w="0">
-            <a:noFill/>
-          </a:ln>
-        </p:spPr>
-        <p:txBody>
-          <a:bodyPr xmlns:a="http://schemas.openxmlformats.org/drawingml/2006/main" wrap="square" lIns="0" tIns="0" rIns="0" bIns="0">
-            <a:normAutofit fontScale="100000"/>
-          </a:bodyPr>
-          <a:lstStyle xmlns:a="http://schemas.openxmlformats.org/drawingml/2006/main"/>
-          <a:p xmlns:a="http://schemas.openxmlformats.org/drawingml/2006/main">
-            <a:pPr>
-              <a:defRPr sz="1538" b="0">
-                <a:solidFill>
-                  <a:srgbClr val="173F33"/>
-                </a:solidFill>
-                <a:latin typeface="Arial"/>
-                <a:ea typeface="Arial"/>
-                <a:cs typeface="Arial"/>
-              </a:defRPr>
-            </a:pPr>
-            <a:r>
-              <a:rPr sz="1538" b="0">
-                <a:solidFill>
-                  <a:srgbClr val="173F33"/>
-                </a:solidFill>
-                <a:latin typeface="Arial"/>
-                <a:ea typeface="Arial"/>
-                <a:cs typeface="Arial"/>
-              </a:rPr>
-              <a:t>Priya records what feels difficult. The family shares tasks and looks for emotional support.</a:t>
-            </a:r>
-          </a:p>
-        </p:txBody>
-      </p:sp>
-      <p:sp>
-        <p:nvSpPr>
-          <p:cNvPr id="39" name="Support directory">
-            <a:extLst xmlns:a="http://schemas.openxmlformats.org/drawingml/2006/main">
-              <a:ext uri="{FF2B5EF4-FFF2-40B4-BE49-F238E27FC236}">
-                <a16:creationId xmlns:a16="http://schemas.microsoft.com/office/drawing/2014/main" id="{2E75A865-6C0F-4135-97A4-B02C7C959E9B}"/>
+              <a:t>Plan rides and home support. Keep medicine calls, costs, paperwork and emotional support together.</a:t>
+            </a:r>
+          </a:p>
+        </p:txBody>
+      </p:sp>
+      <p:sp>
+        <p:nvSpPr>
+          <p:cNvPr id="9" name="Support directory">
+            <a:extLst xmlns:a="http://schemas.openxmlformats.org/drawingml/2006/main">
+              <a:ext uri="{FF2B5EF4-FFF2-40B4-BE49-F238E27FC236}">
+                <a16:creationId xmlns:a16="http://schemas.microsoft.com/office/drawing/2014/main" id="{636DCA4F-38D1-496B-8FEC-377B0A9683BB}"/>
               </a:ext>
             </a:extLst>
           </p:cNvPr>
@@ -8733,7 +7372,7 @@
                 <a:latin typeface="Arial"/>
                 <a:ea typeface="Arial"/>
                 <a:cs typeface="Arial"/>
-                <a:hlinkClick xmlns:r="http://schemas.openxmlformats.org/officeDocument/2006/relationships" r:id="Rb22a101764e445d0"/>
+                <a:hlinkClick xmlns:r="http://schemas.openxmlformats.org/officeDocument/2006/relationships" r:id="Rc8c6314cc1124592"/>
               </a:rPr>
               <a:t>Find a centre → call to confirm → keep the contact and visit plan.</a:t>
             </a:r>
@@ -8774,7 +7413,7 @@
           <p:cNvPr id="14" name="Slide title">
             <a:extLst xmlns:a="http://schemas.openxmlformats.org/drawingml/2006/main">
               <a:ext uri="{FF2B5EF4-FFF2-40B4-BE49-F238E27FC236}">
-                <a16:creationId xmlns:a16="http://schemas.microsoft.com/office/drawing/2014/main" id="{E6D97D31-6C7C-45AF-BE21-179D8B6D4DF5}"/>
+                <a16:creationId xmlns:a16="http://schemas.microsoft.com/office/drawing/2014/main" id="{9F300948-0F6C-46DA-93EF-8875DD1333F8}"/>
               </a:ext>
             </a:extLst>
           </p:cNvPr>
@@ -8831,7 +7470,7 @@
           <p:cNvPr id="2" name="Trial design">
             <a:extLst xmlns:a="http://schemas.openxmlformats.org/drawingml/2006/main">
               <a:ext uri="{FF2B5EF4-FFF2-40B4-BE49-F238E27FC236}">
-                <a16:creationId xmlns:a16="http://schemas.microsoft.com/office/drawing/2014/main" id="{6CFD42F9-A91B-40DD-9950-C19D46FCCAE7}"/>
+                <a16:creationId xmlns:a16="http://schemas.microsoft.com/office/drawing/2014/main" id="{6DECE32F-0F87-4BAD-BD3A-6A7E5F8A5F97}"/>
               </a:ext>
             </a:extLst>
           </p:cNvPr>
@@ -8888,7 +7527,7 @@
           <p:cNvPr id="3" name="Primary measure 1">
             <a:extLst xmlns:a="http://schemas.openxmlformats.org/drawingml/2006/main">
               <a:ext uri="{FF2B5EF4-FFF2-40B4-BE49-F238E27FC236}">
-                <a16:creationId xmlns:a16="http://schemas.microsoft.com/office/drawing/2014/main" id="{C35FA485-5687-420D-9417-C02BEEAA354B}"/>
+                <a16:creationId xmlns:a16="http://schemas.microsoft.com/office/drawing/2014/main" id="{73901517-188E-484C-961A-EC921A20EC5E}"/>
               </a:ext>
             </a:extLst>
           </p:cNvPr>
@@ -8945,7 +7584,7 @@
           <p:cNvPr id="4" name="Primary measure 1 detail">
             <a:extLst xmlns:a="http://schemas.openxmlformats.org/drawingml/2006/main">
               <a:ext uri="{FF2B5EF4-FFF2-40B4-BE49-F238E27FC236}">
-                <a16:creationId xmlns:a16="http://schemas.microsoft.com/office/drawing/2014/main" id="{83121768-9075-4539-8941-CBA00F9FDCD6}"/>
+                <a16:creationId xmlns:a16="http://schemas.microsoft.com/office/drawing/2014/main" id="{EB61BFDB-357C-47D6-8CFD-0ACD2D7FF034}"/>
               </a:ext>
             </a:extLst>
           </p:cNvPr>
@@ -9002,7 +7641,7 @@
           <p:cNvPr id="5" name="Primary measure 2">
             <a:extLst xmlns:a="http://schemas.openxmlformats.org/drawingml/2006/main">
               <a:ext uri="{FF2B5EF4-FFF2-40B4-BE49-F238E27FC236}">
-                <a16:creationId xmlns:a16="http://schemas.microsoft.com/office/drawing/2014/main" id="{27F26141-ADD9-4BDB-8054-3DDC31E7728B}"/>
+                <a16:creationId xmlns:a16="http://schemas.microsoft.com/office/drawing/2014/main" id="{14FAAB55-52B5-496B-A355-E057DEDD0936}"/>
               </a:ext>
             </a:extLst>
           </p:cNvPr>
@@ -9059,7 +7698,7 @@
           <p:cNvPr id="6" name="Primary measure 2 detail">
             <a:extLst xmlns:a="http://schemas.openxmlformats.org/drawingml/2006/main">
               <a:ext uri="{FF2B5EF4-FFF2-40B4-BE49-F238E27FC236}">
-                <a16:creationId xmlns:a16="http://schemas.microsoft.com/office/drawing/2014/main" id="{91EFCE1F-8F9E-43A2-A8BC-F75C17E83C31}"/>
+                <a16:creationId xmlns:a16="http://schemas.microsoft.com/office/drawing/2014/main" id="{3FA06113-238F-4509-BDB5-30BD6D93D36C}"/>
               </a:ext>
             </a:extLst>
           </p:cNvPr>
@@ -9116,7 +7755,7 @@
           <p:cNvPr id="7" name="Primary measure 3">
             <a:extLst xmlns:a="http://schemas.openxmlformats.org/drawingml/2006/main">
               <a:ext uri="{FF2B5EF4-FFF2-40B4-BE49-F238E27FC236}">
-                <a16:creationId xmlns:a16="http://schemas.microsoft.com/office/drawing/2014/main" id="{0A674C49-2D60-445F-ADA3-EA4CA5D3094A}"/>
+                <a16:creationId xmlns:a16="http://schemas.microsoft.com/office/drawing/2014/main" id="{ADA60C8C-33DD-499A-B9FB-00B21A534308}"/>
               </a:ext>
             </a:extLst>
           </p:cNvPr>
@@ -9173,7 +7812,7 @@
           <p:cNvPr id="8" name="Primary measure 3 detail">
             <a:extLst xmlns:a="http://schemas.openxmlformats.org/drawingml/2006/main">
               <a:ext uri="{FF2B5EF4-FFF2-40B4-BE49-F238E27FC236}">
-                <a16:creationId xmlns:a16="http://schemas.microsoft.com/office/drawing/2014/main" id="{54826EAA-B40E-4A5C-AA7E-4AEA588A3E62}"/>
+                <a16:creationId xmlns:a16="http://schemas.microsoft.com/office/drawing/2014/main" id="{BC1228A3-5843-424E-A1F3-E676EFDCA198}"/>
               </a:ext>
             </a:extLst>
           </p:cNvPr>
@@ -9230,7 +7869,7 @@
           <p:cNvPr id="9" name="">
             <a:extLst xmlns:a="http://schemas.openxmlformats.org/drawingml/2006/main">
               <a:ext uri="{FF2B5EF4-FFF2-40B4-BE49-F238E27FC236}">
-                <a16:creationId xmlns:a16="http://schemas.microsoft.com/office/drawing/2014/main" id="{1E9FDB96-2510-4907-9C66-7267FEC71439}"/>
+                <a16:creationId xmlns:a16="http://schemas.microsoft.com/office/drawing/2014/main" id="{BA670816-D678-4166-8007-5482C5C0A491}"/>
               </a:ext>
             </a:extLst>
           </p:cNvPr>
@@ -9259,7 +7898,7 @@
           <p:cNvPr id="10" name="Comparison">
             <a:extLst xmlns:a="http://schemas.openxmlformats.org/drawingml/2006/main">
               <a:ext uri="{FF2B5EF4-FFF2-40B4-BE49-F238E27FC236}">
-                <a16:creationId xmlns:a16="http://schemas.microsoft.com/office/drawing/2014/main" id="{B9EDF9CF-E661-45D8-8291-CF8EA58E0E2B}"/>
+                <a16:creationId xmlns:a16="http://schemas.microsoft.com/office/drawing/2014/main" id="{88CFEFDB-9923-4112-B129-07466B8B74CD}"/>
               </a:ext>
             </a:extLst>
           </p:cNvPr>
@@ -9316,7 +7955,7 @@
           <p:cNvPr id="11" name="Primary outcome definition">
             <a:extLst xmlns:a="http://schemas.openxmlformats.org/drawingml/2006/main">
               <a:ext uri="{FF2B5EF4-FFF2-40B4-BE49-F238E27FC236}">
-                <a16:creationId xmlns:a16="http://schemas.microsoft.com/office/drawing/2014/main" id="{F1547387-A7F0-4E7C-8C05-84E4485429F7}"/>
+                <a16:creationId xmlns:a16="http://schemas.microsoft.com/office/drawing/2014/main" id="{82DF7373-0174-4F6E-9EF0-A34769D453C2}"/>
               </a:ext>
             </a:extLst>
           </p:cNvPr>
@@ -9373,7 +8012,7 @@
           <p:cNvPr id="12" name="Additional measures">
             <a:extLst xmlns:a="http://schemas.openxmlformats.org/drawingml/2006/main">
               <a:ext uri="{FF2B5EF4-FFF2-40B4-BE49-F238E27FC236}">
-                <a16:creationId xmlns:a16="http://schemas.microsoft.com/office/drawing/2014/main" id="{1E753437-09E3-4E69-81EA-D9C870226C04}"/>
+                <a16:creationId xmlns:a16="http://schemas.microsoft.com/office/drawing/2014/main" id="{158E78D2-CD01-4DF7-B6C2-78B170EBAEDE}"/>
               </a:ext>
             </a:extLst>
           </p:cNvPr>
@@ -9430,7 +8069,7 @@
           <p:cNvPr id="13" name="Implementation status">
             <a:extLst xmlns:a="http://schemas.openxmlformats.org/drawingml/2006/main">
               <a:ext uri="{FF2B5EF4-FFF2-40B4-BE49-F238E27FC236}">
-                <a16:creationId xmlns:a16="http://schemas.microsoft.com/office/drawing/2014/main" id="{A6FBFEFF-5BF4-4E38-A19F-2F038010FF63}"/>
+                <a16:creationId xmlns:a16="http://schemas.microsoft.com/office/drawing/2014/main" id="{3ED110BE-FC3E-49C3-AE74-C01E7F2096E6}"/>
               </a:ext>
             </a:extLst>
           </p:cNvPr>
@@ -9516,7 +8155,7 @@
           <p:cNvPr id="31" name="References title">
             <a:extLst xmlns:a="http://schemas.openxmlformats.org/drawingml/2006/main">
               <a:ext uri="{FF2B5EF4-FFF2-40B4-BE49-F238E27FC236}">
-                <a16:creationId xmlns:a16="http://schemas.microsoft.com/office/drawing/2014/main" id="{B57EC4D1-4F16-4FBE-84F7-75A0E7724977}"/>
+                <a16:creationId xmlns:a16="http://schemas.microsoft.com/office/drawing/2014/main" id="{0738B670-43D6-4F92-998C-D8641C3CA9B7}"/>
               </a:ext>
             </a:extLst>
           </p:cNvPr>
@@ -9573,7 +8212,7 @@
           <p:cNvPr id="2" name="References one to four">
             <a:extLst xmlns:a="http://schemas.openxmlformats.org/drawingml/2006/main">
               <a:ext uri="{FF2B5EF4-FFF2-40B4-BE49-F238E27FC236}">
-                <a16:creationId xmlns:a16="http://schemas.microsoft.com/office/drawing/2014/main" id="{67EC1266-D103-45BD-BD0A-BEDDCD076E1F}"/>
+                <a16:creationId xmlns:a16="http://schemas.microsoft.com/office/drawing/2014/main" id="{B1FBFF19-AAED-4C1C-BF16-145DE03CD865}"/>
               </a:ext>
             </a:extLst>
           </p:cNvPr>
@@ -9603,7 +8242,7 @@
           <p:cNvPr id="3" name="References five to nine">
             <a:extLst xmlns:a="http://schemas.openxmlformats.org/drawingml/2006/main">
               <a:ext uri="{FF2B5EF4-FFF2-40B4-BE49-F238E27FC236}">
-                <a16:creationId xmlns:a16="http://schemas.microsoft.com/office/drawing/2014/main" id="{2E13A932-098E-4C4E-9268-DA224A3A6D34}"/>
+                <a16:creationId xmlns:a16="http://schemas.microsoft.com/office/drawing/2014/main" id="{241FA1F6-6B42-42CA-9B84-F651CB10A166}"/>
               </a:ext>
             </a:extLst>
           </p:cNvPr>
@@ -9633,7 +8272,7 @@
           <p:cNvPr id="4" name="Reference 1 author">
             <a:extLst xmlns:a="http://schemas.openxmlformats.org/drawingml/2006/main">
               <a:ext uri="{FF2B5EF4-FFF2-40B4-BE49-F238E27FC236}">
-                <a16:creationId xmlns:a16="http://schemas.microsoft.com/office/drawing/2014/main" id="{72B7F9DA-4241-4F52-8898-602D87ED79D3}"/>
+                <a16:creationId xmlns:a16="http://schemas.microsoft.com/office/drawing/2014/main" id="{A9176D11-52DA-42F5-A861-10FCF18848FF}"/>
               </a:ext>
             </a:extLst>
           </p:cNvPr>
@@ -9690,7 +8329,7 @@
           <p:cNvPr id="5" name="Reference 1 title">
             <a:extLst xmlns:a="http://schemas.openxmlformats.org/drawingml/2006/main">
               <a:ext uri="{FF2B5EF4-FFF2-40B4-BE49-F238E27FC236}">
-                <a16:creationId xmlns:a16="http://schemas.microsoft.com/office/drawing/2014/main" id="{6B23E8D3-C2A9-4BB1-A7B0-C6D862701A64}"/>
+                <a16:creationId xmlns:a16="http://schemas.microsoft.com/office/drawing/2014/main" id="{0F9DCD40-DC9E-47A1-B712-95A8080C1412}"/>
               </a:ext>
             </a:extLst>
           </p:cNvPr>
@@ -9736,7 +8375,7 @@
                 <a:latin typeface="Arial"/>
                 <a:ea typeface="Arial"/>
                 <a:cs typeface="Arial"/>
-                <a:hlinkClick xmlns:r="http://schemas.openxmlformats.org/officeDocument/2006/relationships" r:id="R4dc226c9244d40ec"/>
+                <a:hlinkClick xmlns:r="http://schemas.openxmlformats.org/officeDocument/2006/relationships" r:id="Rafa12fa26a604caa"/>
               </a:rPr>
               <a:t>India: GLOBOCAN 2024 Fact Sheet</a:t>
             </a:r>
@@ -9748,7 +8387,7 @@
           <p:cNvPr id="6" name="Reference 1 link">
             <a:extLst xmlns:a="http://schemas.openxmlformats.org/drawingml/2006/main">
               <a:ext uri="{FF2B5EF4-FFF2-40B4-BE49-F238E27FC236}">
-                <a16:creationId xmlns:a16="http://schemas.microsoft.com/office/drawing/2014/main" id="{2548D416-875D-4F11-BF03-05BFAAD160E8}"/>
+                <a16:creationId xmlns:a16="http://schemas.microsoft.com/office/drawing/2014/main" id="{60AAA8B2-C251-41D6-B543-96A650440675}"/>
               </a:ext>
             </a:extLst>
           </p:cNvPr>
@@ -9794,7 +8433,7 @@
                 <a:latin typeface="Arial"/>
                 <a:ea typeface="Arial"/>
                 <a:cs typeface="Arial"/>
-                <a:hlinkClick xmlns:r="http://schemas.openxmlformats.org/officeDocument/2006/relationships" r:id="Ra45fe59619454f63"/>
+                <a:hlinkClick xmlns:r="http://schemas.openxmlformats.org/officeDocument/2006/relationships" r:id="R1eade76f163a45fc"/>
               </a:rPr>
               <a:t>https://gco.iarc.who.int/media/globocan/factsheets/populations/356-india-fact-sheet.pdf</a:t>
             </a:r>
@@ -9806,7 +8445,7 @@
           <p:cNvPr id="7" name="Reference 2 author">
             <a:extLst xmlns:a="http://schemas.openxmlformats.org/drawingml/2006/main">
               <a:ext uri="{FF2B5EF4-FFF2-40B4-BE49-F238E27FC236}">
-                <a16:creationId xmlns:a16="http://schemas.microsoft.com/office/drawing/2014/main" id="{BC774ACA-919E-4244-8D83-5A35491C73A0}"/>
+                <a16:creationId xmlns:a16="http://schemas.microsoft.com/office/drawing/2014/main" id="{4F5BF9B8-6EB2-434E-8BFB-BAD9DDDE8758}"/>
               </a:ext>
             </a:extLst>
           </p:cNvPr>
@@ -9863,7 +8502,7 @@
           <p:cNvPr id="8" name="Reference 2 title">
             <a:extLst xmlns:a="http://schemas.openxmlformats.org/drawingml/2006/main">
               <a:ext uri="{FF2B5EF4-FFF2-40B4-BE49-F238E27FC236}">
-                <a16:creationId xmlns:a16="http://schemas.microsoft.com/office/drawing/2014/main" id="{165D9109-CE91-4956-9F1A-80B477B86AA6}"/>
+                <a16:creationId xmlns:a16="http://schemas.microsoft.com/office/drawing/2014/main" id="{AFCEB877-B6FC-47EE-B0F6-4C2D152BCF27}"/>
               </a:ext>
             </a:extLst>
           </p:cNvPr>
@@ -9909,7 +8548,7 @@
                 <a:latin typeface="Arial"/>
                 <a:ea typeface="Arial"/>
                 <a:cs typeface="Arial"/>
-                <a:hlinkClick xmlns:r="http://schemas.openxmlformats.org/officeDocument/2006/relationships" r:id="R0e42d417d82746b2"/>
+                <a:hlinkClick xmlns:r="http://schemas.openxmlformats.org/officeDocument/2006/relationships" r:id="R10fe587b7af645e6"/>
               </a:rPr>
               <a:t>Unmet need for cancer palliative care in India</a:t>
             </a:r>
@@ -9921,7 +8560,7 @@
           <p:cNvPr id="9" name="Reference 2 link">
             <a:extLst xmlns:a="http://schemas.openxmlformats.org/drawingml/2006/main">
               <a:ext uri="{FF2B5EF4-FFF2-40B4-BE49-F238E27FC236}">
-                <a16:creationId xmlns:a16="http://schemas.microsoft.com/office/drawing/2014/main" id="{2FBF3253-661F-48D3-9341-F76AD9D1659F}"/>
+                <a16:creationId xmlns:a16="http://schemas.microsoft.com/office/drawing/2014/main" id="{E5B97C81-8914-4316-A18B-5CC918703A6B}"/>
               </a:ext>
             </a:extLst>
           </p:cNvPr>
@@ -9967,7 +8606,7 @@
                 <a:latin typeface="Arial"/>
                 <a:ea typeface="Arial"/>
                 <a:cs typeface="Arial"/>
-                <a:hlinkClick xmlns:r="http://schemas.openxmlformats.org/officeDocument/2006/relationships" r:id="R29b7dc52f1b4493c"/>
+                <a:hlinkClick xmlns:r="http://schemas.openxmlformats.org/officeDocument/2006/relationships" r:id="Rd6f82230d975412d"/>
               </a:rPr>
               <a:t>https://doi.org/10.1136/spcare-2024-004978</a:t>
             </a:r>
@@ -9979,7 +8618,7 @@
           <p:cNvPr id="10" name="Reference 3 author">
             <a:extLst xmlns:a="http://schemas.openxmlformats.org/drawingml/2006/main">
               <a:ext uri="{FF2B5EF4-FFF2-40B4-BE49-F238E27FC236}">
-                <a16:creationId xmlns:a16="http://schemas.microsoft.com/office/drawing/2014/main" id="{C76D97F5-C03E-46F2-BF8E-175793FF11A2}"/>
+                <a16:creationId xmlns:a16="http://schemas.microsoft.com/office/drawing/2014/main" id="{F782BC5B-FB03-48AF-9BCF-15CDEBD6EA36}"/>
               </a:ext>
             </a:extLst>
           </p:cNvPr>
@@ -10036,7 +8675,7 @@
           <p:cNvPr id="11" name="Reference 3 title">
             <a:extLst xmlns:a="http://schemas.openxmlformats.org/drawingml/2006/main">
               <a:ext uri="{FF2B5EF4-FFF2-40B4-BE49-F238E27FC236}">
-                <a16:creationId xmlns:a16="http://schemas.microsoft.com/office/drawing/2014/main" id="{2315F4F2-DB4C-4AC9-BF1F-E2865085A476}"/>
+                <a16:creationId xmlns:a16="http://schemas.microsoft.com/office/drawing/2014/main" id="{53EE8E24-F19F-4FDC-92F3-264C2289658C}"/>
               </a:ext>
             </a:extLst>
           </p:cNvPr>
@@ -10082,7 +8721,7 @@
                 <a:latin typeface="Arial"/>
                 <a:ea typeface="Arial"/>
                 <a:cs typeface="Arial"/>
-                <a:hlinkClick xmlns:r="http://schemas.openxmlformats.org/officeDocument/2006/relationships" r:id="R554027444ecc4dac"/>
+                <a:hlinkClick xmlns:r="http://schemas.openxmlformats.org/officeDocument/2006/relationships" r:id="R6cea0745839b4cba"/>
               </a:rPr>
               <a:t>Early Goal of Care Discussions in Healthcare: A Survey Case Report on Benefits and Perceptions</a:t>
             </a:r>
@@ -10094,7 +8733,7 @@
           <p:cNvPr id="12" name="Reference 3 link">
             <a:extLst xmlns:a="http://schemas.openxmlformats.org/drawingml/2006/main">
               <a:ext uri="{FF2B5EF4-FFF2-40B4-BE49-F238E27FC236}">
-                <a16:creationId xmlns:a16="http://schemas.microsoft.com/office/drawing/2014/main" id="{93FE5718-7896-4E6A-80B4-55EBB13D110A}"/>
+                <a16:creationId xmlns:a16="http://schemas.microsoft.com/office/drawing/2014/main" id="{C7F86AB5-0D78-4B7A-AB06-DE2231E298CF}"/>
               </a:ext>
             </a:extLst>
           </p:cNvPr>
@@ -10140,7 +8779,7 @@
                 <a:latin typeface="Arial"/>
                 <a:ea typeface="Arial"/>
                 <a:cs typeface="Arial"/>
-                <a:hlinkClick xmlns:r="http://schemas.openxmlformats.org/officeDocument/2006/relationships" r:id="R5520ba3d31c6415d"/>
+                <a:hlinkClick xmlns:r="http://schemas.openxmlformats.org/officeDocument/2006/relationships" r:id="R828d5cc75a484ce5"/>
               </a:rPr>
               <a:t>https://doi.org/10.1016/j.jpainsymman.2024.02.030</a:t>
             </a:r>
@@ -10152,7 +8791,7 @@
           <p:cNvPr id="13" name="Reference 4 author">
             <a:extLst xmlns:a="http://schemas.openxmlformats.org/drawingml/2006/main">
               <a:ext uri="{FF2B5EF4-FFF2-40B4-BE49-F238E27FC236}">
-                <a16:creationId xmlns:a16="http://schemas.microsoft.com/office/drawing/2014/main" id="{32BA84EE-300C-48CE-A22A-7571A7FDDAEB}"/>
+                <a16:creationId xmlns:a16="http://schemas.microsoft.com/office/drawing/2014/main" id="{170720D0-E769-46B4-9D55-22A9EC224C05}"/>
               </a:ext>
             </a:extLst>
           </p:cNvPr>
@@ -10209,7 +8848,7 @@
           <p:cNvPr id="14" name="Reference 4 title">
             <a:extLst xmlns:a="http://schemas.openxmlformats.org/drawingml/2006/main">
               <a:ext uri="{FF2B5EF4-FFF2-40B4-BE49-F238E27FC236}">
-                <a16:creationId xmlns:a16="http://schemas.microsoft.com/office/drawing/2014/main" id="{E7E1390B-79DF-4113-9A6C-E822BFEF47F7}"/>
+                <a16:creationId xmlns:a16="http://schemas.microsoft.com/office/drawing/2014/main" id="{0B0C3A09-E5B9-4A9F-8106-928D49583A33}"/>
               </a:ext>
             </a:extLst>
           </p:cNvPr>
@@ -10255,7 +8894,7 @@
                 <a:latin typeface="Arial"/>
                 <a:ea typeface="Arial"/>
                 <a:cs typeface="Arial"/>
-                <a:hlinkClick xmlns:r="http://schemas.openxmlformats.org/officeDocument/2006/relationships" r:id="R4cc117fb0b804dd1"/>
+                <a:hlinkClick xmlns:r="http://schemas.openxmlformats.org/officeDocument/2006/relationships" r:id="R8f3cde6e33274fa1"/>
               </a:rPr>
               <a:t>Initiating and Documenting Goals of Care Discussion in Patients with Advanced Pancreatic and Colorectal Cancers: A Quality Improvement Project in a Low Resource Setting</a:t>
             </a:r>
@@ -10267,7 +8906,7 @@
           <p:cNvPr id="15" name="Reference 4 link">
             <a:extLst xmlns:a="http://schemas.openxmlformats.org/drawingml/2006/main">
               <a:ext uri="{FF2B5EF4-FFF2-40B4-BE49-F238E27FC236}">
-                <a16:creationId xmlns:a16="http://schemas.microsoft.com/office/drawing/2014/main" id="{6BC7A654-2AFB-4A9E-AE9D-8B0A78334239}"/>
+                <a16:creationId xmlns:a16="http://schemas.microsoft.com/office/drawing/2014/main" id="{72252E1C-EB71-4D9B-B085-83D284771A3F}"/>
               </a:ext>
             </a:extLst>
           </p:cNvPr>
@@ -10313,7 +8952,7 @@
                 <a:latin typeface="Arial"/>
                 <a:ea typeface="Arial"/>
                 <a:cs typeface="Arial"/>
-                <a:hlinkClick xmlns:r="http://schemas.openxmlformats.org/officeDocument/2006/relationships" r:id="R815cc88d79754926"/>
+                <a:hlinkClick xmlns:r="http://schemas.openxmlformats.org/officeDocument/2006/relationships" r:id="R8813362111c44402"/>
               </a:rPr>
               <a:t>https://doi.org/10.1177/26892820251392545</a:t>
             </a:r>
@@ -10325,7 +8964,7 @@
           <p:cNvPr id="16" name="Reference 5 author">
             <a:extLst xmlns:a="http://schemas.openxmlformats.org/drawingml/2006/main">
               <a:ext uri="{FF2B5EF4-FFF2-40B4-BE49-F238E27FC236}">
-                <a16:creationId xmlns:a16="http://schemas.microsoft.com/office/drawing/2014/main" id="{FF5CB745-D041-41CD-BF78-10E8008361D2}"/>
+                <a16:creationId xmlns:a16="http://schemas.microsoft.com/office/drawing/2014/main" id="{04AC6D2E-3015-4672-BD13-FB829A8B7E06}"/>
               </a:ext>
             </a:extLst>
           </p:cNvPr>
@@ -10382,7 +9021,7 @@
           <p:cNvPr id="17" name="Reference 5 title">
             <a:extLst xmlns:a="http://schemas.openxmlformats.org/drawingml/2006/main">
               <a:ext uri="{FF2B5EF4-FFF2-40B4-BE49-F238E27FC236}">
-                <a16:creationId xmlns:a16="http://schemas.microsoft.com/office/drawing/2014/main" id="{FB25FF3E-2C87-44F5-9A10-1F4DDA899873}"/>
+                <a16:creationId xmlns:a16="http://schemas.microsoft.com/office/drawing/2014/main" id="{D8E08E73-BA82-49B3-9CC1-96D43EF88436}"/>
               </a:ext>
             </a:extLst>
           </p:cNvPr>
@@ -10428,7 +9067,7 @@
                 <a:latin typeface="Arial"/>
                 <a:ea typeface="Arial"/>
                 <a:cs typeface="Arial"/>
-                <a:hlinkClick xmlns:r="http://schemas.openxmlformats.org/officeDocument/2006/relationships" r:id="R2d98ea2adcf5492e"/>
+                <a:hlinkClick xmlns:r="http://schemas.openxmlformats.org/officeDocument/2006/relationships" r:id="R9bf04d8b994e47cf"/>
               </a:rPr>
               <a:t>73% urban Indians do not know about their right to make a living will, finds a survey</a:t>
             </a:r>
@@ -10440,7 +9079,7 @@
           <p:cNvPr id="18" name="Reference 5 link">
             <a:extLst xmlns:a="http://schemas.openxmlformats.org/drawingml/2006/main">
               <a:ext uri="{FF2B5EF4-FFF2-40B4-BE49-F238E27FC236}">
-                <a16:creationId xmlns:a16="http://schemas.microsoft.com/office/drawing/2014/main" id="{462FC475-6C8E-4C1E-9FA8-5F1E22BFF081}"/>
+                <a16:creationId xmlns:a16="http://schemas.microsoft.com/office/drawing/2014/main" id="{2F9D331E-1BD7-4ADB-A1A9-3FEEEC0C95B0}"/>
               </a:ext>
             </a:extLst>
           </p:cNvPr>
@@ -10486,7 +9125,7 @@
                 <a:latin typeface="Arial"/>
                 <a:ea typeface="Arial"/>
                 <a:cs typeface="Arial"/>
-                <a:hlinkClick xmlns:r="http://schemas.openxmlformats.org/officeDocument/2006/relationships" r:id="R59ef83456d6341bc"/>
+                <a:hlinkClick xmlns:r="http://schemas.openxmlformats.org/officeDocument/2006/relationships" r:id="Rddfaae5f40354ab5"/>
               </a:rPr>
               <a:t>https://scroll.in/article/925875/73-urban-indians-do-not-know-about-their-right-to-make-a-living-will-finds-a-survey</a:t>
             </a:r>
@@ -10498,7 +9137,7 @@
           <p:cNvPr id="19" name="Reference 6 author">
             <a:extLst xmlns:a="http://schemas.openxmlformats.org/drawingml/2006/main">
               <a:ext uri="{FF2B5EF4-FFF2-40B4-BE49-F238E27FC236}">
-                <a16:creationId xmlns:a16="http://schemas.microsoft.com/office/drawing/2014/main" id="{99E71B0E-97E8-49F6-9F8C-B091ED98417B}"/>
+                <a16:creationId xmlns:a16="http://schemas.microsoft.com/office/drawing/2014/main" id="{7E7215C9-49C4-4012-9F4A-776105AEB539}"/>
               </a:ext>
             </a:extLst>
           </p:cNvPr>
@@ -10555,7 +9194,7 @@
           <p:cNvPr id="20" name="Reference 6 title">
             <a:extLst xmlns:a="http://schemas.openxmlformats.org/drawingml/2006/main">
               <a:ext uri="{FF2B5EF4-FFF2-40B4-BE49-F238E27FC236}">
-                <a16:creationId xmlns:a16="http://schemas.microsoft.com/office/drawing/2014/main" id="{DC4807CF-BA93-452A-878C-165483D9E6FD}"/>
+                <a16:creationId xmlns:a16="http://schemas.microsoft.com/office/drawing/2014/main" id="{610A748E-29D3-4454-A139-807409D56F92}"/>
               </a:ext>
             </a:extLst>
           </p:cNvPr>
@@ -10601,7 +9240,7 @@
                 <a:latin typeface="Arial"/>
                 <a:ea typeface="Arial"/>
                 <a:cs typeface="Arial"/>
-                <a:hlinkClick xmlns:r="http://schemas.openxmlformats.org/officeDocument/2006/relationships" r:id="Rc99b2de02fea4fcc"/>
+                <a:hlinkClick xmlns:r="http://schemas.openxmlformats.org/officeDocument/2006/relationships" r:id="Rf3bbc7d4209e4232"/>
               </a:rPr>
               <a:t>Knowledge and attitude towards advance directives for patients with terminal illnesses among doctors working in a tertiary care hospital</a:t>
             </a:r>
@@ -10613,7 +9252,7 @@
           <p:cNvPr id="21" name="Reference 6 link">
             <a:extLst xmlns:a="http://schemas.openxmlformats.org/drawingml/2006/main">
               <a:ext uri="{FF2B5EF4-FFF2-40B4-BE49-F238E27FC236}">
-                <a16:creationId xmlns:a16="http://schemas.microsoft.com/office/drawing/2014/main" id="{532CB3F1-AD4B-4163-9A10-C6F94AE88C56}"/>
+                <a16:creationId xmlns:a16="http://schemas.microsoft.com/office/drawing/2014/main" id="{8579756C-FE58-4EFA-94AF-2A3706E11298}"/>
               </a:ext>
             </a:extLst>
           </p:cNvPr>
@@ -10659,7 +9298,7 @@
                 <a:latin typeface="Arial"/>
                 <a:ea typeface="Arial"/>
                 <a:cs typeface="Arial"/>
-                <a:hlinkClick xmlns:r="http://schemas.openxmlformats.org/officeDocument/2006/relationships" r:id="Re4c86d7427a44f06"/>
+                <a:hlinkClick xmlns:r="http://schemas.openxmlformats.org/officeDocument/2006/relationships" r:id="Re513087f06b14cae"/>
               </a:rPr>
               <a:t>https://doi.org/10.25259/NMJI_817_2023</a:t>
             </a:r>
@@ -10671,7 +9310,7 @@
           <p:cNvPr id="22" name="Reference 7 author">
             <a:extLst xmlns:a="http://schemas.openxmlformats.org/drawingml/2006/main">
               <a:ext uri="{FF2B5EF4-FFF2-40B4-BE49-F238E27FC236}">
-                <a16:creationId xmlns:a16="http://schemas.microsoft.com/office/drawing/2014/main" id="{A251DDDE-B9AB-47E6-A420-597CC700BFAB}"/>
+                <a16:creationId xmlns:a16="http://schemas.microsoft.com/office/drawing/2014/main" id="{877BE95D-5BA1-4273-B3F9-4B83D9B2C292}"/>
               </a:ext>
             </a:extLst>
           </p:cNvPr>
@@ -10728,7 +9367,7 @@
           <p:cNvPr id="23" name="Reference 7 title">
             <a:extLst xmlns:a="http://schemas.openxmlformats.org/drawingml/2006/main">
               <a:ext uri="{FF2B5EF4-FFF2-40B4-BE49-F238E27FC236}">
-                <a16:creationId xmlns:a16="http://schemas.microsoft.com/office/drawing/2014/main" id="{53D16A98-581E-4F8F-8321-6DFDCE834CCE}"/>
+                <a16:creationId xmlns:a16="http://schemas.microsoft.com/office/drawing/2014/main" id="{07F7C807-B4BA-45CB-B110-5B91C9103B65}"/>
               </a:ext>
             </a:extLst>
           </p:cNvPr>
@@ -10774,7 +9413,7 @@
                 <a:latin typeface="Arial"/>
                 <a:ea typeface="Arial"/>
                 <a:cs typeface="Arial"/>
-                <a:hlinkClick xmlns:r="http://schemas.openxmlformats.org/officeDocument/2006/relationships" r:id="R337869d4c1aa4b9e"/>
+                <a:hlinkClick xmlns:r="http://schemas.openxmlformats.org/officeDocument/2006/relationships" r:id="R8c24cf8724cb4323"/>
               </a:rPr>
               <a:t>Barriers and Facilitators to Advance Care Planning Implementation for Patients with Neurodegenerative Diseases among Indian Physicians: A Mixed-Methods Analysis</a:t>
             </a:r>
@@ -10786,7 +9425,7 @@
           <p:cNvPr id="24" name="Reference 7 link">
             <a:extLst xmlns:a="http://schemas.openxmlformats.org/drawingml/2006/main">
               <a:ext uri="{FF2B5EF4-FFF2-40B4-BE49-F238E27FC236}">
-                <a16:creationId xmlns:a16="http://schemas.microsoft.com/office/drawing/2014/main" id="{B7B77071-8B9C-4248-AB3E-59A57113761A}"/>
+                <a16:creationId xmlns:a16="http://schemas.microsoft.com/office/drawing/2014/main" id="{89FFC083-413F-49FE-8634-C7153D3CE170}"/>
               </a:ext>
             </a:extLst>
           </p:cNvPr>
@@ -10832,7 +9471,7 @@
                 <a:latin typeface="Arial"/>
                 <a:ea typeface="Arial"/>
                 <a:cs typeface="Arial"/>
-                <a:hlinkClick xmlns:r="http://schemas.openxmlformats.org/officeDocument/2006/relationships" r:id="R5919be9b485044c4"/>
+                <a:hlinkClick xmlns:r="http://schemas.openxmlformats.org/officeDocument/2006/relationships" r:id="Rb395bf2dcfe74b36"/>
               </a:rPr>
               <a:t>https://doi.org/10.1101/2025.10.17.25338242</a:t>
             </a:r>
@@ -10844,7 +9483,7 @@
           <p:cNvPr id="25" name="Reference 8 author">
             <a:extLst xmlns:a="http://schemas.openxmlformats.org/drawingml/2006/main">
               <a:ext uri="{FF2B5EF4-FFF2-40B4-BE49-F238E27FC236}">
-                <a16:creationId xmlns:a16="http://schemas.microsoft.com/office/drawing/2014/main" id="{C4975B5C-C56D-4AD5-8E65-798E4F6A6D9E}"/>
+                <a16:creationId xmlns:a16="http://schemas.microsoft.com/office/drawing/2014/main" id="{695528D8-0797-482D-818D-E9057525D24D}"/>
               </a:ext>
             </a:extLst>
           </p:cNvPr>
@@ -10901,7 +9540,7 @@
           <p:cNvPr id="26" name="Reference 8 title">
             <a:extLst xmlns:a="http://schemas.openxmlformats.org/drawingml/2006/main">
               <a:ext uri="{FF2B5EF4-FFF2-40B4-BE49-F238E27FC236}">
-                <a16:creationId xmlns:a16="http://schemas.microsoft.com/office/drawing/2014/main" id="{244A1FCE-0B3C-46A4-A37D-5EA127F6DC34}"/>
+                <a16:creationId xmlns:a16="http://schemas.microsoft.com/office/drawing/2014/main" id="{C5C639F9-0794-4F4A-8AED-E513815E0C9D}"/>
               </a:ext>
             </a:extLst>
           </p:cNvPr>
@@ -10947,7 +9586,7 @@
                 <a:latin typeface="Arial"/>
                 <a:ea typeface="Arial"/>
                 <a:cs typeface="Arial"/>
-                <a:hlinkClick xmlns:r="http://schemas.openxmlformats.org/officeDocument/2006/relationships" r:id="Ra397577d3cf341a2"/>
+                <a:hlinkClick xmlns:r="http://schemas.openxmlformats.org/officeDocument/2006/relationships" r:id="Rd3b545c818d14e33"/>
               </a:rPr>
               <a:t>An Ethnographic Study of Barriers to Cancer Pain Management and Opioid Availability in India</a:t>
             </a:r>
@@ -10959,7 +9598,7 @@
           <p:cNvPr id="27" name="Reference 8 link">
             <a:extLst xmlns:a="http://schemas.openxmlformats.org/drawingml/2006/main">
               <a:ext uri="{FF2B5EF4-FFF2-40B4-BE49-F238E27FC236}">
-                <a16:creationId xmlns:a16="http://schemas.microsoft.com/office/drawing/2014/main" id="{325B0C27-9E2B-4CA8-A3DB-80EA57E1C40E}"/>
+                <a16:creationId xmlns:a16="http://schemas.microsoft.com/office/drawing/2014/main" id="{164CA88E-8043-4FB7-B80C-596B93B9DA81}"/>
               </a:ext>
             </a:extLst>
           </p:cNvPr>
@@ -11005,7 +9644,7 @@
                 <a:latin typeface="Arial"/>
                 <a:ea typeface="Arial"/>
                 <a:cs typeface="Arial"/>
-                <a:hlinkClick xmlns:r="http://schemas.openxmlformats.org/officeDocument/2006/relationships" r:id="R5bb9e085a56442f1"/>
+                <a:hlinkClick xmlns:r="http://schemas.openxmlformats.org/officeDocument/2006/relationships" r:id="R3782eab2726146fe"/>
               </a:rPr>
               <a:t>https://doi.org/10.1634/theoncologist.2013-0435</a:t>
             </a:r>
@@ -11017,7 +9656,7 @@
           <p:cNvPr id="28" name="Reference 9 author">
             <a:extLst xmlns:a="http://schemas.openxmlformats.org/drawingml/2006/main">
               <a:ext uri="{FF2B5EF4-FFF2-40B4-BE49-F238E27FC236}">
-                <a16:creationId xmlns:a16="http://schemas.microsoft.com/office/drawing/2014/main" id="{E7979A23-1D43-4F3F-8D50-DBB64BD84B8A}"/>
+                <a16:creationId xmlns:a16="http://schemas.microsoft.com/office/drawing/2014/main" id="{CB6B38E1-D2F0-42A0-9C78-2ABFA26E6949}"/>
               </a:ext>
             </a:extLst>
           </p:cNvPr>
@@ -11074,7 +9713,7 @@
           <p:cNvPr id="29" name="Reference 9 title">
             <a:extLst xmlns:a="http://schemas.openxmlformats.org/drawingml/2006/main">
               <a:ext uri="{FF2B5EF4-FFF2-40B4-BE49-F238E27FC236}">
-                <a16:creationId xmlns:a16="http://schemas.microsoft.com/office/drawing/2014/main" id="{713701DA-1269-48C6-8CBD-57E85D624787}"/>
+                <a16:creationId xmlns:a16="http://schemas.microsoft.com/office/drawing/2014/main" id="{3E08A552-CB42-49AB-BEAF-45029894E647}"/>
               </a:ext>
             </a:extLst>
           </p:cNvPr>
@@ -11120,7 +9759,7 @@
                 <a:latin typeface="Arial"/>
                 <a:ea typeface="Arial"/>
                 <a:cs typeface="Arial"/>
-                <a:hlinkClick xmlns:r="http://schemas.openxmlformats.org/officeDocument/2006/relationships" r:id="Rbeb1385177ad4367"/>
+                <a:hlinkClick xmlns:r="http://schemas.openxmlformats.org/officeDocument/2006/relationships" r:id="R11add638ba134f02"/>
               </a:rPr>
               <a:t>Receipt of Psychosocial Care Among Cancer Survivors in the United States</a:t>
             </a:r>
@@ -11132,7 +9771,7 @@
           <p:cNvPr id="30" name="Reference 9 link">
             <a:extLst xmlns:a="http://schemas.openxmlformats.org/drawingml/2006/main">
               <a:ext uri="{FF2B5EF4-FFF2-40B4-BE49-F238E27FC236}">
-                <a16:creationId xmlns:a16="http://schemas.microsoft.com/office/drawing/2014/main" id="{023BFF9C-FF78-49E4-BD65-71C744E7C88D}"/>
+                <a16:creationId xmlns:a16="http://schemas.microsoft.com/office/drawing/2014/main" id="{D6154259-A463-4C9E-81DC-A107E41CA500}"/>
               </a:ext>
             </a:extLst>
           </p:cNvPr>
@@ -11178,7 +9817,7 @@
                 <a:latin typeface="Arial"/>
                 <a:ea typeface="Arial"/>
                 <a:cs typeface="Arial"/>
-                <a:hlinkClick xmlns:r="http://schemas.openxmlformats.org/officeDocument/2006/relationships" r:id="R8584764cb0c64d3c"/>
+                <a:hlinkClick xmlns:r="http://schemas.openxmlformats.org/officeDocument/2006/relationships" r:id="Re3414ef1901c4d2d"/>
               </a:rPr>
               <a:t>https://doi.org/10.1200/JCO.2012.46.2101</a:t>
             </a:r>

</xml_diff>

<commit_message>
Lead with the patient home and show conversation recording
</commit_message>
<xml_diff>
--- a/submission/Saathi_Healthathon_Final.pptx
+++ b/submission/Saathi_Healthathon_Final.pptx
@@ -2,20 +2,20 @@
 <file path=ppt/presentation.xml><?xml version="1.0" encoding="utf-8"?>
 <p:presentation xmlns:p="http://schemas.openxmlformats.org/presentationml/2006/main">
   <p:sldMasterIdLst>
-    <p:sldMasterId xmlns:r="http://schemas.openxmlformats.org/officeDocument/2006/relationships" id="2147483648" r:id="R179ae768ea0b400c"/>
+    <p:sldMasterId xmlns:r="http://schemas.openxmlformats.org/officeDocument/2006/relationships" id="2147483648" r:id="R2f37da97b7c744c3"/>
   </p:sldMasterIdLst>
   <p:notesMasterIdLst>
-    <p:notesMasterId xmlns:r="http://schemas.openxmlformats.org/officeDocument/2006/relationships" r:id="Rf79ebac7195e44aa"/>
+    <p:notesMasterId xmlns:r="http://schemas.openxmlformats.org/officeDocument/2006/relationships" r:id="R7793016c0c6c4bd7"/>
   </p:notesMasterIdLst>
   <p:sldIdLst>
-    <p:sldId xmlns:r="http://schemas.openxmlformats.org/officeDocument/2006/relationships" id="256" r:id="R4a7c2b4e74d745e7"/>
-    <p:sldId xmlns:r="http://schemas.openxmlformats.org/officeDocument/2006/relationships" id="257" r:id="R7bc417c98a524080"/>
-    <p:sldId xmlns:r="http://schemas.openxmlformats.org/officeDocument/2006/relationships" id="258" r:id="Rabe58e0939444e20"/>
-    <p:sldId xmlns:r="http://schemas.openxmlformats.org/officeDocument/2006/relationships" id="259" r:id="Rbc25a46361824dd6"/>
-    <p:sldId xmlns:r="http://schemas.openxmlformats.org/officeDocument/2006/relationships" id="260" r:id="R438f337bda9a4eed"/>
-    <p:sldId xmlns:r="http://schemas.openxmlformats.org/officeDocument/2006/relationships" id="261" r:id="R8c5ef62f1387490d"/>
-    <p:sldId xmlns:r="http://schemas.openxmlformats.org/officeDocument/2006/relationships" id="262" r:id="R1d9a479dcac441e6"/>
-    <p:sldId xmlns:r="http://schemas.openxmlformats.org/officeDocument/2006/relationships" id="263" r:id="Rcec1c45489b04266"/>
+    <p:sldId xmlns:r="http://schemas.openxmlformats.org/officeDocument/2006/relationships" id="256" r:id="Rd7b0edfa8b5b410d"/>
+    <p:sldId xmlns:r="http://schemas.openxmlformats.org/officeDocument/2006/relationships" id="257" r:id="R1f1b9d6e8b784518"/>
+    <p:sldId xmlns:r="http://schemas.openxmlformats.org/officeDocument/2006/relationships" id="258" r:id="R3930a2f2e1e04b9e"/>
+    <p:sldId xmlns:r="http://schemas.openxmlformats.org/officeDocument/2006/relationships" id="259" r:id="R4500c2a858714391"/>
+    <p:sldId xmlns:r="http://schemas.openxmlformats.org/officeDocument/2006/relationships" id="260" r:id="Rd1e9c3bf28914e77"/>
+    <p:sldId xmlns:r="http://schemas.openxmlformats.org/officeDocument/2006/relationships" id="261" r:id="Re5e13c508e6d4d32"/>
+    <p:sldId xmlns:r="http://schemas.openxmlformats.org/officeDocument/2006/relationships" id="262" r:id="Rf1a6db1328ab4781"/>
+    <p:sldId xmlns:r="http://schemas.openxmlformats.org/officeDocument/2006/relationships" id="263" r:id="Re25fbfc9e15a48f8"/>
   </p:sldIdLst>
   <p:sldSz cx="12192000" cy="6858000"/>
   <p:notesSz cx="6858000" cy="9144000"/>
@@ -449,7 +449,7 @@
           <a:lstStyle xmlns:a="http://schemas.openxmlformats.org/drawingml/2006/main"/>
           <a:p xmlns:a="http://schemas.openxmlformats.org/drawingml/2006/main">
             <a:r>
-              <a:t>Saathi (साथी) means companion. The five named people are the current team; Shirin Ayub was added in the user's latest roster. Basith and Awaiz portraits are original team assets from the DevIT ITI deck, with provenance in submission/assets/2026-09-24-team/README.md. Blank spaces are intentionally reserved for the other members' photos. Roles use the supplied roster. The app logo is extracted from the actual app. GitHub and WhatsApp marks use Simple Icons paths; the WhatsApp mark is coloured green. The QR and OPEN THE WEBSITE link open https://saathi.wedevit.in/. GitHub opens the public project repository; WhatsApp is a contact for questions, not an access request. Entry: Cancer / Patient and Caregiver / Family &amp; Caregiver Support. The cover describes the family-support purpose, not a claim that transport booking, payments or connected AI are operational.</a:t>
+              <a:t>Both images are actual Chrome captures of https://saathi.wedevit.in/home for this revision, saved as output/playwright/2026-09-24-saathi-patient-home.png and output/playwright/2026-09-24-saathi-three-role-login.png. The sign-in image is cropped inside PowerPoint to the original form; no UI has been redrawn. The patient image includes the complete home page, showing the latest Care Note, documents, Find support, My space, Calendar, the upcoming visit and medicine and family-help shortcuts. Meera and the other stored records are fictional. The three current role choices are Patient, Family and Doctor. Patient sign-in was exercised with a different arbitrary 14-digit value and opened the existing patient home. This checks the present format-only entry flow, not real ABHA authentication or permission to open another person's medical records. Verified accounts and sharing between phones remain to connect. This is the broader intended family-support workflow, not a claim of completed rides, guaranteed stock, payments or a deployed financial-assistance system. Patients and families can keep questions, records, confirmed treatment dates, medicine and appointment plans, named tasks, journal entries and support contacts together. Receipts, financial-help paperwork and caregiver-training handoffs remain proposed supporting work. The doctor reviews and signs first; the patient reviews and signs the same version. Directory: Pallium India, https://palliumindia.org/clinics/telangana, lists home/inpatient/outpatient services and medicine availability. The family must call to confirm the prescribed medicine and service; a listing does not establish today's stock, oral formulation or a booked appointment. Caregiver support evidence: https://journals.plos.org/plosone/article?id=10.1371/journal.pone.0274770 supports information, training, practical and emotional support needs. Additional sources: both meeting transcripts and the user's feedback.</a:t>
             </a:r>
           </a:p>
         </p:txBody>
@@ -519,7 +519,7 @@
           <a:lstStyle xmlns:a="http://schemas.openxmlformats.org/drawingml/2006/main"/>
           <a:p xmlns:a="http://schemas.openxmlformats.org/drawingml/2006/main">
             <a:r>
-              <a:t>Illustrative story supplied by the team, not a reported patient case. A 62-year-old woman with advanced breast cancer receives best supportive care. Her husband attends the first discussion. In the later crisis the husband and daughter disagree about attempts to restart her heart and her son is in another city. The story does not recommend or reject emergency treatment. A Care Note records wishes and discussion; it is not an automatic treatment order or a legal advance directive. The contextual photo is a real medical camp in Mannar, Alappuzha district, Kerala, 23 August 2011. It does not depict this story, a cancer-specific visit or a Saathi user. Photo credit: Ministry of Information &amp; Broadcasting / Press Information Bureau, Government of India, photo ID 36197, CNR 39173. Source: https://commons.wikimedia.org/wiki/File:A_medical_camp_conducted_as_part_of_the_public_information_campaign_organized_by_PIB_Thiruvananthapuram,_at_Mannar,_in_Alappuzha_district,_Kerala_on_August_23,_2011.jpg ; original source https://archive.pib.gov.in/photo.aspx?photoid=36197 . Licensed under Government Open Data License – India, https://data.gov.in/sites/default/files/Gazette_Notification_OGDL.pdf . Displayed without image alterations apart from resizing. No government endorsement is implied. Icons: Lucide, https://lucide.dev/license, ISC/MIT, SVG paths unchanged and colours adapted. Full license and credits: submission/assets/2026-09-24-family/. Story sources: docs/meetings/2026-09-23-chat-follow-up.md and both meetings this week.</a:t>
+              <a:t>Saathi (साथी) means companion. The five named people are the current team; Shirin Ayub was added in the user's latest roster. Basith and Awaiz portraits are original team assets from the DevIT ITI deck, with provenance in submission/assets/2026-09-24-team/README.md. Blank spaces are intentionally reserved for the other members' photos. Roles use the supplied roster. The app logo is extracted from the actual app. GitHub and WhatsApp marks use Simple Icons paths; the WhatsApp mark is coloured green. The QR and OPEN THE WEBSITE link open https://saathi.wedevit.in/. GitHub opens the public project repository; WhatsApp is a contact for questions, not an access request. Entry: Cancer / Patient and Caregiver / Family &amp; Caregiver Support. The cover describes the family-support purpose, not a claim that transport booking, payments or connected AI are operational.</a:t>
             </a:r>
           </a:p>
         </p:txBody>
@@ -589,7 +589,7 @@
           <a:lstStyle xmlns:a="http://schemas.openxmlformats.org/drawingml/2006/main"/>
           <a:p xmlns:a="http://schemas.openxmlformats.org/drawingml/2006/main">
             <a:r>
-              <a:t>Five findings with distinct scopes, verified in docs/pitch/2026-09-24-verified-evidence.md: IARC GLOBOCAN estimates 1,562,581 new cancer cases in India in 2024, rounded to 15.6 lakh. Patil et al. report 98.39% unmet palliative-care need among metastatic cancer cases across ten cancer types, using the NCRP 2020 report; this is not all cancer patients and must not be multiplied by the incidence estimate. The 88% figure is from IndiaSpend reporting of the 2019 HCAH Living Will Survey of over 2,400 urban respondents in seven cities; the original survey was inaccessible and this is not a cancer-only or national sample. Jacob et al. report 45 of 391 doctors (11.5%) with prior advance-directive training at CMC Vellore, not a national estimate. Thangasamy et al. report 0% to 92% documented discussions, with 24 of 26 eligible advanced pancreatic or colorectal cancer patients in one Chennai quality-improvement project. A structured process, form and team work produced this result; this was not a Saathi or AI intervention. The native chart and source workbook are preserved byte-for-byte from the existing supplied pitch chart. Each short source credit is a native hyperlink and the full nine-source list remains on slide 8. Icons: Lucide, ISC/MIT, https://lucide.dev/license, source SVGs and full license in submission/assets/2026-09-24-family/.</a:t>
+              <a:t>Illustrative story supplied by the team, not a reported patient case. A 62-year-old woman with advanced breast cancer receives best supportive care. Her husband attends the first discussion. In the later crisis the husband and daughter disagree about attempts to restart her heart and her son is in another city. The story does not recommend or reject emergency treatment. A Care Note records wishes and discussion; it is not an automatic treatment order or a legal advance directive. The contextual photo is a real medical camp in Mannar, Alappuzha district, Kerala, 23 August 2011. It does not depict this story, a cancer-specific visit or a Saathi user. Photo credit: Ministry of Information &amp; Broadcasting / Press Information Bureau, Government of India, photo ID 36197, CNR 39173. Source: https://commons.wikimedia.org/wiki/File:A_medical_camp_conducted_as_part_of_the_public_information_campaign_organized_by_PIB_Thiruvananthapuram,_at_Mannar,_in_Alappuzha_district,_Kerala_on_August_23,_2011.jpg ; original source https://archive.pib.gov.in/photo.aspx?photoid=36197 . Licensed under Government Open Data License – India, https://data.gov.in/sites/default/files/Gazette_Notification_OGDL.pdf . Displayed without image alterations apart from resizing. No government endorsement is implied. Icons: Lucide, https://lucide.dev/license, ISC/MIT, SVG paths unchanged and colours adapted. Full license and credits: submission/assets/2026-09-24-family/. Story sources: docs/meetings/2026-09-23-chat-follow-up.md and both meetings this week.</a:t>
             </a:r>
           </a:p>
         </p:txBody>
@@ -659,7 +659,7 @@
           <a:lstStyle xmlns:a="http://schemas.openxmlformats.org/drawingml/2006/main"/>
           <a:p xmlns:a="http://schemas.openxmlformats.org/drawingml/2006/main">
             <a:r>
-              <a:t>This is the central proposed AI workflow, not a claim that a model is already connected. With recording consent, a transcript or existing note becomes a source-linked draft. The doctor can edit, reject or correct it in a distinct review step, and signs first. The patient then reviews and signs that exact version; changed wording requires a newly reviewed version. Unanswered questions remain unanswered. No diagnosis, treatment recommendation, risk scoring or interpretation of medical results. Clinical choices from the supplied Healthathon form and Saanthvana v 1.0 document belong to the clinician, not the AI. Today the browser app supports recording, source-based rule preparation, editing and typed-name signing. Reliable transcription, model integration, verified accounts and sharing between phones remain to connect. A typed name is not a verified digital signature; a Care Note is not a legal advance directive. Sarvam AI is a proposed provider for Indian-language speech-to-text, translation and read-aloud, supported by official documentation: https://docs.sarvam.ai/api/getting-started/building-for-india and https://docs.sarvam.ai/api-reference/speech-to-text/transcribe. No provider version or working connection is claimed. Screenshot is a fresh real Chrome capture at https://saathi.wedevit.in/doctor/review on 24 September, saved to output/playwright/2026-09-24-saathi-doctor-review.png. The seeded Meera text was prepared using the normal app controls and a faithful wording edit; the draft remains unsigned and is not an actual clinical record. Sources: 21 September transcript lines 251–303 and 1097–1155; 23 September meeting and chat; Sujay's 24 September feedback; supplied clinical forms.</a:t>
+              <a:t>This is the central proposed AI workflow, not a claim that a model is already connected. With recording consent, a transcript or existing note becomes a source-linked draft. The doctor can edit, reject or correct it in a distinct review step, and signs first. The patient then reviews and signs that exact version; changed wording requires a newly reviewed version. Unanswered questions remain unanswered. No diagnosis, treatment recommendation, risk scoring or interpretation of medical results. Clinical choices from the supplied Healthathon form and Saanthvana v 1.0 document belong to the clinician, not the AI. Today the browser app supports recording, source-based rule preparation, editing and typed-name signing. Reliable transcription, model integration, verified accounts and sharing between phones remain to connect. A typed name is not a verified digital signature; a Care Note is not a legal advance directive. Sarvam AI is a proposed provider for Indian-language speech-to-text, translation and read-aloud, supported by official documentation: https://docs.sarvam.ai/api/getting-started/building-for-india and https://docs.sarvam.ai/api-reference/speech-to-text/transcribe. No provider version or working connection is claimed. The recording screen is the actual app screenshot supplied by the user on 24 September, preserved unchanged at submission/assets/2026-09-24-family/saathi-record-conversation.png. It shows the Voice note panel, recording consent, Start recording, English language selection, Upload audio and the Prepare draft, Review &amp; edit and Sign Care Note steps. This image shows the interface before recording; it does not establish that microphone capture or live transcription has been verified. The displayed Meera profile is fictional. Sources: 21 September transcript lines 251–303 and 1097–1155; 23 September meeting and chat; Sujay's 24 September feedback; supplied clinical forms.</a:t>
             </a:r>
           </a:p>
         </p:txBody>
@@ -729,7 +729,7 @@
           <a:lstStyle xmlns:a="http://schemas.openxmlformats.org/drawingml/2006/main"/>
           <a:p xmlns:a="http://schemas.openxmlformats.org/drawingml/2006/main">
             <a:r>
-              <a:t>This slide describes three AI jobs adopted in the meetings: answer questions from the patient's own files with the exact source passage; prepare a dated treatment history from recorded chemotherapy and radiotherapy dates; read medicine details from printed or typed prescriptions for a person to check before adding reminders. Current workflow explicitly asks a person to check extracted text before saving it and to confirm a treatment happened and supply its date before adding it to the care timeline. A report or appointment date must not be inferred as a completed treatment date. Handwritten prescription recognition was not adopted. The screenshot is a fresh real Chrome capture of the live Saathi app on 24 September, showing literal retrieval from a fictional stored record, neutral saved-text provenance, Add treatment date and View original. It does not demonstrate connected semantic AI or image OCR. Provider integration code exists but live model calls are not enabled or verified. AI must not interpret test results or create clinical advice. Sources: 21 September transcript lines 1025–1043, 1099–1123 and 1135–1151; 23 September transcript lines 269–277; output/playwright/2026-09-24-saathi-documents-source.png.</a:t>
+              <a:t>Five findings with distinct scopes, verified in docs/pitch/2026-09-24-verified-evidence.md: IARC GLOBOCAN estimates 1,562,581 new cancer cases in India in 2024, rounded to 15.6 lakh. Patil et al. report 98.39% unmet palliative-care need among metastatic cancer cases across ten cancer types, using the NCRP 2020 report; this is not all cancer patients and must not be multiplied by the incidence estimate. The 88% figure is from IndiaSpend reporting of the 2019 HCAH Living Will Survey of over 2,400 urban respondents in seven cities; the original survey was inaccessible and this is not a cancer-only or national sample. Jacob et al. report 45 of 391 doctors (11.5%) with prior advance-directive training at CMC Vellore, not a national estimate. Thangasamy et al. report 0% to 92% documented discussions, with 24 of 26 eligible advanced pancreatic or colorectal cancer patients in one Chennai quality-improvement project. A structured process, form and team work produced this result; this was not a Saathi or AI intervention. The native chart and source workbook are preserved byte-for-byte from the existing supplied pitch chart. Each short source credit is a native hyperlink and the full nine-source list remains on slide 8. Icons: Lucide, ISC/MIT, https://lucide.dev/license, source SVGs and full license in submission/assets/2026-09-24-family/.</a:t>
             </a:r>
           </a:p>
         </p:txBody>
@@ -799,7 +799,7 @@
           <a:lstStyle xmlns:a="http://schemas.openxmlformats.org/drawingml/2006/main"/>
           <a:p xmlns:a="http://schemas.openxmlformats.org/drawingml/2006/main">
             <a:r>
-              <a:t>Both images are actual Chrome captures of https://saathi.wedevit.in/home for this revision, saved as output/playwright/2026-09-24-saathi-patient-home.png and output/playwright/2026-09-24-saathi-three-role-login.png. The sign-in image is cropped inside PowerPoint to the original form; no UI has been redrawn. The patient image includes the complete home page, showing the latest Care Note, documents, Find support, My space, Calendar, the upcoming visit and medicine and family-help shortcuts. Meera and the other stored records are fictional. The three current role choices are Patient, Family and Doctor. Patient sign-in was exercised with a different arbitrary 14-digit value and opened the existing patient home. This checks the present format-only entry flow, not real ABHA authentication or permission to open another person's medical records. Verified accounts and sharing between phones remain to connect. This is the broader intended family-support workflow, not a claim of completed rides, guaranteed stock, payments or a deployed financial-assistance system. Patients and families can keep questions, records, confirmed treatment dates, medicine and appointment plans, named tasks, journal entries and support contacts together. Receipts, financial-help paperwork and caregiver-training handoffs remain proposed supporting work. The doctor reviews and signs first; the patient reviews and signs the same version. Directory: Pallium India, https://palliumindia.org/clinics/telangana, lists home/inpatient/outpatient services and medicine availability. The family must call to confirm the prescribed medicine and service; a listing does not establish today's stock, oral formulation or a booked appointment. Caregiver support evidence: https://journals.plos.org/plosone/article?id=10.1371/journal.pone.0274770 supports information, training, practical and emotional support needs. Additional sources: both meeting transcripts and the user's feedback.</a:t>
+              <a:t>This slide describes three AI jobs adopted in the meetings: answer questions from the patient's own files with the exact source passage; prepare a dated treatment history from recorded chemotherapy and radiotherapy dates; read medicine details from printed or typed prescriptions for a person to check before adding reminders. Current workflow explicitly asks a person to check extracted text before saving it and to confirm a treatment happened and supply its date before adding it to the care timeline. A report or appointment date must not be inferred as a completed treatment date. Handwritten prescription recognition was not adopted. The screenshot is a fresh real Chrome capture of the live Saathi app on 24 September, showing literal retrieval from a fictional stored record, neutral saved-text provenance, Add treatment date and View original. It does not demonstrate connected semantic AI or image OCR. Provider integration code exists but live model calls are not enabled or verified. AI must not interpret test results or create clinical advice. Sources: 21 September transcript lines 1025–1043, 1099–1123 and 1135–1151; 23 September transcript lines 269–277; output/playwright/2026-09-24-saathi-documents-source.png.</a:t>
             </a:r>
           </a:p>
         </p:txBody>
@@ -1387,7 +1387,7 @@
   </p:cSld>
   <p:clrMap bg1="lt1" tx1="dk1" bg2="lt2" tx2="dk2" accent1="accent1" accent2="accent2" accent3="accent3" accent4="accent4" accent5="accent5" accent6="accent6" hlink="hlink" folHlink="folHlink"/>
   <p:sldLayoutIdLst>
-    <p:sldLayoutId xmlns:r="http://schemas.openxmlformats.org/officeDocument/2006/relationships" id="2147483649" r:id="R0cca68611fc445c5"/>
+    <p:sldLayoutId xmlns:r="http://schemas.openxmlformats.org/officeDocument/2006/relationships" id="2147483649" r:id="Rd919e9f25ca4477c"/>
   </p:sldLayoutIdLst>
   <p:txStyles>
     <p:titleStyle>
@@ -2122,6 +2122,537 @@
     <p:bg>
       <p:bgPr>
         <a:solidFill xmlns:a="http://schemas.openxmlformats.org/drawingml/2006/main">
+          <a:srgbClr val="FCFAF4"/>
+        </a:solidFill>
+      </p:bgPr>
+    </p:bg>
+    <p:spTree>
+      <p:nvGrpSpPr>
+        <p:cNvPr id="1" name=""/>
+        <p:cNvGrpSpPr/>
+        <p:nvPr/>
+      </p:nvGrpSpPr>
+      <p:grpSpPr>
+        <a:xfrm xmlns:a="http://schemas.openxmlformats.org/drawingml/2006/main"/>
+      </p:grpSpPr>
+      <p:sp>
+        <p:nvSpPr>
+          <p:cNvPr id="11" name="Slide title">
+            <a:extLst xmlns:a="http://schemas.openxmlformats.org/drawingml/2006/main">
+              <a:ext uri="{FF2B5EF4-FFF2-40B4-BE49-F238E27FC236}">
+                <a16:creationId xmlns:a16="http://schemas.microsoft.com/office/drawing/2014/main" id="{DD9D4ABF-4CA6-435C-831E-E44F4365E262}"/>
+              </a:ext>
+            </a:extLst>
+          </p:cNvPr>
+          <p:cNvSpPr>
+            <a:spLocks xmlns:a="http://schemas.openxmlformats.org/drawingml/2006/main" noGrp="1"/>
+          </p:cNvSpPr>
+          <p:nvPr/>
+        </p:nvSpPr>
+        <p:spPr>
+          <a:xfrm xmlns:a="http://schemas.openxmlformats.org/drawingml/2006/main">
+            <a:off x="533400" y="361950"/>
+            <a:ext cx="11125200" cy="581025"/>
+          </a:xfrm>
+          <a:prstGeom xmlns:a="http://schemas.openxmlformats.org/drawingml/2006/main" prst="rect">
+            <a:avLst/>
+          </a:prstGeom>
+          <a:noFill xmlns:a="http://schemas.openxmlformats.org/drawingml/2006/main"/>
+          <a:ln xmlns:a="http://schemas.openxmlformats.org/drawingml/2006/main" w="0">
+            <a:noFill/>
+          </a:ln>
+        </p:spPr>
+        <p:txBody>
+          <a:bodyPr xmlns:a="http://schemas.openxmlformats.org/drawingml/2006/main" wrap="square" lIns="0" tIns="0" rIns="0" bIns="0">
+            <a:normAutofit fontScale="100000"/>
+          </a:bodyPr>
+          <a:lstStyle xmlns:a="http://schemas.openxmlformats.org/drawingml/2006/main"/>
+          <a:p xmlns:a="http://schemas.openxmlformats.org/drawingml/2006/main">
+            <a:pPr>
+              <a:defRPr sz="3000" b="1">
+                <a:solidFill>
+                  <a:srgbClr val="173F33"/>
+                </a:solidFill>
+                <a:latin typeface="Arial"/>
+                <a:ea typeface="Arial"/>
+                <a:cs typeface="Arial"/>
+              </a:defRPr>
+            </a:pPr>
+            <a:r>
+              <a:rPr sz="3000" b="1">
+                <a:solidFill>
+                  <a:srgbClr val="173F33"/>
+                </a:solidFill>
+                <a:latin typeface="Arial"/>
+                <a:ea typeface="Arial"/>
+                <a:cs typeface="Arial"/>
+              </a:rPr>
+              <a:t>Saathi keeps your cancer care in one place.</a:t>
+            </a:r>
+          </a:p>
+        </p:txBody>
+      </p:sp>
+      <p:pic>
+        <p:nvPicPr>
+          <p:cNvPr id="12" name=""/>
+          <p:cNvPicPr>
+            <a:picLocks xmlns:a="http://schemas.openxmlformats.org/drawingml/2006/main" noChangeAspect="1"/>
+          </p:cNvPicPr>
+          <p:nvPr/>
+        </p:nvPicPr>
+        <p:blipFill>
+          <a:blip xmlns:r="http://schemas.openxmlformats.org/officeDocument/2006/relationships" xmlns:a="http://schemas.openxmlformats.org/drawingml/2006/main" r:embed="R81cb9184f8c74217"/>
+          <a:stretch xmlns:a="http://schemas.openxmlformats.org/drawingml/2006/main"/>
+        </p:blipFill>
+        <p:spPr>
+          <a:xfrm xmlns:a="http://schemas.openxmlformats.org/drawingml/2006/main">
+            <a:off x="273222" y="1066800"/>
+            <a:ext cx="8673757" cy="5067300"/>
+          </a:xfrm>
+          <a:prstGeom xmlns:a="http://schemas.openxmlformats.org/drawingml/2006/main" prst="rect">
+            <a:avLst/>
+          </a:prstGeom>
+        </p:spPr>
+      </p:pic>
+      <p:sp>
+        <p:nvSpPr>
+          <p:cNvPr id="3" name="Three sign-ins">
+            <a:extLst xmlns:a="http://schemas.openxmlformats.org/drawingml/2006/main">
+              <a:ext uri="{FF2B5EF4-FFF2-40B4-BE49-F238E27FC236}">
+                <a16:creationId xmlns:a16="http://schemas.microsoft.com/office/drawing/2014/main" id="{3D02207E-A809-431E-91DE-60EA620C8DBE}"/>
+              </a:ext>
+            </a:extLst>
+          </p:cNvPr>
+          <p:cNvSpPr>
+            <a:spLocks xmlns:a="http://schemas.openxmlformats.org/drawingml/2006/main" noGrp="1"/>
+          </p:cNvSpPr>
+          <p:nvPr/>
+        </p:nvSpPr>
+        <p:spPr>
+          <a:xfrm xmlns:a="http://schemas.openxmlformats.org/drawingml/2006/main">
+            <a:off x="9296400" y="1076325"/>
+            <a:ext cx="2362200" cy="342900"/>
+          </a:xfrm>
+          <a:prstGeom xmlns:a="http://schemas.openxmlformats.org/drawingml/2006/main" prst="rect">
+            <a:avLst/>
+          </a:prstGeom>
+          <a:noFill xmlns:a="http://schemas.openxmlformats.org/drawingml/2006/main"/>
+          <a:ln xmlns:a="http://schemas.openxmlformats.org/drawingml/2006/main" w="0">
+            <a:noFill/>
+          </a:ln>
+        </p:spPr>
+        <p:txBody>
+          <a:bodyPr xmlns:a="http://schemas.openxmlformats.org/drawingml/2006/main" wrap="square" lIns="0" tIns="0" rIns="0" bIns="0">
+            <a:normAutofit fontScale="100000"/>
+          </a:bodyPr>
+          <a:lstStyle xmlns:a="http://schemas.openxmlformats.org/drawingml/2006/main"/>
+          <a:p xmlns:a="http://schemas.openxmlformats.org/drawingml/2006/main">
+            <a:pPr>
+              <a:defRPr sz="1875" b="1">
+                <a:solidFill>
+                  <a:srgbClr val="173F33"/>
+                </a:solidFill>
+                <a:latin typeface="Arial"/>
+                <a:ea typeface="Arial"/>
+                <a:cs typeface="Arial"/>
+              </a:defRPr>
+            </a:pPr>
+            <a:r>
+              <a:rPr sz="1875" b="1">
+                <a:solidFill>
+                  <a:srgbClr val="173F33"/>
+                </a:solidFill>
+                <a:latin typeface="Arial"/>
+                <a:ea typeface="Arial"/>
+                <a:cs typeface="Arial"/>
+              </a:rPr>
+              <a:t>Three sign-ins</a:t>
+            </a:r>
+          </a:p>
+        </p:txBody>
+      </p:sp>
+      <p:pic>
+        <p:nvPicPr>
+          <p:cNvPr id="14" name=""/>
+          <p:cNvPicPr>
+            <a:picLocks xmlns:a="http://schemas.openxmlformats.org/drawingml/2006/main" noChangeAspect="1"/>
+          </p:cNvPicPr>
+          <p:nvPr/>
+        </p:nvPicPr>
+        <p:blipFill>
+          <a:blip xmlns:r="http://schemas.openxmlformats.org/officeDocument/2006/relationships" xmlns:a="http://schemas.openxmlformats.org/drawingml/2006/main" r:embed="R1c15b0083d9d4873"/>
+          <a:stretch xmlns:a="http://schemas.openxmlformats.org/drawingml/2006/main"/>
+        </p:blipFill>
+        <p:spPr>
+          <a:xfrm xmlns:a="http://schemas.openxmlformats.org/drawingml/2006/main">
+            <a:off x="9144000" y="1498066"/>
+            <a:ext cx="2514600" cy="2690293"/>
+          </a:xfrm>
+          <a:prstGeom xmlns:a="http://schemas.openxmlformats.org/drawingml/2006/main" prst="rect">
+            <a:avLst/>
+          </a:prstGeom>
+        </p:spPr>
+      </p:pic>
+      <p:sp>
+        <p:nvSpPr>
+          <p:cNvPr id="5" name="Patient role">
+            <a:extLst xmlns:a="http://schemas.openxmlformats.org/drawingml/2006/main">
+              <a:ext uri="{FF2B5EF4-FFF2-40B4-BE49-F238E27FC236}">
+                <a16:creationId xmlns:a16="http://schemas.microsoft.com/office/drawing/2014/main" id="{53E1BA6D-3F71-49AC-B796-D49EA1D052B7}"/>
+              </a:ext>
+            </a:extLst>
+          </p:cNvPr>
+          <p:cNvSpPr>
+            <a:spLocks xmlns:a="http://schemas.openxmlformats.org/drawingml/2006/main" noGrp="1"/>
+          </p:cNvSpPr>
+          <p:nvPr/>
+        </p:nvSpPr>
+        <p:spPr>
+          <a:xfrm xmlns:a="http://schemas.openxmlformats.org/drawingml/2006/main">
+            <a:off x="9296400" y="4362450"/>
+            <a:ext cx="2362200" cy="304800"/>
+          </a:xfrm>
+          <a:prstGeom xmlns:a="http://schemas.openxmlformats.org/drawingml/2006/main" prst="rect">
+            <a:avLst/>
+          </a:prstGeom>
+          <a:noFill xmlns:a="http://schemas.openxmlformats.org/drawingml/2006/main"/>
+          <a:ln xmlns:a="http://schemas.openxmlformats.org/drawingml/2006/main" w="0">
+            <a:noFill/>
+          </a:ln>
+        </p:spPr>
+        <p:txBody>
+          <a:bodyPr xmlns:a="http://schemas.openxmlformats.org/drawingml/2006/main" wrap="square" lIns="0" tIns="0" rIns="0" bIns="0">
+            <a:normAutofit fontScale="100000"/>
+          </a:bodyPr>
+          <a:lstStyle xmlns:a="http://schemas.openxmlformats.org/drawingml/2006/main"/>
+          <a:p xmlns:a="http://schemas.openxmlformats.org/drawingml/2006/main">
+            <a:pPr>
+              <a:defRPr sz="1575" b="1">
+                <a:solidFill>
+                  <a:srgbClr val="157B68"/>
+                </a:solidFill>
+                <a:latin typeface="Arial"/>
+                <a:ea typeface="Arial"/>
+                <a:cs typeface="Arial"/>
+              </a:defRPr>
+            </a:pPr>
+            <a:r>
+              <a:rPr sz="1575" b="1">
+                <a:solidFill>
+                  <a:srgbClr val="157B68"/>
+                </a:solidFill>
+                <a:latin typeface="Arial"/>
+                <a:ea typeface="Arial"/>
+                <a:cs typeface="Arial"/>
+              </a:rPr>
+              <a:t>Patients see their care.</a:t>
+            </a:r>
+          </a:p>
+        </p:txBody>
+      </p:sp>
+      <p:sp>
+        <p:nvSpPr>
+          <p:cNvPr id="6" name="Family role">
+            <a:extLst xmlns:a="http://schemas.openxmlformats.org/drawingml/2006/main">
+              <a:ext uri="{FF2B5EF4-FFF2-40B4-BE49-F238E27FC236}">
+                <a16:creationId xmlns:a16="http://schemas.microsoft.com/office/drawing/2014/main" id="{8099B78F-B726-461C-9390-61BDF6DBB371}"/>
+              </a:ext>
+            </a:extLst>
+          </p:cNvPr>
+          <p:cNvSpPr>
+            <a:spLocks xmlns:a="http://schemas.openxmlformats.org/drawingml/2006/main" noGrp="1"/>
+          </p:cNvSpPr>
+          <p:nvPr/>
+        </p:nvSpPr>
+        <p:spPr>
+          <a:xfrm xmlns:a="http://schemas.openxmlformats.org/drawingml/2006/main">
+            <a:off x="9296400" y="4714875"/>
+            <a:ext cx="2362200" cy="304800"/>
+          </a:xfrm>
+          <a:prstGeom xmlns:a="http://schemas.openxmlformats.org/drawingml/2006/main" prst="rect">
+            <a:avLst/>
+          </a:prstGeom>
+          <a:noFill xmlns:a="http://schemas.openxmlformats.org/drawingml/2006/main"/>
+          <a:ln xmlns:a="http://schemas.openxmlformats.org/drawingml/2006/main" w="0">
+            <a:noFill/>
+          </a:ln>
+        </p:spPr>
+        <p:txBody>
+          <a:bodyPr xmlns:a="http://schemas.openxmlformats.org/drawingml/2006/main" wrap="square" lIns="0" tIns="0" rIns="0" bIns="0">
+            <a:normAutofit fontScale="100000"/>
+          </a:bodyPr>
+          <a:lstStyle xmlns:a="http://schemas.openxmlformats.org/drawingml/2006/main"/>
+          <a:p xmlns:a="http://schemas.openxmlformats.org/drawingml/2006/main">
+            <a:pPr>
+              <a:defRPr sz="1575" b="1">
+                <a:solidFill>
+                  <a:srgbClr val="7353AC"/>
+                </a:solidFill>
+                <a:latin typeface="Arial"/>
+                <a:ea typeface="Arial"/>
+                <a:cs typeface="Arial"/>
+              </a:defRPr>
+            </a:pPr>
+            <a:r>
+              <a:rPr sz="1575" b="1">
+                <a:solidFill>
+                  <a:srgbClr val="7353AC"/>
+                </a:solidFill>
+                <a:latin typeface="Arial"/>
+                <a:ea typeface="Arial"/>
+                <a:cs typeface="Arial"/>
+              </a:rPr>
+              <a:t>Families organise help.</a:t>
+            </a:r>
+          </a:p>
+        </p:txBody>
+      </p:sp>
+      <p:sp>
+        <p:nvSpPr>
+          <p:cNvPr id="7" name="Doctor role">
+            <a:extLst xmlns:a="http://schemas.openxmlformats.org/drawingml/2006/main">
+              <a:ext uri="{FF2B5EF4-FFF2-40B4-BE49-F238E27FC236}">
+                <a16:creationId xmlns:a16="http://schemas.microsoft.com/office/drawing/2014/main" id="{F3EB3E7B-A633-430A-9C2B-1689B67CCAE4}"/>
+              </a:ext>
+            </a:extLst>
+          </p:cNvPr>
+          <p:cNvSpPr>
+            <a:spLocks xmlns:a="http://schemas.openxmlformats.org/drawingml/2006/main" noGrp="1"/>
+          </p:cNvSpPr>
+          <p:nvPr/>
+        </p:nvSpPr>
+        <p:spPr>
+          <a:xfrm xmlns:a="http://schemas.openxmlformats.org/drawingml/2006/main">
+            <a:off x="9296400" y="5067300"/>
+            <a:ext cx="2362200" cy="304800"/>
+          </a:xfrm>
+          <a:prstGeom xmlns:a="http://schemas.openxmlformats.org/drawingml/2006/main" prst="rect">
+            <a:avLst/>
+          </a:prstGeom>
+          <a:noFill xmlns:a="http://schemas.openxmlformats.org/drawingml/2006/main"/>
+          <a:ln xmlns:a="http://schemas.openxmlformats.org/drawingml/2006/main" w="0">
+            <a:noFill/>
+          </a:ln>
+        </p:spPr>
+        <p:txBody>
+          <a:bodyPr xmlns:a="http://schemas.openxmlformats.org/drawingml/2006/main" wrap="square" lIns="0" tIns="0" rIns="0" bIns="0">
+            <a:normAutofit fontScale="99374"/>
+          </a:bodyPr>
+          <a:lstStyle xmlns:a="http://schemas.openxmlformats.org/drawingml/2006/main"/>
+          <a:p xmlns:a="http://schemas.openxmlformats.org/drawingml/2006/main">
+            <a:pPr>
+              <a:defRPr sz="1575" b="1">
+                <a:solidFill>
+                  <a:srgbClr val="B75E43"/>
+                </a:solidFill>
+                <a:latin typeface="Arial"/>
+                <a:ea typeface="Arial"/>
+                <a:cs typeface="Arial"/>
+              </a:defRPr>
+            </a:pPr>
+            <a:r>
+              <a:rPr sz="1575" b="1">
+                <a:solidFill>
+                  <a:srgbClr val="B75E43"/>
+                </a:solidFill>
+                <a:latin typeface="Arial"/>
+                <a:ea typeface="Arial"/>
+                <a:cs typeface="Arial"/>
+              </a:rPr>
+              <a:t>Doctors review and sign.</a:t>
+            </a:r>
+          </a:p>
+        </p:txBody>
+      </p:sp>
+      <p:sp>
+        <p:nvSpPr>
+          <p:cNvPr id="8" name="Practical family support">
+            <a:extLst xmlns:a="http://schemas.openxmlformats.org/drawingml/2006/main">
+              <a:ext uri="{FF2B5EF4-FFF2-40B4-BE49-F238E27FC236}">
+                <a16:creationId xmlns:a16="http://schemas.microsoft.com/office/drawing/2014/main" id="{6E4ED9D5-A008-474B-B6D8-8198955880F7}"/>
+              </a:ext>
+            </a:extLst>
+          </p:cNvPr>
+          <p:cNvSpPr>
+            <a:spLocks xmlns:a="http://schemas.openxmlformats.org/drawingml/2006/main" noGrp="1"/>
+          </p:cNvSpPr>
+          <p:nvPr/>
+        </p:nvSpPr>
+        <p:spPr>
+          <a:xfrm xmlns:a="http://schemas.openxmlformats.org/drawingml/2006/main">
+            <a:off x="9296400" y="5486400"/>
+            <a:ext cx="2362200" cy="895350"/>
+          </a:xfrm>
+          <a:prstGeom xmlns:a="http://schemas.openxmlformats.org/drawingml/2006/main" prst="rect">
+            <a:avLst/>
+          </a:prstGeom>
+          <a:noFill xmlns:a="http://schemas.openxmlformats.org/drawingml/2006/main"/>
+          <a:ln xmlns:a="http://schemas.openxmlformats.org/drawingml/2006/main" w="0">
+            <a:noFill/>
+          </a:ln>
+        </p:spPr>
+        <p:txBody>
+          <a:bodyPr xmlns:a="http://schemas.openxmlformats.org/drawingml/2006/main" wrap="square" lIns="0" tIns="0" rIns="0" bIns="0">
+            <a:normAutofit fontScale="100000"/>
+          </a:bodyPr>
+          <a:lstStyle xmlns:a="http://schemas.openxmlformats.org/drawingml/2006/main"/>
+          <a:p xmlns:a="http://schemas.openxmlformats.org/drawingml/2006/main">
+            <a:pPr>
+              <a:defRPr sz="1388" b="0">
+                <a:solidFill>
+                  <a:srgbClr val="173F33"/>
+                </a:solidFill>
+                <a:latin typeface="Arial"/>
+                <a:ea typeface="Arial"/>
+                <a:cs typeface="Arial"/>
+              </a:defRPr>
+            </a:pPr>
+            <a:r>
+              <a:rPr sz="1388" b="0">
+                <a:solidFill>
+                  <a:srgbClr val="173F33"/>
+                </a:solidFill>
+                <a:latin typeface="Arial"/>
+                <a:ea typeface="Arial"/>
+                <a:cs typeface="Arial"/>
+              </a:rPr>
+              <a:t>Plan rides and home support. Keep medicine calls, costs, paperwork and emotional support together.</a:t>
+            </a:r>
+          </a:p>
+        </p:txBody>
+      </p:sp>
+      <p:sp>
+        <p:nvSpPr>
+          <p:cNvPr id="9" name="Patient home website">
+            <a:extLst xmlns:a="http://schemas.openxmlformats.org/drawingml/2006/main">
+              <a:ext uri="{FF2B5EF4-FFF2-40B4-BE49-F238E27FC236}">
+                <a16:creationId xmlns:a16="http://schemas.microsoft.com/office/drawing/2014/main" id="{2DEBC9EB-15F0-4BF7-9AB0-39359DF9A3E7}"/>
+              </a:ext>
+            </a:extLst>
+          </p:cNvPr>
+          <p:cNvSpPr>
+            <a:spLocks xmlns:a="http://schemas.openxmlformats.org/drawingml/2006/main" noGrp="1"/>
+          </p:cNvSpPr>
+          <p:nvPr/>
+        </p:nvSpPr>
+        <p:spPr>
+          <a:xfrm xmlns:a="http://schemas.openxmlformats.org/drawingml/2006/main">
+            <a:off x="533400" y="6505575"/>
+            <a:ext cx="6381750" cy="238125"/>
+          </a:xfrm>
+          <a:prstGeom xmlns:a="http://schemas.openxmlformats.org/drawingml/2006/main" prst="rect">
+            <a:avLst/>
+          </a:prstGeom>
+          <a:noFill xmlns:a="http://schemas.openxmlformats.org/drawingml/2006/main"/>
+          <a:ln xmlns:a="http://schemas.openxmlformats.org/drawingml/2006/main" w="0">
+            <a:noFill/>
+          </a:ln>
+        </p:spPr>
+        <p:txBody>
+          <a:bodyPr xmlns:a="http://schemas.openxmlformats.org/drawingml/2006/main" wrap="square" lIns="0" tIns="0" rIns="0" bIns="0">
+            <a:normAutofit fontScale="99206"/>
+          </a:bodyPr>
+          <a:lstStyle xmlns:a="http://schemas.openxmlformats.org/drawingml/2006/main"/>
+          <a:p xmlns:a="http://schemas.openxmlformats.org/drawingml/2006/main">
+            <a:pPr>
+              <a:defRPr sz="1575" b="1">
+                <a:solidFill>
+                  <a:srgbClr val="145AC6"/>
+                </a:solidFill>
+                <a:latin typeface="Arial"/>
+                <a:ea typeface="Arial"/>
+                <a:cs typeface="Arial"/>
+              </a:defRPr>
+            </a:pPr>
+            <a:r>
+              <a:rPr sz="1575" b="1" u="sng">
+                <a:solidFill>
+                  <a:srgbClr val="145AC6"/>
+                </a:solidFill>
+                <a:latin typeface="Arial"/>
+                <a:ea typeface="Arial"/>
+                <a:cs typeface="Arial"/>
+                <a:hlinkClick xmlns:r="http://schemas.openxmlformats.org/officeDocument/2006/relationships" r:id="Rd68b69e70dcf447c"/>
+              </a:rPr>
+              <a:t>OPEN THE WEBSITE - saathi.wedevit.in</a:t>
+            </a:r>
+          </a:p>
+        </p:txBody>
+      </p:sp>
+      <p:sp>
+        <p:nvSpPr>
+          <p:cNvPr id="10" name="Support directory">
+            <a:extLst xmlns:a="http://schemas.openxmlformats.org/drawingml/2006/main">
+              <a:ext uri="{FF2B5EF4-FFF2-40B4-BE49-F238E27FC236}">
+                <a16:creationId xmlns:a16="http://schemas.microsoft.com/office/drawing/2014/main" id="{3CFB443E-C185-4D81-AA55-D5585BC6A20C}"/>
+              </a:ext>
+            </a:extLst>
+          </p:cNvPr>
+          <p:cNvSpPr>
+            <a:spLocks xmlns:a="http://schemas.openxmlformats.org/drawingml/2006/main" noGrp="1"/>
+          </p:cNvSpPr>
+          <p:nvPr/>
+        </p:nvSpPr>
+        <p:spPr>
+          <a:xfrm xmlns:a="http://schemas.openxmlformats.org/drawingml/2006/main">
+            <a:off x="7400925" y="6505575"/>
+            <a:ext cx="4257675" cy="238125"/>
+          </a:xfrm>
+          <a:prstGeom xmlns:a="http://schemas.openxmlformats.org/drawingml/2006/main" prst="rect">
+            <a:avLst/>
+          </a:prstGeom>
+          <a:noFill xmlns:a="http://schemas.openxmlformats.org/drawingml/2006/main"/>
+          <a:ln xmlns:a="http://schemas.openxmlformats.org/drawingml/2006/main" w="0">
+            <a:noFill/>
+          </a:ln>
+        </p:spPr>
+        <p:txBody>
+          <a:bodyPr xmlns:a="http://schemas.openxmlformats.org/drawingml/2006/main" wrap="square" lIns="0" tIns="0" rIns="0" bIns="0">
+            <a:normAutofit fontScale="100000"/>
+          </a:bodyPr>
+          <a:lstStyle xmlns:a="http://schemas.openxmlformats.org/drawingml/2006/main"/>
+          <a:p xmlns:a="http://schemas.openxmlformats.org/drawingml/2006/main">
+            <a:pPr>
+              <a:defRPr sz="1425" b="0">
+                <a:solidFill>
+                  <a:srgbClr val="145AC6"/>
+                </a:solidFill>
+                <a:latin typeface="Arial"/>
+                <a:ea typeface="Arial"/>
+                <a:cs typeface="Arial"/>
+              </a:defRPr>
+            </a:pPr>
+            <a:r>
+              <a:rPr sz="1425" b="0" u="sng">
+                <a:solidFill>
+                  <a:srgbClr val="145AC6"/>
+                </a:solidFill>
+                <a:latin typeface="Arial"/>
+                <a:ea typeface="Arial"/>
+                <a:cs typeface="Arial"/>
+                <a:hlinkClick xmlns:r="http://schemas.openxmlformats.org/officeDocument/2006/relationships" r:id="Rc8c285729d234c33"/>
+              </a:rPr>
+              <a:t>Find a centre and call to confirm.</a:t>
+            </a:r>
+          </a:p>
+        </p:txBody>
+      </p:sp>
+    </p:spTree>
+    <p:extLst>
+      <p:ext uri="{BB962C8B-B14F-4D97-AF65-F5344CB8AC3E}">
+        <p14:creationId xmlns:p14="http://schemas.microsoft.com/office/powerpoint/2010/main" val="221085739"/>
+      </p:ext>
+    </p:extLst>
+  </p:cSld>
+</p:sld>
+</file>
+
+<file path=ppt/slides/slide2.xml><?xml version="1.0" encoding="utf-8"?>
+<p:sld xmlns:p="http://schemas.openxmlformats.org/presentationml/2006/main">
+  <p:cSld>
+    <p:bg>
+      <p:bgPr>
+        <a:solidFill xmlns:a="http://schemas.openxmlformats.org/drawingml/2006/main">
           <a:srgbClr val="FFF6E5"/>
         </a:solidFill>
       </p:bgPr>
@@ -2144,10 +2675,10 @@
           <p:nvPr/>
         </p:nvPicPr>
         <p:blipFill>
-          <a:blip xmlns:r="http://schemas.openxmlformats.org/officeDocument/2006/relationships" xmlns:a="http://schemas.openxmlformats.org/drawingml/2006/main" r:embed="Rbe1355cc630d4eab">
+          <a:blip xmlns:r="http://schemas.openxmlformats.org/officeDocument/2006/relationships" xmlns:a="http://schemas.openxmlformats.org/drawingml/2006/main" r:embed="R7155c4fc442e4046">
             <a:extLst>
               <a:ext uri="{96DAC541-7B7A-43D3-8B79-37D633B846F1}">
-                <asvg:svgBlip xmlns:asvg="http://schemas.microsoft.com/office/drawing/2016/SVG/main" r:embed="R90e67966794544d0"/>
+                <asvg:svgBlip xmlns:asvg="http://schemas.microsoft.com/office/drawing/2016/SVG/main" r:embed="Rbb6f12668ecb40bf"/>
               </a:ext>
             </a:extLst>
           </a:blip>
@@ -2168,7 +2699,7 @@
           <p:cNvPr id="2" name="Brand">
             <a:extLst xmlns:a="http://schemas.openxmlformats.org/drawingml/2006/main">
               <a:ext uri="{FF2B5EF4-FFF2-40B4-BE49-F238E27FC236}">
-                <a16:creationId xmlns:a16="http://schemas.microsoft.com/office/drawing/2014/main" id="{E73AC438-A948-47D3-8ECE-4FE9CAC712ED}"/>
+                <a16:creationId xmlns:a16="http://schemas.microsoft.com/office/drawing/2014/main" id="{96BE54D1-D0D6-4614-A434-E9D550FB6DFC}"/>
               </a:ext>
             </a:extLst>
           </p:cNvPr>
@@ -2225,7 +2756,7 @@
           <p:cNvPr id="3" name="Hindi name">
             <a:extLst xmlns:a="http://schemas.openxmlformats.org/drawingml/2006/main">
               <a:ext uri="{FF2B5EF4-FFF2-40B4-BE49-F238E27FC236}">
-                <a16:creationId xmlns:a16="http://schemas.microsoft.com/office/drawing/2014/main" id="{EBDA7BAB-F470-4993-B58E-2D96FC44E0D0}"/>
+                <a16:creationId xmlns:a16="http://schemas.microsoft.com/office/drawing/2014/main" id="{C7150D6C-A7B6-475B-8190-542CD0ADD0C8}"/>
               </a:ext>
             </a:extLst>
           </p:cNvPr>
@@ -2282,7 +2813,7 @@
           <p:cNvPr id="4" name="Name meaning">
             <a:extLst xmlns:a="http://schemas.openxmlformats.org/drawingml/2006/main">
               <a:ext uri="{FF2B5EF4-FFF2-40B4-BE49-F238E27FC236}">
-                <a16:creationId xmlns:a16="http://schemas.microsoft.com/office/drawing/2014/main" id="{8BC25651-7E7C-45EF-B3BE-DB8BEDD04F81}"/>
+                <a16:creationId xmlns:a16="http://schemas.microsoft.com/office/drawing/2014/main" id="{BA92B0D1-033C-4799-BD43-2184EF5F4F5E}"/>
               </a:ext>
             </a:extLst>
           </p:cNvPr>
@@ -2339,7 +2870,7 @@
           <p:cNvPr id="5" name="Purpose">
             <a:extLst xmlns:a="http://schemas.openxmlformats.org/drawingml/2006/main">
               <a:ext uri="{FF2B5EF4-FFF2-40B4-BE49-F238E27FC236}">
-                <a16:creationId xmlns:a16="http://schemas.microsoft.com/office/drawing/2014/main" id="{29A037D6-D44B-4B2F-B1FE-646FC7AF0822}"/>
+                <a16:creationId xmlns:a16="http://schemas.microsoft.com/office/drawing/2014/main" id="{3182EADB-3CF9-4752-8F42-0FBBD78AD3AD}"/>
               </a:ext>
             </a:extLst>
           </p:cNvPr>
@@ -2400,7 +2931,7 @@
           <p:nvPr/>
         </p:nvPicPr>
         <p:blipFill>
-          <a:blip xmlns:r="http://schemas.openxmlformats.org/officeDocument/2006/relationships" xmlns:a="http://schemas.openxmlformats.org/drawingml/2006/main" r:embed="R7d6a6ec7559c4fa9"/>
+          <a:blip xmlns:r="http://schemas.openxmlformats.org/officeDocument/2006/relationships" xmlns:a="http://schemas.openxmlformats.org/drawingml/2006/main" r:embed="R73ab780a7ea646da"/>
           <a:stretch xmlns:a="http://schemas.openxmlformats.org/drawingml/2006/main"/>
         </p:blipFill>
         <p:spPr>
@@ -2418,7 +2949,7 @@
           <p:cNvPr id="7" name="Website link">
             <a:extLst xmlns:a="http://schemas.openxmlformats.org/drawingml/2006/main">
               <a:ext uri="{FF2B5EF4-FFF2-40B4-BE49-F238E27FC236}">
-                <a16:creationId xmlns:a16="http://schemas.microsoft.com/office/drawing/2014/main" id="{703DCBB2-2108-402A-BF11-3889B8ED1E43}"/>
+                <a16:creationId xmlns:a16="http://schemas.microsoft.com/office/drawing/2014/main" id="{093A7DB5-5B59-4977-A4B2-E6378E0C193D}"/>
               </a:ext>
             </a:extLst>
           </p:cNvPr>
@@ -2464,7 +2995,7 @@
                 <a:latin typeface="Arial"/>
                 <a:ea typeface="Arial"/>
                 <a:cs typeface="Arial"/>
-                <a:hlinkClick xmlns:r="http://schemas.openxmlformats.org/officeDocument/2006/relationships" r:id="R7e13c9f304114f98"/>
+                <a:hlinkClick xmlns:r="http://schemas.openxmlformats.org/officeDocument/2006/relationships" r:id="Re478a03fdd704f19"/>
               </a:rPr>
               <a:t>OPEN THE WEBSITE - saathi.wedevit.in</a:t>
             </a:r>
@@ -2480,10 +3011,10 @@
           <p:nvPr/>
         </p:nvPicPr>
         <p:blipFill>
-          <a:blip xmlns:r="http://schemas.openxmlformats.org/officeDocument/2006/relationships" xmlns:a="http://schemas.openxmlformats.org/drawingml/2006/main" r:embed="Re20caa07df4b49be">
+          <a:blip xmlns:r="http://schemas.openxmlformats.org/officeDocument/2006/relationships" xmlns:a="http://schemas.openxmlformats.org/drawingml/2006/main" r:embed="Rce6b0f217cda47d4">
             <a:extLst>
               <a:ext uri="{96DAC541-7B7A-43D3-8B79-37D633B846F1}">
-                <asvg:svgBlip xmlns:asvg="http://schemas.microsoft.com/office/drawing/2016/SVG/main" r:embed="Re67fc7e3e47e46c0"/>
+                <asvg:svgBlip xmlns:asvg="http://schemas.microsoft.com/office/drawing/2016/SVG/main" r:embed="R801159551e174ea3"/>
               </a:ext>
             </a:extLst>
           </a:blip>
@@ -2504,7 +3035,7 @@
           <p:cNvPr id="9" name="Repository link">
             <a:extLst xmlns:a="http://schemas.openxmlformats.org/drawingml/2006/main">
               <a:ext uri="{FF2B5EF4-FFF2-40B4-BE49-F238E27FC236}">
-                <a16:creationId xmlns:a16="http://schemas.microsoft.com/office/drawing/2014/main" id="{6DD2182E-ADE2-48E7-97DC-4E761BA3E1B6}"/>
+                <a16:creationId xmlns:a16="http://schemas.microsoft.com/office/drawing/2014/main" id="{A3ED1288-B0F2-417B-86C2-AA25441F414A}"/>
               </a:ext>
             </a:extLst>
           </p:cNvPr>
@@ -2550,7 +3081,7 @@
                 <a:latin typeface="Arial"/>
                 <a:ea typeface="Arial"/>
                 <a:cs typeface="Arial"/>
-                <a:hlinkClick xmlns:r="http://schemas.openxmlformats.org/officeDocument/2006/relationships" r:id="R9f82135b221c4ede"/>
+                <a:hlinkClick xmlns:r="http://schemas.openxmlformats.org/officeDocument/2006/relationships" r:id="Re285b84dacad4b39"/>
               </a:rPr>
               <a:t>github.com/basithladdu/healthathon</a:t>
             </a:r>
@@ -2566,10 +3097,10 @@
           <p:nvPr/>
         </p:nvPicPr>
         <p:blipFill>
-          <a:blip xmlns:r="http://schemas.openxmlformats.org/officeDocument/2006/relationships" xmlns:a="http://schemas.openxmlformats.org/drawingml/2006/main" r:embed="R03ae1f2f2e934d6e">
+          <a:blip xmlns:r="http://schemas.openxmlformats.org/officeDocument/2006/relationships" xmlns:a="http://schemas.openxmlformats.org/drawingml/2006/main" r:embed="R276b65f1067a4029">
             <a:extLst>
               <a:ext uri="{96DAC541-7B7A-43D3-8B79-37D633B846F1}">
-                <asvg:svgBlip xmlns:asvg="http://schemas.microsoft.com/office/drawing/2016/SVG/main" r:embed="R06c2c2e5a6604ea8"/>
+                <asvg:svgBlip xmlns:asvg="http://schemas.microsoft.com/office/drawing/2016/SVG/main" r:embed="R52b61b016c524479"/>
               </a:ext>
             </a:extLst>
           </a:blip>
@@ -2590,7 +3121,7 @@
           <p:cNvPr id="11" name="Questions contact">
             <a:extLst xmlns:a="http://schemas.openxmlformats.org/drawingml/2006/main">
               <a:ext uri="{FF2B5EF4-FFF2-40B4-BE49-F238E27FC236}">
-                <a16:creationId xmlns:a16="http://schemas.microsoft.com/office/drawing/2014/main" id="{B1DB5106-7798-4F2F-BE7F-8BAF2639DAC6}"/>
+                <a16:creationId xmlns:a16="http://schemas.microsoft.com/office/drawing/2014/main" id="{FF337158-612B-48D1-8D96-54526E2C4A83}"/>
               </a:ext>
             </a:extLst>
           </p:cNvPr>
@@ -2636,7 +3167,7 @@
                 <a:latin typeface="Arial"/>
                 <a:ea typeface="Arial"/>
                 <a:cs typeface="Arial"/>
-                <a:hlinkClick xmlns:r="http://schemas.openxmlformats.org/officeDocument/2006/relationships" r:id="R328d3167ee3e4ffe"/>
+                <a:hlinkClick xmlns:r="http://schemas.openxmlformats.org/officeDocument/2006/relationships" r:id="Rcfe228b96b454329"/>
               </a:rPr>
               <a:t>Questions? Contact us</a:t>
             </a:r>
@@ -2648,7 +3179,7 @@
           <p:cNvPr id="12" name="WhatsApp link">
             <a:extLst xmlns:a="http://schemas.openxmlformats.org/drawingml/2006/main">
               <a:ext uri="{FF2B5EF4-FFF2-40B4-BE49-F238E27FC236}">
-                <a16:creationId xmlns:a16="http://schemas.microsoft.com/office/drawing/2014/main" id="{08A31515-BF4F-4E13-BEAB-F65C2DFEA956}"/>
+                <a16:creationId xmlns:a16="http://schemas.microsoft.com/office/drawing/2014/main" id="{0778F4A2-AD6C-48FF-83A2-EDAA05885123}"/>
               </a:ext>
             </a:extLst>
           </p:cNvPr>
@@ -2694,7 +3225,7 @@
                 <a:latin typeface="Arial"/>
                 <a:ea typeface="Arial"/>
                 <a:cs typeface="Arial"/>
-                <a:hlinkClick xmlns:r="http://schemas.openxmlformats.org/officeDocument/2006/relationships" r:id="R83575541d5b94ba4"/>
+                <a:hlinkClick xmlns:r="http://schemas.openxmlformats.org/officeDocument/2006/relationships" r:id="R78ccfdfd1a2649f3"/>
               </a:rPr>
               <a:t>wa.me/919553321211</a:t>
             </a:r>
@@ -2706,7 +3237,7 @@
           <p:cNvPr id="13" name="">
             <a:extLst xmlns:a="http://schemas.openxmlformats.org/drawingml/2006/main">
               <a:ext uri="{FF2B5EF4-FFF2-40B4-BE49-F238E27FC236}">
-                <a16:creationId xmlns:a16="http://schemas.microsoft.com/office/drawing/2014/main" id="{5BCD4B02-6011-43A4-B835-C9D6AD09781F}"/>
+                <a16:creationId xmlns:a16="http://schemas.microsoft.com/office/drawing/2014/main" id="{F1C76AF2-2A78-4635-8C06-598D3E2A3D29}"/>
               </a:ext>
             </a:extLst>
           </p:cNvPr>
@@ -2735,7 +3266,7 @@
           <p:cNvPr id="14" name="Team heading">
             <a:extLst xmlns:a="http://schemas.openxmlformats.org/drawingml/2006/main">
               <a:ext uri="{FF2B5EF4-FFF2-40B4-BE49-F238E27FC236}">
-                <a16:creationId xmlns:a16="http://schemas.microsoft.com/office/drawing/2014/main" id="{A63CC1D0-4A80-43A7-91F4-E830EB181814}"/>
+                <a16:creationId xmlns:a16="http://schemas.microsoft.com/office/drawing/2014/main" id="{F4D94CFE-5C49-47EE-97F4-B3B862FDA2AD}"/>
               </a:ext>
             </a:extLst>
           </p:cNvPr>
@@ -2796,7 +3327,7 @@
           <p:nvPr/>
         </p:nvPicPr>
         <p:blipFill>
-          <a:blip xmlns:r="http://schemas.openxmlformats.org/officeDocument/2006/relationships" xmlns:a="http://schemas.openxmlformats.org/drawingml/2006/main" r:embed="R58f0fe82ae5c484d"/>
+          <a:blip xmlns:r="http://schemas.openxmlformats.org/officeDocument/2006/relationships" xmlns:a="http://schemas.openxmlformats.org/drawingml/2006/main" r:embed="R01f648ef83614ab4"/>
           <a:srcRect xmlns:a="http://schemas.openxmlformats.org/drawingml/2006/main" l="0" t="5331" r="0" b="5331"/>
           <a:stretch xmlns:a="http://schemas.openxmlformats.org/drawingml/2006/main">
             <a:fillRect l="0" t="0" r="0" b="0"/>
@@ -2817,7 +3348,7 @@
           <p:cNvPr id="16" name="Team member 1">
             <a:extLst xmlns:a="http://schemas.openxmlformats.org/drawingml/2006/main">
               <a:ext uri="{FF2B5EF4-FFF2-40B4-BE49-F238E27FC236}">
-                <a16:creationId xmlns:a16="http://schemas.microsoft.com/office/drawing/2014/main" id="{9E046D52-9809-43C5-A1A7-713B9376F9F6}"/>
+                <a16:creationId xmlns:a16="http://schemas.microsoft.com/office/drawing/2014/main" id="{E0614911-0FD5-4CB2-99BA-83AC20D206C5}"/>
               </a:ext>
             </a:extLst>
           </p:cNvPr>
@@ -2897,7 +3428,7 @@
           <p:cNvPr id="17" name="Team role 1">
             <a:extLst xmlns:a="http://schemas.openxmlformats.org/drawingml/2006/main">
               <a:ext uri="{FF2B5EF4-FFF2-40B4-BE49-F238E27FC236}">
-                <a16:creationId xmlns:a16="http://schemas.microsoft.com/office/drawing/2014/main" id="{623B71B1-6774-4684-ABC1-DE607AD6310D}"/>
+                <a16:creationId xmlns:a16="http://schemas.microsoft.com/office/drawing/2014/main" id="{4F3C4680-CF5C-43DF-AB0A-D1C2390B5268}"/>
               </a:ext>
             </a:extLst>
           </p:cNvPr>
@@ -2958,7 +3489,7 @@
           <p:nvPr/>
         </p:nvPicPr>
         <p:blipFill>
-          <a:blip xmlns:r="http://schemas.openxmlformats.org/officeDocument/2006/relationships" xmlns:a="http://schemas.openxmlformats.org/drawingml/2006/main" r:embed="R41c6c715c08546d4"/>
+          <a:blip xmlns:r="http://schemas.openxmlformats.org/officeDocument/2006/relationships" xmlns:a="http://schemas.openxmlformats.org/drawingml/2006/main" r:embed="R9d23964246564713"/>
           <a:srcRect xmlns:a="http://schemas.openxmlformats.org/drawingml/2006/main" l="0" t="19104" r="0" b="19104"/>
           <a:stretch xmlns:a="http://schemas.openxmlformats.org/drawingml/2006/main">
             <a:fillRect l="0" t="0" r="0" b="0"/>
@@ -2979,7 +3510,7 @@
           <p:cNvPr id="19" name="Team member 2">
             <a:extLst xmlns:a="http://schemas.openxmlformats.org/drawingml/2006/main">
               <a:ext uri="{FF2B5EF4-FFF2-40B4-BE49-F238E27FC236}">
-                <a16:creationId xmlns:a16="http://schemas.microsoft.com/office/drawing/2014/main" id="{3A0A7ABE-4221-432A-89D4-B9076621ACEA}"/>
+                <a16:creationId xmlns:a16="http://schemas.microsoft.com/office/drawing/2014/main" id="{5801B780-8C77-4837-B7AB-A61F18C982C9}"/>
               </a:ext>
             </a:extLst>
           </p:cNvPr>
@@ -3059,7 +3590,7 @@
           <p:cNvPr id="20" name="Team role 2">
             <a:extLst xmlns:a="http://schemas.openxmlformats.org/drawingml/2006/main">
               <a:ext uri="{FF2B5EF4-FFF2-40B4-BE49-F238E27FC236}">
-                <a16:creationId xmlns:a16="http://schemas.microsoft.com/office/drawing/2014/main" id="{82049A53-3C3F-4900-BFF4-2DA8E7099FAA}"/>
+                <a16:creationId xmlns:a16="http://schemas.microsoft.com/office/drawing/2014/main" id="{3C9F13AC-9B70-4968-BCE5-BBCA7CAB3D24}"/>
               </a:ext>
             </a:extLst>
           </p:cNvPr>
@@ -3116,7 +3647,7 @@
           <p:cNvPr id="21" name="Photo space for Dr Sharada&#10;Vinod Kutty">
             <a:extLst xmlns:a="http://schemas.openxmlformats.org/drawingml/2006/main">
               <a:ext uri="{FF2B5EF4-FFF2-40B4-BE49-F238E27FC236}">
-                <a16:creationId xmlns:a16="http://schemas.microsoft.com/office/drawing/2014/main" id="{BAEBA162-7672-4DB3-BA35-B00D96050C8D}"/>
+                <a16:creationId xmlns:a16="http://schemas.microsoft.com/office/drawing/2014/main" id="{56922103-3660-405B-A5E0-867189EB8EB0}"/>
               </a:ext>
             </a:extLst>
           </p:cNvPr>
@@ -3148,7 +3679,7 @@
           <p:cNvPr id="22" name="Team member 3">
             <a:extLst xmlns:a="http://schemas.openxmlformats.org/drawingml/2006/main">
               <a:ext uri="{FF2B5EF4-FFF2-40B4-BE49-F238E27FC236}">
-                <a16:creationId xmlns:a16="http://schemas.microsoft.com/office/drawing/2014/main" id="{9D244A0E-43AF-4646-9C02-8E0C1B2F7A2B}"/>
+                <a16:creationId xmlns:a16="http://schemas.microsoft.com/office/drawing/2014/main" id="{5841E01F-1281-4310-91B3-B1951D14712D}"/>
               </a:ext>
             </a:extLst>
           </p:cNvPr>
@@ -3228,7 +3759,7 @@
           <p:cNvPr id="23" name="Team role 3">
             <a:extLst xmlns:a="http://schemas.openxmlformats.org/drawingml/2006/main">
               <a:ext uri="{FF2B5EF4-FFF2-40B4-BE49-F238E27FC236}">
-                <a16:creationId xmlns:a16="http://schemas.microsoft.com/office/drawing/2014/main" id="{B6E1E55B-B000-4B14-BE6C-94F30931DA09}"/>
+                <a16:creationId xmlns:a16="http://schemas.microsoft.com/office/drawing/2014/main" id="{26CEE53B-AB87-4547-91A2-B5CC94AAEFED}"/>
               </a:ext>
             </a:extLst>
           </p:cNvPr>
@@ -3285,7 +3816,7 @@
           <p:cNvPr id="24" name="Photo space for Dr Sujay&#10;Halkur Shankar">
             <a:extLst xmlns:a="http://schemas.openxmlformats.org/drawingml/2006/main">
               <a:ext uri="{FF2B5EF4-FFF2-40B4-BE49-F238E27FC236}">
-                <a16:creationId xmlns:a16="http://schemas.microsoft.com/office/drawing/2014/main" id="{E9B2503A-3480-41E9-9624-45740A9F8814}"/>
+                <a16:creationId xmlns:a16="http://schemas.microsoft.com/office/drawing/2014/main" id="{3F87F583-3357-4855-99FC-71E8EF4D0210}"/>
               </a:ext>
             </a:extLst>
           </p:cNvPr>
@@ -3317,7 +3848,7 @@
           <p:cNvPr id="25" name="Team member 4">
             <a:extLst xmlns:a="http://schemas.openxmlformats.org/drawingml/2006/main">
               <a:ext uri="{FF2B5EF4-FFF2-40B4-BE49-F238E27FC236}">
-                <a16:creationId xmlns:a16="http://schemas.microsoft.com/office/drawing/2014/main" id="{7DC0589B-A412-473E-9C38-9A88E9D6DCF0}"/>
+                <a16:creationId xmlns:a16="http://schemas.microsoft.com/office/drawing/2014/main" id="{D39F784B-AC03-4BB5-97AE-8FA6ADB91DB1}"/>
               </a:ext>
             </a:extLst>
           </p:cNvPr>
@@ -3397,7 +3928,7 @@
           <p:cNvPr id="26" name="Team role 4">
             <a:extLst xmlns:a="http://schemas.openxmlformats.org/drawingml/2006/main">
               <a:ext uri="{FF2B5EF4-FFF2-40B4-BE49-F238E27FC236}">
-                <a16:creationId xmlns:a16="http://schemas.microsoft.com/office/drawing/2014/main" id="{BD9887F1-1F3B-425C-879D-ACEFD1D7751D}"/>
+                <a16:creationId xmlns:a16="http://schemas.microsoft.com/office/drawing/2014/main" id="{AD3C4E5D-42D2-4BDC-96A7-317D94E7134F}"/>
               </a:ext>
             </a:extLst>
           </p:cNvPr>
@@ -3454,7 +3985,7 @@
           <p:cNvPr id="27" name="Photo space for Shirin Ayub">
             <a:extLst xmlns:a="http://schemas.openxmlformats.org/drawingml/2006/main">
               <a:ext uri="{FF2B5EF4-FFF2-40B4-BE49-F238E27FC236}">
-                <a16:creationId xmlns:a16="http://schemas.microsoft.com/office/drawing/2014/main" id="{9363AD9F-C210-44F2-AC01-4B76AA9C86DD}"/>
+                <a16:creationId xmlns:a16="http://schemas.microsoft.com/office/drawing/2014/main" id="{7092B016-9083-4BA1-9932-8CECD8BEE181}"/>
               </a:ext>
             </a:extLst>
           </p:cNvPr>
@@ -3486,7 +4017,7 @@
           <p:cNvPr id="28" name="Team member 5">
             <a:extLst xmlns:a="http://schemas.openxmlformats.org/drawingml/2006/main">
               <a:ext uri="{FF2B5EF4-FFF2-40B4-BE49-F238E27FC236}">
-                <a16:creationId xmlns:a16="http://schemas.microsoft.com/office/drawing/2014/main" id="{97BEBD02-30E2-4EED-BC35-BDB5F0087ADE}"/>
+                <a16:creationId xmlns:a16="http://schemas.microsoft.com/office/drawing/2014/main" id="{79D6B3FC-40FC-4F9F-8841-808BE92D73DA}"/>
               </a:ext>
             </a:extLst>
           </p:cNvPr>
@@ -3543,7 +4074,7 @@
           <p:cNvPr id="29" name="Team role 5">
             <a:extLst xmlns:a="http://schemas.openxmlformats.org/drawingml/2006/main">
               <a:ext uri="{FF2B5EF4-FFF2-40B4-BE49-F238E27FC236}">
-                <a16:creationId xmlns:a16="http://schemas.microsoft.com/office/drawing/2014/main" id="{2AF2123E-B348-4D46-ACCE-842953A3215A}"/>
+                <a16:creationId xmlns:a16="http://schemas.microsoft.com/office/drawing/2014/main" id="{93F62706-F442-4734-82F3-36409AEE8815}"/>
               </a:ext>
             </a:extLst>
           </p:cNvPr>
@@ -3605,7 +4136,7 @@
 </p:sld>
 </file>
 
-<file path=ppt/slides/slide2.xml><?xml version="1.0" encoding="utf-8"?>
+<file path=ppt/slides/slide3.xml><?xml version="1.0" encoding="utf-8"?>
 <p:sld xmlns:p="http://schemas.openxmlformats.org/presentationml/2006/main">
   <p:cSld>
     <p:bg>
@@ -3629,7 +4160,7 @@
           <p:cNvPr id="16" name="Slide title">
             <a:extLst xmlns:a="http://schemas.openxmlformats.org/drawingml/2006/main">
               <a:ext uri="{FF2B5EF4-FFF2-40B4-BE49-F238E27FC236}">
-                <a16:creationId xmlns:a16="http://schemas.microsoft.com/office/drawing/2014/main" id="{11A7A922-F1DC-48F3-B637-1867F975709A}"/>
+                <a16:creationId xmlns:a16="http://schemas.microsoft.com/office/drawing/2014/main" id="{99457DD7-45BE-4283-8E0A-7669687E9D31}"/>
               </a:ext>
             </a:extLst>
           </p:cNvPr>
@@ -3690,7 +4221,7 @@
           <p:nvPr/>
         </p:nvPicPr>
         <p:blipFill>
-          <a:blip xmlns:r="http://schemas.openxmlformats.org/officeDocument/2006/relationships" xmlns:a="http://schemas.openxmlformats.org/drawingml/2006/main" r:embed="Rd3e67d9399bd4b63"/>
+          <a:blip xmlns:r="http://schemas.openxmlformats.org/officeDocument/2006/relationships" xmlns:a="http://schemas.openxmlformats.org/drawingml/2006/main" r:embed="R97b173f0417345f6"/>
           <a:stretch xmlns:a="http://schemas.openxmlformats.org/drawingml/2006/main"/>
         </p:blipFill>
         <p:spPr>
@@ -3708,7 +4239,7 @@
           <p:cNvPr id="3" name="Care photo context">
             <a:extLst xmlns:a="http://schemas.openxmlformats.org/drawingml/2006/main">
               <a:ext uri="{FF2B5EF4-FFF2-40B4-BE49-F238E27FC236}">
-                <a16:creationId xmlns:a16="http://schemas.microsoft.com/office/drawing/2014/main" id="{FF84EE67-B0A8-47A5-A76F-D136AA8C5719}"/>
+                <a16:creationId xmlns:a16="http://schemas.microsoft.com/office/drawing/2014/main" id="{9BE25906-3C9C-4DEE-90C0-BD9CEA1D16DF}"/>
               </a:ext>
             </a:extLst>
           </p:cNvPr>
@@ -3765,7 +4296,7 @@
           <p:cNvPr id="4" name="Illustrative patient">
             <a:extLst xmlns:a="http://schemas.openxmlformats.org/drawingml/2006/main">
               <a:ext uri="{FF2B5EF4-FFF2-40B4-BE49-F238E27FC236}">
-                <a16:creationId xmlns:a16="http://schemas.microsoft.com/office/drawing/2014/main" id="{FFE651C5-6BA3-441C-9F8A-4FE649E09182}"/>
+                <a16:creationId xmlns:a16="http://schemas.microsoft.com/office/drawing/2014/main" id="{4AF693ED-8D2E-42B1-A27C-85A1853BB4E3}"/>
               </a:ext>
             </a:extLst>
           </p:cNvPr>
@@ -3826,10 +4357,10 @@
           <p:nvPr/>
         </p:nvPicPr>
         <p:blipFill>
-          <a:blip xmlns:r="http://schemas.openxmlformats.org/officeDocument/2006/relationships" xmlns:a="http://schemas.openxmlformats.org/drawingml/2006/main" r:embed="R34e802462b4e421e">
+          <a:blip xmlns:r="http://schemas.openxmlformats.org/officeDocument/2006/relationships" xmlns:a="http://schemas.openxmlformats.org/drawingml/2006/main" r:embed="R4a1b7d8727fe4b62">
             <a:extLst>
               <a:ext uri="{96DAC541-7B7A-43D3-8B79-37D633B846F1}">
-                <asvg:svgBlip xmlns:asvg="http://schemas.microsoft.com/office/drawing/2016/SVG/main" r:embed="R06c0e1248169463b"/>
+                <asvg:svgBlip xmlns:asvg="http://schemas.microsoft.com/office/drawing/2016/SVG/main" r:embed="R64282b724b0f492f"/>
               </a:ext>
             </a:extLst>
           </a:blip>
@@ -3850,7 +4381,7 @@
           <p:cNvPr id="6" name="Story step 1">
             <a:extLst xmlns:a="http://schemas.openxmlformats.org/drawingml/2006/main">
               <a:ext uri="{FF2B5EF4-FFF2-40B4-BE49-F238E27FC236}">
-                <a16:creationId xmlns:a16="http://schemas.microsoft.com/office/drawing/2014/main" id="{83C5805E-3630-4AE8-A807-A5C9372295BC}"/>
+                <a16:creationId xmlns:a16="http://schemas.microsoft.com/office/drawing/2014/main" id="{CBDB79B3-2810-42BA-9764-784EDC2AB564}"/>
               </a:ext>
             </a:extLst>
           </p:cNvPr>
@@ -3907,7 +4438,7 @@
           <p:cNvPr id="7" name="Story step 1 detail">
             <a:extLst xmlns:a="http://schemas.openxmlformats.org/drawingml/2006/main">
               <a:ext uri="{FF2B5EF4-FFF2-40B4-BE49-F238E27FC236}">
-                <a16:creationId xmlns:a16="http://schemas.microsoft.com/office/drawing/2014/main" id="{A8FB3A5C-9FDE-404E-85FA-9346637A3832}"/>
+                <a16:creationId xmlns:a16="http://schemas.microsoft.com/office/drawing/2014/main" id="{190922CF-1B05-4691-A51D-E966983FBB0C}"/>
               </a:ext>
             </a:extLst>
           </p:cNvPr>
@@ -3968,10 +4499,10 @@
           <p:nvPr/>
         </p:nvPicPr>
         <p:blipFill>
-          <a:blip xmlns:r="http://schemas.openxmlformats.org/officeDocument/2006/relationships" xmlns:a="http://schemas.openxmlformats.org/drawingml/2006/main" r:embed="R6e749abb67784109">
+          <a:blip xmlns:r="http://schemas.openxmlformats.org/officeDocument/2006/relationships" xmlns:a="http://schemas.openxmlformats.org/drawingml/2006/main" r:embed="Ra721dafa85284225">
             <a:extLst>
               <a:ext uri="{96DAC541-7B7A-43D3-8B79-37D633B846F1}">
-                <asvg:svgBlip xmlns:asvg="http://schemas.microsoft.com/office/drawing/2016/SVG/main" r:embed="Rcef25f6aed5246bb"/>
+                <asvg:svgBlip xmlns:asvg="http://schemas.microsoft.com/office/drawing/2016/SVG/main" r:embed="Rf737962c9f7b47df"/>
               </a:ext>
             </a:extLst>
           </a:blip>
@@ -3992,7 +4523,7 @@
           <p:cNvPr id="9" name="Story step 2">
             <a:extLst xmlns:a="http://schemas.openxmlformats.org/drawingml/2006/main">
               <a:ext uri="{FF2B5EF4-FFF2-40B4-BE49-F238E27FC236}">
-                <a16:creationId xmlns:a16="http://schemas.microsoft.com/office/drawing/2014/main" id="{454958A1-80F4-4493-9ED3-9054DA7FEE25}"/>
+                <a16:creationId xmlns:a16="http://schemas.microsoft.com/office/drawing/2014/main" id="{1EC96354-0730-40D5-AC1E-D4785CCE2DFA}"/>
               </a:ext>
             </a:extLst>
           </p:cNvPr>
@@ -4049,7 +4580,7 @@
           <p:cNvPr id="10" name="Story step 2 detail">
             <a:extLst xmlns:a="http://schemas.openxmlformats.org/drawingml/2006/main">
               <a:ext uri="{FF2B5EF4-FFF2-40B4-BE49-F238E27FC236}">
-                <a16:creationId xmlns:a16="http://schemas.microsoft.com/office/drawing/2014/main" id="{84A65D98-213D-481C-9842-ACD70A993A00}"/>
+                <a16:creationId xmlns:a16="http://schemas.microsoft.com/office/drawing/2014/main" id="{C1B4EF40-F08F-40B1-9065-CB83140F01AC}"/>
               </a:ext>
             </a:extLst>
           </p:cNvPr>
@@ -4110,10 +4641,10 @@
           <p:nvPr/>
         </p:nvPicPr>
         <p:blipFill>
-          <a:blip xmlns:r="http://schemas.openxmlformats.org/officeDocument/2006/relationships" xmlns:a="http://schemas.openxmlformats.org/drawingml/2006/main" r:embed="Rd7ef592b79e54ef3">
+          <a:blip xmlns:r="http://schemas.openxmlformats.org/officeDocument/2006/relationships" xmlns:a="http://schemas.openxmlformats.org/drawingml/2006/main" r:embed="R5b9881006f6d4578">
             <a:extLst>
               <a:ext uri="{96DAC541-7B7A-43D3-8B79-37D633B846F1}">
-                <asvg:svgBlip xmlns:asvg="http://schemas.microsoft.com/office/drawing/2016/SVG/main" r:embed="R5bdb02f6d5c5482b"/>
+                <asvg:svgBlip xmlns:asvg="http://schemas.microsoft.com/office/drawing/2016/SVG/main" r:embed="R8a627815eecd4d93"/>
               </a:ext>
             </a:extLst>
           </a:blip>
@@ -4134,7 +4665,7 @@
           <p:cNvPr id="12" name="Story step 3">
             <a:extLst xmlns:a="http://schemas.openxmlformats.org/drawingml/2006/main">
               <a:ext uri="{FF2B5EF4-FFF2-40B4-BE49-F238E27FC236}">
-                <a16:creationId xmlns:a16="http://schemas.microsoft.com/office/drawing/2014/main" id="{7406C37D-AAC2-45E2-B7A9-088505B35A40}"/>
+                <a16:creationId xmlns:a16="http://schemas.microsoft.com/office/drawing/2014/main" id="{BA5A42B4-8E91-4D3D-86BE-BC1560F3AC45}"/>
               </a:ext>
             </a:extLst>
           </p:cNvPr>
@@ -4191,7 +4722,7 @@
           <p:cNvPr id="13" name="Story step 3 detail">
             <a:extLst xmlns:a="http://schemas.openxmlformats.org/drawingml/2006/main">
               <a:ext uri="{FF2B5EF4-FFF2-40B4-BE49-F238E27FC236}">
-                <a16:creationId xmlns:a16="http://schemas.microsoft.com/office/drawing/2014/main" id="{320123CA-D13C-4D96-A0C8-F60A9B055BF8}"/>
+                <a16:creationId xmlns:a16="http://schemas.microsoft.com/office/drawing/2014/main" id="{E81C76CC-01F8-47E2-A7CE-EC7726DD18A1}"/>
               </a:ext>
             </a:extLst>
           </p:cNvPr>
@@ -4248,7 +4779,7 @@
           <p:cNvPr id="14" name="Shared record takeaway">
             <a:extLst xmlns:a="http://schemas.openxmlformats.org/drawingml/2006/main">
               <a:ext uri="{FF2B5EF4-FFF2-40B4-BE49-F238E27FC236}">
-                <a16:creationId xmlns:a16="http://schemas.microsoft.com/office/drawing/2014/main" id="{426C2484-F0D3-418D-9610-1149DE985AAB}"/>
+                <a16:creationId xmlns:a16="http://schemas.microsoft.com/office/drawing/2014/main" id="{42F2568C-6B2E-4BC3-A592-53BCB8575127}"/>
               </a:ext>
             </a:extLst>
           </p:cNvPr>
@@ -4278,7 +4809,7 @@
           <p:cNvPr id="15" name="Closing thought">
             <a:extLst xmlns:a="http://schemas.openxmlformats.org/drawingml/2006/main">
               <a:ext uri="{FF2B5EF4-FFF2-40B4-BE49-F238E27FC236}">
-                <a16:creationId xmlns:a16="http://schemas.microsoft.com/office/drawing/2014/main" id="{F6E39BE8-1A03-4D7A-A977-A56176F96D9D}"/>
+                <a16:creationId xmlns:a16="http://schemas.microsoft.com/office/drawing/2014/main" id="{F51269BF-CB16-4132-ADA8-282A8DA433D9}"/>
               </a:ext>
             </a:extLst>
           </p:cNvPr>
@@ -4334,1282 +4865,6 @@
     <p:extLst>
       <p:ext uri="{BB962C8B-B14F-4D97-AF65-F5344CB8AC3E}">
         <p14:creationId xmlns:p14="http://schemas.microsoft.com/office/powerpoint/2010/main" val="486496822"/>
-      </p:ext>
-    </p:extLst>
-  </p:cSld>
-</p:sld>
-</file>
-
-<file path=ppt/slides/slide3.xml><?xml version="1.0" encoding="utf-8"?>
-<p:sld xmlns:p="http://schemas.openxmlformats.org/presentationml/2006/main">
-  <p:cSld>
-    <p:bg>
-      <p:bgPr>
-        <a:solidFill xmlns:a="http://schemas.openxmlformats.org/drawingml/2006/main">
-          <a:srgbClr val="CAD8ED"/>
-        </a:solidFill>
-      </p:bgPr>
-    </p:bg>
-    <p:spTree>
-      <p:nvGrpSpPr>
-        <p:cNvPr id="1" name=""/>
-        <p:cNvGrpSpPr/>
-        <p:nvPr/>
-      </p:nvGrpSpPr>
-      <p:grpSpPr>
-        <a:xfrm xmlns:a="http://schemas.openxmlformats.org/drawingml/2006/main"/>
-      </p:grpSpPr>
-      <p:graphicFrame>
-        <p:nvGraphicFramePr>
-          <p:cNvPr id="40" name="Chart"/>
-          <p:cNvGraphicFramePr/>
-          <p:nvPr/>
-        </p:nvGraphicFramePr>
-        <p:xfrm>
-          <a:off xmlns:a="http://schemas.openxmlformats.org/drawingml/2006/main" x="7372350" y="2181225"/>
-          <a:ext xmlns:a="http://schemas.openxmlformats.org/drawingml/2006/main" cx="4057650" cy="2533650"/>
-        </p:xfrm>
-        <a:graphic xmlns:a="http://schemas.openxmlformats.org/drawingml/2006/main">
-          <a:graphicData uri="http://schemas.openxmlformats.org/drawingml/2006/chart">
-            <c:chart xmlns:r="http://schemas.openxmlformats.org/officeDocument/2006/relationships" xmlns:c="http://schemas.openxmlformats.org/drawingml/2006/chart" r:id="R913b9c9b099a4fb8"/>
-          </a:graphicData>
-        </a:graphic>
-      </p:graphicFrame>
-      <p:sp>
-        <p:nvSpPr>
-          <p:cNvPr id="15" name="Slide title">
-            <a:extLst xmlns:a="http://schemas.openxmlformats.org/drawingml/2006/main">
-              <a:ext uri="{FF2B5EF4-FFF2-40B4-BE49-F238E27FC236}">
-                <a16:creationId xmlns:a16="http://schemas.microsoft.com/office/drawing/2014/main" id="{13947CDC-EFDB-4353-8E23-BC88C17E9A67}"/>
-              </a:ext>
-            </a:extLst>
-          </p:cNvPr>
-          <p:cNvSpPr>
-            <a:spLocks xmlns:a="http://schemas.openxmlformats.org/drawingml/2006/main" noGrp="1"/>
-          </p:cNvSpPr>
-          <p:nvPr/>
-        </p:nvSpPr>
-        <p:spPr>
-          <a:xfrm xmlns:a="http://schemas.openxmlformats.org/drawingml/2006/main">
-            <a:off x="533400" y="361950"/>
-            <a:ext cx="11125200" cy="638175"/>
-          </a:xfrm>
-          <a:prstGeom xmlns:a="http://schemas.openxmlformats.org/drawingml/2006/main" prst="rect">
-            <a:avLst/>
-          </a:prstGeom>
-          <a:noFill xmlns:a="http://schemas.openxmlformats.org/drawingml/2006/main"/>
-          <a:ln xmlns:a="http://schemas.openxmlformats.org/drawingml/2006/main" w="0">
-            <a:noFill/>
-          </a:ln>
-        </p:spPr>
-        <p:txBody>
-          <a:bodyPr xmlns:a="http://schemas.openxmlformats.org/drawingml/2006/main" wrap="square" lIns="0" tIns="0" rIns="0" bIns="0">
-            <a:normAutofit fontScale="100000"/>
-          </a:bodyPr>
-          <a:lstStyle xmlns:a="http://schemas.openxmlformats.org/drawingml/2006/main"/>
-          <a:p xmlns:a="http://schemas.openxmlformats.org/drawingml/2006/main">
-            <a:pPr>
-              <a:defRPr sz="3075" b="1">
-                <a:solidFill>
-                  <a:srgbClr val="173F33"/>
-                </a:solidFill>
-                <a:latin typeface="Arial"/>
-                <a:ea typeface="Arial"/>
-                <a:cs typeface="Arial"/>
-              </a:defRPr>
-            </a:pPr>
-            <a:r>
-              <a:rPr sz="3075" b="1">
-                <a:solidFill>
-                  <a:srgbClr val="173F33"/>
-                </a:solidFill>
-                <a:latin typeface="Arial"/>
-                <a:ea typeface="Arial"/>
-                <a:cs typeface="Arial"/>
-              </a:rPr>
-              <a:t>Why families need support between visits</a:t>
-            </a:r>
-          </a:p>
-        </p:txBody>
-      </p:sp>
-      <p:sp>
-        <p:nvSpPr>
-          <p:cNvPr id="16" name="Chennai evidence heading">
-            <a:extLst xmlns:a="http://schemas.openxmlformats.org/drawingml/2006/main">
-              <a:ext uri="{FF2B5EF4-FFF2-40B4-BE49-F238E27FC236}">
-                <a16:creationId xmlns:a16="http://schemas.microsoft.com/office/drawing/2014/main" id="{DF20DB2A-5E27-40F8-8436-CB14D473A66F}"/>
-              </a:ext>
-            </a:extLst>
-          </p:cNvPr>
-          <p:cNvSpPr>
-            <a:spLocks xmlns:a="http://schemas.openxmlformats.org/drawingml/2006/main" noGrp="1"/>
-          </p:cNvSpPr>
-          <p:nvPr/>
-        </p:nvSpPr>
-        <p:spPr>
-          <a:xfrm xmlns:a="http://schemas.openxmlformats.org/drawingml/2006/main">
-            <a:off x="7143750" y="1333500"/>
-            <a:ext cx="4514850" cy="828675"/>
-          </a:xfrm>
-          <a:prstGeom xmlns:a="http://schemas.openxmlformats.org/drawingml/2006/main" prst="rect">
-            <a:avLst/>
-          </a:prstGeom>
-          <a:solidFill xmlns:a="http://schemas.openxmlformats.org/drawingml/2006/main">
-            <a:srgbClr val="F3F6FA"/>
-          </a:solidFill>
-          <a:ln xmlns:a="http://schemas.openxmlformats.org/drawingml/2006/main" w="0">
-            <a:noFill/>
-          </a:ln>
-        </p:spPr>
-      </p:sp>
-      <p:sp>
-        <p:nvSpPr>
-          <p:cNvPr id="17" name="Chennai evidence explanation">
-            <a:extLst xmlns:a="http://schemas.openxmlformats.org/drawingml/2006/main">
-              <a:ext uri="{FF2B5EF4-FFF2-40B4-BE49-F238E27FC236}">
-                <a16:creationId xmlns:a16="http://schemas.microsoft.com/office/drawing/2014/main" id="{44D3BBAE-949D-4EF9-9373-AC2683D5018F}"/>
-              </a:ext>
-            </a:extLst>
-          </p:cNvPr>
-          <p:cNvSpPr>
-            <a:spLocks xmlns:a="http://schemas.openxmlformats.org/drawingml/2006/main" noGrp="1"/>
-          </p:cNvSpPr>
-          <p:nvPr/>
-        </p:nvSpPr>
-        <p:spPr>
-          <a:xfrm xmlns:a="http://schemas.openxmlformats.org/drawingml/2006/main">
-            <a:off x="7143750" y="4791075"/>
-            <a:ext cx="4514850" cy="1533525"/>
-          </a:xfrm>
-          <a:prstGeom xmlns:a="http://schemas.openxmlformats.org/drawingml/2006/main" prst="rect">
-            <a:avLst/>
-          </a:prstGeom>
-          <a:solidFill xmlns:a="http://schemas.openxmlformats.org/drawingml/2006/main">
-            <a:srgbClr val="F3F6FA"/>
-          </a:solidFill>
-          <a:ln xmlns:a="http://schemas.openxmlformats.org/drawingml/2006/main" w="0">
-            <a:noFill/>
-          </a:ln>
-        </p:spPr>
-      </p:sp>
-      <p:pic>
-        <p:nvPicPr>
-          <p:cNvPr id="44" name=""/>
-          <p:cNvPicPr>
-            <a:picLocks xmlns:a="http://schemas.openxmlformats.org/drawingml/2006/main" noChangeAspect="1"/>
-          </p:cNvPicPr>
-          <p:nvPr/>
-        </p:nvPicPr>
-        <p:blipFill>
-          <a:blip xmlns:r="http://schemas.openxmlformats.org/officeDocument/2006/relationships" xmlns:a="http://schemas.openxmlformats.org/drawingml/2006/main" r:embed="R920f763b925442ba">
-            <a:extLst>
-              <a:ext uri="{96DAC541-7B7A-43D3-8B79-37D633B846F1}">
-                <asvg:svgBlip xmlns:asvg="http://schemas.microsoft.com/office/drawing/2016/SVG/main" r:embed="R79f0a532ba84428e"/>
-              </a:ext>
-            </a:extLst>
-          </a:blip>
-          <a:stretch xmlns:a="http://schemas.openxmlformats.org/drawingml/2006/main"/>
-        </p:blipFill>
-        <p:spPr>
-          <a:xfrm xmlns:a="http://schemas.openxmlformats.org/drawingml/2006/main">
-            <a:off x="533400" y="1543050"/>
-            <a:ext cx="400050" cy="400050"/>
-          </a:xfrm>
-          <a:prstGeom xmlns:a="http://schemas.openxmlformats.org/drawingml/2006/main" prst="rect">
-            <a:avLst/>
-          </a:prstGeom>
-        </p:spPr>
-      </p:pic>
-      <p:sp>
-        <p:nvSpPr>
-          <p:cNvPr id="19" name="Evidence 15.6 lakh">
-            <a:extLst xmlns:a="http://schemas.openxmlformats.org/drawingml/2006/main">
-              <a:ext uri="{FF2B5EF4-FFF2-40B4-BE49-F238E27FC236}">
-                <a16:creationId xmlns:a16="http://schemas.microsoft.com/office/drawing/2014/main" id="{1E0D3F00-149C-4E3B-A160-745E4FF732EA}"/>
-              </a:ext>
-            </a:extLst>
-          </p:cNvPr>
-          <p:cNvSpPr>
-            <a:spLocks xmlns:a="http://schemas.openxmlformats.org/drawingml/2006/main" noGrp="1"/>
-          </p:cNvSpPr>
-          <p:nvPr/>
-        </p:nvSpPr>
-        <p:spPr>
-          <a:xfrm xmlns:a="http://schemas.openxmlformats.org/drawingml/2006/main">
-            <a:off x="1057275" y="1447800"/>
-            <a:ext cx="2390775" cy="638175"/>
-          </a:xfrm>
-          <a:prstGeom xmlns:a="http://schemas.openxmlformats.org/drawingml/2006/main" prst="rect">
-            <a:avLst/>
-          </a:prstGeom>
-          <a:noFill xmlns:a="http://schemas.openxmlformats.org/drawingml/2006/main"/>
-          <a:ln xmlns:a="http://schemas.openxmlformats.org/drawingml/2006/main" w="0">
-            <a:noFill/>
-          </a:ln>
-        </p:spPr>
-        <p:txBody>
-          <a:bodyPr xmlns:a="http://schemas.openxmlformats.org/drawingml/2006/main" wrap="square" lIns="0" tIns="0" rIns="0" bIns="0">
-            <a:normAutofit fontScale="100000"/>
-          </a:bodyPr>
-          <a:lstStyle xmlns:a="http://schemas.openxmlformats.org/drawingml/2006/main"/>
-          <a:p xmlns:a="http://schemas.openxmlformats.org/drawingml/2006/main">
-            <a:pPr>
-              <a:defRPr sz="3675" b="1">
-                <a:solidFill>
-                  <a:srgbClr val="B75E43"/>
-                </a:solidFill>
-                <a:latin typeface="Arial"/>
-                <a:ea typeface="Arial"/>
-                <a:cs typeface="Arial"/>
-              </a:defRPr>
-            </a:pPr>
-            <a:r>
-              <a:rPr sz="3675" b="1">
-                <a:solidFill>
-                  <a:srgbClr val="B75E43"/>
-                </a:solidFill>
-                <a:latin typeface="Arial"/>
-                <a:ea typeface="Arial"/>
-                <a:cs typeface="Arial"/>
-              </a:rPr>
-              <a:t>15.6 lakh</a:t>
-            </a:r>
-          </a:p>
-        </p:txBody>
-      </p:sp>
-      <p:sp>
-        <p:nvSpPr>
-          <p:cNvPr id="20" name="Evidence 15.6 lakh scope">
-            <a:extLst xmlns:a="http://schemas.openxmlformats.org/drawingml/2006/main">
-              <a:ext uri="{FF2B5EF4-FFF2-40B4-BE49-F238E27FC236}">
-                <a16:creationId xmlns:a16="http://schemas.microsoft.com/office/drawing/2014/main" id="{6CDEA900-F524-4372-ACB9-F53F91FC444A}"/>
-              </a:ext>
-            </a:extLst>
-          </p:cNvPr>
-          <p:cNvSpPr>
-            <a:spLocks xmlns:a="http://schemas.openxmlformats.org/drawingml/2006/main" noGrp="1"/>
-          </p:cNvSpPr>
-          <p:nvPr/>
-        </p:nvSpPr>
-        <p:spPr>
-          <a:xfrm xmlns:a="http://schemas.openxmlformats.org/drawingml/2006/main">
-            <a:off x="533400" y="2238375"/>
-            <a:ext cx="2914650" cy="1162050"/>
-          </a:xfrm>
-          <a:prstGeom xmlns:a="http://schemas.openxmlformats.org/drawingml/2006/main" prst="rect">
-            <a:avLst/>
-          </a:prstGeom>
-          <a:noFill xmlns:a="http://schemas.openxmlformats.org/drawingml/2006/main"/>
-          <a:ln xmlns:a="http://schemas.openxmlformats.org/drawingml/2006/main" w="0">
-            <a:noFill/>
-          </a:ln>
-        </p:spPr>
-        <p:txBody>
-          <a:bodyPr xmlns:a="http://schemas.openxmlformats.org/drawingml/2006/main" wrap="square" lIns="0" tIns="0" rIns="0" bIns="0">
-            <a:normAutofit fontScale="100000"/>
-          </a:bodyPr>
-          <a:lstStyle xmlns:a="http://schemas.openxmlformats.org/drawingml/2006/main"/>
-          <a:p xmlns:a="http://schemas.openxmlformats.org/drawingml/2006/main">
-            <a:pPr>
-              <a:defRPr sz="1575" b="0">
-                <a:solidFill>
-                  <a:srgbClr val="173F33"/>
-                </a:solidFill>
-                <a:latin typeface="Arial"/>
-                <a:ea typeface="Arial"/>
-                <a:cs typeface="Arial"/>
-              </a:defRPr>
-            </a:pPr>
-            <a:r>
-              <a:rPr sz="1575" b="0">
-                <a:solidFill>
-                  <a:srgbClr val="173F33"/>
-                </a:solidFill>
-                <a:latin typeface="Arial"/>
-                <a:ea typeface="Arial"/>
-                <a:cs typeface="Arial"/>
-              </a:rPr>
-              <a:t>Estimated new cancer cases in India in 2024.</a:t>
-            </a:r>
-          </a:p>
-        </p:txBody>
-      </p:sp>
-      <p:sp>
-        <p:nvSpPr>
-          <p:cNvPr id="21" name="Evidence 15.6 lakh source">
-            <a:extLst xmlns:a="http://schemas.openxmlformats.org/drawingml/2006/main">
-              <a:ext uri="{FF2B5EF4-FFF2-40B4-BE49-F238E27FC236}">
-                <a16:creationId xmlns:a16="http://schemas.microsoft.com/office/drawing/2014/main" id="{E7D3F050-0B7E-45BF-96C4-6D7AEC175C84}"/>
-              </a:ext>
-            </a:extLst>
-          </p:cNvPr>
-          <p:cNvSpPr>
-            <a:spLocks xmlns:a="http://schemas.openxmlformats.org/drawingml/2006/main" noGrp="1"/>
-          </p:cNvSpPr>
-          <p:nvPr/>
-        </p:nvSpPr>
-        <p:spPr>
-          <a:xfrm xmlns:a="http://schemas.openxmlformats.org/drawingml/2006/main">
-            <a:off x="533400" y="3457575"/>
-            <a:ext cx="2914650" cy="371475"/>
-          </a:xfrm>
-          <a:prstGeom xmlns:a="http://schemas.openxmlformats.org/drawingml/2006/main" prst="rect">
-            <a:avLst/>
-          </a:prstGeom>
-          <a:noFill xmlns:a="http://schemas.openxmlformats.org/drawingml/2006/main"/>
-          <a:ln xmlns:a="http://schemas.openxmlformats.org/drawingml/2006/main" w="0">
-            <a:noFill/>
-          </a:ln>
-        </p:spPr>
-        <p:txBody>
-          <a:bodyPr xmlns:a="http://schemas.openxmlformats.org/drawingml/2006/main" wrap="square" lIns="0" tIns="0" rIns="0" bIns="0">
-            <a:normAutofit fontScale="100000"/>
-          </a:bodyPr>
-          <a:lstStyle xmlns:a="http://schemas.openxmlformats.org/drawingml/2006/main"/>
-          <a:p xmlns:a="http://schemas.openxmlformats.org/drawingml/2006/main">
-            <a:pPr>
-              <a:defRPr sz="1163" b="0">
-                <a:solidFill>
-                  <a:srgbClr val="145AC6"/>
-                </a:solidFill>
-                <a:latin typeface="Arial"/>
-                <a:ea typeface="Arial"/>
-                <a:cs typeface="Arial"/>
-              </a:defRPr>
-            </a:pPr>
-            <a:r>
-              <a:rPr sz="1163" b="0" u="sng">
-                <a:solidFill>
-                  <a:srgbClr val="145AC6"/>
-                </a:solidFill>
-                <a:latin typeface="Arial"/>
-                <a:ea typeface="Arial"/>
-                <a:cs typeface="Arial"/>
-                <a:hlinkClick xmlns:r="http://schemas.openxmlformats.org/officeDocument/2006/relationships" r:id="Rab4c578e80334357"/>
-              </a:rPr>
-              <a:t>IARC, GLOBOCAN 2024</a:t>
-            </a:r>
-          </a:p>
-        </p:txBody>
-      </p:sp>
-      <p:pic>
-        <p:nvPicPr>
-          <p:cNvPr id="48" name=""/>
-          <p:cNvPicPr>
-            <a:picLocks xmlns:a="http://schemas.openxmlformats.org/drawingml/2006/main" noChangeAspect="1"/>
-          </p:cNvPicPr>
-          <p:nvPr/>
-        </p:nvPicPr>
-        <p:blipFill>
-          <a:blip xmlns:r="http://schemas.openxmlformats.org/officeDocument/2006/relationships" xmlns:a="http://schemas.openxmlformats.org/drawingml/2006/main" r:embed="R4bff11e25d7d4488">
-            <a:extLst>
-              <a:ext uri="{96DAC541-7B7A-43D3-8B79-37D633B846F1}">
-                <asvg:svgBlip xmlns:asvg="http://schemas.microsoft.com/office/drawing/2016/SVG/main" r:embed="R4cf26de1dd9f4ec4"/>
-              </a:ext>
-            </a:extLst>
-          </a:blip>
-          <a:stretch xmlns:a="http://schemas.openxmlformats.org/drawingml/2006/main"/>
-        </p:blipFill>
-        <p:spPr>
-          <a:xfrm xmlns:a="http://schemas.openxmlformats.org/drawingml/2006/main">
-            <a:off x="3829050" y="1543050"/>
-            <a:ext cx="400050" cy="400050"/>
-          </a:xfrm>
-          <a:prstGeom xmlns:a="http://schemas.openxmlformats.org/drawingml/2006/main" prst="rect">
-            <a:avLst/>
-          </a:prstGeom>
-        </p:spPr>
-      </p:pic>
-      <p:sp>
-        <p:nvSpPr>
-          <p:cNvPr id="23" name="Evidence 98.39%">
-            <a:extLst xmlns:a="http://schemas.openxmlformats.org/drawingml/2006/main">
-              <a:ext uri="{FF2B5EF4-FFF2-40B4-BE49-F238E27FC236}">
-                <a16:creationId xmlns:a16="http://schemas.microsoft.com/office/drawing/2014/main" id="{6CE93032-0102-4554-A8C8-5FD06036B029}"/>
-              </a:ext>
-            </a:extLst>
-          </p:cNvPr>
-          <p:cNvSpPr>
-            <a:spLocks xmlns:a="http://schemas.openxmlformats.org/drawingml/2006/main" noGrp="1"/>
-          </p:cNvSpPr>
-          <p:nvPr/>
-        </p:nvSpPr>
-        <p:spPr>
-          <a:xfrm xmlns:a="http://schemas.openxmlformats.org/drawingml/2006/main">
-            <a:off x="4352925" y="1447800"/>
-            <a:ext cx="2390775" cy="638175"/>
-          </a:xfrm>
-          <a:prstGeom xmlns:a="http://schemas.openxmlformats.org/drawingml/2006/main" prst="rect">
-            <a:avLst/>
-          </a:prstGeom>
-          <a:noFill xmlns:a="http://schemas.openxmlformats.org/drawingml/2006/main"/>
-          <a:ln xmlns:a="http://schemas.openxmlformats.org/drawingml/2006/main" w="0">
-            <a:noFill/>
-          </a:ln>
-        </p:spPr>
-        <p:txBody>
-          <a:bodyPr xmlns:a="http://schemas.openxmlformats.org/drawingml/2006/main" wrap="square" lIns="0" tIns="0" rIns="0" bIns="0">
-            <a:normAutofit fontScale="100000"/>
-          </a:bodyPr>
-          <a:lstStyle xmlns:a="http://schemas.openxmlformats.org/drawingml/2006/main"/>
-          <a:p xmlns:a="http://schemas.openxmlformats.org/drawingml/2006/main">
-            <a:pPr>
-              <a:defRPr sz="3675" b="1">
-                <a:solidFill>
-                  <a:srgbClr val="157B68"/>
-                </a:solidFill>
-                <a:latin typeface="Arial"/>
-                <a:ea typeface="Arial"/>
-                <a:cs typeface="Arial"/>
-              </a:defRPr>
-            </a:pPr>
-            <a:r>
-              <a:rPr sz="3675" b="1">
-                <a:solidFill>
-                  <a:srgbClr val="157B68"/>
-                </a:solidFill>
-                <a:latin typeface="Arial"/>
-                <a:ea typeface="Arial"/>
-                <a:cs typeface="Arial"/>
-              </a:rPr>
-              <a:t>98.39%</a:t>
-            </a:r>
-          </a:p>
-        </p:txBody>
-      </p:sp>
-      <p:sp>
-        <p:nvSpPr>
-          <p:cNvPr id="24" name="Evidence 98.39% scope">
-            <a:extLst xmlns:a="http://schemas.openxmlformats.org/drawingml/2006/main">
-              <a:ext uri="{FF2B5EF4-FFF2-40B4-BE49-F238E27FC236}">
-                <a16:creationId xmlns:a16="http://schemas.microsoft.com/office/drawing/2014/main" id="{32B58A39-88D9-42C5-B9F3-5BE22F46425F}"/>
-              </a:ext>
-            </a:extLst>
-          </p:cNvPr>
-          <p:cNvSpPr>
-            <a:spLocks xmlns:a="http://schemas.openxmlformats.org/drawingml/2006/main" noGrp="1"/>
-          </p:cNvSpPr>
-          <p:nvPr/>
-        </p:nvSpPr>
-        <p:spPr>
-          <a:xfrm xmlns:a="http://schemas.openxmlformats.org/drawingml/2006/main">
-            <a:off x="3829050" y="2238375"/>
-            <a:ext cx="2914650" cy="1162050"/>
-          </a:xfrm>
-          <a:prstGeom xmlns:a="http://schemas.openxmlformats.org/drawingml/2006/main" prst="rect">
-            <a:avLst/>
-          </a:prstGeom>
-          <a:noFill xmlns:a="http://schemas.openxmlformats.org/drawingml/2006/main"/>
-          <a:ln xmlns:a="http://schemas.openxmlformats.org/drawingml/2006/main" w="0">
-            <a:noFill/>
-          </a:ln>
-        </p:spPr>
-        <p:txBody>
-          <a:bodyPr xmlns:a="http://schemas.openxmlformats.org/drawingml/2006/main" wrap="square" lIns="0" tIns="0" rIns="0" bIns="0">
-            <a:normAutofit fontScale="100000"/>
-          </a:bodyPr>
-          <a:lstStyle xmlns:a="http://schemas.openxmlformats.org/drawingml/2006/main"/>
-          <a:p xmlns:a="http://schemas.openxmlformats.org/drawingml/2006/main">
-            <a:pPr>
-              <a:defRPr sz="1575" b="0">
-                <a:solidFill>
-                  <a:srgbClr val="173F33"/>
-                </a:solidFill>
-                <a:latin typeface="Arial"/>
-                <a:ea typeface="Arial"/>
-                <a:cs typeface="Arial"/>
-              </a:defRPr>
-            </a:pPr>
-            <a:r>
-              <a:rPr sz="1575" b="0">
-                <a:solidFill>
-                  <a:srgbClr val="173F33"/>
-                </a:solidFill>
-                <a:latin typeface="Arial"/>
-                <a:ea typeface="Arial"/>
-                <a:cs typeface="Arial"/>
-              </a:rPr>
-              <a:t>Estimated unmet palliative-care need among people whose cancer had spread, across 10 cancer types.</a:t>
-            </a:r>
-          </a:p>
-        </p:txBody>
-      </p:sp>
-      <p:sp>
-        <p:nvSpPr>
-          <p:cNvPr id="25" name="Evidence 98.39% source">
-            <a:extLst xmlns:a="http://schemas.openxmlformats.org/drawingml/2006/main">
-              <a:ext uri="{FF2B5EF4-FFF2-40B4-BE49-F238E27FC236}">
-                <a16:creationId xmlns:a16="http://schemas.microsoft.com/office/drawing/2014/main" id="{CA977751-1DB2-4171-9168-1158C8ADD222}"/>
-              </a:ext>
-            </a:extLst>
-          </p:cNvPr>
-          <p:cNvSpPr>
-            <a:spLocks xmlns:a="http://schemas.openxmlformats.org/drawingml/2006/main" noGrp="1"/>
-          </p:cNvSpPr>
-          <p:nvPr/>
-        </p:nvSpPr>
-        <p:spPr>
-          <a:xfrm xmlns:a="http://schemas.openxmlformats.org/drawingml/2006/main">
-            <a:off x="3829050" y="3457575"/>
-            <a:ext cx="2914650" cy="371475"/>
-          </a:xfrm>
-          <a:prstGeom xmlns:a="http://schemas.openxmlformats.org/drawingml/2006/main" prst="rect">
-            <a:avLst/>
-          </a:prstGeom>
-          <a:noFill xmlns:a="http://schemas.openxmlformats.org/drawingml/2006/main"/>
-          <a:ln xmlns:a="http://schemas.openxmlformats.org/drawingml/2006/main" w="0">
-            <a:noFill/>
-          </a:ln>
-        </p:spPr>
-        <p:txBody>
-          <a:bodyPr xmlns:a="http://schemas.openxmlformats.org/drawingml/2006/main" wrap="square" lIns="0" tIns="0" rIns="0" bIns="0">
-            <a:normAutofit fontScale="100000"/>
-          </a:bodyPr>
-          <a:lstStyle xmlns:a="http://schemas.openxmlformats.org/drawingml/2006/main"/>
-          <a:p xmlns:a="http://schemas.openxmlformats.org/drawingml/2006/main">
-            <a:pPr>
-              <a:defRPr sz="1163" b="0">
-                <a:solidFill>
-                  <a:srgbClr val="145AC6"/>
-                </a:solidFill>
-                <a:latin typeface="Arial"/>
-                <a:ea typeface="Arial"/>
-                <a:cs typeface="Arial"/>
-              </a:defRPr>
-            </a:pPr>
-            <a:r>
-              <a:rPr sz="1163" b="0" u="sng">
-                <a:solidFill>
-                  <a:srgbClr val="145AC6"/>
-                </a:solidFill>
-                <a:latin typeface="Arial"/>
-                <a:ea typeface="Arial"/>
-                <a:cs typeface="Arial"/>
-                <a:hlinkClick xmlns:r="http://schemas.openxmlformats.org/officeDocument/2006/relationships" r:id="Rd799c1bf899c4352"/>
-              </a:rPr>
-              <a:t>Patil et al., 2024</a:t>
-            </a:r>
-          </a:p>
-        </p:txBody>
-      </p:sp>
-      <p:pic>
-        <p:nvPicPr>
-          <p:cNvPr id="52" name=""/>
-          <p:cNvPicPr>
-            <a:picLocks xmlns:a="http://schemas.openxmlformats.org/drawingml/2006/main" noChangeAspect="1"/>
-          </p:cNvPicPr>
-          <p:nvPr/>
-        </p:nvPicPr>
-        <p:blipFill>
-          <a:blip xmlns:r="http://schemas.openxmlformats.org/officeDocument/2006/relationships" xmlns:a="http://schemas.openxmlformats.org/drawingml/2006/main" r:embed="Rcc55cf1aedb44bb6">
-            <a:extLst>
-              <a:ext uri="{96DAC541-7B7A-43D3-8B79-37D633B846F1}">
-                <asvg:svgBlip xmlns:asvg="http://schemas.microsoft.com/office/drawing/2016/SVG/main" r:embed="Rf12737ff2b1443c1"/>
-              </a:ext>
-            </a:extLst>
-          </a:blip>
-          <a:stretch xmlns:a="http://schemas.openxmlformats.org/drawingml/2006/main"/>
-        </p:blipFill>
-        <p:spPr>
-          <a:xfrm xmlns:a="http://schemas.openxmlformats.org/drawingml/2006/main">
-            <a:off x="533400" y="4076700"/>
-            <a:ext cx="400050" cy="400050"/>
-          </a:xfrm>
-          <a:prstGeom xmlns:a="http://schemas.openxmlformats.org/drawingml/2006/main" prst="rect">
-            <a:avLst/>
-          </a:prstGeom>
-        </p:spPr>
-      </p:pic>
-      <p:sp>
-        <p:nvSpPr>
-          <p:cNvPr id="27" name="Evidence 88%">
-            <a:extLst xmlns:a="http://schemas.openxmlformats.org/drawingml/2006/main">
-              <a:ext uri="{FF2B5EF4-FFF2-40B4-BE49-F238E27FC236}">
-                <a16:creationId xmlns:a16="http://schemas.microsoft.com/office/drawing/2014/main" id="{4E9CD7F5-B611-453D-8179-7B5DAF869144}"/>
-              </a:ext>
-            </a:extLst>
-          </p:cNvPr>
-          <p:cNvSpPr>
-            <a:spLocks xmlns:a="http://schemas.openxmlformats.org/drawingml/2006/main" noGrp="1"/>
-          </p:cNvSpPr>
-          <p:nvPr/>
-        </p:nvSpPr>
-        <p:spPr>
-          <a:xfrm xmlns:a="http://schemas.openxmlformats.org/drawingml/2006/main">
-            <a:off x="1057275" y="3981450"/>
-            <a:ext cx="2390775" cy="638175"/>
-          </a:xfrm>
-          <a:prstGeom xmlns:a="http://schemas.openxmlformats.org/drawingml/2006/main" prst="rect">
-            <a:avLst/>
-          </a:prstGeom>
-          <a:noFill xmlns:a="http://schemas.openxmlformats.org/drawingml/2006/main"/>
-          <a:ln xmlns:a="http://schemas.openxmlformats.org/drawingml/2006/main" w="0">
-            <a:noFill/>
-          </a:ln>
-        </p:spPr>
-        <p:txBody>
-          <a:bodyPr xmlns:a="http://schemas.openxmlformats.org/drawingml/2006/main" wrap="square" lIns="0" tIns="0" rIns="0" bIns="0">
-            <a:normAutofit fontScale="100000"/>
-          </a:bodyPr>
-          <a:lstStyle xmlns:a="http://schemas.openxmlformats.org/drawingml/2006/main"/>
-          <a:p xmlns:a="http://schemas.openxmlformats.org/drawingml/2006/main">
-            <a:pPr>
-              <a:defRPr sz="3675" b="1">
-                <a:solidFill>
-                  <a:srgbClr val="7353AC"/>
-                </a:solidFill>
-                <a:latin typeface="Arial"/>
-                <a:ea typeface="Arial"/>
-                <a:cs typeface="Arial"/>
-              </a:defRPr>
-            </a:pPr>
-            <a:r>
-              <a:rPr sz="3675" b="1">
-                <a:solidFill>
-                  <a:srgbClr val="7353AC"/>
-                </a:solidFill>
-                <a:latin typeface="Arial"/>
-                <a:ea typeface="Arial"/>
-                <a:cs typeface="Arial"/>
-              </a:rPr>
-              <a:t>88%</a:t>
-            </a:r>
-          </a:p>
-        </p:txBody>
-      </p:sp>
-      <p:sp>
-        <p:nvSpPr>
-          <p:cNvPr id="28" name="Evidence 88% scope">
-            <a:extLst xmlns:a="http://schemas.openxmlformats.org/drawingml/2006/main">
-              <a:ext uri="{FF2B5EF4-FFF2-40B4-BE49-F238E27FC236}">
-                <a16:creationId xmlns:a16="http://schemas.microsoft.com/office/drawing/2014/main" id="{6EC8E998-40F4-41E4-848A-E657D591F75C}"/>
-              </a:ext>
-            </a:extLst>
-          </p:cNvPr>
-          <p:cNvSpPr>
-            <a:spLocks xmlns:a="http://schemas.openxmlformats.org/drawingml/2006/main" noGrp="1"/>
-          </p:cNvSpPr>
-          <p:nvPr/>
-        </p:nvSpPr>
-        <p:spPr>
-          <a:xfrm xmlns:a="http://schemas.openxmlformats.org/drawingml/2006/main">
-            <a:off x="533400" y="4772025"/>
-            <a:ext cx="2914650" cy="1162050"/>
-          </a:xfrm>
-          <a:prstGeom xmlns:a="http://schemas.openxmlformats.org/drawingml/2006/main" prst="rect">
-            <a:avLst/>
-          </a:prstGeom>
-          <a:noFill xmlns:a="http://schemas.openxmlformats.org/drawingml/2006/main"/>
-          <a:ln xmlns:a="http://schemas.openxmlformats.org/drawingml/2006/main" w="0">
-            <a:noFill/>
-          </a:ln>
-        </p:spPr>
-        <p:txBody>
-          <a:bodyPr xmlns:a="http://schemas.openxmlformats.org/drawingml/2006/main" wrap="square" lIns="0" tIns="0" rIns="0" bIns="0">
-            <a:normAutofit fontScale="100000"/>
-          </a:bodyPr>
-          <a:lstStyle xmlns:a="http://schemas.openxmlformats.org/drawingml/2006/main"/>
-          <a:p xmlns:a="http://schemas.openxmlformats.org/drawingml/2006/main">
-            <a:pPr>
-              <a:defRPr sz="1575" b="0">
-                <a:solidFill>
-                  <a:srgbClr val="173F33"/>
-                </a:solidFill>
-                <a:latin typeface="Arial"/>
-                <a:ea typeface="Arial"/>
-                <a:cs typeface="Arial"/>
-              </a:defRPr>
-            </a:pPr>
-            <a:r>
-              <a:rPr sz="1575" b="0">
-                <a:solidFill>
-                  <a:srgbClr val="173F33"/>
-                </a:solidFill>
-                <a:latin typeface="Arial"/>
-                <a:ea typeface="Arial"/>
-                <a:cs typeface="Arial"/>
-              </a:rPr>
-              <a:t>Wanted to choose their treatment near the end of life in a 2019 survey of 2,400+ urban respondents.</a:t>
-            </a:r>
-          </a:p>
-        </p:txBody>
-      </p:sp>
-      <p:sp>
-        <p:nvSpPr>
-          <p:cNvPr id="29" name="Evidence 88% source">
-            <a:extLst xmlns:a="http://schemas.openxmlformats.org/drawingml/2006/main">
-              <a:ext uri="{FF2B5EF4-FFF2-40B4-BE49-F238E27FC236}">
-                <a16:creationId xmlns:a16="http://schemas.microsoft.com/office/drawing/2014/main" id="{0B6494A8-2AAC-4AB9-8BB8-E42E05550CAE}"/>
-              </a:ext>
-            </a:extLst>
-          </p:cNvPr>
-          <p:cNvSpPr>
-            <a:spLocks xmlns:a="http://schemas.openxmlformats.org/drawingml/2006/main" noGrp="1"/>
-          </p:cNvSpPr>
-          <p:nvPr/>
-        </p:nvSpPr>
-        <p:spPr>
-          <a:xfrm xmlns:a="http://schemas.openxmlformats.org/drawingml/2006/main">
-            <a:off x="533400" y="5991225"/>
-            <a:ext cx="2914650" cy="371475"/>
-          </a:xfrm>
-          <a:prstGeom xmlns:a="http://schemas.openxmlformats.org/drawingml/2006/main" prst="rect">
-            <a:avLst/>
-          </a:prstGeom>
-          <a:noFill xmlns:a="http://schemas.openxmlformats.org/drawingml/2006/main"/>
-          <a:ln xmlns:a="http://schemas.openxmlformats.org/drawingml/2006/main" w="0">
-            <a:noFill/>
-          </a:ln>
-        </p:spPr>
-        <p:txBody>
-          <a:bodyPr xmlns:a="http://schemas.openxmlformats.org/drawingml/2006/main" wrap="square" lIns="0" tIns="0" rIns="0" bIns="0">
-            <a:normAutofit fontScale="100000"/>
-          </a:bodyPr>
-          <a:lstStyle xmlns:a="http://schemas.openxmlformats.org/drawingml/2006/main"/>
-          <a:p xmlns:a="http://schemas.openxmlformats.org/drawingml/2006/main">
-            <a:pPr>
-              <a:defRPr sz="1163" b="0">
-                <a:solidFill>
-                  <a:srgbClr val="145AC6"/>
-                </a:solidFill>
-                <a:latin typeface="Arial"/>
-                <a:ea typeface="Arial"/>
-                <a:cs typeface="Arial"/>
-              </a:defRPr>
-            </a:pPr>
-            <a:r>
-              <a:rPr sz="1163" b="0" u="sng">
-                <a:solidFill>
-                  <a:srgbClr val="145AC6"/>
-                </a:solidFill>
-                <a:latin typeface="Arial"/>
-                <a:ea typeface="Arial"/>
-                <a:cs typeface="Arial"/>
-                <a:hlinkClick xmlns:r="http://schemas.openxmlformats.org/officeDocument/2006/relationships" r:id="R5089ef7c1d744f08"/>
-              </a:rPr>
-              <a:t>IndiaSpend reporting; seven cities</a:t>
-            </a:r>
-          </a:p>
-        </p:txBody>
-      </p:sp>
-      <p:pic>
-        <p:nvPicPr>
-          <p:cNvPr id="56" name=""/>
-          <p:cNvPicPr>
-            <a:picLocks xmlns:a="http://schemas.openxmlformats.org/drawingml/2006/main" noChangeAspect="1"/>
-          </p:cNvPicPr>
-          <p:nvPr/>
-        </p:nvPicPr>
-        <p:blipFill>
-          <a:blip xmlns:r="http://schemas.openxmlformats.org/officeDocument/2006/relationships" xmlns:a="http://schemas.openxmlformats.org/drawingml/2006/main" r:embed="Rddbd7cb823314ba5">
-            <a:extLst>
-              <a:ext uri="{96DAC541-7B7A-43D3-8B79-37D633B846F1}">
-                <asvg:svgBlip xmlns:asvg="http://schemas.microsoft.com/office/drawing/2016/SVG/main" r:embed="R9fc2583e67574187"/>
-              </a:ext>
-            </a:extLst>
-          </a:blip>
-          <a:stretch xmlns:a="http://schemas.openxmlformats.org/drawingml/2006/main"/>
-        </p:blipFill>
-        <p:spPr>
-          <a:xfrm xmlns:a="http://schemas.openxmlformats.org/drawingml/2006/main">
-            <a:off x="3829050" y="4076700"/>
-            <a:ext cx="400050" cy="400050"/>
-          </a:xfrm>
-          <a:prstGeom xmlns:a="http://schemas.openxmlformats.org/drawingml/2006/main" prst="rect">
-            <a:avLst/>
-          </a:prstGeom>
-        </p:spPr>
-      </p:pic>
-      <p:sp>
-        <p:nvSpPr>
-          <p:cNvPr id="31" name="Evidence 11.5%">
-            <a:extLst xmlns:a="http://schemas.openxmlformats.org/drawingml/2006/main">
-              <a:ext uri="{FF2B5EF4-FFF2-40B4-BE49-F238E27FC236}">
-                <a16:creationId xmlns:a16="http://schemas.microsoft.com/office/drawing/2014/main" id="{514AB0BC-89CD-4642-9E56-8FFD985B36A8}"/>
-              </a:ext>
-            </a:extLst>
-          </p:cNvPr>
-          <p:cNvSpPr>
-            <a:spLocks xmlns:a="http://schemas.openxmlformats.org/drawingml/2006/main" noGrp="1"/>
-          </p:cNvSpPr>
-          <p:nvPr/>
-        </p:nvSpPr>
-        <p:spPr>
-          <a:xfrm xmlns:a="http://schemas.openxmlformats.org/drawingml/2006/main">
-            <a:off x="4352925" y="3981450"/>
-            <a:ext cx="2390775" cy="638175"/>
-          </a:xfrm>
-          <a:prstGeom xmlns:a="http://schemas.openxmlformats.org/drawingml/2006/main" prst="rect">
-            <a:avLst/>
-          </a:prstGeom>
-          <a:noFill xmlns:a="http://schemas.openxmlformats.org/drawingml/2006/main"/>
-          <a:ln xmlns:a="http://schemas.openxmlformats.org/drawingml/2006/main" w="0">
-            <a:noFill/>
-          </a:ln>
-        </p:spPr>
-        <p:txBody>
-          <a:bodyPr xmlns:a="http://schemas.openxmlformats.org/drawingml/2006/main" wrap="square" lIns="0" tIns="0" rIns="0" bIns="0">
-            <a:normAutofit fontScale="100000"/>
-          </a:bodyPr>
-          <a:lstStyle xmlns:a="http://schemas.openxmlformats.org/drawingml/2006/main"/>
-          <a:p xmlns:a="http://schemas.openxmlformats.org/drawingml/2006/main">
-            <a:pPr>
-              <a:defRPr sz="3675" b="1">
-                <a:solidFill>
-                  <a:srgbClr val="4357C7"/>
-                </a:solidFill>
-                <a:latin typeface="Arial"/>
-                <a:ea typeface="Arial"/>
-                <a:cs typeface="Arial"/>
-              </a:defRPr>
-            </a:pPr>
-            <a:r>
-              <a:rPr sz="3675" b="1">
-                <a:solidFill>
-                  <a:srgbClr val="4357C7"/>
-                </a:solidFill>
-                <a:latin typeface="Arial"/>
-                <a:ea typeface="Arial"/>
-                <a:cs typeface="Arial"/>
-              </a:rPr>
-              <a:t>11.5%</a:t>
-            </a:r>
-          </a:p>
-        </p:txBody>
-      </p:sp>
-      <p:sp>
-        <p:nvSpPr>
-          <p:cNvPr id="32" name="Evidence 11.5% scope">
-            <a:extLst xmlns:a="http://schemas.openxmlformats.org/drawingml/2006/main">
-              <a:ext uri="{FF2B5EF4-FFF2-40B4-BE49-F238E27FC236}">
-                <a16:creationId xmlns:a16="http://schemas.microsoft.com/office/drawing/2014/main" id="{FD6D0EED-41EF-4DB9-8280-2C878C0E01B4}"/>
-              </a:ext>
-            </a:extLst>
-          </p:cNvPr>
-          <p:cNvSpPr>
-            <a:spLocks xmlns:a="http://schemas.openxmlformats.org/drawingml/2006/main" noGrp="1"/>
-          </p:cNvSpPr>
-          <p:nvPr/>
-        </p:nvSpPr>
-        <p:spPr>
-          <a:xfrm xmlns:a="http://schemas.openxmlformats.org/drawingml/2006/main">
-            <a:off x="3829050" y="4772025"/>
-            <a:ext cx="2914650" cy="1162050"/>
-          </a:xfrm>
-          <a:prstGeom xmlns:a="http://schemas.openxmlformats.org/drawingml/2006/main" prst="rect">
-            <a:avLst/>
-          </a:prstGeom>
-          <a:noFill xmlns:a="http://schemas.openxmlformats.org/drawingml/2006/main"/>
-          <a:ln xmlns:a="http://schemas.openxmlformats.org/drawingml/2006/main" w="0">
-            <a:noFill/>
-          </a:ln>
-        </p:spPr>
-        <p:txBody>
-          <a:bodyPr xmlns:a="http://schemas.openxmlformats.org/drawingml/2006/main" wrap="square" lIns="0" tIns="0" rIns="0" bIns="0">
-            <a:normAutofit fontScale="100000"/>
-          </a:bodyPr>
-          <a:lstStyle xmlns:a="http://schemas.openxmlformats.org/drawingml/2006/main"/>
-          <a:p xmlns:a="http://schemas.openxmlformats.org/drawingml/2006/main">
-            <a:pPr>
-              <a:defRPr sz="1575" b="0">
-                <a:solidFill>
-                  <a:srgbClr val="173F33"/>
-                </a:solidFill>
-                <a:latin typeface="Arial"/>
-                <a:ea typeface="Arial"/>
-                <a:cs typeface="Arial"/>
-              </a:defRPr>
-            </a:pPr>
-            <a:r>
-              <a:rPr sz="1575" b="0">
-                <a:solidFill>
-                  <a:srgbClr val="173F33"/>
-                </a:solidFill>
-                <a:latin typeface="Arial"/>
-                <a:ea typeface="Arial"/>
-                <a:cs typeface="Arial"/>
-              </a:rPr>
-              <a:t>45 of 391 doctors at one hospital had training in advance directives, which record wishes for future care.</a:t>
-            </a:r>
-          </a:p>
-        </p:txBody>
-      </p:sp>
-      <p:sp>
-        <p:nvSpPr>
-          <p:cNvPr id="33" name="Evidence 11.5% source">
-            <a:extLst xmlns:a="http://schemas.openxmlformats.org/drawingml/2006/main">
-              <a:ext uri="{FF2B5EF4-FFF2-40B4-BE49-F238E27FC236}">
-                <a16:creationId xmlns:a16="http://schemas.microsoft.com/office/drawing/2014/main" id="{9B8E6C53-3906-4A0A-8CFE-8E7F2EE6B42F}"/>
-              </a:ext>
-            </a:extLst>
-          </p:cNvPr>
-          <p:cNvSpPr>
-            <a:spLocks xmlns:a="http://schemas.openxmlformats.org/drawingml/2006/main" noGrp="1"/>
-          </p:cNvSpPr>
-          <p:nvPr/>
-        </p:nvSpPr>
-        <p:spPr>
-          <a:xfrm xmlns:a="http://schemas.openxmlformats.org/drawingml/2006/main">
-            <a:off x="3829050" y="5991225"/>
-            <a:ext cx="2914650" cy="371475"/>
-          </a:xfrm>
-          <a:prstGeom xmlns:a="http://schemas.openxmlformats.org/drawingml/2006/main" prst="rect">
-            <a:avLst/>
-          </a:prstGeom>
-          <a:noFill xmlns:a="http://schemas.openxmlformats.org/drawingml/2006/main"/>
-          <a:ln xmlns:a="http://schemas.openxmlformats.org/drawingml/2006/main" w="0">
-            <a:noFill/>
-          </a:ln>
-        </p:spPr>
-        <p:txBody>
-          <a:bodyPr xmlns:a="http://schemas.openxmlformats.org/drawingml/2006/main" wrap="square" lIns="0" tIns="0" rIns="0" bIns="0">
-            <a:normAutofit fontScale="100000"/>
-          </a:bodyPr>
-          <a:lstStyle xmlns:a="http://schemas.openxmlformats.org/drawingml/2006/main"/>
-          <a:p xmlns:a="http://schemas.openxmlformats.org/drawingml/2006/main">
-            <a:pPr>
-              <a:defRPr sz="1163" b="0">
-                <a:solidFill>
-                  <a:srgbClr val="145AC6"/>
-                </a:solidFill>
-                <a:latin typeface="Arial"/>
-                <a:ea typeface="Arial"/>
-                <a:cs typeface="Arial"/>
-              </a:defRPr>
-            </a:pPr>
-            <a:r>
-              <a:rPr sz="1163" b="0" u="sng">
-                <a:solidFill>
-                  <a:srgbClr val="145AC6"/>
-                </a:solidFill>
-                <a:latin typeface="Arial"/>
-                <a:ea typeface="Arial"/>
-                <a:cs typeface="Arial"/>
-                <a:hlinkClick xmlns:r="http://schemas.openxmlformats.org/officeDocument/2006/relationships" r:id="Rb053a137070f4f44"/>
-              </a:rPr>
-              <a:t>Jacob et al., CMC Vellore, 2026</a:t>
-            </a:r>
-          </a:p>
-        </p:txBody>
-      </p:sp>
-      <p:pic>
-        <p:nvPicPr>
-          <p:cNvPr id="60" name=""/>
-          <p:cNvPicPr>
-            <a:picLocks xmlns:a="http://schemas.openxmlformats.org/drawingml/2006/main" noChangeAspect="1"/>
-          </p:cNvPicPr>
-          <p:nvPr/>
-        </p:nvPicPr>
-        <p:blipFill>
-          <a:blip xmlns:r="http://schemas.openxmlformats.org/officeDocument/2006/relationships" xmlns:a="http://schemas.openxmlformats.org/drawingml/2006/main" r:embed="R1f9e082886864a11">
-            <a:extLst>
-              <a:ext uri="{96DAC541-7B7A-43D3-8B79-37D633B846F1}">
-                <asvg:svgBlip xmlns:asvg="http://schemas.microsoft.com/office/drawing/2016/SVG/main" r:embed="Rc9bae1b679b64aa3"/>
-              </a:ext>
-            </a:extLst>
-          </a:blip>
-          <a:stretch xmlns:a="http://schemas.openxmlformats.org/drawingml/2006/main"/>
-        </p:blipFill>
-        <p:spPr>
-          <a:xfrm xmlns:a="http://schemas.openxmlformats.org/drawingml/2006/main">
-            <a:off x="7372350" y="1533525"/>
-            <a:ext cx="381000" cy="381000"/>
-          </a:xfrm>
-          <a:prstGeom xmlns:a="http://schemas.openxmlformats.org/drawingml/2006/main" prst="rect">
-            <a:avLst/>
-          </a:prstGeom>
-        </p:spPr>
-      </p:pic>
-      <p:sp>
-        <p:nvSpPr>
-          <p:cNvPr id="35" name="QI measure">
-            <a:extLst xmlns:a="http://schemas.openxmlformats.org/drawingml/2006/main">
-              <a:ext uri="{FF2B5EF4-FFF2-40B4-BE49-F238E27FC236}">
-                <a16:creationId xmlns:a16="http://schemas.microsoft.com/office/drawing/2014/main" id="{E4494B7E-9A16-4DBC-B6A4-FCDB9CB609E3}"/>
-              </a:ext>
-            </a:extLst>
-          </p:cNvPr>
-          <p:cNvSpPr>
-            <a:spLocks xmlns:a="http://schemas.openxmlformats.org/drawingml/2006/main" noGrp="1"/>
-          </p:cNvSpPr>
-          <p:nvPr/>
-        </p:nvSpPr>
-        <p:spPr>
-          <a:xfrm xmlns:a="http://schemas.openxmlformats.org/drawingml/2006/main">
-            <a:off x="7905750" y="1514475"/>
-            <a:ext cx="3524250" cy="647700"/>
-          </a:xfrm>
-          <a:prstGeom xmlns:a="http://schemas.openxmlformats.org/drawingml/2006/main" prst="rect">
-            <a:avLst/>
-          </a:prstGeom>
-          <a:noFill xmlns:a="http://schemas.openxmlformats.org/drawingml/2006/main"/>
-          <a:ln xmlns:a="http://schemas.openxmlformats.org/drawingml/2006/main" w="0">
-            <a:noFill/>
-          </a:ln>
-        </p:spPr>
-        <p:txBody>
-          <a:bodyPr xmlns:a="http://schemas.openxmlformats.org/drawingml/2006/main" wrap="square" lIns="0" tIns="0" rIns="0" bIns="0">
-            <a:normAutofit fontScale="100000"/>
-          </a:bodyPr>
-          <a:lstStyle xmlns:a="http://schemas.openxmlformats.org/drawingml/2006/main"/>
-          <a:p xmlns:a="http://schemas.openxmlformats.org/drawingml/2006/main">
-            <a:pPr>
-              <a:defRPr sz="2025" b="1">
-                <a:solidFill>
-                  <a:srgbClr val="173F33"/>
-                </a:solidFill>
-                <a:latin typeface="Arial"/>
-                <a:ea typeface="Arial"/>
-                <a:cs typeface="Arial"/>
-              </a:defRPr>
-            </a:pPr>
-            <a:r>
-              <a:rPr sz="2025" b="1">
-                <a:solidFill>
-                  <a:srgbClr val="173F33"/>
-                </a:solidFill>
-                <a:latin typeface="Arial"/>
-                <a:ea typeface="Arial"/>
-                <a:cs typeface="Arial"/>
-              </a:rPr>
-              <a:t>One Chennai hospital improved documentation.</a:t>
-            </a:r>
-          </a:p>
-        </p:txBody>
-      </p:sp>
-      <p:sp>
-        <p:nvSpPr>
-          <p:cNvPr id="36" name="QI finding">
-            <a:extLst xmlns:a="http://schemas.openxmlformats.org/drawingml/2006/main">
-              <a:ext uri="{FF2B5EF4-FFF2-40B4-BE49-F238E27FC236}">
-                <a16:creationId xmlns:a16="http://schemas.microsoft.com/office/drawing/2014/main" id="{E71F5A69-FC3A-48C3-BCBC-CB252287AB3F}"/>
-              </a:ext>
-            </a:extLst>
-          </p:cNvPr>
-          <p:cNvSpPr>
-            <a:spLocks xmlns:a="http://schemas.openxmlformats.org/drawingml/2006/main" noGrp="1"/>
-          </p:cNvSpPr>
-          <p:nvPr/>
-        </p:nvSpPr>
-        <p:spPr>
-          <a:xfrm xmlns:a="http://schemas.openxmlformats.org/drawingml/2006/main">
-            <a:off x="7372350" y="4857750"/>
-            <a:ext cx="4057650" cy="981075"/>
-          </a:xfrm>
-          <a:prstGeom xmlns:a="http://schemas.openxmlformats.org/drawingml/2006/main" prst="rect">
-            <a:avLst/>
-          </a:prstGeom>
-          <a:noFill xmlns:a="http://schemas.openxmlformats.org/drawingml/2006/main"/>
-          <a:ln xmlns:a="http://schemas.openxmlformats.org/drawingml/2006/main" w="0">
-            <a:noFill/>
-          </a:ln>
-        </p:spPr>
-        <p:txBody>
-          <a:bodyPr xmlns:a="http://schemas.openxmlformats.org/drawingml/2006/main" wrap="square" lIns="0" tIns="0" rIns="0" bIns="0">
-            <a:normAutofit fontScale="100000"/>
-          </a:bodyPr>
-          <a:lstStyle xmlns:a="http://schemas.openxmlformats.org/drawingml/2006/main"/>
-          <a:p xmlns:a="http://schemas.openxmlformats.org/drawingml/2006/main">
-            <a:pPr>
-              <a:defRPr sz="1725" b="0">
-                <a:solidFill>
-                  <a:srgbClr val="173F33"/>
-                </a:solidFill>
-                <a:latin typeface="Arial"/>
-                <a:ea typeface="Arial"/>
-                <a:cs typeface="Arial"/>
-              </a:defRPr>
-            </a:pPr>
-            <a:r>
-              <a:rPr sz="1725" b="0">
-                <a:solidFill>
-                  <a:srgbClr val="173F33"/>
-                </a:solidFill>
-                <a:latin typeface="Arial"/>
-                <a:ea typeface="Arial"/>
-                <a:cs typeface="Arial"/>
-              </a:rPr>
-              <a:t>A standard process helped staff write down care discussions for 24 of 26 eligible patients.</a:t>
-            </a:r>
-          </a:p>
-        </p:txBody>
-      </p:sp>
-      <p:sp>
-        <p:nvSpPr>
-          <p:cNvPr id="37" name="QI scope">
-            <a:extLst xmlns:a="http://schemas.openxmlformats.org/drawingml/2006/main">
-              <a:ext uri="{FF2B5EF4-FFF2-40B4-BE49-F238E27FC236}">
-                <a16:creationId xmlns:a16="http://schemas.microsoft.com/office/drawing/2014/main" id="{93D39431-A01C-4349-8221-3A0CF1CD05D3}"/>
-              </a:ext>
-            </a:extLst>
-          </p:cNvPr>
-          <p:cNvSpPr>
-            <a:spLocks xmlns:a="http://schemas.openxmlformats.org/drawingml/2006/main" noGrp="1"/>
-          </p:cNvSpPr>
-          <p:nvPr/>
-        </p:nvSpPr>
-        <p:spPr>
-          <a:xfrm xmlns:a="http://schemas.openxmlformats.org/drawingml/2006/main">
-            <a:off x="7372350" y="5819775"/>
-            <a:ext cx="4057650" cy="247650"/>
-          </a:xfrm>
-          <a:prstGeom xmlns:a="http://schemas.openxmlformats.org/drawingml/2006/main" prst="rect">
-            <a:avLst/>
-          </a:prstGeom>
-          <a:noFill xmlns:a="http://schemas.openxmlformats.org/drawingml/2006/main"/>
-          <a:ln xmlns:a="http://schemas.openxmlformats.org/drawingml/2006/main" w="0">
-            <a:noFill/>
-          </a:ln>
-        </p:spPr>
-        <p:txBody>
-          <a:bodyPr xmlns:a="http://schemas.openxmlformats.org/drawingml/2006/main" wrap="square" lIns="0" tIns="0" rIns="0" bIns="0">
-            <a:normAutofit fontScale="100000"/>
-          </a:bodyPr>
-          <a:lstStyle xmlns:a="http://schemas.openxmlformats.org/drawingml/2006/main"/>
-          <a:p xmlns:a="http://schemas.openxmlformats.org/drawingml/2006/main">
-            <a:pPr>
-              <a:defRPr sz="1238" b="0">
-                <a:solidFill>
-                  <a:srgbClr val="53655C"/>
-                </a:solidFill>
-                <a:latin typeface="Arial"/>
-                <a:ea typeface="Arial"/>
-                <a:cs typeface="Arial"/>
-              </a:defRPr>
-            </a:pPr>
-            <a:r>
-              <a:rPr sz="1238" b="0">
-                <a:solidFill>
-                  <a:srgbClr val="53655C"/>
-                </a:solidFill>
-                <a:latin typeface="Arial"/>
-                <a:ea typeface="Arial"/>
-                <a:cs typeface="Arial"/>
-              </a:rPr>
-              <a:t>Advanced pancreatic / colorectal cancer.</a:t>
-            </a:r>
-          </a:p>
-        </p:txBody>
-      </p:sp>
-      <p:sp>
-        <p:nvSpPr>
-          <p:cNvPr id="38" name="QI source">
-            <a:extLst xmlns:a="http://schemas.openxmlformats.org/drawingml/2006/main">
-              <a:ext uri="{FF2B5EF4-FFF2-40B4-BE49-F238E27FC236}">
-                <a16:creationId xmlns:a16="http://schemas.microsoft.com/office/drawing/2014/main" id="{C23E94AB-CFED-4A30-B468-1C1DA1A42A56}"/>
-              </a:ext>
-            </a:extLst>
-          </p:cNvPr>
-          <p:cNvSpPr>
-            <a:spLocks xmlns:a="http://schemas.openxmlformats.org/drawingml/2006/main" noGrp="1"/>
-          </p:cNvSpPr>
-          <p:nvPr/>
-        </p:nvSpPr>
-        <p:spPr>
-          <a:xfrm xmlns:a="http://schemas.openxmlformats.org/drawingml/2006/main">
-            <a:off x="7372350" y="6067425"/>
-            <a:ext cx="4057650" cy="238125"/>
-          </a:xfrm>
-          <a:prstGeom xmlns:a="http://schemas.openxmlformats.org/drawingml/2006/main" prst="rect">
-            <a:avLst/>
-          </a:prstGeom>
-          <a:noFill xmlns:a="http://schemas.openxmlformats.org/drawingml/2006/main"/>
-          <a:ln xmlns:a="http://schemas.openxmlformats.org/drawingml/2006/main" w="0">
-            <a:noFill/>
-          </a:ln>
-        </p:spPr>
-        <p:txBody>
-          <a:bodyPr xmlns:a="http://schemas.openxmlformats.org/drawingml/2006/main" wrap="square" lIns="0" tIns="0" rIns="0" bIns="0">
-            <a:normAutofit fontScale="100000"/>
-          </a:bodyPr>
-          <a:lstStyle xmlns:a="http://schemas.openxmlformats.org/drawingml/2006/main"/>
-          <a:p xmlns:a="http://schemas.openxmlformats.org/drawingml/2006/main">
-            <a:pPr>
-              <a:defRPr sz="1238" b="0">
-                <a:solidFill>
-                  <a:srgbClr val="145AC6"/>
-                </a:solidFill>
-                <a:latin typeface="Arial"/>
-                <a:ea typeface="Arial"/>
-                <a:cs typeface="Arial"/>
-              </a:defRPr>
-            </a:pPr>
-            <a:r>
-              <a:rPr sz="1238" b="0" u="sng">
-                <a:solidFill>
-                  <a:srgbClr val="145AC6"/>
-                </a:solidFill>
-                <a:latin typeface="Arial"/>
-                <a:ea typeface="Arial"/>
-                <a:cs typeface="Arial"/>
-                <a:hlinkClick xmlns:r="http://schemas.openxmlformats.org/officeDocument/2006/relationships" r:id="R444c0cc6359745f8"/>
-              </a:rPr>
-              <a:t>Thangasamy et al., 2025</a:t>
-            </a:r>
-          </a:p>
-        </p:txBody>
-      </p:sp>
-      <p:sp>
-        <p:nvSpPr>
-          <p:cNvPr id="39" name="Evidence boundary">
-            <a:extLst xmlns:a="http://schemas.openxmlformats.org/drawingml/2006/main">
-              <a:ext uri="{FF2B5EF4-FFF2-40B4-BE49-F238E27FC236}">
-                <a16:creationId xmlns:a16="http://schemas.microsoft.com/office/drawing/2014/main" id="{6ED18324-044A-463B-BCFF-492C9AFFDEFF}"/>
-              </a:ext>
-            </a:extLst>
-          </p:cNvPr>
-          <p:cNvSpPr>
-            <a:spLocks xmlns:a="http://schemas.openxmlformats.org/drawingml/2006/main" noGrp="1"/>
-          </p:cNvSpPr>
-          <p:nvPr/>
-        </p:nvSpPr>
-        <p:spPr>
-          <a:xfrm xmlns:a="http://schemas.openxmlformats.org/drawingml/2006/main">
-            <a:off x="533400" y="6515100"/>
-            <a:ext cx="11125200" cy="228600"/>
-          </a:xfrm>
-          <a:prstGeom xmlns:a="http://schemas.openxmlformats.org/drawingml/2006/main" prst="rect">
-            <a:avLst/>
-          </a:prstGeom>
-          <a:noFill xmlns:a="http://schemas.openxmlformats.org/drawingml/2006/main"/>
-          <a:ln xmlns:a="http://schemas.openxmlformats.org/drawingml/2006/main" w="0">
-            <a:noFill/>
-          </a:ln>
-        </p:spPr>
-        <p:txBody>
-          <a:bodyPr xmlns:a="http://schemas.openxmlformats.org/drawingml/2006/main" wrap="square" lIns="0" tIns="0" rIns="0" bIns="0">
-            <a:normAutofit fontScale="100000"/>
-          </a:bodyPr>
-          <a:lstStyle xmlns:a="http://schemas.openxmlformats.org/drawingml/2006/main"/>
-          <a:p xmlns:a="http://schemas.openxmlformats.org/drawingml/2006/main">
-            <a:pPr>
-              <a:defRPr sz="1200" b="0">
-                <a:solidFill>
-                  <a:srgbClr val="53655C"/>
-                </a:solidFill>
-                <a:latin typeface="Arial"/>
-                <a:ea typeface="Arial"/>
-                <a:cs typeface="Arial"/>
-              </a:defRPr>
-            </a:pPr>
-            <a:r>
-              <a:rPr sz="1200" b="0">
-                <a:solidFill>
-                  <a:srgbClr val="53655C"/>
-                </a:solidFill>
-                <a:latin typeface="Arial"/>
-                <a:ea typeface="Arial"/>
-                <a:cs typeface="Arial"/>
-              </a:rPr>
-              <a:t>Each study looked at a different group of people. These figures are not results from Saathi.</a:t>
-            </a:r>
-          </a:p>
-        </p:txBody>
-      </p:sp>
-    </p:spTree>
-    <p:extLst>
-      <p:ext uri="{BB962C8B-B14F-4D97-AF65-F5344CB8AC3E}">
-        <p14:creationId xmlns:p14="http://schemas.microsoft.com/office/powerpoint/2010/main" val="1299123762"/>
       </p:ext>
     </p:extLst>
   </p:cSld>
@@ -5640,7 +4895,7 @@
           <p:cNvPr id="14" name="Slide title">
             <a:extLst xmlns:a="http://schemas.openxmlformats.org/drawingml/2006/main">
               <a:ext uri="{FF2B5EF4-FFF2-40B4-BE49-F238E27FC236}">
-                <a16:creationId xmlns:a16="http://schemas.microsoft.com/office/drawing/2014/main" id="{7A2E1FB1-0E42-4360-ACD8-FB011EEFE95F}"/>
+                <a16:creationId xmlns:a16="http://schemas.microsoft.com/office/drawing/2014/main" id="{1FCC484E-44B7-49E9-B245-4A47DAE5745A}"/>
               </a:ext>
             </a:extLst>
           </p:cNvPr>
@@ -5697,7 +4952,7 @@
           <p:cNvPr id="2" name="Human review">
             <a:extLst xmlns:a="http://schemas.openxmlformats.org/drawingml/2006/main">
               <a:ext uri="{FF2B5EF4-FFF2-40B4-BE49-F238E27FC236}">
-                <a16:creationId xmlns:a16="http://schemas.microsoft.com/office/drawing/2014/main" id="{984C3DBF-75F1-4D9A-9A72-C3DD39288085}"/>
+                <a16:creationId xmlns:a16="http://schemas.microsoft.com/office/drawing/2014/main" id="{A5AB5DCF-511F-40DC-9497-E0BF889D0C07}"/>
               </a:ext>
             </a:extLst>
           </p:cNvPr>
@@ -5758,13 +5013,13 @@
           <p:nvPr/>
         </p:nvPicPr>
         <p:blipFill>
-          <a:blip xmlns:r="http://schemas.openxmlformats.org/officeDocument/2006/relationships" xmlns:a="http://schemas.openxmlformats.org/drawingml/2006/main" r:embed="R42288b82276e45d2"/>
+          <a:blip xmlns:r="http://schemas.openxmlformats.org/officeDocument/2006/relationships" xmlns:a="http://schemas.openxmlformats.org/drawingml/2006/main" r:embed="Rd7cb07e2e45a4d16"/>
           <a:stretch xmlns:a="http://schemas.openxmlformats.org/drawingml/2006/main"/>
         </p:blipFill>
         <p:spPr>
           <a:xfrm xmlns:a="http://schemas.openxmlformats.org/drawingml/2006/main">
-            <a:off x="400050" y="1847953"/>
-            <a:ext cx="8286750" cy="3933618"/>
+            <a:off x="400050" y="1876325"/>
+            <a:ext cx="8286750" cy="3876875"/>
           </a:xfrm>
           <a:prstGeom xmlns:a="http://schemas.openxmlformats.org/drawingml/2006/main" prst="rect">
             <a:avLst/>
@@ -5776,7 +5031,7 @@
           <p:cNvPr id="4" name="Source traceability">
             <a:extLst xmlns:a="http://schemas.openxmlformats.org/drawingml/2006/main">
               <a:ext uri="{FF2B5EF4-FFF2-40B4-BE49-F238E27FC236}">
-                <a16:creationId xmlns:a16="http://schemas.microsoft.com/office/drawing/2014/main" id="{F08467FF-51A5-4489-8B8F-45BDD55A1746}"/>
+                <a16:creationId xmlns:a16="http://schemas.microsoft.com/office/drawing/2014/main" id="{89F9170C-E389-4841-AA19-3944A31A9132}"/>
               </a:ext>
             </a:extLst>
           </p:cNvPr>
@@ -5833,7 +5088,7 @@
           <p:cNvPr id="5" name="Proposed voice provider">
             <a:extLst xmlns:a="http://schemas.openxmlformats.org/drawingml/2006/main">
               <a:ext uri="{FF2B5EF4-FFF2-40B4-BE49-F238E27FC236}">
-                <a16:creationId xmlns:a16="http://schemas.microsoft.com/office/drawing/2014/main" id="{7A759568-FC1C-4D90-B802-CE2B6514E9F4}"/>
+                <a16:creationId xmlns:a16="http://schemas.microsoft.com/office/drawing/2014/main" id="{48DD65DB-F360-4C5B-A3C6-C599B260EAC1}"/>
               </a:ext>
             </a:extLst>
           </p:cNvPr>
@@ -5879,7 +5134,7 @@
                 <a:latin typeface="Arial"/>
                 <a:ea typeface="Arial"/>
                 <a:cs typeface="Arial"/>
-                <a:hlinkClick xmlns:r="http://schemas.openxmlformats.org/officeDocument/2006/relationships" r:id="R2ee9c6937c7046b1"/>
+                <a:hlinkClick xmlns:r="http://schemas.openxmlformats.org/officeDocument/2006/relationships" r:id="Rd1cfbf9e32694dc1"/>
               </a:rPr>
               <a:t>Planned with Sarvam AI: Indian-language speech, translation and read-aloud.</a:t>
             </a:r>
@@ -5891,7 +5146,7 @@
           <p:cNvPr id="6" name="AI step 1">
             <a:extLst xmlns:a="http://schemas.openxmlformats.org/drawingml/2006/main">
               <a:ext uri="{FF2B5EF4-FFF2-40B4-BE49-F238E27FC236}">
-                <a16:creationId xmlns:a16="http://schemas.microsoft.com/office/drawing/2014/main" id="{8825B2B9-ABB2-4B77-94C8-354A81DE411C}"/>
+                <a16:creationId xmlns:a16="http://schemas.microsoft.com/office/drawing/2014/main" id="{A99F3678-0EEE-41FD-8AA7-9665B3F2F1BA}"/>
               </a:ext>
             </a:extLst>
           </p:cNvPr>
@@ -5948,7 +5203,7 @@
           <p:cNvPr id="7" name="AI step 1 detail">
             <a:extLst xmlns:a="http://schemas.openxmlformats.org/drawingml/2006/main">
               <a:ext uri="{FF2B5EF4-FFF2-40B4-BE49-F238E27FC236}">
-                <a16:creationId xmlns:a16="http://schemas.microsoft.com/office/drawing/2014/main" id="{5FE7B7F3-F5AA-49F3-8522-D6007326250D}"/>
+                <a16:creationId xmlns:a16="http://schemas.microsoft.com/office/drawing/2014/main" id="{33B8F5D4-3801-43D1-896B-9A869CFAEC85}"/>
               </a:ext>
             </a:extLst>
           </p:cNvPr>
@@ -6005,7 +5260,7 @@
           <p:cNvPr id="8" name="AI step 2">
             <a:extLst xmlns:a="http://schemas.openxmlformats.org/drawingml/2006/main">
               <a:ext uri="{FF2B5EF4-FFF2-40B4-BE49-F238E27FC236}">
-                <a16:creationId xmlns:a16="http://schemas.microsoft.com/office/drawing/2014/main" id="{0582A7B6-AE3E-492A-A4B2-B8C622484F40}"/>
+                <a16:creationId xmlns:a16="http://schemas.microsoft.com/office/drawing/2014/main" id="{32664CD7-8313-4727-8570-08AD8D68BE04}"/>
               </a:ext>
             </a:extLst>
           </p:cNvPr>
@@ -6062,7 +5317,7 @@
           <p:cNvPr id="9" name="AI step 2 detail">
             <a:extLst xmlns:a="http://schemas.openxmlformats.org/drawingml/2006/main">
               <a:ext uri="{FF2B5EF4-FFF2-40B4-BE49-F238E27FC236}">
-                <a16:creationId xmlns:a16="http://schemas.microsoft.com/office/drawing/2014/main" id="{B61D7E8E-4D5A-4C0E-8FE3-498F0C4082A6}"/>
+                <a16:creationId xmlns:a16="http://schemas.microsoft.com/office/drawing/2014/main" id="{728079FA-561F-4FB4-9EAB-6DC4DCA2E31A}"/>
               </a:ext>
             </a:extLst>
           </p:cNvPr>
@@ -6119,7 +5374,7 @@
           <p:cNvPr id="10" name="AI step 3">
             <a:extLst xmlns:a="http://schemas.openxmlformats.org/drawingml/2006/main">
               <a:ext uri="{FF2B5EF4-FFF2-40B4-BE49-F238E27FC236}">
-                <a16:creationId xmlns:a16="http://schemas.microsoft.com/office/drawing/2014/main" id="{B7916987-8A88-42A7-A4FD-5DB0AE154E94}"/>
+                <a16:creationId xmlns:a16="http://schemas.microsoft.com/office/drawing/2014/main" id="{70793CDE-C33C-4CBA-AA9C-0232C3A5D4F4}"/>
               </a:ext>
             </a:extLst>
           </p:cNvPr>
@@ -6176,7 +5431,7 @@
           <p:cNvPr id="11" name="AI step 3 detail">
             <a:extLst xmlns:a="http://schemas.openxmlformats.org/drawingml/2006/main">
               <a:ext uri="{FF2B5EF4-FFF2-40B4-BE49-F238E27FC236}">
-                <a16:creationId xmlns:a16="http://schemas.microsoft.com/office/drawing/2014/main" id="{BA743D06-0EDC-4B2E-987C-0FDE1068CC79}"/>
+                <a16:creationId xmlns:a16="http://schemas.microsoft.com/office/drawing/2014/main" id="{140DDFD4-FF5E-41BD-945A-25C136C80349}"/>
               </a:ext>
             </a:extLst>
           </p:cNvPr>
@@ -6233,7 +5488,7 @@
           <p:cNvPr id="12" name="AI step 4">
             <a:extLst xmlns:a="http://schemas.openxmlformats.org/drawingml/2006/main">
               <a:ext uri="{FF2B5EF4-FFF2-40B4-BE49-F238E27FC236}">
-                <a16:creationId xmlns:a16="http://schemas.microsoft.com/office/drawing/2014/main" id="{7826E4A5-4B60-46C5-9D34-AA009BD8001A}"/>
+                <a16:creationId xmlns:a16="http://schemas.microsoft.com/office/drawing/2014/main" id="{CA2DE991-FF2E-48AA-ABE4-809848F68A8E}"/>
               </a:ext>
             </a:extLst>
           </p:cNvPr>
@@ -6290,7 +5545,7 @@
           <p:cNvPr id="13" name="AI step 4 detail">
             <a:extLst xmlns:a="http://schemas.openxmlformats.org/drawingml/2006/main">
               <a:ext uri="{FF2B5EF4-FFF2-40B4-BE49-F238E27FC236}">
-                <a16:creationId xmlns:a16="http://schemas.microsoft.com/office/drawing/2014/main" id="{28B90533-8EC2-4453-9390-E202F350E4AB}"/>
+                <a16:creationId xmlns:a16="http://schemas.microsoft.com/office/drawing/2014/main" id="{0F2AD767-667C-4E61-8303-021BBC6D609B}"/>
               </a:ext>
             </a:extLst>
           </p:cNvPr>
@@ -6353,6 +5608,1282 @@
 </file>
 
 <file path=ppt/slides/slide5.xml><?xml version="1.0" encoding="utf-8"?>
+<p:sld xmlns:p="http://schemas.openxmlformats.org/presentationml/2006/main">
+  <p:cSld>
+    <p:bg>
+      <p:bgPr>
+        <a:solidFill xmlns:a="http://schemas.openxmlformats.org/drawingml/2006/main">
+          <a:srgbClr val="CAD8ED"/>
+        </a:solidFill>
+      </p:bgPr>
+    </p:bg>
+    <p:spTree>
+      <p:nvGrpSpPr>
+        <p:cNvPr id="1" name=""/>
+        <p:cNvGrpSpPr/>
+        <p:nvPr/>
+      </p:nvGrpSpPr>
+      <p:grpSpPr>
+        <a:xfrm xmlns:a="http://schemas.openxmlformats.org/drawingml/2006/main"/>
+      </p:grpSpPr>
+      <p:graphicFrame>
+        <p:nvGraphicFramePr>
+          <p:cNvPr id="40" name="Chart"/>
+          <p:cNvGraphicFramePr/>
+          <p:nvPr/>
+        </p:nvGraphicFramePr>
+        <p:xfrm>
+          <a:off xmlns:a="http://schemas.openxmlformats.org/drawingml/2006/main" x="7372350" y="2181225"/>
+          <a:ext xmlns:a="http://schemas.openxmlformats.org/drawingml/2006/main" cx="4057650" cy="2533650"/>
+        </p:xfrm>
+        <a:graphic xmlns:a="http://schemas.openxmlformats.org/drawingml/2006/main">
+          <a:graphicData uri="http://schemas.openxmlformats.org/drawingml/2006/chart">
+            <c:chart xmlns:r="http://schemas.openxmlformats.org/officeDocument/2006/relationships" xmlns:c="http://schemas.openxmlformats.org/drawingml/2006/chart" r:id="R9db884fda8714dd3"/>
+          </a:graphicData>
+        </a:graphic>
+      </p:graphicFrame>
+      <p:sp>
+        <p:nvSpPr>
+          <p:cNvPr id="15" name="Slide title">
+            <a:extLst xmlns:a="http://schemas.openxmlformats.org/drawingml/2006/main">
+              <a:ext uri="{FF2B5EF4-FFF2-40B4-BE49-F238E27FC236}">
+                <a16:creationId xmlns:a16="http://schemas.microsoft.com/office/drawing/2014/main" id="{E53A44B9-FF4F-45B3-894B-2B05822DABFD}"/>
+              </a:ext>
+            </a:extLst>
+          </p:cNvPr>
+          <p:cNvSpPr>
+            <a:spLocks xmlns:a="http://schemas.openxmlformats.org/drawingml/2006/main" noGrp="1"/>
+          </p:cNvSpPr>
+          <p:nvPr/>
+        </p:nvSpPr>
+        <p:spPr>
+          <a:xfrm xmlns:a="http://schemas.openxmlformats.org/drawingml/2006/main">
+            <a:off x="533400" y="361950"/>
+            <a:ext cx="11125200" cy="638175"/>
+          </a:xfrm>
+          <a:prstGeom xmlns:a="http://schemas.openxmlformats.org/drawingml/2006/main" prst="rect">
+            <a:avLst/>
+          </a:prstGeom>
+          <a:noFill xmlns:a="http://schemas.openxmlformats.org/drawingml/2006/main"/>
+          <a:ln xmlns:a="http://schemas.openxmlformats.org/drawingml/2006/main" w="0">
+            <a:noFill/>
+          </a:ln>
+        </p:spPr>
+        <p:txBody>
+          <a:bodyPr xmlns:a="http://schemas.openxmlformats.org/drawingml/2006/main" wrap="square" lIns="0" tIns="0" rIns="0" bIns="0">
+            <a:normAutofit fontScale="100000"/>
+          </a:bodyPr>
+          <a:lstStyle xmlns:a="http://schemas.openxmlformats.org/drawingml/2006/main"/>
+          <a:p xmlns:a="http://schemas.openxmlformats.org/drawingml/2006/main">
+            <a:pPr>
+              <a:defRPr sz="3075" b="1">
+                <a:solidFill>
+                  <a:srgbClr val="173F33"/>
+                </a:solidFill>
+                <a:latin typeface="Arial"/>
+                <a:ea typeface="Arial"/>
+                <a:cs typeface="Arial"/>
+              </a:defRPr>
+            </a:pPr>
+            <a:r>
+              <a:rPr sz="3075" b="1">
+                <a:solidFill>
+                  <a:srgbClr val="173F33"/>
+                </a:solidFill>
+                <a:latin typeface="Arial"/>
+                <a:ea typeface="Arial"/>
+                <a:cs typeface="Arial"/>
+              </a:rPr>
+              <a:t>Why families need support between visits</a:t>
+            </a:r>
+          </a:p>
+        </p:txBody>
+      </p:sp>
+      <p:sp>
+        <p:nvSpPr>
+          <p:cNvPr id="16" name="Chennai evidence heading">
+            <a:extLst xmlns:a="http://schemas.openxmlformats.org/drawingml/2006/main">
+              <a:ext uri="{FF2B5EF4-FFF2-40B4-BE49-F238E27FC236}">
+                <a16:creationId xmlns:a16="http://schemas.microsoft.com/office/drawing/2014/main" id="{95CBE83E-B354-4E74-B40B-01E860778B09}"/>
+              </a:ext>
+            </a:extLst>
+          </p:cNvPr>
+          <p:cNvSpPr>
+            <a:spLocks xmlns:a="http://schemas.openxmlformats.org/drawingml/2006/main" noGrp="1"/>
+          </p:cNvSpPr>
+          <p:nvPr/>
+        </p:nvSpPr>
+        <p:spPr>
+          <a:xfrm xmlns:a="http://schemas.openxmlformats.org/drawingml/2006/main">
+            <a:off x="7143750" y="1333500"/>
+            <a:ext cx="4514850" cy="828675"/>
+          </a:xfrm>
+          <a:prstGeom xmlns:a="http://schemas.openxmlformats.org/drawingml/2006/main" prst="rect">
+            <a:avLst/>
+          </a:prstGeom>
+          <a:solidFill xmlns:a="http://schemas.openxmlformats.org/drawingml/2006/main">
+            <a:srgbClr val="F3F6FA"/>
+          </a:solidFill>
+          <a:ln xmlns:a="http://schemas.openxmlformats.org/drawingml/2006/main" w="0">
+            <a:noFill/>
+          </a:ln>
+        </p:spPr>
+      </p:sp>
+      <p:sp>
+        <p:nvSpPr>
+          <p:cNvPr id="17" name="Chennai evidence explanation">
+            <a:extLst xmlns:a="http://schemas.openxmlformats.org/drawingml/2006/main">
+              <a:ext uri="{FF2B5EF4-FFF2-40B4-BE49-F238E27FC236}">
+                <a16:creationId xmlns:a16="http://schemas.microsoft.com/office/drawing/2014/main" id="{97F6FCA3-C29E-4EE3-9771-04E36CEA2FC3}"/>
+              </a:ext>
+            </a:extLst>
+          </p:cNvPr>
+          <p:cNvSpPr>
+            <a:spLocks xmlns:a="http://schemas.openxmlformats.org/drawingml/2006/main" noGrp="1"/>
+          </p:cNvSpPr>
+          <p:nvPr/>
+        </p:nvSpPr>
+        <p:spPr>
+          <a:xfrm xmlns:a="http://schemas.openxmlformats.org/drawingml/2006/main">
+            <a:off x="7143750" y="4791075"/>
+            <a:ext cx="4514850" cy="1533525"/>
+          </a:xfrm>
+          <a:prstGeom xmlns:a="http://schemas.openxmlformats.org/drawingml/2006/main" prst="rect">
+            <a:avLst/>
+          </a:prstGeom>
+          <a:solidFill xmlns:a="http://schemas.openxmlformats.org/drawingml/2006/main">
+            <a:srgbClr val="F3F6FA"/>
+          </a:solidFill>
+          <a:ln xmlns:a="http://schemas.openxmlformats.org/drawingml/2006/main" w="0">
+            <a:noFill/>
+          </a:ln>
+        </p:spPr>
+      </p:sp>
+      <p:pic>
+        <p:nvPicPr>
+          <p:cNvPr id="44" name=""/>
+          <p:cNvPicPr>
+            <a:picLocks xmlns:a="http://schemas.openxmlformats.org/drawingml/2006/main" noChangeAspect="1"/>
+          </p:cNvPicPr>
+          <p:nvPr/>
+        </p:nvPicPr>
+        <p:blipFill>
+          <a:blip xmlns:r="http://schemas.openxmlformats.org/officeDocument/2006/relationships" xmlns:a="http://schemas.openxmlformats.org/drawingml/2006/main" r:embed="Raa289c8bc0c948f3">
+            <a:extLst>
+              <a:ext uri="{96DAC541-7B7A-43D3-8B79-37D633B846F1}">
+                <asvg:svgBlip xmlns:asvg="http://schemas.microsoft.com/office/drawing/2016/SVG/main" r:embed="R55ad117f387d40d1"/>
+              </a:ext>
+            </a:extLst>
+          </a:blip>
+          <a:stretch xmlns:a="http://schemas.openxmlformats.org/drawingml/2006/main"/>
+        </p:blipFill>
+        <p:spPr>
+          <a:xfrm xmlns:a="http://schemas.openxmlformats.org/drawingml/2006/main">
+            <a:off x="533400" y="1543050"/>
+            <a:ext cx="400050" cy="400050"/>
+          </a:xfrm>
+          <a:prstGeom xmlns:a="http://schemas.openxmlformats.org/drawingml/2006/main" prst="rect">
+            <a:avLst/>
+          </a:prstGeom>
+        </p:spPr>
+      </p:pic>
+      <p:sp>
+        <p:nvSpPr>
+          <p:cNvPr id="19" name="Evidence 15.6 lakh">
+            <a:extLst xmlns:a="http://schemas.openxmlformats.org/drawingml/2006/main">
+              <a:ext uri="{FF2B5EF4-FFF2-40B4-BE49-F238E27FC236}">
+                <a16:creationId xmlns:a16="http://schemas.microsoft.com/office/drawing/2014/main" id="{225CD085-4E4E-4E7A-9E05-558D123B4345}"/>
+              </a:ext>
+            </a:extLst>
+          </p:cNvPr>
+          <p:cNvSpPr>
+            <a:spLocks xmlns:a="http://schemas.openxmlformats.org/drawingml/2006/main" noGrp="1"/>
+          </p:cNvSpPr>
+          <p:nvPr/>
+        </p:nvSpPr>
+        <p:spPr>
+          <a:xfrm xmlns:a="http://schemas.openxmlformats.org/drawingml/2006/main">
+            <a:off x="1057275" y="1447800"/>
+            <a:ext cx="2390775" cy="638175"/>
+          </a:xfrm>
+          <a:prstGeom xmlns:a="http://schemas.openxmlformats.org/drawingml/2006/main" prst="rect">
+            <a:avLst/>
+          </a:prstGeom>
+          <a:noFill xmlns:a="http://schemas.openxmlformats.org/drawingml/2006/main"/>
+          <a:ln xmlns:a="http://schemas.openxmlformats.org/drawingml/2006/main" w="0">
+            <a:noFill/>
+          </a:ln>
+        </p:spPr>
+        <p:txBody>
+          <a:bodyPr xmlns:a="http://schemas.openxmlformats.org/drawingml/2006/main" wrap="square" lIns="0" tIns="0" rIns="0" bIns="0">
+            <a:normAutofit fontScale="100000"/>
+          </a:bodyPr>
+          <a:lstStyle xmlns:a="http://schemas.openxmlformats.org/drawingml/2006/main"/>
+          <a:p xmlns:a="http://schemas.openxmlformats.org/drawingml/2006/main">
+            <a:pPr>
+              <a:defRPr sz="3675" b="1">
+                <a:solidFill>
+                  <a:srgbClr val="B75E43"/>
+                </a:solidFill>
+                <a:latin typeface="Arial"/>
+                <a:ea typeface="Arial"/>
+                <a:cs typeface="Arial"/>
+              </a:defRPr>
+            </a:pPr>
+            <a:r>
+              <a:rPr sz="3675" b="1">
+                <a:solidFill>
+                  <a:srgbClr val="B75E43"/>
+                </a:solidFill>
+                <a:latin typeface="Arial"/>
+                <a:ea typeface="Arial"/>
+                <a:cs typeface="Arial"/>
+              </a:rPr>
+              <a:t>15.6 lakh</a:t>
+            </a:r>
+          </a:p>
+        </p:txBody>
+      </p:sp>
+      <p:sp>
+        <p:nvSpPr>
+          <p:cNvPr id="20" name="Evidence 15.6 lakh scope">
+            <a:extLst xmlns:a="http://schemas.openxmlformats.org/drawingml/2006/main">
+              <a:ext uri="{FF2B5EF4-FFF2-40B4-BE49-F238E27FC236}">
+                <a16:creationId xmlns:a16="http://schemas.microsoft.com/office/drawing/2014/main" id="{771A0706-DE8F-400B-95A1-37CC74922440}"/>
+              </a:ext>
+            </a:extLst>
+          </p:cNvPr>
+          <p:cNvSpPr>
+            <a:spLocks xmlns:a="http://schemas.openxmlformats.org/drawingml/2006/main" noGrp="1"/>
+          </p:cNvSpPr>
+          <p:nvPr/>
+        </p:nvSpPr>
+        <p:spPr>
+          <a:xfrm xmlns:a="http://schemas.openxmlformats.org/drawingml/2006/main">
+            <a:off x="533400" y="2238375"/>
+            <a:ext cx="2914650" cy="1162050"/>
+          </a:xfrm>
+          <a:prstGeom xmlns:a="http://schemas.openxmlformats.org/drawingml/2006/main" prst="rect">
+            <a:avLst/>
+          </a:prstGeom>
+          <a:noFill xmlns:a="http://schemas.openxmlformats.org/drawingml/2006/main"/>
+          <a:ln xmlns:a="http://schemas.openxmlformats.org/drawingml/2006/main" w="0">
+            <a:noFill/>
+          </a:ln>
+        </p:spPr>
+        <p:txBody>
+          <a:bodyPr xmlns:a="http://schemas.openxmlformats.org/drawingml/2006/main" wrap="square" lIns="0" tIns="0" rIns="0" bIns="0">
+            <a:normAutofit fontScale="100000"/>
+          </a:bodyPr>
+          <a:lstStyle xmlns:a="http://schemas.openxmlformats.org/drawingml/2006/main"/>
+          <a:p xmlns:a="http://schemas.openxmlformats.org/drawingml/2006/main">
+            <a:pPr>
+              <a:defRPr sz="1575" b="0">
+                <a:solidFill>
+                  <a:srgbClr val="173F33"/>
+                </a:solidFill>
+                <a:latin typeface="Arial"/>
+                <a:ea typeface="Arial"/>
+                <a:cs typeface="Arial"/>
+              </a:defRPr>
+            </a:pPr>
+            <a:r>
+              <a:rPr sz="1575" b="0">
+                <a:solidFill>
+                  <a:srgbClr val="173F33"/>
+                </a:solidFill>
+                <a:latin typeface="Arial"/>
+                <a:ea typeface="Arial"/>
+                <a:cs typeface="Arial"/>
+              </a:rPr>
+              <a:t>Estimated new cancer cases in India in 2024.</a:t>
+            </a:r>
+          </a:p>
+        </p:txBody>
+      </p:sp>
+      <p:sp>
+        <p:nvSpPr>
+          <p:cNvPr id="21" name="Evidence 15.6 lakh source">
+            <a:extLst xmlns:a="http://schemas.openxmlformats.org/drawingml/2006/main">
+              <a:ext uri="{FF2B5EF4-FFF2-40B4-BE49-F238E27FC236}">
+                <a16:creationId xmlns:a16="http://schemas.microsoft.com/office/drawing/2014/main" id="{DA231214-4290-430C-9B17-AA34E63D9F55}"/>
+              </a:ext>
+            </a:extLst>
+          </p:cNvPr>
+          <p:cNvSpPr>
+            <a:spLocks xmlns:a="http://schemas.openxmlformats.org/drawingml/2006/main" noGrp="1"/>
+          </p:cNvSpPr>
+          <p:nvPr/>
+        </p:nvSpPr>
+        <p:spPr>
+          <a:xfrm xmlns:a="http://schemas.openxmlformats.org/drawingml/2006/main">
+            <a:off x="533400" y="3457575"/>
+            <a:ext cx="2914650" cy="371475"/>
+          </a:xfrm>
+          <a:prstGeom xmlns:a="http://schemas.openxmlformats.org/drawingml/2006/main" prst="rect">
+            <a:avLst/>
+          </a:prstGeom>
+          <a:noFill xmlns:a="http://schemas.openxmlformats.org/drawingml/2006/main"/>
+          <a:ln xmlns:a="http://schemas.openxmlformats.org/drawingml/2006/main" w="0">
+            <a:noFill/>
+          </a:ln>
+        </p:spPr>
+        <p:txBody>
+          <a:bodyPr xmlns:a="http://schemas.openxmlformats.org/drawingml/2006/main" wrap="square" lIns="0" tIns="0" rIns="0" bIns="0">
+            <a:normAutofit fontScale="100000"/>
+          </a:bodyPr>
+          <a:lstStyle xmlns:a="http://schemas.openxmlformats.org/drawingml/2006/main"/>
+          <a:p xmlns:a="http://schemas.openxmlformats.org/drawingml/2006/main">
+            <a:pPr>
+              <a:defRPr sz="1163" b="0">
+                <a:solidFill>
+                  <a:srgbClr val="145AC6"/>
+                </a:solidFill>
+                <a:latin typeface="Arial"/>
+                <a:ea typeface="Arial"/>
+                <a:cs typeface="Arial"/>
+              </a:defRPr>
+            </a:pPr>
+            <a:r>
+              <a:rPr sz="1163" b="0" u="sng">
+                <a:solidFill>
+                  <a:srgbClr val="145AC6"/>
+                </a:solidFill>
+                <a:latin typeface="Arial"/>
+                <a:ea typeface="Arial"/>
+                <a:cs typeface="Arial"/>
+                <a:hlinkClick xmlns:r="http://schemas.openxmlformats.org/officeDocument/2006/relationships" r:id="Rf10a3be8b8da40cb"/>
+              </a:rPr>
+              <a:t>IARC, GLOBOCAN 2024</a:t>
+            </a:r>
+          </a:p>
+        </p:txBody>
+      </p:sp>
+      <p:pic>
+        <p:nvPicPr>
+          <p:cNvPr id="48" name=""/>
+          <p:cNvPicPr>
+            <a:picLocks xmlns:a="http://schemas.openxmlformats.org/drawingml/2006/main" noChangeAspect="1"/>
+          </p:cNvPicPr>
+          <p:nvPr/>
+        </p:nvPicPr>
+        <p:blipFill>
+          <a:blip xmlns:r="http://schemas.openxmlformats.org/officeDocument/2006/relationships" xmlns:a="http://schemas.openxmlformats.org/drawingml/2006/main" r:embed="R92533f0eaf384bf4">
+            <a:extLst>
+              <a:ext uri="{96DAC541-7B7A-43D3-8B79-37D633B846F1}">
+                <asvg:svgBlip xmlns:asvg="http://schemas.microsoft.com/office/drawing/2016/SVG/main" r:embed="R5d6423ae344f43eb"/>
+              </a:ext>
+            </a:extLst>
+          </a:blip>
+          <a:stretch xmlns:a="http://schemas.openxmlformats.org/drawingml/2006/main"/>
+        </p:blipFill>
+        <p:spPr>
+          <a:xfrm xmlns:a="http://schemas.openxmlformats.org/drawingml/2006/main">
+            <a:off x="3829050" y="1543050"/>
+            <a:ext cx="400050" cy="400050"/>
+          </a:xfrm>
+          <a:prstGeom xmlns:a="http://schemas.openxmlformats.org/drawingml/2006/main" prst="rect">
+            <a:avLst/>
+          </a:prstGeom>
+        </p:spPr>
+      </p:pic>
+      <p:sp>
+        <p:nvSpPr>
+          <p:cNvPr id="23" name="Evidence 98.39%">
+            <a:extLst xmlns:a="http://schemas.openxmlformats.org/drawingml/2006/main">
+              <a:ext uri="{FF2B5EF4-FFF2-40B4-BE49-F238E27FC236}">
+                <a16:creationId xmlns:a16="http://schemas.microsoft.com/office/drawing/2014/main" id="{D94C939A-0CC8-4B25-95B0-A39015275B21}"/>
+              </a:ext>
+            </a:extLst>
+          </p:cNvPr>
+          <p:cNvSpPr>
+            <a:spLocks xmlns:a="http://schemas.openxmlformats.org/drawingml/2006/main" noGrp="1"/>
+          </p:cNvSpPr>
+          <p:nvPr/>
+        </p:nvSpPr>
+        <p:spPr>
+          <a:xfrm xmlns:a="http://schemas.openxmlformats.org/drawingml/2006/main">
+            <a:off x="4352925" y="1447800"/>
+            <a:ext cx="2390775" cy="638175"/>
+          </a:xfrm>
+          <a:prstGeom xmlns:a="http://schemas.openxmlformats.org/drawingml/2006/main" prst="rect">
+            <a:avLst/>
+          </a:prstGeom>
+          <a:noFill xmlns:a="http://schemas.openxmlformats.org/drawingml/2006/main"/>
+          <a:ln xmlns:a="http://schemas.openxmlformats.org/drawingml/2006/main" w="0">
+            <a:noFill/>
+          </a:ln>
+        </p:spPr>
+        <p:txBody>
+          <a:bodyPr xmlns:a="http://schemas.openxmlformats.org/drawingml/2006/main" wrap="square" lIns="0" tIns="0" rIns="0" bIns="0">
+            <a:normAutofit fontScale="100000"/>
+          </a:bodyPr>
+          <a:lstStyle xmlns:a="http://schemas.openxmlformats.org/drawingml/2006/main"/>
+          <a:p xmlns:a="http://schemas.openxmlformats.org/drawingml/2006/main">
+            <a:pPr>
+              <a:defRPr sz="3675" b="1">
+                <a:solidFill>
+                  <a:srgbClr val="157B68"/>
+                </a:solidFill>
+                <a:latin typeface="Arial"/>
+                <a:ea typeface="Arial"/>
+                <a:cs typeface="Arial"/>
+              </a:defRPr>
+            </a:pPr>
+            <a:r>
+              <a:rPr sz="3675" b="1">
+                <a:solidFill>
+                  <a:srgbClr val="157B68"/>
+                </a:solidFill>
+                <a:latin typeface="Arial"/>
+                <a:ea typeface="Arial"/>
+                <a:cs typeface="Arial"/>
+              </a:rPr>
+              <a:t>98.39%</a:t>
+            </a:r>
+          </a:p>
+        </p:txBody>
+      </p:sp>
+      <p:sp>
+        <p:nvSpPr>
+          <p:cNvPr id="24" name="Evidence 98.39% scope">
+            <a:extLst xmlns:a="http://schemas.openxmlformats.org/drawingml/2006/main">
+              <a:ext uri="{FF2B5EF4-FFF2-40B4-BE49-F238E27FC236}">
+                <a16:creationId xmlns:a16="http://schemas.microsoft.com/office/drawing/2014/main" id="{CF11C7D6-36C2-4718-843B-9AC36B15AC8B}"/>
+              </a:ext>
+            </a:extLst>
+          </p:cNvPr>
+          <p:cNvSpPr>
+            <a:spLocks xmlns:a="http://schemas.openxmlformats.org/drawingml/2006/main" noGrp="1"/>
+          </p:cNvSpPr>
+          <p:nvPr/>
+        </p:nvSpPr>
+        <p:spPr>
+          <a:xfrm xmlns:a="http://schemas.openxmlformats.org/drawingml/2006/main">
+            <a:off x="3829050" y="2238375"/>
+            <a:ext cx="2914650" cy="1162050"/>
+          </a:xfrm>
+          <a:prstGeom xmlns:a="http://schemas.openxmlformats.org/drawingml/2006/main" prst="rect">
+            <a:avLst/>
+          </a:prstGeom>
+          <a:noFill xmlns:a="http://schemas.openxmlformats.org/drawingml/2006/main"/>
+          <a:ln xmlns:a="http://schemas.openxmlformats.org/drawingml/2006/main" w="0">
+            <a:noFill/>
+          </a:ln>
+        </p:spPr>
+        <p:txBody>
+          <a:bodyPr xmlns:a="http://schemas.openxmlformats.org/drawingml/2006/main" wrap="square" lIns="0" tIns="0" rIns="0" bIns="0">
+            <a:normAutofit fontScale="100000"/>
+          </a:bodyPr>
+          <a:lstStyle xmlns:a="http://schemas.openxmlformats.org/drawingml/2006/main"/>
+          <a:p xmlns:a="http://schemas.openxmlformats.org/drawingml/2006/main">
+            <a:pPr>
+              <a:defRPr sz="1575" b="0">
+                <a:solidFill>
+                  <a:srgbClr val="173F33"/>
+                </a:solidFill>
+                <a:latin typeface="Arial"/>
+                <a:ea typeface="Arial"/>
+                <a:cs typeface="Arial"/>
+              </a:defRPr>
+            </a:pPr>
+            <a:r>
+              <a:rPr sz="1575" b="0">
+                <a:solidFill>
+                  <a:srgbClr val="173F33"/>
+                </a:solidFill>
+                <a:latin typeface="Arial"/>
+                <a:ea typeface="Arial"/>
+                <a:cs typeface="Arial"/>
+              </a:rPr>
+              <a:t>Estimated unmet palliative-care need among people whose cancer had spread, across 10 cancer types.</a:t>
+            </a:r>
+          </a:p>
+        </p:txBody>
+      </p:sp>
+      <p:sp>
+        <p:nvSpPr>
+          <p:cNvPr id="25" name="Evidence 98.39% source">
+            <a:extLst xmlns:a="http://schemas.openxmlformats.org/drawingml/2006/main">
+              <a:ext uri="{FF2B5EF4-FFF2-40B4-BE49-F238E27FC236}">
+                <a16:creationId xmlns:a16="http://schemas.microsoft.com/office/drawing/2014/main" id="{CF9A6192-734A-4D2C-B82A-DE31F58B0A76}"/>
+              </a:ext>
+            </a:extLst>
+          </p:cNvPr>
+          <p:cNvSpPr>
+            <a:spLocks xmlns:a="http://schemas.openxmlformats.org/drawingml/2006/main" noGrp="1"/>
+          </p:cNvSpPr>
+          <p:nvPr/>
+        </p:nvSpPr>
+        <p:spPr>
+          <a:xfrm xmlns:a="http://schemas.openxmlformats.org/drawingml/2006/main">
+            <a:off x="3829050" y="3457575"/>
+            <a:ext cx="2914650" cy="371475"/>
+          </a:xfrm>
+          <a:prstGeom xmlns:a="http://schemas.openxmlformats.org/drawingml/2006/main" prst="rect">
+            <a:avLst/>
+          </a:prstGeom>
+          <a:noFill xmlns:a="http://schemas.openxmlformats.org/drawingml/2006/main"/>
+          <a:ln xmlns:a="http://schemas.openxmlformats.org/drawingml/2006/main" w="0">
+            <a:noFill/>
+          </a:ln>
+        </p:spPr>
+        <p:txBody>
+          <a:bodyPr xmlns:a="http://schemas.openxmlformats.org/drawingml/2006/main" wrap="square" lIns="0" tIns="0" rIns="0" bIns="0">
+            <a:normAutofit fontScale="100000"/>
+          </a:bodyPr>
+          <a:lstStyle xmlns:a="http://schemas.openxmlformats.org/drawingml/2006/main"/>
+          <a:p xmlns:a="http://schemas.openxmlformats.org/drawingml/2006/main">
+            <a:pPr>
+              <a:defRPr sz="1163" b="0">
+                <a:solidFill>
+                  <a:srgbClr val="145AC6"/>
+                </a:solidFill>
+                <a:latin typeface="Arial"/>
+                <a:ea typeface="Arial"/>
+                <a:cs typeface="Arial"/>
+              </a:defRPr>
+            </a:pPr>
+            <a:r>
+              <a:rPr sz="1163" b="0" u="sng">
+                <a:solidFill>
+                  <a:srgbClr val="145AC6"/>
+                </a:solidFill>
+                <a:latin typeface="Arial"/>
+                <a:ea typeface="Arial"/>
+                <a:cs typeface="Arial"/>
+                <a:hlinkClick xmlns:r="http://schemas.openxmlformats.org/officeDocument/2006/relationships" r:id="R5c25164529a840f8"/>
+              </a:rPr>
+              <a:t>Patil et al., 2024</a:t>
+            </a:r>
+          </a:p>
+        </p:txBody>
+      </p:sp>
+      <p:pic>
+        <p:nvPicPr>
+          <p:cNvPr id="52" name=""/>
+          <p:cNvPicPr>
+            <a:picLocks xmlns:a="http://schemas.openxmlformats.org/drawingml/2006/main" noChangeAspect="1"/>
+          </p:cNvPicPr>
+          <p:nvPr/>
+        </p:nvPicPr>
+        <p:blipFill>
+          <a:blip xmlns:r="http://schemas.openxmlformats.org/officeDocument/2006/relationships" xmlns:a="http://schemas.openxmlformats.org/drawingml/2006/main" r:embed="R11c2c5659a264965">
+            <a:extLst>
+              <a:ext uri="{96DAC541-7B7A-43D3-8B79-37D633B846F1}">
+                <asvg:svgBlip xmlns:asvg="http://schemas.microsoft.com/office/drawing/2016/SVG/main" r:embed="R112d498715ca4c4a"/>
+              </a:ext>
+            </a:extLst>
+          </a:blip>
+          <a:stretch xmlns:a="http://schemas.openxmlformats.org/drawingml/2006/main"/>
+        </p:blipFill>
+        <p:spPr>
+          <a:xfrm xmlns:a="http://schemas.openxmlformats.org/drawingml/2006/main">
+            <a:off x="533400" y="4076700"/>
+            <a:ext cx="400050" cy="400050"/>
+          </a:xfrm>
+          <a:prstGeom xmlns:a="http://schemas.openxmlformats.org/drawingml/2006/main" prst="rect">
+            <a:avLst/>
+          </a:prstGeom>
+        </p:spPr>
+      </p:pic>
+      <p:sp>
+        <p:nvSpPr>
+          <p:cNvPr id="27" name="Evidence 88%">
+            <a:extLst xmlns:a="http://schemas.openxmlformats.org/drawingml/2006/main">
+              <a:ext uri="{FF2B5EF4-FFF2-40B4-BE49-F238E27FC236}">
+                <a16:creationId xmlns:a16="http://schemas.microsoft.com/office/drawing/2014/main" id="{4073AD07-1E89-4BE4-A197-3C2F2F17B32D}"/>
+              </a:ext>
+            </a:extLst>
+          </p:cNvPr>
+          <p:cNvSpPr>
+            <a:spLocks xmlns:a="http://schemas.openxmlformats.org/drawingml/2006/main" noGrp="1"/>
+          </p:cNvSpPr>
+          <p:nvPr/>
+        </p:nvSpPr>
+        <p:spPr>
+          <a:xfrm xmlns:a="http://schemas.openxmlformats.org/drawingml/2006/main">
+            <a:off x="1057275" y="3981450"/>
+            <a:ext cx="2390775" cy="638175"/>
+          </a:xfrm>
+          <a:prstGeom xmlns:a="http://schemas.openxmlformats.org/drawingml/2006/main" prst="rect">
+            <a:avLst/>
+          </a:prstGeom>
+          <a:noFill xmlns:a="http://schemas.openxmlformats.org/drawingml/2006/main"/>
+          <a:ln xmlns:a="http://schemas.openxmlformats.org/drawingml/2006/main" w="0">
+            <a:noFill/>
+          </a:ln>
+        </p:spPr>
+        <p:txBody>
+          <a:bodyPr xmlns:a="http://schemas.openxmlformats.org/drawingml/2006/main" wrap="square" lIns="0" tIns="0" rIns="0" bIns="0">
+            <a:normAutofit fontScale="100000"/>
+          </a:bodyPr>
+          <a:lstStyle xmlns:a="http://schemas.openxmlformats.org/drawingml/2006/main"/>
+          <a:p xmlns:a="http://schemas.openxmlformats.org/drawingml/2006/main">
+            <a:pPr>
+              <a:defRPr sz="3675" b="1">
+                <a:solidFill>
+                  <a:srgbClr val="7353AC"/>
+                </a:solidFill>
+                <a:latin typeface="Arial"/>
+                <a:ea typeface="Arial"/>
+                <a:cs typeface="Arial"/>
+              </a:defRPr>
+            </a:pPr>
+            <a:r>
+              <a:rPr sz="3675" b="1">
+                <a:solidFill>
+                  <a:srgbClr val="7353AC"/>
+                </a:solidFill>
+                <a:latin typeface="Arial"/>
+                <a:ea typeface="Arial"/>
+                <a:cs typeface="Arial"/>
+              </a:rPr>
+              <a:t>88%</a:t>
+            </a:r>
+          </a:p>
+        </p:txBody>
+      </p:sp>
+      <p:sp>
+        <p:nvSpPr>
+          <p:cNvPr id="28" name="Evidence 88% scope">
+            <a:extLst xmlns:a="http://schemas.openxmlformats.org/drawingml/2006/main">
+              <a:ext uri="{FF2B5EF4-FFF2-40B4-BE49-F238E27FC236}">
+                <a16:creationId xmlns:a16="http://schemas.microsoft.com/office/drawing/2014/main" id="{E865A898-0E06-4018-8A93-499C26EC53FB}"/>
+              </a:ext>
+            </a:extLst>
+          </p:cNvPr>
+          <p:cNvSpPr>
+            <a:spLocks xmlns:a="http://schemas.openxmlformats.org/drawingml/2006/main" noGrp="1"/>
+          </p:cNvSpPr>
+          <p:nvPr/>
+        </p:nvSpPr>
+        <p:spPr>
+          <a:xfrm xmlns:a="http://schemas.openxmlformats.org/drawingml/2006/main">
+            <a:off x="533400" y="4772025"/>
+            <a:ext cx="2914650" cy="1162050"/>
+          </a:xfrm>
+          <a:prstGeom xmlns:a="http://schemas.openxmlformats.org/drawingml/2006/main" prst="rect">
+            <a:avLst/>
+          </a:prstGeom>
+          <a:noFill xmlns:a="http://schemas.openxmlformats.org/drawingml/2006/main"/>
+          <a:ln xmlns:a="http://schemas.openxmlformats.org/drawingml/2006/main" w="0">
+            <a:noFill/>
+          </a:ln>
+        </p:spPr>
+        <p:txBody>
+          <a:bodyPr xmlns:a="http://schemas.openxmlformats.org/drawingml/2006/main" wrap="square" lIns="0" tIns="0" rIns="0" bIns="0">
+            <a:normAutofit fontScale="100000"/>
+          </a:bodyPr>
+          <a:lstStyle xmlns:a="http://schemas.openxmlformats.org/drawingml/2006/main"/>
+          <a:p xmlns:a="http://schemas.openxmlformats.org/drawingml/2006/main">
+            <a:pPr>
+              <a:defRPr sz="1575" b="0">
+                <a:solidFill>
+                  <a:srgbClr val="173F33"/>
+                </a:solidFill>
+                <a:latin typeface="Arial"/>
+                <a:ea typeface="Arial"/>
+                <a:cs typeface="Arial"/>
+              </a:defRPr>
+            </a:pPr>
+            <a:r>
+              <a:rPr sz="1575" b="0">
+                <a:solidFill>
+                  <a:srgbClr val="173F33"/>
+                </a:solidFill>
+                <a:latin typeface="Arial"/>
+                <a:ea typeface="Arial"/>
+                <a:cs typeface="Arial"/>
+              </a:rPr>
+              <a:t>Wanted to choose their treatment near the end of life in a 2019 survey of 2,400+ urban respondents.</a:t>
+            </a:r>
+          </a:p>
+        </p:txBody>
+      </p:sp>
+      <p:sp>
+        <p:nvSpPr>
+          <p:cNvPr id="29" name="Evidence 88% source">
+            <a:extLst xmlns:a="http://schemas.openxmlformats.org/drawingml/2006/main">
+              <a:ext uri="{FF2B5EF4-FFF2-40B4-BE49-F238E27FC236}">
+                <a16:creationId xmlns:a16="http://schemas.microsoft.com/office/drawing/2014/main" id="{907AFFE1-EC54-4F7F-A47C-F2ABE9F5F09D}"/>
+              </a:ext>
+            </a:extLst>
+          </p:cNvPr>
+          <p:cNvSpPr>
+            <a:spLocks xmlns:a="http://schemas.openxmlformats.org/drawingml/2006/main" noGrp="1"/>
+          </p:cNvSpPr>
+          <p:nvPr/>
+        </p:nvSpPr>
+        <p:spPr>
+          <a:xfrm xmlns:a="http://schemas.openxmlformats.org/drawingml/2006/main">
+            <a:off x="533400" y="5991225"/>
+            <a:ext cx="2914650" cy="371475"/>
+          </a:xfrm>
+          <a:prstGeom xmlns:a="http://schemas.openxmlformats.org/drawingml/2006/main" prst="rect">
+            <a:avLst/>
+          </a:prstGeom>
+          <a:noFill xmlns:a="http://schemas.openxmlformats.org/drawingml/2006/main"/>
+          <a:ln xmlns:a="http://schemas.openxmlformats.org/drawingml/2006/main" w="0">
+            <a:noFill/>
+          </a:ln>
+        </p:spPr>
+        <p:txBody>
+          <a:bodyPr xmlns:a="http://schemas.openxmlformats.org/drawingml/2006/main" wrap="square" lIns="0" tIns="0" rIns="0" bIns="0">
+            <a:normAutofit fontScale="100000"/>
+          </a:bodyPr>
+          <a:lstStyle xmlns:a="http://schemas.openxmlformats.org/drawingml/2006/main"/>
+          <a:p xmlns:a="http://schemas.openxmlformats.org/drawingml/2006/main">
+            <a:pPr>
+              <a:defRPr sz="1163" b="0">
+                <a:solidFill>
+                  <a:srgbClr val="145AC6"/>
+                </a:solidFill>
+                <a:latin typeface="Arial"/>
+                <a:ea typeface="Arial"/>
+                <a:cs typeface="Arial"/>
+              </a:defRPr>
+            </a:pPr>
+            <a:r>
+              <a:rPr sz="1163" b="0" u="sng">
+                <a:solidFill>
+                  <a:srgbClr val="145AC6"/>
+                </a:solidFill>
+                <a:latin typeface="Arial"/>
+                <a:ea typeface="Arial"/>
+                <a:cs typeface="Arial"/>
+                <a:hlinkClick xmlns:r="http://schemas.openxmlformats.org/officeDocument/2006/relationships" r:id="Rde27b88f53d94d52"/>
+              </a:rPr>
+              <a:t>IndiaSpend reporting; seven cities</a:t>
+            </a:r>
+          </a:p>
+        </p:txBody>
+      </p:sp>
+      <p:pic>
+        <p:nvPicPr>
+          <p:cNvPr id="56" name=""/>
+          <p:cNvPicPr>
+            <a:picLocks xmlns:a="http://schemas.openxmlformats.org/drawingml/2006/main" noChangeAspect="1"/>
+          </p:cNvPicPr>
+          <p:nvPr/>
+        </p:nvPicPr>
+        <p:blipFill>
+          <a:blip xmlns:r="http://schemas.openxmlformats.org/officeDocument/2006/relationships" xmlns:a="http://schemas.openxmlformats.org/drawingml/2006/main" r:embed="Rae8a9b6cc6f8477c">
+            <a:extLst>
+              <a:ext uri="{96DAC541-7B7A-43D3-8B79-37D633B846F1}">
+                <asvg:svgBlip xmlns:asvg="http://schemas.microsoft.com/office/drawing/2016/SVG/main" r:embed="R359bc1e3680340b2"/>
+              </a:ext>
+            </a:extLst>
+          </a:blip>
+          <a:stretch xmlns:a="http://schemas.openxmlformats.org/drawingml/2006/main"/>
+        </p:blipFill>
+        <p:spPr>
+          <a:xfrm xmlns:a="http://schemas.openxmlformats.org/drawingml/2006/main">
+            <a:off x="3829050" y="4076700"/>
+            <a:ext cx="400050" cy="400050"/>
+          </a:xfrm>
+          <a:prstGeom xmlns:a="http://schemas.openxmlformats.org/drawingml/2006/main" prst="rect">
+            <a:avLst/>
+          </a:prstGeom>
+        </p:spPr>
+      </p:pic>
+      <p:sp>
+        <p:nvSpPr>
+          <p:cNvPr id="31" name="Evidence 11.5%">
+            <a:extLst xmlns:a="http://schemas.openxmlformats.org/drawingml/2006/main">
+              <a:ext uri="{FF2B5EF4-FFF2-40B4-BE49-F238E27FC236}">
+                <a16:creationId xmlns:a16="http://schemas.microsoft.com/office/drawing/2014/main" id="{637B60D4-2E67-443E-9A85-7B3BD3776C53}"/>
+              </a:ext>
+            </a:extLst>
+          </p:cNvPr>
+          <p:cNvSpPr>
+            <a:spLocks xmlns:a="http://schemas.openxmlformats.org/drawingml/2006/main" noGrp="1"/>
+          </p:cNvSpPr>
+          <p:nvPr/>
+        </p:nvSpPr>
+        <p:spPr>
+          <a:xfrm xmlns:a="http://schemas.openxmlformats.org/drawingml/2006/main">
+            <a:off x="4352925" y="3981450"/>
+            <a:ext cx="2390775" cy="638175"/>
+          </a:xfrm>
+          <a:prstGeom xmlns:a="http://schemas.openxmlformats.org/drawingml/2006/main" prst="rect">
+            <a:avLst/>
+          </a:prstGeom>
+          <a:noFill xmlns:a="http://schemas.openxmlformats.org/drawingml/2006/main"/>
+          <a:ln xmlns:a="http://schemas.openxmlformats.org/drawingml/2006/main" w="0">
+            <a:noFill/>
+          </a:ln>
+        </p:spPr>
+        <p:txBody>
+          <a:bodyPr xmlns:a="http://schemas.openxmlformats.org/drawingml/2006/main" wrap="square" lIns="0" tIns="0" rIns="0" bIns="0">
+            <a:normAutofit fontScale="100000"/>
+          </a:bodyPr>
+          <a:lstStyle xmlns:a="http://schemas.openxmlformats.org/drawingml/2006/main"/>
+          <a:p xmlns:a="http://schemas.openxmlformats.org/drawingml/2006/main">
+            <a:pPr>
+              <a:defRPr sz="3675" b="1">
+                <a:solidFill>
+                  <a:srgbClr val="4357C7"/>
+                </a:solidFill>
+                <a:latin typeface="Arial"/>
+                <a:ea typeface="Arial"/>
+                <a:cs typeface="Arial"/>
+              </a:defRPr>
+            </a:pPr>
+            <a:r>
+              <a:rPr sz="3675" b="1">
+                <a:solidFill>
+                  <a:srgbClr val="4357C7"/>
+                </a:solidFill>
+                <a:latin typeface="Arial"/>
+                <a:ea typeface="Arial"/>
+                <a:cs typeface="Arial"/>
+              </a:rPr>
+              <a:t>11.5%</a:t>
+            </a:r>
+          </a:p>
+        </p:txBody>
+      </p:sp>
+      <p:sp>
+        <p:nvSpPr>
+          <p:cNvPr id="32" name="Evidence 11.5% scope">
+            <a:extLst xmlns:a="http://schemas.openxmlformats.org/drawingml/2006/main">
+              <a:ext uri="{FF2B5EF4-FFF2-40B4-BE49-F238E27FC236}">
+                <a16:creationId xmlns:a16="http://schemas.microsoft.com/office/drawing/2014/main" id="{DD614463-215F-44CA-9EE5-4548EDD1A704}"/>
+              </a:ext>
+            </a:extLst>
+          </p:cNvPr>
+          <p:cNvSpPr>
+            <a:spLocks xmlns:a="http://schemas.openxmlformats.org/drawingml/2006/main" noGrp="1"/>
+          </p:cNvSpPr>
+          <p:nvPr/>
+        </p:nvSpPr>
+        <p:spPr>
+          <a:xfrm xmlns:a="http://schemas.openxmlformats.org/drawingml/2006/main">
+            <a:off x="3829050" y="4772025"/>
+            <a:ext cx="2914650" cy="1162050"/>
+          </a:xfrm>
+          <a:prstGeom xmlns:a="http://schemas.openxmlformats.org/drawingml/2006/main" prst="rect">
+            <a:avLst/>
+          </a:prstGeom>
+          <a:noFill xmlns:a="http://schemas.openxmlformats.org/drawingml/2006/main"/>
+          <a:ln xmlns:a="http://schemas.openxmlformats.org/drawingml/2006/main" w="0">
+            <a:noFill/>
+          </a:ln>
+        </p:spPr>
+        <p:txBody>
+          <a:bodyPr xmlns:a="http://schemas.openxmlformats.org/drawingml/2006/main" wrap="square" lIns="0" tIns="0" rIns="0" bIns="0">
+            <a:normAutofit fontScale="100000"/>
+          </a:bodyPr>
+          <a:lstStyle xmlns:a="http://schemas.openxmlformats.org/drawingml/2006/main"/>
+          <a:p xmlns:a="http://schemas.openxmlformats.org/drawingml/2006/main">
+            <a:pPr>
+              <a:defRPr sz="1575" b="0">
+                <a:solidFill>
+                  <a:srgbClr val="173F33"/>
+                </a:solidFill>
+                <a:latin typeface="Arial"/>
+                <a:ea typeface="Arial"/>
+                <a:cs typeface="Arial"/>
+              </a:defRPr>
+            </a:pPr>
+            <a:r>
+              <a:rPr sz="1575" b="0">
+                <a:solidFill>
+                  <a:srgbClr val="173F33"/>
+                </a:solidFill>
+                <a:latin typeface="Arial"/>
+                <a:ea typeface="Arial"/>
+                <a:cs typeface="Arial"/>
+              </a:rPr>
+              <a:t>45 of 391 doctors at one hospital had training in advance directives, which record wishes for future care.</a:t>
+            </a:r>
+          </a:p>
+        </p:txBody>
+      </p:sp>
+      <p:sp>
+        <p:nvSpPr>
+          <p:cNvPr id="33" name="Evidence 11.5% source">
+            <a:extLst xmlns:a="http://schemas.openxmlformats.org/drawingml/2006/main">
+              <a:ext uri="{FF2B5EF4-FFF2-40B4-BE49-F238E27FC236}">
+                <a16:creationId xmlns:a16="http://schemas.microsoft.com/office/drawing/2014/main" id="{243D93FE-F2D4-4231-B3E0-71428F5EDF31}"/>
+              </a:ext>
+            </a:extLst>
+          </p:cNvPr>
+          <p:cNvSpPr>
+            <a:spLocks xmlns:a="http://schemas.openxmlformats.org/drawingml/2006/main" noGrp="1"/>
+          </p:cNvSpPr>
+          <p:nvPr/>
+        </p:nvSpPr>
+        <p:spPr>
+          <a:xfrm xmlns:a="http://schemas.openxmlformats.org/drawingml/2006/main">
+            <a:off x="3829050" y="5991225"/>
+            <a:ext cx="2914650" cy="371475"/>
+          </a:xfrm>
+          <a:prstGeom xmlns:a="http://schemas.openxmlformats.org/drawingml/2006/main" prst="rect">
+            <a:avLst/>
+          </a:prstGeom>
+          <a:noFill xmlns:a="http://schemas.openxmlformats.org/drawingml/2006/main"/>
+          <a:ln xmlns:a="http://schemas.openxmlformats.org/drawingml/2006/main" w="0">
+            <a:noFill/>
+          </a:ln>
+        </p:spPr>
+        <p:txBody>
+          <a:bodyPr xmlns:a="http://schemas.openxmlformats.org/drawingml/2006/main" wrap="square" lIns="0" tIns="0" rIns="0" bIns="0">
+            <a:normAutofit fontScale="100000"/>
+          </a:bodyPr>
+          <a:lstStyle xmlns:a="http://schemas.openxmlformats.org/drawingml/2006/main"/>
+          <a:p xmlns:a="http://schemas.openxmlformats.org/drawingml/2006/main">
+            <a:pPr>
+              <a:defRPr sz="1163" b="0">
+                <a:solidFill>
+                  <a:srgbClr val="145AC6"/>
+                </a:solidFill>
+                <a:latin typeface="Arial"/>
+                <a:ea typeface="Arial"/>
+                <a:cs typeface="Arial"/>
+              </a:defRPr>
+            </a:pPr>
+            <a:r>
+              <a:rPr sz="1163" b="0" u="sng">
+                <a:solidFill>
+                  <a:srgbClr val="145AC6"/>
+                </a:solidFill>
+                <a:latin typeface="Arial"/>
+                <a:ea typeface="Arial"/>
+                <a:cs typeface="Arial"/>
+                <a:hlinkClick xmlns:r="http://schemas.openxmlformats.org/officeDocument/2006/relationships" r:id="R8460401a990442cd"/>
+              </a:rPr>
+              <a:t>Jacob et al., CMC Vellore, 2026</a:t>
+            </a:r>
+          </a:p>
+        </p:txBody>
+      </p:sp>
+      <p:pic>
+        <p:nvPicPr>
+          <p:cNvPr id="60" name=""/>
+          <p:cNvPicPr>
+            <a:picLocks xmlns:a="http://schemas.openxmlformats.org/drawingml/2006/main" noChangeAspect="1"/>
+          </p:cNvPicPr>
+          <p:nvPr/>
+        </p:nvPicPr>
+        <p:blipFill>
+          <a:blip xmlns:r="http://schemas.openxmlformats.org/officeDocument/2006/relationships" xmlns:a="http://schemas.openxmlformats.org/drawingml/2006/main" r:embed="R7912fb7ee2cd46f7">
+            <a:extLst>
+              <a:ext uri="{96DAC541-7B7A-43D3-8B79-37D633B846F1}">
+                <asvg:svgBlip xmlns:asvg="http://schemas.microsoft.com/office/drawing/2016/SVG/main" r:embed="R203879d950ad4bc4"/>
+              </a:ext>
+            </a:extLst>
+          </a:blip>
+          <a:stretch xmlns:a="http://schemas.openxmlformats.org/drawingml/2006/main"/>
+        </p:blipFill>
+        <p:spPr>
+          <a:xfrm xmlns:a="http://schemas.openxmlformats.org/drawingml/2006/main">
+            <a:off x="7372350" y="1533525"/>
+            <a:ext cx="381000" cy="381000"/>
+          </a:xfrm>
+          <a:prstGeom xmlns:a="http://schemas.openxmlformats.org/drawingml/2006/main" prst="rect">
+            <a:avLst/>
+          </a:prstGeom>
+        </p:spPr>
+      </p:pic>
+      <p:sp>
+        <p:nvSpPr>
+          <p:cNvPr id="35" name="QI measure">
+            <a:extLst xmlns:a="http://schemas.openxmlformats.org/drawingml/2006/main">
+              <a:ext uri="{FF2B5EF4-FFF2-40B4-BE49-F238E27FC236}">
+                <a16:creationId xmlns:a16="http://schemas.microsoft.com/office/drawing/2014/main" id="{D2651FD1-CAD0-493B-BC0A-FD9CA6B390B2}"/>
+              </a:ext>
+            </a:extLst>
+          </p:cNvPr>
+          <p:cNvSpPr>
+            <a:spLocks xmlns:a="http://schemas.openxmlformats.org/drawingml/2006/main" noGrp="1"/>
+          </p:cNvSpPr>
+          <p:nvPr/>
+        </p:nvSpPr>
+        <p:spPr>
+          <a:xfrm xmlns:a="http://schemas.openxmlformats.org/drawingml/2006/main">
+            <a:off x="7905750" y="1514475"/>
+            <a:ext cx="3524250" cy="647700"/>
+          </a:xfrm>
+          <a:prstGeom xmlns:a="http://schemas.openxmlformats.org/drawingml/2006/main" prst="rect">
+            <a:avLst/>
+          </a:prstGeom>
+          <a:noFill xmlns:a="http://schemas.openxmlformats.org/drawingml/2006/main"/>
+          <a:ln xmlns:a="http://schemas.openxmlformats.org/drawingml/2006/main" w="0">
+            <a:noFill/>
+          </a:ln>
+        </p:spPr>
+        <p:txBody>
+          <a:bodyPr xmlns:a="http://schemas.openxmlformats.org/drawingml/2006/main" wrap="square" lIns="0" tIns="0" rIns="0" bIns="0">
+            <a:normAutofit fontScale="100000"/>
+          </a:bodyPr>
+          <a:lstStyle xmlns:a="http://schemas.openxmlformats.org/drawingml/2006/main"/>
+          <a:p xmlns:a="http://schemas.openxmlformats.org/drawingml/2006/main">
+            <a:pPr>
+              <a:defRPr sz="2025" b="1">
+                <a:solidFill>
+                  <a:srgbClr val="173F33"/>
+                </a:solidFill>
+                <a:latin typeface="Arial"/>
+                <a:ea typeface="Arial"/>
+                <a:cs typeface="Arial"/>
+              </a:defRPr>
+            </a:pPr>
+            <a:r>
+              <a:rPr sz="2025" b="1">
+                <a:solidFill>
+                  <a:srgbClr val="173F33"/>
+                </a:solidFill>
+                <a:latin typeface="Arial"/>
+                <a:ea typeface="Arial"/>
+                <a:cs typeface="Arial"/>
+              </a:rPr>
+              <a:t>One Chennai hospital improved documentation.</a:t>
+            </a:r>
+          </a:p>
+        </p:txBody>
+      </p:sp>
+      <p:sp>
+        <p:nvSpPr>
+          <p:cNvPr id="36" name="QI finding">
+            <a:extLst xmlns:a="http://schemas.openxmlformats.org/drawingml/2006/main">
+              <a:ext uri="{FF2B5EF4-FFF2-40B4-BE49-F238E27FC236}">
+                <a16:creationId xmlns:a16="http://schemas.microsoft.com/office/drawing/2014/main" id="{D1FA14F3-05C8-44B4-8C88-B74468A57F85}"/>
+              </a:ext>
+            </a:extLst>
+          </p:cNvPr>
+          <p:cNvSpPr>
+            <a:spLocks xmlns:a="http://schemas.openxmlformats.org/drawingml/2006/main" noGrp="1"/>
+          </p:cNvSpPr>
+          <p:nvPr/>
+        </p:nvSpPr>
+        <p:spPr>
+          <a:xfrm xmlns:a="http://schemas.openxmlformats.org/drawingml/2006/main">
+            <a:off x="7372350" y="4857750"/>
+            <a:ext cx="4057650" cy="981075"/>
+          </a:xfrm>
+          <a:prstGeom xmlns:a="http://schemas.openxmlformats.org/drawingml/2006/main" prst="rect">
+            <a:avLst/>
+          </a:prstGeom>
+          <a:noFill xmlns:a="http://schemas.openxmlformats.org/drawingml/2006/main"/>
+          <a:ln xmlns:a="http://schemas.openxmlformats.org/drawingml/2006/main" w="0">
+            <a:noFill/>
+          </a:ln>
+        </p:spPr>
+        <p:txBody>
+          <a:bodyPr xmlns:a="http://schemas.openxmlformats.org/drawingml/2006/main" wrap="square" lIns="0" tIns="0" rIns="0" bIns="0">
+            <a:normAutofit fontScale="100000"/>
+          </a:bodyPr>
+          <a:lstStyle xmlns:a="http://schemas.openxmlformats.org/drawingml/2006/main"/>
+          <a:p xmlns:a="http://schemas.openxmlformats.org/drawingml/2006/main">
+            <a:pPr>
+              <a:defRPr sz="1725" b="0">
+                <a:solidFill>
+                  <a:srgbClr val="173F33"/>
+                </a:solidFill>
+                <a:latin typeface="Arial"/>
+                <a:ea typeface="Arial"/>
+                <a:cs typeface="Arial"/>
+              </a:defRPr>
+            </a:pPr>
+            <a:r>
+              <a:rPr sz="1725" b="0">
+                <a:solidFill>
+                  <a:srgbClr val="173F33"/>
+                </a:solidFill>
+                <a:latin typeface="Arial"/>
+                <a:ea typeface="Arial"/>
+                <a:cs typeface="Arial"/>
+              </a:rPr>
+              <a:t>A standard process helped staff write down care discussions for 24 of 26 eligible patients.</a:t>
+            </a:r>
+          </a:p>
+        </p:txBody>
+      </p:sp>
+      <p:sp>
+        <p:nvSpPr>
+          <p:cNvPr id="37" name="QI scope">
+            <a:extLst xmlns:a="http://schemas.openxmlformats.org/drawingml/2006/main">
+              <a:ext uri="{FF2B5EF4-FFF2-40B4-BE49-F238E27FC236}">
+                <a16:creationId xmlns:a16="http://schemas.microsoft.com/office/drawing/2014/main" id="{32CCF79E-F75F-4054-A281-C140E652B715}"/>
+              </a:ext>
+            </a:extLst>
+          </p:cNvPr>
+          <p:cNvSpPr>
+            <a:spLocks xmlns:a="http://schemas.openxmlformats.org/drawingml/2006/main" noGrp="1"/>
+          </p:cNvSpPr>
+          <p:nvPr/>
+        </p:nvSpPr>
+        <p:spPr>
+          <a:xfrm xmlns:a="http://schemas.openxmlformats.org/drawingml/2006/main">
+            <a:off x="7372350" y="5819775"/>
+            <a:ext cx="4057650" cy="247650"/>
+          </a:xfrm>
+          <a:prstGeom xmlns:a="http://schemas.openxmlformats.org/drawingml/2006/main" prst="rect">
+            <a:avLst/>
+          </a:prstGeom>
+          <a:noFill xmlns:a="http://schemas.openxmlformats.org/drawingml/2006/main"/>
+          <a:ln xmlns:a="http://schemas.openxmlformats.org/drawingml/2006/main" w="0">
+            <a:noFill/>
+          </a:ln>
+        </p:spPr>
+        <p:txBody>
+          <a:bodyPr xmlns:a="http://schemas.openxmlformats.org/drawingml/2006/main" wrap="square" lIns="0" tIns="0" rIns="0" bIns="0">
+            <a:normAutofit fontScale="100000"/>
+          </a:bodyPr>
+          <a:lstStyle xmlns:a="http://schemas.openxmlformats.org/drawingml/2006/main"/>
+          <a:p xmlns:a="http://schemas.openxmlformats.org/drawingml/2006/main">
+            <a:pPr>
+              <a:defRPr sz="1238" b="0">
+                <a:solidFill>
+                  <a:srgbClr val="53655C"/>
+                </a:solidFill>
+                <a:latin typeface="Arial"/>
+                <a:ea typeface="Arial"/>
+                <a:cs typeface="Arial"/>
+              </a:defRPr>
+            </a:pPr>
+            <a:r>
+              <a:rPr sz="1238" b="0">
+                <a:solidFill>
+                  <a:srgbClr val="53655C"/>
+                </a:solidFill>
+                <a:latin typeface="Arial"/>
+                <a:ea typeface="Arial"/>
+                <a:cs typeface="Arial"/>
+              </a:rPr>
+              <a:t>Advanced pancreatic / colorectal cancer.</a:t>
+            </a:r>
+          </a:p>
+        </p:txBody>
+      </p:sp>
+      <p:sp>
+        <p:nvSpPr>
+          <p:cNvPr id="38" name="QI source">
+            <a:extLst xmlns:a="http://schemas.openxmlformats.org/drawingml/2006/main">
+              <a:ext uri="{FF2B5EF4-FFF2-40B4-BE49-F238E27FC236}">
+                <a16:creationId xmlns:a16="http://schemas.microsoft.com/office/drawing/2014/main" id="{9F7600D9-C0DB-4668-AD7E-865B80440CA3}"/>
+              </a:ext>
+            </a:extLst>
+          </p:cNvPr>
+          <p:cNvSpPr>
+            <a:spLocks xmlns:a="http://schemas.openxmlformats.org/drawingml/2006/main" noGrp="1"/>
+          </p:cNvSpPr>
+          <p:nvPr/>
+        </p:nvSpPr>
+        <p:spPr>
+          <a:xfrm xmlns:a="http://schemas.openxmlformats.org/drawingml/2006/main">
+            <a:off x="7372350" y="6067425"/>
+            <a:ext cx="4057650" cy="238125"/>
+          </a:xfrm>
+          <a:prstGeom xmlns:a="http://schemas.openxmlformats.org/drawingml/2006/main" prst="rect">
+            <a:avLst/>
+          </a:prstGeom>
+          <a:noFill xmlns:a="http://schemas.openxmlformats.org/drawingml/2006/main"/>
+          <a:ln xmlns:a="http://schemas.openxmlformats.org/drawingml/2006/main" w="0">
+            <a:noFill/>
+          </a:ln>
+        </p:spPr>
+        <p:txBody>
+          <a:bodyPr xmlns:a="http://schemas.openxmlformats.org/drawingml/2006/main" wrap="square" lIns="0" tIns="0" rIns="0" bIns="0">
+            <a:normAutofit fontScale="100000"/>
+          </a:bodyPr>
+          <a:lstStyle xmlns:a="http://schemas.openxmlformats.org/drawingml/2006/main"/>
+          <a:p xmlns:a="http://schemas.openxmlformats.org/drawingml/2006/main">
+            <a:pPr>
+              <a:defRPr sz="1238" b="0">
+                <a:solidFill>
+                  <a:srgbClr val="145AC6"/>
+                </a:solidFill>
+                <a:latin typeface="Arial"/>
+                <a:ea typeface="Arial"/>
+                <a:cs typeface="Arial"/>
+              </a:defRPr>
+            </a:pPr>
+            <a:r>
+              <a:rPr sz="1238" b="0" u="sng">
+                <a:solidFill>
+                  <a:srgbClr val="145AC6"/>
+                </a:solidFill>
+                <a:latin typeface="Arial"/>
+                <a:ea typeface="Arial"/>
+                <a:cs typeface="Arial"/>
+                <a:hlinkClick xmlns:r="http://schemas.openxmlformats.org/officeDocument/2006/relationships" r:id="Rad120cafcb784cab"/>
+              </a:rPr>
+              <a:t>Thangasamy et al., 2025</a:t>
+            </a:r>
+          </a:p>
+        </p:txBody>
+      </p:sp>
+      <p:sp>
+        <p:nvSpPr>
+          <p:cNvPr id="39" name="Evidence boundary">
+            <a:extLst xmlns:a="http://schemas.openxmlformats.org/drawingml/2006/main">
+              <a:ext uri="{FF2B5EF4-FFF2-40B4-BE49-F238E27FC236}">
+                <a16:creationId xmlns:a16="http://schemas.microsoft.com/office/drawing/2014/main" id="{D241C6FD-8DA6-4834-90E6-8ADD3D24A0F9}"/>
+              </a:ext>
+            </a:extLst>
+          </p:cNvPr>
+          <p:cNvSpPr>
+            <a:spLocks xmlns:a="http://schemas.openxmlformats.org/drawingml/2006/main" noGrp="1"/>
+          </p:cNvSpPr>
+          <p:nvPr/>
+        </p:nvSpPr>
+        <p:spPr>
+          <a:xfrm xmlns:a="http://schemas.openxmlformats.org/drawingml/2006/main">
+            <a:off x="533400" y="6515100"/>
+            <a:ext cx="11125200" cy="228600"/>
+          </a:xfrm>
+          <a:prstGeom xmlns:a="http://schemas.openxmlformats.org/drawingml/2006/main" prst="rect">
+            <a:avLst/>
+          </a:prstGeom>
+          <a:noFill xmlns:a="http://schemas.openxmlformats.org/drawingml/2006/main"/>
+          <a:ln xmlns:a="http://schemas.openxmlformats.org/drawingml/2006/main" w="0">
+            <a:noFill/>
+          </a:ln>
+        </p:spPr>
+        <p:txBody>
+          <a:bodyPr xmlns:a="http://schemas.openxmlformats.org/drawingml/2006/main" wrap="square" lIns="0" tIns="0" rIns="0" bIns="0">
+            <a:normAutofit fontScale="100000"/>
+          </a:bodyPr>
+          <a:lstStyle xmlns:a="http://schemas.openxmlformats.org/drawingml/2006/main"/>
+          <a:p xmlns:a="http://schemas.openxmlformats.org/drawingml/2006/main">
+            <a:pPr>
+              <a:defRPr sz="1200" b="0">
+                <a:solidFill>
+                  <a:srgbClr val="53655C"/>
+                </a:solidFill>
+                <a:latin typeface="Arial"/>
+                <a:ea typeface="Arial"/>
+                <a:cs typeface="Arial"/>
+              </a:defRPr>
+            </a:pPr>
+            <a:r>
+              <a:rPr sz="1200" b="0">
+                <a:solidFill>
+                  <a:srgbClr val="53655C"/>
+                </a:solidFill>
+                <a:latin typeface="Arial"/>
+                <a:ea typeface="Arial"/>
+                <a:cs typeface="Arial"/>
+              </a:rPr>
+              <a:t>Each study looked at a different group of people. These figures are not results from Saathi.</a:t>
+            </a:r>
+          </a:p>
+        </p:txBody>
+      </p:sp>
+    </p:spTree>
+    <p:extLst>
+      <p:ext uri="{BB962C8B-B14F-4D97-AF65-F5344CB8AC3E}">
+        <p14:creationId xmlns:p14="http://schemas.microsoft.com/office/powerpoint/2010/main" val="1299123762"/>
+      </p:ext>
+    </p:extLst>
+  </p:cSld>
+</p:sld>
+</file>
+
+<file path=ppt/slides/slide6.xml><?xml version="1.0" encoding="utf-8"?>
 <p:sld xmlns:p="http://schemas.openxmlformats.org/presentationml/2006/main">
   <p:cSld>
     <p:bg>
@@ -6376,7 +6907,7 @@
           <p:cNvPr id="11" name="Slide title">
             <a:extLst xmlns:a="http://schemas.openxmlformats.org/drawingml/2006/main">
               <a:ext uri="{FF2B5EF4-FFF2-40B4-BE49-F238E27FC236}">
-                <a16:creationId xmlns:a16="http://schemas.microsoft.com/office/drawing/2014/main" id="{5BF878A1-D41B-44B5-BDEA-2AAD4275F6E2}"/>
+                <a16:creationId xmlns:a16="http://schemas.microsoft.com/office/drawing/2014/main" id="{FC0F1AA6-CD69-4465-BDF3-A2ECBAB084C2}"/>
               </a:ext>
             </a:extLst>
           </p:cNvPr>
@@ -6433,7 +6964,7 @@
           <p:cNvPr id="2" name="Records assistant purpose">
             <a:extLst xmlns:a="http://schemas.openxmlformats.org/drawingml/2006/main">
               <a:ext uri="{FF2B5EF4-FFF2-40B4-BE49-F238E27FC236}">
-                <a16:creationId xmlns:a16="http://schemas.microsoft.com/office/drawing/2014/main" id="{90CAD21E-62E0-4A5D-92D0-098B5B5DE82F}"/>
+                <a16:creationId xmlns:a16="http://schemas.microsoft.com/office/drawing/2014/main" id="{36DAC2A2-C7FA-41CA-BD02-8D09C310D738}"/>
               </a:ext>
             </a:extLst>
           </p:cNvPr>
@@ -6494,7 +7025,7 @@
           <p:nvPr/>
         </p:nvPicPr>
         <p:blipFill>
-          <a:blip xmlns:r="http://schemas.openxmlformats.org/officeDocument/2006/relationships" xmlns:a="http://schemas.openxmlformats.org/drawingml/2006/main" r:embed="R8ad2fb7eeeaa49a0"/>
+          <a:blip xmlns:r="http://schemas.openxmlformats.org/officeDocument/2006/relationships" xmlns:a="http://schemas.openxmlformats.org/drawingml/2006/main" r:embed="Rd7571ae9d6624988"/>
           <a:stretch xmlns:a="http://schemas.openxmlformats.org/drawingml/2006/main"/>
         </p:blipFill>
         <p:spPr>
@@ -6512,7 +7043,7 @@
           <p:cNvPr id="4" name="Records assistant 1">
             <a:extLst xmlns:a="http://schemas.openxmlformats.org/drawingml/2006/main">
               <a:ext uri="{FF2B5EF4-FFF2-40B4-BE49-F238E27FC236}">
-                <a16:creationId xmlns:a16="http://schemas.microsoft.com/office/drawing/2014/main" id="{37F61E7F-1860-438D-B8A5-3E3A9F3C9E6B}"/>
+                <a16:creationId xmlns:a16="http://schemas.microsoft.com/office/drawing/2014/main" id="{707ADA56-D3E3-4A83-983D-55258ACEBE37}"/>
               </a:ext>
             </a:extLst>
           </p:cNvPr>
@@ -6569,7 +7100,7 @@
           <p:cNvPr id="5" name="Records assistant 1 detail">
             <a:extLst xmlns:a="http://schemas.openxmlformats.org/drawingml/2006/main">
               <a:ext uri="{FF2B5EF4-FFF2-40B4-BE49-F238E27FC236}">
-                <a16:creationId xmlns:a16="http://schemas.microsoft.com/office/drawing/2014/main" id="{6E651E4A-D000-4F47-9C1E-0412BAA346AA}"/>
+                <a16:creationId xmlns:a16="http://schemas.microsoft.com/office/drawing/2014/main" id="{87F62111-2B3F-4C52-B1EC-1BFC846A7062}"/>
               </a:ext>
             </a:extLst>
           </p:cNvPr>
@@ -6626,7 +7157,7 @@
           <p:cNvPr id="6" name="Records assistant 2">
             <a:extLst xmlns:a="http://schemas.openxmlformats.org/drawingml/2006/main">
               <a:ext uri="{FF2B5EF4-FFF2-40B4-BE49-F238E27FC236}">
-                <a16:creationId xmlns:a16="http://schemas.microsoft.com/office/drawing/2014/main" id="{7234EE46-0F1F-46A4-8F99-6C246351C487}"/>
+                <a16:creationId xmlns:a16="http://schemas.microsoft.com/office/drawing/2014/main" id="{B25C4C63-F04B-4F72-BE17-351747897C0F}"/>
               </a:ext>
             </a:extLst>
           </p:cNvPr>
@@ -6683,7 +7214,7 @@
           <p:cNvPr id="7" name="Records assistant 2 detail">
             <a:extLst xmlns:a="http://schemas.openxmlformats.org/drawingml/2006/main">
               <a:ext uri="{FF2B5EF4-FFF2-40B4-BE49-F238E27FC236}">
-                <a16:creationId xmlns:a16="http://schemas.microsoft.com/office/drawing/2014/main" id="{725DCB49-04B8-4316-920A-D17644CF8B7B}"/>
+                <a16:creationId xmlns:a16="http://schemas.microsoft.com/office/drawing/2014/main" id="{4A963A6A-2896-4323-9808-0A49C0A0E546}"/>
               </a:ext>
             </a:extLst>
           </p:cNvPr>
@@ -6740,7 +7271,7 @@
           <p:cNvPr id="8" name="Records assistant 3">
             <a:extLst xmlns:a="http://schemas.openxmlformats.org/drawingml/2006/main">
               <a:ext uri="{FF2B5EF4-FFF2-40B4-BE49-F238E27FC236}">
-                <a16:creationId xmlns:a16="http://schemas.microsoft.com/office/drawing/2014/main" id="{5EB1CBA9-B72A-4B0C-B81F-56337BA6F580}"/>
+                <a16:creationId xmlns:a16="http://schemas.microsoft.com/office/drawing/2014/main" id="{7FEE974E-5119-48E6-AC5B-A839B24F33EE}"/>
               </a:ext>
             </a:extLst>
           </p:cNvPr>
@@ -6797,7 +7328,7 @@
           <p:cNvPr id="9" name="Records assistant 3 detail">
             <a:extLst xmlns:a="http://schemas.openxmlformats.org/drawingml/2006/main">
               <a:ext uri="{FF2B5EF4-FFF2-40B4-BE49-F238E27FC236}">
-                <a16:creationId xmlns:a16="http://schemas.microsoft.com/office/drawing/2014/main" id="{D9C8CBD6-3FF0-447A-B77C-F845EDDCC1BC}"/>
+                <a16:creationId xmlns:a16="http://schemas.microsoft.com/office/drawing/2014/main" id="{06542707-B17B-4B98-B625-61020AC76186}"/>
               </a:ext>
             </a:extLst>
           </p:cNvPr>
@@ -6854,7 +7385,7 @@
           <p:cNvPr id="10" name="Clinical scope">
             <a:extLst xmlns:a="http://schemas.openxmlformats.org/drawingml/2006/main">
               <a:ext uri="{FF2B5EF4-FFF2-40B4-BE49-F238E27FC236}">
-                <a16:creationId xmlns:a16="http://schemas.microsoft.com/office/drawing/2014/main" id="{3553AE5D-CC73-4940-AC25-9A4E69F63497}"/>
+                <a16:creationId xmlns:a16="http://schemas.microsoft.com/office/drawing/2014/main" id="{F4651643-CE9F-4C16-81F0-B009634992A9}"/>
               </a:ext>
             </a:extLst>
           </p:cNvPr>
@@ -6910,479 +7441,6 @@
     <p:extLst>
       <p:ext uri="{BB962C8B-B14F-4D97-AF65-F5344CB8AC3E}">
         <p14:creationId xmlns:p14="http://schemas.microsoft.com/office/powerpoint/2010/main" val="1405124457"/>
-      </p:ext>
-    </p:extLst>
-  </p:cSld>
-</p:sld>
-</file>
-
-<file path=ppt/slides/slide6.xml><?xml version="1.0" encoding="utf-8"?>
-<p:sld xmlns:p="http://schemas.openxmlformats.org/presentationml/2006/main">
-  <p:cSld>
-    <p:bg>
-      <p:bgPr>
-        <a:solidFill xmlns:a="http://schemas.openxmlformats.org/drawingml/2006/main">
-          <a:srgbClr val="FCFAF4"/>
-        </a:solidFill>
-      </p:bgPr>
-    </p:bg>
-    <p:spTree>
-      <p:nvGrpSpPr>
-        <p:cNvPr id="1" name=""/>
-        <p:cNvGrpSpPr/>
-        <p:nvPr/>
-      </p:nvGrpSpPr>
-      <p:grpSpPr>
-        <a:xfrm xmlns:a="http://schemas.openxmlformats.org/drawingml/2006/main"/>
-      </p:grpSpPr>
-      <p:sp>
-        <p:nvSpPr>
-          <p:cNvPr id="10" name="Slide title">
-            <a:extLst xmlns:a="http://schemas.openxmlformats.org/drawingml/2006/main">
-              <a:ext uri="{FF2B5EF4-FFF2-40B4-BE49-F238E27FC236}">
-                <a16:creationId xmlns:a16="http://schemas.microsoft.com/office/drawing/2014/main" id="{1E9EF11D-75C8-4F85-8EFA-7827D85A75A8}"/>
-              </a:ext>
-            </a:extLst>
-          </p:cNvPr>
-          <p:cNvSpPr>
-            <a:spLocks xmlns:a="http://schemas.openxmlformats.org/drawingml/2006/main" noGrp="1"/>
-          </p:cNvSpPr>
-          <p:nvPr/>
-        </p:nvSpPr>
-        <p:spPr>
-          <a:xfrm xmlns:a="http://schemas.openxmlformats.org/drawingml/2006/main">
-            <a:off x="533400" y="361950"/>
-            <a:ext cx="11125200" cy="581025"/>
-          </a:xfrm>
-          <a:prstGeom xmlns:a="http://schemas.openxmlformats.org/drawingml/2006/main" prst="rect">
-            <a:avLst/>
-          </a:prstGeom>
-          <a:noFill xmlns:a="http://schemas.openxmlformats.org/drawingml/2006/main"/>
-          <a:ln xmlns:a="http://schemas.openxmlformats.org/drawingml/2006/main" w="0">
-            <a:noFill/>
-          </a:ln>
-        </p:spPr>
-        <p:txBody>
-          <a:bodyPr xmlns:a="http://schemas.openxmlformats.org/drawingml/2006/main" wrap="square" lIns="0" tIns="0" rIns="0" bIns="0">
-            <a:normAutofit fontScale="100000"/>
-          </a:bodyPr>
-          <a:lstStyle xmlns:a="http://schemas.openxmlformats.org/drawingml/2006/main"/>
-          <a:p xmlns:a="http://schemas.openxmlformats.org/drawingml/2006/main">
-            <a:pPr>
-              <a:defRPr sz="3000" b="1">
-                <a:solidFill>
-                  <a:srgbClr val="173F33"/>
-                </a:solidFill>
-                <a:latin typeface="Arial"/>
-                <a:ea typeface="Arial"/>
-                <a:cs typeface="Arial"/>
-              </a:defRPr>
-            </a:pPr>
-            <a:r>
-              <a:rPr sz="3000" b="1">
-                <a:solidFill>
-                  <a:srgbClr val="173F33"/>
-                </a:solidFill>
-                <a:latin typeface="Arial"/>
-                <a:ea typeface="Arial"/>
-                <a:cs typeface="Arial"/>
-              </a:rPr>
-              <a:t>Your care, medicines and help in one place.</a:t>
-            </a:r>
-          </a:p>
-        </p:txBody>
-      </p:sp>
-      <p:pic>
-        <p:nvPicPr>
-          <p:cNvPr id="11" name=""/>
-          <p:cNvPicPr>
-            <a:picLocks xmlns:a="http://schemas.openxmlformats.org/drawingml/2006/main" noChangeAspect="1"/>
-          </p:cNvPicPr>
-          <p:nvPr/>
-        </p:nvPicPr>
-        <p:blipFill>
-          <a:blip xmlns:r="http://schemas.openxmlformats.org/officeDocument/2006/relationships" xmlns:a="http://schemas.openxmlformats.org/drawingml/2006/main" r:embed="R857bef5b39344b3e"/>
-          <a:stretch xmlns:a="http://schemas.openxmlformats.org/drawingml/2006/main"/>
-        </p:blipFill>
-        <p:spPr>
-          <a:xfrm xmlns:a="http://schemas.openxmlformats.org/drawingml/2006/main">
-            <a:off x="273222" y="1066800"/>
-            <a:ext cx="8673757" cy="5067300"/>
-          </a:xfrm>
-          <a:prstGeom xmlns:a="http://schemas.openxmlformats.org/drawingml/2006/main" prst="rect">
-            <a:avLst/>
-          </a:prstGeom>
-        </p:spPr>
-      </p:pic>
-      <p:sp>
-        <p:nvSpPr>
-          <p:cNvPr id="3" name="Three sign-ins">
-            <a:extLst xmlns:a="http://schemas.openxmlformats.org/drawingml/2006/main">
-              <a:ext uri="{FF2B5EF4-FFF2-40B4-BE49-F238E27FC236}">
-                <a16:creationId xmlns:a16="http://schemas.microsoft.com/office/drawing/2014/main" id="{DE10829C-98BB-4B12-88B6-6339E26E3E93}"/>
-              </a:ext>
-            </a:extLst>
-          </p:cNvPr>
-          <p:cNvSpPr>
-            <a:spLocks xmlns:a="http://schemas.openxmlformats.org/drawingml/2006/main" noGrp="1"/>
-          </p:cNvSpPr>
-          <p:nvPr/>
-        </p:nvSpPr>
-        <p:spPr>
-          <a:xfrm xmlns:a="http://schemas.openxmlformats.org/drawingml/2006/main">
-            <a:off x="9296400" y="1076325"/>
-            <a:ext cx="2362200" cy="342900"/>
-          </a:xfrm>
-          <a:prstGeom xmlns:a="http://schemas.openxmlformats.org/drawingml/2006/main" prst="rect">
-            <a:avLst/>
-          </a:prstGeom>
-          <a:noFill xmlns:a="http://schemas.openxmlformats.org/drawingml/2006/main"/>
-          <a:ln xmlns:a="http://schemas.openxmlformats.org/drawingml/2006/main" w="0">
-            <a:noFill/>
-          </a:ln>
-        </p:spPr>
-        <p:txBody>
-          <a:bodyPr xmlns:a="http://schemas.openxmlformats.org/drawingml/2006/main" wrap="square" lIns="0" tIns="0" rIns="0" bIns="0">
-            <a:normAutofit fontScale="100000"/>
-          </a:bodyPr>
-          <a:lstStyle xmlns:a="http://schemas.openxmlformats.org/drawingml/2006/main"/>
-          <a:p xmlns:a="http://schemas.openxmlformats.org/drawingml/2006/main">
-            <a:pPr>
-              <a:defRPr sz="1875" b="1">
-                <a:solidFill>
-                  <a:srgbClr val="173F33"/>
-                </a:solidFill>
-                <a:latin typeface="Arial"/>
-                <a:ea typeface="Arial"/>
-                <a:cs typeface="Arial"/>
-              </a:defRPr>
-            </a:pPr>
-            <a:r>
-              <a:rPr sz="1875" b="1">
-                <a:solidFill>
-                  <a:srgbClr val="173F33"/>
-                </a:solidFill>
-                <a:latin typeface="Arial"/>
-                <a:ea typeface="Arial"/>
-                <a:cs typeface="Arial"/>
-              </a:rPr>
-              <a:t>Three sign-ins</a:t>
-            </a:r>
-          </a:p>
-        </p:txBody>
-      </p:sp>
-      <p:pic>
-        <p:nvPicPr>
-          <p:cNvPr id="13" name=""/>
-          <p:cNvPicPr>
-            <a:picLocks xmlns:a="http://schemas.openxmlformats.org/drawingml/2006/main" noChangeAspect="1"/>
-          </p:cNvPicPr>
-          <p:nvPr/>
-        </p:nvPicPr>
-        <p:blipFill>
-          <a:blip xmlns:r="http://schemas.openxmlformats.org/officeDocument/2006/relationships" xmlns:a="http://schemas.openxmlformats.org/drawingml/2006/main" r:embed="R4f7d4c11c4d24583"/>
-          <a:stretch xmlns:a="http://schemas.openxmlformats.org/drawingml/2006/main"/>
-        </p:blipFill>
-        <p:spPr>
-          <a:xfrm xmlns:a="http://schemas.openxmlformats.org/drawingml/2006/main">
-            <a:off x="9144000" y="1498066"/>
-            <a:ext cx="2514600" cy="2690293"/>
-          </a:xfrm>
-          <a:prstGeom xmlns:a="http://schemas.openxmlformats.org/drawingml/2006/main" prst="rect">
-            <a:avLst/>
-          </a:prstGeom>
-        </p:spPr>
-      </p:pic>
-      <p:sp>
-        <p:nvSpPr>
-          <p:cNvPr id="5" name="Patient role">
-            <a:extLst xmlns:a="http://schemas.openxmlformats.org/drawingml/2006/main">
-              <a:ext uri="{FF2B5EF4-FFF2-40B4-BE49-F238E27FC236}">
-                <a16:creationId xmlns:a16="http://schemas.microsoft.com/office/drawing/2014/main" id="{8689E2EB-57A0-42F3-8F44-F5E4AE2E9FFE}"/>
-              </a:ext>
-            </a:extLst>
-          </p:cNvPr>
-          <p:cNvSpPr>
-            <a:spLocks xmlns:a="http://schemas.openxmlformats.org/drawingml/2006/main" noGrp="1"/>
-          </p:cNvSpPr>
-          <p:nvPr/>
-        </p:nvSpPr>
-        <p:spPr>
-          <a:xfrm xmlns:a="http://schemas.openxmlformats.org/drawingml/2006/main">
-            <a:off x="9296400" y="4362450"/>
-            <a:ext cx="2362200" cy="304800"/>
-          </a:xfrm>
-          <a:prstGeom xmlns:a="http://schemas.openxmlformats.org/drawingml/2006/main" prst="rect">
-            <a:avLst/>
-          </a:prstGeom>
-          <a:noFill xmlns:a="http://schemas.openxmlformats.org/drawingml/2006/main"/>
-          <a:ln xmlns:a="http://schemas.openxmlformats.org/drawingml/2006/main" w="0">
-            <a:noFill/>
-          </a:ln>
-        </p:spPr>
-        <p:txBody>
-          <a:bodyPr xmlns:a="http://schemas.openxmlformats.org/drawingml/2006/main" wrap="square" lIns="0" tIns="0" rIns="0" bIns="0">
-            <a:normAutofit fontScale="100000"/>
-          </a:bodyPr>
-          <a:lstStyle xmlns:a="http://schemas.openxmlformats.org/drawingml/2006/main"/>
-          <a:p xmlns:a="http://schemas.openxmlformats.org/drawingml/2006/main">
-            <a:pPr>
-              <a:defRPr sz="1575" b="1">
-                <a:solidFill>
-                  <a:srgbClr val="157B68"/>
-                </a:solidFill>
-                <a:latin typeface="Arial"/>
-                <a:ea typeface="Arial"/>
-                <a:cs typeface="Arial"/>
-              </a:defRPr>
-            </a:pPr>
-            <a:r>
-              <a:rPr sz="1575" b="1">
-                <a:solidFill>
-                  <a:srgbClr val="157B68"/>
-                </a:solidFill>
-                <a:latin typeface="Arial"/>
-                <a:ea typeface="Arial"/>
-                <a:cs typeface="Arial"/>
-              </a:rPr>
-              <a:t>Patients see their care.</a:t>
-            </a:r>
-          </a:p>
-        </p:txBody>
-      </p:sp>
-      <p:sp>
-        <p:nvSpPr>
-          <p:cNvPr id="6" name="Family role">
-            <a:extLst xmlns:a="http://schemas.openxmlformats.org/drawingml/2006/main">
-              <a:ext uri="{FF2B5EF4-FFF2-40B4-BE49-F238E27FC236}">
-                <a16:creationId xmlns:a16="http://schemas.microsoft.com/office/drawing/2014/main" id="{777085A5-A05C-4320-B5E8-D2CBF79CF575}"/>
-              </a:ext>
-            </a:extLst>
-          </p:cNvPr>
-          <p:cNvSpPr>
-            <a:spLocks xmlns:a="http://schemas.openxmlformats.org/drawingml/2006/main" noGrp="1"/>
-          </p:cNvSpPr>
-          <p:nvPr/>
-        </p:nvSpPr>
-        <p:spPr>
-          <a:xfrm xmlns:a="http://schemas.openxmlformats.org/drawingml/2006/main">
-            <a:off x="9296400" y="4714875"/>
-            <a:ext cx="2362200" cy="304800"/>
-          </a:xfrm>
-          <a:prstGeom xmlns:a="http://schemas.openxmlformats.org/drawingml/2006/main" prst="rect">
-            <a:avLst/>
-          </a:prstGeom>
-          <a:noFill xmlns:a="http://schemas.openxmlformats.org/drawingml/2006/main"/>
-          <a:ln xmlns:a="http://schemas.openxmlformats.org/drawingml/2006/main" w="0">
-            <a:noFill/>
-          </a:ln>
-        </p:spPr>
-        <p:txBody>
-          <a:bodyPr xmlns:a="http://schemas.openxmlformats.org/drawingml/2006/main" wrap="square" lIns="0" tIns="0" rIns="0" bIns="0">
-            <a:normAutofit fontScale="100000"/>
-          </a:bodyPr>
-          <a:lstStyle xmlns:a="http://schemas.openxmlformats.org/drawingml/2006/main"/>
-          <a:p xmlns:a="http://schemas.openxmlformats.org/drawingml/2006/main">
-            <a:pPr>
-              <a:defRPr sz="1575" b="1">
-                <a:solidFill>
-                  <a:srgbClr val="7353AC"/>
-                </a:solidFill>
-                <a:latin typeface="Arial"/>
-                <a:ea typeface="Arial"/>
-                <a:cs typeface="Arial"/>
-              </a:defRPr>
-            </a:pPr>
-            <a:r>
-              <a:rPr sz="1575" b="1">
-                <a:solidFill>
-                  <a:srgbClr val="7353AC"/>
-                </a:solidFill>
-                <a:latin typeface="Arial"/>
-                <a:ea typeface="Arial"/>
-                <a:cs typeface="Arial"/>
-              </a:rPr>
-              <a:t>Families organise help.</a:t>
-            </a:r>
-          </a:p>
-        </p:txBody>
-      </p:sp>
-      <p:sp>
-        <p:nvSpPr>
-          <p:cNvPr id="7" name="Doctor role">
-            <a:extLst xmlns:a="http://schemas.openxmlformats.org/drawingml/2006/main">
-              <a:ext uri="{FF2B5EF4-FFF2-40B4-BE49-F238E27FC236}">
-                <a16:creationId xmlns:a16="http://schemas.microsoft.com/office/drawing/2014/main" id="{F7E42846-4F2F-489D-B612-6330DB0FD1E2}"/>
-              </a:ext>
-            </a:extLst>
-          </p:cNvPr>
-          <p:cNvSpPr>
-            <a:spLocks xmlns:a="http://schemas.openxmlformats.org/drawingml/2006/main" noGrp="1"/>
-          </p:cNvSpPr>
-          <p:nvPr/>
-        </p:nvSpPr>
-        <p:spPr>
-          <a:xfrm xmlns:a="http://schemas.openxmlformats.org/drawingml/2006/main">
-            <a:off x="9296400" y="5067300"/>
-            <a:ext cx="2362200" cy="304800"/>
-          </a:xfrm>
-          <a:prstGeom xmlns:a="http://schemas.openxmlformats.org/drawingml/2006/main" prst="rect">
-            <a:avLst/>
-          </a:prstGeom>
-          <a:noFill xmlns:a="http://schemas.openxmlformats.org/drawingml/2006/main"/>
-          <a:ln xmlns:a="http://schemas.openxmlformats.org/drawingml/2006/main" w="0">
-            <a:noFill/>
-          </a:ln>
-        </p:spPr>
-        <p:txBody>
-          <a:bodyPr xmlns:a="http://schemas.openxmlformats.org/drawingml/2006/main" wrap="square" lIns="0" tIns="0" rIns="0" bIns="0">
-            <a:normAutofit fontScale="99374"/>
-          </a:bodyPr>
-          <a:lstStyle xmlns:a="http://schemas.openxmlformats.org/drawingml/2006/main"/>
-          <a:p xmlns:a="http://schemas.openxmlformats.org/drawingml/2006/main">
-            <a:pPr>
-              <a:defRPr sz="1575" b="1">
-                <a:solidFill>
-                  <a:srgbClr val="B75E43"/>
-                </a:solidFill>
-                <a:latin typeface="Arial"/>
-                <a:ea typeface="Arial"/>
-                <a:cs typeface="Arial"/>
-              </a:defRPr>
-            </a:pPr>
-            <a:r>
-              <a:rPr sz="1575" b="1">
-                <a:solidFill>
-                  <a:srgbClr val="B75E43"/>
-                </a:solidFill>
-                <a:latin typeface="Arial"/>
-                <a:ea typeface="Arial"/>
-                <a:cs typeface="Arial"/>
-              </a:rPr>
-              <a:t>Doctors review and sign.</a:t>
-            </a:r>
-          </a:p>
-        </p:txBody>
-      </p:sp>
-      <p:sp>
-        <p:nvSpPr>
-          <p:cNvPr id="8" name="Practical family support">
-            <a:extLst xmlns:a="http://schemas.openxmlformats.org/drawingml/2006/main">
-              <a:ext uri="{FF2B5EF4-FFF2-40B4-BE49-F238E27FC236}">
-                <a16:creationId xmlns:a16="http://schemas.microsoft.com/office/drawing/2014/main" id="{69033310-A3F1-4208-8E63-F24E6B178FA9}"/>
-              </a:ext>
-            </a:extLst>
-          </p:cNvPr>
-          <p:cNvSpPr>
-            <a:spLocks xmlns:a="http://schemas.openxmlformats.org/drawingml/2006/main" noGrp="1"/>
-          </p:cNvSpPr>
-          <p:nvPr/>
-        </p:nvSpPr>
-        <p:spPr>
-          <a:xfrm xmlns:a="http://schemas.openxmlformats.org/drawingml/2006/main">
-            <a:off x="9296400" y="5486400"/>
-            <a:ext cx="2362200" cy="895350"/>
-          </a:xfrm>
-          <a:prstGeom xmlns:a="http://schemas.openxmlformats.org/drawingml/2006/main" prst="rect">
-            <a:avLst/>
-          </a:prstGeom>
-          <a:noFill xmlns:a="http://schemas.openxmlformats.org/drawingml/2006/main"/>
-          <a:ln xmlns:a="http://schemas.openxmlformats.org/drawingml/2006/main" w="0">
-            <a:noFill/>
-          </a:ln>
-        </p:spPr>
-        <p:txBody>
-          <a:bodyPr xmlns:a="http://schemas.openxmlformats.org/drawingml/2006/main" wrap="square" lIns="0" tIns="0" rIns="0" bIns="0">
-            <a:normAutofit fontScale="100000"/>
-          </a:bodyPr>
-          <a:lstStyle xmlns:a="http://schemas.openxmlformats.org/drawingml/2006/main"/>
-          <a:p xmlns:a="http://schemas.openxmlformats.org/drawingml/2006/main">
-            <a:pPr>
-              <a:defRPr sz="1388" b="0">
-                <a:solidFill>
-                  <a:srgbClr val="173F33"/>
-                </a:solidFill>
-                <a:latin typeface="Arial"/>
-                <a:ea typeface="Arial"/>
-                <a:cs typeface="Arial"/>
-              </a:defRPr>
-            </a:pPr>
-            <a:r>
-              <a:rPr sz="1388" b="0">
-                <a:solidFill>
-                  <a:srgbClr val="173F33"/>
-                </a:solidFill>
-                <a:latin typeface="Arial"/>
-                <a:ea typeface="Arial"/>
-                <a:cs typeface="Arial"/>
-              </a:rPr>
-              <a:t>Plan rides and home support. Keep medicine calls, costs, paperwork and emotional support together.</a:t>
-            </a:r>
-          </a:p>
-        </p:txBody>
-      </p:sp>
-      <p:sp>
-        <p:nvSpPr>
-          <p:cNvPr id="9" name="Support directory">
-            <a:extLst xmlns:a="http://schemas.openxmlformats.org/drawingml/2006/main">
-              <a:ext uri="{FF2B5EF4-FFF2-40B4-BE49-F238E27FC236}">
-                <a16:creationId xmlns:a16="http://schemas.microsoft.com/office/drawing/2014/main" id="{636DCA4F-38D1-496B-8FEC-377B0A9683BB}"/>
-              </a:ext>
-            </a:extLst>
-          </p:cNvPr>
-          <p:cNvSpPr>
-            <a:spLocks xmlns:a="http://schemas.openxmlformats.org/drawingml/2006/main" noGrp="1"/>
-          </p:cNvSpPr>
-          <p:nvPr/>
-        </p:nvSpPr>
-        <p:spPr>
-          <a:xfrm xmlns:a="http://schemas.openxmlformats.org/drawingml/2006/main">
-            <a:off x="533400" y="6505575"/>
-            <a:ext cx="11125200" cy="238125"/>
-          </a:xfrm>
-          <a:prstGeom xmlns:a="http://schemas.openxmlformats.org/drawingml/2006/main" prst="rect">
-            <a:avLst/>
-          </a:prstGeom>
-          <a:noFill xmlns:a="http://schemas.openxmlformats.org/drawingml/2006/main"/>
-          <a:ln xmlns:a="http://schemas.openxmlformats.org/drawingml/2006/main" w="0">
-            <a:noFill/>
-          </a:ln>
-        </p:spPr>
-        <p:txBody>
-          <a:bodyPr xmlns:a="http://schemas.openxmlformats.org/drawingml/2006/main" wrap="square" lIns="0" tIns="0" rIns="0" bIns="0">
-            <a:normAutofit fontScale="100000"/>
-          </a:bodyPr>
-          <a:lstStyle xmlns:a="http://schemas.openxmlformats.org/drawingml/2006/main"/>
-          <a:p xmlns:a="http://schemas.openxmlformats.org/drawingml/2006/main">
-            <a:pPr>
-              <a:defRPr sz="1425" b="0">
-                <a:solidFill>
-                  <a:srgbClr val="145AC6"/>
-                </a:solidFill>
-                <a:latin typeface="Arial"/>
-                <a:ea typeface="Arial"/>
-                <a:cs typeface="Arial"/>
-              </a:defRPr>
-            </a:pPr>
-            <a:r>
-              <a:rPr sz="1425" b="0" u="sng">
-                <a:solidFill>
-                  <a:srgbClr val="145AC6"/>
-                </a:solidFill>
-                <a:latin typeface="Arial"/>
-                <a:ea typeface="Arial"/>
-                <a:cs typeface="Arial"/>
-                <a:hlinkClick xmlns:r="http://schemas.openxmlformats.org/officeDocument/2006/relationships" r:id="Rc8c6314cc1124592"/>
-              </a:rPr>
-              <a:t>Find a centre → call to confirm → keep the contact and visit plan.</a:t>
-            </a:r>
-          </a:p>
-        </p:txBody>
-      </p:sp>
-    </p:spTree>
-    <p:extLst>
-      <p:ext uri="{BB962C8B-B14F-4D97-AF65-F5344CB8AC3E}">
-        <p14:creationId xmlns:p14="http://schemas.microsoft.com/office/powerpoint/2010/main" val="221085739"/>
       </p:ext>
     </p:extLst>
   </p:cSld>
@@ -7413,7 +7471,7 @@
           <p:cNvPr id="14" name="Slide title">
             <a:extLst xmlns:a="http://schemas.openxmlformats.org/drawingml/2006/main">
               <a:ext uri="{FF2B5EF4-FFF2-40B4-BE49-F238E27FC236}">
-                <a16:creationId xmlns:a16="http://schemas.microsoft.com/office/drawing/2014/main" id="{9F300948-0F6C-46DA-93EF-8875DD1333F8}"/>
+                <a16:creationId xmlns:a16="http://schemas.microsoft.com/office/drawing/2014/main" id="{E8236332-8D13-4DA0-BFAA-07C4798D91C3}"/>
               </a:ext>
             </a:extLst>
           </p:cNvPr>
@@ -7470,7 +7528,7 @@
           <p:cNvPr id="2" name="Trial design">
             <a:extLst xmlns:a="http://schemas.openxmlformats.org/drawingml/2006/main">
               <a:ext uri="{FF2B5EF4-FFF2-40B4-BE49-F238E27FC236}">
-                <a16:creationId xmlns:a16="http://schemas.microsoft.com/office/drawing/2014/main" id="{6DECE32F-0F87-4BAD-BD3A-6A7E5F8A5F97}"/>
+                <a16:creationId xmlns:a16="http://schemas.microsoft.com/office/drawing/2014/main" id="{0C854B8C-F98D-4D31-981C-5A1547012839}"/>
               </a:ext>
             </a:extLst>
           </p:cNvPr>
@@ -7527,7 +7585,7 @@
           <p:cNvPr id="3" name="Primary measure 1">
             <a:extLst xmlns:a="http://schemas.openxmlformats.org/drawingml/2006/main">
               <a:ext uri="{FF2B5EF4-FFF2-40B4-BE49-F238E27FC236}">
-                <a16:creationId xmlns:a16="http://schemas.microsoft.com/office/drawing/2014/main" id="{73901517-188E-484C-961A-EC921A20EC5E}"/>
+                <a16:creationId xmlns:a16="http://schemas.microsoft.com/office/drawing/2014/main" id="{A9291487-4346-4063-A246-2F8226C25597}"/>
               </a:ext>
             </a:extLst>
           </p:cNvPr>
@@ -7584,7 +7642,7 @@
           <p:cNvPr id="4" name="Primary measure 1 detail">
             <a:extLst xmlns:a="http://schemas.openxmlformats.org/drawingml/2006/main">
               <a:ext uri="{FF2B5EF4-FFF2-40B4-BE49-F238E27FC236}">
-                <a16:creationId xmlns:a16="http://schemas.microsoft.com/office/drawing/2014/main" id="{EB61BFDB-357C-47D6-8CFD-0ACD2D7FF034}"/>
+                <a16:creationId xmlns:a16="http://schemas.microsoft.com/office/drawing/2014/main" id="{C456B535-8E21-417C-BF95-D1C2232AFDE4}"/>
               </a:ext>
             </a:extLst>
           </p:cNvPr>
@@ -7641,7 +7699,7 @@
           <p:cNvPr id="5" name="Primary measure 2">
             <a:extLst xmlns:a="http://schemas.openxmlformats.org/drawingml/2006/main">
               <a:ext uri="{FF2B5EF4-FFF2-40B4-BE49-F238E27FC236}">
-                <a16:creationId xmlns:a16="http://schemas.microsoft.com/office/drawing/2014/main" id="{14FAAB55-52B5-496B-A355-E057DEDD0936}"/>
+                <a16:creationId xmlns:a16="http://schemas.microsoft.com/office/drawing/2014/main" id="{1E22CEB3-5269-4DEE-9B65-03DC1216C70E}"/>
               </a:ext>
             </a:extLst>
           </p:cNvPr>
@@ -7698,7 +7756,7 @@
           <p:cNvPr id="6" name="Primary measure 2 detail">
             <a:extLst xmlns:a="http://schemas.openxmlformats.org/drawingml/2006/main">
               <a:ext uri="{FF2B5EF4-FFF2-40B4-BE49-F238E27FC236}">
-                <a16:creationId xmlns:a16="http://schemas.microsoft.com/office/drawing/2014/main" id="{3FA06113-238F-4509-BDB5-30BD6D93D36C}"/>
+                <a16:creationId xmlns:a16="http://schemas.microsoft.com/office/drawing/2014/main" id="{DCE626EC-779F-4249-9F98-4C777FA1C15F}"/>
               </a:ext>
             </a:extLst>
           </p:cNvPr>
@@ -7755,7 +7813,7 @@
           <p:cNvPr id="7" name="Primary measure 3">
             <a:extLst xmlns:a="http://schemas.openxmlformats.org/drawingml/2006/main">
               <a:ext uri="{FF2B5EF4-FFF2-40B4-BE49-F238E27FC236}">
-                <a16:creationId xmlns:a16="http://schemas.microsoft.com/office/drawing/2014/main" id="{ADA60C8C-33DD-499A-B9FB-00B21A534308}"/>
+                <a16:creationId xmlns:a16="http://schemas.microsoft.com/office/drawing/2014/main" id="{AFD233C2-8414-4AC2-9451-8402D7AEC6A4}"/>
               </a:ext>
             </a:extLst>
           </p:cNvPr>
@@ -7812,7 +7870,7 @@
           <p:cNvPr id="8" name="Primary measure 3 detail">
             <a:extLst xmlns:a="http://schemas.openxmlformats.org/drawingml/2006/main">
               <a:ext uri="{FF2B5EF4-FFF2-40B4-BE49-F238E27FC236}">
-                <a16:creationId xmlns:a16="http://schemas.microsoft.com/office/drawing/2014/main" id="{BC1228A3-5843-424E-A1F3-E676EFDCA198}"/>
+                <a16:creationId xmlns:a16="http://schemas.microsoft.com/office/drawing/2014/main" id="{CA55EEA7-7BE3-44C1-BBF1-E35B478862CF}"/>
               </a:ext>
             </a:extLst>
           </p:cNvPr>
@@ -7869,7 +7927,7 @@
           <p:cNvPr id="9" name="">
             <a:extLst xmlns:a="http://schemas.openxmlformats.org/drawingml/2006/main">
               <a:ext uri="{FF2B5EF4-FFF2-40B4-BE49-F238E27FC236}">
-                <a16:creationId xmlns:a16="http://schemas.microsoft.com/office/drawing/2014/main" id="{BA670816-D678-4166-8007-5482C5C0A491}"/>
+                <a16:creationId xmlns:a16="http://schemas.microsoft.com/office/drawing/2014/main" id="{6377A37F-2F23-46CB-9DDA-64DA458C9E0D}"/>
               </a:ext>
             </a:extLst>
           </p:cNvPr>
@@ -7898,7 +7956,7 @@
           <p:cNvPr id="10" name="Comparison">
             <a:extLst xmlns:a="http://schemas.openxmlformats.org/drawingml/2006/main">
               <a:ext uri="{FF2B5EF4-FFF2-40B4-BE49-F238E27FC236}">
-                <a16:creationId xmlns:a16="http://schemas.microsoft.com/office/drawing/2014/main" id="{88CFEFDB-9923-4112-B129-07466B8B74CD}"/>
+                <a16:creationId xmlns:a16="http://schemas.microsoft.com/office/drawing/2014/main" id="{CC91C6E2-4DFF-46F1-B51F-92682D6EBE77}"/>
               </a:ext>
             </a:extLst>
           </p:cNvPr>
@@ -7955,7 +8013,7 @@
           <p:cNvPr id="11" name="Primary outcome definition">
             <a:extLst xmlns:a="http://schemas.openxmlformats.org/drawingml/2006/main">
               <a:ext uri="{FF2B5EF4-FFF2-40B4-BE49-F238E27FC236}">
-                <a16:creationId xmlns:a16="http://schemas.microsoft.com/office/drawing/2014/main" id="{82DF7373-0174-4F6E-9EF0-A34769D453C2}"/>
+                <a16:creationId xmlns:a16="http://schemas.microsoft.com/office/drawing/2014/main" id="{65DCC58E-0DCC-4C47-B3B4-0390D93B7EC4}"/>
               </a:ext>
             </a:extLst>
           </p:cNvPr>
@@ -8012,7 +8070,7 @@
           <p:cNvPr id="12" name="Additional measures">
             <a:extLst xmlns:a="http://schemas.openxmlformats.org/drawingml/2006/main">
               <a:ext uri="{FF2B5EF4-FFF2-40B4-BE49-F238E27FC236}">
-                <a16:creationId xmlns:a16="http://schemas.microsoft.com/office/drawing/2014/main" id="{158E78D2-CD01-4DF7-B6C2-78B170EBAEDE}"/>
+                <a16:creationId xmlns:a16="http://schemas.microsoft.com/office/drawing/2014/main" id="{DA02E18E-454C-4CA2-BF3C-4386F1942029}"/>
               </a:ext>
             </a:extLst>
           </p:cNvPr>
@@ -8069,7 +8127,7 @@
           <p:cNvPr id="13" name="Implementation status">
             <a:extLst xmlns:a="http://schemas.openxmlformats.org/drawingml/2006/main">
               <a:ext uri="{FF2B5EF4-FFF2-40B4-BE49-F238E27FC236}">
-                <a16:creationId xmlns:a16="http://schemas.microsoft.com/office/drawing/2014/main" id="{3ED110BE-FC3E-49C3-AE74-C01E7F2096E6}"/>
+                <a16:creationId xmlns:a16="http://schemas.microsoft.com/office/drawing/2014/main" id="{1D772724-F102-4577-87DB-1C45101DD3FA}"/>
               </a:ext>
             </a:extLst>
           </p:cNvPr>
@@ -8155,7 +8213,7 @@
           <p:cNvPr id="31" name="References title">
             <a:extLst xmlns:a="http://schemas.openxmlformats.org/drawingml/2006/main">
               <a:ext uri="{FF2B5EF4-FFF2-40B4-BE49-F238E27FC236}">
-                <a16:creationId xmlns:a16="http://schemas.microsoft.com/office/drawing/2014/main" id="{0738B670-43D6-4F92-998C-D8641C3CA9B7}"/>
+                <a16:creationId xmlns:a16="http://schemas.microsoft.com/office/drawing/2014/main" id="{64856C7A-8805-47F8-AD3E-895037FC4B58}"/>
               </a:ext>
             </a:extLst>
           </p:cNvPr>
@@ -8212,7 +8270,7 @@
           <p:cNvPr id="2" name="References one to four">
             <a:extLst xmlns:a="http://schemas.openxmlformats.org/drawingml/2006/main">
               <a:ext uri="{FF2B5EF4-FFF2-40B4-BE49-F238E27FC236}">
-                <a16:creationId xmlns:a16="http://schemas.microsoft.com/office/drawing/2014/main" id="{B1FBFF19-AAED-4C1C-BF16-145DE03CD865}"/>
+                <a16:creationId xmlns:a16="http://schemas.microsoft.com/office/drawing/2014/main" id="{235B16A1-709E-49C0-ADB7-7E148B619924}"/>
               </a:ext>
             </a:extLst>
           </p:cNvPr>
@@ -8242,7 +8300,7 @@
           <p:cNvPr id="3" name="References five to nine">
             <a:extLst xmlns:a="http://schemas.openxmlformats.org/drawingml/2006/main">
               <a:ext uri="{FF2B5EF4-FFF2-40B4-BE49-F238E27FC236}">
-                <a16:creationId xmlns:a16="http://schemas.microsoft.com/office/drawing/2014/main" id="{241FA1F6-6B42-42CA-9B84-F651CB10A166}"/>
+                <a16:creationId xmlns:a16="http://schemas.microsoft.com/office/drawing/2014/main" id="{2D997F53-EE29-48CC-B526-00A3C12DA9F8}"/>
               </a:ext>
             </a:extLst>
           </p:cNvPr>
@@ -8272,7 +8330,7 @@
           <p:cNvPr id="4" name="Reference 1 author">
             <a:extLst xmlns:a="http://schemas.openxmlformats.org/drawingml/2006/main">
               <a:ext uri="{FF2B5EF4-FFF2-40B4-BE49-F238E27FC236}">
-                <a16:creationId xmlns:a16="http://schemas.microsoft.com/office/drawing/2014/main" id="{A9176D11-52DA-42F5-A861-10FCF18848FF}"/>
+                <a16:creationId xmlns:a16="http://schemas.microsoft.com/office/drawing/2014/main" id="{6D918FBA-9736-468F-B6EF-6C1482DC93A7}"/>
               </a:ext>
             </a:extLst>
           </p:cNvPr>
@@ -8329,7 +8387,7 @@
           <p:cNvPr id="5" name="Reference 1 title">
             <a:extLst xmlns:a="http://schemas.openxmlformats.org/drawingml/2006/main">
               <a:ext uri="{FF2B5EF4-FFF2-40B4-BE49-F238E27FC236}">
-                <a16:creationId xmlns:a16="http://schemas.microsoft.com/office/drawing/2014/main" id="{0F9DCD40-DC9E-47A1-B712-95A8080C1412}"/>
+                <a16:creationId xmlns:a16="http://schemas.microsoft.com/office/drawing/2014/main" id="{DD693854-9C39-4311-9FE8-E003813F63A6}"/>
               </a:ext>
             </a:extLst>
           </p:cNvPr>
@@ -8375,7 +8433,7 @@
                 <a:latin typeface="Arial"/>
                 <a:ea typeface="Arial"/>
                 <a:cs typeface="Arial"/>
-                <a:hlinkClick xmlns:r="http://schemas.openxmlformats.org/officeDocument/2006/relationships" r:id="Rafa12fa26a604caa"/>
+                <a:hlinkClick xmlns:r="http://schemas.openxmlformats.org/officeDocument/2006/relationships" r:id="Rb7cd7ff0cdae4be5"/>
               </a:rPr>
               <a:t>India: GLOBOCAN 2024 Fact Sheet</a:t>
             </a:r>
@@ -8387,7 +8445,7 @@
           <p:cNvPr id="6" name="Reference 1 link">
             <a:extLst xmlns:a="http://schemas.openxmlformats.org/drawingml/2006/main">
               <a:ext uri="{FF2B5EF4-FFF2-40B4-BE49-F238E27FC236}">
-                <a16:creationId xmlns:a16="http://schemas.microsoft.com/office/drawing/2014/main" id="{60AAA8B2-C251-41D6-B543-96A650440675}"/>
+                <a16:creationId xmlns:a16="http://schemas.microsoft.com/office/drawing/2014/main" id="{C6B58B15-B33A-4094-95CB-EC4F45A24309}"/>
               </a:ext>
             </a:extLst>
           </p:cNvPr>
@@ -8433,7 +8491,7 @@
                 <a:latin typeface="Arial"/>
                 <a:ea typeface="Arial"/>
                 <a:cs typeface="Arial"/>
-                <a:hlinkClick xmlns:r="http://schemas.openxmlformats.org/officeDocument/2006/relationships" r:id="R1eade76f163a45fc"/>
+                <a:hlinkClick xmlns:r="http://schemas.openxmlformats.org/officeDocument/2006/relationships" r:id="Rb789ef3b45e74ad8"/>
               </a:rPr>
               <a:t>https://gco.iarc.who.int/media/globocan/factsheets/populations/356-india-fact-sheet.pdf</a:t>
             </a:r>
@@ -8445,7 +8503,7 @@
           <p:cNvPr id="7" name="Reference 2 author">
             <a:extLst xmlns:a="http://schemas.openxmlformats.org/drawingml/2006/main">
               <a:ext uri="{FF2B5EF4-FFF2-40B4-BE49-F238E27FC236}">
-                <a16:creationId xmlns:a16="http://schemas.microsoft.com/office/drawing/2014/main" id="{4F5BF9B8-6EB2-434E-8BFB-BAD9DDDE8758}"/>
+                <a16:creationId xmlns:a16="http://schemas.microsoft.com/office/drawing/2014/main" id="{ED908D20-4B37-428C-B25D-3C1F1F633D34}"/>
               </a:ext>
             </a:extLst>
           </p:cNvPr>
@@ -8502,7 +8560,7 @@
           <p:cNvPr id="8" name="Reference 2 title">
             <a:extLst xmlns:a="http://schemas.openxmlformats.org/drawingml/2006/main">
               <a:ext uri="{FF2B5EF4-FFF2-40B4-BE49-F238E27FC236}">
-                <a16:creationId xmlns:a16="http://schemas.microsoft.com/office/drawing/2014/main" id="{AFCEB877-B6FC-47EE-B0F6-4C2D152BCF27}"/>
+                <a16:creationId xmlns:a16="http://schemas.microsoft.com/office/drawing/2014/main" id="{8BCCB934-A8C4-4A31-BB72-EF47FE72C19B}"/>
               </a:ext>
             </a:extLst>
           </p:cNvPr>
@@ -8548,7 +8606,7 @@
                 <a:latin typeface="Arial"/>
                 <a:ea typeface="Arial"/>
                 <a:cs typeface="Arial"/>
-                <a:hlinkClick xmlns:r="http://schemas.openxmlformats.org/officeDocument/2006/relationships" r:id="R10fe587b7af645e6"/>
+                <a:hlinkClick xmlns:r="http://schemas.openxmlformats.org/officeDocument/2006/relationships" r:id="R26ab7d4d2286421d"/>
               </a:rPr>
               <a:t>Unmet need for cancer palliative care in India</a:t>
             </a:r>
@@ -8560,7 +8618,7 @@
           <p:cNvPr id="9" name="Reference 2 link">
             <a:extLst xmlns:a="http://schemas.openxmlformats.org/drawingml/2006/main">
               <a:ext uri="{FF2B5EF4-FFF2-40B4-BE49-F238E27FC236}">
-                <a16:creationId xmlns:a16="http://schemas.microsoft.com/office/drawing/2014/main" id="{E5B97C81-8914-4316-A18B-5CC918703A6B}"/>
+                <a16:creationId xmlns:a16="http://schemas.microsoft.com/office/drawing/2014/main" id="{1A693860-E7D1-468F-B0A2-B520ABD2CFBA}"/>
               </a:ext>
             </a:extLst>
           </p:cNvPr>
@@ -8606,7 +8664,7 @@
                 <a:latin typeface="Arial"/>
                 <a:ea typeface="Arial"/>
                 <a:cs typeface="Arial"/>
-                <a:hlinkClick xmlns:r="http://schemas.openxmlformats.org/officeDocument/2006/relationships" r:id="Rd6f82230d975412d"/>
+                <a:hlinkClick xmlns:r="http://schemas.openxmlformats.org/officeDocument/2006/relationships" r:id="Ra7769f711b8b45af"/>
               </a:rPr>
               <a:t>https://doi.org/10.1136/spcare-2024-004978</a:t>
             </a:r>
@@ -8618,7 +8676,7 @@
           <p:cNvPr id="10" name="Reference 3 author">
             <a:extLst xmlns:a="http://schemas.openxmlformats.org/drawingml/2006/main">
               <a:ext uri="{FF2B5EF4-FFF2-40B4-BE49-F238E27FC236}">
-                <a16:creationId xmlns:a16="http://schemas.microsoft.com/office/drawing/2014/main" id="{F782BC5B-FB03-48AF-9BCF-15CDEBD6EA36}"/>
+                <a16:creationId xmlns:a16="http://schemas.microsoft.com/office/drawing/2014/main" id="{74170842-EE59-4CE1-B5C6-4FE9BC8E9525}"/>
               </a:ext>
             </a:extLst>
           </p:cNvPr>
@@ -8675,7 +8733,7 @@
           <p:cNvPr id="11" name="Reference 3 title">
             <a:extLst xmlns:a="http://schemas.openxmlformats.org/drawingml/2006/main">
               <a:ext uri="{FF2B5EF4-FFF2-40B4-BE49-F238E27FC236}">
-                <a16:creationId xmlns:a16="http://schemas.microsoft.com/office/drawing/2014/main" id="{53EE8E24-F19F-4FDC-92F3-264C2289658C}"/>
+                <a16:creationId xmlns:a16="http://schemas.microsoft.com/office/drawing/2014/main" id="{D54445DC-9081-49E3-8925-5216BC5EB955}"/>
               </a:ext>
             </a:extLst>
           </p:cNvPr>
@@ -8721,7 +8779,7 @@
                 <a:latin typeface="Arial"/>
                 <a:ea typeface="Arial"/>
                 <a:cs typeface="Arial"/>
-                <a:hlinkClick xmlns:r="http://schemas.openxmlformats.org/officeDocument/2006/relationships" r:id="R6cea0745839b4cba"/>
+                <a:hlinkClick xmlns:r="http://schemas.openxmlformats.org/officeDocument/2006/relationships" r:id="Re66e18913136486e"/>
               </a:rPr>
               <a:t>Early Goal of Care Discussions in Healthcare: A Survey Case Report on Benefits and Perceptions</a:t>
             </a:r>
@@ -8733,7 +8791,7 @@
           <p:cNvPr id="12" name="Reference 3 link">
             <a:extLst xmlns:a="http://schemas.openxmlformats.org/drawingml/2006/main">
               <a:ext uri="{FF2B5EF4-FFF2-40B4-BE49-F238E27FC236}">
-                <a16:creationId xmlns:a16="http://schemas.microsoft.com/office/drawing/2014/main" id="{C7F86AB5-0D78-4B7A-AB06-DE2231E298CF}"/>
+                <a16:creationId xmlns:a16="http://schemas.microsoft.com/office/drawing/2014/main" id="{9D6B862D-D2C4-4461-939E-DC4E6481FB0A}"/>
               </a:ext>
             </a:extLst>
           </p:cNvPr>
@@ -8779,7 +8837,7 @@
                 <a:latin typeface="Arial"/>
                 <a:ea typeface="Arial"/>
                 <a:cs typeface="Arial"/>
-                <a:hlinkClick xmlns:r="http://schemas.openxmlformats.org/officeDocument/2006/relationships" r:id="R828d5cc75a484ce5"/>
+                <a:hlinkClick xmlns:r="http://schemas.openxmlformats.org/officeDocument/2006/relationships" r:id="R251c402cc7784cde"/>
               </a:rPr>
               <a:t>https://doi.org/10.1016/j.jpainsymman.2024.02.030</a:t>
             </a:r>
@@ -8791,7 +8849,7 @@
           <p:cNvPr id="13" name="Reference 4 author">
             <a:extLst xmlns:a="http://schemas.openxmlformats.org/drawingml/2006/main">
               <a:ext uri="{FF2B5EF4-FFF2-40B4-BE49-F238E27FC236}">
-                <a16:creationId xmlns:a16="http://schemas.microsoft.com/office/drawing/2014/main" id="{170720D0-E769-46B4-9D55-22A9EC224C05}"/>
+                <a16:creationId xmlns:a16="http://schemas.microsoft.com/office/drawing/2014/main" id="{F0155441-1E6B-4CCE-9ED9-F6A20CD9FB83}"/>
               </a:ext>
             </a:extLst>
           </p:cNvPr>
@@ -8848,7 +8906,7 @@
           <p:cNvPr id="14" name="Reference 4 title">
             <a:extLst xmlns:a="http://schemas.openxmlformats.org/drawingml/2006/main">
               <a:ext uri="{FF2B5EF4-FFF2-40B4-BE49-F238E27FC236}">
-                <a16:creationId xmlns:a16="http://schemas.microsoft.com/office/drawing/2014/main" id="{0B0C3A09-E5B9-4A9F-8106-928D49583A33}"/>
+                <a16:creationId xmlns:a16="http://schemas.microsoft.com/office/drawing/2014/main" id="{246097F6-78B4-4B51-8A40-056D94F2CF13}"/>
               </a:ext>
             </a:extLst>
           </p:cNvPr>
@@ -8894,7 +8952,7 @@
                 <a:latin typeface="Arial"/>
                 <a:ea typeface="Arial"/>
                 <a:cs typeface="Arial"/>
-                <a:hlinkClick xmlns:r="http://schemas.openxmlformats.org/officeDocument/2006/relationships" r:id="R8f3cde6e33274fa1"/>
+                <a:hlinkClick xmlns:r="http://schemas.openxmlformats.org/officeDocument/2006/relationships" r:id="R269f695015ba40e5"/>
               </a:rPr>
               <a:t>Initiating and Documenting Goals of Care Discussion in Patients with Advanced Pancreatic and Colorectal Cancers: A Quality Improvement Project in a Low Resource Setting</a:t>
             </a:r>
@@ -8906,7 +8964,7 @@
           <p:cNvPr id="15" name="Reference 4 link">
             <a:extLst xmlns:a="http://schemas.openxmlformats.org/drawingml/2006/main">
               <a:ext uri="{FF2B5EF4-FFF2-40B4-BE49-F238E27FC236}">
-                <a16:creationId xmlns:a16="http://schemas.microsoft.com/office/drawing/2014/main" id="{72252E1C-EB71-4D9B-B085-83D284771A3F}"/>
+                <a16:creationId xmlns:a16="http://schemas.microsoft.com/office/drawing/2014/main" id="{0808695F-7608-4DE5-AAF3-3C1032CEDAD3}"/>
               </a:ext>
             </a:extLst>
           </p:cNvPr>
@@ -8952,7 +9010,7 @@
                 <a:latin typeface="Arial"/>
                 <a:ea typeface="Arial"/>
                 <a:cs typeface="Arial"/>
-                <a:hlinkClick xmlns:r="http://schemas.openxmlformats.org/officeDocument/2006/relationships" r:id="R8813362111c44402"/>
+                <a:hlinkClick xmlns:r="http://schemas.openxmlformats.org/officeDocument/2006/relationships" r:id="Rf2d16b71274e47e6"/>
               </a:rPr>
               <a:t>https://doi.org/10.1177/26892820251392545</a:t>
             </a:r>
@@ -8964,7 +9022,7 @@
           <p:cNvPr id="16" name="Reference 5 author">
             <a:extLst xmlns:a="http://schemas.openxmlformats.org/drawingml/2006/main">
               <a:ext uri="{FF2B5EF4-FFF2-40B4-BE49-F238E27FC236}">
-                <a16:creationId xmlns:a16="http://schemas.microsoft.com/office/drawing/2014/main" id="{04AC6D2E-3015-4672-BD13-FB829A8B7E06}"/>
+                <a16:creationId xmlns:a16="http://schemas.microsoft.com/office/drawing/2014/main" id="{800F2E48-2469-4858-9FD6-BB952F1C1101}"/>
               </a:ext>
             </a:extLst>
           </p:cNvPr>
@@ -9021,7 +9079,7 @@
           <p:cNvPr id="17" name="Reference 5 title">
             <a:extLst xmlns:a="http://schemas.openxmlformats.org/drawingml/2006/main">
               <a:ext uri="{FF2B5EF4-FFF2-40B4-BE49-F238E27FC236}">
-                <a16:creationId xmlns:a16="http://schemas.microsoft.com/office/drawing/2014/main" id="{D8E08E73-BA82-49B3-9CC1-96D43EF88436}"/>
+                <a16:creationId xmlns:a16="http://schemas.microsoft.com/office/drawing/2014/main" id="{AEE54AAE-5C1D-44FA-A11F-70F31D03408B}"/>
               </a:ext>
             </a:extLst>
           </p:cNvPr>
@@ -9067,7 +9125,7 @@
                 <a:latin typeface="Arial"/>
                 <a:ea typeface="Arial"/>
                 <a:cs typeface="Arial"/>
-                <a:hlinkClick xmlns:r="http://schemas.openxmlformats.org/officeDocument/2006/relationships" r:id="R9bf04d8b994e47cf"/>
+                <a:hlinkClick xmlns:r="http://schemas.openxmlformats.org/officeDocument/2006/relationships" r:id="Rb27e4f37d8084bc3"/>
               </a:rPr>
               <a:t>73% urban Indians do not know about their right to make a living will, finds a survey</a:t>
             </a:r>
@@ -9079,7 +9137,7 @@
           <p:cNvPr id="18" name="Reference 5 link">
             <a:extLst xmlns:a="http://schemas.openxmlformats.org/drawingml/2006/main">
               <a:ext uri="{FF2B5EF4-FFF2-40B4-BE49-F238E27FC236}">
-                <a16:creationId xmlns:a16="http://schemas.microsoft.com/office/drawing/2014/main" id="{2F9D331E-1BD7-4ADB-A1A9-3FEEEC0C95B0}"/>
+                <a16:creationId xmlns:a16="http://schemas.microsoft.com/office/drawing/2014/main" id="{2AA09D6E-4647-454D-A881-CF0E4D354DB4}"/>
               </a:ext>
             </a:extLst>
           </p:cNvPr>
@@ -9125,7 +9183,7 @@
                 <a:latin typeface="Arial"/>
                 <a:ea typeface="Arial"/>
                 <a:cs typeface="Arial"/>
-                <a:hlinkClick xmlns:r="http://schemas.openxmlformats.org/officeDocument/2006/relationships" r:id="Rddfaae5f40354ab5"/>
+                <a:hlinkClick xmlns:r="http://schemas.openxmlformats.org/officeDocument/2006/relationships" r:id="Rfcf387f88cec4cb0"/>
               </a:rPr>
               <a:t>https://scroll.in/article/925875/73-urban-indians-do-not-know-about-their-right-to-make-a-living-will-finds-a-survey</a:t>
             </a:r>
@@ -9137,7 +9195,7 @@
           <p:cNvPr id="19" name="Reference 6 author">
             <a:extLst xmlns:a="http://schemas.openxmlformats.org/drawingml/2006/main">
               <a:ext uri="{FF2B5EF4-FFF2-40B4-BE49-F238E27FC236}">
-                <a16:creationId xmlns:a16="http://schemas.microsoft.com/office/drawing/2014/main" id="{7E7215C9-49C4-4012-9F4A-776105AEB539}"/>
+                <a16:creationId xmlns:a16="http://schemas.microsoft.com/office/drawing/2014/main" id="{5EE15D09-1BAF-4775-AFA4-78C1D1BB1DFD}"/>
               </a:ext>
             </a:extLst>
           </p:cNvPr>
@@ -9194,7 +9252,7 @@
           <p:cNvPr id="20" name="Reference 6 title">
             <a:extLst xmlns:a="http://schemas.openxmlformats.org/drawingml/2006/main">
               <a:ext uri="{FF2B5EF4-FFF2-40B4-BE49-F238E27FC236}">
-                <a16:creationId xmlns:a16="http://schemas.microsoft.com/office/drawing/2014/main" id="{610A748E-29D3-4454-A139-807409D56F92}"/>
+                <a16:creationId xmlns:a16="http://schemas.microsoft.com/office/drawing/2014/main" id="{4EF09634-66FF-474F-82B2-A94C7CCB5F94}"/>
               </a:ext>
             </a:extLst>
           </p:cNvPr>
@@ -9240,7 +9298,7 @@
                 <a:latin typeface="Arial"/>
                 <a:ea typeface="Arial"/>
                 <a:cs typeface="Arial"/>
-                <a:hlinkClick xmlns:r="http://schemas.openxmlformats.org/officeDocument/2006/relationships" r:id="Rf3bbc7d4209e4232"/>
+                <a:hlinkClick xmlns:r="http://schemas.openxmlformats.org/officeDocument/2006/relationships" r:id="R3431cd50e645498a"/>
               </a:rPr>
               <a:t>Knowledge and attitude towards advance directives for patients with terminal illnesses among doctors working in a tertiary care hospital</a:t>
             </a:r>
@@ -9252,7 +9310,7 @@
           <p:cNvPr id="21" name="Reference 6 link">
             <a:extLst xmlns:a="http://schemas.openxmlformats.org/drawingml/2006/main">
               <a:ext uri="{FF2B5EF4-FFF2-40B4-BE49-F238E27FC236}">
-                <a16:creationId xmlns:a16="http://schemas.microsoft.com/office/drawing/2014/main" id="{8579756C-FE58-4EFA-94AF-2A3706E11298}"/>
+                <a16:creationId xmlns:a16="http://schemas.microsoft.com/office/drawing/2014/main" id="{E8226A4F-C3EC-4B92-9895-12D9D0D8731C}"/>
               </a:ext>
             </a:extLst>
           </p:cNvPr>
@@ -9298,7 +9356,7 @@
                 <a:latin typeface="Arial"/>
                 <a:ea typeface="Arial"/>
                 <a:cs typeface="Arial"/>
-                <a:hlinkClick xmlns:r="http://schemas.openxmlformats.org/officeDocument/2006/relationships" r:id="Re513087f06b14cae"/>
+                <a:hlinkClick xmlns:r="http://schemas.openxmlformats.org/officeDocument/2006/relationships" r:id="R760f90c3d96c4e4d"/>
               </a:rPr>
               <a:t>https://doi.org/10.25259/NMJI_817_2023</a:t>
             </a:r>
@@ -9310,7 +9368,7 @@
           <p:cNvPr id="22" name="Reference 7 author">
             <a:extLst xmlns:a="http://schemas.openxmlformats.org/drawingml/2006/main">
               <a:ext uri="{FF2B5EF4-FFF2-40B4-BE49-F238E27FC236}">
-                <a16:creationId xmlns:a16="http://schemas.microsoft.com/office/drawing/2014/main" id="{877BE95D-5BA1-4273-B3F9-4B83D9B2C292}"/>
+                <a16:creationId xmlns:a16="http://schemas.microsoft.com/office/drawing/2014/main" id="{73E57447-AC1B-4F98-9521-64A742003BFA}"/>
               </a:ext>
             </a:extLst>
           </p:cNvPr>
@@ -9367,7 +9425,7 @@
           <p:cNvPr id="23" name="Reference 7 title">
             <a:extLst xmlns:a="http://schemas.openxmlformats.org/drawingml/2006/main">
               <a:ext uri="{FF2B5EF4-FFF2-40B4-BE49-F238E27FC236}">
-                <a16:creationId xmlns:a16="http://schemas.microsoft.com/office/drawing/2014/main" id="{07F7C807-B4BA-45CB-B110-5B91C9103B65}"/>
+                <a16:creationId xmlns:a16="http://schemas.microsoft.com/office/drawing/2014/main" id="{A837176B-54ED-4714-B353-B063FF8AD0B1}"/>
               </a:ext>
             </a:extLst>
           </p:cNvPr>
@@ -9413,7 +9471,7 @@
                 <a:latin typeface="Arial"/>
                 <a:ea typeface="Arial"/>
                 <a:cs typeface="Arial"/>
-                <a:hlinkClick xmlns:r="http://schemas.openxmlformats.org/officeDocument/2006/relationships" r:id="R8c24cf8724cb4323"/>
+                <a:hlinkClick xmlns:r="http://schemas.openxmlformats.org/officeDocument/2006/relationships" r:id="Rc0fec17cc7a74b31"/>
               </a:rPr>
               <a:t>Barriers and Facilitators to Advance Care Planning Implementation for Patients with Neurodegenerative Diseases among Indian Physicians: A Mixed-Methods Analysis</a:t>
             </a:r>
@@ -9425,7 +9483,7 @@
           <p:cNvPr id="24" name="Reference 7 link">
             <a:extLst xmlns:a="http://schemas.openxmlformats.org/drawingml/2006/main">
               <a:ext uri="{FF2B5EF4-FFF2-40B4-BE49-F238E27FC236}">
-                <a16:creationId xmlns:a16="http://schemas.microsoft.com/office/drawing/2014/main" id="{89FFC083-413F-49FE-8634-C7153D3CE170}"/>
+                <a16:creationId xmlns:a16="http://schemas.microsoft.com/office/drawing/2014/main" id="{5A065043-FC1C-4DB8-BBE3-F3C0C83D318E}"/>
               </a:ext>
             </a:extLst>
           </p:cNvPr>
@@ -9471,7 +9529,7 @@
                 <a:latin typeface="Arial"/>
                 <a:ea typeface="Arial"/>
                 <a:cs typeface="Arial"/>
-                <a:hlinkClick xmlns:r="http://schemas.openxmlformats.org/officeDocument/2006/relationships" r:id="Rb395bf2dcfe74b36"/>
+                <a:hlinkClick xmlns:r="http://schemas.openxmlformats.org/officeDocument/2006/relationships" r:id="Rc014c35307644ba6"/>
               </a:rPr>
               <a:t>https://doi.org/10.1101/2025.10.17.25338242</a:t>
             </a:r>
@@ -9483,7 +9541,7 @@
           <p:cNvPr id="25" name="Reference 8 author">
             <a:extLst xmlns:a="http://schemas.openxmlformats.org/drawingml/2006/main">
               <a:ext uri="{FF2B5EF4-FFF2-40B4-BE49-F238E27FC236}">
-                <a16:creationId xmlns:a16="http://schemas.microsoft.com/office/drawing/2014/main" id="{695528D8-0797-482D-818D-E9057525D24D}"/>
+                <a16:creationId xmlns:a16="http://schemas.microsoft.com/office/drawing/2014/main" id="{94E369D9-5A95-4C29-B4B0-17695FEC142A}"/>
               </a:ext>
             </a:extLst>
           </p:cNvPr>
@@ -9540,7 +9598,7 @@
           <p:cNvPr id="26" name="Reference 8 title">
             <a:extLst xmlns:a="http://schemas.openxmlformats.org/drawingml/2006/main">
               <a:ext uri="{FF2B5EF4-FFF2-40B4-BE49-F238E27FC236}">
-                <a16:creationId xmlns:a16="http://schemas.microsoft.com/office/drawing/2014/main" id="{C5C639F9-0794-4F4A-8AED-E513815E0C9D}"/>
+                <a16:creationId xmlns:a16="http://schemas.microsoft.com/office/drawing/2014/main" id="{38C6836B-65CC-4A8A-9F85-3A1ED78A0E14}"/>
               </a:ext>
             </a:extLst>
           </p:cNvPr>
@@ -9586,7 +9644,7 @@
                 <a:latin typeface="Arial"/>
                 <a:ea typeface="Arial"/>
                 <a:cs typeface="Arial"/>
-                <a:hlinkClick xmlns:r="http://schemas.openxmlformats.org/officeDocument/2006/relationships" r:id="Rd3b545c818d14e33"/>
+                <a:hlinkClick xmlns:r="http://schemas.openxmlformats.org/officeDocument/2006/relationships" r:id="R54b0c71ef6424719"/>
               </a:rPr>
               <a:t>An Ethnographic Study of Barriers to Cancer Pain Management and Opioid Availability in India</a:t>
             </a:r>
@@ -9598,7 +9656,7 @@
           <p:cNvPr id="27" name="Reference 8 link">
             <a:extLst xmlns:a="http://schemas.openxmlformats.org/drawingml/2006/main">
               <a:ext uri="{FF2B5EF4-FFF2-40B4-BE49-F238E27FC236}">
-                <a16:creationId xmlns:a16="http://schemas.microsoft.com/office/drawing/2014/main" id="{164CA88E-8043-4FB7-B80C-596B93B9DA81}"/>
+                <a16:creationId xmlns:a16="http://schemas.microsoft.com/office/drawing/2014/main" id="{85062187-130A-430A-9AE5-5E694166937D}"/>
               </a:ext>
             </a:extLst>
           </p:cNvPr>
@@ -9644,7 +9702,7 @@
                 <a:latin typeface="Arial"/>
                 <a:ea typeface="Arial"/>
                 <a:cs typeface="Arial"/>
-                <a:hlinkClick xmlns:r="http://schemas.openxmlformats.org/officeDocument/2006/relationships" r:id="R3782eab2726146fe"/>
+                <a:hlinkClick xmlns:r="http://schemas.openxmlformats.org/officeDocument/2006/relationships" r:id="R8e18fafa3a11490a"/>
               </a:rPr>
               <a:t>https://doi.org/10.1634/theoncologist.2013-0435</a:t>
             </a:r>
@@ -9656,7 +9714,7 @@
           <p:cNvPr id="28" name="Reference 9 author">
             <a:extLst xmlns:a="http://schemas.openxmlformats.org/drawingml/2006/main">
               <a:ext uri="{FF2B5EF4-FFF2-40B4-BE49-F238E27FC236}">
-                <a16:creationId xmlns:a16="http://schemas.microsoft.com/office/drawing/2014/main" id="{CB6B38E1-D2F0-42A0-9C78-2ABFA26E6949}"/>
+                <a16:creationId xmlns:a16="http://schemas.microsoft.com/office/drawing/2014/main" id="{F9132870-C6A4-4587-BC5C-AABD496031FF}"/>
               </a:ext>
             </a:extLst>
           </p:cNvPr>
@@ -9713,7 +9771,7 @@
           <p:cNvPr id="29" name="Reference 9 title">
             <a:extLst xmlns:a="http://schemas.openxmlformats.org/drawingml/2006/main">
               <a:ext uri="{FF2B5EF4-FFF2-40B4-BE49-F238E27FC236}">
-                <a16:creationId xmlns:a16="http://schemas.microsoft.com/office/drawing/2014/main" id="{3E08A552-CB42-49AB-BEAF-45029894E647}"/>
+                <a16:creationId xmlns:a16="http://schemas.microsoft.com/office/drawing/2014/main" id="{47973DD1-84DF-4529-814F-4FA04AAFEC11}"/>
               </a:ext>
             </a:extLst>
           </p:cNvPr>
@@ -9759,7 +9817,7 @@
                 <a:latin typeface="Arial"/>
                 <a:ea typeface="Arial"/>
                 <a:cs typeface="Arial"/>
-                <a:hlinkClick xmlns:r="http://schemas.openxmlformats.org/officeDocument/2006/relationships" r:id="R11add638ba134f02"/>
+                <a:hlinkClick xmlns:r="http://schemas.openxmlformats.org/officeDocument/2006/relationships" r:id="Rf97b2ab115454a75"/>
               </a:rPr>
               <a:t>Receipt of Psychosocial Care Among Cancer Survivors in the United States</a:t>
             </a:r>
@@ -9771,7 +9829,7 @@
           <p:cNvPr id="30" name="Reference 9 link">
             <a:extLst xmlns:a="http://schemas.openxmlformats.org/drawingml/2006/main">
               <a:ext uri="{FF2B5EF4-FFF2-40B4-BE49-F238E27FC236}">
-                <a16:creationId xmlns:a16="http://schemas.microsoft.com/office/drawing/2014/main" id="{D6154259-A463-4C9E-81DC-A107E41CA500}"/>
+                <a16:creationId xmlns:a16="http://schemas.microsoft.com/office/drawing/2014/main" id="{778DD96A-A34E-4CCA-B7C0-C451B85AB7D5}"/>
               </a:ext>
             </a:extLst>
           </p:cNvPr>
@@ -9817,7 +9875,7 @@
                 <a:latin typeface="Arial"/>
                 <a:ea typeface="Arial"/>
                 <a:cs typeface="Arial"/>
-                <a:hlinkClick xmlns:r="http://schemas.openxmlformats.org/officeDocument/2006/relationships" r:id="Re3414ef1901c4d2d"/>
+                <a:hlinkClick xmlns:r="http://schemas.openxmlformats.org/officeDocument/2006/relationships" r:id="Re8f69de745ef451e"/>
               </a:rPr>
               <a:t>https://doi.org/10.1200/JCO.2012.46.2101</a:t>
             </a:r>

</xml_diff>

<commit_message>
Restore pitch sequence and include doctors in records support
</commit_message>
<xml_diff>
--- a/submission/Saathi_Healthathon_Final.pptx
+++ b/submission/Saathi_Healthathon_Final.pptx
@@ -2,20 +2,20 @@
 <file path=ppt/presentation.xml><?xml version="1.0" encoding="utf-8"?>
 <p:presentation xmlns:p="http://schemas.openxmlformats.org/presentationml/2006/main">
   <p:sldMasterIdLst>
-    <p:sldMasterId xmlns:r="http://schemas.openxmlformats.org/officeDocument/2006/relationships" id="2147483648" r:id="R2f37da97b7c744c3"/>
+    <p:sldMasterId xmlns:r="http://schemas.openxmlformats.org/officeDocument/2006/relationships" id="2147483648" r:id="Rd63178ece7714f25"/>
   </p:sldMasterIdLst>
   <p:notesMasterIdLst>
-    <p:notesMasterId xmlns:r="http://schemas.openxmlformats.org/officeDocument/2006/relationships" r:id="R7793016c0c6c4bd7"/>
+    <p:notesMasterId xmlns:r="http://schemas.openxmlformats.org/officeDocument/2006/relationships" r:id="Rd68b8b459b4a4222"/>
   </p:notesMasterIdLst>
   <p:sldIdLst>
-    <p:sldId xmlns:r="http://schemas.openxmlformats.org/officeDocument/2006/relationships" id="256" r:id="Rd7b0edfa8b5b410d"/>
-    <p:sldId xmlns:r="http://schemas.openxmlformats.org/officeDocument/2006/relationships" id="257" r:id="R1f1b9d6e8b784518"/>
-    <p:sldId xmlns:r="http://schemas.openxmlformats.org/officeDocument/2006/relationships" id="258" r:id="R3930a2f2e1e04b9e"/>
-    <p:sldId xmlns:r="http://schemas.openxmlformats.org/officeDocument/2006/relationships" id="259" r:id="R4500c2a858714391"/>
-    <p:sldId xmlns:r="http://schemas.openxmlformats.org/officeDocument/2006/relationships" id="260" r:id="Rd1e9c3bf28914e77"/>
-    <p:sldId xmlns:r="http://schemas.openxmlformats.org/officeDocument/2006/relationships" id="261" r:id="Re5e13c508e6d4d32"/>
-    <p:sldId xmlns:r="http://schemas.openxmlformats.org/officeDocument/2006/relationships" id="262" r:id="Rf1a6db1328ab4781"/>
-    <p:sldId xmlns:r="http://schemas.openxmlformats.org/officeDocument/2006/relationships" id="263" r:id="Re25fbfc9e15a48f8"/>
+    <p:sldId xmlns:r="http://schemas.openxmlformats.org/officeDocument/2006/relationships" id="256" r:id="R03448a2c4d264545"/>
+    <p:sldId xmlns:r="http://schemas.openxmlformats.org/officeDocument/2006/relationships" id="257" r:id="Rbdfceb2139a24be5"/>
+    <p:sldId xmlns:r="http://schemas.openxmlformats.org/officeDocument/2006/relationships" id="258" r:id="Rbcff84e4184d4cb0"/>
+    <p:sldId xmlns:r="http://schemas.openxmlformats.org/officeDocument/2006/relationships" id="259" r:id="R3d86dc09bb6c4a07"/>
+    <p:sldId xmlns:r="http://schemas.openxmlformats.org/officeDocument/2006/relationships" id="260" r:id="Rdff4d750bc6347b8"/>
+    <p:sldId xmlns:r="http://schemas.openxmlformats.org/officeDocument/2006/relationships" id="261" r:id="R9c6296f5b5bd4721"/>
+    <p:sldId xmlns:r="http://schemas.openxmlformats.org/officeDocument/2006/relationships" id="262" r:id="R77497aa8c5774ba6"/>
+    <p:sldId xmlns:r="http://schemas.openxmlformats.org/officeDocument/2006/relationships" id="263" r:id="Rd72356854b694758"/>
   </p:sldIdLst>
   <p:sldSz cx="12192000" cy="6858000"/>
   <p:notesSz cx="6858000" cy="9144000"/>
@@ -449,7 +449,7 @@
           <a:lstStyle xmlns:a="http://schemas.openxmlformats.org/drawingml/2006/main"/>
           <a:p xmlns:a="http://schemas.openxmlformats.org/drawingml/2006/main">
             <a:r>
-              <a:t>Both images are actual Chrome captures of https://saathi.wedevit.in/home for this revision, saved as output/playwright/2026-09-24-saathi-patient-home.png and output/playwright/2026-09-24-saathi-three-role-login.png. The sign-in image is cropped inside PowerPoint to the original form; no UI has been redrawn. The patient image includes the complete home page, showing the latest Care Note, documents, Find support, My space, Calendar, the upcoming visit and medicine and family-help shortcuts. Meera and the other stored records are fictional. The three current role choices are Patient, Family and Doctor. Patient sign-in was exercised with a different arbitrary 14-digit value and opened the existing patient home. This checks the present format-only entry flow, not real ABHA authentication or permission to open another person's medical records. Verified accounts and sharing between phones remain to connect. This is the broader intended family-support workflow, not a claim of completed rides, guaranteed stock, payments or a deployed financial-assistance system. Patients and families can keep questions, records, confirmed treatment dates, medicine and appointment plans, named tasks, journal entries and support contacts together. Receipts, financial-help paperwork and caregiver-training handoffs remain proposed supporting work. The doctor reviews and signs first; the patient reviews and signs the same version. Directory: Pallium India, https://palliumindia.org/clinics/telangana, lists home/inpatient/outpatient services and medicine availability. The family must call to confirm the prescribed medicine and service; a listing does not establish today's stock, oral formulation or a booked appointment. Caregiver support evidence: https://journals.plos.org/plosone/article?id=10.1371/journal.pone.0274770 supports information, training, practical and emotional support needs. Additional sources: both meeting transcripts and the user's feedback.</a:t>
+              <a:t>Saathi (साथी) means companion. The five named people are the current team; Shirin Ayub was added in the user's latest roster. Basith and Awaiz portraits are original team assets from the DevIT ITI deck, with provenance in submission/assets/2026-09-24-team/README.md. Blank spaces are intentionally reserved for the other members' photos. Roles use the supplied roster. The app logo is extracted from the actual app. GitHub and WhatsApp marks use Simple Icons paths; the WhatsApp mark is coloured green. The QR and OPEN THE WEBSITE link open https://saathi.wedevit.in/. GitHub opens the public project repository; WhatsApp is a contact for questions, not an access request. Entry: Cancer / Patient and Caregiver / Family &amp; Caregiver Support. The cover describes the family-support purpose, not a claim that transport booking, payments or connected AI are operational.</a:t>
             </a:r>
           </a:p>
         </p:txBody>
@@ -519,7 +519,7 @@
           <a:lstStyle xmlns:a="http://schemas.openxmlformats.org/drawingml/2006/main"/>
           <a:p xmlns:a="http://schemas.openxmlformats.org/drawingml/2006/main">
             <a:r>
-              <a:t>Saathi (साथी) means companion. The five named people are the current team; Shirin Ayub was added in the user's latest roster. Basith and Awaiz portraits are original team assets from the DevIT ITI deck, with provenance in submission/assets/2026-09-24-team/README.md. Blank spaces are intentionally reserved for the other members' photos. Roles use the supplied roster. The app logo is extracted from the actual app. GitHub and WhatsApp marks use Simple Icons paths; the WhatsApp mark is coloured green. The QR and OPEN THE WEBSITE link open https://saathi.wedevit.in/. GitHub opens the public project repository; WhatsApp is a contact for questions, not an access request. Entry: Cancer / Patient and Caregiver / Family &amp; Caregiver Support. The cover describes the family-support purpose, not a claim that transport booking, payments or connected AI are operational.</a:t>
+              <a:t>Illustrative story supplied by the team, not a reported patient case. A 62-year-old woman with advanced breast cancer receives best supportive care. Her husband attends the first discussion. In the later crisis the husband and daughter disagree about attempts to restart her heart and her son is in another city. The story does not recommend or reject emergency treatment. A Care Note records wishes and discussion; it is not an automatic treatment order or a legal advance directive. The contextual photo is a real medical camp in Mannar, Alappuzha district, Kerala, 23 August 2011. It does not depict this story, a cancer-specific visit or a Saathi user. Photo credit: Ministry of Information &amp; Broadcasting / Press Information Bureau, Government of India, photo ID 36197, CNR 39173. Source: https://commons.wikimedia.org/wiki/File:A_medical_camp_conducted_as_part_of_the_public_information_campaign_organized_by_PIB_Thiruvananthapuram,_at_Mannar,_in_Alappuzha_district,_Kerala_on_August_23,_2011.jpg ; original source https://archive.pib.gov.in/photo.aspx?photoid=36197 . Licensed under Government Open Data License – India, https://data.gov.in/sites/default/files/Gazette_Notification_OGDL.pdf . Displayed without image alterations apart from resizing. No government endorsement is implied. Icons: Lucide, https://lucide.dev/license, ISC/MIT, SVG paths unchanged and colours adapted. Full license and credits: submission/assets/2026-09-24-family/. Story sources: docs/meetings/2026-09-23-chat-follow-up.md and both meetings this week.</a:t>
             </a:r>
           </a:p>
         </p:txBody>
@@ -589,7 +589,7 @@
           <a:lstStyle xmlns:a="http://schemas.openxmlformats.org/drawingml/2006/main"/>
           <a:p xmlns:a="http://schemas.openxmlformats.org/drawingml/2006/main">
             <a:r>
-              <a:t>Illustrative story supplied by the team, not a reported patient case. A 62-year-old woman with advanced breast cancer receives best supportive care. Her husband attends the first discussion. In the later crisis the husband and daughter disagree about attempts to restart her heart and her son is in another city. The story does not recommend or reject emergency treatment. A Care Note records wishes and discussion; it is not an automatic treatment order or a legal advance directive. The contextual photo is a real medical camp in Mannar, Alappuzha district, Kerala, 23 August 2011. It does not depict this story, a cancer-specific visit or a Saathi user. Photo credit: Ministry of Information &amp; Broadcasting / Press Information Bureau, Government of India, photo ID 36197, CNR 39173. Source: https://commons.wikimedia.org/wiki/File:A_medical_camp_conducted_as_part_of_the_public_information_campaign_organized_by_PIB_Thiruvananthapuram,_at_Mannar,_in_Alappuzha_district,_Kerala_on_August_23,_2011.jpg ; original source https://archive.pib.gov.in/photo.aspx?photoid=36197 . Licensed under Government Open Data License – India, https://data.gov.in/sites/default/files/Gazette_Notification_OGDL.pdf . Displayed without image alterations apart from resizing. No government endorsement is implied. Icons: Lucide, https://lucide.dev/license, ISC/MIT, SVG paths unchanged and colours adapted. Full license and credits: submission/assets/2026-09-24-family/. Story sources: docs/meetings/2026-09-23-chat-follow-up.md and both meetings this week.</a:t>
+              <a:t>Five findings with distinct scopes, verified in docs/pitch/2026-09-24-verified-evidence.md: IARC GLOBOCAN estimates 1,562,581 new cancer cases in India in 2024, rounded to 15.6 lakh. Patil et al. report 98.39% unmet palliative-care need among metastatic cancer cases across ten cancer types, using the NCRP 2020 report; this is not all cancer patients and must not be multiplied by the incidence estimate. The 88% figure is from IndiaSpend reporting of the 2019 HCAH Living Will Survey of over 2,400 urban respondents in seven cities; the original survey was inaccessible and this is not a cancer-only or national sample. Jacob et al. report 45 of 391 doctors (11.5%) with prior advance-directive training at CMC Vellore, not a national estimate. Thangasamy et al. report 0% to 92% documented discussions, with 24 of 26 eligible advanced pancreatic or colorectal cancer patients in one Chennai quality-improvement project. A structured process, form and team work produced this result; this was not a Saathi or AI intervention. The native chart and source workbook are preserved byte-for-byte from the existing supplied pitch chart. Each short source credit is a native hyperlink and the full nine-source list remains on slide 8. Icons: Lucide, ISC/MIT, https://lucide.dev/license, source SVGs and full license in submission/assets/2026-09-24-family/.</a:t>
             </a:r>
           </a:p>
         </p:txBody>
@@ -659,7 +659,7 @@
           <a:lstStyle xmlns:a="http://schemas.openxmlformats.org/drawingml/2006/main"/>
           <a:p xmlns:a="http://schemas.openxmlformats.org/drawingml/2006/main">
             <a:r>
-              <a:t>This is the central proposed AI workflow, not a claim that a model is already connected. With recording consent, a transcript or existing note becomes a source-linked draft. The doctor can edit, reject or correct it in a distinct review step, and signs first. The patient then reviews and signs that exact version; changed wording requires a newly reviewed version. Unanswered questions remain unanswered. No diagnosis, treatment recommendation, risk scoring or interpretation of medical results. Clinical choices from the supplied Healthathon form and Saanthvana v 1.0 document belong to the clinician, not the AI. Today the browser app supports recording, source-based rule preparation, editing and typed-name signing. Reliable transcription, model integration, verified accounts and sharing between phones remain to connect. A typed name is not a verified digital signature; a Care Note is not a legal advance directive. Sarvam AI is a proposed provider for Indian-language speech-to-text, translation and read-aloud, supported by official documentation: https://docs.sarvam.ai/api/getting-started/building-for-india and https://docs.sarvam.ai/api-reference/speech-to-text/transcribe. No provider version or working connection is claimed. The recording screen is the actual app screenshot supplied by the user on 24 September, preserved unchanged at submission/assets/2026-09-24-family/saathi-record-conversation.png. It shows the Voice note panel, recording consent, Start recording, English language selection, Upload audio and the Prepare draft, Review &amp; edit and Sign Care Note steps. This image shows the interface before recording; it does not establish that microphone capture or live transcription has been verified. The displayed Meera profile is fictional. Sources: 21 September transcript lines 251–303 and 1097–1155; 23 September meeting and chat; Sujay's 24 September feedback; supplied clinical forms.</a:t>
+              <a:t>Both images are actual Chrome captures of https://saathi.wedevit.in/home for this revision, saved as output/playwright/2026-09-24-saathi-patient-home.png and output/playwright/2026-09-24-saathi-three-role-login.png. The sign-in image is cropped inside PowerPoint to the original form; no UI has been redrawn. The patient image includes the complete home page, showing the latest Care Note, documents, Find support, My space, Calendar, the upcoming visit and medicine and family-help shortcuts. Meera and the other stored records are fictional. The three current role choices are Patient, Family and Doctor. Patient sign-in was exercised with a different arbitrary 14-digit value and opened the existing patient home. This checks the present format-only entry flow, not real ABHA authentication or permission to open another person's medical records. Verified accounts and sharing between phones remain to connect. This is the broader intended family-support workflow, not a claim of completed rides, guaranteed stock, payments or a deployed financial-assistance system. Patients and families can keep questions, records, confirmed treatment dates, medicine and appointment plans, named tasks, journal entries and support contacts together. Receipts, financial-help paperwork and caregiver-training handoffs remain proposed supporting work. The doctor reviews and signs first; the patient reviews and signs the same version. Directory: Pallium India, https://palliumindia.org/clinics/telangana, lists home/inpatient/outpatient services and medicine availability. The family must call to confirm the prescribed medicine and service; a listing does not establish today's stock, oral formulation or a booked appointment. Caregiver support evidence: https://journals.plos.org/plosone/article?id=10.1371/journal.pone.0274770 supports information, training, practical and emotional support needs. Additional sources: both meeting transcripts and the user's feedback.</a:t>
             </a:r>
           </a:p>
         </p:txBody>
@@ -729,7 +729,7 @@
           <a:lstStyle xmlns:a="http://schemas.openxmlformats.org/drawingml/2006/main"/>
           <a:p xmlns:a="http://schemas.openxmlformats.org/drawingml/2006/main">
             <a:r>
-              <a:t>Five findings with distinct scopes, verified in docs/pitch/2026-09-24-verified-evidence.md: IARC GLOBOCAN estimates 1,562,581 new cancer cases in India in 2024, rounded to 15.6 lakh. Patil et al. report 98.39% unmet palliative-care need among metastatic cancer cases across ten cancer types, using the NCRP 2020 report; this is not all cancer patients and must not be multiplied by the incidence estimate. The 88% figure is from IndiaSpend reporting of the 2019 HCAH Living Will Survey of over 2,400 urban respondents in seven cities; the original survey was inaccessible and this is not a cancer-only or national sample. Jacob et al. report 45 of 391 doctors (11.5%) with prior advance-directive training at CMC Vellore, not a national estimate. Thangasamy et al. report 0% to 92% documented discussions, with 24 of 26 eligible advanced pancreatic or colorectal cancer patients in one Chennai quality-improvement project. A structured process, form and team work produced this result; this was not a Saathi or AI intervention. The native chart and source workbook are preserved byte-for-byte from the existing supplied pitch chart. Each short source credit is a native hyperlink and the full nine-source list remains on slide 8. Icons: Lucide, ISC/MIT, https://lucide.dev/license, source SVGs and full license in submission/assets/2026-09-24-family/.</a:t>
+              <a:t>This is the central proposed AI workflow, not a claim that a model is already connected. With recording consent, a transcript or existing note becomes a source-linked draft. The doctor can edit, reject or correct it in a distinct review step, and signs first. The patient then reviews and signs that exact version; changed wording requires a newly reviewed version. Unanswered questions remain unanswered. No diagnosis, treatment recommendation, risk scoring or interpretation of medical results. Clinical choices from the supplied Healthathon form and Saanthvana v 1.0 document belong to the clinician, not the AI. Today the browser app supports recording, source-based rule preparation, editing and typed-name signing. Reliable transcription, model integration, verified accounts and sharing between phones remain to connect. A typed name is not a verified digital signature; a Care Note is not a legal advance directive. Sarvam AI is a proposed provider for Indian-language speech-to-text, translation and read-aloud, supported by official documentation: https://docs.sarvam.ai/api/getting-started/building-for-india and https://docs.sarvam.ai/api-reference/speech-to-text/transcribe. No provider version or working connection is claimed. The recording screen is the actual app screenshot supplied by the user on 24 September, preserved unchanged at submission/assets/2026-09-24-family/saathi-record-conversation.png. It shows the Voice note panel, recording consent, Start recording, English language selection, Upload audio and the Prepare draft, Review &amp; edit and Sign Care Note steps. This image shows the interface before recording; it does not establish that microphone capture or live transcription has been verified. The displayed Meera profile is fictional. Sources: 21 September transcript lines 251–303 and 1097–1155; 23 September meeting and chat; Sujay's 24 September feedback; supplied clinical forms.</a:t>
             </a:r>
           </a:p>
         </p:txBody>
@@ -799,7 +799,7 @@
           <a:lstStyle xmlns:a="http://schemas.openxmlformats.org/drawingml/2006/main"/>
           <a:p xmlns:a="http://schemas.openxmlformats.org/drawingml/2006/main">
             <a:r>
-              <a:t>This slide describes three AI jobs adopted in the meetings: answer questions from the patient's own files with the exact source passage; prepare a dated treatment history from recorded chemotherapy and radiotherapy dates; read medicine details from printed or typed prescriptions for a person to check before adding reminders. Current workflow explicitly asks a person to check extracted text before saving it and to confirm a treatment happened and supply its date before adding it to the care timeline. A report or appointment date must not be inferred as a completed treatment date. Handwritten prescription recognition was not adopted. The screenshot is a fresh real Chrome capture of the live Saathi app on 24 September, showing literal retrieval from a fictional stored record, neutral saved-text provenance, Add treatment date and View original. It does not demonstrate connected semantic AI or image OCR. Provider integration code exists but live model calls are not enabled or verified. AI must not interpret test results or create clinical advice. Sources: 21 September transcript lines 1025–1043, 1099–1123 and 1135–1151; 23 September transcript lines 269–277; output/playwright/2026-09-24-saathi-documents-source.png.</a:t>
+              <a:t>Patients, their families and their doctors can use these record-organising features within the patient’s sharing permissions. Doctors are included as members of the care team, with a separate role from family caregivers. This slide describes three AI jobs adopted in the meetings: answer questions from the patient's own files with the exact source passage; prepare a dated treatment history from recorded chemotherapy and radiotherapy dates; read medicine details from printed or typed prescriptions for a person to check before adding reminders. Current workflow explicitly asks a person to check extracted text before saving it and to confirm a treatment happened and supply its date before adding it to the care timeline. A report or appointment date must not be inferred as a completed treatment date. Handwritten prescription recognition was not adopted. The screenshot is a fresh real Chrome capture of the live Saathi app on 24 September, showing literal retrieval from a fictional stored record, neutral saved-text provenance, Add treatment date and View original. It does not demonstrate connected semantic AI or image OCR. Provider integration code exists but live model calls are not enabled or verified. AI must not interpret test results or create clinical advice. Sources: 21 September transcript lines 1025–1043, 1099–1123 and 1135–1151; 23 September transcript lines 269–277; output/playwright/2026-09-24-saathi-documents-source.png.</a:t>
             </a:r>
           </a:p>
         </p:txBody>
@@ -1387,7 +1387,7 @@
   </p:cSld>
   <p:clrMap bg1="lt1" tx1="dk1" bg2="lt2" tx2="dk2" accent1="accent1" accent2="accent2" accent3="accent3" accent4="accent4" accent5="accent5" accent6="accent6" hlink="hlink" folHlink="folHlink"/>
   <p:sldLayoutIdLst>
-    <p:sldLayoutId xmlns:r="http://schemas.openxmlformats.org/officeDocument/2006/relationships" id="2147483649" r:id="Rd919e9f25ca4477c"/>
+    <p:sldLayoutId xmlns:r="http://schemas.openxmlformats.org/officeDocument/2006/relationships" id="2147483649" r:id="Rd8ba2cbfcf7046ba"/>
   </p:sldLayoutIdLst>
   <p:txStyles>
     <p:titleStyle>
@@ -2122,537 +2122,6 @@
     <p:bg>
       <p:bgPr>
         <a:solidFill xmlns:a="http://schemas.openxmlformats.org/drawingml/2006/main">
-          <a:srgbClr val="FCFAF4"/>
-        </a:solidFill>
-      </p:bgPr>
-    </p:bg>
-    <p:spTree>
-      <p:nvGrpSpPr>
-        <p:cNvPr id="1" name=""/>
-        <p:cNvGrpSpPr/>
-        <p:nvPr/>
-      </p:nvGrpSpPr>
-      <p:grpSpPr>
-        <a:xfrm xmlns:a="http://schemas.openxmlformats.org/drawingml/2006/main"/>
-      </p:grpSpPr>
-      <p:sp>
-        <p:nvSpPr>
-          <p:cNvPr id="11" name="Slide title">
-            <a:extLst xmlns:a="http://schemas.openxmlformats.org/drawingml/2006/main">
-              <a:ext uri="{FF2B5EF4-FFF2-40B4-BE49-F238E27FC236}">
-                <a16:creationId xmlns:a16="http://schemas.microsoft.com/office/drawing/2014/main" id="{DD9D4ABF-4CA6-435C-831E-E44F4365E262}"/>
-              </a:ext>
-            </a:extLst>
-          </p:cNvPr>
-          <p:cNvSpPr>
-            <a:spLocks xmlns:a="http://schemas.openxmlformats.org/drawingml/2006/main" noGrp="1"/>
-          </p:cNvSpPr>
-          <p:nvPr/>
-        </p:nvSpPr>
-        <p:spPr>
-          <a:xfrm xmlns:a="http://schemas.openxmlformats.org/drawingml/2006/main">
-            <a:off x="533400" y="361950"/>
-            <a:ext cx="11125200" cy="581025"/>
-          </a:xfrm>
-          <a:prstGeom xmlns:a="http://schemas.openxmlformats.org/drawingml/2006/main" prst="rect">
-            <a:avLst/>
-          </a:prstGeom>
-          <a:noFill xmlns:a="http://schemas.openxmlformats.org/drawingml/2006/main"/>
-          <a:ln xmlns:a="http://schemas.openxmlformats.org/drawingml/2006/main" w="0">
-            <a:noFill/>
-          </a:ln>
-        </p:spPr>
-        <p:txBody>
-          <a:bodyPr xmlns:a="http://schemas.openxmlformats.org/drawingml/2006/main" wrap="square" lIns="0" tIns="0" rIns="0" bIns="0">
-            <a:normAutofit fontScale="100000"/>
-          </a:bodyPr>
-          <a:lstStyle xmlns:a="http://schemas.openxmlformats.org/drawingml/2006/main"/>
-          <a:p xmlns:a="http://schemas.openxmlformats.org/drawingml/2006/main">
-            <a:pPr>
-              <a:defRPr sz="3000" b="1">
-                <a:solidFill>
-                  <a:srgbClr val="173F33"/>
-                </a:solidFill>
-                <a:latin typeface="Arial"/>
-                <a:ea typeface="Arial"/>
-                <a:cs typeface="Arial"/>
-              </a:defRPr>
-            </a:pPr>
-            <a:r>
-              <a:rPr sz="3000" b="1">
-                <a:solidFill>
-                  <a:srgbClr val="173F33"/>
-                </a:solidFill>
-                <a:latin typeface="Arial"/>
-                <a:ea typeface="Arial"/>
-                <a:cs typeface="Arial"/>
-              </a:rPr>
-              <a:t>Saathi keeps your cancer care in one place.</a:t>
-            </a:r>
-          </a:p>
-        </p:txBody>
-      </p:sp>
-      <p:pic>
-        <p:nvPicPr>
-          <p:cNvPr id="12" name=""/>
-          <p:cNvPicPr>
-            <a:picLocks xmlns:a="http://schemas.openxmlformats.org/drawingml/2006/main" noChangeAspect="1"/>
-          </p:cNvPicPr>
-          <p:nvPr/>
-        </p:nvPicPr>
-        <p:blipFill>
-          <a:blip xmlns:r="http://schemas.openxmlformats.org/officeDocument/2006/relationships" xmlns:a="http://schemas.openxmlformats.org/drawingml/2006/main" r:embed="R81cb9184f8c74217"/>
-          <a:stretch xmlns:a="http://schemas.openxmlformats.org/drawingml/2006/main"/>
-        </p:blipFill>
-        <p:spPr>
-          <a:xfrm xmlns:a="http://schemas.openxmlformats.org/drawingml/2006/main">
-            <a:off x="273222" y="1066800"/>
-            <a:ext cx="8673757" cy="5067300"/>
-          </a:xfrm>
-          <a:prstGeom xmlns:a="http://schemas.openxmlformats.org/drawingml/2006/main" prst="rect">
-            <a:avLst/>
-          </a:prstGeom>
-        </p:spPr>
-      </p:pic>
-      <p:sp>
-        <p:nvSpPr>
-          <p:cNvPr id="3" name="Three sign-ins">
-            <a:extLst xmlns:a="http://schemas.openxmlformats.org/drawingml/2006/main">
-              <a:ext uri="{FF2B5EF4-FFF2-40B4-BE49-F238E27FC236}">
-                <a16:creationId xmlns:a16="http://schemas.microsoft.com/office/drawing/2014/main" id="{3D02207E-A809-431E-91DE-60EA620C8DBE}"/>
-              </a:ext>
-            </a:extLst>
-          </p:cNvPr>
-          <p:cNvSpPr>
-            <a:spLocks xmlns:a="http://schemas.openxmlformats.org/drawingml/2006/main" noGrp="1"/>
-          </p:cNvSpPr>
-          <p:nvPr/>
-        </p:nvSpPr>
-        <p:spPr>
-          <a:xfrm xmlns:a="http://schemas.openxmlformats.org/drawingml/2006/main">
-            <a:off x="9296400" y="1076325"/>
-            <a:ext cx="2362200" cy="342900"/>
-          </a:xfrm>
-          <a:prstGeom xmlns:a="http://schemas.openxmlformats.org/drawingml/2006/main" prst="rect">
-            <a:avLst/>
-          </a:prstGeom>
-          <a:noFill xmlns:a="http://schemas.openxmlformats.org/drawingml/2006/main"/>
-          <a:ln xmlns:a="http://schemas.openxmlformats.org/drawingml/2006/main" w="0">
-            <a:noFill/>
-          </a:ln>
-        </p:spPr>
-        <p:txBody>
-          <a:bodyPr xmlns:a="http://schemas.openxmlformats.org/drawingml/2006/main" wrap="square" lIns="0" tIns="0" rIns="0" bIns="0">
-            <a:normAutofit fontScale="100000"/>
-          </a:bodyPr>
-          <a:lstStyle xmlns:a="http://schemas.openxmlformats.org/drawingml/2006/main"/>
-          <a:p xmlns:a="http://schemas.openxmlformats.org/drawingml/2006/main">
-            <a:pPr>
-              <a:defRPr sz="1875" b="1">
-                <a:solidFill>
-                  <a:srgbClr val="173F33"/>
-                </a:solidFill>
-                <a:latin typeface="Arial"/>
-                <a:ea typeface="Arial"/>
-                <a:cs typeface="Arial"/>
-              </a:defRPr>
-            </a:pPr>
-            <a:r>
-              <a:rPr sz="1875" b="1">
-                <a:solidFill>
-                  <a:srgbClr val="173F33"/>
-                </a:solidFill>
-                <a:latin typeface="Arial"/>
-                <a:ea typeface="Arial"/>
-                <a:cs typeface="Arial"/>
-              </a:rPr>
-              <a:t>Three sign-ins</a:t>
-            </a:r>
-          </a:p>
-        </p:txBody>
-      </p:sp>
-      <p:pic>
-        <p:nvPicPr>
-          <p:cNvPr id="14" name=""/>
-          <p:cNvPicPr>
-            <a:picLocks xmlns:a="http://schemas.openxmlformats.org/drawingml/2006/main" noChangeAspect="1"/>
-          </p:cNvPicPr>
-          <p:nvPr/>
-        </p:nvPicPr>
-        <p:blipFill>
-          <a:blip xmlns:r="http://schemas.openxmlformats.org/officeDocument/2006/relationships" xmlns:a="http://schemas.openxmlformats.org/drawingml/2006/main" r:embed="R1c15b0083d9d4873"/>
-          <a:stretch xmlns:a="http://schemas.openxmlformats.org/drawingml/2006/main"/>
-        </p:blipFill>
-        <p:spPr>
-          <a:xfrm xmlns:a="http://schemas.openxmlformats.org/drawingml/2006/main">
-            <a:off x="9144000" y="1498066"/>
-            <a:ext cx="2514600" cy="2690293"/>
-          </a:xfrm>
-          <a:prstGeom xmlns:a="http://schemas.openxmlformats.org/drawingml/2006/main" prst="rect">
-            <a:avLst/>
-          </a:prstGeom>
-        </p:spPr>
-      </p:pic>
-      <p:sp>
-        <p:nvSpPr>
-          <p:cNvPr id="5" name="Patient role">
-            <a:extLst xmlns:a="http://schemas.openxmlformats.org/drawingml/2006/main">
-              <a:ext uri="{FF2B5EF4-FFF2-40B4-BE49-F238E27FC236}">
-                <a16:creationId xmlns:a16="http://schemas.microsoft.com/office/drawing/2014/main" id="{53E1BA6D-3F71-49AC-B796-D49EA1D052B7}"/>
-              </a:ext>
-            </a:extLst>
-          </p:cNvPr>
-          <p:cNvSpPr>
-            <a:spLocks xmlns:a="http://schemas.openxmlformats.org/drawingml/2006/main" noGrp="1"/>
-          </p:cNvSpPr>
-          <p:nvPr/>
-        </p:nvSpPr>
-        <p:spPr>
-          <a:xfrm xmlns:a="http://schemas.openxmlformats.org/drawingml/2006/main">
-            <a:off x="9296400" y="4362450"/>
-            <a:ext cx="2362200" cy="304800"/>
-          </a:xfrm>
-          <a:prstGeom xmlns:a="http://schemas.openxmlformats.org/drawingml/2006/main" prst="rect">
-            <a:avLst/>
-          </a:prstGeom>
-          <a:noFill xmlns:a="http://schemas.openxmlformats.org/drawingml/2006/main"/>
-          <a:ln xmlns:a="http://schemas.openxmlformats.org/drawingml/2006/main" w="0">
-            <a:noFill/>
-          </a:ln>
-        </p:spPr>
-        <p:txBody>
-          <a:bodyPr xmlns:a="http://schemas.openxmlformats.org/drawingml/2006/main" wrap="square" lIns="0" tIns="0" rIns="0" bIns="0">
-            <a:normAutofit fontScale="100000"/>
-          </a:bodyPr>
-          <a:lstStyle xmlns:a="http://schemas.openxmlformats.org/drawingml/2006/main"/>
-          <a:p xmlns:a="http://schemas.openxmlformats.org/drawingml/2006/main">
-            <a:pPr>
-              <a:defRPr sz="1575" b="1">
-                <a:solidFill>
-                  <a:srgbClr val="157B68"/>
-                </a:solidFill>
-                <a:latin typeface="Arial"/>
-                <a:ea typeface="Arial"/>
-                <a:cs typeface="Arial"/>
-              </a:defRPr>
-            </a:pPr>
-            <a:r>
-              <a:rPr sz="1575" b="1">
-                <a:solidFill>
-                  <a:srgbClr val="157B68"/>
-                </a:solidFill>
-                <a:latin typeface="Arial"/>
-                <a:ea typeface="Arial"/>
-                <a:cs typeface="Arial"/>
-              </a:rPr>
-              <a:t>Patients see their care.</a:t>
-            </a:r>
-          </a:p>
-        </p:txBody>
-      </p:sp>
-      <p:sp>
-        <p:nvSpPr>
-          <p:cNvPr id="6" name="Family role">
-            <a:extLst xmlns:a="http://schemas.openxmlformats.org/drawingml/2006/main">
-              <a:ext uri="{FF2B5EF4-FFF2-40B4-BE49-F238E27FC236}">
-                <a16:creationId xmlns:a16="http://schemas.microsoft.com/office/drawing/2014/main" id="{8099B78F-B726-461C-9390-61BDF6DBB371}"/>
-              </a:ext>
-            </a:extLst>
-          </p:cNvPr>
-          <p:cNvSpPr>
-            <a:spLocks xmlns:a="http://schemas.openxmlformats.org/drawingml/2006/main" noGrp="1"/>
-          </p:cNvSpPr>
-          <p:nvPr/>
-        </p:nvSpPr>
-        <p:spPr>
-          <a:xfrm xmlns:a="http://schemas.openxmlformats.org/drawingml/2006/main">
-            <a:off x="9296400" y="4714875"/>
-            <a:ext cx="2362200" cy="304800"/>
-          </a:xfrm>
-          <a:prstGeom xmlns:a="http://schemas.openxmlformats.org/drawingml/2006/main" prst="rect">
-            <a:avLst/>
-          </a:prstGeom>
-          <a:noFill xmlns:a="http://schemas.openxmlformats.org/drawingml/2006/main"/>
-          <a:ln xmlns:a="http://schemas.openxmlformats.org/drawingml/2006/main" w="0">
-            <a:noFill/>
-          </a:ln>
-        </p:spPr>
-        <p:txBody>
-          <a:bodyPr xmlns:a="http://schemas.openxmlformats.org/drawingml/2006/main" wrap="square" lIns="0" tIns="0" rIns="0" bIns="0">
-            <a:normAutofit fontScale="100000"/>
-          </a:bodyPr>
-          <a:lstStyle xmlns:a="http://schemas.openxmlformats.org/drawingml/2006/main"/>
-          <a:p xmlns:a="http://schemas.openxmlformats.org/drawingml/2006/main">
-            <a:pPr>
-              <a:defRPr sz="1575" b="1">
-                <a:solidFill>
-                  <a:srgbClr val="7353AC"/>
-                </a:solidFill>
-                <a:latin typeface="Arial"/>
-                <a:ea typeface="Arial"/>
-                <a:cs typeface="Arial"/>
-              </a:defRPr>
-            </a:pPr>
-            <a:r>
-              <a:rPr sz="1575" b="1">
-                <a:solidFill>
-                  <a:srgbClr val="7353AC"/>
-                </a:solidFill>
-                <a:latin typeface="Arial"/>
-                <a:ea typeface="Arial"/>
-                <a:cs typeface="Arial"/>
-              </a:rPr>
-              <a:t>Families organise help.</a:t>
-            </a:r>
-          </a:p>
-        </p:txBody>
-      </p:sp>
-      <p:sp>
-        <p:nvSpPr>
-          <p:cNvPr id="7" name="Doctor role">
-            <a:extLst xmlns:a="http://schemas.openxmlformats.org/drawingml/2006/main">
-              <a:ext uri="{FF2B5EF4-FFF2-40B4-BE49-F238E27FC236}">
-                <a16:creationId xmlns:a16="http://schemas.microsoft.com/office/drawing/2014/main" id="{F3EB3E7B-A633-430A-9C2B-1689B67CCAE4}"/>
-              </a:ext>
-            </a:extLst>
-          </p:cNvPr>
-          <p:cNvSpPr>
-            <a:spLocks xmlns:a="http://schemas.openxmlformats.org/drawingml/2006/main" noGrp="1"/>
-          </p:cNvSpPr>
-          <p:nvPr/>
-        </p:nvSpPr>
-        <p:spPr>
-          <a:xfrm xmlns:a="http://schemas.openxmlformats.org/drawingml/2006/main">
-            <a:off x="9296400" y="5067300"/>
-            <a:ext cx="2362200" cy="304800"/>
-          </a:xfrm>
-          <a:prstGeom xmlns:a="http://schemas.openxmlformats.org/drawingml/2006/main" prst="rect">
-            <a:avLst/>
-          </a:prstGeom>
-          <a:noFill xmlns:a="http://schemas.openxmlformats.org/drawingml/2006/main"/>
-          <a:ln xmlns:a="http://schemas.openxmlformats.org/drawingml/2006/main" w="0">
-            <a:noFill/>
-          </a:ln>
-        </p:spPr>
-        <p:txBody>
-          <a:bodyPr xmlns:a="http://schemas.openxmlformats.org/drawingml/2006/main" wrap="square" lIns="0" tIns="0" rIns="0" bIns="0">
-            <a:normAutofit fontScale="99374"/>
-          </a:bodyPr>
-          <a:lstStyle xmlns:a="http://schemas.openxmlformats.org/drawingml/2006/main"/>
-          <a:p xmlns:a="http://schemas.openxmlformats.org/drawingml/2006/main">
-            <a:pPr>
-              <a:defRPr sz="1575" b="1">
-                <a:solidFill>
-                  <a:srgbClr val="B75E43"/>
-                </a:solidFill>
-                <a:latin typeface="Arial"/>
-                <a:ea typeface="Arial"/>
-                <a:cs typeface="Arial"/>
-              </a:defRPr>
-            </a:pPr>
-            <a:r>
-              <a:rPr sz="1575" b="1">
-                <a:solidFill>
-                  <a:srgbClr val="B75E43"/>
-                </a:solidFill>
-                <a:latin typeface="Arial"/>
-                <a:ea typeface="Arial"/>
-                <a:cs typeface="Arial"/>
-              </a:rPr>
-              <a:t>Doctors review and sign.</a:t>
-            </a:r>
-          </a:p>
-        </p:txBody>
-      </p:sp>
-      <p:sp>
-        <p:nvSpPr>
-          <p:cNvPr id="8" name="Practical family support">
-            <a:extLst xmlns:a="http://schemas.openxmlformats.org/drawingml/2006/main">
-              <a:ext uri="{FF2B5EF4-FFF2-40B4-BE49-F238E27FC236}">
-                <a16:creationId xmlns:a16="http://schemas.microsoft.com/office/drawing/2014/main" id="{6E4ED9D5-A008-474B-B6D8-8198955880F7}"/>
-              </a:ext>
-            </a:extLst>
-          </p:cNvPr>
-          <p:cNvSpPr>
-            <a:spLocks xmlns:a="http://schemas.openxmlformats.org/drawingml/2006/main" noGrp="1"/>
-          </p:cNvSpPr>
-          <p:nvPr/>
-        </p:nvSpPr>
-        <p:spPr>
-          <a:xfrm xmlns:a="http://schemas.openxmlformats.org/drawingml/2006/main">
-            <a:off x="9296400" y="5486400"/>
-            <a:ext cx="2362200" cy="895350"/>
-          </a:xfrm>
-          <a:prstGeom xmlns:a="http://schemas.openxmlformats.org/drawingml/2006/main" prst="rect">
-            <a:avLst/>
-          </a:prstGeom>
-          <a:noFill xmlns:a="http://schemas.openxmlformats.org/drawingml/2006/main"/>
-          <a:ln xmlns:a="http://schemas.openxmlformats.org/drawingml/2006/main" w="0">
-            <a:noFill/>
-          </a:ln>
-        </p:spPr>
-        <p:txBody>
-          <a:bodyPr xmlns:a="http://schemas.openxmlformats.org/drawingml/2006/main" wrap="square" lIns="0" tIns="0" rIns="0" bIns="0">
-            <a:normAutofit fontScale="100000"/>
-          </a:bodyPr>
-          <a:lstStyle xmlns:a="http://schemas.openxmlformats.org/drawingml/2006/main"/>
-          <a:p xmlns:a="http://schemas.openxmlformats.org/drawingml/2006/main">
-            <a:pPr>
-              <a:defRPr sz="1388" b="0">
-                <a:solidFill>
-                  <a:srgbClr val="173F33"/>
-                </a:solidFill>
-                <a:latin typeface="Arial"/>
-                <a:ea typeface="Arial"/>
-                <a:cs typeface="Arial"/>
-              </a:defRPr>
-            </a:pPr>
-            <a:r>
-              <a:rPr sz="1388" b="0">
-                <a:solidFill>
-                  <a:srgbClr val="173F33"/>
-                </a:solidFill>
-                <a:latin typeface="Arial"/>
-                <a:ea typeface="Arial"/>
-                <a:cs typeface="Arial"/>
-              </a:rPr>
-              <a:t>Plan rides and home support. Keep medicine calls, costs, paperwork and emotional support together.</a:t>
-            </a:r>
-          </a:p>
-        </p:txBody>
-      </p:sp>
-      <p:sp>
-        <p:nvSpPr>
-          <p:cNvPr id="9" name="Patient home website">
-            <a:extLst xmlns:a="http://schemas.openxmlformats.org/drawingml/2006/main">
-              <a:ext uri="{FF2B5EF4-FFF2-40B4-BE49-F238E27FC236}">
-                <a16:creationId xmlns:a16="http://schemas.microsoft.com/office/drawing/2014/main" id="{2DEBC9EB-15F0-4BF7-9AB0-39359DF9A3E7}"/>
-              </a:ext>
-            </a:extLst>
-          </p:cNvPr>
-          <p:cNvSpPr>
-            <a:spLocks xmlns:a="http://schemas.openxmlformats.org/drawingml/2006/main" noGrp="1"/>
-          </p:cNvSpPr>
-          <p:nvPr/>
-        </p:nvSpPr>
-        <p:spPr>
-          <a:xfrm xmlns:a="http://schemas.openxmlformats.org/drawingml/2006/main">
-            <a:off x="533400" y="6505575"/>
-            <a:ext cx="6381750" cy="238125"/>
-          </a:xfrm>
-          <a:prstGeom xmlns:a="http://schemas.openxmlformats.org/drawingml/2006/main" prst="rect">
-            <a:avLst/>
-          </a:prstGeom>
-          <a:noFill xmlns:a="http://schemas.openxmlformats.org/drawingml/2006/main"/>
-          <a:ln xmlns:a="http://schemas.openxmlformats.org/drawingml/2006/main" w="0">
-            <a:noFill/>
-          </a:ln>
-        </p:spPr>
-        <p:txBody>
-          <a:bodyPr xmlns:a="http://schemas.openxmlformats.org/drawingml/2006/main" wrap="square" lIns="0" tIns="0" rIns="0" bIns="0">
-            <a:normAutofit fontScale="99206"/>
-          </a:bodyPr>
-          <a:lstStyle xmlns:a="http://schemas.openxmlformats.org/drawingml/2006/main"/>
-          <a:p xmlns:a="http://schemas.openxmlformats.org/drawingml/2006/main">
-            <a:pPr>
-              <a:defRPr sz="1575" b="1">
-                <a:solidFill>
-                  <a:srgbClr val="145AC6"/>
-                </a:solidFill>
-                <a:latin typeface="Arial"/>
-                <a:ea typeface="Arial"/>
-                <a:cs typeface="Arial"/>
-              </a:defRPr>
-            </a:pPr>
-            <a:r>
-              <a:rPr sz="1575" b="1" u="sng">
-                <a:solidFill>
-                  <a:srgbClr val="145AC6"/>
-                </a:solidFill>
-                <a:latin typeface="Arial"/>
-                <a:ea typeface="Arial"/>
-                <a:cs typeface="Arial"/>
-                <a:hlinkClick xmlns:r="http://schemas.openxmlformats.org/officeDocument/2006/relationships" r:id="Rd68b69e70dcf447c"/>
-              </a:rPr>
-              <a:t>OPEN THE WEBSITE - saathi.wedevit.in</a:t>
-            </a:r>
-          </a:p>
-        </p:txBody>
-      </p:sp>
-      <p:sp>
-        <p:nvSpPr>
-          <p:cNvPr id="10" name="Support directory">
-            <a:extLst xmlns:a="http://schemas.openxmlformats.org/drawingml/2006/main">
-              <a:ext uri="{FF2B5EF4-FFF2-40B4-BE49-F238E27FC236}">
-                <a16:creationId xmlns:a16="http://schemas.microsoft.com/office/drawing/2014/main" id="{3CFB443E-C185-4D81-AA55-D5585BC6A20C}"/>
-              </a:ext>
-            </a:extLst>
-          </p:cNvPr>
-          <p:cNvSpPr>
-            <a:spLocks xmlns:a="http://schemas.openxmlformats.org/drawingml/2006/main" noGrp="1"/>
-          </p:cNvSpPr>
-          <p:nvPr/>
-        </p:nvSpPr>
-        <p:spPr>
-          <a:xfrm xmlns:a="http://schemas.openxmlformats.org/drawingml/2006/main">
-            <a:off x="7400925" y="6505575"/>
-            <a:ext cx="4257675" cy="238125"/>
-          </a:xfrm>
-          <a:prstGeom xmlns:a="http://schemas.openxmlformats.org/drawingml/2006/main" prst="rect">
-            <a:avLst/>
-          </a:prstGeom>
-          <a:noFill xmlns:a="http://schemas.openxmlformats.org/drawingml/2006/main"/>
-          <a:ln xmlns:a="http://schemas.openxmlformats.org/drawingml/2006/main" w="0">
-            <a:noFill/>
-          </a:ln>
-        </p:spPr>
-        <p:txBody>
-          <a:bodyPr xmlns:a="http://schemas.openxmlformats.org/drawingml/2006/main" wrap="square" lIns="0" tIns="0" rIns="0" bIns="0">
-            <a:normAutofit fontScale="100000"/>
-          </a:bodyPr>
-          <a:lstStyle xmlns:a="http://schemas.openxmlformats.org/drawingml/2006/main"/>
-          <a:p xmlns:a="http://schemas.openxmlformats.org/drawingml/2006/main">
-            <a:pPr>
-              <a:defRPr sz="1425" b="0">
-                <a:solidFill>
-                  <a:srgbClr val="145AC6"/>
-                </a:solidFill>
-                <a:latin typeface="Arial"/>
-                <a:ea typeface="Arial"/>
-                <a:cs typeface="Arial"/>
-              </a:defRPr>
-            </a:pPr>
-            <a:r>
-              <a:rPr sz="1425" b="0" u="sng">
-                <a:solidFill>
-                  <a:srgbClr val="145AC6"/>
-                </a:solidFill>
-                <a:latin typeface="Arial"/>
-                <a:ea typeface="Arial"/>
-                <a:cs typeface="Arial"/>
-                <a:hlinkClick xmlns:r="http://schemas.openxmlformats.org/officeDocument/2006/relationships" r:id="Rc8c285729d234c33"/>
-              </a:rPr>
-              <a:t>Find a centre and call to confirm.</a:t>
-            </a:r>
-          </a:p>
-        </p:txBody>
-      </p:sp>
-    </p:spTree>
-    <p:extLst>
-      <p:ext uri="{BB962C8B-B14F-4D97-AF65-F5344CB8AC3E}">
-        <p14:creationId xmlns:p14="http://schemas.microsoft.com/office/powerpoint/2010/main" val="221085739"/>
-      </p:ext>
-    </p:extLst>
-  </p:cSld>
-</p:sld>
-</file>
-
-<file path=ppt/slides/slide2.xml><?xml version="1.0" encoding="utf-8"?>
-<p:sld xmlns:p="http://schemas.openxmlformats.org/presentationml/2006/main">
-  <p:cSld>
-    <p:bg>
-      <p:bgPr>
-        <a:solidFill xmlns:a="http://schemas.openxmlformats.org/drawingml/2006/main">
           <a:srgbClr val="FFF6E5"/>
         </a:solidFill>
       </p:bgPr>
@@ -2675,10 +2144,10 @@
           <p:nvPr/>
         </p:nvPicPr>
         <p:blipFill>
-          <a:blip xmlns:r="http://schemas.openxmlformats.org/officeDocument/2006/relationships" xmlns:a="http://schemas.openxmlformats.org/drawingml/2006/main" r:embed="R7155c4fc442e4046">
+          <a:blip xmlns:r="http://schemas.openxmlformats.org/officeDocument/2006/relationships" xmlns:a="http://schemas.openxmlformats.org/drawingml/2006/main" r:embed="R4a4da8a1b97a4651">
             <a:extLst>
               <a:ext uri="{96DAC541-7B7A-43D3-8B79-37D633B846F1}">
-                <asvg:svgBlip xmlns:asvg="http://schemas.microsoft.com/office/drawing/2016/SVG/main" r:embed="Rbb6f12668ecb40bf"/>
+                <asvg:svgBlip xmlns:asvg="http://schemas.microsoft.com/office/drawing/2016/SVG/main" r:embed="R8ca62f39482d4814"/>
               </a:ext>
             </a:extLst>
           </a:blip>
@@ -2699,7 +2168,7 @@
           <p:cNvPr id="2" name="Brand">
             <a:extLst xmlns:a="http://schemas.openxmlformats.org/drawingml/2006/main">
               <a:ext uri="{FF2B5EF4-FFF2-40B4-BE49-F238E27FC236}">
-                <a16:creationId xmlns:a16="http://schemas.microsoft.com/office/drawing/2014/main" id="{96BE54D1-D0D6-4614-A434-E9D550FB6DFC}"/>
+                <a16:creationId xmlns:a16="http://schemas.microsoft.com/office/drawing/2014/main" id="{418AAFAB-1FDD-4803-A79F-DC43B54266BD}"/>
               </a:ext>
             </a:extLst>
           </p:cNvPr>
@@ -2756,7 +2225,7 @@
           <p:cNvPr id="3" name="Hindi name">
             <a:extLst xmlns:a="http://schemas.openxmlformats.org/drawingml/2006/main">
               <a:ext uri="{FF2B5EF4-FFF2-40B4-BE49-F238E27FC236}">
-                <a16:creationId xmlns:a16="http://schemas.microsoft.com/office/drawing/2014/main" id="{C7150D6C-A7B6-475B-8190-542CD0ADD0C8}"/>
+                <a16:creationId xmlns:a16="http://schemas.microsoft.com/office/drawing/2014/main" id="{0D122A80-256E-4310-851A-C1100A35E7DB}"/>
               </a:ext>
             </a:extLst>
           </p:cNvPr>
@@ -2813,7 +2282,7 @@
           <p:cNvPr id="4" name="Name meaning">
             <a:extLst xmlns:a="http://schemas.openxmlformats.org/drawingml/2006/main">
               <a:ext uri="{FF2B5EF4-FFF2-40B4-BE49-F238E27FC236}">
-                <a16:creationId xmlns:a16="http://schemas.microsoft.com/office/drawing/2014/main" id="{BA92B0D1-033C-4799-BD43-2184EF5F4F5E}"/>
+                <a16:creationId xmlns:a16="http://schemas.microsoft.com/office/drawing/2014/main" id="{90B23076-7179-404F-8DC1-975AADECA5AE}"/>
               </a:ext>
             </a:extLst>
           </p:cNvPr>
@@ -2870,7 +2339,7 @@
           <p:cNvPr id="5" name="Purpose">
             <a:extLst xmlns:a="http://schemas.openxmlformats.org/drawingml/2006/main">
               <a:ext uri="{FF2B5EF4-FFF2-40B4-BE49-F238E27FC236}">
-                <a16:creationId xmlns:a16="http://schemas.microsoft.com/office/drawing/2014/main" id="{3182EADB-3CF9-4752-8F42-0FBBD78AD3AD}"/>
+                <a16:creationId xmlns:a16="http://schemas.microsoft.com/office/drawing/2014/main" id="{BCFDC817-E653-426E-AFFA-0D01351A7A26}"/>
               </a:ext>
             </a:extLst>
           </p:cNvPr>
@@ -2931,7 +2400,7 @@
           <p:nvPr/>
         </p:nvPicPr>
         <p:blipFill>
-          <a:blip xmlns:r="http://schemas.openxmlformats.org/officeDocument/2006/relationships" xmlns:a="http://schemas.openxmlformats.org/drawingml/2006/main" r:embed="R73ab780a7ea646da"/>
+          <a:blip xmlns:r="http://schemas.openxmlformats.org/officeDocument/2006/relationships" xmlns:a="http://schemas.openxmlformats.org/drawingml/2006/main" r:embed="Rbc1393f139014a9b"/>
           <a:stretch xmlns:a="http://schemas.openxmlformats.org/drawingml/2006/main"/>
         </p:blipFill>
         <p:spPr>
@@ -2949,7 +2418,7 @@
           <p:cNvPr id="7" name="Website link">
             <a:extLst xmlns:a="http://schemas.openxmlformats.org/drawingml/2006/main">
               <a:ext uri="{FF2B5EF4-FFF2-40B4-BE49-F238E27FC236}">
-                <a16:creationId xmlns:a16="http://schemas.microsoft.com/office/drawing/2014/main" id="{093A7DB5-5B59-4977-A4B2-E6378E0C193D}"/>
+                <a16:creationId xmlns:a16="http://schemas.microsoft.com/office/drawing/2014/main" id="{B9F2D566-C406-4A9B-BEC8-F03D4AE20FD5}"/>
               </a:ext>
             </a:extLst>
           </p:cNvPr>
@@ -2995,7 +2464,7 @@
                 <a:latin typeface="Arial"/>
                 <a:ea typeface="Arial"/>
                 <a:cs typeface="Arial"/>
-                <a:hlinkClick xmlns:r="http://schemas.openxmlformats.org/officeDocument/2006/relationships" r:id="Re478a03fdd704f19"/>
+                <a:hlinkClick xmlns:r="http://schemas.openxmlformats.org/officeDocument/2006/relationships" r:id="R9e450a0b56884aa2"/>
               </a:rPr>
               <a:t>OPEN THE WEBSITE - saathi.wedevit.in</a:t>
             </a:r>
@@ -3011,10 +2480,10 @@
           <p:nvPr/>
         </p:nvPicPr>
         <p:blipFill>
-          <a:blip xmlns:r="http://schemas.openxmlformats.org/officeDocument/2006/relationships" xmlns:a="http://schemas.openxmlformats.org/drawingml/2006/main" r:embed="Rce6b0f217cda47d4">
+          <a:blip xmlns:r="http://schemas.openxmlformats.org/officeDocument/2006/relationships" xmlns:a="http://schemas.openxmlformats.org/drawingml/2006/main" r:embed="R575ed5f4efc6417f">
             <a:extLst>
               <a:ext uri="{96DAC541-7B7A-43D3-8B79-37D633B846F1}">
-                <asvg:svgBlip xmlns:asvg="http://schemas.microsoft.com/office/drawing/2016/SVG/main" r:embed="R801159551e174ea3"/>
+                <asvg:svgBlip xmlns:asvg="http://schemas.microsoft.com/office/drawing/2016/SVG/main" r:embed="R2576b7841f4142af"/>
               </a:ext>
             </a:extLst>
           </a:blip>
@@ -3035,7 +2504,7 @@
           <p:cNvPr id="9" name="Repository link">
             <a:extLst xmlns:a="http://schemas.openxmlformats.org/drawingml/2006/main">
               <a:ext uri="{FF2B5EF4-FFF2-40B4-BE49-F238E27FC236}">
-                <a16:creationId xmlns:a16="http://schemas.microsoft.com/office/drawing/2014/main" id="{A3ED1288-B0F2-417B-86C2-AA25441F414A}"/>
+                <a16:creationId xmlns:a16="http://schemas.microsoft.com/office/drawing/2014/main" id="{BC3EED23-8134-493D-B055-0971F449E76D}"/>
               </a:ext>
             </a:extLst>
           </p:cNvPr>
@@ -3081,7 +2550,7 @@
                 <a:latin typeface="Arial"/>
                 <a:ea typeface="Arial"/>
                 <a:cs typeface="Arial"/>
-                <a:hlinkClick xmlns:r="http://schemas.openxmlformats.org/officeDocument/2006/relationships" r:id="Re285b84dacad4b39"/>
+                <a:hlinkClick xmlns:r="http://schemas.openxmlformats.org/officeDocument/2006/relationships" r:id="Rbd8fc42f8ac3457d"/>
               </a:rPr>
               <a:t>github.com/basithladdu/healthathon</a:t>
             </a:r>
@@ -3097,10 +2566,10 @@
           <p:nvPr/>
         </p:nvPicPr>
         <p:blipFill>
-          <a:blip xmlns:r="http://schemas.openxmlformats.org/officeDocument/2006/relationships" xmlns:a="http://schemas.openxmlformats.org/drawingml/2006/main" r:embed="R276b65f1067a4029">
+          <a:blip xmlns:r="http://schemas.openxmlformats.org/officeDocument/2006/relationships" xmlns:a="http://schemas.openxmlformats.org/drawingml/2006/main" r:embed="R17fd41a0679e42f7">
             <a:extLst>
               <a:ext uri="{96DAC541-7B7A-43D3-8B79-37D633B846F1}">
-                <asvg:svgBlip xmlns:asvg="http://schemas.microsoft.com/office/drawing/2016/SVG/main" r:embed="R52b61b016c524479"/>
+                <asvg:svgBlip xmlns:asvg="http://schemas.microsoft.com/office/drawing/2016/SVG/main" r:embed="Rc9216592157f4566"/>
               </a:ext>
             </a:extLst>
           </a:blip>
@@ -3121,7 +2590,7 @@
           <p:cNvPr id="11" name="Questions contact">
             <a:extLst xmlns:a="http://schemas.openxmlformats.org/drawingml/2006/main">
               <a:ext uri="{FF2B5EF4-FFF2-40B4-BE49-F238E27FC236}">
-                <a16:creationId xmlns:a16="http://schemas.microsoft.com/office/drawing/2014/main" id="{FF337158-612B-48D1-8D96-54526E2C4A83}"/>
+                <a16:creationId xmlns:a16="http://schemas.microsoft.com/office/drawing/2014/main" id="{B3E417B3-DBA5-4D0F-918C-C4CD382C2CED}"/>
               </a:ext>
             </a:extLst>
           </p:cNvPr>
@@ -3167,7 +2636,7 @@
                 <a:latin typeface="Arial"/>
                 <a:ea typeface="Arial"/>
                 <a:cs typeface="Arial"/>
-                <a:hlinkClick xmlns:r="http://schemas.openxmlformats.org/officeDocument/2006/relationships" r:id="Rcfe228b96b454329"/>
+                <a:hlinkClick xmlns:r="http://schemas.openxmlformats.org/officeDocument/2006/relationships" r:id="R48a23460611e411a"/>
               </a:rPr>
               <a:t>Questions? Contact us</a:t>
             </a:r>
@@ -3179,7 +2648,7 @@
           <p:cNvPr id="12" name="WhatsApp link">
             <a:extLst xmlns:a="http://schemas.openxmlformats.org/drawingml/2006/main">
               <a:ext uri="{FF2B5EF4-FFF2-40B4-BE49-F238E27FC236}">
-                <a16:creationId xmlns:a16="http://schemas.microsoft.com/office/drawing/2014/main" id="{0778F4A2-AD6C-48FF-83A2-EDAA05885123}"/>
+                <a16:creationId xmlns:a16="http://schemas.microsoft.com/office/drawing/2014/main" id="{4DD98DBD-267D-4956-9020-1252EB3CDB5C}"/>
               </a:ext>
             </a:extLst>
           </p:cNvPr>
@@ -3225,7 +2694,7 @@
                 <a:latin typeface="Arial"/>
                 <a:ea typeface="Arial"/>
                 <a:cs typeface="Arial"/>
-                <a:hlinkClick xmlns:r="http://schemas.openxmlformats.org/officeDocument/2006/relationships" r:id="R78ccfdfd1a2649f3"/>
+                <a:hlinkClick xmlns:r="http://schemas.openxmlformats.org/officeDocument/2006/relationships" r:id="R0c0527758f184db6"/>
               </a:rPr>
               <a:t>wa.me/919553321211</a:t>
             </a:r>
@@ -3237,7 +2706,7 @@
           <p:cNvPr id="13" name="">
             <a:extLst xmlns:a="http://schemas.openxmlformats.org/drawingml/2006/main">
               <a:ext uri="{FF2B5EF4-FFF2-40B4-BE49-F238E27FC236}">
-                <a16:creationId xmlns:a16="http://schemas.microsoft.com/office/drawing/2014/main" id="{F1C76AF2-2A78-4635-8C06-598D3E2A3D29}"/>
+                <a16:creationId xmlns:a16="http://schemas.microsoft.com/office/drawing/2014/main" id="{19497489-3080-4631-9642-F85A4CD139EE}"/>
               </a:ext>
             </a:extLst>
           </p:cNvPr>
@@ -3266,7 +2735,7 @@
           <p:cNvPr id="14" name="Team heading">
             <a:extLst xmlns:a="http://schemas.openxmlformats.org/drawingml/2006/main">
               <a:ext uri="{FF2B5EF4-FFF2-40B4-BE49-F238E27FC236}">
-                <a16:creationId xmlns:a16="http://schemas.microsoft.com/office/drawing/2014/main" id="{F4D94CFE-5C49-47EE-97F4-B3B862FDA2AD}"/>
+                <a16:creationId xmlns:a16="http://schemas.microsoft.com/office/drawing/2014/main" id="{276E980B-A438-4A93-958F-AA3E6A89D32E}"/>
               </a:ext>
             </a:extLst>
           </p:cNvPr>
@@ -3327,7 +2796,7 @@
           <p:nvPr/>
         </p:nvPicPr>
         <p:blipFill>
-          <a:blip xmlns:r="http://schemas.openxmlformats.org/officeDocument/2006/relationships" xmlns:a="http://schemas.openxmlformats.org/drawingml/2006/main" r:embed="R01f648ef83614ab4"/>
+          <a:blip xmlns:r="http://schemas.openxmlformats.org/officeDocument/2006/relationships" xmlns:a="http://schemas.openxmlformats.org/drawingml/2006/main" r:embed="Rb6935264bf9242c1"/>
           <a:srcRect xmlns:a="http://schemas.openxmlformats.org/drawingml/2006/main" l="0" t="5331" r="0" b="5331"/>
           <a:stretch xmlns:a="http://schemas.openxmlformats.org/drawingml/2006/main">
             <a:fillRect l="0" t="0" r="0" b="0"/>
@@ -3348,7 +2817,7 @@
           <p:cNvPr id="16" name="Team member 1">
             <a:extLst xmlns:a="http://schemas.openxmlformats.org/drawingml/2006/main">
               <a:ext uri="{FF2B5EF4-FFF2-40B4-BE49-F238E27FC236}">
-                <a16:creationId xmlns:a16="http://schemas.microsoft.com/office/drawing/2014/main" id="{E0614911-0FD5-4CB2-99BA-83AC20D206C5}"/>
+                <a16:creationId xmlns:a16="http://schemas.microsoft.com/office/drawing/2014/main" id="{E298E0DA-BD6F-4F78-8235-8C8913F0F962}"/>
               </a:ext>
             </a:extLst>
           </p:cNvPr>
@@ -3428,7 +2897,7 @@
           <p:cNvPr id="17" name="Team role 1">
             <a:extLst xmlns:a="http://schemas.openxmlformats.org/drawingml/2006/main">
               <a:ext uri="{FF2B5EF4-FFF2-40B4-BE49-F238E27FC236}">
-                <a16:creationId xmlns:a16="http://schemas.microsoft.com/office/drawing/2014/main" id="{4F3C4680-CF5C-43DF-AB0A-D1C2390B5268}"/>
+                <a16:creationId xmlns:a16="http://schemas.microsoft.com/office/drawing/2014/main" id="{3B00B3FC-0A53-478A-A5DB-1D5F41A627C7}"/>
               </a:ext>
             </a:extLst>
           </p:cNvPr>
@@ -3489,7 +2958,7 @@
           <p:nvPr/>
         </p:nvPicPr>
         <p:blipFill>
-          <a:blip xmlns:r="http://schemas.openxmlformats.org/officeDocument/2006/relationships" xmlns:a="http://schemas.openxmlformats.org/drawingml/2006/main" r:embed="R9d23964246564713"/>
+          <a:blip xmlns:r="http://schemas.openxmlformats.org/officeDocument/2006/relationships" xmlns:a="http://schemas.openxmlformats.org/drawingml/2006/main" r:embed="R445de02fa822493c"/>
           <a:srcRect xmlns:a="http://schemas.openxmlformats.org/drawingml/2006/main" l="0" t="19104" r="0" b="19104"/>
           <a:stretch xmlns:a="http://schemas.openxmlformats.org/drawingml/2006/main">
             <a:fillRect l="0" t="0" r="0" b="0"/>
@@ -3510,7 +2979,7 @@
           <p:cNvPr id="19" name="Team member 2">
             <a:extLst xmlns:a="http://schemas.openxmlformats.org/drawingml/2006/main">
               <a:ext uri="{FF2B5EF4-FFF2-40B4-BE49-F238E27FC236}">
-                <a16:creationId xmlns:a16="http://schemas.microsoft.com/office/drawing/2014/main" id="{5801B780-8C77-4837-B7AB-A61F18C982C9}"/>
+                <a16:creationId xmlns:a16="http://schemas.microsoft.com/office/drawing/2014/main" id="{D892960C-180D-420D-8164-58C299ABD1CC}"/>
               </a:ext>
             </a:extLst>
           </p:cNvPr>
@@ -3590,7 +3059,7 @@
           <p:cNvPr id="20" name="Team role 2">
             <a:extLst xmlns:a="http://schemas.openxmlformats.org/drawingml/2006/main">
               <a:ext uri="{FF2B5EF4-FFF2-40B4-BE49-F238E27FC236}">
-                <a16:creationId xmlns:a16="http://schemas.microsoft.com/office/drawing/2014/main" id="{3C9F13AC-9B70-4968-BCE5-BBCA7CAB3D24}"/>
+                <a16:creationId xmlns:a16="http://schemas.microsoft.com/office/drawing/2014/main" id="{13CD9112-7EEA-4569-BC0C-84F66AE628FD}"/>
               </a:ext>
             </a:extLst>
           </p:cNvPr>
@@ -3647,7 +3116,7 @@
           <p:cNvPr id="21" name="Photo space for Dr Sharada&#10;Vinod Kutty">
             <a:extLst xmlns:a="http://schemas.openxmlformats.org/drawingml/2006/main">
               <a:ext uri="{FF2B5EF4-FFF2-40B4-BE49-F238E27FC236}">
-                <a16:creationId xmlns:a16="http://schemas.microsoft.com/office/drawing/2014/main" id="{56922103-3660-405B-A5E0-867189EB8EB0}"/>
+                <a16:creationId xmlns:a16="http://schemas.microsoft.com/office/drawing/2014/main" id="{D2BB19F0-6EAE-4850-BD1A-38BCBAEF08F2}"/>
               </a:ext>
             </a:extLst>
           </p:cNvPr>
@@ -3679,7 +3148,7 @@
           <p:cNvPr id="22" name="Team member 3">
             <a:extLst xmlns:a="http://schemas.openxmlformats.org/drawingml/2006/main">
               <a:ext uri="{FF2B5EF4-FFF2-40B4-BE49-F238E27FC236}">
-                <a16:creationId xmlns:a16="http://schemas.microsoft.com/office/drawing/2014/main" id="{5841E01F-1281-4310-91B3-B1951D14712D}"/>
+                <a16:creationId xmlns:a16="http://schemas.microsoft.com/office/drawing/2014/main" id="{E9117FD6-7DB3-4661-82EE-4C472200749A}"/>
               </a:ext>
             </a:extLst>
           </p:cNvPr>
@@ -3759,7 +3228,7 @@
           <p:cNvPr id="23" name="Team role 3">
             <a:extLst xmlns:a="http://schemas.openxmlformats.org/drawingml/2006/main">
               <a:ext uri="{FF2B5EF4-FFF2-40B4-BE49-F238E27FC236}">
-                <a16:creationId xmlns:a16="http://schemas.microsoft.com/office/drawing/2014/main" id="{26CEE53B-AB87-4547-91A2-B5CC94AAEFED}"/>
+                <a16:creationId xmlns:a16="http://schemas.microsoft.com/office/drawing/2014/main" id="{1F04A683-4ADD-4AD3-8670-9A22B4AA4002}"/>
               </a:ext>
             </a:extLst>
           </p:cNvPr>
@@ -3816,7 +3285,7 @@
           <p:cNvPr id="24" name="Photo space for Dr Sujay&#10;Halkur Shankar">
             <a:extLst xmlns:a="http://schemas.openxmlformats.org/drawingml/2006/main">
               <a:ext uri="{FF2B5EF4-FFF2-40B4-BE49-F238E27FC236}">
-                <a16:creationId xmlns:a16="http://schemas.microsoft.com/office/drawing/2014/main" id="{3F87F583-3357-4855-99FC-71E8EF4D0210}"/>
+                <a16:creationId xmlns:a16="http://schemas.microsoft.com/office/drawing/2014/main" id="{F5320B9B-A5EB-43DE-ADA2-A5AC8E45E47D}"/>
               </a:ext>
             </a:extLst>
           </p:cNvPr>
@@ -3848,7 +3317,7 @@
           <p:cNvPr id="25" name="Team member 4">
             <a:extLst xmlns:a="http://schemas.openxmlformats.org/drawingml/2006/main">
               <a:ext uri="{FF2B5EF4-FFF2-40B4-BE49-F238E27FC236}">
-                <a16:creationId xmlns:a16="http://schemas.microsoft.com/office/drawing/2014/main" id="{D39F784B-AC03-4BB5-97AE-8FA6ADB91DB1}"/>
+                <a16:creationId xmlns:a16="http://schemas.microsoft.com/office/drawing/2014/main" id="{468D4804-F236-404A-8763-70D761E94355}"/>
               </a:ext>
             </a:extLst>
           </p:cNvPr>
@@ -3928,7 +3397,7 @@
           <p:cNvPr id="26" name="Team role 4">
             <a:extLst xmlns:a="http://schemas.openxmlformats.org/drawingml/2006/main">
               <a:ext uri="{FF2B5EF4-FFF2-40B4-BE49-F238E27FC236}">
-                <a16:creationId xmlns:a16="http://schemas.microsoft.com/office/drawing/2014/main" id="{AD3C4E5D-42D2-4BDC-96A7-317D94E7134F}"/>
+                <a16:creationId xmlns:a16="http://schemas.microsoft.com/office/drawing/2014/main" id="{269628AA-3EBB-4904-A5D6-67062205AE3C}"/>
               </a:ext>
             </a:extLst>
           </p:cNvPr>
@@ -3985,7 +3454,7 @@
           <p:cNvPr id="27" name="Photo space for Shirin Ayub">
             <a:extLst xmlns:a="http://schemas.openxmlformats.org/drawingml/2006/main">
               <a:ext uri="{FF2B5EF4-FFF2-40B4-BE49-F238E27FC236}">
-                <a16:creationId xmlns:a16="http://schemas.microsoft.com/office/drawing/2014/main" id="{7092B016-9083-4BA1-9932-8CECD8BEE181}"/>
+                <a16:creationId xmlns:a16="http://schemas.microsoft.com/office/drawing/2014/main" id="{E4C707B9-9761-4C40-AFA2-DFC47E04C666}"/>
               </a:ext>
             </a:extLst>
           </p:cNvPr>
@@ -4017,7 +3486,7 @@
           <p:cNvPr id="28" name="Team member 5">
             <a:extLst xmlns:a="http://schemas.openxmlformats.org/drawingml/2006/main">
               <a:ext uri="{FF2B5EF4-FFF2-40B4-BE49-F238E27FC236}">
-                <a16:creationId xmlns:a16="http://schemas.microsoft.com/office/drawing/2014/main" id="{79D6B3FC-40FC-4F9F-8841-808BE92D73DA}"/>
+                <a16:creationId xmlns:a16="http://schemas.microsoft.com/office/drawing/2014/main" id="{C2FC0321-28FB-41B0-88E7-16AF033625CC}"/>
               </a:ext>
             </a:extLst>
           </p:cNvPr>
@@ -4074,7 +3543,7 @@
           <p:cNvPr id="29" name="Team role 5">
             <a:extLst xmlns:a="http://schemas.openxmlformats.org/drawingml/2006/main">
               <a:ext uri="{FF2B5EF4-FFF2-40B4-BE49-F238E27FC236}">
-                <a16:creationId xmlns:a16="http://schemas.microsoft.com/office/drawing/2014/main" id="{93F62706-F442-4734-82F3-36409AEE8815}"/>
+                <a16:creationId xmlns:a16="http://schemas.microsoft.com/office/drawing/2014/main" id="{357CAE59-F643-413B-BA93-2DEE90625A17}"/>
               </a:ext>
             </a:extLst>
           </p:cNvPr>
@@ -4136,7 +3605,7 @@
 </p:sld>
 </file>
 
-<file path=ppt/slides/slide3.xml><?xml version="1.0" encoding="utf-8"?>
+<file path=ppt/slides/slide2.xml><?xml version="1.0" encoding="utf-8"?>
 <p:sld xmlns:p="http://schemas.openxmlformats.org/presentationml/2006/main">
   <p:cSld>
     <p:bg>
@@ -4160,7 +3629,7 @@
           <p:cNvPr id="16" name="Slide title">
             <a:extLst xmlns:a="http://schemas.openxmlformats.org/drawingml/2006/main">
               <a:ext uri="{FF2B5EF4-FFF2-40B4-BE49-F238E27FC236}">
-                <a16:creationId xmlns:a16="http://schemas.microsoft.com/office/drawing/2014/main" id="{99457DD7-45BE-4283-8E0A-7669687E9D31}"/>
+                <a16:creationId xmlns:a16="http://schemas.microsoft.com/office/drawing/2014/main" id="{DFD5C514-0D50-4F63-B734-DB2FD3573033}"/>
               </a:ext>
             </a:extLst>
           </p:cNvPr>
@@ -4221,7 +3690,7 @@
           <p:nvPr/>
         </p:nvPicPr>
         <p:blipFill>
-          <a:blip xmlns:r="http://schemas.openxmlformats.org/officeDocument/2006/relationships" xmlns:a="http://schemas.openxmlformats.org/drawingml/2006/main" r:embed="R97b173f0417345f6"/>
+          <a:blip xmlns:r="http://schemas.openxmlformats.org/officeDocument/2006/relationships" xmlns:a="http://schemas.openxmlformats.org/drawingml/2006/main" r:embed="Rd0e89ef268b64c9f"/>
           <a:stretch xmlns:a="http://schemas.openxmlformats.org/drawingml/2006/main"/>
         </p:blipFill>
         <p:spPr>
@@ -4239,7 +3708,7 @@
           <p:cNvPr id="3" name="Care photo context">
             <a:extLst xmlns:a="http://schemas.openxmlformats.org/drawingml/2006/main">
               <a:ext uri="{FF2B5EF4-FFF2-40B4-BE49-F238E27FC236}">
-                <a16:creationId xmlns:a16="http://schemas.microsoft.com/office/drawing/2014/main" id="{9BE25906-3C9C-4DEE-90C0-BD9CEA1D16DF}"/>
+                <a16:creationId xmlns:a16="http://schemas.microsoft.com/office/drawing/2014/main" id="{D2441B6D-9D75-4126-AFB7-F3A6A74CBA55}"/>
               </a:ext>
             </a:extLst>
           </p:cNvPr>
@@ -4296,7 +3765,7 @@
           <p:cNvPr id="4" name="Illustrative patient">
             <a:extLst xmlns:a="http://schemas.openxmlformats.org/drawingml/2006/main">
               <a:ext uri="{FF2B5EF4-FFF2-40B4-BE49-F238E27FC236}">
-                <a16:creationId xmlns:a16="http://schemas.microsoft.com/office/drawing/2014/main" id="{4AF693ED-8D2E-42B1-A27C-85A1853BB4E3}"/>
+                <a16:creationId xmlns:a16="http://schemas.microsoft.com/office/drawing/2014/main" id="{00195D5A-2029-40E4-9910-C0660697F497}"/>
               </a:ext>
             </a:extLst>
           </p:cNvPr>
@@ -4357,10 +3826,10 @@
           <p:nvPr/>
         </p:nvPicPr>
         <p:blipFill>
-          <a:blip xmlns:r="http://schemas.openxmlformats.org/officeDocument/2006/relationships" xmlns:a="http://schemas.openxmlformats.org/drawingml/2006/main" r:embed="R4a1b7d8727fe4b62">
+          <a:blip xmlns:r="http://schemas.openxmlformats.org/officeDocument/2006/relationships" xmlns:a="http://schemas.openxmlformats.org/drawingml/2006/main" r:embed="Rc6d944e4b545448c">
             <a:extLst>
               <a:ext uri="{96DAC541-7B7A-43D3-8B79-37D633B846F1}">
-                <asvg:svgBlip xmlns:asvg="http://schemas.microsoft.com/office/drawing/2016/SVG/main" r:embed="R64282b724b0f492f"/>
+                <asvg:svgBlip xmlns:asvg="http://schemas.microsoft.com/office/drawing/2016/SVG/main" r:embed="R3645ad1616634e1f"/>
               </a:ext>
             </a:extLst>
           </a:blip>
@@ -4381,7 +3850,7 @@
           <p:cNvPr id="6" name="Story step 1">
             <a:extLst xmlns:a="http://schemas.openxmlformats.org/drawingml/2006/main">
               <a:ext uri="{FF2B5EF4-FFF2-40B4-BE49-F238E27FC236}">
-                <a16:creationId xmlns:a16="http://schemas.microsoft.com/office/drawing/2014/main" id="{CBDB79B3-2810-42BA-9764-784EDC2AB564}"/>
+                <a16:creationId xmlns:a16="http://schemas.microsoft.com/office/drawing/2014/main" id="{04E1E969-AD29-4D13-B1AF-A965E4E28AEF}"/>
               </a:ext>
             </a:extLst>
           </p:cNvPr>
@@ -4438,7 +3907,7 @@
           <p:cNvPr id="7" name="Story step 1 detail">
             <a:extLst xmlns:a="http://schemas.openxmlformats.org/drawingml/2006/main">
               <a:ext uri="{FF2B5EF4-FFF2-40B4-BE49-F238E27FC236}">
-                <a16:creationId xmlns:a16="http://schemas.microsoft.com/office/drawing/2014/main" id="{190922CF-1B05-4691-A51D-E966983FBB0C}"/>
+                <a16:creationId xmlns:a16="http://schemas.microsoft.com/office/drawing/2014/main" id="{6571E9A9-0090-4AA4-A9D5-2AFC0C0DC610}"/>
               </a:ext>
             </a:extLst>
           </p:cNvPr>
@@ -4499,10 +3968,10 @@
           <p:nvPr/>
         </p:nvPicPr>
         <p:blipFill>
-          <a:blip xmlns:r="http://schemas.openxmlformats.org/officeDocument/2006/relationships" xmlns:a="http://schemas.openxmlformats.org/drawingml/2006/main" r:embed="Ra721dafa85284225">
+          <a:blip xmlns:r="http://schemas.openxmlformats.org/officeDocument/2006/relationships" xmlns:a="http://schemas.openxmlformats.org/drawingml/2006/main" r:embed="R06fd89c7888c4f2c">
             <a:extLst>
               <a:ext uri="{96DAC541-7B7A-43D3-8B79-37D633B846F1}">
-                <asvg:svgBlip xmlns:asvg="http://schemas.microsoft.com/office/drawing/2016/SVG/main" r:embed="Rf737962c9f7b47df"/>
+                <asvg:svgBlip xmlns:asvg="http://schemas.microsoft.com/office/drawing/2016/SVG/main" r:embed="Rc77457fba766497f"/>
               </a:ext>
             </a:extLst>
           </a:blip>
@@ -4523,7 +3992,7 @@
           <p:cNvPr id="9" name="Story step 2">
             <a:extLst xmlns:a="http://schemas.openxmlformats.org/drawingml/2006/main">
               <a:ext uri="{FF2B5EF4-FFF2-40B4-BE49-F238E27FC236}">
-                <a16:creationId xmlns:a16="http://schemas.microsoft.com/office/drawing/2014/main" id="{1EC96354-0730-40D5-AC1E-D4785CCE2DFA}"/>
+                <a16:creationId xmlns:a16="http://schemas.microsoft.com/office/drawing/2014/main" id="{63FB2085-A2C3-47B1-B78E-E90901D2667A}"/>
               </a:ext>
             </a:extLst>
           </p:cNvPr>
@@ -4580,7 +4049,7 @@
           <p:cNvPr id="10" name="Story step 2 detail">
             <a:extLst xmlns:a="http://schemas.openxmlformats.org/drawingml/2006/main">
               <a:ext uri="{FF2B5EF4-FFF2-40B4-BE49-F238E27FC236}">
-                <a16:creationId xmlns:a16="http://schemas.microsoft.com/office/drawing/2014/main" id="{C1B4EF40-F08F-40B1-9065-CB83140F01AC}"/>
+                <a16:creationId xmlns:a16="http://schemas.microsoft.com/office/drawing/2014/main" id="{616215DB-026C-4D81-A7FD-4A27C6A1641F}"/>
               </a:ext>
             </a:extLst>
           </p:cNvPr>
@@ -4641,10 +4110,10 @@
           <p:nvPr/>
         </p:nvPicPr>
         <p:blipFill>
-          <a:blip xmlns:r="http://schemas.openxmlformats.org/officeDocument/2006/relationships" xmlns:a="http://schemas.openxmlformats.org/drawingml/2006/main" r:embed="R5b9881006f6d4578">
+          <a:blip xmlns:r="http://schemas.openxmlformats.org/officeDocument/2006/relationships" xmlns:a="http://schemas.openxmlformats.org/drawingml/2006/main" r:embed="R360646fc022446d1">
             <a:extLst>
               <a:ext uri="{96DAC541-7B7A-43D3-8B79-37D633B846F1}">
-                <asvg:svgBlip xmlns:asvg="http://schemas.microsoft.com/office/drawing/2016/SVG/main" r:embed="R8a627815eecd4d93"/>
+                <asvg:svgBlip xmlns:asvg="http://schemas.microsoft.com/office/drawing/2016/SVG/main" r:embed="Rc3bc28002c2d4204"/>
               </a:ext>
             </a:extLst>
           </a:blip>
@@ -4665,7 +4134,7 @@
           <p:cNvPr id="12" name="Story step 3">
             <a:extLst xmlns:a="http://schemas.openxmlformats.org/drawingml/2006/main">
               <a:ext uri="{FF2B5EF4-FFF2-40B4-BE49-F238E27FC236}">
-                <a16:creationId xmlns:a16="http://schemas.microsoft.com/office/drawing/2014/main" id="{BA5A42B4-8E91-4D3D-86BE-BC1560F3AC45}"/>
+                <a16:creationId xmlns:a16="http://schemas.microsoft.com/office/drawing/2014/main" id="{4A5DED47-3603-4329-8DDF-8D90B1E425A7}"/>
               </a:ext>
             </a:extLst>
           </p:cNvPr>
@@ -4722,7 +4191,7 @@
           <p:cNvPr id="13" name="Story step 3 detail">
             <a:extLst xmlns:a="http://schemas.openxmlformats.org/drawingml/2006/main">
               <a:ext uri="{FF2B5EF4-FFF2-40B4-BE49-F238E27FC236}">
-                <a16:creationId xmlns:a16="http://schemas.microsoft.com/office/drawing/2014/main" id="{E81C76CC-01F8-47E2-A7CE-EC7726DD18A1}"/>
+                <a16:creationId xmlns:a16="http://schemas.microsoft.com/office/drawing/2014/main" id="{EFC8410A-B92D-457B-B438-C7656031B336}"/>
               </a:ext>
             </a:extLst>
           </p:cNvPr>
@@ -4779,7 +4248,7 @@
           <p:cNvPr id="14" name="Shared record takeaway">
             <a:extLst xmlns:a="http://schemas.openxmlformats.org/drawingml/2006/main">
               <a:ext uri="{FF2B5EF4-FFF2-40B4-BE49-F238E27FC236}">
-                <a16:creationId xmlns:a16="http://schemas.microsoft.com/office/drawing/2014/main" id="{42F2568C-6B2E-4BC3-A592-53BCB8575127}"/>
+                <a16:creationId xmlns:a16="http://schemas.microsoft.com/office/drawing/2014/main" id="{7E3CA69D-583D-40A8-87B9-A56C736A3755}"/>
               </a:ext>
             </a:extLst>
           </p:cNvPr>
@@ -4809,7 +4278,7 @@
           <p:cNvPr id="15" name="Closing thought">
             <a:extLst xmlns:a="http://schemas.openxmlformats.org/drawingml/2006/main">
               <a:ext uri="{FF2B5EF4-FFF2-40B4-BE49-F238E27FC236}">
-                <a16:creationId xmlns:a16="http://schemas.microsoft.com/office/drawing/2014/main" id="{F51269BF-CB16-4132-ADA8-282A8DA433D9}"/>
+                <a16:creationId xmlns:a16="http://schemas.microsoft.com/office/drawing/2014/main" id="{176C47F1-28BC-4685-BA91-E0297F17F218}"/>
               </a:ext>
             </a:extLst>
           </p:cNvPr>
@@ -4871,743 +4340,7 @@
 </p:sld>
 </file>
 
-<file path=ppt/slides/slide4.xml><?xml version="1.0" encoding="utf-8"?>
-<p:sld xmlns:p="http://schemas.openxmlformats.org/presentationml/2006/main">
-  <p:cSld>
-    <p:bg>
-      <p:bgPr>
-        <a:solidFill xmlns:a="http://schemas.openxmlformats.org/drawingml/2006/main">
-          <a:srgbClr val="FFC799"/>
-        </a:solidFill>
-      </p:bgPr>
-    </p:bg>
-    <p:spTree>
-      <p:nvGrpSpPr>
-        <p:cNvPr id="1" name=""/>
-        <p:cNvGrpSpPr/>
-        <p:nvPr/>
-      </p:nvGrpSpPr>
-      <p:grpSpPr>
-        <a:xfrm xmlns:a="http://schemas.openxmlformats.org/drawingml/2006/main"/>
-      </p:grpSpPr>
-      <p:sp>
-        <p:nvSpPr>
-          <p:cNvPr id="14" name="Slide title">
-            <a:extLst xmlns:a="http://schemas.openxmlformats.org/drawingml/2006/main">
-              <a:ext uri="{FF2B5EF4-FFF2-40B4-BE49-F238E27FC236}">
-                <a16:creationId xmlns:a16="http://schemas.microsoft.com/office/drawing/2014/main" id="{1FCC484E-44B7-49E9-B245-4A47DAE5745A}"/>
-              </a:ext>
-            </a:extLst>
-          </p:cNvPr>
-          <p:cNvSpPr>
-            <a:spLocks xmlns:a="http://schemas.openxmlformats.org/drawingml/2006/main" noGrp="1"/>
-          </p:cNvSpPr>
-          <p:nvPr/>
-        </p:nvSpPr>
-        <p:spPr>
-          <a:xfrm xmlns:a="http://schemas.openxmlformats.org/drawingml/2006/main">
-            <a:off x="533400" y="361950"/>
-            <a:ext cx="11125200" cy="600075"/>
-          </a:xfrm>
-          <a:prstGeom xmlns:a="http://schemas.openxmlformats.org/drawingml/2006/main" prst="rect">
-            <a:avLst/>
-          </a:prstGeom>
-          <a:noFill xmlns:a="http://schemas.openxmlformats.org/drawingml/2006/main"/>
-          <a:ln xmlns:a="http://schemas.openxmlformats.org/drawingml/2006/main" w="0">
-            <a:noFill/>
-          </a:ln>
-        </p:spPr>
-        <p:txBody>
-          <a:bodyPr xmlns:a="http://schemas.openxmlformats.org/drawingml/2006/main" wrap="square" lIns="0" tIns="0" rIns="0" bIns="0">
-            <a:normAutofit fontScale="100000"/>
-          </a:bodyPr>
-          <a:lstStyle xmlns:a="http://schemas.openxmlformats.org/drawingml/2006/main"/>
-          <a:p xmlns:a="http://schemas.openxmlformats.org/drawingml/2006/main">
-            <a:pPr>
-              <a:defRPr sz="2925" b="1">
-                <a:solidFill>
-                  <a:srgbClr val="173F33"/>
-                </a:solidFill>
-                <a:latin typeface="Arial"/>
-                <a:ea typeface="Arial"/>
-                <a:cs typeface="Arial"/>
-              </a:defRPr>
-            </a:pPr>
-            <a:r>
-              <a:rPr sz="2925" b="1">
-                <a:solidFill>
-                  <a:srgbClr val="173F33"/>
-                </a:solidFill>
-                <a:latin typeface="Arial"/>
-                <a:ea typeface="Arial"/>
-                <a:cs typeface="Arial"/>
-              </a:rPr>
-              <a:t>AI prepares the note. People check and sign it.</a:t>
-            </a:r>
-          </a:p>
-        </p:txBody>
-      </p:sp>
-      <p:sp>
-        <p:nvSpPr>
-          <p:cNvPr id="2" name="Human review">
-            <a:extLst xmlns:a="http://schemas.openxmlformats.org/drawingml/2006/main">
-              <a:ext uri="{FF2B5EF4-FFF2-40B4-BE49-F238E27FC236}">
-                <a16:creationId xmlns:a16="http://schemas.microsoft.com/office/drawing/2014/main" id="{A5AB5DCF-511F-40DC-9497-E0BF889D0C07}"/>
-              </a:ext>
-            </a:extLst>
-          </p:cNvPr>
-          <p:cNvSpPr>
-            <a:spLocks xmlns:a="http://schemas.openxmlformats.org/drawingml/2006/main" noGrp="1"/>
-          </p:cNvSpPr>
-          <p:nvPr/>
-        </p:nvSpPr>
-        <p:spPr>
-          <a:xfrm xmlns:a="http://schemas.openxmlformats.org/drawingml/2006/main">
-            <a:off x="533400" y="1028700"/>
-            <a:ext cx="11125200" cy="400050"/>
-          </a:xfrm>
-          <a:prstGeom xmlns:a="http://schemas.openxmlformats.org/drawingml/2006/main" prst="rect">
-            <a:avLst/>
-          </a:prstGeom>
-          <a:noFill xmlns:a="http://schemas.openxmlformats.org/drawingml/2006/main"/>
-          <a:ln xmlns:a="http://schemas.openxmlformats.org/drawingml/2006/main" w="0">
-            <a:noFill/>
-          </a:ln>
-        </p:spPr>
-        <p:txBody>
-          <a:bodyPr xmlns:a="http://schemas.openxmlformats.org/drawingml/2006/main" wrap="square" lIns="0" tIns="0" rIns="0" bIns="0">
-            <a:normAutofit fontScale="100000"/>
-          </a:bodyPr>
-          <a:lstStyle xmlns:a="http://schemas.openxmlformats.org/drawingml/2006/main"/>
-          <a:p xmlns:a="http://schemas.openxmlformats.org/drawingml/2006/main">
-            <a:pPr>
-              <a:defRPr sz="1875" b="0">
-                <a:solidFill>
-                  <a:srgbClr val="53655C"/>
-                </a:solidFill>
-                <a:latin typeface="Arial"/>
-                <a:ea typeface="Arial"/>
-                <a:cs typeface="Arial"/>
-              </a:defRPr>
-            </a:pPr>
-            <a:r>
-              <a:rPr sz="1875" b="0">
-                <a:solidFill>
-                  <a:srgbClr val="53655C"/>
-                </a:solidFill>
-                <a:latin typeface="Arial"/>
-                <a:ea typeface="Arial"/>
-                <a:cs typeface="Arial"/>
-              </a:rPr>
-              <a:t>The doctor signs first. The patient then reviews and signs that version.</a:t>
-            </a:r>
-          </a:p>
-        </p:txBody>
-      </p:sp>
-      <p:pic>
-        <p:nvPicPr>
-          <p:cNvPr id="16" name=""/>
-          <p:cNvPicPr>
-            <a:picLocks xmlns:a="http://schemas.openxmlformats.org/drawingml/2006/main" noChangeAspect="1"/>
-          </p:cNvPicPr>
-          <p:nvPr/>
-        </p:nvPicPr>
-        <p:blipFill>
-          <a:blip xmlns:r="http://schemas.openxmlformats.org/officeDocument/2006/relationships" xmlns:a="http://schemas.openxmlformats.org/drawingml/2006/main" r:embed="Rd7cb07e2e45a4d16"/>
-          <a:stretch xmlns:a="http://schemas.openxmlformats.org/drawingml/2006/main"/>
-        </p:blipFill>
-        <p:spPr>
-          <a:xfrm xmlns:a="http://schemas.openxmlformats.org/drawingml/2006/main">
-            <a:off x="400050" y="1876325"/>
-            <a:ext cx="8286750" cy="3876875"/>
-          </a:xfrm>
-          <a:prstGeom xmlns:a="http://schemas.openxmlformats.org/drawingml/2006/main" prst="rect">
-            <a:avLst/>
-          </a:prstGeom>
-        </p:spPr>
-      </p:pic>
-      <p:sp>
-        <p:nvSpPr>
-          <p:cNvPr id="4" name="Source traceability">
-            <a:extLst xmlns:a="http://schemas.openxmlformats.org/drawingml/2006/main">
-              <a:ext uri="{FF2B5EF4-FFF2-40B4-BE49-F238E27FC236}">
-                <a16:creationId xmlns:a16="http://schemas.microsoft.com/office/drawing/2014/main" id="{89F9170C-E389-4841-AA19-3944A31A9132}"/>
-              </a:ext>
-            </a:extLst>
-          </p:cNvPr>
-          <p:cNvSpPr>
-            <a:spLocks xmlns:a="http://schemas.openxmlformats.org/drawingml/2006/main" noGrp="1"/>
-          </p:cNvSpPr>
-          <p:nvPr/>
-        </p:nvSpPr>
-        <p:spPr>
-          <a:xfrm xmlns:a="http://schemas.openxmlformats.org/drawingml/2006/main">
-            <a:off x="533400" y="5991225"/>
-            <a:ext cx="8001000" cy="523875"/>
-          </a:xfrm>
-          <a:prstGeom xmlns:a="http://schemas.openxmlformats.org/drawingml/2006/main" prst="rect">
-            <a:avLst/>
-          </a:prstGeom>
-          <a:noFill xmlns:a="http://schemas.openxmlformats.org/drawingml/2006/main"/>
-          <a:ln xmlns:a="http://schemas.openxmlformats.org/drawingml/2006/main" w="0">
-            <a:noFill/>
-          </a:ln>
-        </p:spPr>
-        <p:txBody>
-          <a:bodyPr xmlns:a="http://schemas.openxmlformats.org/drawingml/2006/main" wrap="square" lIns="0" tIns="0" rIns="0" bIns="0">
-            <a:normAutofit fontScale="100000"/>
-          </a:bodyPr>
-          <a:lstStyle xmlns:a="http://schemas.openxmlformats.org/drawingml/2006/main"/>
-          <a:p xmlns:a="http://schemas.openxmlformats.org/drawingml/2006/main">
-            <a:pPr>
-              <a:defRPr sz="1725" b="1">
-                <a:solidFill>
-                  <a:srgbClr val="B75E43"/>
-                </a:solidFill>
-                <a:latin typeface="Arial"/>
-                <a:ea typeface="Arial"/>
-                <a:cs typeface="Arial"/>
-              </a:defRPr>
-            </a:pPr>
-            <a:r>
-              <a:rPr sz="1725" b="1">
-                <a:solidFill>
-                  <a:srgbClr val="B75E43"/>
-                </a:solidFill>
-                <a:latin typeface="Arial"/>
-                <a:ea typeface="Arial"/>
-                <a:cs typeface="Arial"/>
-              </a:rPr>
-              <a:t>Keep the source words and every signed version for the next conversation.</a:t>
-            </a:r>
-          </a:p>
-        </p:txBody>
-      </p:sp>
-      <p:sp>
-        <p:nvSpPr>
-          <p:cNvPr id="5" name="Proposed voice provider">
-            <a:extLst xmlns:a="http://schemas.openxmlformats.org/drawingml/2006/main">
-              <a:ext uri="{FF2B5EF4-FFF2-40B4-BE49-F238E27FC236}">
-                <a16:creationId xmlns:a16="http://schemas.microsoft.com/office/drawing/2014/main" id="{48DD65DB-F360-4C5B-A3C6-C599B260EAC1}"/>
-              </a:ext>
-            </a:extLst>
-          </p:cNvPr>
-          <p:cNvSpPr>
-            <a:spLocks xmlns:a="http://schemas.openxmlformats.org/drawingml/2006/main" noGrp="1"/>
-          </p:cNvSpPr>
-          <p:nvPr/>
-        </p:nvSpPr>
-        <p:spPr>
-          <a:xfrm xmlns:a="http://schemas.openxmlformats.org/drawingml/2006/main">
-            <a:off x="533400" y="6543675"/>
-            <a:ext cx="11125200" cy="228600"/>
-          </a:xfrm>
-          <a:prstGeom xmlns:a="http://schemas.openxmlformats.org/drawingml/2006/main" prst="rect">
-            <a:avLst/>
-          </a:prstGeom>
-          <a:noFill xmlns:a="http://schemas.openxmlformats.org/drawingml/2006/main"/>
-          <a:ln xmlns:a="http://schemas.openxmlformats.org/drawingml/2006/main" w="0">
-            <a:noFill/>
-          </a:ln>
-        </p:spPr>
-        <p:txBody>
-          <a:bodyPr xmlns:a="http://schemas.openxmlformats.org/drawingml/2006/main" wrap="square" lIns="0" tIns="0" rIns="0" bIns="0">
-            <a:normAutofit fontScale="100000"/>
-          </a:bodyPr>
-          <a:lstStyle xmlns:a="http://schemas.openxmlformats.org/drawingml/2006/main"/>
-          <a:p xmlns:a="http://schemas.openxmlformats.org/drawingml/2006/main">
-            <a:pPr>
-              <a:defRPr sz="1313" b="0">
-                <a:solidFill>
-                  <a:srgbClr val="145AC6"/>
-                </a:solidFill>
-                <a:latin typeface="Arial"/>
-                <a:ea typeface="Arial"/>
-                <a:cs typeface="Arial"/>
-              </a:defRPr>
-            </a:pPr>
-            <a:r>
-              <a:rPr sz="1313" b="0" u="sng">
-                <a:solidFill>
-                  <a:srgbClr val="145AC6"/>
-                </a:solidFill>
-                <a:latin typeface="Arial"/>
-                <a:ea typeface="Arial"/>
-                <a:cs typeface="Arial"/>
-                <a:hlinkClick xmlns:r="http://schemas.openxmlformats.org/officeDocument/2006/relationships" r:id="Rd1cfbf9e32694dc1"/>
-              </a:rPr>
-              <a:t>Planned with Sarvam AI: Indian-language speech, translation and read-aloud.</a:t>
-            </a:r>
-          </a:p>
-        </p:txBody>
-      </p:sp>
-      <p:sp>
-        <p:nvSpPr>
-          <p:cNvPr id="6" name="AI step 1">
-            <a:extLst xmlns:a="http://schemas.openxmlformats.org/drawingml/2006/main">
-              <a:ext uri="{FF2B5EF4-FFF2-40B4-BE49-F238E27FC236}">
-                <a16:creationId xmlns:a16="http://schemas.microsoft.com/office/drawing/2014/main" id="{A99F3678-0EEE-41FD-8AA7-9665B3F2F1BA}"/>
-              </a:ext>
-            </a:extLst>
-          </p:cNvPr>
-          <p:cNvSpPr>
-            <a:spLocks xmlns:a="http://schemas.openxmlformats.org/drawingml/2006/main" noGrp="1"/>
-          </p:cNvSpPr>
-          <p:nvPr/>
-        </p:nvSpPr>
-        <p:spPr>
-          <a:xfrm xmlns:a="http://schemas.openxmlformats.org/drawingml/2006/main">
-            <a:off x="9001125" y="1676400"/>
-            <a:ext cx="2657475" cy="523875"/>
-          </a:xfrm>
-          <a:prstGeom xmlns:a="http://schemas.openxmlformats.org/drawingml/2006/main" prst="rect">
-            <a:avLst/>
-          </a:prstGeom>
-          <a:noFill xmlns:a="http://schemas.openxmlformats.org/drawingml/2006/main"/>
-          <a:ln xmlns:a="http://schemas.openxmlformats.org/drawingml/2006/main" w="0">
-            <a:noFill/>
-          </a:ln>
-        </p:spPr>
-        <p:txBody>
-          <a:bodyPr xmlns:a="http://schemas.openxmlformats.org/drawingml/2006/main" wrap="square" lIns="0" tIns="0" rIns="0" bIns="0">
-            <a:normAutofit fontScale="99638"/>
-          </a:bodyPr>
-          <a:lstStyle xmlns:a="http://schemas.openxmlformats.org/drawingml/2006/main"/>
-          <a:p xmlns:a="http://schemas.openxmlformats.org/drawingml/2006/main">
-            <a:pPr>
-              <a:defRPr sz="1725" b="1">
-                <a:solidFill>
-                  <a:srgbClr val="173F33"/>
-                </a:solidFill>
-                <a:latin typeface="Arial"/>
-                <a:ea typeface="Arial"/>
-                <a:cs typeface="Arial"/>
-              </a:defRPr>
-            </a:pPr>
-            <a:r>
-              <a:rPr sz="1725" b="1">
-                <a:solidFill>
-                  <a:srgbClr val="173F33"/>
-                </a:solidFill>
-                <a:latin typeface="Arial"/>
-                <a:ea typeface="Arial"/>
-                <a:cs typeface="Arial"/>
-              </a:rPr>
-              <a:t>1. Record with permission.</a:t>
-            </a:r>
-          </a:p>
-        </p:txBody>
-      </p:sp>
-      <p:sp>
-        <p:nvSpPr>
-          <p:cNvPr id="7" name="AI step 1 detail">
-            <a:extLst xmlns:a="http://schemas.openxmlformats.org/drawingml/2006/main">
-              <a:ext uri="{FF2B5EF4-FFF2-40B4-BE49-F238E27FC236}">
-                <a16:creationId xmlns:a16="http://schemas.microsoft.com/office/drawing/2014/main" id="{33B8F5D4-3801-43D1-896B-9A869CFAEC85}"/>
-              </a:ext>
-            </a:extLst>
-          </p:cNvPr>
-          <p:cNvSpPr>
-            <a:spLocks xmlns:a="http://schemas.openxmlformats.org/drawingml/2006/main" noGrp="1"/>
-          </p:cNvSpPr>
-          <p:nvPr/>
-        </p:nvSpPr>
-        <p:spPr>
-          <a:xfrm xmlns:a="http://schemas.openxmlformats.org/drawingml/2006/main">
-            <a:off x="9001125" y="2247900"/>
-            <a:ext cx="2657475" cy="561975"/>
-          </a:xfrm>
-          <a:prstGeom xmlns:a="http://schemas.openxmlformats.org/drawingml/2006/main" prst="rect">
-            <a:avLst/>
-          </a:prstGeom>
-          <a:noFill xmlns:a="http://schemas.openxmlformats.org/drawingml/2006/main"/>
-          <a:ln xmlns:a="http://schemas.openxmlformats.org/drawingml/2006/main" w="0">
-            <a:noFill/>
-          </a:ln>
-        </p:spPr>
-        <p:txBody>
-          <a:bodyPr xmlns:a="http://schemas.openxmlformats.org/drawingml/2006/main" wrap="square" lIns="0" tIns="0" rIns="0" bIns="0">
-            <a:normAutofit fontScale="100000"/>
-          </a:bodyPr>
-          <a:lstStyle xmlns:a="http://schemas.openxmlformats.org/drawingml/2006/main"/>
-          <a:p xmlns:a="http://schemas.openxmlformats.org/drawingml/2006/main">
-            <a:pPr>
-              <a:defRPr sz="1463" b="0">
-                <a:solidFill>
-                  <a:srgbClr val="53655C"/>
-                </a:solidFill>
-                <a:latin typeface="Arial"/>
-                <a:ea typeface="Arial"/>
-                <a:cs typeface="Arial"/>
-              </a:defRPr>
-            </a:pPr>
-            <a:r>
-              <a:rPr sz="1463" b="0">
-                <a:solidFill>
-                  <a:srgbClr val="53655C"/>
-                </a:solidFill>
-                <a:latin typeface="Arial"/>
-                <a:ea typeface="Arial"/>
-                <a:cs typeface="Arial"/>
-              </a:rPr>
-              <a:t>Keep who said what in the conversation.</a:t>
-            </a:r>
-          </a:p>
-        </p:txBody>
-      </p:sp>
-      <p:sp>
-        <p:nvSpPr>
-          <p:cNvPr id="8" name="AI step 2">
-            <a:extLst xmlns:a="http://schemas.openxmlformats.org/drawingml/2006/main">
-              <a:ext uri="{FF2B5EF4-FFF2-40B4-BE49-F238E27FC236}">
-                <a16:creationId xmlns:a16="http://schemas.microsoft.com/office/drawing/2014/main" id="{32664CD7-8313-4727-8570-08AD8D68BE04}"/>
-              </a:ext>
-            </a:extLst>
-          </p:cNvPr>
-          <p:cNvSpPr>
-            <a:spLocks xmlns:a="http://schemas.openxmlformats.org/drawingml/2006/main" noGrp="1"/>
-          </p:cNvSpPr>
-          <p:nvPr/>
-        </p:nvSpPr>
-        <p:spPr>
-          <a:xfrm xmlns:a="http://schemas.openxmlformats.org/drawingml/2006/main">
-            <a:off x="9001125" y="2838450"/>
-            <a:ext cx="2657475" cy="523875"/>
-          </a:xfrm>
-          <a:prstGeom xmlns:a="http://schemas.openxmlformats.org/drawingml/2006/main" prst="rect">
-            <a:avLst/>
-          </a:prstGeom>
-          <a:noFill xmlns:a="http://schemas.openxmlformats.org/drawingml/2006/main"/>
-          <a:ln xmlns:a="http://schemas.openxmlformats.org/drawingml/2006/main" w="0">
-            <a:noFill/>
-          </a:ln>
-        </p:spPr>
-        <p:txBody>
-          <a:bodyPr xmlns:a="http://schemas.openxmlformats.org/drawingml/2006/main" wrap="square" lIns="0" tIns="0" rIns="0" bIns="0">
-            <a:normAutofit fontScale="100000"/>
-          </a:bodyPr>
-          <a:lstStyle xmlns:a="http://schemas.openxmlformats.org/drawingml/2006/main"/>
-          <a:p xmlns:a="http://schemas.openxmlformats.org/drawingml/2006/main">
-            <a:pPr>
-              <a:defRPr sz="1725" b="1">
-                <a:solidFill>
-                  <a:srgbClr val="173F33"/>
-                </a:solidFill>
-                <a:latin typeface="Arial"/>
-                <a:ea typeface="Arial"/>
-                <a:cs typeface="Arial"/>
-              </a:defRPr>
-            </a:pPr>
-            <a:r>
-              <a:rPr sz="1725" b="1">
-                <a:solidFill>
-                  <a:srgbClr val="173F33"/>
-                </a:solidFill>
-                <a:latin typeface="Arial"/>
-                <a:ea typeface="Arial"/>
-                <a:cs typeface="Arial"/>
-              </a:rPr>
-              <a:t>2. AI prepares a draft.</a:t>
-            </a:r>
-          </a:p>
-        </p:txBody>
-      </p:sp>
-      <p:sp>
-        <p:nvSpPr>
-          <p:cNvPr id="9" name="AI step 2 detail">
-            <a:extLst xmlns:a="http://schemas.openxmlformats.org/drawingml/2006/main">
-              <a:ext uri="{FF2B5EF4-FFF2-40B4-BE49-F238E27FC236}">
-                <a16:creationId xmlns:a16="http://schemas.microsoft.com/office/drawing/2014/main" id="{728079FA-561F-4FB4-9EAB-6DC4DCA2E31A}"/>
-              </a:ext>
-            </a:extLst>
-          </p:cNvPr>
-          <p:cNvSpPr>
-            <a:spLocks xmlns:a="http://schemas.openxmlformats.org/drawingml/2006/main" noGrp="1"/>
-          </p:cNvSpPr>
-          <p:nvPr/>
-        </p:nvSpPr>
-        <p:spPr>
-          <a:xfrm xmlns:a="http://schemas.openxmlformats.org/drawingml/2006/main">
-            <a:off x="9001125" y="3409950"/>
-            <a:ext cx="2657475" cy="561975"/>
-          </a:xfrm>
-          <a:prstGeom xmlns:a="http://schemas.openxmlformats.org/drawingml/2006/main" prst="rect">
-            <a:avLst/>
-          </a:prstGeom>
-          <a:noFill xmlns:a="http://schemas.openxmlformats.org/drawingml/2006/main"/>
-          <a:ln xmlns:a="http://schemas.openxmlformats.org/drawingml/2006/main" w="0">
-            <a:noFill/>
-          </a:ln>
-        </p:spPr>
-        <p:txBody>
-          <a:bodyPr xmlns:a="http://schemas.openxmlformats.org/drawingml/2006/main" wrap="square" lIns="0" tIns="0" rIns="0" bIns="0">
-            <a:normAutofit fontScale="100000"/>
-          </a:bodyPr>
-          <a:lstStyle xmlns:a="http://schemas.openxmlformats.org/drawingml/2006/main"/>
-          <a:p xmlns:a="http://schemas.openxmlformats.org/drawingml/2006/main">
-            <a:pPr>
-              <a:defRPr sz="1463" b="0">
-                <a:solidFill>
-                  <a:srgbClr val="53655C"/>
-                </a:solidFill>
-                <a:latin typeface="Arial"/>
-                <a:ea typeface="Arial"/>
-                <a:cs typeface="Arial"/>
-              </a:defRPr>
-            </a:pPr>
-            <a:r>
-              <a:rPr sz="1463" b="0">
-                <a:solidFill>
-                  <a:srgbClr val="53655C"/>
-                </a:solidFill>
-                <a:latin typeface="Arial"/>
-                <a:ea typeface="Arial"/>
-                <a:cs typeface="Arial"/>
-              </a:rPr>
-              <a:t>Separate agreed points from unanswered questions.</a:t>
-            </a:r>
-          </a:p>
-        </p:txBody>
-      </p:sp>
-      <p:sp>
-        <p:nvSpPr>
-          <p:cNvPr id="10" name="AI step 3">
-            <a:extLst xmlns:a="http://schemas.openxmlformats.org/drawingml/2006/main">
-              <a:ext uri="{FF2B5EF4-FFF2-40B4-BE49-F238E27FC236}">
-                <a16:creationId xmlns:a16="http://schemas.microsoft.com/office/drawing/2014/main" id="{70793CDE-C33C-4CBA-AA9C-0232C3A5D4F4}"/>
-              </a:ext>
-            </a:extLst>
-          </p:cNvPr>
-          <p:cNvSpPr>
-            <a:spLocks xmlns:a="http://schemas.openxmlformats.org/drawingml/2006/main" noGrp="1"/>
-          </p:cNvSpPr>
-          <p:nvPr/>
-        </p:nvSpPr>
-        <p:spPr>
-          <a:xfrm xmlns:a="http://schemas.openxmlformats.org/drawingml/2006/main">
-            <a:off x="9001125" y="4000500"/>
-            <a:ext cx="2657475" cy="523875"/>
-          </a:xfrm>
-          <a:prstGeom xmlns:a="http://schemas.openxmlformats.org/drawingml/2006/main" prst="rect">
-            <a:avLst/>
-          </a:prstGeom>
-          <a:noFill xmlns:a="http://schemas.openxmlformats.org/drawingml/2006/main"/>
-          <a:ln xmlns:a="http://schemas.openxmlformats.org/drawingml/2006/main" w="0">
-            <a:noFill/>
-          </a:ln>
-        </p:spPr>
-        <p:txBody>
-          <a:bodyPr xmlns:a="http://schemas.openxmlformats.org/drawingml/2006/main" wrap="square" lIns="0" tIns="0" rIns="0" bIns="0">
-            <a:normAutofit fontScale="99638"/>
-          </a:bodyPr>
-          <a:lstStyle xmlns:a="http://schemas.openxmlformats.org/drawingml/2006/main"/>
-          <a:p xmlns:a="http://schemas.openxmlformats.org/drawingml/2006/main">
-            <a:pPr>
-              <a:defRPr sz="1725" b="1">
-                <a:solidFill>
-                  <a:srgbClr val="173F33"/>
-                </a:solidFill>
-                <a:latin typeface="Arial"/>
-                <a:ea typeface="Arial"/>
-                <a:cs typeface="Arial"/>
-              </a:defRPr>
-            </a:pPr>
-            <a:r>
-              <a:rPr sz="1725" b="1">
-                <a:solidFill>
-                  <a:srgbClr val="173F33"/>
-                </a:solidFill>
-                <a:latin typeface="Arial"/>
-                <a:ea typeface="Arial"/>
-                <a:cs typeface="Arial"/>
-              </a:rPr>
-              <a:t>3. The doctor checks and signs.</a:t>
-            </a:r>
-          </a:p>
-        </p:txBody>
-      </p:sp>
-      <p:sp>
-        <p:nvSpPr>
-          <p:cNvPr id="11" name="AI step 3 detail">
-            <a:extLst xmlns:a="http://schemas.openxmlformats.org/drawingml/2006/main">
-              <a:ext uri="{FF2B5EF4-FFF2-40B4-BE49-F238E27FC236}">
-                <a16:creationId xmlns:a16="http://schemas.microsoft.com/office/drawing/2014/main" id="{140DDFD4-FF5E-41BD-945A-25C136C80349}"/>
-              </a:ext>
-            </a:extLst>
-          </p:cNvPr>
-          <p:cNvSpPr>
-            <a:spLocks xmlns:a="http://schemas.openxmlformats.org/drawingml/2006/main" noGrp="1"/>
-          </p:cNvSpPr>
-          <p:nvPr/>
-        </p:nvSpPr>
-        <p:spPr>
-          <a:xfrm xmlns:a="http://schemas.openxmlformats.org/drawingml/2006/main">
-            <a:off x="9001125" y="4572000"/>
-            <a:ext cx="2657475" cy="561975"/>
-          </a:xfrm>
-          <a:prstGeom xmlns:a="http://schemas.openxmlformats.org/drawingml/2006/main" prst="rect">
-            <a:avLst/>
-          </a:prstGeom>
-          <a:noFill xmlns:a="http://schemas.openxmlformats.org/drawingml/2006/main"/>
-          <a:ln xmlns:a="http://schemas.openxmlformats.org/drawingml/2006/main" w="0">
-            <a:noFill/>
-          </a:ln>
-        </p:spPr>
-        <p:txBody>
-          <a:bodyPr xmlns:a="http://schemas.openxmlformats.org/drawingml/2006/main" wrap="square" lIns="0" tIns="0" rIns="0" bIns="0">
-            <a:normAutofit fontScale="100000"/>
-          </a:bodyPr>
-          <a:lstStyle xmlns:a="http://schemas.openxmlformats.org/drawingml/2006/main"/>
-          <a:p xmlns:a="http://schemas.openxmlformats.org/drawingml/2006/main">
-            <a:pPr>
-              <a:defRPr sz="1463" b="0">
-                <a:solidFill>
-                  <a:srgbClr val="53655C"/>
-                </a:solidFill>
-                <a:latin typeface="Arial"/>
-                <a:ea typeface="Arial"/>
-                <a:cs typeface="Arial"/>
-              </a:defRPr>
-            </a:pPr>
-            <a:r>
-              <a:rPr sz="1463" b="0">
-                <a:solidFill>
-                  <a:srgbClr val="53655C"/>
-                </a:solidFill>
-                <a:latin typeface="Arial"/>
-                <a:ea typeface="Arial"/>
-                <a:cs typeface="Arial"/>
-              </a:rPr>
-              <a:t>Correct the note and record clinical choices.</a:t>
-            </a:r>
-          </a:p>
-        </p:txBody>
-      </p:sp>
-      <p:sp>
-        <p:nvSpPr>
-          <p:cNvPr id="12" name="AI step 4">
-            <a:extLst xmlns:a="http://schemas.openxmlformats.org/drawingml/2006/main">
-              <a:ext uri="{FF2B5EF4-FFF2-40B4-BE49-F238E27FC236}">
-                <a16:creationId xmlns:a16="http://schemas.microsoft.com/office/drawing/2014/main" id="{CA2DE991-FF2E-48AA-ABE4-809848F68A8E}"/>
-              </a:ext>
-            </a:extLst>
-          </p:cNvPr>
-          <p:cNvSpPr>
-            <a:spLocks xmlns:a="http://schemas.openxmlformats.org/drawingml/2006/main" noGrp="1"/>
-          </p:cNvSpPr>
-          <p:nvPr/>
-        </p:nvSpPr>
-        <p:spPr>
-          <a:xfrm xmlns:a="http://schemas.openxmlformats.org/drawingml/2006/main">
-            <a:off x="9001125" y="5162550"/>
-            <a:ext cx="2657475" cy="523875"/>
-          </a:xfrm>
-          <a:prstGeom xmlns:a="http://schemas.openxmlformats.org/drawingml/2006/main" prst="rect">
-            <a:avLst/>
-          </a:prstGeom>
-          <a:noFill xmlns:a="http://schemas.openxmlformats.org/drawingml/2006/main"/>
-          <a:ln xmlns:a="http://schemas.openxmlformats.org/drawingml/2006/main" w="0">
-            <a:noFill/>
-          </a:ln>
-        </p:spPr>
-        <p:txBody>
-          <a:bodyPr xmlns:a="http://schemas.openxmlformats.org/drawingml/2006/main" wrap="square" lIns="0" tIns="0" rIns="0" bIns="0">
-            <a:normAutofit fontScale="99638"/>
-          </a:bodyPr>
-          <a:lstStyle xmlns:a="http://schemas.openxmlformats.org/drawingml/2006/main"/>
-          <a:p xmlns:a="http://schemas.openxmlformats.org/drawingml/2006/main">
-            <a:pPr>
-              <a:defRPr sz="1725" b="1">
-                <a:solidFill>
-                  <a:srgbClr val="173F33"/>
-                </a:solidFill>
-                <a:latin typeface="Arial"/>
-                <a:ea typeface="Arial"/>
-                <a:cs typeface="Arial"/>
-              </a:defRPr>
-            </a:pPr>
-            <a:r>
-              <a:rPr sz="1725" b="1">
-                <a:solidFill>
-                  <a:srgbClr val="173F33"/>
-                </a:solidFill>
-                <a:latin typeface="Arial"/>
-                <a:ea typeface="Arial"/>
-                <a:cs typeface="Arial"/>
-              </a:rPr>
-              <a:t>4. The patient signs that version.</a:t>
-            </a:r>
-          </a:p>
-        </p:txBody>
-      </p:sp>
-      <p:sp>
-        <p:nvSpPr>
-          <p:cNvPr id="13" name="AI step 4 detail">
-            <a:extLst xmlns:a="http://schemas.openxmlformats.org/drawingml/2006/main">
-              <a:ext uri="{FF2B5EF4-FFF2-40B4-BE49-F238E27FC236}">
-                <a16:creationId xmlns:a16="http://schemas.microsoft.com/office/drawing/2014/main" id="{0F2AD767-667C-4E61-8303-021BBC6D609B}"/>
-              </a:ext>
-            </a:extLst>
-          </p:cNvPr>
-          <p:cNvSpPr>
-            <a:spLocks xmlns:a="http://schemas.openxmlformats.org/drawingml/2006/main" noGrp="1"/>
-          </p:cNvSpPr>
-          <p:nvPr/>
-        </p:nvSpPr>
-        <p:spPr>
-          <a:xfrm xmlns:a="http://schemas.openxmlformats.org/drawingml/2006/main">
-            <a:off x="9001125" y="5734050"/>
-            <a:ext cx="2657475" cy="561975"/>
-          </a:xfrm>
-          <a:prstGeom xmlns:a="http://schemas.openxmlformats.org/drawingml/2006/main" prst="rect">
-            <a:avLst/>
-          </a:prstGeom>
-          <a:noFill xmlns:a="http://schemas.openxmlformats.org/drawingml/2006/main"/>
-          <a:ln xmlns:a="http://schemas.openxmlformats.org/drawingml/2006/main" w="0">
-            <a:noFill/>
-          </a:ln>
-        </p:spPr>
-        <p:txBody>
-          <a:bodyPr xmlns:a="http://schemas.openxmlformats.org/drawingml/2006/main" wrap="square" lIns="0" tIns="0" rIns="0" bIns="0">
-            <a:normAutofit fontScale="100000"/>
-          </a:bodyPr>
-          <a:lstStyle xmlns:a="http://schemas.openxmlformats.org/drawingml/2006/main"/>
-          <a:p xmlns:a="http://schemas.openxmlformats.org/drawingml/2006/main">
-            <a:pPr>
-              <a:defRPr sz="1463" b="0">
-                <a:solidFill>
-                  <a:srgbClr val="53655C"/>
-                </a:solidFill>
-                <a:latin typeface="Arial"/>
-                <a:ea typeface="Arial"/>
-                <a:cs typeface="Arial"/>
-              </a:defRPr>
-            </a:pPr>
-            <a:r>
-              <a:rPr sz="1463" b="0">
-                <a:solidFill>
-                  <a:srgbClr val="53655C"/>
-                </a:solidFill>
-                <a:latin typeface="Arial"/>
-                <a:ea typeface="Arial"/>
-                <a:cs typeface="Arial"/>
-              </a:rPr>
-              <a:t>Review the exact version. Keep earlier notes.</a:t>
-            </a:r>
-          </a:p>
-        </p:txBody>
-      </p:sp>
-    </p:spTree>
-    <p:extLst>
-      <p:ext uri="{BB962C8B-B14F-4D97-AF65-F5344CB8AC3E}">
-        <p14:creationId xmlns:p14="http://schemas.microsoft.com/office/powerpoint/2010/main" val="1779657811"/>
-      </p:ext>
-    </p:extLst>
-  </p:cSld>
-</p:sld>
-</file>
-
-<file path=ppt/slides/slide5.xml><?xml version="1.0" encoding="utf-8"?>
+<file path=ppt/slides/slide3.xml><?xml version="1.0" encoding="utf-8"?>
 <p:sld xmlns:p="http://schemas.openxmlformats.org/presentationml/2006/main">
   <p:cSld>
     <p:bg>
@@ -5638,7 +4371,7 @@
         </p:xfrm>
         <a:graphic xmlns:a="http://schemas.openxmlformats.org/drawingml/2006/main">
           <a:graphicData uri="http://schemas.openxmlformats.org/drawingml/2006/chart">
-            <c:chart xmlns:r="http://schemas.openxmlformats.org/officeDocument/2006/relationships" xmlns:c="http://schemas.openxmlformats.org/drawingml/2006/chart" r:id="R9db884fda8714dd3"/>
+            <c:chart xmlns:r="http://schemas.openxmlformats.org/officeDocument/2006/relationships" xmlns:c="http://schemas.openxmlformats.org/drawingml/2006/chart" r:id="Rbd47fc4028bc4658"/>
           </a:graphicData>
         </a:graphic>
       </p:graphicFrame>
@@ -5647,7 +4380,7 @@
           <p:cNvPr id="15" name="Slide title">
             <a:extLst xmlns:a="http://schemas.openxmlformats.org/drawingml/2006/main">
               <a:ext uri="{FF2B5EF4-FFF2-40B4-BE49-F238E27FC236}">
-                <a16:creationId xmlns:a16="http://schemas.microsoft.com/office/drawing/2014/main" id="{E53A44B9-FF4F-45B3-894B-2B05822DABFD}"/>
+                <a16:creationId xmlns:a16="http://schemas.microsoft.com/office/drawing/2014/main" id="{AE200FF0-4413-44C3-AE0B-B2A2D86DB151}"/>
               </a:ext>
             </a:extLst>
           </p:cNvPr>
@@ -5704,7 +4437,7 @@
           <p:cNvPr id="16" name="Chennai evidence heading">
             <a:extLst xmlns:a="http://schemas.openxmlformats.org/drawingml/2006/main">
               <a:ext uri="{FF2B5EF4-FFF2-40B4-BE49-F238E27FC236}">
-                <a16:creationId xmlns:a16="http://schemas.microsoft.com/office/drawing/2014/main" id="{95CBE83E-B354-4E74-B40B-01E860778B09}"/>
+                <a16:creationId xmlns:a16="http://schemas.microsoft.com/office/drawing/2014/main" id="{030D4925-1687-4F9D-9ADD-A5ABDBD23010}"/>
               </a:ext>
             </a:extLst>
           </p:cNvPr>
@@ -5734,7 +4467,7 @@
           <p:cNvPr id="17" name="Chennai evidence explanation">
             <a:extLst xmlns:a="http://schemas.openxmlformats.org/drawingml/2006/main">
               <a:ext uri="{FF2B5EF4-FFF2-40B4-BE49-F238E27FC236}">
-                <a16:creationId xmlns:a16="http://schemas.microsoft.com/office/drawing/2014/main" id="{97F6FCA3-C29E-4EE3-9771-04E36CEA2FC3}"/>
+                <a16:creationId xmlns:a16="http://schemas.microsoft.com/office/drawing/2014/main" id="{5B2EE1B8-F73D-4E54-A9F0-586FD198D7AD}"/>
               </a:ext>
             </a:extLst>
           </p:cNvPr>
@@ -5768,10 +4501,10 @@
           <p:nvPr/>
         </p:nvPicPr>
         <p:blipFill>
-          <a:blip xmlns:r="http://schemas.openxmlformats.org/officeDocument/2006/relationships" xmlns:a="http://schemas.openxmlformats.org/drawingml/2006/main" r:embed="Raa289c8bc0c948f3">
+          <a:blip xmlns:r="http://schemas.openxmlformats.org/officeDocument/2006/relationships" xmlns:a="http://schemas.openxmlformats.org/drawingml/2006/main" r:embed="Rd08c8b5478624a33">
             <a:extLst>
               <a:ext uri="{96DAC541-7B7A-43D3-8B79-37D633B846F1}">
-                <asvg:svgBlip xmlns:asvg="http://schemas.microsoft.com/office/drawing/2016/SVG/main" r:embed="R55ad117f387d40d1"/>
+                <asvg:svgBlip xmlns:asvg="http://schemas.microsoft.com/office/drawing/2016/SVG/main" r:embed="R72170081104643b6"/>
               </a:ext>
             </a:extLst>
           </a:blip>
@@ -5792,7 +4525,7 @@
           <p:cNvPr id="19" name="Evidence 15.6 lakh">
             <a:extLst xmlns:a="http://schemas.openxmlformats.org/drawingml/2006/main">
               <a:ext uri="{FF2B5EF4-FFF2-40B4-BE49-F238E27FC236}">
-                <a16:creationId xmlns:a16="http://schemas.microsoft.com/office/drawing/2014/main" id="{225CD085-4E4E-4E7A-9E05-558D123B4345}"/>
+                <a16:creationId xmlns:a16="http://schemas.microsoft.com/office/drawing/2014/main" id="{6EC2C2B4-914A-4D45-B7A8-9D794A8BFB14}"/>
               </a:ext>
             </a:extLst>
           </p:cNvPr>
@@ -5849,7 +4582,7 @@
           <p:cNvPr id="20" name="Evidence 15.6 lakh scope">
             <a:extLst xmlns:a="http://schemas.openxmlformats.org/drawingml/2006/main">
               <a:ext uri="{FF2B5EF4-FFF2-40B4-BE49-F238E27FC236}">
-                <a16:creationId xmlns:a16="http://schemas.microsoft.com/office/drawing/2014/main" id="{771A0706-DE8F-400B-95A1-37CC74922440}"/>
+                <a16:creationId xmlns:a16="http://schemas.microsoft.com/office/drawing/2014/main" id="{BFA343F3-9281-42FB-B5FA-6C57EF2B0ABF}"/>
               </a:ext>
             </a:extLst>
           </p:cNvPr>
@@ -5906,7 +4639,7 @@
           <p:cNvPr id="21" name="Evidence 15.6 lakh source">
             <a:extLst xmlns:a="http://schemas.openxmlformats.org/drawingml/2006/main">
               <a:ext uri="{FF2B5EF4-FFF2-40B4-BE49-F238E27FC236}">
-                <a16:creationId xmlns:a16="http://schemas.microsoft.com/office/drawing/2014/main" id="{DA231214-4290-430C-9B17-AA34E63D9F55}"/>
+                <a16:creationId xmlns:a16="http://schemas.microsoft.com/office/drawing/2014/main" id="{1E6D6B4D-7B3A-4F75-91EC-2B6E8E13FFE3}"/>
               </a:ext>
             </a:extLst>
           </p:cNvPr>
@@ -5952,7 +4685,7 @@
                 <a:latin typeface="Arial"/>
                 <a:ea typeface="Arial"/>
                 <a:cs typeface="Arial"/>
-                <a:hlinkClick xmlns:r="http://schemas.openxmlformats.org/officeDocument/2006/relationships" r:id="Rf10a3be8b8da40cb"/>
+                <a:hlinkClick xmlns:r="http://schemas.openxmlformats.org/officeDocument/2006/relationships" r:id="R842892044f3e4820"/>
               </a:rPr>
               <a:t>IARC, GLOBOCAN 2024</a:t>
             </a:r>
@@ -5968,10 +4701,10 @@
           <p:nvPr/>
         </p:nvPicPr>
         <p:blipFill>
-          <a:blip xmlns:r="http://schemas.openxmlformats.org/officeDocument/2006/relationships" xmlns:a="http://schemas.openxmlformats.org/drawingml/2006/main" r:embed="R92533f0eaf384bf4">
+          <a:blip xmlns:r="http://schemas.openxmlformats.org/officeDocument/2006/relationships" xmlns:a="http://schemas.openxmlformats.org/drawingml/2006/main" r:embed="R83793cbf49164d29">
             <a:extLst>
               <a:ext uri="{96DAC541-7B7A-43D3-8B79-37D633B846F1}">
-                <asvg:svgBlip xmlns:asvg="http://schemas.microsoft.com/office/drawing/2016/SVG/main" r:embed="R5d6423ae344f43eb"/>
+                <asvg:svgBlip xmlns:asvg="http://schemas.microsoft.com/office/drawing/2016/SVG/main" r:embed="R780068d38334478d"/>
               </a:ext>
             </a:extLst>
           </a:blip>
@@ -5992,7 +4725,7 @@
           <p:cNvPr id="23" name="Evidence 98.39%">
             <a:extLst xmlns:a="http://schemas.openxmlformats.org/drawingml/2006/main">
               <a:ext uri="{FF2B5EF4-FFF2-40B4-BE49-F238E27FC236}">
-                <a16:creationId xmlns:a16="http://schemas.microsoft.com/office/drawing/2014/main" id="{D94C939A-0CC8-4B25-95B0-A39015275B21}"/>
+                <a16:creationId xmlns:a16="http://schemas.microsoft.com/office/drawing/2014/main" id="{5BB9CF72-D0CB-4A85-8B55-5D22C40524E4}"/>
               </a:ext>
             </a:extLst>
           </p:cNvPr>
@@ -6049,7 +4782,7 @@
           <p:cNvPr id="24" name="Evidence 98.39% scope">
             <a:extLst xmlns:a="http://schemas.openxmlformats.org/drawingml/2006/main">
               <a:ext uri="{FF2B5EF4-FFF2-40B4-BE49-F238E27FC236}">
-                <a16:creationId xmlns:a16="http://schemas.microsoft.com/office/drawing/2014/main" id="{CF11C7D6-36C2-4718-843B-9AC36B15AC8B}"/>
+                <a16:creationId xmlns:a16="http://schemas.microsoft.com/office/drawing/2014/main" id="{D2CA9C72-FD46-474D-8262-39B507E5E1CD}"/>
               </a:ext>
             </a:extLst>
           </p:cNvPr>
@@ -6106,7 +4839,7 @@
           <p:cNvPr id="25" name="Evidence 98.39% source">
             <a:extLst xmlns:a="http://schemas.openxmlformats.org/drawingml/2006/main">
               <a:ext uri="{FF2B5EF4-FFF2-40B4-BE49-F238E27FC236}">
-                <a16:creationId xmlns:a16="http://schemas.microsoft.com/office/drawing/2014/main" id="{CF9A6192-734A-4D2C-B82A-DE31F58B0A76}"/>
+                <a16:creationId xmlns:a16="http://schemas.microsoft.com/office/drawing/2014/main" id="{28045943-66BA-4E6E-B6CA-4FE398E1878C}"/>
               </a:ext>
             </a:extLst>
           </p:cNvPr>
@@ -6152,7 +4885,7 @@
                 <a:latin typeface="Arial"/>
                 <a:ea typeface="Arial"/>
                 <a:cs typeface="Arial"/>
-                <a:hlinkClick xmlns:r="http://schemas.openxmlformats.org/officeDocument/2006/relationships" r:id="R5c25164529a840f8"/>
+                <a:hlinkClick xmlns:r="http://schemas.openxmlformats.org/officeDocument/2006/relationships" r:id="Ra0576ac9f7014d2d"/>
               </a:rPr>
               <a:t>Patil et al., 2024</a:t>
             </a:r>
@@ -6168,10 +4901,10 @@
           <p:nvPr/>
         </p:nvPicPr>
         <p:blipFill>
-          <a:blip xmlns:r="http://schemas.openxmlformats.org/officeDocument/2006/relationships" xmlns:a="http://schemas.openxmlformats.org/drawingml/2006/main" r:embed="R11c2c5659a264965">
+          <a:blip xmlns:r="http://schemas.openxmlformats.org/officeDocument/2006/relationships" xmlns:a="http://schemas.openxmlformats.org/drawingml/2006/main" r:embed="Rcd3460c78fd842a8">
             <a:extLst>
               <a:ext uri="{96DAC541-7B7A-43D3-8B79-37D633B846F1}">
-                <asvg:svgBlip xmlns:asvg="http://schemas.microsoft.com/office/drawing/2016/SVG/main" r:embed="R112d498715ca4c4a"/>
+                <asvg:svgBlip xmlns:asvg="http://schemas.microsoft.com/office/drawing/2016/SVG/main" r:embed="R2ab098064fa44520"/>
               </a:ext>
             </a:extLst>
           </a:blip>
@@ -6192,7 +4925,7 @@
           <p:cNvPr id="27" name="Evidence 88%">
             <a:extLst xmlns:a="http://schemas.openxmlformats.org/drawingml/2006/main">
               <a:ext uri="{FF2B5EF4-FFF2-40B4-BE49-F238E27FC236}">
-                <a16:creationId xmlns:a16="http://schemas.microsoft.com/office/drawing/2014/main" id="{4073AD07-1E89-4BE4-A197-3C2F2F17B32D}"/>
+                <a16:creationId xmlns:a16="http://schemas.microsoft.com/office/drawing/2014/main" id="{DE52C92C-7E37-4407-B2DD-5BB0907B964A}"/>
               </a:ext>
             </a:extLst>
           </p:cNvPr>
@@ -6249,7 +4982,7 @@
           <p:cNvPr id="28" name="Evidence 88% scope">
             <a:extLst xmlns:a="http://schemas.openxmlformats.org/drawingml/2006/main">
               <a:ext uri="{FF2B5EF4-FFF2-40B4-BE49-F238E27FC236}">
-                <a16:creationId xmlns:a16="http://schemas.microsoft.com/office/drawing/2014/main" id="{E865A898-0E06-4018-8A93-499C26EC53FB}"/>
+                <a16:creationId xmlns:a16="http://schemas.microsoft.com/office/drawing/2014/main" id="{8BD2DEDB-0478-4370-914D-00734DA31D14}"/>
               </a:ext>
             </a:extLst>
           </p:cNvPr>
@@ -6306,7 +5039,7 @@
           <p:cNvPr id="29" name="Evidence 88% source">
             <a:extLst xmlns:a="http://schemas.openxmlformats.org/drawingml/2006/main">
               <a:ext uri="{FF2B5EF4-FFF2-40B4-BE49-F238E27FC236}">
-                <a16:creationId xmlns:a16="http://schemas.microsoft.com/office/drawing/2014/main" id="{907AFFE1-EC54-4F7F-A47C-F2ABE9F5F09D}"/>
+                <a16:creationId xmlns:a16="http://schemas.microsoft.com/office/drawing/2014/main" id="{DC8BA32C-A68D-4565-9AE1-D989A58AED14}"/>
               </a:ext>
             </a:extLst>
           </p:cNvPr>
@@ -6352,7 +5085,7 @@
                 <a:latin typeface="Arial"/>
                 <a:ea typeface="Arial"/>
                 <a:cs typeface="Arial"/>
-                <a:hlinkClick xmlns:r="http://schemas.openxmlformats.org/officeDocument/2006/relationships" r:id="Rde27b88f53d94d52"/>
+                <a:hlinkClick xmlns:r="http://schemas.openxmlformats.org/officeDocument/2006/relationships" r:id="R6705c1bd0bfd41ee"/>
               </a:rPr>
               <a:t>IndiaSpend reporting; seven cities</a:t>
             </a:r>
@@ -6368,10 +5101,10 @@
           <p:nvPr/>
         </p:nvPicPr>
         <p:blipFill>
-          <a:blip xmlns:r="http://schemas.openxmlformats.org/officeDocument/2006/relationships" xmlns:a="http://schemas.openxmlformats.org/drawingml/2006/main" r:embed="Rae8a9b6cc6f8477c">
+          <a:blip xmlns:r="http://schemas.openxmlformats.org/officeDocument/2006/relationships" xmlns:a="http://schemas.openxmlformats.org/drawingml/2006/main" r:embed="R9ffa13e2200041ab">
             <a:extLst>
               <a:ext uri="{96DAC541-7B7A-43D3-8B79-37D633B846F1}">
-                <asvg:svgBlip xmlns:asvg="http://schemas.microsoft.com/office/drawing/2016/SVG/main" r:embed="R359bc1e3680340b2"/>
+                <asvg:svgBlip xmlns:asvg="http://schemas.microsoft.com/office/drawing/2016/SVG/main" r:embed="R52b4af6d00a844a8"/>
               </a:ext>
             </a:extLst>
           </a:blip>
@@ -6392,7 +5125,7 @@
           <p:cNvPr id="31" name="Evidence 11.5%">
             <a:extLst xmlns:a="http://schemas.openxmlformats.org/drawingml/2006/main">
               <a:ext uri="{FF2B5EF4-FFF2-40B4-BE49-F238E27FC236}">
-                <a16:creationId xmlns:a16="http://schemas.microsoft.com/office/drawing/2014/main" id="{637B60D4-2E67-443E-9A85-7B3BD3776C53}"/>
+                <a16:creationId xmlns:a16="http://schemas.microsoft.com/office/drawing/2014/main" id="{2D4B4229-3B9C-4483-8497-E9D37320139B}"/>
               </a:ext>
             </a:extLst>
           </p:cNvPr>
@@ -6449,7 +5182,7 @@
           <p:cNvPr id="32" name="Evidence 11.5% scope">
             <a:extLst xmlns:a="http://schemas.openxmlformats.org/drawingml/2006/main">
               <a:ext uri="{FF2B5EF4-FFF2-40B4-BE49-F238E27FC236}">
-                <a16:creationId xmlns:a16="http://schemas.microsoft.com/office/drawing/2014/main" id="{DD614463-215F-44CA-9EE5-4548EDD1A704}"/>
+                <a16:creationId xmlns:a16="http://schemas.microsoft.com/office/drawing/2014/main" id="{5009D734-8381-4E6C-98F1-463B0B559EEB}"/>
               </a:ext>
             </a:extLst>
           </p:cNvPr>
@@ -6506,7 +5239,7 @@
           <p:cNvPr id="33" name="Evidence 11.5% source">
             <a:extLst xmlns:a="http://schemas.openxmlformats.org/drawingml/2006/main">
               <a:ext uri="{FF2B5EF4-FFF2-40B4-BE49-F238E27FC236}">
-                <a16:creationId xmlns:a16="http://schemas.microsoft.com/office/drawing/2014/main" id="{243D93FE-F2D4-4231-B3E0-71428F5EDF31}"/>
+                <a16:creationId xmlns:a16="http://schemas.microsoft.com/office/drawing/2014/main" id="{E3F19FBC-6632-458C-BD4E-28C6AC143E04}"/>
               </a:ext>
             </a:extLst>
           </p:cNvPr>
@@ -6552,7 +5285,7 @@
                 <a:latin typeface="Arial"/>
                 <a:ea typeface="Arial"/>
                 <a:cs typeface="Arial"/>
-                <a:hlinkClick xmlns:r="http://schemas.openxmlformats.org/officeDocument/2006/relationships" r:id="R8460401a990442cd"/>
+                <a:hlinkClick xmlns:r="http://schemas.openxmlformats.org/officeDocument/2006/relationships" r:id="R8b2e4d25f3c34d46"/>
               </a:rPr>
               <a:t>Jacob et al., CMC Vellore, 2026</a:t>
             </a:r>
@@ -6568,10 +5301,10 @@
           <p:nvPr/>
         </p:nvPicPr>
         <p:blipFill>
-          <a:blip xmlns:r="http://schemas.openxmlformats.org/officeDocument/2006/relationships" xmlns:a="http://schemas.openxmlformats.org/drawingml/2006/main" r:embed="R7912fb7ee2cd46f7">
+          <a:blip xmlns:r="http://schemas.openxmlformats.org/officeDocument/2006/relationships" xmlns:a="http://schemas.openxmlformats.org/drawingml/2006/main" r:embed="R43b80d0819144d0e">
             <a:extLst>
               <a:ext uri="{96DAC541-7B7A-43D3-8B79-37D633B846F1}">
-                <asvg:svgBlip xmlns:asvg="http://schemas.microsoft.com/office/drawing/2016/SVG/main" r:embed="R203879d950ad4bc4"/>
+                <asvg:svgBlip xmlns:asvg="http://schemas.microsoft.com/office/drawing/2016/SVG/main" r:embed="Rd10f2e6b40c74b53"/>
               </a:ext>
             </a:extLst>
           </a:blip>
@@ -6592,7 +5325,7 @@
           <p:cNvPr id="35" name="QI measure">
             <a:extLst xmlns:a="http://schemas.openxmlformats.org/drawingml/2006/main">
               <a:ext uri="{FF2B5EF4-FFF2-40B4-BE49-F238E27FC236}">
-                <a16:creationId xmlns:a16="http://schemas.microsoft.com/office/drawing/2014/main" id="{D2651FD1-CAD0-493B-BC0A-FD9CA6B390B2}"/>
+                <a16:creationId xmlns:a16="http://schemas.microsoft.com/office/drawing/2014/main" id="{2AEBDAB5-8B66-4F60-9F24-8E8F254CBAA6}"/>
               </a:ext>
             </a:extLst>
           </p:cNvPr>
@@ -6649,7 +5382,7 @@
           <p:cNvPr id="36" name="QI finding">
             <a:extLst xmlns:a="http://schemas.openxmlformats.org/drawingml/2006/main">
               <a:ext uri="{FF2B5EF4-FFF2-40B4-BE49-F238E27FC236}">
-                <a16:creationId xmlns:a16="http://schemas.microsoft.com/office/drawing/2014/main" id="{D1FA14F3-05C8-44B4-8C88-B74468A57F85}"/>
+                <a16:creationId xmlns:a16="http://schemas.microsoft.com/office/drawing/2014/main" id="{24D79601-E170-467E-B6B5-6BC570CC59DB}"/>
               </a:ext>
             </a:extLst>
           </p:cNvPr>
@@ -6706,7 +5439,7 @@
           <p:cNvPr id="37" name="QI scope">
             <a:extLst xmlns:a="http://schemas.openxmlformats.org/drawingml/2006/main">
               <a:ext uri="{FF2B5EF4-FFF2-40B4-BE49-F238E27FC236}">
-                <a16:creationId xmlns:a16="http://schemas.microsoft.com/office/drawing/2014/main" id="{32CCF79E-F75F-4054-A281-C140E652B715}"/>
+                <a16:creationId xmlns:a16="http://schemas.microsoft.com/office/drawing/2014/main" id="{F36F4243-86C7-4DA6-86FF-4D165CCA6D7B}"/>
               </a:ext>
             </a:extLst>
           </p:cNvPr>
@@ -6763,7 +5496,7 @@
           <p:cNvPr id="38" name="QI source">
             <a:extLst xmlns:a="http://schemas.openxmlformats.org/drawingml/2006/main">
               <a:ext uri="{FF2B5EF4-FFF2-40B4-BE49-F238E27FC236}">
-                <a16:creationId xmlns:a16="http://schemas.microsoft.com/office/drawing/2014/main" id="{9F7600D9-C0DB-4668-AD7E-865B80440CA3}"/>
+                <a16:creationId xmlns:a16="http://schemas.microsoft.com/office/drawing/2014/main" id="{DFC4F305-9EDC-470E-A85B-E8F9ECD6D58B}"/>
               </a:ext>
             </a:extLst>
           </p:cNvPr>
@@ -6809,7 +5542,7 @@
                 <a:latin typeface="Arial"/>
                 <a:ea typeface="Arial"/>
                 <a:cs typeface="Arial"/>
-                <a:hlinkClick xmlns:r="http://schemas.openxmlformats.org/officeDocument/2006/relationships" r:id="Rad120cafcb784cab"/>
+                <a:hlinkClick xmlns:r="http://schemas.openxmlformats.org/officeDocument/2006/relationships" r:id="R8fa84104afe9481a"/>
               </a:rPr>
               <a:t>Thangasamy et al., 2025</a:t>
             </a:r>
@@ -6821,7 +5554,7 @@
           <p:cNvPr id="39" name="Evidence boundary">
             <a:extLst xmlns:a="http://schemas.openxmlformats.org/drawingml/2006/main">
               <a:ext uri="{FF2B5EF4-FFF2-40B4-BE49-F238E27FC236}">
-                <a16:creationId xmlns:a16="http://schemas.microsoft.com/office/drawing/2014/main" id="{D241C6FD-8DA6-4834-90E6-8ADD3D24A0F9}"/>
+                <a16:creationId xmlns:a16="http://schemas.microsoft.com/office/drawing/2014/main" id="{55DEEAF8-DD96-422A-9FFC-26C21D840D40}"/>
               </a:ext>
             </a:extLst>
           </p:cNvPr>
@@ -6877,6 +5610,1273 @@
     <p:extLst>
       <p:ext uri="{BB962C8B-B14F-4D97-AF65-F5344CB8AC3E}">
         <p14:creationId xmlns:p14="http://schemas.microsoft.com/office/powerpoint/2010/main" val="1299123762"/>
+      </p:ext>
+    </p:extLst>
+  </p:cSld>
+</p:sld>
+</file>
+
+<file path=ppt/slides/slide4.xml><?xml version="1.0" encoding="utf-8"?>
+<p:sld xmlns:p="http://schemas.openxmlformats.org/presentationml/2006/main">
+  <p:cSld>
+    <p:bg>
+      <p:bgPr>
+        <a:solidFill xmlns:a="http://schemas.openxmlformats.org/drawingml/2006/main">
+          <a:srgbClr val="FCFAF4"/>
+        </a:solidFill>
+      </p:bgPr>
+    </p:bg>
+    <p:spTree>
+      <p:nvGrpSpPr>
+        <p:cNvPr id="1" name=""/>
+        <p:cNvGrpSpPr/>
+        <p:nvPr/>
+      </p:nvGrpSpPr>
+      <p:grpSpPr>
+        <a:xfrm xmlns:a="http://schemas.openxmlformats.org/drawingml/2006/main"/>
+      </p:grpSpPr>
+      <p:sp>
+        <p:nvSpPr>
+          <p:cNvPr id="11" name="Slide title">
+            <a:extLst xmlns:a="http://schemas.openxmlformats.org/drawingml/2006/main">
+              <a:ext uri="{FF2B5EF4-FFF2-40B4-BE49-F238E27FC236}">
+                <a16:creationId xmlns:a16="http://schemas.microsoft.com/office/drawing/2014/main" id="{2AB9D88E-2600-4D40-8199-2C309F63516C}"/>
+              </a:ext>
+            </a:extLst>
+          </p:cNvPr>
+          <p:cNvSpPr>
+            <a:spLocks xmlns:a="http://schemas.openxmlformats.org/drawingml/2006/main" noGrp="1"/>
+          </p:cNvSpPr>
+          <p:nvPr/>
+        </p:nvSpPr>
+        <p:spPr>
+          <a:xfrm xmlns:a="http://schemas.openxmlformats.org/drawingml/2006/main">
+            <a:off x="533400" y="361950"/>
+            <a:ext cx="11125200" cy="581025"/>
+          </a:xfrm>
+          <a:prstGeom xmlns:a="http://schemas.openxmlformats.org/drawingml/2006/main" prst="rect">
+            <a:avLst/>
+          </a:prstGeom>
+          <a:noFill xmlns:a="http://schemas.openxmlformats.org/drawingml/2006/main"/>
+          <a:ln xmlns:a="http://schemas.openxmlformats.org/drawingml/2006/main" w="0">
+            <a:noFill/>
+          </a:ln>
+        </p:spPr>
+        <p:txBody>
+          <a:bodyPr xmlns:a="http://schemas.openxmlformats.org/drawingml/2006/main" wrap="square" lIns="0" tIns="0" rIns="0" bIns="0">
+            <a:normAutofit fontScale="100000"/>
+          </a:bodyPr>
+          <a:lstStyle xmlns:a="http://schemas.openxmlformats.org/drawingml/2006/main"/>
+          <a:p xmlns:a="http://schemas.openxmlformats.org/drawingml/2006/main">
+            <a:pPr>
+              <a:defRPr sz="3000" b="1">
+                <a:solidFill>
+                  <a:srgbClr val="173F33"/>
+                </a:solidFill>
+                <a:latin typeface="Arial"/>
+                <a:ea typeface="Arial"/>
+                <a:cs typeface="Arial"/>
+              </a:defRPr>
+            </a:pPr>
+            <a:r>
+              <a:rPr sz="3000" b="1">
+                <a:solidFill>
+                  <a:srgbClr val="173F33"/>
+                </a:solidFill>
+                <a:latin typeface="Arial"/>
+                <a:ea typeface="Arial"/>
+                <a:cs typeface="Arial"/>
+              </a:rPr>
+              <a:t>Saathi keeps your cancer care in one place.</a:t>
+            </a:r>
+          </a:p>
+        </p:txBody>
+      </p:sp>
+      <p:pic>
+        <p:nvPicPr>
+          <p:cNvPr id="12" name=""/>
+          <p:cNvPicPr>
+            <a:picLocks xmlns:a="http://schemas.openxmlformats.org/drawingml/2006/main" noChangeAspect="1"/>
+          </p:cNvPicPr>
+          <p:nvPr/>
+        </p:nvPicPr>
+        <p:blipFill>
+          <a:blip xmlns:r="http://schemas.openxmlformats.org/officeDocument/2006/relationships" xmlns:a="http://schemas.openxmlformats.org/drawingml/2006/main" r:embed="R6932073ada1c4b78"/>
+          <a:stretch xmlns:a="http://schemas.openxmlformats.org/drawingml/2006/main"/>
+        </p:blipFill>
+        <p:spPr>
+          <a:xfrm xmlns:a="http://schemas.openxmlformats.org/drawingml/2006/main">
+            <a:off x="273222" y="1066800"/>
+            <a:ext cx="8673757" cy="5067300"/>
+          </a:xfrm>
+          <a:prstGeom xmlns:a="http://schemas.openxmlformats.org/drawingml/2006/main" prst="rect">
+            <a:avLst/>
+          </a:prstGeom>
+        </p:spPr>
+      </p:pic>
+      <p:sp>
+        <p:nvSpPr>
+          <p:cNvPr id="3" name="Three sign-ins">
+            <a:extLst xmlns:a="http://schemas.openxmlformats.org/drawingml/2006/main">
+              <a:ext uri="{FF2B5EF4-FFF2-40B4-BE49-F238E27FC236}">
+                <a16:creationId xmlns:a16="http://schemas.microsoft.com/office/drawing/2014/main" id="{87D7927A-6C1F-4B5C-86EA-B835E2624C76}"/>
+              </a:ext>
+            </a:extLst>
+          </p:cNvPr>
+          <p:cNvSpPr>
+            <a:spLocks xmlns:a="http://schemas.openxmlformats.org/drawingml/2006/main" noGrp="1"/>
+          </p:cNvSpPr>
+          <p:nvPr/>
+        </p:nvSpPr>
+        <p:spPr>
+          <a:xfrm xmlns:a="http://schemas.openxmlformats.org/drawingml/2006/main">
+            <a:off x="9296400" y="1076325"/>
+            <a:ext cx="2362200" cy="342900"/>
+          </a:xfrm>
+          <a:prstGeom xmlns:a="http://schemas.openxmlformats.org/drawingml/2006/main" prst="rect">
+            <a:avLst/>
+          </a:prstGeom>
+          <a:noFill xmlns:a="http://schemas.openxmlformats.org/drawingml/2006/main"/>
+          <a:ln xmlns:a="http://schemas.openxmlformats.org/drawingml/2006/main" w="0">
+            <a:noFill/>
+          </a:ln>
+        </p:spPr>
+        <p:txBody>
+          <a:bodyPr xmlns:a="http://schemas.openxmlformats.org/drawingml/2006/main" wrap="square" lIns="0" tIns="0" rIns="0" bIns="0">
+            <a:normAutofit fontScale="100000"/>
+          </a:bodyPr>
+          <a:lstStyle xmlns:a="http://schemas.openxmlformats.org/drawingml/2006/main"/>
+          <a:p xmlns:a="http://schemas.openxmlformats.org/drawingml/2006/main">
+            <a:pPr>
+              <a:defRPr sz="1875" b="1">
+                <a:solidFill>
+                  <a:srgbClr val="173F33"/>
+                </a:solidFill>
+                <a:latin typeface="Arial"/>
+                <a:ea typeface="Arial"/>
+                <a:cs typeface="Arial"/>
+              </a:defRPr>
+            </a:pPr>
+            <a:r>
+              <a:rPr sz="1875" b="1">
+                <a:solidFill>
+                  <a:srgbClr val="173F33"/>
+                </a:solidFill>
+                <a:latin typeface="Arial"/>
+                <a:ea typeface="Arial"/>
+                <a:cs typeface="Arial"/>
+              </a:rPr>
+              <a:t>Three sign-ins</a:t>
+            </a:r>
+          </a:p>
+        </p:txBody>
+      </p:sp>
+      <p:pic>
+        <p:nvPicPr>
+          <p:cNvPr id="14" name=""/>
+          <p:cNvPicPr>
+            <a:picLocks xmlns:a="http://schemas.openxmlformats.org/drawingml/2006/main" noChangeAspect="1"/>
+          </p:cNvPicPr>
+          <p:nvPr/>
+        </p:nvPicPr>
+        <p:blipFill>
+          <a:blip xmlns:r="http://schemas.openxmlformats.org/officeDocument/2006/relationships" xmlns:a="http://schemas.openxmlformats.org/drawingml/2006/main" r:embed="R511be50821944e55"/>
+          <a:stretch xmlns:a="http://schemas.openxmlformats.org/drawingml/2006/main"/>
+        </p:blipFill>
+        <p:spPr>
+          <a:xfrm xmlns:a="http://schemas.openxmlformats.org/drawingml/2006/main">
+            <a:off x="9144000" y="1498066"/>
+            <a:ext cx="2514600" cy="2690293"/>
+          </a:xfrm>
+          <a:prstGeom xmlns:a="http://schemas.openxmlformats.org/drawingml/2006/main" prst="rect">
+            <a:avLst/>
+          </a:prstGeom>
+        </p:spPr>
+      </p:pic>
+      <p:sp>
+        <p:nvSpPr>
+          <p:cNvPr id="5" name="Patient role">
+            <a:extLst xmlns:a="http://schemas.openxmlformats.org/drawingml/2006/main">
+              <a:ext uri="{FF2B5EF4-FFF2-40B4-BE49-F238E27FC236}">
+                <a16:creationId xmlns:a16="http://schemas.microsoft.com/office/drawing/2014/main" id="{AFAE34A2-0F5A-447C-9A0B-216D09CF13EE}"/>
+              </a:ext>
+            </a:extLst>
+          </p:cNvPr>
+          <p:cNvSpPr>
+            <a:spLocks xmlns:a="http://schemas.openxmlformats.org/drawingml/2006/main" noGrp="1"/>
+          </p:cNvSpPr>
+          <p:nvPr/>
+        </p:nvSpPr>
+        <p:spPr>
+          <a:xfrm xmlns:a="http://schemas.openxmlformats.org/drawingml/2006/main">
+            <a:off x="9296400" y="4362450"/>
+            <a:ext cx="2362200" cy="304800"/>
+          </a:xfrm>
+          <a:prstGeom xmlns:a="http://schemas.openxmlformats.org/drawingml/2006/main" prst="rect">
+            <a:avLst/>
+          </a:prstGeom>
+          <a:noFill xmlns:a="http://schemas.openxmlformats.org/drawingml/2006/main"/>
+          <a:ln xmlns:a="http://schemas.openxmlformats.org/drawingml/2006/main" w="0">
+            <a:noFill/>
+          </a:ln>
+        </p:spPr>
+        <p:txBody>
+          <a:bodyPr xmlns:a="http://schemas.openxmlformats.org/drawingml/2006/main" wrap="square" lIns="0" tIns="0" rIns="0" bIns="0">
+            <a:normAutofit fontScale="100000"/>
+          </a:bodyPr>
+          <a:lstStyle xmlns:a="http://schemas.openxmlformats.org/drawingml/2006/main"/>
+          <a:p xmlns:a="http://schemas.openxmlformats.org/drawingml/2006/main">
+            <a:pPr>
+              <a:defRPr sz="1575" b="1">
+                <a:solidFill>
+                  <a:srgbClr val="157B68"/>
+                </a:solidFill>
+                <a:latin typeface="Arial"/>
+                <a:ea typeface="Arial"/>
+                <a:cs typeface="Arial"/>
+              </a:defRPr>
+            </a:pPr>
+            <a:r>
+              <a:rPr sz="1575" b="1">
+                <a:solidFill>
+                  <a:srgbClr val="157B68"/>
+                </a:solidFill>
+                <a:latin typeface="Arial"/>
+                <a:ea typeface="Arial"/>
+                <a:cs typeface="Arial"/>
+              </a:rPr>
+              <a:t>Patients see their care.</a:t>
+            </a:r>
+          </a:p>
+        </p:txBody>
+      </p:sp>
+      <p:sp>
+        <p:nvSpPr>
+          <p:cNvPr id="6" name="Family role">
+            <a:extLst xmlns:a="http://schemas.openxmlformats.org/drawingml/2006/main">
+              <a:ext uri="{FF2B5EF4-FFF2-40B4-BE49-F238E27FC236}">
+                <a16:creationId xmlns:a16="http://schemas.microsoft.com/office/drawing/2014/main" id="{EEC89FC7-7A28-4A56-A573-46724CDC983B}"/>
+              </a:ext>
+            </a:extLst>
+          </p:cNvPr>
+          <p:cNvSpPr>
+            <a:spLocks xmlns:a="http://schemas.openxmlformats.org/drawingml/2006/main" noGrp="1"/>
+          </p:cNvSpPr>
+          <p:nvPr/>
+        </p:nvSpPr>
+        <p:spPr>
+          <a:xfrm xmlns:a="http://schemas.openxmlformats.org/drawingml/2006/main">
+            <a:off x="9296400" y="4714875"/>
+            <a:ext cx="2362200" cy="304800"/>
+          </a:xfrm>
+          <a:prstGeom xmlns:a="http://schemas.openxmlformats.org/drawingml/2006/main" prst="rect">
+            <a:avLst/>
+          </a:prstGeom>
+          <a:noFill xmlns:a="http://schemas.openxmlformats.org/drawingml/2006/main"/>
+          <a:ln xmlns:a="http://schemas.openxmlformats.org/drawingml/2006/main" w="0">
+            <a:noFill/>
+          </a:ln>
+        </p:spPr>
+        <p:txBody>
+          <a:bodyPr xmlns:a="http://schemas.openxmlformats.org/drawingml/2006/main" wrap="square" lIns="0" tIns="0" rIns="0" bIns="0">
+            <a:normAutofit fontScale="100000"/>
+          </a:bodyPr>
+          <a:lstStyle xmlns:a="http://schemas.openxmlformats.org/drawingml/2006/main"/>
+          <a:p xmlns:a="http://schemas.openxmlformats.org/drawingml/2006/main">
+            <a:pPr>
+              <a:defRPr sz="1575" b="1">
+                <a:solidFill>
+                  <a:srgbClr val="7353AC"/>
+                </a:solidFill>
+                <a:latin typeface="Arial"/>
+                <a:ea typeface="Arial"/>
+                <a:cs typeface="Arial"/>
+              </a:defRPr>
+            </a:pPr>
+            <a:r>
+              <a:rPr sz="1575" b="1">
+                <a:solidFill>
+                  <a:srgbClr val="7353AC"/>
+                </a:solidFill>
+                <a:latin typeface="Arial"/>
+                <a:ea typeface="Arial"/>
+                <a:cs typeface="Arial"/>
+              </a:rPr>
+              <a:t>Families organise help.</a:t>
+            </a:r>
+          </a:p>
+        </p:txBody>
+      </p:sp>
+      <p:sp>
+        <p:nvSpPr>
+          <p:cNvPr id="7" name="Doctor role">
+            <a:extLst xmlns:a="http://schemas.openxmlformats.org/drawingml/2006/main">
+              <a:ext uri="{FF2B5EF4-FFF2-40B4-BE49-F238E27FC236}">
+                <a16:creationId xmlns:a16="http://schemas.microsoft.com/office/drawing/2014/main" id="{913A616F-92F3-4F91-842E-99C7A4295783}"/>
+              </a:ext>
+            </a:extLst>
+          </p:cNvPr>
+          <p:cNvSpPr>
+            <a:spLocks xmlns:a="http://schemas.openxmlformats.org/drawingml/2006/main" noGrp="1"/>
+          </p:cNvSpPr>
+          <p:nvPr/>
+        </p:nvSpPr>
+        <p:spPr>
+          <a:xfrm xmlns:a="http://schemas.openxmlformats.org/drawingml/2006/main">
+            <a:off x="9296400" y="5067300"/>
+            <a:ext cx="2362200" cy="304800"/>
+          </a:xfrm>
+          <a:prstGeom xmlns:a="http://schemas.openxmlformats.org/drawingml/2006/main" prst="rect">
+            <a:avLst/>
+          </a:prstGeom>
+          <a:noFill xmlns:a="http://schemas.openxmlformats.org/drawingml/2006/main"/>
+          <a:ln xmlns:a="http://schemas.openxmlformats.org/drawingml/2006/main" w="0">
+            <a:noFill/>
+          </a:ln>
+        </p:spPr>
+        <p:txBody>
+          <a:bodyPr xmlns:a="http://schemas.openxmlformats.org/drawingml/2006/main" wrap="square" lIns="0" tIns="0" rIns="0" bIns="0">
+            <a:normAutofit fontScale="99374"/>
+          </a:bodyPr>
+          <a:lstStyle xmlns:a="http://schemas.openxmlformats.org/drawingml/2006/main"/>
+          <a:p xmlns:a="http://schemas.openxmlformats.org/drawingml/2006/main">
+            <a:pPr>
+              <a:defRPr sz="1575" b="1">
+                <a:solidFill>
+                  <a:srgbClr val="B75E43"/>
+                </a:solidFill>
+                <a:latin typeface="Arial"/>
+                <a:ea typeface="Arial"/>
+                <a:cs typeface="Arial"/>
+              </a:defRPr>
+            </a:pPr>
+            <a:r>
+              <a:rPr sz="1575" b="1">
+                <a:solidFill>
+                  <a:srgbClr val="B75E43"/>
+                </a:solidFill>
+                <a:latin typeface="Arial"/>
+                <a:ea typeface="Arial"/>
+                <a:cs typeface="Arial"/>
+              </a:rPr>
+              <a:t>Doctors review and sign.</a:t>
+            </a:r>
+          </a:p>
+        </p:txBody>
+      </p:sp>
+      <p:sp>
+        <p:nvSpPr>
+          <p:cNvPr id="8" name="Practical family support">
+            <a:extLst xmlns:a="http://schemas.openxmlformats.org/drawingml/2006/main">
+              <a:ext uri="{FF2B5EF4-FFF2-40B4-BE49-F238E27FC236}">
+                <a16:creationId xmlns:a16="http://schemas.microsoft.com/office/drawing/2014/main" id="{C6C3D994-1F0F-4E10-9DCC-7DABFBA05786}"/>
+              </a:ext>
+            </a:extLst>
+          </p:cNvPr>
+          <p:cNvSpPr>
+            <a:spLocks xmlns:a="http://schemas.openxmlformats.org/drawingml/2006/main" noGrp="1"/>
+          </p:cNvSpPr>
+          <p:nvPr/>
+        </p:nvSpPr>
+        <p:spPr>
+          <a:xfrm xmlns:a="http://schemas.openxmlformats.org/drawingml/2006/main">
+            <a:off x="9296400" y="5486400"/>
+            <a:ext cx="2362200" cy="895350"/>
+          </a:xfrm>
+          <a:prstGeom xmlns:a="http://schemas.openxmlformats.org/drawingml/2006/main" prst="rect">
+            <a:avLst/>
+          </a:prstGeom>
+          <a:noFill xmlns:a="http://schemas.openxmlformats.org/drawingml/2006/main"/>
+          <a:ln xmlns:a="http://schemas.openxmlformats.org/drawingml/2006/main" w="0">
+            <a:noFill/>
+          </a:ln>
+        </p:spPr>
+        <p:txBody>
+          <a:bodyPr xmlns:a="http://schemas.openxmlformats.org/drawingml/2006/main" wrap="square" lIns="0" tIns="0" rIns="0" bIns="0">
+            <a:normAutofit fontScale="100000"/>
+          </a:bodyPr>
+          <a:lstStyle xmlns:a="http://schemas.openxmlformats.org/drawingml/2006/main"/>
+          <a:p xmlns:a="http://schemas.openxmlformats.org/drawingml/2006/main">
+            <a:pPr>
+              <a:defRPr sz="1388" b="0">
+                <a:solidFill>
+                  <a:srgbClr val="173F33"/>
+                </a:solidFill>
+                <a:latin typeface="Arial"/>
+                <a:ea typeface="Arial"/>
+                <a:cs typeface="Arial"/>
+              </a:defRPr>
+            </a:pPr>
+            <a:r>
+              <a:rPr sz="1388" b="0">
+                <a:solidFill>
+                  <a:srgbClr val="173F33"/>
+                </a:solidFill>
+                <a:latin typeface="Arial"/>
+                <a:ea typeface="Arial"/>
+                <a:cs typeface="Arial"/>
+              </a:rPr>
+              <a:t>Plan rides and home support. Keep medicine calls, costs, paperwork and emotional support together.</a:t>
+            </a:r>
+          </a:p>
+        </p:txBody>
+      </p:sp>
+      <p:sp>
+        <p:nvSpPr>
+          <p:cNvPr id="9" name="Patient home website">
+            <a:extLst xmlns:a="http://schemas.openxmlformats.org/drawingml/2006/main">
+              <a:ext uri="{FF2B5EF4-FFF2-40B4-BE49-F238E27FC236}">
+                <a16:creationId xmlns:a16="http://schemas.microsoft.com/office/drawing/2014/main" id="{585982FF-389C-40DB-AC40-23AF0016854D}"/>
+              </a:ext>
+            </a:extLst>
+          </p:cNvPr>
+          <p:cNvSpPr>
+            <a:spLocks xmlns:a="http://schemas.openxmlformats.org/drawingml/2006/main" noGrp="1"/>
+          </p:cNvSpPr>
+          <p:nvPr/>
+        </p:nvSpPr>
+        <p:spPr>
+          <a:xfrm xmlns:a="http://schemas.openxmlformats.org/drawingml/2006/main">
+            <a:off x="533400" y="6505575"/>
+            <a:ext cx="6381750" cy="238125"/>
+          </a:xfrm>
+          <a:prstGeom xmlns:a="http://schemas.openxmlformats.org/drawingml/2006/main" prst="rect">
+            <a:avLst/>
+          </a:prstGeom>
+          <a:noFill xmlns:a="http://schemas.openxmlformats.org/drawingml/2006/main"/>
+          <a:ln xmlns:a="http://schemas.openxmlformats.org/drawingml/2006/main" w="0">
+            <a:noFill/>
+          </a:ln>
+        </p:spPr>
+        <p:txBody>
+          <a:bodyPr xmlns:a="http://schemas.openxmlformats.org/drawingml/2006/main" wrap="square" lIns="0" tIns="0" rIns="0" bIns="0">
+            <a:normAutofit fontScale="99206"/>
+          </a:bodyPr>
+          <a:lstStyle xmlns:a="http://schemas.openxmlformats.org/drawingml/2006/main"/>
+          <a:p xmlns:a="http://schemas.openxmlformats.org/drawingml/2006/main">
+            <a:pPr>
+              <a:defRPr sz="1575" b="1">
+                <a:solidFill>
+                  <a:srgbClr val="145AC6"/>
+                </a:solidFill>
+                <a:latin typeface="Arial"/>
+                <a:ea typeface="Arial"/>
+                <a:cs typeface="Arial"/>
+              </a:defRPr>
+            </a:pPr>
+            <a:r>
+              <a:rPr sz="1575" b="1" u="sng">
+                <a:solidFill>
+                  <a:srgbClr val="145AC6"/>
+                </a:solidFill>
+                <a:latin typeface="Arial"/>
+                <a:ea typeface="Arial"/>
+                <a:cs typeface="Arial"/>
+                <a:hlinkClick xmlns:r="http://schemas.openxmlformats.org/officeDocument/2006/relationships" r:id="R975354d8b3aa4073"/>
+              </a:rPr>
+              <a:t>OPEN THE WEBSITE - saathi.wedevit.in</a:t>
+            </a:r>
+          </a:p>
+        </p:txBody>
+      </p:sp>
+      <p:sp>
+        <p:nvSpPr>
+          <p:cNvPr id="10" name="Support directory">
+            <a:extLst xmlns:a="http://schemas.openxmlformats.org/drawingml/2006/main">
+              <a:ext uri="{FF2B5EF4-FFF2-40B4-BE49-F238E27FC236}">
+                <a16:creationId xmlns:a16="http://schemas.microsoft.com/office/drawing/2014/main" id="{6EBB0FAB-581C-4164-85CF-2ACD8DCEB3D3}"/>
+              </a:ext>
+            </a:extLst>
+          </p:cNvPr>
+          <p:cNvSpPr>
+            <a:spLocks xmlns:a="http://schemas.openxmlformats.org/drawingml/2006/main" noGrp="1"/>
+          </p:cNvSpPr>
+          <p:nvPr/>
+        </p:nvSpPr>
+        <p:spPr>
+          <a:xfrm xmlns:a="http://schemas.openxmlformats.org/drawingml/2006/main">
+            <a:off x="7400925" y="6505575"/>
+            <a:ext cx="4257675" cy="238125"/>
+          </a:xfrm>
+          <a:prstGeom xmlns:a="http://schemas.openxmlformats.org/drawingml/2006/main" prst="rect">
+            <a:avLst/>
+          </a:prstGeom>
+          <a:noFill xmlns:a="http://schemas.openxmlformats.org/drawingml/2006/main"/>
+          <a:ln xmlns:a="http://schemas.openxmlformats.org/drawingml/2006/main" w="0">
+            <a:noFill/>
+          </a:ln>
+        </p:spPr>
+        <p:txBody>
+          <a:bodyPr xmlns:a="http://schemas.openxmlformats.org/drawingml/2006/main" wrap="square" lIns="0" tIns="0" rIns="0" bIns="0">
+            <a:normAutofit fontScale="100000"/>
+          </a:bodyPr>
+          <a:lstStyle xmlns:a="http://schemas.openxmlformats.org/drawingml/2006/main"/>
+          <a:p xmlns:a="http://schemas.openxmlformats.org/drawingml/2006/main">
+            <a:pPr>
+              <a:defRPr sz="1425" b="0">
+                <a:solidFill>
+                  <a:srgbClr val="145AC6"/>
+                </a:solidFill>
+                <a:latin typeface="Arial"/>
+                <a:ea typeface="Arial"/>
+                <a:cs typeface="Arial"/>
+              </a:defRPr>
+            </a:pPr>
+            <a:r>
+              <a:rPr sz="1425" b="0" u="sng">
+                <a:solidFill>
+                  <a:srgbClr val="145AC6"/>
+                </a:solidFill>
+                <a:latin typeface="Arial"/>
+                <a:ea typeface="Arial"/>
+                <a:cs typeface="Arial"/>
+                <a:hlinkClick xmlns:r="http://schemas.openxmlformats.org/officeDocument/2006/relationships" r:id="R5074f1267f73441e"/>
+              </a:rPr>
+              <a:t>Find a centre and call to confirm.</a:t>
+            </a:r>
+          </a:p>
+        </p:txBody>
+      </p:sp>
+    </p:spTree>
+    <p:extLst>
+      <p:ext uri="{BB962C8B-B14F-4D97-AF65-F5344CB8AC3E}">
+        <p14:creationId xmlns:p14="http://schemas.microsoft.com/office/powerpoint/2010/main" val="221085739"/>
+      </p:ext>
+    </p:extLst>
+  </p:cSld>
+</p:sld>
+</file>
+
+<file path=ppt/slides/slide5.xml><?xml version="1.0" encoding="utf-8"?>
+<p:sld xmlns:p="http://schemas.openxmlformats.org/presentationml/2006/main">
+  <p:cSld>
+    <p:bg>
+      <p:bgPr>
+        <a:solidFill xmlns:a="http://schemas.openxmlformats.org/drawingml/2006/main">
+          <a:srgbClr val="FFC799"/>
+        </a:solidFill>
+      </p:bgPr>
+    </p:bg>
+    <p:spTree>
+      <p:nvGrpSpPr>
+        <p:cNvPr id="1" name=""/>
+        <p:cNvGrpSpPr/>
+        <p:nvPr/>
+      </p:nvGrpSpPr>
+      <p:grpSpPr>
+        <a:xfrm xmlns:a="http://schemas.openxmlformats.org/drawingml/2006/main"/>
+      </p:grpSpPr>
+      <p:sp>
+        <p:nvSpPr>
+          <p:cNvPr id="14" name="Slide title">
+            <a:extLst xmlns:a="http://schemas.openxmlformats.org/drawingml/2006/main">
+              <a:ext uri="{FF2B5EF4-FFF2-40B4-BE49-F238E27FC236}">
+                <a16:creationId xmlns:a16="http://schemas.microsoft.com/office/drawing/2014/main" id="{0A0449C0-B182-4551-A504-8CF7E4058C1A}"/>
+              </a:ext>
+            </a:extLst>
+          </p:cNvPr>
+          <p:cNvSpPr>
+            <a:spLocks xmlns:a="http://schemas.openxmlformats.org/drawingml/2006/main" noGrp="1"/>
+          </p:cNvSpPr>
+          <p:nvPr/>
+        </p:nvSpPr>
+        <p:spPr>
+          <a:xfrm xmlns:a="http://schemas.openxmlformats.org/drawingml/2006/main">
+            <a:off x="533400" y="361950"/>
+            <a:ext cx="11125200" cy="600075"/>
+          </a:xfrm>
+          <a:prstGeom xmlns:a="http://schemas.openxmlformats.org/drawingml/2006/main" prst="rect">
+            <a:avLst/>
+          </a:prstGeom>
+          <a:noFill xmlns:a="http://schemas.openxmlformats.org/drawingml/2006/main"/>
+          <a:ln xmlns:a="http://schemas.openxmlformats.org/drawingml/2006/main" w="0">
+            <a:noFill/>
+          </a:ln>
+        </p:spPr>
+        <p:txBody>
+          <a:bodyPr xmlns:a="http://schemas.openxmlformats.org/drawingml/2006/main" wrap="square" lIns="0" tIns="0" rIns="0" bIns="0">
+            <a:normAutofit fontScale="100000"/>
+          </a:bodyPr>
+          <a:lstStyle xmlns:a="http://schemas.openxmlformats.org/drawingml/2006/main"/>
+          <a:p xmlns:a="http://schemas.openxmlformats.org/drawingml/2006/main">
+            <a:pPr>
+              <a:defRPr sz="2925" b="1">
+                <a:solidFill>
+                  <a:srgbClr val="173F33"/>
+                </a:solidFill>
+                <a:latin typeface="Arial"/>
+                <a:ea typeface="Arial"/>
+                <a:cs typeface="Arial"/>
+              </a:defRPr>
+            </a:pPr>
+            <a:r>
+              <a:rPr sz="2925" b="1">
+                <a:solidFill>
+                  <a:srgbClr val="173F33"/>
+                </a:solidFill>
+                <a:latin typeface="Arial"/>
+                <a:ea typeface="Arial"/>
+                <a:cs typeface="Arial"/>
+              </a:rPr>
+              <a:t>AI prepares the note. People check and sign it.</a:t>
+            </a:r>
+          </a:p>
+        </p:txBody>
+      </p:sp>
+      <p:sp>
+        <p:nvSpPr>
+          <p:cNvPr id="2" name="Human review">
+            <a:extLst xmlns:a="http://schemas.openxmlformats.org/drawingml/2006/main">
+              <a:ext uri="{FF2B5EF4-FFF2-40B4-BE49-F238E27FC236}">
+                <a16:creationId xmlns:a16="http://schemas.microsoft.com/office/drawing/2014/main" id="{A3AAEBD6-A70A-41A8-AFB7-CA8E93FA6429}"/>
+              </a:ext>
+            </a:extLst>
+          </p:cNvPr>
+          <p:cNvSpPr>
+            <a:spLocks xmlns:a="http://schemas.openxmlformats.org/drawingml/2006/main" noGrp="1"/>
+          </p:cNvSpPr>
+          <p:nvPr/>
+        </p:nvSpPr>
+        <p:spPr>
+          <a:xfrm xmlns:a="http://schemas.openxmlformats.org/drawingml/2006/main">
+            <a:off x="533400" y="1028700"/>
+            <a:ext cx="11125200" cy="400050"/>
+          </a:xfrm>
+          <a:prstGeom xmlns:a="http://schemas.openxmlformats.org/drawingml/2006/main" prst="rect">
+            <a:avLst/>
+          </a:prstGeom>
+          <a:noFill xmlns:a="http://schemas.openxmlformats.org/drawingml/2006/main"/>
+          <a:ln xmlns:a="http://schemas.openxmlformats.org/drawingml/2006/main" w="0">
+            <a:noFill/>
+          </a:ln>
+        </p:spPr>
+        <p:txBody>
+          <a:bodyPr xmlns:a="http://schemas.openxmlformats.org/drawingml/2006/main" wrap="square" lIns="0" tIns="0" rIns="0" bIns="0">
+            <a:normAutofit fontScale="100000"/>
+          </a:bodyPr>
+          <a:lstStyle xmlns:a="http://schemas.openxmlformats.org/drawingml/2006/main"/>
+          <a:p xmlns:a="http://schemas.openxmlformats.org/drawingml/2006/main">
+            <a:pPr>
+              <a:defRPr sz="1875" b="0">
+                <a:solidFill>
+                  <a:srgbClr val="53655C"/>
+                </a:solidFill>
+                <a:latin typeface="Arial"/>
+                <a:ea typeface="Arial"/>
+                <a:cs typeface="Arial"/>
+              </a:defRPr>
+            </a:pPr>
+            <a:r>
+              <a:rPr sz="1875" b="0">
+                <a:solidFill>
+                  <a:srgbClr val="53655C"/>
+                </a:solidFill>
+                <a:latin typeface="Arial"/>
+                <a:ea typeface="Arial"/>
+                <a:cs typeface="Arial"/>
+              </a:rPr>
+              <a:t>The doctor signs first. The patient then reviews and signs that version.</a:t>
+            </a:r>
+          </a:p>
+        </p:txBody>
+      </p:sp>
+      <p:pic>
+        <p:nvPicPr>
+          <p:cNvPr id="16" name=""/>
+          <p:cNvPicPr>
+            <a:picLocks xmlns:a="http://schemas.openxmlformats.org/drawingml/2006/main" noChangeAspect="1"/>
+          </p:cNvPicPr>
+          <p:nvPr/>
+        </p:nvPicPr>
+        <p:blipFill>
+          <a:blip xmlns:r="http://schemas.openxmlformats.org/officeDocument/2006/relationships" xmlns:a="http://schemas.openxmlformats.org/drawingml/2006/main" r:embed="R06a12e83481d4a72"/>
+          <a:stretch xmlns:a="http://schemas.openxmlformats.org/drawingml/2006/main"/>
+        </p:blipFill>
+        <p:spPr>
+          <a:xfrm xmlns:a="http://schemas.openxmlformats.org/drawingml/2006/main">
+            <a:off x="400050" y="1876325"/>
+            <a:ext cx="8286750" cy="3876875"/>
+          </a:xfrm>
+          <a:prstGeom xmlns:a="http://schemas.openxmlformats.org/drawingml/2006/main" prst="rect">
+            <a:avLst/>
+          </a:prstGeom>
+        </p:spPr>
+      </p:pic>
+      <p:sp>
+        <p:nvSpPr>
+          <p:cNvPr id="4" name="Source traceability">
+            <a:extLst xmlns:a="http://schemas.openxmlformats.org/drawingml/2006/main">
+              <a:ext uri="{FF2B5EF4-FFF2-40B4-BE49-F238E27FC236}">
+                <a16:creationId xmlns:a16="http://schemas.microsoft.com/office/drawing/2014/main" id="{90918D73-22B4-4510-92D8-4D05DCD8B034}"/>
+              </a:ext>
+            </a:extLst>
+          </p:cNvPr>
+          <p:cNvSpPr>
+            <a:spLocks xmlns:a="http://schemas.openxmlformats.org/drawingml/2006/main" noGrp="1"/>
+          </p:cNvSpPr>
+          <p:nvPr/>
+        </p:nvSpPr>
+        <p:spPr>
+          <a:xfrm xmlns:a="http://schemas.openxmlformats.org/drawingml/2006/main">
+            <a:off x="533400" y="5991225"/>
+            <a:ext cx="8001000" cy="523875"/>
+          </a:xfrm>
+          <a:prstGeom xmlns:a="http://schemas.openxmlformats.org/drawingml/2006/main" prst="rect">
+            <a:avLst/>
+          </a:prstGeom>
+          <a:noFill xmlns:a="http://schemas.openxmlformats.org/drawingml/2006/main"/>
+          <a:ln xmlns:a="http://schemas.openxmlformats.org/drawingml/2006/main" w="0">
+            <a:noFill/>
+          </a:ln>
+        </p:spPr>
+        <p:txBody>
+          <a:bodyPr xmlns:a="http://schemas.openxmlformats.org/drawingml/2006/main" wrap="square" lIns="0" tIns="0" rIns="0" bIns="0">
+            <a:normAutofit fontScale="100000"/>
+          </a:bodyPr>
+          <a:lstStyle xmlns:a="http://schemas.openxmlformats.org/drawingml/2006/main"/>
+          <a:p xmlns:a="http://schemas.openxmlformats.org/drawingml/2006/main">
+            <a:pPr>
+              <a:defRPr sz="1725" b="1">
+                <a:solidFill>
+                  <a:srgbClr val="B75E43"/>
+                </a:solidFill>
+                <a:latin typeface="Arial"/>
+                <a:ea typeface="Arial"/>
+                <a:cs typeface="Arial"/>
+              </a:defRPr>
+            </a:pPr>
+            <a:r>
+              <a:rPr sz="1725" b="1">
+                <a:solidFill>
+                  <a:srgbClr val="B75E43"/>
+                </a:solidFill>
+                <a:latin typeface="Arial"/>
+                <a:ea typeface="Arial"/>
+                <a:cs typeface="Arial"/>
+              </a:rPr>
+              <a:t>Keep the source words and every signed version for the next conversation.</a:t>
+            </a:r>
+          </a:p>
+        </p:txBody>
+      </p:sp>
+      <p:sp>
+        <p:nvSpPr>
+          <p:cNvPr id="5" name="Proposed voice provider">
+            <a:extLst xmlns:a="http://schemas.openxmlformats.org/drawingml/2006/main">
+              <a:ext uri="{FF2B5EF4-FFF2-40B4-BE49-F238E27FC236}">
+                <a16:creationId xmlns:a16="http://schemas.microsoft.com/office/drawing/2014/main" id="{2595E3B1-C578-4984-9D80-4C22DBDE21EC}"/>
+              </a:ext>
+            </a:extLst>
+          </p:cNvPr>
+          <p:cNvSpPr>
+            <a:spLocks xmlns:a="http://schemas.openxmlformats.org/drawingml/2006/main" noGrp="1"/>
+          </p:cNvSpPr>
+          <p:nvPr/>
+        </p:nvSpPr>
+        <p:spPr>
+          <a:xfrm xmlns:a="http://schemas.openxmlformats.org/drawingml/2006/main">
+            <a:off x="533400" y="6543675"/>
+            <a:ext cx="11125200" cy="228600"/>
+          </a:xfrm>
+          <a:prstGeom xmlns:a="http://schemas.openxmlformats.org/drawingml/2006/main" prst="rect">
+            <a:avLst/>
+          </a:prstGeom>
+          <a:noFill xmlns:a="http://schemas.openxmlformats.org/drawingml/2006/main"/>
+          <a:ln xmlns:a="http://schemas.openxmlformats.org/drawingml/2006/main" w="0">
+            <a:noFill/>
+          </a:ln>
+        </p:spPr>
+        <p:txBody>
+          <a:bodyPr xmlns:a="http://schemas.openxmlformats.org/drawingml/2006/main" wrap="square" lIns="0" tIns="0" rIns="0" bIns="0">
+            <a:normAutofit fontScale="100000"/>
+          </a:bodyPr>
+          <a:lstStyle xmlns:a="http://schemas.openxmlformats.org/drawingml/2006/main"/>
+          <a:p xmlns:a="http://schemas.openxmlformats.org/drawingml/2006/main">
+            <a:pPr>
+              <a:defRPr sz="1313" b="0">
+                <a:solidFill>
+                  <a:srgbClr val="145AC6"/>
+                </a:solidFill>
+                <a:latin typeface="Arial"/>
+                <a:ea typeface="Arial"/>
+                <a:cs typeface="Arial"/>
+              </a:defRPr>
+            </a:pPr>
+            <a:r>
+              <a:rPr sz="1313" b="0" u="sng">
+                <a:solidFill>
+                  <a:srgbClr val="145AC6"/>
+                </a:solidFill>
+                <a:latin typeface="Arial"/>
+                <a:ea typeface="Arial"/>
+                <a:cs typeface="Arial"/>
+                <a:hlinkClick xmlns:r="http://schemas.openxmlformats.org/officeDocument/2006/relationships" r:id="R3f6056b8fabf4aae"/>
+              </a:rPr>
+              <a:t>Planned with Sarvam AI: Indian-language speech, translation and read-aloud.</a:t>
+            </a:r>
+          </a:p>
+        </p:txBody>
+      </p:sp>
+      <p:sp>
+        <p:nvSpPr>
+          <p:cNvPr id="6" name="AI step 1">
+            <a:extLst xmlns:a="http://schemas.openxmlformats.org/drawingml/2006/main">
+              <a:ext uri="{FF2B5EF4-FFF2-40B4-BE49-F238E27FC236}">
+                <a16:creationId xmlns:a16="http://schemas.microsoft.com/office/drawing/2014/main" id="{A72CFC45-8D98-4E73-86ED-BF439D7B9552}"/>
+              </a:ext>
+            </a:extLst>
+          </p:cNvPr>
+          <p:cNvSpPr>
+            <a:spLocks xmlns:a="http://schemas.openxmlformats.org/drawingml/2006/main" noGrp="1"/>
+          </p:cNvSpPr>
+          <p:nvPr/>
+        </p:nvSpPr>
+        <p:spPr>
+          <a:xfrm xmlns:a="http://schemas.openxmlformats.org/drawingml/2006/main">
+            <a:off x="9001125" y="1676400"/>
+            <a:ext cx="2657475" cy="523875"/>
+          </a:xfrm>
+          <a:prstGeom xmlns:a="http://schemas.openxmlformats.org/drawingml/2006/main" prst="rect">
+            <a:avLst/>
+          </a:prstGeom>
+          <a:noFill xmlns:a="http://schemas.openxmlformats.org/drawingml/2006/main"/>
+          <a:ln xmlns:a="http://schemas.openxmlformats.org/drawingml/2006/main" w="0">
+            <a:noFill/>
+          </a:ln>
+        </p:spPr>
+        <p:txBody>
+          <a:bodyPr xmlns:a="http://schemas.openxmlformats.org/drawingml/2006/main" wrap="square" lIns="0" tIns="0" rIns="0" bIns="0">
+            <a:normAutofit fontScale="99638"/>
+          </a:bodyPr>
+          <a:lstStyle xmlns:a="http://schemas.openxmlformats.org/drawingml/2006/main"/>
+          <a:p xmlns:a="http://schemas.openxmlformats.org/drawingml/2006/main">
+            <a:pPr>
+              <a:defRPr sz="1725" b="1">
+                <a:solidFill>
+                  <a:srgbClr val="173F33"/>
+                </a:solidFill>
+                <a:latin typeface="Arial"/>
+                <a:ea typeface="Arial"/>
+                <a:cs typeface="Arial"/>
+              </a:defRPr>
+            </a:pPr>
+            <a:r>
+              <a:rPr sz="1725" b="1">
+                <a:solidFill>
+                  <a:srgbClr val="173F33"/>
+                </a:solidFill>
+                <a:latin typeface="Arial"/>
+                <a:ea typeface="Arial"/>
+                <a:cs typeface="Arial"/>
+              </a:rPr>
+              <a:t>1. Record with permission.</a:t>
+            </a:r>
+          </a:p>
+        </p:txBody>
+      </p:sp>
+      <p:sp>
+        <p:nvSpPr>
+          <p:cNvPr id="7" name="AI step 1 detail">
+            <a:extLst xmlns:a="http://schemas.openxmlformats.org/drawingml/2006/main">
+              <a:ext uri="{FF2B5EF4-FFF2-40B4-BE49-F238E27FC236}">
+                <a16:creationId xmlns:a16="http://schemas.microsoft.com/office/drawing/2014/main" id="{28743428-9780-4A8B-B0A9-B522C2124FE0}"/>
+              </a:ext>
+            </a:extLst>
+          </p:cNvPr>
+          <p:cNvSpPr>
+            <a:spLocks xmlns:a="http://schemas.openxmlformats.org/drawingml/2006/main" noGrp="1"/>
+          </p:cNvSpPr>
+          <p:nvPr/>
+        </p:nvSpPr>
+        <p:spPr>
+          <a:xfrm xmlns:a="http://schemas.openxmlformats.org/drawingml/2006/main">
+            <a:off x="9001125" y="2247900"/>
+            <a:ext cx="2657475" cy="561975"/>
+          </a:xfrm>
+          <a:prstGeom xmlns:a="http://schemas.openxmlformats.org/drawingml/2006/main" prst="rect">
+            <a:avLst/>
+          </a:prstGeom>
+          <a:noFill xmlns:a="http://schemas.openxmlformats.org/drawingml/2006/main"/>
+          <a:ln xmlns:a="http://schemas.openxmlformats.org/drawingml/2006/main" w="0">
+            <a:noFill/>
+          </a:ln>
+        </p:spPr>
+        <p:txBody>
+          <a:bodyPr xmlns:a="http://schemas.openxmlformats.org/drawingml/2006/main" wrap="square" lIns="0" tIns="0" rIns="0" bIns="0">
+            <a:normAutofit fontScale="100000"/>
+          </a:bodyPr>
+          <a:lstStyle xmlns:a="http://schemas.openxmlformats.org/drawingml/2006/main"/>
+          <a:p xmlns:a="http://schemas.openxmlformats.org/drawingml/2006/main">
+            <a:pPr>
+              <a:defRPr sz="1463" b="0">
+                <a:solidFill>
+                  <a:srgbClr val="53655C"/>
+                </a:solidFill>
+                <a:latin typeface="Arial"/>
+                <a:ea typeface="Arial"/>
+                <a:cs typeface="Arial"/>
+              </a:defRPr>
+            </a:pPr>
+            <a:r>
+              <a:rPr sz="1463" b="0">
+                <a:solidFill>
+                  <a:srgbClr val="53655C"/>
+                </a:solidFill>
+                <a:latin typeface="Arial"/>
+                <a:ea typeface="Arial"/>
+                <a:cs typeface="Arial"/>
+              </a:rPr>
+              <a:t>Keep who said what in the conversation.</a:t>
+            </a:r>
+          </a:p>
+        </p:txBody>
+      </p:sp>
+      <p:sp>
+        <p:nvSpPr>
+          <p:cNvPr id="8" name="AI step 2">
+            <a:extLst xmlns:a="http://schemas.openxmlformats.org/drawingml/2006/main">
+              <a:ext uri="{FF2B5EF4-FFF2-40B4-BE49-F238E27FC236}">
+                <a16:creationId xmlns:a16="http://schemas.microsoft.com/office/drawing/2014/main" id="{C2046684-830B-484D-AE36-4C48B3CE83DB}"/>
+              </a:ext>
+            </a:extLst>
+          </p:cNvPr>
+          <p:cNvSpPr>
+            <a:spLocks xmlns:a="http://schemas.openxmlformats.org/drawingml/2006/main" noGrp="1"/>
+          </p:cNvSpPr>
+          <p:nvPr/>
+        </p:nvSpPr>
+        <p:spPr>
+          <a:xfrm xmlns:a="http://schemas.openxmlformats.org/drawingml/2006/main">
+            <a:off x="9001125" y="2838450"/>
+            <a:ext cx="2657475" cy="523875"/>
+          </a:xfrm>
+          <a:prstGeom xmlns:a="http://schemas.openxmlformats.org/drawingml/2006/main" prst="rect">
+            <a:avLst/>
+          </a:prstGeom>
+          <a:noFill xmlns:a="http://schemas.openxmlformats.org/drawingml/2006/main"/>
+          <a:ln xmlns:a="http://schemas.openxmlformats.org/drawingml/2006/main" w="0">
+            <a:noFill/>
+          </a:ln>
+        </p:spPr>
+        <p:txBody>
+          <a:bodyPr xmlns:a="http://schemas.openxmlformats.org/drawingml/2006/main" wrap="square" lIns="0" tIns="0" rIns="0" bIns="0">
+            <a:normAutofit fontScale="100000"/>
+          </a:bodyPr>
+          <a:lstStyle xmlns:a="http://schemas.openxmlformats.org/drawingml/2006/main"/>
+          <a:p xmlns:a="http://schemas.openxmlformats.org/drawingml/2006/main">
+            <a:pPr>
+              <a:defRPr sz="1725" b="1">
+                <a:solidFill>
+                  <a:srgbClr val="173F33"/>
+                </a:solidFill>
+                <a:latin typeface="Arial"/>
+                <a:ea typeface="Arial"/>
+                <a:cs typeface="Arial"/>
+              </a:defRPr>
+            </a:pPr>
+            <a:r>
+              <a:rPr sz="1725" b="1">
+                <a:solidFill>
+                  <a:srgbClr val="173F33"/>
+                </a:solidFill>
+                <a:latin typeface="Arial"/>
+                <a:ea typeface="Arial"/>
+                <a:cs typeface="Arial"/>
+              </a:rPr>
+              <a:t>2. AI prepares a draft.</a:t>
+            </a:r>
+          </a:p>
+        </p:txBody>
+      </p:sp>
+      <p:sp>
+        <p:nvSpPr>
+          <p:cNvPr id="9" name="AI step 2 detail">
+            <a:extLst xmlns:a="http://schemas.openxmlformats.org/drawingml/2006/main">
+              <a:ext uri="{FF2B5EF4-FFF2-40B4-BE49-F238E27FC236}">
+                <a16:creationId xmlns:a16="http://schemas.microsoft.com/office/drawing/2014/main" id="{E306E871-7DE2-4535-B0EB-C69206992137}"/>
+              </a:ext>
+            </a:extLst>
+          </p:cNvPr>
+          <p:cNvSpPr>
+            <a:spLocks xmlns:a="http://schemas.openxmlformats.org/drawingml/2006/main" noGrp="1"/>
+          </p:cNvSpPr>
+          <p:nvPr/>
+        </p:nvSpPr>
+        <p:spPr>
+          <a:xfrm xmlns:a="http://schemas.openxmlformats.org/drawingml/2006/main">
+            <a:off x="9001125" y="3409950"/>
+            <a:ext cx="2657475" cy="561975"/>
+          </a:xfrm>
+          <a:prstGeom xmlns:a="http://schemas.openxmlformats.org/drawingml/2006/main" prst="rect">
+            <a:avLst/>
+          </a:prstGeom>
+          <a:noFill xmlns:a="http://schemas.openxmlformats.org/drawingml/2006/main"/>
+          <a:ln xmlns:a="http://schemas.openxmlformats.org/drawingml/2006/main" w="0">
+            <a:noFill/>
+          </a:ln>
+        </p:spPr>
+        <p:txBody>
+          <a:bodyPr xmlns:a="http://schemas.openxmlformats.org/drawingml/2006/main" wrap="square" lIns="0" tIns="0" rIns="0" bIns="0">
+            <a:normAutofit fontScale="100000"/>
+          </a:bodyPr>
+          <a:lstStyle xmlns:a="http://schemas.openxmlformats.org/drawingml/2006/main"/>
+          <a:p xmlns:a="http://schemas.openxmlformats.org/drawingml/2006/main">
+            <a:pPr>
+              <a:defRPr sz="1463" b="0">
+                <a:solidFill>
+                  <a:srgbClr val="53655C"/>
+                </a:solidFill>
+                <a:latin typeface="Arial"/>
+                <a:ea typeface="Arial"/>
+                <a:cs typeface="Arial"/>
+              </a:defRPr>
+            </a:pPr>
+            <a:r>
+              <a:rPr sz="1463" b="0">
+                <a:solidFill>
+                  <a:srgbClr val="53655C"/>
+                </a:solidFill>
+                <a:latin typeface="Arial"/>
+                <a:ea typeface="Arial"/>
+                <a:cs typeface="Arial"/>
+              </a:rPr>
+              <a:t>Separate agreed points from unanswered questions.</a:t>
+            </a:r>
+          </a:p>
+        </p:txBody>
+      </p:sp>
+      <p:sp>
+        <p:nvSpPr>
+          <p:cNvPr id="10" name="AI step 3">
+            <a:extLst xmlns:a="http://schemas.openxmlformats.org/drawingml/2006/main">
+              <a:ext uri="{FF2B5EF4-FFF2-40B4-BE49-F238E27FC236}">
+                <a16:creationId xmlns:a16="http://schemas.microsoft.com/office/drawing/2014/main" id="{0FE2EF7D-6915-45CC-833A-7BAAFC92C26A}"/>
+              </a:ext>
+            </a:extLst>
+          </p:cNvPr>
+          <p:cNvSpPr>
+            <a:spLocks xmlns:a="http://schemas.openxmlformats.org/drawingml/2006/main" noGrp="1"/>
+          </p:cNvSpPr>
+          <p:nvPr/>
+        </p:nvSpPr>
+        <p:spPr>
+          <a:xfrm xmlns:a="http://schemas.openxmlformats.org/drawingml/2006/main">
+            <a:off x="9001125" y="4000500"/>
+            <a:ext cx="2657475" cy="523875"/>
+          </a:xfrm>
+          <a:prstGeom xmlns:a="http://schemas.openxmlformats.org/drawingml/2006/main" prst="rect">
+            <a:avLst/>
+          </a:prstGeom>
+          <a:noFill xmlns:a="http://schemas.openxmlformats.org/drawingml/2006/main"/>
+          <a:ln xmlns:a="http://schemas.openxmlformats.org/drawingml/2006/main" w="0">
+            <a:noFill/>
+          </a:ln>
+        </p:spPr>
+        <p:txBody>
+          <a:bodyPr xmlns:a="http://schemas.openxmlformats.org/drawingml/2006/main" wrap="square" lIns="0" tIns="0" rIns="0" bIns="0">
+            <a:normAutofit fontScale="99638"/>
+          </a:bodyPr>
+          <a:lstStyle xmlns:a="http://schemas.openxmlformats.org/drawingml/2006/main"/>
+          <a:p xmlns:a="http://schemas.openxmlformats.org/drawingml/2006/main">
+            <a:pPr>
+              <a:defRPr sz="1725" b="1">
+                <a:solidFill>
+                  <a:srgbClr val="173F33"/>
+                </a:solidFill>
+                <a:latin typeface="Arial"/>
+                <a:ea typeface="Arial"/>
+                <a:cs typeface="Arial"/>
+              </a:defRPr>
+            </a:pPr>
+            <a:r>
+              <a:rPr sz="1725" b="1">
+                <a:solidFill>
+                  <a:srgbClr val="173F33"/>
+                </a:solidFill>
+                <a:latin typeface="Arial"/>
+                <a:ea typeface="Arial"/>
+                <a:cs typeface="Arial"/>
+              </a:rPr>
+              <a:t>3. The doctor checks and signs.</a:t>
+            </a:r>
+          </a:p>
+        </p:txBody>
+      </p:sp>
+      <p:sp>
+        <p:nvSpPr>
+          <p:cNvPr id="11" name="AI step 3 detail">
+            <a:extLst xmlns:a="http://schemas.openxmlformats.org/drawingml/2006/main">
+              <a:ext uri="{FF2B5EF4-FFF2-40B4-BE49-F238E27FC236}">
+                <a16:creationId xmlns:a16="http://schemas.microsoft.com/office/drawing/2014/main" id="{50DFEF95-5420-4358-97A5-5FC91C17776D}"/>
+              </a:ext>
+            </a:extLst>
+          </p:cNvPr>
+          <p:cNvSpPr>
+            <a:spLocks xmlns:a="http://schemas.openxmlformats.org/drawingml/2006/main" noGrp="1"/>
+          </p:cNvSpPr>
+          <p:nvPr/>
+        </p:nvSpPr>
+        <p:spPr>
+          <a:xfrm xmlns:a="http://schemas.openxmlformats.org/drawingml/2006/main">
+            <a:off x="9001125" y="4572000"/>
+            <a:ext cx="2657475" cy="561975"/>
+          </a:xfrm>
+          <a:prstGeom xmlns:a="http://schemas.openxmlformats.org/drawingml/2006/main" prst="rect">
+            <a:avLst/>
+          </a:prstGeom>
+          <a:noFill xmlns:a="http://schemas.openxmlformats.org/drawingml/2006/main"/>
+          <a:ln xmlns:a="http://schemas.openxmlformats.org/drawingml/2006/main" w="0">
+            <a:noFill/>
+          </a:ln>
+        </p:spPr>
+        <p:txBody>
+          <a:bodyPr xmlns:a="http://schemas.openxmlformats.org/drawingml/2006/main" wrap="square" lIns="0" tIns="0" rIns="0" bIns="0">
+            <a:normAutofit fontScale="100000"/>
+          </a:bodyPr>
+          <a:lstStyle xmlns:a="http://schemas.openxmlformats.org/drawingml/2006/main"/>
+          <a:p xmlns:a="http://schemas.openxmlformats.org/drawingml/2006/main">
+            <a:pPr>
+              <a:defRPr sz="1463" b="0">
+                <a:solidFill>
+                  <a:srgbClr val="53655C"/>
+                </a:solidFill>
+                <a:latin typeface="Arial"/>
+                <a:ea typeface="Arial"/>
+                <a:cs typeface="Arial"/>
+              </a:defRPr>
+            </a:pPr>
+            <a:r>
+              <a:rPr sz="1463" b="0">
+                <a:solidFill>
+                  <a:srgbClr val="53655C"/>
+                </a:solidFill>
+                <a:latin typeface="Arial"/>
+                <a:ea typeface="Arial"/>
+                <a:cs typeface="Arial"/>
+              </a:rPr>
+              <a:t>Correct the note and record clinical choices.</a:t>
+            </a:r>
+          </a:p>
+        </p:txBody>
+      </p:sp>
+      <p:sp>
+        <p:nvSpPr>
+          <p:cNvPr id="12" name="AI step 4">
+            <a:extLst xmlns:a="http://schemas.openxmlformats.org/drawingml/2006/main">
+              <a:ext uri="{FF2B5EF4-FFF2-40B4-BE49-F238E27FC236}">
+                <a16:creationId xmlns:a16="http://schemas.microsoft.com/office/drawing/2014/main" id="{71723C3A-7D9A-4692-B5AA-EAD633CBD4B8}"/>
+              </a:ext>
+            </a:extLst>
+          </p:cNvPr>
+          <p:cNvSpPr>
+            <a:spLocks xmlns:a="http://schemas.openxmlformats.org/drawingml/2006/main" noGrp="1"/>
+          </p:cNvSpPr>
+          <p:nvPr/>
+        </p:nvSpPr>
+        <p:spPr>
+          <a:xfrm xmlns:a="http://schemas.openxmlformats.org/drawingml/2006/main">
+            <a:off x="9001125" y="5162550"/>
+            <a:ext cx="2657475" cy="523875"/>
+          </a:xfrm>
+          <a:prstGeom xmlns:a="http://schemas.openxmlformats.org/drawingml/2006/main" prst="rect">
+            <a:avLst/>
+          </a:prstGeom>
+          <a:noFill xmlns:a="http://schemas.openxmlformats.org/drawingml/2006/main"/>
+          <a:ln xmlns:a="http://schemas.openxmlformats.org/drawingml/2006/main" w="0">
+            <a:noFill/>
+          </a:ln>
+        </p:spPr>
+        <p:txBody>
+          <a:bodyPr xmlns:a="http://schemas.openxmlformats.org/drawingml/2006/main" wrap="square" lIns="0" tIns="0" rIns="0" bIns="0">
+            <a:normAutofit fontScale="99638"/>
+          </a:bodyPr>
+          <a:lstStyle xmlns:a="http://schemas.openxmlformats.org/drawingml/2006/main"/>
+          <a:p xmlns:a="http://schemas.openxmlformats.org/drawingml/2006/main">
+            <a:pPr>
+              <a:defRPr sz="1725" b="1">
+                <a:solidFill>
+                  <a:srgbClr val="173F33"/>
+                </a:solidFill>
+                <a:latin typeface="Arial"/>
+                <a:ea typeface="Arial"/>
+                <a:cs typeface="Arial"/>
+              </a:defRPr>
+            </a:pPr>
+            <a:r>
+              <a:rPr sz="1725" b="1">
+                <a:solidFill>
+                  <a:srgbClr val="173F33"/>
+                </a:solidFill>
+                <a:latin typeface="Arial"/>
+                <a:ea typeface="Arial"/>
+                <a:cs typeface="Arial"/>
+              </a:rPr>
+              <a:t>4. The patient signs that version.</a:t>
+            </a:r>
+          </a:p>
+        </p:txBody>
+      </p:sp>
+      <p:sp>
+        <p:nvSpPr>
+          <p:cNvPr id="13" name="AI step 4 detail">
+            <a:extLst xmlns:a="http://schemas.openxmlformats.org/drawingml/2006/main">
+              <a:ext uri="{FF2B5EF4-FFF2-40B4-BE49-F238E27FC236}">
+                <a16:creationId xmlns:a16="http://schemas.microsoft.com/office/drawing/2014/main" id="{60FD48FE-92E5-416E-8D28-BB925000569E}"/>
+              </a:ext>
+            </a:extLst>
+          </p:cNvPr>
+          <p:cNvSpPr>
+            <a:spLocks xmlns:a="http://schemas.openxmlformats.org/drawingml/2006/main" noGrp="1"/>
+          </p:cNvSpPr>
+          <p:nvPr/>
+        </p:nvSpPr>
+        <p:spPr>
+          <a:xfrm xmlns:a="http://schemas.openxmlformats.org/drawingml/2006/main">
+            <a:off x="9001125" y="5734050"/>
+            <a:ext cx="2657475" cy="561975"/>
+          </a:xfrm>
+          <a:prstGeom xmlns:a="http://schemas.openxmlformats.org/drawingml/2006/main" prst="rect">
+            <a:avLst/>
+          </a:prstGeom>
+          <a:noFill xmlns:a="http://schemas.openxmlformats.org/drawingml/2006/main"/>
+          <a:ln xmlns:a="http://schemas.openxmlformats.org/drawingml/2006/main" w="0">
+            <a:noFill/>
+          </a:ln>
+        </p:spPr>
+        <p:txBody>
+          <a:bodyPr xmlns:a="http://schemas.openxmlformats.org/drawingml/2006/main" wrap="square" lIns="0" tIns="0" rIns="0" bIns="0">
+            <a:normAutofit fontScale="100000"/>
+          </a:bodyPr>
+          <a:lstStyle xmlns:a="http://schemas.openxmlformats.org/drawingml/2006/main"/>
+          <a:p xmlns:a="http://schemas.openxmlformats.org/drawingml/2006/main">
+            <a:pPr>
+              <a:defRPr sz="1463" b="0">
+                <a:solidFill>
+                  <a:srgbClr val="53655C"/>
+                </a:solidFill>
+                <a:latin typeface="Arial"/>
+                <a:ea typeface="Arial"/>
+                <a:cs typeface="Arial"/>
+              </a:defRPr>
+            </a:pPr>
+            <a:r>
+              <a:rPr sz="1463" b="0">
+                <a:solidFill>
+                  <a:srgbClr val="53655C"/>
+                </a:solidFill>
+                <a:latin typeface="Arial"/>
+                <a:ea typeface="Arial"/>
+                <a:cs typeface="Arial"/>
+              </a:rPr>
+              <a:t>Review the exact version. Keep earlier notes.</a:t>
+            </a:r>
+          </a:p>
+        </p:txBody>
+      </p:sp>
+    </p:spTree>
+    <p:extLst>
+      <p:ext uri="{BB962C8B-B14F-4D97-AF65-F5344CB8AC3E}">
+        <p14:creationId xmlns:p14="http://schemas.microsoft.com/office/powerpoint/2010/main" val="1779657811"/>
       </p:ext>
     </p:extLst>
   </p:cSld>
@@ -6907,7 +6907,7 @@
           <p:cNvPr id="11" name="Slide title">
             <a:extLst xmlns:a="http://schemas.openxmlformats.org/drawingml/2006/main">
               <a:ext uri="{FF2B5EF4-FFF2-40B4-BE49-F238E27FC236}">
-                <a16:creationId xmlns:a16="http://schemas.microsoft.com/office/drawing/2014/main" id="{FC0F1AA6-CD69-4465-BDF3-A2ECBAB084C2}"/>
+                <a16:creationId xmlns:a16="http://schemas.microsoft.com/office/drawing/2014/main" id="{4156AFC3-84FA-49B3-B823-AF8378E255D1}"/>
               </a:ext>
             </a:extLst>
           </p:cNvPr>
@@ -6954,7 +6954,7 @@
                 <a:ea typeface="Arial"/>
                 <a:cs typeface="Arial"/>
               </a:rPr>
-              <a:t>AI helps the family use its own records.</a:t>
+              <a:t>AI helps families and doctors use patient records.</a:t>
             </a:r>
           </a:p>
         </p:txBody>
@@ -6964,7 +6964,7 @@
           <p:cNvPr id="2" name="Records assistant purpose">
             <a:extLst xmlns:a="http://schemas.openxmlformats.org/drawingml/2006/main">
               <a:ext uri="{FF2B5EF4-FFF2-40B4-BE49-F238E27FC236}">
-                <a16:creationId xmlns:a16="http://schemas.microsoft.com/office/drawing/2014/main" id="{36DAC2A2-C7FA-41CA-BD02-8D09C310D738}"/>
+                <a16:creationId xmlns:a16="http://schemas.microsoft.com/office/drawing/2014/main" id="{841292D3-EF00-4B48-8573-D39C559B4D89}"/>
               </a:ext>
             </a:extLst>
           </p:cNvPr>
@@ -7011,7 +7011,7 @@
                 <a:ea typeface="Arial"/>
                 <a:cs typeface="Arial"/>
               </a:rPr>
-              <a:t>Ask about your own reports. See the original passage with the answer.</a:t>
+              <a:t>With the patient’s permission, find answers and see the original passage.</a:t>
             </a:r>
           </a:p>
         </p:txBody>
@@ -7025,7 +7025,7 @@
           <p:nvPr/>
         </p:nvPicPr>
         <p:blipFill>
-          <a:blip xmlns:r="http://schemas.openxmlformats.org/officeDocument/2006/relationships" xmlns:a="http://schemas.openxmlformats.org/drawingml/2006/main" r:embed="Rd7571ae9d6624988"/>
+          <a:blip xmlns:r="http://schemas.openxmlformats.org/officeDocument/2006/relationships" xmlns:a="http://schemas.openxmlformats.org/drawingml/2006/main" r:embed="R60bdc2977b2c4475"/>
           <a:stretch xmlns:a="http://schemas.openxmlformats.org/drawingml/2006/main"/>
         </p:blipFill>
         <p:spPr>
@@ -7043,7 +7043,7 @@
           <p:cNvPr id="4" name="Records assistant 1">
             <a:extLst xmlns:a="http://schemas.openxmlformats.org/drawingml/2006/main">
               <a:ext uri="{FF2B5EF4-FFF2-40B4-BE49-F238E27FC236}">
-                <a16:creationId xmlns:a16="http://schemas.microsoft.com/office/drawing/2014/main" id="{707ADA56-D3E3-4A83-983D-55258ACEBE37}"/>
+                <a16:creationId xmlns:a16="http://schemas.microsoft.com/office/drawing/2014/main" id="{CBB39248-4671-4AFF-8C67-9F6E627C1613}"/>
               </a:ext>
             </a:extLst>
           </p:cNvPr>
@@ -7100,7 +7100,7 @@
           <p:cNvPr id="5" name="Records assistant 1 detail">
             <a:extLst xmlns:a="http://schemas.openxmlformats.org/drawingml/2006/main">
               <a:ext uri="{FF2B5EF4-FFF2-40B4-BE49-F238E27FC236}">
-                <a16:creationId xmlns:a16="http://schemas.microsoft.com/office/drawing/2014/main" id="{87F62111-2B3F-4C52-B1EC-1BFC846A7062}"/>
+                <a16:creationId xmlns:a16="http://schemas.microsoft.com/office/drawing/2014/main" id="{C338143F-F2B1-434C-9464-E6580ACA6760}"/>
               </a:ext>
             </a:extLst>
           </p:cNvPr>
@@ -7157,7 +7157,7 @@
           <p:cNvPr id="6" name="Records assistant 2">
             <a:extLst xmlns:a="http://schemas.openxmlformats.org/drawingml/2006/main">
               <a:ext uri="{FF2B5EF4-FFF2-40B4-BE49-F238E27FC236}">
-                <a16:creationId xmlns:a16="http://schemas.microsoft.com/office/drawing/2014/main" id="{B25C4C63-F04B-4F72-BE17-351747897C0F}"/>
+                <a16:creationId xmlns:a16="http://schemas.microsoft.com/office/drawing/2014/main" id="{185D487A-5598-4D82-8F69-48C8A74DEF36}"/>
               </a:ext>
             </a:extLst>
           </p:cNvPr>
@@ -7214,7 +7214,7 @@
           <p:cNvPr id="7" name="Records assistant 2 detail">
             <a:extLst xmlns:a="http://schemas.openxmlformats.org/drawingml/2006/main">
               <a:ext uri="{FF2B5EF4-FFF2-40B4-BE49-F238E27FC236}">
-                <a16:creationId xmlns:a16="http://schemas.microsoft.com/office/drawing/2014/main" id="{4A963A6A-2896-4323-9808-0A49C0A0E546}"/>
+                <a16:creationId xmlns:a16="http://schemas.microsoft.com/office/drawing/2014/main" id="{0DA2B490-52F5-4B59-98CB-ACC7657C35AE}"/>
               </a:ext>
             </a:extLst>
           </p:cNvPr>
@@ -7271,7 +7271,7 @@
           <p:cNvPr id="8" name="Records assistant 3">
             <a:extLst xmlns:a="http://schemas.openxmlformats.org/drawingml/2006/main">
               <a:ext uri="{FF2B5EF4-FFF2-40B4-BE49-F238E27FC236}">
-                <a16:creationId xmlns:a16="http://schemas.microsoft.com/office/drawing/2014/main" id="{7FEE974E-5119-48E6-AC5B-A839B24F33EE}"/>
+                <a16:creationId xmlns:a16="http://schemas.microsoft.com/office/drawing/2014/main" id="{F852A358-102C-455F-B5EE-A53052763848}"/>
               </a:ext>
             </a:extLst>
           </p:cNvPr>
@@ -7328,7 +7328,7 @@
           <p:cNvPr id="9" name="Records assistant 3 detail">
             <a:extLst xmlns:a="http://schemas.openxmlformats.org/drawingml/2006/main">
               <a:ext uri="{FF2B5EF4-FFF2-40B4-BE49-F238E27FC236}">
-                <a16:creationId xmlns:a16="http://schemas.microsoft.com/office/drawing/2014/main" id="{06542707-B17B-4B98-B625-61020AC76186}"/>
+                <a16:creationId xmlns:a16="http://schemas.microsoft.com/office/drawing/2014/main" id="{8BA2CDF3-491E-4AE2-B815-0685DF1BFF43}"/>
               </a:ext>
             </a:extLst>
           </p:cNvPr>
@@ -7385,7 +7385,7 @@
           <p:cNvPr id="10" name="Clinical scope">
             <a:extLst xmlns:a="http://schemas.openxmlformats.org/drawingml/2006/main">
               <a:ext uri="{FF2B5EF4-FFF2-40B4-BE49-F238E27FC236}">
-                <a16:creationId xmlns:a16="http://schemas.microsoft.com/office/drawing/2014/main" id="{F4651643-CE9F-4C16-81F0-B009634992A9}"/>
+                <a16:creationId xmlns:a16="http://schemas.microsoft.com/office/drawing/2014/main" id="{23B2B7F5-686E-49EE-A68A-57B8330F0B93}"/>
               </a:ext>
             </a:extLst>
           </p:cNvPr>
@@ -7471,7 +7471,7 @@
           <p:cNvPr id="14" name="Slide title">
             <a:extLst xmlns:a="http://schemas.openxmlformats.org/drawingml/2006/main">
               <a:ext uri="{FF2B5EF4-FFF2-40B4-BE49-F238E27FC236}">
-                <a16:creationId xmlns:a16="http://schemas.microsoft.com/office/drawing/2014/main" id="{E8236332-8D13-4DA0-BFAA-07C4798D91C3}"/>
+                <a16:creationId xmlns:a16="http://schemas.microsoft.com/office/drawing/2014/main" id="{4E6C834D-5F85-4F9A-AF1F-BB07000CD60B}"/>
               </a:ext>
             </a:extLst>
           </p:cNvPr>
@@ -7528,7 +7528,7 @@
           <p:cNvPr id="2" name="Trial design">
             <a:extLst xmlns:a="http://schemas.openxmlformats.org/drawingml/2006/main">
               <a:ext uri="{FF2B5EF4-FFF2-40B4-BE49-F238E27FC236}">
-                <a16:creationId xmlns:a16="http://schemas.microsoft.com/office/drawing/2014/main" id="{0C854B8C-F98D-4D31-981C-5A1547012839}"/>
+                <a16:creationId xmlns:a16="http://schemas.microsoft.com/office/drawing/2014/main" id="{37F64E9D-4648-4810-8DC9-748105044887}"/>
               </a:ext>
             </a:extLst>
           </p:cNvPr>
@@ -7585,7 +7585,7 @@
           <p:cNvPr id="3" name="Primary measure 1">
             <a:extLst xmlns:a="http://schemas.openxmlformats.org/drawingml/2006/main">
               <a:ext uri="{FF2B5EF4-FFF2-40B4-BE49-F238E27FC236}">
-                <a16:creationId xmlns:a16="http://schemas.microsoft.com/office/drawing/2014/main" id="{A9291487-4346-4063-A246-2F8226C25597}"/>
+                <a16:creationId xmlns:a16="http://schemas.microsoft.com/office/drawing/2014/main" id="{37C29A3C-899A-4400-AC5F-0C212E7E5507}"/>
               </a:ext>
             </a:extLst>
           </p:cNvPr>
@@ -7642,7 +7642,7 @@
           <p:cNvPr id="4" name="Primary measure 1 detail">
             <a:extLst xmlns:a="http://schemas.openxmlformats.org/drawingml/2006/main">
               <a:ext uri="{FF2B5EF4-FFF2-40B4-BE49-F238E27FC236}">
-                <a16:creationId xmlns:a16="http://schemas.microsoft.com/office/drawing/2014/main" id="{C456B535-8E21-417C-BF95-D1C2232AFDE4}"/>
+                <a16:creationId xmlns:a16="http://schemas.microsoft.com/office/drawing/2014/main" id="{9CFFD085-43A2-48BD-ABA7-5816EA52A8F4}"/>
               </a:ext>
             </a:extLst>
           </p:cNvPr>
@@ -7699,7 +7699,7 @@
           <p:cNvPr id="5" name="Primary measure 2">
             <a:extLst xmlns:a="http://schemas.openxmlformats.org/drawingml/2006/main">
               <a:ext uri="{FF2B5EF4-FFF2-40B4-BE49-F238E27FC236}">
-                <a16:creationId xmlns:a16="http://schemas.microsoft.com/office/drawing/2014/main" id="{1E22CEB3-5269-4DEE-9B65-03DC1216C70E}"/>
+                <a16:creationId xmlns:a16="http://schemas.microsoft.com/office/drawing/2014/main" id="{C66B3877-C5E2-4E3E-A858-9F6260B43982}"/>
               </a:ext>
             </a:extLst>
           </p:cNvPr>
@@ -7756,7 +7756,7 @@
           <p:cNvPr id="6" name="Primary measure 2 detail">
             <a:extLst xmlns:a="http://schemas.openxmlformats.org/drawingml/2006/main">
               <a:ext uri="{FF2B5EF4-FFF2-40B4-BE49-F238E27FC236}">
-                <a16:creationId xmlns:a16="http://schemas.microsoft.com/office/drawing/2014/main" id="{DCE626EC-779F-4249-9F98-4C777FA1C15F}"/>
+                <a16:creationId xmlns:a16="http://schemas.microsoft.com/office/drawing/2014/main" id="{2E8D3BAC-610A-476A-9E97-F0A4BE30AF82}"/>
               </a:ext>
             </a:extLst>
           </p:cNvPr>
@@ -7813,7 +7813,7 @@
           <p:cNvPr id="7" name="Primary measure 3">
             <a:extLst xmlns:a="http://schemas.openxmlformats.org/drawingml/2006/main">
               <a:ext uri="{FF2B5EF4-FFF2-40B4-BE49-F238E27FC236}">
-                <a16:creationId xmlns:a16="http://schemas.microsoft.com/office/drawing/2014/main" id="{AFD233C2-8414-4AC2-9451-8402D7AEC6A4}"/>
+                <a16:creationId xmlns:a16="http://schemas.microsoft.com/office/drawing/2014/main" id="{B16FEFFE-37B8-4B58-84F6-13BD0F60A7A2}"/>
               </a:ext>
             </a:extLst>
           </p:cNvPr>
@@ -7870,7 +7870,7 @@
           <p:cNvPr id="8" name="Primary measure 3 detail">
             <a:extLst xmlns:a="http://schemas.openxmlformats.org/drawingml/2006/main">
               <a:ext uri="{FF2B5EF4-FFF2-40B4-BE49-F238E27FC236}">
-                <a16:creationId xmlns:a16="http://schemas.microsoft.com/office/drawing/2014/main" id="{CA55EEA7-7BE3-44C1-BBF1-E35B478862CF}"/>
+                <a16:creationId xmlns:a16="http://schemas.microsoft.com/office/drawing/2014/main" id="{3A2DCA5C-FF81-4D69-87E0-848463773E26}"/>
               </a:ext>
             </a:extLst>
           </p:cNvPr>
@@ -7927,7 +7927,7 @@
           <p:cNvPr id="9" name="">
             <a:extLst xmlns:a="http://schemas.openxmlformats.org/drawingml/2006/main">
               <a:ext uri="{FF2B5EF4-FFF2-40B4-BE49-F238E27FC236}">
-                <a16:creationId xmlns:a16="http://schemas.microsoft.com/office/drawing/2014/main" id="{6377A37F-2F23-46CB-9DDA-64DA458C9E0D}"/>
+                <a16:creationId xmlns:a16="http://schemas.microsoft.com/office/drawing/2014/main" id="{A49C5224-0710-4E91-B36A-F9534173417C}"/>
               </a:ext>
             </a:extLst>
           </p:cNvPr>
@@ -7956,7 +7956,7 @@
           <p:cNvPr id="10" name="Comparison">
             <a:extLst xmlns:a="http://schemas.openxmlformats.org/drawingml/2006/main">
               <a:ext uri="{FF2B5EF4-FFF2-40B4-BE49-F238E27FC236}">
-                <a16:creationId xmlns:a16="http://schemas.microsoft.com/office/drawing/2014/main" id="{CC91C6E2-4DFF-46F1-B51F-92682D6EBE77}"/>
+                <a16:creationId xmlns:a16="http://schemas.microsoft.com/office/drawing/2014/main" id="{E610FDE2-9C17-4637-8B37-2D802358F290}"/>
               </a:ext>
             </a:extLst>
           </p:cNvPr>
@@ -8013,7 +8013,7 @@
           <p:cNvPr id="11" name="Primary outcome definition">
             <a:extLst xmlns:a="http://schemas.openxmlformats.org/drawingml/2006/main">
               <a:ext uri="{FF2B5EF4-FFF2-40B4-BE49-F238E27FC236}">
-                <a16:creationId xmlns:a16="http://schemas.microsoft.com/office/drawing/2014/main" id="{65DCC58E-0DCC-4C47-B3B4-0390D93B7EC4}"/>
+                <a16:creationId xmlns:a16="http://schemas.microsoft.com/office/drawing/2014/main" id="{6F8718DD-6503-44C9-A7E5-AA10DCE4C8C3}"/>
               </a:ext>
             </a:extLst>
           </p:cNvPr>
@@ -8070,7 +8070,7 @@
           <p:cNvPr id="12" name="Additional measures">
             <a:extLst xmlns:a="http://schemas.openxmlformats.org/drawingml/2006/main">
               <a:ext uri="{FF2B5EF4-FFF2-40B4-BE49-F238E27FC236}">
-                <a16:creationId xmlns:a16="http://schemas.microsoft.com/office/drawing/2014/main" id="{DA02E18E-454C-4CA2-BF3C-4386F1942029}"/>
+                <a16:creationId xmlns:a16="http://schemas.microsoft.com/office/drawing/2014/main" id="{5125BF07-19E4-421D-AE33-3B5E0EE41380}"/>
               </a:ext>
             </a:extLst>
           </p:cNvPr>
@@ -8127,7 +8127,7 @@
           <p:cNvPr id="13" name="Implementation status">
             <a:extLst xmlns:a="http://schemas.openxmlformats.org/drawingml/2006/main">
               <a:ext uri="{FF2B5EF4-FFF2-40B4-BE49-F238E27FC236}">
-                <a16:creationId xmlns:a16="http://schemas.microsoft.com/office/drawing/2014/main" id="{1D772724-F102-4577-87DB-1C45101DD3FA}"/>
+                <a16:creationId xmlns:a16="http://schemas.microsoft.com/office/drawing/2014/main" id="{8D288212-132A-4444-ADE2-04FFF724039B}"/>
               </a:ext>
             </a:extLst>
           </p:cNvPr>
@@ -8213,7 +8213,7 @@
           <p:cNvPr id="31" name="References title">
             <a:extLst xmlns:a="http://schemas.openxmlformats.org/drawingml/2006/main">
               <a:ext uri="{FF2B5EF4-FFF2-40B4-BE49-F238E27FC236}">
-                <a16:creationId xmlns:a16="http://schemas.microsoft.com/office/drawing/2014/main" id="{64856C7A-8805-47F8-AD3E-895037FC4B58}"/>
+                <a16:creationId xmlns:a16="http://schemas.microsoft.com/office/drawing/2014/main" id="{759222FB-0676-4A9A-AC50-44A150DF87DA}"/>
               </a:ext>
             </a:extLst>
           </p:cNvPr>
@@ -8270,7 +8270,7 @@
           <p:cNvPr id="2" name="References one to four">
             <a:extLst xmlns:a="http://schemas.openxmlformats.org/drawingml/2006/main">
               <a:ext uri="{FF2B5EF4-FFF2-40B4-BE49-F238E27FC236}">
-                <a16:creationId xmlns:a16="http://schemas.microsoft.com/office/drawing/2014/main" id="{235B16A1-709E-49C0-ADB7-7E148B619924}"/>
+                <a16:creationId xmlns:a16="http://schemas.microsoft.com/office/drawing/2014/main" id="{89925C71-9FA4-4A98-97EE-204C14DA8C52}"/>
               </a:ext>
             </a:extLst>
           </p:cNvPr>
@@ -8300,7 +8300,7 @@
           <p:cNvPr id="3" name="References five to nine">
             <a:extLst xmlns:a="http://schemas.openxmlformats.org/drawingml/2006/main">
               <a:ext uri="{FF2B5EF4-FFF2-40B4-BE49-F238E27FC236}">
-                <a16:creationId xmlns:a16="http://schemas.microsoft.com/office/drawing/2014/main" id="{2D997F53-EE29-48CC-B526-00A3C12DA9F8}"/>
+                <a16:creationId xmlns:a16="http://schemas.microsoft.com/office/drawing/2014/main" id="{3F23491D-5CF2-4666-84EF-38E0CC2CE5D2}"/>
               </a:ext>
             </a:extLst>
           </p:cNvPr>
@@ -8330,7 +8330,7 @@
           <p:cNvPr id="4" name="Reference 1 author">
             <a:extLst xmlns:a="http://schemas.openxmlformats.org/drawingml/2006/main">
               <a:ext uri="{FF2B5EF4-FFF2-40B4-BE49-F238E27FC236}">
-                <a16:creationId xmlns:a16="http://schemas.microsoft.com/office/drawing/2014/main" id="{6D918FBA-9736-468F-B6EF-6C1482DC93A7}"/>
+                <a16:creationId xmlns:a16="http://schemas.microsoft.com/office/drawing/2014/main" id="{6146401B-BC86-4594-A058-B2ECBCC890A7}"/>
               </a:ext>
             </a:extLst>
           </p:cNvPr>
@@ -8387,7 +8387,7 @@
           <p:cNvPr id="5" name="Reference 1 title">
             <a:extLst xmlns:a="http://schemas.openxmlformats.org/drawingml/2006/main">
               <a:ext uri="{FF2B5EF4-FFF2-40B4-BE49-F238E27FC236}">
-                <a16:creationId xmlns:a16="http://schemas.microsoft.com/office/drawing/2014/main" id="{DD693854-9C39-4311-9FE8-E003813F63A6}"/>
+                <a16:creationId xmlns:a16="http://schemas.microsoft.com/office/drawing/2014/main" id="{E9916D16-E758-4369-B65C-5C4F2E1F79FF}"/>
               </a:ext>
             </a:extLst>
           </p:cNvPr>
@@ -8433,7 +8433,7 @@
                 <a:latin typeface="Arial"/>
                 <a:ea typeface="Arial"/>
                 <a:cs typeface="Arial"/>
-                <a:hlinkClick xmlns:r="http://schemas.openxmlformats.org/officeDocument/2006/relationships" r:id="Rb7cd7ff0cdae4be5"/>
+                <a:hlinkClick xmlns:r="http://schemas.openxmlformats.org/officeDocument/2006/relationships" r:id="R7dd56817eb0e4175"/>
               </a:rPr>
               <a:t>India: GLOBOCAN 2024 Fact Sheet</a:t>
             </a:r>
@@ -8445,7 +8445,7 @@
           <p:cNvPr id="6" name="Reference 1 link">
             <a:extLst xmlns:a="http://schemas.openxmlformats.org/drawingml/2006/main">
               <a:ext uri="{FF2B5EF4-FFF2-40B4-BE49-F238E27FC236}">
-                <a16:creationId xmlns:a16="http://schemas.microsoft.com/office/drawing/2014/main" id="{C6B58B15-B33A-4094-95CB-EC4F45A24309}"/>
+                <a16:creationId xmlns:a16="http://schemas.microsoft.com/office/drawing/2014/main" id="{F2E7DED7-356A-4FB4-97D0-F9FB9625C997}"/>
               </a:ext>
             </a:extLst>
           </p:cNvPr>
@@ -8491,7 +8491,7 @@
                 <a:latin typeface="Arial"/>
                 <a:ea typeface="Arial"/>
                 <a:cs typeface="Arial"/>
-                <a:hlinkClick xmlns:r="http://schemas.openxmlformats.org/officeDocument/2006/relationships" r:id="Rb789ef3b45e74ad8"/>
+                <a:hlinkClick xmlns:r="http://schemas.openxmlformats.org/officeDocument/2006/relationships" r:id="Rf345ae124653426c"/>
               </a:rPr>
               <a:t>https://gco.iarc.who.int/media/globocan/factsheets/populations/356-india-fact-sheet.pdf</a:t>
             </a:r>
@@ -8503,7 +8503,7 @@
           <p:cNvPr id="7" name="Reference 2 author">
             <a:extLst xmlns:a="http://schemas.openxmlformats.org/drawingml/2006/main">
               <a:ext uri="{FF2B5EF4-FFF2-40B4-BE49-F238E27FC236}">
-                <a16:creationId xmlns:a16="http://schemas.microsoft.com/office/drawing/2014/main" id="{ED908D20-4B37-428C-B25D-3C1F1F633D34}"/>
+                <a16:creationId xmlns:a16="http://schemas.microsoft.com/office/drawing/2014/main" id="{DCF79783-1BD3-4FEF-9051-77A64B1ADD7F}"/>
               </a:ext>
             </a:extLst>
           </p:cNvPr>
@@ -8560,7 +8560,7 @@
           <p:cNvPr id="8" name="Reference 2 title">
             <a:extLst xmlns:a="http://schemas.openxmlformats.org/drawingml/2006/main">
               <a:ext uri="{FF2B5EF4-FFF2-40B4-BE49-F238E27FC236}">
-                <a16:creationId xmlns:a16="http://schemas.microsoft.com/office/drawing/2014/main" id="{8BCCB934-A8C4-4A31-BB72-EF47FE72C19B}"/>
+                <a16:creationId xmlns:a16="http://schemas.microsoft.com/office/drawing/2014/main" id="{B614826D-1504-46DE-A889-08AF7BAF5123}"/>
               </a:ext>
             </a:extLst>
           </p:cNvPr>
@@ -8606,7 +8606,7 @@
                 <a:latin typeface="Arial"/>
                 <a:ea typeface="Arial"/>
                 <a:cs typeface="Arial"/>
-                <a:hlinkClick xmlns:r="http://schemas.openxmlformats.org/officeDocument/2006/relationships" r:id="R26ab7d4d2286421d"/>
+                <a:hlinkClick xmlns:r="http://schemas.openxmlformats.org/officeDocument/2006/relationships" r:id="R0a2a464f66a041df"/>
               </a:rPr>
               <a:t>Unmet need for cancer palliative care in India</a:t>
             </a:r>
@@ -8618,7 +8618,7 @@
           <p:cNvPr id="9" name="Reference 2 link">
             <a:extLst xmlns:a="http://schemas.openxmlformats.org/drawingml/2006/main">
               <a:ext uri="{FF2B5EF4-FFF2-40B4-BE49-F238E27FC236}">
-                <a16:creationId xmlns:a16="http://schemas.microsoft.com/office/drawing/2014/main" id="{1A693860-E7D1-468F-B0A2-B520ABD2CFBA}"/>
+                <a16:creationId xmlns:a16="http://schemas.microsoft.com/office/drawing/2014/main" id="{DC9AAB45-E938-4989-A373-09E223C3A80D}"/>
               </a:ext>
             </a:extLst>
           </p:cNvPr>
@@ -8664,7 +8664,7 @@
                 <a:latin typeface="Arial"/>
                 <a:ea typeface="Arial"/>
                 <a:cs typeface="Arial"/>
-                <a:hlinkClick xmlns:r="http://schemas.openxmlformats.org/officeDocument/2006/relationships" r:id="Ra7769f711b8b45af"/>
+                <a:hlinkClick xmlns:r="http://schemas.openxmlformats.org/officeDocument/2006/relationships" r:id="R9a10e108d0a44d5a"/>
               </a:rPr>
               <a:t>https://doi.org/10.1136/spcare-2024-004978</a:t>
             </a:r>
@@ -8676,7 +8676,7 @@
           <p:cNvPr id="10" name="Reference 3 author">
             <a:extLst xmlns:a="http://schemas.openxmlformats.org/drawingml/2006/main">
               <a:ext uri="{FF2B5EF4-FFF2-40B4-BE49-F238E27FC236}">
-                <a16:creationId xmlns:a16="http://schemas.microsoft.com/office/drawing/2014/main" id="{74170842-EE59-4CE1-B5C6-4FE9BC8E9525}"/>
+                <a16:creationId xmlns:a16="http://schemas.microsoft.com/office/drawing/2014/main" id="{357FE010-2B61-416D-BF0C-BFE2FEA7062D}"/>
               </a:ext>
             </a:extLst>
           </p:cNvPr>
@@ -8733,7 +8733,7 @@
           <p:cNvPr id="11" name="Reference 3 title">
             <a:extLst xmlns:a="http://schemas.openxmlformats.org/drawingml/2006/main">
               <a:ext uri="{FF2B5EF4-FFF2-40B4-BE49-F238E27FC236}">
-                <a16:creationId xmlns:a16="http://schemas.microsoft.com/office/drawing/2014/main" id="{D54445DC-9081-49E3-8925-5216BC5EB955}"/>
+                <a16:creationId xmlns:a16="http://schemas.microsoft.com/office/drawing/2014/main" id="{C33E2180-6282-4E87-84CE-077FAA0E2E39}"/>
               </a:ext>
             </a:extLst>
           </p:cNvPr>
@@ -8779,7 +8779,7 @@
                 <a:latin typeface="Arial"/>
                 <a:ea typeface="Arial"/>
                 <a:cs typeface="Arial"/>
-                <a:hlinkClick xmlns:r="http://schemas.openxmlformats.org/officeDocument/2006/relationships" r:id="Re66e18913136486e"/>
+                <a:hlinkClick xmlns:r="http://schemas.openxmlformats.org/officeDocument/2006/relationships" r:id="R523ceeda6e16437d"/>
               </a:rPr>
               <a:t>Early Goal of Care Discussions in Healthcare: A Survey Case Report on Benefits and Perceptions</a:t>
             </a:r>
@@ -8791,7 +8791,7 @@
           <p:cNvPr id="12" name="Reference 3 link">
             <a:extLst xmlns:a="http://schemas.openxmlformats.org/drawingml/2006/main">
               <a:ext uri="{FF2B5EF4-FFF2-40B4-BE49-F238E27FC236}">
-                <a16:creationId xmlns:a16="http://schemas.microsoft.com/office/drawing/2014/main" id="{9D6B862D-D2C4-4461-939E-DC4E6481FB0A}"/>
+                <a16:creationId xmlns:a16="http://schemas.microsoft.com/office/drawing/2014/main" id="{0454F3FB-333A-4BE1-A84E-A7DE5F752AC5}"/>
               </a:ext>
             </a:extLst>
           </p:cNvPr>
@@ -8837,7 +8837,7 @@
                 <a:latin typeface="Arial"/>
                 <a:ea typeface="Arial"/>
                 <a:cs typeface="Arial"/>
-                <a:hlinkClick xmlns:r="http://schemas.openxmlformats.org/officeDocument/2006/relationships" r:id="R251c402cc7784cde"/>
+                <a:hlinkClick xmlns:r="http://schemas.openxmlformats.org/officeDocument/2006/relationships" r:id="R10a27981791245e7"/>
               </a:rPr>
               <a:t>https://doi.org/10.1016/j.jpainsymman.2024.02.030</a:t>
             </a:r>
@@ -8849,7 +8849,7 @@
           <p:cNvPr id="13" name="Reference 4 author">
             <a:extLst xmlns:a="http://schemas.openxmlformats.org/drawingml/2006/main">
               <a:ext uri="{FF2B5EF4-FFF2-40B4-BE49-F238E27FC236}">
-                <a16:creationId xmlns:a16="http://schemas.microsoft.com/office/drawing/2014/main" id="{F0155441-1E6B-4CCE-9ED9-F6A20CD9FB83}"/>
+                <a16:creationId xmlns:a16="http://schemas.microsoft.com/office/drawing/2014/main" id="{F2A305EA-F253-42E5-8277-E39A8E624B7D}"/>
               </a:ext>
             </a:extLst>
           </p:cNvPr>
@@ -8906,7 +8906,7 @@
           <p:cNvPr id="14" name="Reference 4 title">
             <a:extLst xmlns:a="http://schemas.openxmlformats.org/drawingml/2006/main">
               <a:ext uri="{FF2B5EF4-FFF2-40B4-BE49-F238E27FC236}">
-                <a16:creationId xmlns:a16="http://schemas.microsoft.com/office/drawing/2014/main" id="{246097F6-78B4-4B51-8A40-056D94F2CF13}"/>
+                <a16:creationId xmlns:a16="http://schemas.microsoft.com/office/drawing/2014/main" id="{778C158C-20F9-4275-9E83-EB8AEB9EDA57}"/>
               </a:ext>
             </a:extLst>
           </p:cNvPr>
@@ -8952,7 +8952,7 @@
                 <a:latin typeface="Arial"/>
                 <a:ea typeface="Arial"/>
                 <a:cs typeface="Arial"/>
-                <a:hlinkClick xmlns:r="http://schemas.openxmlformats.org/officeDocument/2006/relationships" r:id="R269f695015ba40e5"/>
+                <a:hlinkClick xmlns:r="http://schemas.openxmlformats.org/officeDocument/2006/relationships" r:id="Rf9c2439e32e34834"/>
               </a:rPr>
               <a:t>Initiating and Documenting Goals of Care Discussion in Patients with Advanced Pancreatic and Colorectal Cancers: A Quality Improvement Project in a Low Resource Setting</a:t>
             </a:r>
@@ -8964,7 +8964,7 @@
           <p:cNvPr id="15" name="Reference 4 link">
             <a:extLst xmlns:a="http://schemas.openxmlformats.org/drawingml/2006/main">
               <a:ext uri="{FF2B5EF4-FFF2-40B4-BE49-F238E27FC236}">
-                <a16:creationId xmlns:a16="http://schemas.microsoft.com/office/drawing/2014/main" id="{0808695F-7608-4DE5-AAF3-3C1032CEDAD3}"/>
+                <a16:creationId xmlns:a16="http://schemas.microsoft.com/office/drawing/2014/main" id="{D922D3DD-8559-4A39-B5A0-1B177550E83D}"/>
               </a:ext>
             </a:extLst>
           </p:cNvPr>
@@ -9010,7 +9010,7 @@
                 <a:latin typeface="Arial"/>
                 <a:ea typeface="Arial"/>
                 <a:cs typeface="Arial"/>
-                <a:hlinkClick xmlns:r="http://schemas.openxmlformats.org/officeDocument/2006/relationships" r:id="Rf2d16b71274e47e6"/>
+                <a:hlinkClick xmlns:r="http://schemas.openxmlformats.org/officeDocument/2006/relationships" r:id="R049ae3bf2679406e"/>
               </a:rPr>
               <a:t>https://doi.org/10.1177/26892820251392545</a:t>
             </a:r>
@@ -9022,7 +9022,7 @@
           <p:cNvPr id="16" name="Reference 5 author">
             <a:extLst xmlns:a="http://schemas.openxmlformats.org/drawingml/2006/main">
               <a:ext uri="{FF2B5EF4-FFF2-40B4-BE49-F238E27FC236}">
-                <a16:creationId xmlns:a16="http://schemas.microsoft.com/office/drawing/2014/main" id="{800F2E48-2469-4858-9FD6-BB952F1C1101}"/>
+                <a16:creationId xmlns:a16="http://schemas.microsoft.com/office/drawing/2014/main" id="{A28472A8-A5AB-4AC0-B1C6-0DC5C4A13DAE}"/>
               </a:ext>
             </a:extLst>
           </p:cNvPr>
@@ -9079,7 +9079,7 @@
           <p:cNvPr id="17" name="Reference 5 title">
             <a:extLst xmlns:a="http://schemas.openxmlformats.org/drawingml/2006/main">
               <a:ext uri="{FF2B5EF4-FFF2-40B4-BE49-F238E27FC236}">
-                <a16:creationId xmlns:a16="http://schemas.microsoft.com/office/drawing/2014/main" id="{AEE54AAE-5C1D-44FA-A11F-70F31D03408B}"/>
+                <a16:creationId xmlns:a16="http://schemas.microsoft.com/office/drawing/2014/main" id="{B91AD9A6-E8F0-4036-A265-C80BDDE31FFF}"/>
               </a:ext>
             </a:extLst>
           </p:cNvPr>
@@ -9125,7 +9125,7 @@
                 <a:latin typeface="Arial"/>
                 <a:ea typeface="Arial"/>
                 <a:cs typeface="Arial"/>
-                <a:hlinkClick xmlns:r="http://schemas.openxmlformats.org/officeDocument/2006/relationships" r:id="Rb27e4f37d8084bc3"/>
+                <a:hlinkClick xmlns:r="http://schemas.openxmlformats.org/officeDocument/2006/relationships" r:id="R826a559093a14feb"/>
               </a:rPr>
               <a:t>73% urban Indians do not know about their right to make a living will, finds a survey</a:t>
             </a:r>
@@ -9137,7 +9137,7 @@
           <p:cNvPr id="18" name="Reference 5 link">
             <a:extLst xmlns:a="http://schemas.openxmlformats.org/drawingml/2006/main">
               <a:ext uri="{FF2B5EF4-FFF2-40B4-BE49-F238E27FC236}">
-                <a16:creationId xmlns:a16="http://schemas.microsoft.com/office/drawing/2014/main" id="{2AA09D6E-4647-454D-A881-CF0E4D354DB4}"/>
+                <a16:creationId xmlns:a16="http://schemas.microsoft.com/office/drawing/2014/main" id="{3AF25D4D-C707-4F0A-B144-EA8F13743E1C}"/>
               </a:ext>
             </a:extLst>
           </p:cNvPr>
@@ -9183,7 +9183,7 @@
                 <a:latin typeface="Arial"/>
                 <a:ea typeface="Arial"/>
                 <a:cs typeface="Arial"/>
-                <a:hlinkClick xmlns:r="http://schemas.openxmlformats.org/officeDocument/2006/relationships" r:id="Rfcf387f88cec4cb0"/>
+                <a:hlinkClick xmlns:r="http://schemas.openxmlformats.org/officeDocument/2006/relationships" r:id="R6d1b1acca86b4978"/>
               </a:rPr>
               <a:t>https://scroll.in/article/925875/73-urban-indians-do-not-know-about-their-right-to-make-a-living-will-finds-a-survey</a:t>
             </a:r>
@@ -9195,7 +9195,7 @@
           <p:cNvPr id="19" name="Reference 6 author">
             <a:extLst xmlns:a="http://schemas.openxmlformats.org/drawingml/2006/main">
               <a:ext uri="{FF2B5EF4-FFF2-40B4-BE49-F238E27FC236}">
-                <a16:creationId xmlns:a16="http://schemas.microsoft.com/office/drawing/2014/main" id="{5EE15D09-1BAF-4775-AFA4-78C1D1BB1DFD}"/>
+                <a16:creationId xmlns:a16="http://schemas.microsoft.com/office/drawing/2014/main" id="{96AB32C8-BE61-4B9B-9099-074AE95BABEE}"/>
               </a:ext>
             </a:extLst>
           </p:cNvPr>
@@ -9252,7 +9252,7 @@
           <p:cNvPr id="20" name="Reference 6 title">
             <a:extLst xmlns:a="http://schemas.openxmlformats.org/drawingml/2006/main">
               <a:ext uri="{FF2B5EF4-FFF2-40B4-BE49-F238E27FC236}">
-                <a16:creationId xmlns:a16="http://schemas.microsoft.com/office/drawing/2014/main" id="{4EF09634-66FF-474F-82B2-A94C7CCB5F94}"/>
+                <a16:creationId xmlns:a16="http://schemas.microsoft.com/office/drawing/2014/main" id="{C9BF5CFA-6848-49EA-94AD-64C553602020}"/>
               </a:ext>
             </a:extLst>
           </p:cNvPr>
@@ -9298,7 +9298,7 @@
                 <a:latin typeface="Arial"/>
                 <a:ea typeface="Arial"/>
                 <a:cs typeface="Arial"/>
-                <a:hlinkClick xmlns:r="http://schemas.openxmlformats.org/officeDocument/2006/relationships" r:id="R3431cd50e645498a"/>
+                <a:hlinkClick xmlns:r="http://schemas.openxmlformats.org/officeDocument/2006/relationships" r:id="Rf84e13531599470b"/>
               </a:rPr>
               <a:t>Knowledge and attitude towards advance directives for patients with terminal illnesses among doctors working in a tertiary care hospital</a:t>
             </a:r>
@@ -9310,7 +9310,7 @@
           <p:cNvPr id="21" name="Reference 6 link">
             <a:extLst xmlns:a="http://schemas.openxmlformats.org/drawingml/2006/main">
               <a:ext uri="{FF2B5EF4-FFF2-40B4-BE49-F238E27FC236}">
-                <a16:creationId xmlns:a16="http://schemas.microsoft.com/office/drawing/2014/main" id="{E8226A4F-C3EC-4B92-9895-12D9D0D8731C}"/>
+                <a16:creationId xmlns:a16="http://schemas.microsoft.com/office/drawing/2014/main" id="{75D5CB04-9710-4413-A099-26527456F237}"/>
               </a:ext>
             </a:extLst>
           </p:cNvPr>
@@ -9356,7 +9356,7 @@
                 <a:latin typeface="Arial"/>
                 <a:ea typeface="Arial"/>
                 <a:cs typeface="Arial"/>
-                <a:hlinkClick xmlns:r="http://schemas.openxmlformats.org/officeDocument/2006/relationships" r:id="R760f90c3d96c4e4d"/>
+                <a:hlinkClick xmlns:r="http://schemas.openxmlformats.org/officeDocument/2006/relationships" r:id="R9c33fc6f916a4c43"/>
               </a:rPr>
               <a:t>https://doi.org/10.25259/NMJI_817_2023</a:t>
             </a:r>
@@ -9368,7 +9368,7 @@
           <p:cNvPr id="22" name="Reference 7 author">
             <a:extLst xmlns:a="http://schemas.openxmlformats.org/drawingml/2006/main">
               <a:ext uri="{FF2B5EF4-FFF2-40B4-BE49-F238E27FC236}">
-                <a16:creationId xmlns:a16="http://schemas.microsoft.com/office/drawing/2014/main" id="{73E57447-AC1B-4F98-9521-64A742003BFA}"/>
+                <a16:creationId xmlns:a16="http://schemas.microsoft.com/office/drawing/2014/main" id="{984E8CA1-81A7-4FBD-9FC7-A16DBC90695D}"/>
               </a:ext>
             </a:extLst>
           </p:cNvPr>
@@ -9425,7 +9425,7 @@
           <p:cNvPr id="23" name="Reference 7 title">
             <a:extLst xmlns:a="http://schemas.openxmlformats.org/drawingml/2006/main">
               <a:ext uri="{FF2B5EF4-FFF2-40B4-BE49-F238E27FC236}">
-                <a16:creationId xmlns:a16="http://schemas.microsoft.com/office/drawing/2014/main" id="{A837176B-54ED-4714-B353-B063FF8AD0B1}"/>
+                <a16:creationId xmlns:a16="http://schemas.microsoft.com/office/drawing/2014/main" id="{EE802C88-4FB7-4989-8459-BF1D98E4601C}"/>
               </a:ext>
             </a:extLst>
           </p:cNvPr>
@@ -9471,7 +9471,7 @@
                 <a:latin typeface="Arial"/>
                 <a:ea typeface="Arial"/>
                 <a:cs typeface="Arial"/>
-                <a:hlinkClick xmlns:r="http://schemas.openxmlformats.org/officeDocument/2006/relationships" r:id="Rc0fec17cc7a74b31"/>
+                <a:hlinkClick xmlns:r="http://schemas.openxmlformats.org/officeDocument/2006/relationships" r:id="R409f5a25a54b4322"/>
               </a:rPr>
               <a:t>Barriers and Facilitators to Advance Care Planning Implementation for Patients with Neurodegenerative Diseases among Indian Physicians: A Mixed-Methods Analysis</a:t>
             </a:r>
@@ -9483,7 +9483,7 @@
           <p:cNvPr id="24" name="Reference 7 link">
             <a:extLst xmlns:a="http://schemas.openxmlformats.org/drawingml/2006/main">
               <a:ext uri="{FF2B5EF4-FFF2-40B4-BE49-F238E27FC236}">
-                <a16:creationId xmlns:a16="http://schemas.microsoft.com/office/drawing/2014/main" id="{5A065043-FC1C-4DB8-BBE3-F3C0C83D318E}"/>
+                <a16:creationId xmlns:a16="http://schemas.microsoft.com/office/drawing/2014/main" id="{AC348910-CB9D-40E9-9BFD-8359C72F6C3B}"/>
               </a:ext>
             </a:extLst>
           </p:cNvPr>
@@ -9529,7 +9529,7 @@
                 <a:latin typeface="Arial"/>
                 <a:ea typeface="Arial"/>
                 <a:cs typeface="Arial"/>
-                <a:hlinkClick xmlns:r="http://schemas.openxmlformats.org/officeDocument/2006/relationships" r:id="Rc014c35307644ba6"/>
+                <a:hlinkClick xmlns:r="http://schemas.openxmlformats.org/officeDocument/2006/relationships" r:id="R874b985e13094ab3"/>
               </a:rPr>
               <a:t>https://doi.org/10.1101/2025.10.17.25338242</a:t>
             </a:r>
@@ -9541,7 +9541,7 @@
           <p:cNvPr id="25" name="Reference 8 author">
             <a:extLst xmlns:a="http://schemas.openxmlformats.org/drawingml/2006/main">
               <a:ext uri="{FF2B5EF4-FFF2-40B4-BE49-F238E27FC236}">
-                <a16:creationId xmlns:a16="http://schemas.microsoft.com/office/drawing/2014/main" id="{94E369D9-5A95-4C29-B4B0-17695FEC142A}"/>
+                <a16:creationId xmlns:a16="http://schemas.microsoft.com/office/drawing/2014/main" id="{D9C1890E-617C-4EC8-8519-74DE3663E182}"/>
               </a:ext>
             </a:extLst>
           </p:cNvPr>
@@ -9598,7 +9598,7 @@
           <p:cNvPr id="26" name="Reference 8 title">
             <a:extLst xmlns:a="http://schemas.openxmlformats.org/drawingml/2006/main">
               <a:ext uri="{FF2B5EF4-FFF2-40B4-BE49-F238E27FC236}">
-                <a16:creationId xmlns:a16="http://schemas.microsoft.com/office/drawing/2014/main" id="{38C6836B-65CC-4A8A-9F85-3A1ED78A0E14}"/>
+                <a16:creationId xmlns:a16="http://schemas.microsoft.com/office/drawing/2014/main" id="{7381AA99-54A3-49E8-BCBB-51C241B3C5F5}"/>
               </a:ext>
             </a:extLst>
           </p:cNvPr>
@@ -9644,7 +9644,7 @@
                 <a:latin typeface="Arial"/>
                 <a:ea typeface="Arial"/>
                 <a:cs typeface="Arial"/>
-                <a:hlinkClick xmlns:r="http://schemas.openxmlformats.org/officeDocument/2006/relationships" r:id="R54b0c71ef6424719"/>
+                <a:hlinkClick xmlns:r="http://schemas.openxmlformats.org/officeDocument/2006/relationships" r:id="Rcb7c2676c10c4688"/>
               </a:rPr>
               <a:t>An Ethnographic Study of Barriers to Cancer Pain Management and Opioid Availability in India</a:t>
             </a:r>
@@ -9656,7 +9656,7 @@
           <p:cNvPr id="27" name="Reference 8 link">
             <a:extLst xmlns:a="http://schemas.openxmlformats.org/drawingml/2006/main">
               <a:ext uri="{FF2B5EF4-FFF2-40B4-BE49-F238E27FC236}">
-                <a16:creationId xmlns:a16="http://schemas.microsoft.com/office/drawing/2014/main" id="{85062187-130A-430A-9AE5-5E694166937D}"/>
+                <a16:creationId xmlns:a16="http://schemas.microsoft.com/office/drawing/2014/main" id="{0347F115-D583-4A40-BDD5-31193910C090}"/>
               </a:ext>
             </a:extLst>
           </p:cNvPr>
@@ -9702,7 +9702,7 @@
                 <a:latin typeface="Arial"/>
                 <a:ea typeface="Arial"/>
                 <a:cs typeface="Arial"/>
-                <a:hlinkClick xmlns:r="http://schemas.openxmlformats.org/officeDocument/2006/relationships" r:id="R8e18fafa3a11490a"/>
+                <a:hlinkClick xmlns:r="http://schemas.openxmlformats.org/officeDocument/2006/relationships" r:id="R0a9db6b5b7104476"/>
               </a:rPr>
               <a:t>https://doi.org/10.1634/theoncologist.2013-0435</a:t>
             </a:r>
@@ -9714,7 +9714,7 @@
           <p:cNvPr id="28" name="Reference 9 author">
             <a:extLst xmlns:a="http://schemas.openxmlformats.org/drawingml/2006/main">
               <a:ext uri="{FF2B5EF4-FFF2-40B4-BE49-F238E27FC236}">
-                <a16:creationId xmlns:a16="http://schemas.microsoft.com/office/drawing/2014/main" id="{F9132870-C6A4-4587-BC5C-AABD496031FF}"/>
+                <a16:creationId xmlns:a16="http://schemas.microsoft.com/office/drawing/2014/main" id="{577170F5-9FD2-4574-9683-203E99E6C561}"/>
               </a:ext>
             </a:extLst>
           </p:cNvPr>
@@ -9771,7 +9771,7 @@
           <p:cNvPr id="29" name="Reference 9 title">
             <a:extLst xmlns:a="http://schemas.openxmlformats.org/drawingml/2006/main">
               <a:ext uri="{FF2B5EF4-FFF2-40B4-BE49-F238E27FC236}">
-                <a16:creationId xmlns:a16="http://schemas.microsoft.com/office/drawing/2014/main" id="{47973DD1-84DF-4529-814F-4FA04AAFEC11}"/>
+                <a16:creationId xmlns:a16="http://schemas.microsoft.com/office/drawing/2014/main" id="{1E795304-B9F2-4CFA-85B9-187DDBC22C1F}"/>
               </a:ext>
             </a:extLst>
           </p:cNvPr>
@@ -9817,7 +9817,7 @@
                 <a:latin typeface="Arial"/>
                 <a:ea typeface="Arial"/>
                 <a:cs typeface="Arial"/>
-                <a:hlinkClick xmlns:r="http://schemas.openxmlformats.org/officeDocument/2006/relationships" r:id="Rf97b2ab115454a75"/>
+                <a:hlinkClick xmlns:r="http://schemas.openxmlformats.org/officeDocument/2006/relationships" r:id="Rfe8f5f59ed684403"/>
               </a:rPr>
               <a:t>Receipt of Psychosocial Care Among Cancer Survivors in the United States</a:t>
             </a:r>
@@ -9829,7 +9829,7 @@
           <p:cNvPr id="30" name="Reference 9 link">
             <a:extLst xmlns:a="http://schemas.openxmlformats.org/drawingml/2006/main">
               <a:ext uri="{FF2B5EF4-FFF2-40B4-BE49-F238E27FC236}">
-                <a16:creationId xmlns:a16="http://schemas.microsoft.com/office/drawing/2014/main" id="{778DD96A-A34E-4CCA-B7C0-C451B85AB7D5}"/>
+                <a16:creationId xmlns:a16="http://schemas.microsoft.com/office/drawing/2014/main" id="{6B919672-B838-4C88-BF6E-6C2071EF030F}"/>
               </a:ext>
             </a:extLst>
           </p:cNvPr>
@@ -9875,7 +9875,7 @@
                 <a:latin typeface="Arial"/>
                 <a:ea typeface="Arial"/>
                 <a:cs typeface="Arial"/>
-                <a:hlinkClick xmlns:r="http://schemas.openxmlformats.org/officeDocument/2006/relationships" r:id="Re8f69de745ef451e"/>
+                <a:hlinkClick xmlns:r="http://schemas.openxmlformats.org/officeDocument/2006/relationships" r:id="R84aafabe43424cb1"/>
               </a:rPr>
               <a:t>https://doi.org/10.1200/JCO.2012.46.2101</a:t>
             </a:r>

</xml_diff>